<commit_message>
feat: quantite matériau dans slide estimation
</commit_message>
<xml_diff>
--- a/public/templates/template_synthese_projet.pptx
+++ b/public/templates/template_synthese_projet.pptx
@@ -213,7 +213,7 @@
           <a:p>
             <a:fld id="{4C638A9C-6ED0-4718-B5E7-9D405962C144}" type="datetimeFigureOut">
               <a:rPr lang="fr-FR" smtClean="0"/>
-              <a:t>04/09/2026</a:t>
+              <a:t>09/09/2026</a:t>
             </a:fld>
             <a:endParaRPr lang="fr-FR"/>
           </a:p>
@@ -843,7 +843,7 @@
           <a:p>
             <a:fld id="{82E7F8B9-DFDB-4965-877D-C04A580740C9}" type="datetimeFigureOut">
               <a:rPr lang="fr-FR" smtClean="0"/>
-              <a:t>04/09/2026</a:t>
+              <a:t>09/09/2026</a:t>
             </a:fld>
             <a:endParaRPr lang="fr-FR"/>
           </a:p>
@@ -1041,7 +1041,7 @@
           <a:p>
             <a:fld id="{82E7F8B9-DFDB-4965-877D-C04A580740C9}" type="datetimeFigureOut">
               <a:rPr lang="fr-FR" smtClean="0"/>
-              <a:t>04/09/2026</a:t>
+              <a:t>09/09/2026</a:t>
             </a:fld>
             <a:endParaRPr lang="fr-FR"/>
           </a:p>
@@ -1249,7 +1249,7 @@
           <a:p>
             <a:fld id="{82E7F8B9-DFDB-4965-877D-C04A580740C9}" type="datetimeFigureOut">
               <a:rPr lang="fr-FR" smtClean="0"/>
-              <a:t>04/09/2026</a:t>
+              <a:t>09/09/2026</a:t>
             </a:fld>
             <a:endParaRPr lang="fr-FR"/>
           </a:p>
@@ -1482,7 +1482,7 @@
           <a:p>
             <a:fld id="{82E7F8B9-DFDB-4965-877D-C04A580740C9}" type="datetimeFigureOut">
               <a:rPr lang="fr-FR" smtClean="0"/>
-              <a:t>04/09/2026</a:t>
+              <a:t>09/09/2026</a:t>
             </a:fld>
             <a:endParaRPr lang="fr-FR"/>
           </a:p>
@@ -1757,7 +1757,7 @@
           <a:p>
             <a:fld id="{82E7F8B9-DFDB-4965-877D-C04A580740C9}" type="datetimeFigureOut">
               <a:rPr lang="fr-FR" smtClean="0"/>
-              <a:t>04/09/2026</a:t>
+              <a:t>09/09/2026</a:t>
             </a:fld>
             <a:endParaRPr lang="fr-FR"/>
           </a:p>
@@ -2022,7 +2022,7 @@
           <a:p>
             <a:fld id="{82E7F8B9-DFDB-4965-877D-C04A580740C9}" type="datetimeFigureOut">
               <a:rPr lang="fr-FR" smtClean="0"/>
-              <a:t>04/09/2026</a:t>
+              <a:t>09/09/2026</a:t>
             </a:fld>
             <a:endParaRPr lang="fr-FR"/>
           </a:p>
@@ -2434,7 +2434,7 @@
           <a:p>
             <a:fld id="{82E7F8B9-DFDB-4965-877D-C04A580740C9}" type="datetimeFigureOut">
               <a:rPr lang="fr-FR" smtClean="0"/>
-              <a:t>04/09/2026</a:t>
+              <a:t>09/09/2026</a:t>
             </a:fld>
             <a:endParaRPr lang="fr-FR"/>
           </a:p>
@@ -2575,7 +2575,7 @@
           <a:p>
             <a:fld id="{82E7F8B9-DFDB-4965-877D-C04A580740C9}" type="datetimeFigureOut">
               <a:rPr lang="fr-FR" smtClean="0"/>
-              <a:t>04/09/2026</a:t>
+              <a:t>09/09/2026</a:t>
             </a:fld>
             <a:endParaRPr lang="fr-FR"/>
           </a:p>
@@ -2688,7 +2688,7 @@
           <a:p>
             <a:fld id="{82E7F8B9-DFDB-4965-877D-C04A580740C9}" type="datetimeFigureOut">
               <a:rPr lang="fr-FR" smtClean="0"/>
-              <a:t>04/09/2026</a:t>
+              <a:t>09/09/2026</a:t>
             </a:fld>
             <a:endParaRPr lang="fr-FR"/>
           </a:p>
@@ -2999,7 +2999,7 @@
           <a:p>
             <a:fld id="{82E7F8B9-DFDB-4965-877D-C04A580740C9}" type="datetimeFigureOut">
               <a:rPr lang="fr-FR" smtClean="0"/>
-              <a:t>04/09/2026</a:t>
+              <a:t>09/09/2026</a:t>
             </a:fld>
             <a:endParaRPr lang="fr-FR"/>
           </a:p>
@@ -3287,7 +3287,7 @@
           <a:p>
             <a:fld id="{82E7F8B9-DFDB-4965-877D-C04A580740C9}" type="datetimeFigureOut">
               <a:rPr lang="fr-FR" smtClean="0"/>
-              <a:t>04/09/2026</a:t>
+              <a:t>09/09/2026</a:t>
             </a:fld>
             <a:endParaRPr lang="fr-FR"/>
           </a:p>
@@ -3528,7 +3528,7 @@
           <a:p>
             <a:fld id="{82E7F8B9-DFDB-4965-877D-C04A580740C9}" type="datetimeFigureOut">
               <a:rPr lang="fr-FR" smtClean="0"/>
-              <a:t>04/09/2026</a:t>
+              <a:t>09/09/2026</a:t>
             </a:fld>
             <a:endParaRPr lang="fr-FR"/>
           </a:p>
@@ -5309,8 +5309,9 @@
             <a:r>
               <a:rPr lang="fr-FR" b="1" dirty="0">
                 <a:solidFill>
-                  <a:schemeClr val="bg1">
-                    <a:lumMod val="50000"/>
+                  <a:schemeClr val="tx1">
+                    <a:lumMod val="65000"/>
+                    <a:lumOff val="35000"/>
                   </a:schemeClr>
                 </a:solidFill>
                 <a:latin typeface="Calibri" panose="020F0502020204030204" pitchFamily="34" charset="0"/>
@@ -5321,8 +5322,9 @@
             </a:r>
             <a:endParaRPr lang="fr-FR" sz="1600" dirty="0">
               <a:solidFill>
-                <a:schemeClr val="bg1">
-                  <a:lumMod val="50000"/>
+                <a:schemeClr val="tx1">
+                  <a:lumMod val="65000"/>
+                  <a:lumOff val="35000"/>
                 </a:schemeClr>
               </a:solidFill>
               <a:latin typeface="Calibri" panose="020F0502020204030204" pitchFamily="34" charset="0"/>
@@ -5463,8 +5465,9 @@
             <a:r>
               <a:rPr lang="fr-FR" dirty="0">
                 <a:solidFill>
-                  <a:schemeClr val="bg1">
-                    <a:lumMod val="50000"/>
+                  <a:schemeClr val="tx1">
+                    <a:lumMod val="65000"/>
+                    <a:lumOff val="35000"/>
                   </a:schemeClr>
                 </a:solidFill>
                 <a:latin typeface="Calibri" panose="020F0502020204030204" pitchFamily="34" charset="0"/>
@@ -5687,8 +5690,9 @@
             <a:r>
               <a:rPr lang="fr-FR" dirty="0">
                 <a:solidFill>
-                  <a:schemeClr val="bg1">
-                    <a:lumMod val="50000"/>
+                  <a:schemeClr val="tx1">
+                    <a:lumMod val="65000"/>
+                    <a:lumOff val="35000"/>
                   </a:schemeClr>
                 </a:solidFill>
                 <a:latin typeface="Calibri" panose="020F0502020204030204" pitchFamily="34" charset="0"/>
@@ -5731,8 +5735,9 @@
             <a:r>
               <a:rPr lang="fr-FR" dirty="0">
                 <a:solidFill>
-                  <a:schemeClr val="bg1">
-                    <a:lumMod val="50000"/>
+                  <a:schemeClr val="tx1">
+                    <a:lumMod val="65000"/>
+                    <a:lumOff val="35000"/>
                   </a:schemeClr>
                 </a:solidFill>
                 <a:latin typeface="Calibri" panose="020F0502020204030204" pitchFamily="34" charset="0"/>
@@ -5775,8 +5780,9 @@
             <a:r>
               <a:rPr lang="fr-FR" dirty="0">
                 <a:solidFill>
-                  <a:schemeClr val="bg1">
-                    <a:lumMod val="50000"/>
+                  <a:schemeClr val="tx1">
+                    <a:lumMod val="65000"/>
+                    <a:lumOff val="35000"/>
                   </a:schemeClr>
                 </a:solidFill>
                 <a:latin typeface="Calibri" panose="020F0502020204030204" pitchFamily="34" charset="0"/>
@@ -5819,8 +5825,9 @@
             <a:r>
               <a:rPr lang="fr-FR" dirty="0">
                 <a:solidFill>
-                  <a:schemeClr val="bg1">
-                    <a:lumMod val="50000"/>
+                  <a:schemeClr val="tx1">
+                    <a:lumMod val="65000"/>
+                    <a:lumOff val="35000"/>
                   </a:schemeClr>
                 </a:solidFill>
                 <a:latin typeface="Calibri" panose="020F0502020204030204" pitchFamily="34" charset="0"/>
@@ -5847,7 +5854,7 @@
         <p:spPr>
           <a:xfrm>
             <a:off x="762151" y="2395650"/>
-            <a:ext cx="1994034" cy="815608"/>
+            <a:ext cx="1994034" cy="830997"/>
           </a:xfrm>
           <a:prstGeom prst="rect">
             <a:avLst/>
@@ -5863,8 +5870,9 @@
             <a:r>
               <a:rPr lang="fr-FR" sz="1600" dirty="0">
                 <a:solidFill>
-                  <a:schemeClr val="bg1">
-                    <a:lumMod val="50000"/>
+                  <a:schemeClr val="tx1">
+                    <a:lumMod val="65000"/>
+                    <a:lumOff val="35000"/>
                   </a:schemeClr>
                 </a:solidFill>
                 <a:latin typeface="Calibri" panose="020F0502020204030204" pitchFamily="34" charset="0"/>
@@ -5876,8 +5884,9 @@
             <a:r>
               <a:rPr lang="fr-FR" sz="1600" dirty="0" err="1">
                 <a:solidFill>
-                  <a:schemeClr val="bg1">
-                    <a:lumMod val="50000"/>
+                  <a:schemeClr val="tx1">
+                    <a:lumMod val="65000"/>
+                    <a:lumOff val="35000"/>
                   </a:schemeClr>
                 </a:solidFill>
                 <a:latin typeface="Calibri" panose="020F0502020204030204" pitchFamily="34" charset="0"/>
@@ -5889,8 +5898,9 @@
             <a:r>
               <a:rPr lang="fr-FR" sz="1600" dirty="0">
                 <a:solidFill>
-                  <a:schemeClr val="bg1">
-                    <a:lumMod val="50000"/>
+                  <a:schemeClr val="tx1">
+                    <a:lumMod val="65000"/>
+                    <a:lumOff val="35000"/>
                   </a:schemeClr>
                 </a:solidFill>
                 <a:latin typeface="Calibri" panose="020F0502020204030204" pitchFamily="34" charset="0"/>
@@ -5899,12 +5909,11 @@
               </a:rPr>
               <a:t>}}</a:t>
             </a:r>
-          </a:p>
-          <a:p>
             <a:endParaRPr lang="fr-FR" sz="1500" dirty="0">
               <a:solidFill>
-                <a:schemeClr val="bg1">
-                  <a:lumMod val="50000"/>
+                <a:schemeClr val="tx1">
+                  <a:lumMod val="65000"/>
+                  <a:lumOff val="35000"/>
                 </a:schemeClr>
               </a:solidFill>
               <a:latin typeface="Calibri" panose="020F0502020204030204" pitchFamily="34" charset="0"/>
@@ -5912,53 +5921,12 @@
               <a:cs typeface="Calibri" panose="020F0502020204030204" pitchFamily="34" charset="0"/>
             </a:endParaRPr>
           </a:p>
-        </p:txBody>
-      </p:sp>
-      <p:sp>
-        <p:nvSpPr>
-          <p:cNvPr id="24" name="ZoneTexte 23">
-            <a:extLst>
-              <a:ext uri="{FF2B5EF4-FFF2-40B4-BE49-F238E27FC236}">
-                <a16:creationId xmlns:a16="http://schemas.microsoft.com/office/drawing/2014/main" id="{85DCA6C4-87A6-9194-C19C-D27B78EB3AD6}"/>
-              </a:ext>
-            </a:extLst>
-          </p:cNvPr>
-          <p:cNvSpPr txBox="1"/>
-          <p:nvPr/>
-        </p:nvSpPr>
-        <p:spPr>
-          <a:xfrm>
-            <a:off x="754275" y="4853531"/>
-            <a:ext cx="1944964" cy="369332"/>
-          </a:xfrm>
-          <a:prstGeom prst="rect">
-            <a:avLst/>
-          </a:prstGeom>
-          <a:noFill/>
-        </p:spPr>
-        <p:txBody>
-          <a:bodyPr wrap="square">
-            <a:spAutoFit/>
-          </a:bodyPr>
-          <a:lstStyle/>
-          <a:p>
-            <a:r>
-              <a:rPr lang="fr-FR" b="1" dirty="0">
-                <a:solidFill>
-                  <a:schemeClr val="bg1">
-                    <a:lumMod val="50000"/>
-                  </a:schemeClr>
-                </a:solidFill>
-                <a:latin typeface="Calibri" panose="020F0502020204030204" pitchFamily="34" charset="0"/>
-                <a:ea typeface="Calibri" panose="020F0502020204030204" pitchFamily="34" charset="0"/>
-                <a:cs typeface="Calibri" panose="020F0502020204030204" pitchFamily="34" charset="0"/>
-              </a:rPr>
-              <a:t>Délai des travaux :</a:t>
-            </a:r>
+          <a:p>
             <a:endParaRPr lang="fr-FR" sz="1600" dirty="0">
               <a:solidFill>
-                <a:schemeClr val="bg1">
-                  <a:lumMod val="50000"/>
+                <a:schemeClr val="tx1">
+                  <a:lumMod val="65000"/>
+                  <a:lumOff val="35000"/>
                 </a:schemeClr>
               </a:solidFill>
               <a:latin typeface="Calibri" panose="020F0502020204030204" pitchFamily="34" charset="0"/>
@@ -5970,10 +5938,10 @@
       </p:sp>
       <p:sp>
         <p:nvSpPr>
-          <p:cNvPr id="25" name="ZoneTexte 24">
-            <a:extLst>
-              <a:ext uri="{FF2B5EF4-FFF2-40B4-BE49-F238E27FC236}">
-                <a16:creationId xmlns:a16="http://schemas.microsoft.com/office/drawing/2014/main" id="{032C04B6-E4A2-36FB-8482-DEAEE2233EC0}"/>
+          <p:cNvPr id="24" name="ZoneTexte 23">
+            <a:extLst>
+              <a:ext uri="{FF2B5EF4-FFF2-40B4-BE49-F238E27FC236}">
+                <a16:creationId xmlns:a16="http://schemas.microsoft.com/office/drawing/2014/main" id="{85DCA6C4-87A6-9194-C19C-D27B78EB3AD6}"/>
               </a:ext>
             </a:extLst>
           </p:cNvPr>
@@ -5982,8 +5950,8 @@
         </p:nvSpPr>
         <p:spPr>
           <a:xfrm>
-            <a:off x="2581955" y="4877899"/>
-            <a:ext cx="2609903" cy="338554"/>
+            <a:off x="754275" y="4853531"/>
+            <a:ext cx="1944964" cy="369332"/>
           </a:xfrm>
           <a:prstGeom prst="rect">
             <a:avLst/>
@@ -5997,53 +5965,39 @@
           <a:lstStyle/>
           <a:p>
             <a:r>
-              <a:rPr lang="fr-FR" sz="1600" dirty="0">
-                <a:solidFill>
-                  <a:schemeClr val="bg1">
-                    <a:lumMod val="50000"/>
+              <a:rPr lang="fr-FR" b="1" dirty="0">
+                <a:solidFill>
+                  <a:schemeClr val="tx1">
+                    <a:lumMod val="65000"/>
+                    <a:lumOff val="35000"/>
                   </a:schemeClr>
                 </a:solidFill>
                 <a:latin typeface="Calibri" panose="020F0502020204030204" pitchFamily="34" charset="0"/>
                 <a:ea typeface="Calibri" panose="020F0502020204030204" pitchFamily="34" charset="0"/>
                 <a:cs typeface="Calibri" panose="020F0502020204030204" pitchFamily="34" charset="0"/>
               </a:rPr>
-              <a:t>{{</a:t>
-            </a:r>
-            <a:r>
-              <a:rPr lang="fr-FR" sz="1600" dirty="0" err="1">
-                <a:solidFill>
-                  <a:schemeClr val="bg1">
-                    <a:lumMod val="50000"/>
-                  </a:schemeClr>
-                </a:solidFill>
-                <a:latin typeface="Calibri" panose="020F0502020204030204" pitchFamily="34" charset="0"/>
-                <a:ea typeface="Calibri" panose="020F0502020204030204" pitchFamily="34" charset="0"/>
-                <a:cs typeface="Calibri" panose="020F0502020204030204" pitchFamily="34" charset="0"/>
-              </a:rPr>
-              <a:t>delai_fiche_solution</a:t>
-            </a:r>
-            <a:r>
-              <a:rPr lang="fr-FR" sz="1600" dirty="0">
-                <a:solidFill>
-                  <a:schemeClr val="bg1">
-                    <a:lumMod val="50000"/>
-                  </a:schemeClr>
-                </a:solidFill>
-                <a:latin typeface="Calibri" panose="020F0502020204030204" pitchFamily="34" charset="0"/>
-                <a:ea typeface="Calibri" panose="020F0502020204030204" pitchFamily="34" charset="0"/>
-                <a:cs typeface="Calibri" panose="020F0502020204030204" pitchFamily="34" charset="0"/>
-              </a:rPr>
-              <a:t>}}</a:t>
-            </a:r>
-          </a:p>
-        </p:txBody>
-      </p:sp>
-      <p:sp>
-        <p:nvSpPr>
-          <p:cNvPr id="26" name="ZoneTexte 25">
-            <a:extLst>
-              <a:ext uri="{FF2B5EF4-FFF2-40B4-BE49-F238E27FC236}">
-                <a16:creationId xmlns:a16="http://schemas.microsoft.com/office/drawing/2014/main" id="{608F7C5C-B2A7-E255-DC57-2AE0D978AD00}"/>
+              <a:t>Délai des travaux :</a:t>
+            </a:r>
+            <a:endParaRPr lang="fr-FR" sz="1600" dirty="0">
+              <a:solidFill>
+                <a:schemeClr val="tx1">
+                  <a:lumMod val="65000"/>
+                  <a:lumOff val="35000"/>
+                </a:schemeClr>
+              </a:solidFill>
+              <a:latin typeface="Calibri" panose="020F0502020204030204" pitchFamily="34" charset="0"/>
+              <a:ea typeface="Calibri" panose="020F0502020204030204" pitchFamily="34" charset="0"/>
+              <a:cs typeface="Calibri" panose="020F0502020204030204" pitchFamily="34" charset="0"/>
+            </a:endParaRPr>
+          </a:p>
+        </p:txBody>
+      </p:sp>
+      <p:sp>
+        <p:nvSpPr>
+          <p:cNvPr id="25" name="ZoneTexte 24">
+            <a:extLst>
+              <a:ext uri="{FF2B5EF4-FFF2-40B4-BE49-F238E27FC236}">
+                <a16:creationId xmlns:a16="http://schemas.microsoft.com/office/drawing/2014/main" id="{032C04B6-E4A2-36FB-8482-DEAEE2233EC0}"/>
               </a:ext>
             </a:extLst>
           </p:cNvPr>
@@ -6052,8 +6006,8 @@
         </p:nvSpPr>
         <p:spPr>
           <a:xfrm>
-            <a:off x="1377409" y="4386098"/>
-            <a:ext cx="3814449" cy="338554"/>
+            <a:off x="2581955" y="4877899"/>
+            <a:ext cx="2609903" cy="338554"/>
           </a:xfrm>
           <a:prstGeom prst="rect">
             <a:avLst/>
@@ -6069,8 +6023,9 @@
             <a:r>
               <a:rPr lang="fr-FR" sz="1600" dirty="0">
                 <a:solidFill>
-                  <a:schemeClr val="bg1">
-                    <a:lumMod val="50000"/>
+                  <a:schemeClr val="tx1">
+                    <a:lumMod val="65000"/>
+                    <a:lumOff val="35000"/>
                   </a:schemeClr>
                 </a:solidFill>
                 <a:latin typeface="Calibri" panose="020F0502020204030204" pitchFamily="34" charset="0"/>
@@ -6082,21 +6037,96 @@
             <a:r>
               <a:rPr lang="fr-FR" sz="1600" dirty="0" err="1">
                 <a:solidFill>
-                  <a:schemeClr val="bg1">
-                    <a:lumMod val="50000"/>
+                  <a:schemeClr val="tx1">
+                    <a:lumMod val="65000"/>
+                    <a:lumOff val="35000"/>
                   </a:schemeClr>
                 </a:solidFill>
                 <a:latin typeface="Calibri" panose="020F0502020204030204" pitchFamily="34" charset="0"/>
                 <a:ea typeface="Calibri" panose="020F0502020204030204" pitchFamily="34" charset="0"/>
                 <a:cs typeface="Calibri" panose="020F0502020204030204" pitchFamily="34" charset="0"/>
               </a:rPr>
+              <a:t>delai_fiche_solution</a:t>
+            </a:r>
+            <a:r>
+              <a:rPr lang="fr-FR" sz="1600" dirty="0">
+                <a:solidFill>
+                  <a:schemeClr val="tx1">
+                    <a:lumMod val="65000"/>
+                    <a:lumOff val="35000"/>
+                  </a:schemeClr>
+                </a:solidFill>
+                <a:latin typeface="Calibri" panose="020F0502020204030204" pitchFamily="34" charset="0"/>
+                <a:ea typeface="Calibri" panose="020F0502020204030204" pitchFamily="34" charset="0"/>
+                <a:cs typeface="Calibri" panose="020F0502020204030204" pitchFamily="34" charset="0"/>
+              </a:rPr>
+              <a:t>}}</a:t>
+            </a:r>
+          </a:p>
+        </p:txBody>
+      </p:sp>
+      <p:sp>
+        <p:nvSpPr>
+          <p:cNvPr id="26" name="ZoneTexte 25">
+            <a:extLst>
+              <a:ext uri="{FF2B5EF4-FFF2-40B4-BE49-F238E27FC236}">
+                <a16:creationId xmlns:a16="http://schemas.microsoft.com/office/drawing/2014/main" id="{608F7C5C-B2A7-E255-DC57-2AE0D978AD00}"/>
+              </a:ext>
+            </a:extLst>
+          </p:cNvPr>
+          <p:cNvSpPr txBox="1"/>
+          <p:nvPr/>
+        </p:nvSpPr>
+        <p:spPr>
+          <a:xfrm>
+            <a:off x="1377409" y="4386098"/>
+            <a:ext cx="3814449" cy="338554"/>
+          </a:xfrm>
+          <a:prstGeom prst="rect">
+            <a:avLst/>
+          </a:prstGeom>
+          <a:noFill/>
+        </p:spPr>
+        <p:txBody>
+          <a:bodyPr wrap="square">
+            <a:spAutoFit/>
+          </a:bodyPr>
+          <a:lstStyle/>
+          <a:p>
+            <a:r>
+              <a:rPr lang="fr-FR" sz="1600" dirty="0">
+                <a:solidFill>
+                  <a:schemeClr val="tx1">
+                    <a:lumMod val="65000"/>
+                    <a:lumOff val="35000"/>
+                  </a:schemeClr>
+                </a:solidFill>
+                <a:latin typeface="Calibri" panose="020F0502020204030204" pitchFamily="34" charset="0"/>
+                <a:ea typeface="Calibri" panose="020F0502020204030204" pitchFamily="34" charset="0"/>
+                <a:cs typeface="Calibri" panose="020F0502020204030204" pitchFamily="34" charset="0"/>
+              </a:rPr>
+              <a:t>{{</a:t>
+            </a:r>
+            <a:r>
+              <a:rPr lang="fr-FR" sz="1600" dirty="0" err="1">
+                <a:solidFill>
+                  <a:schemeClr val="tx1">
+                    <a:lumMod val="65000"/>
+                    <a:lumOff val="35000"/>
+                  </a:schemeClr>
+                </a:solidFill>
+                <a:latin typeface="Calibri" panose="020F0502020204030204" pitchFamily="34" charset="0"/>
+                <a:ea typeface="Calibri" panose="020F0502020204030204" pitchFamily="34" charset="0"/>
+                <a:cs typeface="Calibri" panose="020F0502020204030204" pitchFamily="34" charset="0"/>
+              </a:rPr>
               <a:t>cout_fiche_solution</a:t>
             </a:r>
             <a:r>
               <a:rPr lang="fr-FR" sz="1600" dirty="0">
                 <a:solidFill>
-                  <a:schemeClr val="bg1">
-                    <a:lumMod val="50000"/>
+                  <a:schemeClr val="tx1">
+                    <a:lumMod val="65000"/>
+                    <a:lumOff val="35000"/>
                   </a:schemeClr>
                 </a:solidFill>
                 <a:latin typeface="Calibri" panose="020F0502020204030204" pitchFamily="34" charset="0"/>
@@ -6257,7 +6287,7 @@
       </p:sp>
       <p:sp>
         <p:nvSpPr>
-          <p:cNvPr id="9" name="ZoneTexte 8">
+          <p:cNvPr id="9" name="zone_titre_materiau">
             <a:extLst>
               <a:ext uri="{FF2B5EF4-FFF2-40B4-BE49-F238E27FC236}">
                 <a16:creationId xmlns:a16="http://schemas.microsoft.com/office/drawing/2014/main" id="{A88800C3-C9AC-CC70-2E75-A1BBA164B372}"/>
@@ -6312,7 +6342,7 @@
       </p:sp>
       <p:sp>
         <p:nvSpPr>
-          <p:cNvPr id="10" name="Text 8">
+          <p:cNvPr id="10" name="zone_quantite_materiau">
             <a:extLst>
               <a:ext uri="{FF2B5EF4-FFF2-40B4-BE49-F238E27FC236}">
                 <a16:creationId xmlns:a16="http://schemas.microsoft.com/office/drawing/2014/main" id="{99178690-04DD-6BBB-B2F6-1E672F23CAA3}"/>
@@ -6409,7 +6439,7 @@
       </p:pic>
       <p:sp>
         <p:nvSpPr>
-          <p:cNvPr id="17" name="ZoneTexte 16">
+          <p:cNvPr id="17" name="zone_description_materiau">
             <a:extLst>
               <a:ext uri="{FF2B5EF4-FFF2-40B4-BE49-F238E27FC236}">
                 <a16:creationId xmlns:a16="http://schemas.microsoft.com/office/drawing/2014/main" id="{E402B53A-5129-3D25-265B-DC4D2781533E}"/>
@@ -6458,7 +6488,7 @@
       </p:sp>
       <p:sp>
         <p:nvSpPr>
-          <p:cNvPr id="19" name="ZoneTexte 18">
+          <p:cNvPr id="19" name="zone_cout_materiau">
             <a:extLst>
               <a:ext uri="{FF2B5EF4-FFF2-40B4-BE49-F238E27FC236}">
                 <a16:creationId xmlns:a16="http://schemas.microsoft.com/office/drawing/2014/main" id="{79E9B9CA-0F08-3137-64D1-50FFF50EA47E}"/>
@@ -7221,7 +7251,7 @@
       </p:grpSpPr>
       <p:sp>
         <p:nvSpPr>
-          <p:cNvPr id="12" name="Rectangle 11">
+          <p:cNvPr id="12" name="bg_recap_estimation_fs">
             <a:extLst>
               <a:ext uri="{FF2B5EF4-FFF2-40B4-BE49-F238E27FC236}">
                 <a16:creationId xmlns:a16="http://schemas.microsoft.com/office/drawing/2014/main" id="{6BA12113-ED47-B687-ED73-BF7EB1432512}"/>
@@ -7275,7 +7305,7 @@
       </p:sp>
       <p:sp>
         <p:nvSpPr>
-          <p:cNvPr id="9" name="ZoneTexte 8">
+          <p:cNvPr id="9" name="zone_titre_materiau">
             <a:extLst>
               <a:ext uri="{FF2B5EF4-FFF2-40B4-BE49-F238E27FC236}">
                 <a16:creationId xmlns:a16="http://schemas.microsoft.com/office/drawing/2014/main" id="{A88800C3-C9AC-CC70-2E75-A1BBA164B372}"/>
@@ -7287,7 +7317,7 @@
         </p:nvSpPr>
         <p:spPr>
           <a:xfrm>
-            <a:off x="1865713" y="1666147"/>
+            <a:off x="1865713" y="1529871"/>
             <a:ext cx="5597103" cy="276999"/>
           </a:xfrm>
           <a:prstGeom prst="rect">
@@ -7360,7 +7390,7 @@
       </p:pic>
       <p:sp>
         <p:nvSpPr>
-          <p:cNvPr id="19" name="ZoneTexte 18">
+          <p:cNvPr id="19" name="zone_cout_materiau">
             <a:extLst>
               <a:ext uri="{FF2B5EF4-FFF2-40B4-BE49-F238E27FC236}">
                 <a16:creationId xmlns:a16="http://schemas.microsoft.com/office/drawing/2014/main" id="{79E9B9CA-0F08-3137-64D1-50FFF50EA47E}"/>
@@ -7656,7 +7686,7 @@
       </p:pic>
       <p:sp>
         <p:nvSpPr>
-          <p:cNvPr id="2" name="ZoneTexte 1">
+          <p:cNvPr id="2" name="zone_titre_fs_recap_estimation">
             <a:extLst>
               <a:ext uri="{FF2B5EF4-FFF2-40B4-BE49-F238E27FC236}">
                 <a16:creationId xmlns:a16="http://schemas.microsoft.com/office/drawing/2014/main" id="{B161BF39-D0D2-C1A3-6A29-174F5C4B931B}"/>
@@ -7711,7 +7741,7 @@
       </p:sp>
       <p:sp>
         <p:nvSpPr>
-          <p:cNvPr id="6" name="ZoneTexte 5">
+          <p:cNvPr id="6" name="recap_total_libelles">
             <a:extLst>
               <a:ext uri="{FF2B5EF4-FFF2-40B4-BE49-F238E27FC236}">
                 <a16:creationId xmlns:a16="http://schemas.microsoft.com/office/drawing/2014/main" id="{8CF6B5B8-BAD7-E10A-E363-18498172553F}"/>
@@ -8050,7 +8080,7 @@
       </p:sp>
       <p:sp>
         <p:nvSpPr>
-          <p:cNvPr id="18" name="ZoneTexte 17">
+          <p:cNvPr id="18" name="recap_total_libelles_valeurs">
             <a:extLst>
               <a:ext uri="{FF2B5EF4-FFF2-40B4-BE49-F238E27FC236}">
                 <a16:creationId xmlns:a16="http://schemas.microsoft.com/office/drawing/2014/main" id="{09E2F9B4-E5A1-7459-5392-6A6FC53C59B6}"/>
@@ -8171,6 +8201,61 @@
                   <a:lumOff val="25000"/>
                 </a:schemeClr>
               </a:solidFill>
+            </a:endParaRPr>
+          </a:p>
+        </p:txBody>
+      </p:sp>
+      <p:sp>
+        <p:nvSpPr>
+          <p:cNvPr id="8" name="zone_quantite_materiau">
+            <a:extLst>
+              <a:ext uri="{FF2B5EF4-FFF2-40B4-BE49-F238E27FC236}">
+                <a16:creationId xmlns:a16="http://schemas.microsoft.com/office/drawing/2014/main" id="{2E3BE4A1-A1C8-70C6-319A-D994B244BC29}"/>
+              </a:ext>
+            </a:extLst>
+          </p:cNvPr>
+          <p:cNvSpPr txBox="1"/>
+          <p:nvPr/>
+        </p:nvSpPr>
+        <p:spPr>
+          <a:xfrm>
+            <a:off x="1865713" y="1824986"/>
+            <a:ext cx="5597103" cy="246221"/>
+          </a:xfrm>
+          <a:prstGeom prst="rect">
+            <a:avLst/>
+          </a:prstGeom>
+          <a:noFill/>
+        </p:spPr>
+        <p:txBody>
+          <a:bodyPr wrap="square">
+            <a:spAutoFit/>
+          </a:bodyPr>
+          <a:lstStyle/>
+          <a:p>
+            <a:r>
+              <a:rPr lang="fr-FR" sz="1000" i="0" dirty="0">
+                <a:effectLst/>
+                <a:latin typeface="Aptos" panose="020B0004020202020204" pitchFamily="34" charset="0"/>
+              </a:rPr>
+              <a:t>{{</a:t>
+            </a:r>
+            <a:r>
+              <a:rPr lang="fr-FR" sz="1000" i="0" dirty="0" err="1">
+                <a:effectLst/>
+                <a:latin typeface="Aptos" panose="020B0004020202020204" pitchFamily="34" charset="0"/>
+              </a:rPr>
+              <a:t>quantite_materiau</a:t>
+            </a:r>
+            <a:r>
+              <a:rPr lang="fr-FR" sz="1000" i="0" dirty="0">
+                <a:effectLst/>
+                <a:latin typeface="Aptos" panose="020B0004020202020204" pitchFamily="34" charset="0"/>
+              </a:rPr>
+              <a:t>}}</a:t>
+            </a:r>
+            <a:endParaRPr lang="fr-FR" sz="1000" dirty="0">
+              <a:latin typeface="Aptos" panose="020B0004020202020204" pitchFamily="34" charset="0"/>
             </a:endParaRPr>
           </a:p>
         </p:txBody>

</xml_diff>

<commit_message>
feat: prise en compte des solutions sans matériau dans l'export des estimations
</commit_message>
<xml_diff>
--- a/public/templates/template_synthese_projet.pptx
+++ b/public/templates/template_synthese_projet.pptx
@@ -7263,7 +7263,7 @@
         </p:nvSpPr>
         <p:spPr>
           <a:xfrm>
-            <a:off x="1255554" y="2765181"/>
+            <a:off x="1255554" y="2549770"/>
             <a:ext cx="9765604" cy="663816"/>
           </a:xfrm>
           <a:prstGeom prst="rect">
@@ -7836,7 +7836,7 @@
         </p:nvSpPr>
         <p:spPr>
           <a:xfrm>
-            <a:off x="6918732" y="2843261"/>
+            <a:off x="6918732" y="2627850"/>
             <a:ext cx="3950835" cy="430887"/>
           </a:xfrm>
           <a:prstGeom prst="rect">
@@ -8001,7 +8001,7 @@
         </p:nvSpPr>
         <p:spPr>
           <a:xfrm>
-            <a:off x="1377181" y="2881645"/>
+            <a:off x="1377181" y="2666234"/>
             <a:ext cx="3285673" cy="430887"/>
           </a:xfrm>
           <a:prstGeom prst="rect">

</xml_diff>

<commit_message>
feat: déplacement du bandeau de récap de l'estimation
</commit_message>
<xml_diff>
--- a/public/templates/template_synthese_projet.pptx
+++ b/public/templates/template_synthese_projet.pptx
@@ -7263,7 +7263,7 @@
         </p:nvSpPr>
         <p:spPr>
           <a:xfrm>
-            <a:off x="1255554" y="2549770"/>
+            <a:off x="1255554" y="2602517"/>
             <a:ext cx="9765604" cy="663816"/>
           </a:xfrm>
           <a:prstGeom prst="rect">
@@ -7836,7 +7836,7 @@
         </p:nvSpPr>
         <p:spPr>
           <a:xfrm>
-            <a:off x="6918732" y="2627850"/>
+            <a:off x="6918732" y="2680597"/>
             <a:ext cx="3950835" cy="430887"/>
           </a:xfrm>
           <a:prstGeom prst="rect">
@@ -8001,7 +8001,7 @@
         </p:nvSpPr>
         <p:spPr>
           <a:xfrm>
-            <a:off x="1377181" y="2666234"/>
+            <a:off x="1377181" y="2718981"/>
             <a:ext cx="3285673" cy="430887"/>
           </a:xfrm>
           <a:prstGeom prst="rect">

</xml_diff>

<commit_message>
feat: Rajout de la pagination pour la récap budgétaire
</commit_message>
<xml_diff>
--- a/public/templates/template_synthese_projet.pptx
+++ b/public/templates/template_synthese_projet.pptx
@@ -14,8 +14,8 @@
     <p:sldId id="270" r:id="rId5"/>
     <p:sldId id="274" r:id="rId6"/>
     <p:sldId id="275" r:id="rId7"/>
-    <p:sldId id="257" r:id="rId8"/>
-    <p:sldId id="258" r:id="rId9"/>
+    <p:sldId id="276" r:id="rId8"/>
+    <p:sldId id="277" r:id="rId9"/>
   </p:sldIdLst>
   <p:sldSz cx="12192000" cy="6858000"/>
   <p:notesSz cx="6858000" cy="9144000"/>
@@ -687,6 +687,114 @@
     <p:extLst>
       <p:ext uri="{BB962C8B-B14F-4D97-AF65-F5344CB8AC3E}">
         <p14:creationId xmlns:p14="http://schemas.microsoft.com/office/powerpoint/2010/main" val="2866518631"/>
+      </p:ext>
+    </p:extLst>
+  </p:cSld>
+  <p:clrMapOvr>
+    <a:masterClrMapping/>
+  </p:clrMapOvr>
+</p:notes>
+</file>
+
+<file path=ppt/notesSlides/notesSlide3.xml><?xml version="1.0" encoding="utf-8"?>
+<p:notes xmlns:a="http://schemas.openxmlformats.org/drawingml/2006/main" xmlns:r="http://schemas.openxmlformats.org/officeDocument/2006/relationships" xmlns:p="http://schemas.openxmlformats.org/presentationml/2006/main">
+  <p:cSld>
+    <p:spTree>
+      <p:nvGrpSpPr>
+        <p:cNvPr id="1" name="">
+          <a:extLst>
+            <a:ext uri="{FF2B5EF4-FFF2-40B4-BE49-F238E27FC236}">
+              <a16:creationId xmlns:a16="http://schemas.microsoft.com/office/drawing/2014/main" id="{048D1F06-EBEC-48E7-718E-679E9C7AB652}"/>
+            </a:ext>
+          </a:extLst>
+        </p:cNvPr>
+        <p:cNvGrpSpPr/>
+        <p:nvPr/>
+      </p:nvGrpSpPr>
+      <p:grpSpPr>
+        <a:xfrm>
+          <a:off x="0" y="0"/>
+          <a:ext cx="0" cy="0"/>
+          <a:chOff x="0" y="0"/>
+          <a:chExt cx="0" cy="0"/>
+        </a:xfrm>
+      </p:grpSpPr>
+      <p:sp>
+        <p:nvSpPr>
+          <p:cNvPr id="2" name="Slide Image Placeholder 1">
+            <a:extLst>
+              <a:ext uri="{FF2B5EF4-FFF2-40B4-BE49-F238E27FC236}">
+                <a16:creationId xmlns:a16="http://schemas.microsoft.com/office/drawing/2014/main" id="{15188976-03C7-BDC5-F35A-502E38D967CC}"/>
+              </a:ext>
+            </a:extLst>
+          </p:cNvPr>
+          <p:cNvSpPr>
+            <a:spLocks noGrp="1" noRot="1" noChangeAspect="1"/>
+          </p:cNvSpPr>
+          <p:nvPr>
+            <p:ph type="sldImg"/>
+          </p:nvPr>
+        </p:nvSpPr>
+        <p:spPr/>
+      </p:sp>
+      <p:sp>
+        <p:nvSpPr>
+          <p:cNvPr id="3" name="Notes Placeholder 2">
+            <a:extLst>
+              <a:ext uri="{FF2B5EF4-FFF2-40B4-BE49-F238E27FC236}">
+                <a16:creationId xmlns:a16="http://schemas.microsoft.com/office/drawing/2014/main" id="{32392900-84C4-792B-45B3-9A38832A4769}"/>
+              </a:ext>
+            </a:extLst>
+          </p:cNvPr>
+          <p:cNvSpPr>
+            <a:spLocks noGrp="1"/>
+          </p:cNvSpPr>
+          <p:nvPr>
+            <p:ph type="body" idx="1"/>
+          </p:nvPr>
+        </p:nvSpPr>
+        <p:spPr/>
+        <p:txBody>
+          <a:bodyPr/>
+          <a:lstStyle/>
+          <a:p>
+            <a:endParaRPr lang="en-US"/>
+          </a:p>
+        </p:txBody>
+      </p:sp>
+      <p:sp>
+        <p:nvSpPr>
+          <p:cNvPr id="4" name="Slide Number Placeholder 3">
+            <a:extLst>
+              <a:ext uri="{FF2B5EF4-FFF2-40B4-BE49-F238E27FC236}">
+                <a16:creationId xmlns:a16="http://schemas.microsoft.com/office/drawing/2014/main" id="{FD3A749C-0CD8-8944-6CB6-BFC00D52AF73}"/>
+              </a:ext>
+            </a:extLst>
+          </p:cNvPr>
+          <p:cNvSpPr>
+            <a:spLocks noGrp="1"/>
+          </p:cNvSpPr>
+          <p:nvPr>
+            <p:ph type="sldNum" sz="quarter" idx="10"/>
+          </p:nvPr>
+        </p:nvSpPr>
+        <p:spPr/>
+        <p:txBody>
+          <a:bodyPr/>
+          <a:lstStyle/>
+          <a:p>
+            <a:fld id="{F7021451-1387-4CA6-816F-3879F97B5CBC}" type="slidenum">
+              <a:rPr lang="en-US"/>
+              <a:t>7</a:t>
+            </a:fld>
+            <a:endParaRPr lang="en-US"/>
+          </a:p>
+        </p:txBody>
+      </p:sp>
+    </p:spTree>
+    <p:extLst>
+      <p:ext uri="{BB962C8B-B14F-4D97-AF65-F5344CB8AC3E}">
+        <p14:creationId xmlns:p14="http://schemas.microsoft.com/office/powerpoint/2010/main" val="1503641096"/>
       </p:ext>
     </p:extLst>
   </p:cSld>
@@ -4120,8 +4228,8 @@
         </p:blipFill>
         <p:spPr>
           <a:xfrm>
-            <a:off x="364435" y="199707"/>
-            <a:ext cx="949579" cy="1119802"/>
+            <a:off x="307189" y="193063"/>
+            <a:ext cx="777534" cy="916916"/>
           </a:xfrm>
           <a:prstGeom prst="rect">
             <a:avLst/>
@@ -4769,7 +4877,7 @@
         <p:spPr>
           <a:xfrm>
             <a:off x="576263" y="345395"/>
-            <a:ext cx="10015195" cy="615294"/>
+            <a:ext cx="10031656" cy="615294"/>
           </a:xfrm>
         </p:spPr>
         <p:txBody>
@@ -4782,18 +4890,45 @@
               <a:buNone/>
             </a:pPr>
             <a:r>
-              <a:rPr lang="en-US" sz="3200">
+              <a:rPr lang="en-US" sz="3200" dirty="0">
                 <a:latin typeface="Calibri" panose="020F0502020204030204" pitchFamily="34" charset="0"/>
                 <a:ea typeface="Calibri" panose="020F0502020204030204" pitchFamily="34" charset="0"/>
                 <a:cs typeface="Calibri" panose="020F0502020204030204" pitchFamily="34" charset="0"/>
               </a:rPr>
-              <a:t>Solution {{n°_solution}} : {{titre_fiche_solution}}</a:t>
-            </a:r>
-            <a:endParaRPr lang="en-US" sz="3200" dirty="0">
-              <a:latin typeface="Calibri" panose="020F0502020204030204" pitchFamily="34" charset="0"/>
-              <a:ea typeface="Calibri" panose="020F0502020204030204" pitchFamily="34" charset="0"/>
-              <a:cs typeface="Calibri" panose="020F0502020204030204" pitchFamily="34" charset="0"/>
-            </a:endParaRPr>
+              <a:t>Solution {{</a:t>
+            </a:r>
+            <a:r>
+              <a:rPr lang="en-US" sz="3200" dirty="0" err="1">
+                <a:latin typeface="Calibri" panose="020F0502020204030204" pitchFamily="34" charset="0"/>
+                <a:ea typeface="Calibri" panose="020F0502020204030204" pitchFamily="34" charset="0"/>
+                <a:cs typeface="Calibri" panose="020F0502020204030204" pitchFamily="34" charset="0"/>
+              </a:rPr>
+              <a:t>n°_solution</a:t>
+            </a:r>
+            <a:r>
+              <a:rPr lang="en-US" sz="3200" dirty="0">
+                <a:latin typeface="Calibri" panose="020F0502020204030204" pitchFamily="34" charset="0"/>
+                <a:ea typeface="Calibri" panose="020F0502020204030204" pitchFamily="34" charset="0"/>
+                <a:cs typeface="Calibri" panose="020F0502020204030204" pitchFamily="34" charset="0"/>
+              </a:rPr>
+              <a:t>}} : {{</a:t>
+            </a:r>
+            <a:r>
+              <a:rPr lang="en-US" sz="3200" dirty="0" err="1">
+                <a:latin typeface="Calibri" panose="020F0502020204030204" pitchFamily="34" charset="0"/>
+                <a:ea typeface="Calibri" panose="020F0502020204030204" pitchFamily="34" charset="0"/>
+                <a:cs typeface="Calibri" panose="020F0502020204030204" pitchFamily="34" charset="0"/>
+              </a:rPr>
+              <a:t>titre_fiche_solution</a:t>
+            </a:r>
+            <a:r>
+              <a:rPr lang="en-US" sz="3200" dirty="0">
+                <a:latin typeface="Calibri" panose="020F0502020204030204" pitchFamily="34" charset="0"/>
+                <a:ea typeface="Calibri" panose="020F0502020204030204" pitchFamily="34" charset="0"/>
+                <a:cs typeface="Calibri" panose="020F0502020204030204" pitchFamily="34" charset="0"/>
+              </a:rPr>
+              <a:t>}}</a:t>
+            </a:r>
           </a:p>
         </p:txBody>
       </p:sp>
@@ -7507,7 +7642,7 @@
       </p:sp>
       <p:sp>
         <p:nvSpPr>
-          <p:cNvPr id="3" name="Titre 1">
+          <p:cNvPr id="3" name="titre_recap_estimation">
             <a:extLst>
               <a:ext uri="{FF2B5EF4-FFF2-40B4-BE49-F238E27FC236}">
                 <a16:creationId xmlns:a16="http://schemas.microsoft.com/office/drawing/2014/main" id="{F82418D9-B39F-2905-A2C1-E7CF651F5D36}"/>
@@ -7576,7 +7711,33 @@
               </a:rPr>
               <a:t>budgétaire</a:t>
             </a:r>
-            <a:endParaRPr lang="en-US" sz="3200" dirty="0"/>
+            <a:r>
+              <a:rPr lang="en-US" sz="3200" dirty="0">
+                <a:latin typeface="Calibri" panose="020F0502020204030204" pitchFamily="34" charset="0"/>
+                <a:ea typeface="Calibri" panose="020F0502020204030204" pitchFamily="34" charset="0"/>
+                <a:cs typeface="Calibri" panose="020F0502020204030204" pitchFamily="34" charset="0"/>
+              </a:rPr>
+              <a:t> {{</a:t>
+            </a:r>
+            <a:r>
+              <a:rPr lang="en-US" sz="3200" dirty="0" err="1">
+                <a:latin typeface="Calibri" panose="020F0502020204030204" pitchFamily="34" charset="0"/>
+                <a:ea typeface="Calibri" panose="020F0502020204030204" pitchFamily="34" charset="0"/>
+                <a:cs typeface="Calibri" panose="020F0502020204030204" pitchFamily="34" charset="0"/>
+              </a:rPr>
+              <a:t>pagination_recap_estimation</a:t>
+            </a:r>
+            <a:r>
+              <a:rPr lang="en-US" sz="3200" dirty="0">
+                <a:latin typeface="Calibri" panose="020F0502020204030204" pitchFamily="34" charset="0"/>
+                <a:ea typeface="Calibri" panose="020F0502020204030204" pitchFamily="34" charset="0"/>
+                <a:cs typeface="Calibri" panose="020F0502020204030204" pitchFamily="34" charset="0"/>
+              </a:rPr>
+              <a:t>}}</a:t>
+            </a:r>
+            <a:endParaRPr lang="fr-FR" sz="1200" dirty="0">
+              <a:latin typeface="Aptos" panose="020B0004020202020204" pitchFamily="34" charset="0"/>
+            </a:endParaRPr>
           </a:p>
         </p:txBody>
       </p:sp>
@@ -8260,6 +8421,100 @@
           </a:p>
         </p:txBody>
       </p:sp>
+      <p:cxnSp>
+        <p:nvCxnSpPr>
+          <p:cNvPr id="10" name="Connecteur droit 9">
+            <a:extLst>
+              <a:ext uri="{FF2B5EF4-FFF2-40B4-BE49-F238E27FC236}">
+                <a16:creationId xmlns:a16="http://schemas.microsoft.com/office/drawing/2014/main" id="{AC020DFA-7CBC-D296-9C51-4CDB5F6EEA67}"/>
+              </a:ext>
+            </a:extLst>
+          </p:cNvPr>
+          <p:cNvCxnSpPr>
+            <a:cxnSpLocks/>
+          </p:cNvCxnSpPr>
+          <p:nvPr/>
+        </p:nvCxnSpPr>
+        <p:spPr>
+          <a:xfrm>
+            <a:off x="576263" y="6512991"/>
+            <a:ext cx="11615737" cy="0"/>
+          </a:xfrm>
+          <a:prstGeom prst="line">
+            <a:avLst/>
+          </a:prstGeom>
+          <a:ln>
+            <a:solidFill>
+              <a:schemeClr val="bg1">
+                <a:lumMod val="85000"/>
+              </a:schemeClr>
+            </a:solidFill>
+          </a:ln>
+        </p:spPr>
+        <p:style>
+          <a:lnRef idx="2">
+            <a:schemeClr val="accent1"/>
+          </a:lnRef>
+          <a:fillRef idx="0">
+            <a:schemeClr val="accent1"/>
+          </a:fillRef>
+          <a:effectRef idx="1">
+            <a:schemeClr val="accent1"/>
+          </a:effectRef>
+          <a:fontRef idx="minor">
+            <a:schemeClr val="tx1"/>
+          </a:fontRef>
+        </p:style>
+      </p:cxnSp>
+      <p:sp>
+        <p:nvSpPr>
+          <p:cNvPr id="17" name="Text 3">
+            <a:extLst>
+              <a:ext uri="{FF2B5EF4-FFF2-40B4-BE49-F238E27FC236}">
+                <a16:creationId xmlns:a16="http://schemas.microsoft.com/office/drawing/2014/main" id="{513ED38C-6EE1-7913-25F4-4C8F7039ADA0}"/>
+              </a:ext>
+            </a:extLst>
+          </p:cNvPr>
+          <p:cNvSpPr/>
+          <p:nvPr/>
+        </p:nvSpPr>
+        <p:spPr>
+          <a:xfrm>
+            <a:off x="576263" y="6598217"/>
+            <a:ext cx="8229600" cy="182880"/>
+          </a:xfrm>
+          <a:prstGeom prst="rect">
+            <a:avLst/>
+          </a:prstGeom>
+          <a:noFill/>
+          <a:ln/>
+        </p:spPr>
+        <p:txBody>
+          <a:bodyPr wrap="square" lIns="0" tIns="0" rIns="0" bIns="0" rtlCol="0" anchor="ctr"/>
+          <a:lstStyle/>
+          <a:p>
+            <a:pPr marL="0" indent="0">
+              <a:buNone/>
+            </a:pPr>
+            <a:r>
+              <a:rPr lang="en-US" sz="1000" i="1">
+                <a:solidFill>
+                  <a:srgbClr val="A0A0A0"/>
+                </a:solidFill>
+                <a:latin typeface="Calibri" panose="020F0502020204030204" pitchFamily="34" charset="0"/>
+                <a:ea typeface="Calibri" panose="020F0502020204030204" pitchFamily="34" charset="0"/>
+                <a:cs typeface="Calibri" panose="020F0502020204030204" pitchFamily="34" charset="0"/>
+              </a:rPr>
+              <a:t>Données issues de Plus fraîche ma ville (ADEME)</a:t>
+            </a:r>
+            <a:endParaRPr lang="en-US" sz="1000">
+              <a:latin typeface="Calibri" panose="020F0502020204030204" pitchFamily="34" charset="0"/>
+              <a:ea typeface="Calibri" panose="020F0502020204030204" pitchFamily="34" charset="0"/>
+              <a:cs typeface="Calibri" panose="020F0502020204030204" pitchFamily="34" charset="0"/>
+            </a:endParaRPr>
+          </a:p>
+        </p:txBody>
+      </p:sp>
     </p:spTree>
     <p:extLst>
       <p:ext uri="{BB962C8B-B14F-4D97-AF65-F5344CB8AC3E}">
@@ -8278,7 +8533,13 @@
   <p:cSld>
     <p:spTree>
       <p:nvGrpSpPr>
-        <p:cNvPr id="1" name=""/>
+        <p:cNvPr id="1" name="">
+          <a:extLst>
+            <a:ext uri="{FF2B5EF4-FFF2-40B4-BE49-F238E27FC236}">
+              <a16:creationId xmlns:a16="http://schemas.microsoft.com/office/drawing/2014/main" id="{955CEECE-80BD-24F5-29ED-51D02A8DC5DD}"/>
+            </a:ext>
+          </a:extLst>
+        </p:cNvPr>
         <p:cNvGrpSpPr/>
         <p:nvPr/>
       </p:nvGrpSpPr>
@@ -8292,45 +8553,303 @@
       </p:grpSpPr>
       <p:sp>
         <p:nvSpPr>
-          <p:cNvPr id="2" name="Titre 1">
-            <a:extLst>
-              <a:ext uri="{FF2B5EF4-FFF2-40B4-BE49-F238E27FC236}">
-                <a16:creationId xmlns:a16="http://schemas.microsoft.com/office/drawing/2014/main" id="{4A72A99C-E15F-6CD3-39F4-5747E50DB9DD}"/>
-              </a:ext>
-            </a:extLst>
-          </p:cNvPr>
-          <p:cNvSpPr>
-            <a:spLocks noGrp="1"/>
-          </p:cNvSpPr>
-          <p:nvPr>
-            <p:ph type="ctrTitle"/>
-          </p:nvPr>
-        </p:nvSpPr>
-        <p:spPr>
-          <a:xfrm>
-            <a:off x="1138566" y="3565278"/>
-            <a:ext cx="2924987" cy="530118"/>
-          </a:xfrm>
-        </p:spPr>
-        <p:txBody>
-          <a:bodyPr>
-            <a:normAutofit/>
-          </a:bodyPr>
-          <a:lstStyle/>
-          <a:p>
-            <a:r>
-              <a:rPr lang="fr-FR" sz="1400" dirty="0"/>
-              <a:t>{{fiche1_titre}}</a:t>
-            </a:r>
+          <p:cNvPr id="3" name="Text 1">
+            <a:extLst>
+              <a:ext uri="{FF2B5EF4-FFF2-40B4-BE49-F238E27FC236}">
+                <a16:creationId xmlns:a16="http://schemas.microsoft.com/office/drawing/2014/main" id="{2CE7C914-9BAE-BFF2-E2E6-8DFEAA338D00}"/>
+              </a:ext>
+            </a:extLst>
+          </p:cNvPr>
+          <p:cNvSpPr/>
+          <p:nvPr/>
+        </p:nvSpPr>
+        <p:spPr>
+          <a:xfrm>
+            <a:off x="609600" y="975360"/>
+            <a:ext cx="10972800" cy="1950720"/>
+          </a:xfrm>
+          <a:prstGeom prst="rect">
+            <a:avLst/>
+          </a:prstGeom>
+          <a:noFill/>
+          <a:ln/>
+        </p:spPr>
+        <p:txBody>
+          <a:bodyPr wrap="square" lIns="0" tIns="0" rIns="0" bIns="0" rtlCol="0" anchor="ctr"/>
+          <a:lstStyle/>
+          <a:p>
+            <a:endParaRPr lang="en-US" sz="13333" dirty="0">
+              <a:latin typeface="Calibri" panose="020F0502020204030204" pitchFamily="34" charset="0"/>
+              <a:ea typeface="Calibri" panose="020F0502020204030204" pitchFamily="34" charset="0"/>
+              <a:cs typeface="Calibri" panose="020F0502020204030204" pitchFamily="34" charset="0"/>
+            </a:endParaRPr>
+          </a:p>
+        </p:txBody>
+      </p:sp>
+      <p:sp>
+        <p:nvSpPr>
+          <p:cNvPr id="4" name="Text 2">
+            <a:extLst>
+              <a:ext uri="{FF2B5EF4-FFF2-40B4-BE49-F238E27FC236}">
+                <a16:creationId xmlns:a16="http://schemas.microsoft.com/office/drawing/2014/main" id="{3AA7DA23-AC46-53C2-5481-F11CF1FF75EA}"/>
+              </a:ext>
+            </a:extLst>
+          </p:cNvPr>
+          <p:cNvSpPr/>
+          <p:nvPr/>
+        </p:nvSpPr>
+        <p:spPr>
+          <a:xfrm>
+            <a:off x="609600" y="2202220"/>
+            <a:ext cx="10972800" cy="792480"/>
+          </a:xfrm>
+          <a:prstGeom prst="rect">
+            <a:avLst/>
+          </a:prstGeom>
+          <a:noFill/>
+          <a:ln/>
+        </p:spPr>
+        <p:txBody>
+          <a:bodyPr wrap="square" lIns="0" tIns="0" rIns="0" bIns="0" rtlCol="0" anchor="ctr"/>
+          <a:lstStyle/>
+          <a:p>
+            <a:r>
+              <a:rPr lang="en-US" sz="3733" b="1" dirty="0" err="1">
+                <a:solidFill>
+                  <a:srgbClr val="1A1A1A"/>
+                </a:solidFill>
+                <a:latin typeface="Aptos" panose="020B0004020202020204" pitchFamily="34" charset="0"/>
+                <a:ea typeface="Calibri" pitchFamily="34" charset="-122"/>
+                <a:cs typeface="Calibri" pitchFamily="34" charset="-120"/>
+              </a:rPr>
+              <a:t>Ressources</a:t>
+            </a:r>
+            <a:r>
+              <a:rPr lang="en-US" sz="3733" b="1" dirty="0">
+                <a:solidFill>
+                  <a:srgbClr val="1A1A1A"/>
+                </a:solidFill>
+                <a:latin typeface="Aptos" panose="020B0004020202020204" pitchFamily="34" charset="0"/>
+                <a:ea typeface="Calibri" pitchFamily="34" charset="-122"/>
+                <a:cs typeface="Calibri" pitchFamily="34" charset="-120"/>
+              </a:rPr>
+              <a:t> </a:t>
+            </a:r>
+            <a:r>
+              <a:rPr lang="en-US" sz="3733" b="1" dirty="0" err="1">
+                <a:solidFill>
+                  <a:srgbClr val="1A1A1A"/>
+                </a:solidFill>
+                <a:latin typeface="Aptos" panose="020B0004020202020204" pitchFamily="34" charset="0"/>
+                <a:ea typeface="Calibri" pitchFamily="34" charset="-122"/>
+                <a:cs typeface="Calibri" pitchFamily="34" charset="-120"/>
+              </a:rPr>
+              <a:t>utiles</a:t>
+            </a:r>
+            <a:endParaRPr lang="en-US" sz="3733" dirty="0">
+              <a:latin typeface="Aptos" panose="020B0004020202020204" pitchFamily="34" charset="0"/>
+            </a:endParaRPr>
+          </a:p>
+        </p:txBody>
+      </p:sp>
+      <p:sp>
+        <p:nvSpPr>
+          <p:cNvPr id="5" name="Shape 3">
+            <a:extLst>
+              <a:ext uri="{FF2B5EF4-FFF2-40B4-BE49-F238E27FC236}">
+                <a16:creationId xmlns:a16="http://schemas.microsoft.com/office/drawing/2014/main" id="{302F78CA-65FF-9043-6070-1584BC6D4D54}"/>
+              </a:ext>
+            </a:extLst>
+          </p:cNvPr>
+          <p:cNvSpPr/>
+          <p:nvPr/>
+        </p:nvSpPr>
+        <p:spPr>
+          <a:xfrm>
+            <a:off x="609600" y="3080044"/>
+            <a:ext cx="731520" cy="48768"/>
+          </a:xfrm>
+          <a:prstGeom prst="rect">
+            <a:avLst/>
+          </a:prstGeom>
+          <a:solidFill>
+            <a:srgbClr val="1A1A1A"/>
+          </a:solidFill>
+          <a:ln w="12700">
+            <a:solidFill>
+              <a:srgbClr val="1A1A1A"/>
+            </a:solidFill>
+            <a:prstDash val="solid"/>
+          </a:ln>
+        </p:spPr>
+        <p:txBody>
+          <a:bodyPr/>
+          <a:lstStyle/>
+          <a:p>
+            <a:endParaRPr lang="fr-FR" sz="2400">
+              <a:latin typeface="Calibri" panose="020F0502020204030204" pitchFamily="34" charset="0"/>
+              <a:ea typeface="Calibri" panose="020F0502020204030204" pitchFamily="34" charset="0"/>
+              <a:cs typeface="Calibri" panose="020F0502020204030204" pitchFamily="34" charset="0"/>
+            </a:endParaRPr>
+          </a:p>
+        </p:txBody>
+      </p:sp>
+      <p:sp>
+        <p:nvSpPr>
+          <p:cNvPr id="6" name="Text 4">
+            <a:extLst>
+              <a:ext uri="{FF2B5EF4-FFF2-40B4-BE49-F238E27FC236}">
+                <a16:creationId xmlns:a16="http://schemas.microsoft.com/office/drawing/2014/main" id="{9328B9A3-CC8F-11E9-FAB1-0824EF7E88D7}"/>
+              </a:ext>
+            </a:extLst>
+          </p:cNvPr>
+          <p:cNvSpPr/>
+          <p:nvPr/>
+        </p:nvSpPr>
+        <p:spPr>
+          <a:xfrm>
+            <a:off x="609600" y="3398401"/>
+            <a:ext cx="10972800" cy="2879386"/>
+          </a:xfrm>
+          <a:prstGeom prst="rect">
+            <a:avLst/>
+          </a:prstGeom>
+          <a:noFill/>
+          <a:ln/>
+        </p:spPr>
+        <p:txBody>
+          <a:bodyPr wrap="square" lIns="0" tIns="0" rIns="0" bIns="0" rtlCol="0" anchor="t"/>
+          <a:lstStyle/>
+          <a:p>
+            <a:pPr marL="0" indent="0">
+              <a:buNone/>
+            </a:pPr>
+            <a:r>
+              <a:rPr lang="en-US" sz="1600" dirty="0">
+                <a:solidFill>
+                  <a:srgbClr val="5C5C5C"/>
+                </a:solidFill>
+                <a:latin typeface="Calibri" pitchFamily="34" charset="0"/>
+                <a:ea typeface="Calibri" pitchFamily="34" charset="-122"/>
+                <a:cs typeface="Calibri" pitchFamily="34" charset="-120"/>
+              </a:rPr>
+              <a:t>Documentation </a:t>
+            </a:r>
+            <a:r>
+              <a:rPr lang="en-US" sz="1600" dirty="0" err="1">
+                <a:solidFill>
+                  <a:srgbClr val="5C5C5C"/>
+                </a:solidFill>
+                <a:latin typeface="Calibri" pitchFamily="34" charset="0"/>
+                <a:ea typeface="Calibri" pitchFamily="34" charset="-122"/>
+                <a:cs typeface="Calibri" pitchFamily="34" charset="-120"/>
+              </a:rPr>
+              <a:t>complémentaire</a:t>
+            </a:r>
+            <a:endParaRPr lang="en-US" sz="1600" dirty="0"/>
+          </a:p>
+        </p:txBody>
+      </p:sp>
+      <p:cxnSp>
+        <p:nvCxnSpPr>
+          <p:cNvPr id="2" name="Connecteur droit 1">
+            <a:extLst>
+              <a:ext uri="{FF2B5EF4-FFF2-40B4-BE49-F238E27FC236}">
+                <a16:creationId xmlns:a16="http://schemas.microsoft.com/office/drawing/2014/main" id="{A3CAC41A-66B0-361D-B372-62D87EE7A9F8}"/>
+              </a:ext>
+            </a:extLst>
+          </p:cNvPr>
+          <p:cNvCxnSpPr>
+            <a:cxnSpLocks/>
+          </p:cNvCxnSpPr>
+          <p:nvPr/>
+        </p:nvCxnSpPr>
+        <p:spPr>
+          <a:xfrm>
+            <a:off x="576263" y="6512991"/>
+            <a:ext cx="11615737" cy="0"/>
+          </a:xfrm>
+          <a:prstGeom prst="line">
+            <a:avLst/>
+          </a:prstGeom>
+          <a:ln>
+            <a:solidFill>
+              <a:schemeClr val="bg1">
+                <a:lumMod val="85000"/>
+              </a:schemeClr>
+            </a:solidFill>
+          </a:ln>
+        </p:spPr>
+        <p:style>
+          <a:lnRef idx="2">
+            <a:schemeClr val="accent1"/>
+          </a:lnRef>
+          <a:fillRef idx="0">
+            <a:schemeClr val="accent1"/>
+          </a:fillRef>
+          <a:effectRef idx="1">
+            <a:schemeClr val="accent1"/>
+          </a:effectRef>
+          <a:fontRef idx="minor">
+            <a:schemeClr val="tx1"/>
+          </a:fontRef>
+        </p:style>
+      </p:cxnSp>
+      <p:sp>
+        <p:nvSpPr>
+          <p:cNvPr id="8" name="Text 3">
+            <a:extLst>
+              <a:ext uri="{FF2B5EF4-FFF2-40B4-BE49-F238E27FC236}">
+                <a16:creationId xmlns:a16="http://schemas.microsoft.com/office/drawing/2014/main" id="{515558A7-65FA-3B23-4336-CA7CF66783E3}"/>
+              </a:ext>
+            </a:extLst>
+          </p:cNvPr>
+          <p:cNvSpPr/>
+          <p:nvPr/>
+        </p:nvSpPr>
+        <p:spPr>
+          <a:xfrm>
+            <a:off x="576263" y="6598217"/>
+            <a:ext cx="8229600" cy="182880"/>
+          </a:xfrm>
+          <a:prstGeom prst="rect">
+            <a:avLst/>
+          </a:prstGeom>
+          <a:noFill/>
+          <a:ln/>
+        </p:spPr>
+        <p:txBody>
+          <a:bodyPr wrap="square" lIns="0" tIns="0" rIns="0" bIns="0" rtlCol="0" anchor="ctr"/>
+          <a:lstStyle/>
+          <a:p>
+            <a:pPr marL="0" indent="0">
+              <a:buNone/>
+            </a:pPr>
+            <a:r>
+              <a:rPr lang="en-US" sz="1000" i="1">
+                <a:solidFill>
+                  <a:srgbClr val="A0A0A0"/>
+                </a:solidFill>
+                <a:latin typeface="Calibri" panose="020F0502020204030204" pitchFamily="34" charset="0"/>
+                <a:ea typeface="Calibri" panose="020F0502020204030204" pitchFamily="34" charset="0"/>
+                <a:cs typeface="Calibri" panose="020F0502020204030204" pitchFamily="34" charset="0"/>
+              </a:rPr>
+              <a:t>Données issues de Plus fraîche ma ville (ADEME)</a:t>
+            </a:r>
+            <a:endParaRPr lang="en-US" sz="1000">
+              <a:latin typeface="Calibri" panose="020F0502020204030204" pitchFamily="34" charset="0"/>
+              <a:ea typeface="Calibri" panose="020F0502020204030204" pitchFamily="34" charset="0"/>
+              <a:cs typeface="Calibri" panose="020F0502020204030204" pitchFamily="34" charset="0"/>
+            </a:endParaRPr>
           </a:p>
         </p:txBody>
       </p:sp>
       <p:pic>
         <p:nvPicPr>
-          <p:cNvPr id="5" name="fiche1_image">
-            <a:extLst>
-              <a:ext uri="{FF2B5EF4-FFF2-40B4-BE49-F238E27FC236}">
-                <a16:creationId xmlns:a16="http://schemas.microsoft.com/office/drawing/2014/main" id="{5D7982A6-7118-576E-5274-9B022A908D5F}"/>
+          <p:cNvPr id="9" name="Image 8" descr="Une image contenant Police, Graphique, logo, graphisme&#10;&#10;Description générée automatiquement">
+            <a:extLst>
+              <a:ext uri="{FF2B5EF4-FFF2-40B4-BE49-F238E27FC236}">
+                <a16:creationId xmlns:a16="http://schemas.microsoft.com/office/drawing/2014/main" id="{5FA40CA5-18D5-ABCF-9EE1-BF9C0AE210FD}"/>
               </a:ext>
             </a:extLst>
           </p:cNvPr>
@@ -8340,135 +8859,26 @@
           <p:nvPr/>
         </p:nvPicPr>
         <p:blipFill>
-          <a:blip r:embed="rId2"/>
-          <a:stretch>
-            <a:fillRect/>
-          </a:stretch>
+          <a:blip r:embed="rId3"/>
+          <a:srcRect t="19804" b="18118"/>
+          <a:stretch/>
         </p:blipFill>
         <p:spPr>
           <a:xfrm>
-            <a:off x="1460616" y="1418754"/>
-            <a:ext cx="2280889" cy="1973353"/>
+            <a:off x="10763987" y="98854"/>
+            <a:ext cx="1229053" cy="762977"/>
           </a:xfrm>
           <a:prstGeom prst="rect">
             <a:avLst/>
           </a:prstGeom>
         </p:spPr>
       </p:pic>
-      <p:sp>
-        <p:nvSpPr>
-          <p:cNvPr id="8" name="Titre 1">
-            <a:extLst>
-              <a:ext uri="{FF2B5EF4-FFF2-40B4-BE49-F238E27FC236}">
-                <a16:creationId xmlns:a16="http://schemas.microsoft.com/office/drawing/2014/main" id="{DFD446A5-1AE0-FC42-6104-416E85007852}"/>
-              </a:ext>
-            </a:extLst>
-          </p:cNvPr>
-          <p:cNvSpPr txBox="1">
-            <a:spLocks/>
-          </p:cNvSpPr>
-          <p:nvPr/>
-        </p:nvSpPr>
-        <p:spPr>
-          <a:xfrm>
-            <a:off x="1003243" y="4268567"/>
-            <a:ext cx="3060310" cy="2386461"/>
-          </a:xfrm>
-          <a:prstGeom prst="rect">
-            <a:avLst/>
-          </a:prstGeom>
-        </p:spPr>
-        <p:txBody>
-          <a:bodyPr vert="horz" lIns="91440" tIns="45720" rIns="91440" bIns="45720" rtlCol="0" anchor="b">
-            <a:normAutofit/>
-          </a:bodyPr>
-          <a:lstStyle>
-            <a:lvl1pPr algn="ctr" defTabSz="914400" rtl="0" eaLnBrk="1" latinLnBrk="0" hangingPunct="1">
-              <a:lnSpc>
-                <a:spcPct val="90000"/>
-              </a:lnSpc>
-              <a:spcBef>
-                <a:spcPct val="0"/>
-              </a:spcBef>
-              <a:buNone/>
-              <a:defRPr sz="6000" kern="1200">
-                <a:solidFill>
-                  <a:schemeClr val="tx1"/>
-                </a:solidFill>
-                <a:latin typeface="+mj-lt"/>
-                <a:ea typeface="+mj-ea"/>
-                <a:cs typeface="+mj-cs"/>
-              </a:defRPr>
-            </a:lvl1pPr>
-          </a:lstStyle>
-          <a:p>
-            <a:r>
-              <a:rPr lang="fr-FR" sz="1200" dirty="0"/>
-              <a:t>{{fiche1_description}}</a:t>
-            </a:r>
-          </a:p>
-        </p:txBody>
-      </p:sp>
-      <p:sp>
-        <p:nvSpPr>
-          <p:cNvPr id="9" name="Titre 1">
-            <a:extLst>
-              <a:ext uri="{FF2B5EF4-FFF2-40B4-BE49-F238E27FC236}">
-                <a16:creationId xmlns:a16="http://schemas.microsoft.com/office/drawing/2014/main" id="{D96C96BC-B8F7-C618-B100-303616F41F4F}"/>
-              </a:ext>
-            </a:extLst>
-          </p:cNvPr>
-          <p:cNvSpPr txBox="1">
-            <a:spLocks/>
-          </p:cNvSpPr>
-          <p:nvPr/>
-        </p:nvSpPr>
-        <p:spPr>
-          <a:xfrm>
-            <a:off x="4733413" y="3565278"/>
-            <a:ext cx="2924987" cy="530118"/>
-          </a:xfrm>
-          <a:prstGeom prst="rect">
-            <a:avLst/>
-          </a:prstGeom>
-        </p:spPr>
-        <p:txBody>
-          <a:bodyPr vert="horz" lIns="91440" tIns="45720" rIns="91440" bIns="45720" rtlCol="0" anchor="b">
-            <a:normAutofit/>
-          </a:bodyPr>
-          <a:lstStyle>
-            <a:lvl1pPr algn="ctr" defTabSz="914400" rtl="0" eaLnBrk="1" latinLnBrk="0" hangingPunct="1">
-              <a:lnSpc>
-                <a:spcPct val="90000"/>
-              </a:lnSpc>
-              <a:spcBef>
-                <a:spcPct val="0"/>
-              </a:spcBef>
-              <a:buNone/>
-              <a:defRPr sz="6000" kern="1200">
-                <a:solidFill>
-                  <a:schemeClr val="tx1"/>
-                </a:solidFill>
-                <a:latin typeface="+mj-lt"/>
-                <a:ea typeface="+mj-ea"/>
-                <a:cs typeface="+mj-cs"/>
-              </a:defRPr>
-            </a:lvl1pPr>
-          </a:lstStyle>
-          <a:p>
-            <a:r>
-              <a:rPr lang="fr-FR" sz="1400" dirty="0"/>
-              <a:t>{{fiche2_titre}}</a:t>
-            </a:r>
-          </a:p>
-        </p:txBody>
-      </p:sp>
       <p:pic>
         <p:nvPicPr>
-          <p:cNvPr id="10" name="fiche2_image">
-            <a:extLst>
-              <a:ext uri="{FF2B5EF4-FFF2-40B4-BE49-F238E27FC236}">
-                <a16:creationId xmlns:a16="http://schemas.microsoft.com/office/drawing/2014/main" id="{1B6B780A-A39D-636C-4D64-802525F4EC76}"/>
+          <p:cNvPr id="10" name="Picture 9">
+            <a:extLst>
+              <a:ext uri="{FF2B5EF4-FFF2-40B4-BE49-F238E27FC236}">
+                <a16:creationId xmlns:a16="http://schemas.microsoft.com/office/drawing/2014/main" id="{E922595D-B49E-4187-3566-440EF1D1B583}"/>
               </a:ext>
             </a:extLst>
           </p:cNvPr>
@@ -8478,218 +8888,25 @@
           <p:nvPr/>
         </p:nvPicPr>
         <p:blipFill>
-          <a:blip r:embed="rId2"/>
+          <a:blip r:embed="rId4"/>
           <a:stretch>
             <a:fillRect/>
           </a:stretch>
         </p:blipFill>
         <p:spPr>
           <a:xfrm>
-            <a:off x="5055463" y="1418754"/>
-            <a:ext cx="2280889" cy="1973353"/>
+            <a:off x="10546452" y="104580"/>
+            <a:ext cx="1552051" cy="758533"/>
           </a:xfrm>
           <a:prstGeom prst="rect">
             <a:avLst/>
           </a:prstGeom>
         </p:spPr>
       </p:pic>
-      <p:sp>
-        <p:nvSpPr>
-          <p:cNvPr id="11" name="Titre 1">
-            <a:extLst>
-              <a:ext uri="{FF2B5EF4-FFF2-40B4-BE49-F238E27FC236}">
-                <a16:creationId xmlns:a16="http://schemas.microsoft.com/office/drawing/2014/main" id="{DF4FAFD1-C5C8-F650-D808-D9A446485065}"/>
-              </a:ext>
-            </a:extLst>
-          </p:cNvPr>
-          <p:cNvSpPr txBox="1">
-            <a:spLocks/>
-          </p:cNvSpPr>
-          <p:nvPr/>
-        </p:nvSpPr>
-        <p:spPr>
-          <a:xfrm>
-            <a:off x="4598090" y="4268567"/>
-            <a:ext cx="3060310" cy="2386461"/>
-          </a:xfrm>
-          <a:prstGeom prst="rect">
-            <a:avLst/>
-          </a:prstGeom>
-        </p:spPr>
-        <p:txBody>
-          <a:bodyPr vert="horz" lIns="91440" tIns="45720" rIns="91440" bIns="45720" rtlCol="0" anchor="b">
-            <a:normAutofit/>
-          </a:bodyPr>
-          <a:lstStyle>
-            <a:lvl1pPr algn="ctr" defTabSz="914400" rtl="0" eaLnBrk="1" latinLnBrk="0" hangingPunct="1">
-              <a:lnSpc>
-                <a:spcPct val="90000"/>
-              </a:lnSpc>
-              <a:spcBef>
-                <a:spcPct val="0"/>
-              </a:spcBef>
-              <a:buNone/>
-              <a:defRPr sz="6000" kern="1200">
-                <a:solidFill>
-                  <a:schemeClr val="tx1"/>
-                </a:solidFill>
-                <a:latin typeface="+mj-lt"/>
-                <a:ea typeface="+mj-ea"/>
-                <a:cs typeface="+mj-cs"/>
-              </a:defRPr>
-            </a:lvl1pPr>
-          </a:lstStyle>
-          <a:p>
-            <a:r>
-              <a:rPr lang="fr-FR" sz="1200" dirty="0"/>
-              <a:t>{{fiche2_description}}</a:t>
-            </a:r>
-          </a:p>
-        </p:txBody>
-      </p:sp>
-      <p:sp>
-        <p:nvSpPr>
-          <p:cNvPr id="12" name="Titre 1">
-            <a:extLst>
-              <a:ext uri="{FF2B5EF4-FFF2-40B4-BE49-F238E27FC236}">
-                <a16:creationId xmlns:a16="http://schemas.microsoft.com/office/drawing/2014/main" id="{2322BB7D-3CC3-52EC-9176-598B063FF26D}"/>
-              </a:ext>
-            </a:extLst>
-          </p:cNvPr>
-          <p:cNvSpPr txBox="1">
-            <a:spLocks/>
-          </p:cNvSpPr>
-          <p:nvPr/>
-        </p:nvSpPr>
-        <p:spPr>
-          <a:xfrm>
-            <a:off x="8529966" y="3565278"/>
-            <a:ext cx="2924987" cy="530118"/>
-          </a:xfrm>
-          <a:prstGeom prst="rect">
-            <a:avLst/>
-          </a:prstGeom>
-        </p:spPr>
-        <p:txBody>
-          <a:bodyPr vert="horz" lIns="91440" tIns="45720" rIns="91440" bIns="45720" rtlCol="0" anchor="b">
-            <a:normAutofit/>
-          </a:bodyPr>
-          <a:lstStyle>
-            <a:lvl1pPr algn="ctr" defTabSz="914400" rtl="0" eaLnBrk="1" latinLnBrk="0" hangingPunct="1">
-              <a:lnSpc>
-                <a:spcPct val="90000"/>
-              </a:lnSpc>
-              <a:spcBef>
-                <a:spcPct val="0"/>
-              </a:spcBef>
-              <a:buNone/>
-              <a:defRPr sz="6000" kern="1200">
-                <a:solidFill>
-                  <a:schemeClr val="tx1"/>
-                </a:solidFill>
-                <a:latin typeface="+mj-lt"/>
-                <a:ea typeface="+mj-ea"/>
-                <a:cs typeface="+mj-cs"/>
-              </a:defRPr>
-            </a:lvl1pPr>
-          </a:lstStyle>
-          <a:p>
-            <a:r>
-              <a:rPr lang="fr-FR" sz="1400" dirty="0"/>
-              <a:t>{{fiche3_titre}}</a:t>
-            </a:r>
-          </a:p>
-        </p:txBody>
-      </p:sp>
-      <p:pic>
-        <p:nvPicPr>
-          <p:cNvPr id="13" name="fiche3_image">
-            <a:extLst>
-              <a:ext uri="{FF2B5EF4-FFF2-40B4-BE49-F238E27FC236}">
-                <a16:creationId xmlns:a16="http://schemas.microsoft.com/office/drawing/2014/main" id="{39719801-C60D-A9CB-865F-AA2451EF1643}"/>
-              </a:ext>
-            </a:extLst>
-          </p:cNvPr>
-          <p:cNvPicPr>
-            <a:picLocks noChangeAspect="1"/>
-          </p:cNvPicPr>
-          <p:nvPr/>
-        </p:nvPicPr>
-        <p:blipFill>
-          <a:blip r:embed="rId2"/>
-          <a:stretch>
-            <a:fillRect/>
-          </a:stretch>
-        </p:blipFill>
-        <p:spPr>
-          <a:xfrm>
-            <a:off x="8852016" y="1418754"/>
-            <a:ext cx="2280889" cy="1973353"/>
-          </a:xfrm>
-          <a:prstGeom prst="rect">
-            <a:avLst/>
-          </a:prstGeom>
-        </p:spPr>
-      </p:pic>
-      <p:sp>
-        <p:nvSpPr>
-          <p:cNvPr id="14" name="Titre 1">
-            <a:extLst>
-              <a:ext uri="{FF2B5EF4-FFF2-40B4-BE49-F238E27FC236}">
-                <a16:creationId xmlns:a16="http://schemas.microsoft.com/office/drawing/2014/main" id="{2B5F9271-D23A-AE1F-9887-C0E8E46B34B2}"/>
-              </a:ext>
-            </a:extLst>
-          </p:cNvPr>
-          <p:cNvSpPr txBox="1">
-            <a:spLocks/>
-          </p:cNvSpPr>
-          <p:nvPr/>
-        </p:nvSpPr>
-        <p:spPr>
-          <a:xfrm>
-            <a:off x="8394643" y="4268567"/>
-            <a:ext cx="3060310" cy="2386461"/>
-          </a:xfrm>
-          <a:prstGeom prst="rect">
-            <a:avLst/>
-          </a:prstGeom>
-        </p:spPr>
-        <p:txBody>
-          <a:bodyPr vert="horz" lIns="91440" tIns="45720" rIns="91440" bIns="45720" rtlCol="0" anchor="b">
-            <a:normAutofit/>
-          </a:bodyPr>
-          <a:lstStyle>
-            <a:lvl1pPr algn="ctr" defTabSz="914400" rtl="0" eaLnBrk="1" latinLnBrk="0" hangingPunct="1">
-              <a:lnSpc>
-                <a:spcPct val="90000"/>
-              </a:lnSpc>
-              <a:spcBef>
-                <a:spcPct val="0"/>
-              </a:spcBef>
-              <a:buNone/>
-              <a:defRPr sz="6000" kern="1200">
-                <a:solidFill>
-                  <a:schemeClr val="tx1"/>
-                </a:solidFill>
-                <a:latin typeface="+mj-lt"/>
-                <a:ea typeface="+mj-ea"/>
-                <a:cs typeface="+mj-cs"/>
-              </a:defRPr>
-            </a:lvl1pPr>
-          </a:lstStyle>
-          <a:p>
-            <a:r>
-              <a:rPr lang="fr-FR" sz="1200"/>
-              <a:t>{{fiche3_description}}</a:t>
-            </a:r>
-            <a:endParaRPr lang="fr-FR" sz="1200" dirty="0"/>
-          </a:p>
-        </p:txBody>
-      </p:sp>
     </p:spTree>
     <p:extLst>
       <p:ext uri="{BB962C8B-B14F-4D97-AF65-F5344CB8AC3E}">
-        <p14:creationId xmlns:p14="http://schemas.microsoft.com/office/powerpoint/2010/main" val="4009440306"/>
+        <p14:creationId xmlns:p14="http://schemas.microsoft.com/office/powerpoint/2010/main" val="2848617555"/>
       </p:ext>
     </p:extLst>
   </p:cSld>
@@ -8704,7 +8921,13 @@
   <p:cSld>
     <p:spTree>
       <p:nvGrpSpPr>
-        <p:cNvPr id="1" name=""/>
+        <p:cNvPr id="1" name="">
+          <a:extLst>
+            <a:ext uri="{FF2B5EF4-FFF2-40B4-BE49-F238E27FC236}">
+              <a16:creationId xmlns:a16="http://schemas.microsoft.com/office/drawing/2014/main" id="{1917CAA9-6ECD-8F49-8289-13579AAE1FB7}"/>
+            </a:ext>
+          </a:extLst>
+        </p:cNvPr>
         <p:cNvGrpSpPr/>
         <p:nvPr/>
       </p:nvGrpSpPr>
@@ -8718,10 +8941,10 @@
       </p:grpSpPr>
       <p:sp>
         <p:nvSpPr>
-          <p:cNvPr id="4" name="Titre 3">
-            <a:extLst>
-              <a:ext uri="{FF2B5EF4-FFF2-40B4-BE49-F238E27FC236}">
-                <a16:creationId xmlns:a16="http://schemas.microsoft.com/office/drawing/2014/main" id="{34E2C556-0F82-2AF8-1F6F-094222D11943}"/>
+          <p:cNvPr id="2" name="Titre 1">
+            <a:extLst>
+              <a:ext uri="{FF2B5EF4-FFF2-40B4-BE49-F238E27FC236}">
+                <a16:creationId xmlns:a16="http://schemas.microsoft.com/office/drawing/2014/main" id="{474A7BA3-D950-9097-DDDD-F688CBFCCB67}"/>
               </a:ext>
             </a:extLst>
           </p:cNvPr>
@@ -8729,30 +8952,458 @@
             <a:spLocks noGrp="1"/>
           </p:cNvSpPr>
           <p:nvPr>
-            <p:ph type="ctrTitle"/>
+            <p:ph type="title"/>
           </p:nvPr>
         </p:nvSpPr>
         <p:spPr>
           <a:xfrm>
-            <a:off x="1327178" y="474492"/>
-            <a:ext cx="9144000" cy="923761"/>
-          </a:xfrm>
-        </p:spPr>
-        <p:txBody>
-          <a:bodyPr/>
-          <a:lstStyle/>
-          <a:p>
-            <a:r>
-              <a:rPr lang="fr-FR" dirty="0"/>
-              <a:t>Carte LCZ</a:t>
-            </a:r>
+            <a:off x="576263" y="345395"/>
+            <a:ext cx="10031656" cy="615294"/>
+          </a:xfrm>
+        </p:spPr>
+        <p:txBody>
+          <a:bodyPr>
+            <a:normAutofit/>
+          </a:bodyPr>
+          <a:lstStyle/>
+          <a:p>
+            <a:pPr marL="0" indent="0">
+              <a:buNone/>
+            </a:pPr>
+            <a:r>
+              <a:rPr lang="en-US" sz="3200" dirty="0" err="1"/>
+              <a:t>Ressources</a:t>
+            </a:r>
+            <a:r>
+              <a:rPr lang="en-US" sz="3200" dirty="0"/>
+              <a:t> </a:t>
+            </a:r>
+            <a:r>
+              <a:rPr lang="en-US" sz="3200" dirty="0" err="1"/>
+              <a:t>utiles</a:t>
+            </a:r>
+            <a:r>
+              <a:rPr lang="en-US" sz="3200" dirty="0">
+                <a:latin typeface="Calibri" panose="020F0502020204030204" pitchFamily="34" charset="0"/>
+                <a:ea typeface="Calibri" panose="020F0502020204030204" pitchFamily="34" charset="0"/>
+                <a:cs typeface="Calibri" panose="020F0502020204030204" pitchFamily="34" charset="0"/>
+              </a:rPr>
+              <a:t> {{</a:t>
+            </a:r>
+            <a:r>
+              <a:rPr lang="en-US" sz="3200" dirty="0" err="1">
+                <a:latin typeface="Calibri" panose="020F0502020204030204" pitchFamily="34" charset="0"/>
+                <a:ea typeface="Calibri" panose="020F0502020204030204" pitchFamily="34" charset="0"/>
+                <a:cs typeface="Calibri" panose="020F0502020204030204" pitchFamily="34" charset="0"/>
+              </a:rPr>
+              <a:t>pagination_ressources_utiles</a:t>
+            </a:r>
+            <a:r>
+              <a:rPr lang="en-US" sz="3200" dirty="0">
+                <a:latin typeface="Calibri" panose="020F0502020204030204" pitchFamily="34" charset="0"/>
+                <a:ea typeface="Calibri" panose="020F0502020204030204" pitchFamily="34" charset="0"/>
+                <a:cs typeface="Calibri" panose="020F0502020204030204" pitchFamily="34" charset="0"/>
+              </a:rPr>
+              <a:t>}}</a:t>
+            </a:r>
+          </a:p>
+        </p:txBody>
+      </p:sp>
+      <p:sp>
+        <p:nvSpPr>
+          <p:cNvPr id="5" name="zone_titre_fiche_solution">
+            <a:extLst>
+              <a:ext uri="{FF2B5EF4-FFF2-40B4-BE49-F238E27FC236}">
+                <a16:creationId xmlns:a16="http://schemas.microsoft.com/office/drawing/2014/main" id="{C76718D3-101C-1B45-FD71-3691F60DE7E5}"/>
+              </a:ext>
+            </a:extLst>
+          </p:cNvPr>
+          <p:cNvSpPr txBox="1"/>
+          <p:nvPr/>
+        </p:nvSpPr>
+        <p:spPr>
+          <a:xfrm>
+            <a:off x="576263" y="1093598"/>
+            <a:ext cx="9706988" cy="400110"/>
+          </a:xfrm>
+          <a:prstGeom prst="rect">
+            <a:avLst/>
+          </a:prstGeom>
+          <a:noFill/>
+        </p:spPr>
+        <p:txBody>
+          <a:bodyPr wrap="square">
+            <a:spAutoFit/>
+          </a:bodyPr>
+          <a:lstStyle/>
+          <a:p>
+            <a:r>
+              <a:rPr lang="fr-FR" sz="2000" b="1" dirty="0">
+                <a:solidFill>
+                  <a:srgbClr val="161616"/>
+                </a:solidFill>
+                <a:latin typeface="Calibri" panose="020F0502020204030204" pitchFamily="34" charset="0"/>
+                <a:ea typeface="Calibri" panose="020F0502020204030204" pitchFamily="34" charset="0"/>
+                <a:cs typeface="Calibri" panose="020F0502020204030204" pitchFamily="34" charset="0"/>
+              </a:rPr>
+              <a:t>{{</a:t>
+            </a:r>
+            <a:r>
+              <a:rPr lang="fr-FR" sz="2000" b="1" dirty="0" err="1">
+                <a:solidFill>
+                  <a:srgbClr val="161616"/>
+                </a:solidFill>
+                <a:latin typeface="Calibri" panose="020F0502020204030204" pitchFamily="34" charset="0"/>
+                <a:ea typeface="Calibri" panose="020F0502020204030204" pitchFamily="34" charset="0"/>
+                <a:cs typeface="Calibri" panose="020F0502020204030204" pitchFamily="34" charset="0"/>
+              </a:rPr>
+              <a:t>titre_fiche_solution</a:t>
+            </a:r>
+            <a:r>
+              <a:rPr lang="fr-FR" sz="2000" b="1" dirty="0">
+                <a:solidFill>
+                  <a:srgbClr val="161616"/>
+                </a:solidFill>
+                <a:latin typeface="Calibri" panose="020F0502020204030204" pitchFamily="34" charset="0"/>
+                <a:ea typeface="Calibri" panose="020F0502020204030204" pitchFamily="34" charset="0"/>
+                <a:cs typeface="Calibri" panose="020F0502020204030204" pitchFamily="34" charset="0"/>
+              </a:rPr>
+              <a:t>}}</a:t>
+            </a:r>
+            <a:endParaRPr lang="fr-FR" sz="2000" dirty="0">
+              <a:latin typeface="Calibri" panose="020F0502020204030204" pitchFamily="34" charset="0"/>
+              <a:ea typeface="Calibri" panose="020F0502020204030204" pitchFamily="34" charset="0"/>
+              <a:cs typeface="Calibri" panose="020F0502020204030204" pitchFamily="34" charset="0"/>
+            </a:endParaRPr>
+          </a:p>
+        </p:txBody>
+      </p:sp>
+      <p:cxnSp>
+        <p:nvCxnSpPr>
+          <p:cNvPr id="34" name="Connecteur droit 33">
+            <a:extLst>
+              <a:ext uri="{FF2B5EF4-FFF2-40B4-BE49-F238E27FC236}">
+                <a16:creationId xmlns:a16="http://schemas.microsoft.com/office/drawing/2014/main" id="{B62F42A1-9E9E-D546-190A-5C7D09368113}"/>
+              </a:ext>
+            </a:extLst>
+          </p:cNvPr>
+          <p:cNvCxnSpPr>
+            <a:cxnSpLocks/>
+          </p:cNvCxnSpPr>
+          <p:nvPr/>
+        </p:nvCxnSpPr>
+        <p:spPr>
+          <a:xfrm>
+            <a:off x="576263" y="960689"/>
+            <a:ext cx="11615737" cy="0"/>
+          </a:xfrm>
+          <a:prstGeom prst="line">
+            <a:avLst/>
+          </a:prstGeom>
+          <a:ln>
+            <a:solidFill>
+              <a:schemeClr val="bg1">
+                <a:lumMod val="85000"/>
+              </a:schemeClr>
+            </a:solidFill>
+          </a:ln>
+        </p:spPr>
+        <p:style>
+          <a:lnRef idx="2">
+            <a:schemeClr val="accent1"/>
+          </a:lnRef>
+          <a:fillRef idx="0">
+            <a:schemeClr val="accent1"/>
+          </a:fillRef>
+          <a:effectRef idx="1">
+            <a:schemeClr val="accent1"/>
+          </a:effectRef>
+          <a:fontRef idx="minor">
+            <a:schemeClr val="tx1"/>
+          </a:fontRef>
+        </p:style>
+      </p:cxnSp>
+      <p:cxnSp>
+        <p:nvCxnSpPr>
+          <p:cNvPr id="55" name="Connecteur droit 54">
+            <a:extLst>
+              <a:ext uri="{FF2B5EF4-FFF2-40B4-BE49-F238E27FC236}">
+                <a16:creationId xmlns:a16="http://schemas.microsoft.com/office/drawing/2014/main" id="{BFBD2EB6-34B6-54D8-319B-95BBA847CB21}"/>
+              </a:ext>
+            </a:extLst>
+          </p:cNvPr>
+          <p:cNvCxnSpPr>
+            <a:cxnSpLocks/>
+          </p:cNvCxnSpPr>
+          <p:nvPr/>
+        </p:nvCxnSpPr>
+        <p:spPr>
+          <a:xfrm>
+            <a:off x="576263" y="6512991"/>
+            <a:ext cx="11615737" cy="0"/>
+          </a:xfrm>
+          <a:prstGeom prst="line">
+            <a:avLst/>
+          </a:prstGeom>
+          <a:ln>
+            <a:solidFill>
+              <a:schemeClr val="bg1">
+                <a:lumMod val="85000"/>
+              </a:schemeClr>
+            </a:solidFill>
+          </a:ln>
+        </p:spPr>
+        <p:style>
+          <a:lnRef idx="2">
+            <a:schemeClr val="accent1"/>
+          </a:lnRef>
+          <a:fillRef idx="0">
+            <a:schemeClr val="accent1"/>
+          </a:fillRef>
+          <a:effectRef idx="1">
+            <a:schemeClr val="accent1"/>
+          </a:effectRef>
+          <a:fontRef idx="minor">
+            <a:schemeClr val="tx1"/>
+          </a:fontRef>
+        </p:style>
+      </p:cxnSp>
+      <p:sp>
+        <p:nvSpPr>
+          <p:cNvPr id="56" name="Text 3">
+            <a:extLst>
+              <a:ext uri="{FF2B5EF4-FFF2-40B4-BE49-F238E27FC236}">
+                <a16:creationId xmlns:a16="http://schemas.microsoft.com/office/drawing/2014/main" id="{8B657D20-7F9C-8851-0BA6-B35DF1DB8D17}"/>
+              </a:ext>
+            </a:extLst>
+          </p:cNvPr>
+          <p:cNvSpPr/>
+          <p:nvPr/>
+        </p:nvSpPr>
+        <p:spPr>
+          <a:xfrm>
+            <a:off x="576263" y="6598217"/>
+            <a:ext cx="8229600" cy="182880"/>
+          </a:xfrm>
+          <a:prstGeom prst="rect">
+            <a:avLst/>
+          </a:prstGeom>
+          <a:noFill/>
+          <a:ln/>
+        </p:spPr>
+        <p:txBody>
+          <a:bodyPr wrap="square" lIns="0" tIns="0" rIns="0" bIns="0" rtlCol="0" anchor="ctr"/>
+          <a:lstStyle/>
+          <a:p>
+            <a:pPr marL="0" indent="0">
+              <a:buNone/>
+            </a:pPr>
+            <a:r>
+              <a:rPr lang="en-US" sz="1000" i="1" dirty="0">
+                <a:solidFill>
+                  <a:srgbClr val="A0A0A0"/>
+                </a:solidFill>
+                <a:latin typeface="Calibri" panose="020F0502020204030204" pitchFamily="34" charset="0"/>
+                <a:ea typeface="Calibri" panose="020F0502020204030204" pitchFamily="34" charset="0"/>
+                <a:cs typeface="Calibri" panose="020F0502020204030204" pitchFamily="34" charset="0"/>
+              </a:rPr>
+              <a:t>Données issues de Plus </a:t>
+            </a:r>
+            <a:r>
+              <a:rPr lang="en-US" sz="1000" i="1" dirty="0" err="1">
+                <a:solidFill>
+                  <a:srgbClr val="A0A0A0"/>
+                </a:solidFill>
+                <a:latin typeface="Calibri" panose="020F0502020204030204" pitchFamily="34" charset="0"/>
+                <a:ea typeface="Calibri" panose="020F0502020204030204" pitchFamily="34" charset="0"/>
+                <a:cs typeface="Calibri" panose="020F0502020204030204" pitchFamily="34" charset="0"/>
+              </a:rPr>
+              <a:t>fraîche</a:t>
+            </a:r>
+            <a:r>
+              <a:rPr lang="en-US" sz="1000" i="1" dirty="0">
+                <a:solidFill>
+                  <a:srgbClr val="A0A0A0"/>
+                </a:solidFill>
+                <a:latin typeface="Calibri" panose="020F0502020204030204" pitchFamily="34" charset="0"/>
+                <a:ea typeface="Calibri" panose="020F0502020204030204" pitchFamily="34" charset="0"/>
+                <a:cs typeface="Calibri" panose="020F0502020204030204" pitchFamily="34" charset="0"/>
+              </a:rPr>
+              <a:t> ma </a:t>
+            </a:r>
+            <a:r>
+              <a:rPr lang="en-US" sz="1000" i="1" dirty="0" err="1">
+                <a:solidFill>
+                  <a:srgbClr val="A0A0A0"/>
+                </a:solidFill>
+                <a:latin typeface="Calibri" panose="020F0502020204030204" pitchFamily="34" charset="0"/>
+                <a:ea typeface="Calibri" panose="020F0502020204030204" pitchFamily="34" charset="0"/>
+                <a:cs typeface="Calibri" panose="020F0502020204030204" pitchFamily="34" charset="0"/>
+              </a:rPr>
+              <a:t>ville</a:t>
+            </a:r>
+            <a:r>
+              <a:rPr lang="en-US" sz="1000" i="1" dirty="0">
+                <a:solidFill>
+                  <a:srgbClr val="A0A0A0"/>
+                </a:solidFill>
+                <a:latin typeface="Calibri" panose="020F0502020204030204" pitchFamily="34" charset="0"/>
+                <a:ea typeface="Calibri" panose="020F0502020204030204" pitchFamily="34" charset="0"/>
+                <a:cs typeface="Calibri" panose="020F0502020204030204" pitchFamily="34" charset="0"/>
+              </a:rPr>
+              <a:t> (ADEME)</a:t>
+            </a:r>
+            <a:endParaRPr lang="en-US" sz="1000" dirty="0">
+              <a:latin typeface="Calibri" panose="020F0502020204030204" pitchFamily="34" charset="0"/>
+              <a:ea typeface="Calibri" panose="020F0502020204030204" pitchFamily="34" charset="0"/>
+              <a:cs typeface="Calibri" panose="020F0502020204030204" pitchFamily="34" charset="0"/>
+            </a:endParaRPr>
+          </a:p>
+        </p:txBody>
+      </p:sp>
+      <p:pic>
+        <p:nvPicPr>
+          <p:cNvPr id="57" name="Image 56" descr="Une image contenant Police, Graphique, logo, graphisme&#10;&#10;Description générée automatiquement">
+            <a:extLst>
+              <a:ext uri="{FF2B5EF4-FFF2-40B4-BE49-F238E27FC236}">
+                <a16:creationId xmlns:a16="http://schemas.microsoft.com/office/drawing/2014/main" id="{830EBC68-A5C6-15CA-95C1-839F0A7C9BA7}"/>
+              </a:ext>
+            </a:extLst>
+          </p:cNvPr>
+          <p:cNvPicPr>
+            <a:picLocks noChangeAspect="1"/>
+          </p:cNvPicPr>
+          <p:nvPr/>
+        </p:nvPicPr>
+        <p:blipFill>
+          <a:blip r:embed="rId2"/>
+          <a:srcRect t="19804" b="18118"/>
+          <a:stretch/>
+        </p:blipFill>
+        <p:spPr>
+          <a:xfrm>
+            <a:off x="10763987" y="98854"/>
+            <a:ext cx="1229053" cy="762977"/>
+          </a:xfrm>
+          <a:prstGeom prst="rect">
+            <a:avLst/>
+          </a:prstGeom>
+        </p:spPr>
+      </p:pic>
+      <p:pic>
+        <p:nvPicPr>
+          <p:cNvPr id="4" name="Picture 3">
+            <a:extLst>
+              <a:ext uri="{FF2B5EF4-FFF2-40B4-BE49-F238E27FC236}">
+                <a16:creationId xmlns:a16="http://schemas.microsoft.com/office/drawing/2014/main" id="{7D131FE9-968A-7934-D330-1035AA73A364}"/>
+              </a:ext>
+            </a:extLst>
+          </p:cNvPr>
+          <p:cNvPicPr>
+            <a:picLocks noChangeAspect="1"/>
+          </p:cNvPicPr>
+          <p:nvPr/>
+        </p:nvPicPr>
+        <p:blipFill>
+          <a:blip r:embed="rId3"/>
+          <a:stretch>
+            <a:fillRect/>
+          </a:stretch>
+        </p:blipFill>
+        <p:spPr>
+          <a:xfrm>
+            <a:off x="10546452" y="104580"/>
+            <a:ext cx="1552051" cy="758533"/>
+          </a:xfrm>
+          <a:prstGeom prst="rect">
+            <a:avLst/>
+          </a:prstGeom>
+        </p:spPr>
+      </p:pic>
+      <p:sp>
+        <p:nvSpPr>
+          <p:cNvPr id="7" name="zone_titre_fiche_solution">
+            <a:extLst>
+              <a:ext uri="{FF2B5EF4-FFF2-40B4-BE49-F238E27FC236}">
+                <a16:creationId xmlns:a16="http://schemas.microsoft.com/office/drawing/2014/main" id="{67927841-950D-B96E-D880-93E461963945}"/>
+              </a:ext>
+            </a:extLst>
+          </p:cNvPr>
+          <p:cNvSpPr txBox="1"/>
+          <p:nvPr/>
+        </p:nvSpPr>
+        <p:spPr>
+          <a:xfrm>
+            <a:off x="839464" y="1626616"/>
+            <a:ext cx="9706988" cy="276999"/>
+          </a:xfrm>
+          <a:prstGeom prst="rect">
+            <a:avLst/>
+          </a:prstGeom>
+          <a:noFill/>
+        </p:spPr>
+        <p:txBody>
+          <a:bodyPr wrap="square">
+            <a:spAutoFit/>
+          </a:bodyPr>
+          <a:lstStyle/>
+          <a:p>
+            <a:r>
+              <a:rPr lang="fr-FR" sz="1200" dirty="0">
+                <a:solidFill>
+                  <a:srgbClr val="161616"/>
+                </a:solidFill>
+                <a:latin typeface="Calibri" panose="020F0502020204030204" pitchFamily="34" charset="0"/>
+                <a:ea typeface="Calibri" panose="020F0502020204030204" pitchFamily="34" charset="0"/>
+                <a:cs typeface="Calibri" panose="020F0502020204030204" pitchFamily="34" charset="0"/>
+              </a:rPr>
+              <a:t>{{</a:t>
+            </a:r>
+            <a:r>
+              <a:rPr lang="fr-FR" sz="1200">
+                <a:solidFill>
+                  <a:srgbClr val="161616"/>
+                </a:solidFill>
+                <a:latin typeface="Calibri" panose="020F0502020204030204" pitchFamily="34" charset="0"/>
+                <a:ea typeface="Calibri" panose="020F0502020204030204" pitchFamily="34" charset="0"/>
+                <a:cs typeface="Calibri" panose="020F0502020204030204" pitchFamily="34" charset="0"/>
+              </a:rPr>
+              <a:t>ressources_utiles_</a:t>
+            </a:r>
+            <a:r>
+              <a:rPr lang="fr-FR" sz="1200" dirty="0" err="1">
+                <a:solidFill>
+                  <a:srgbClr val="161616"/>
+                </a:solidFill>
+                <a:latin typeface="Calibri" panose="020F0502020204030204" pitchFamily="34" charset="0"/>
+                <a:ea typeface="Calibri" panose="020F0502020204030204" pitchFamily="34" charset="0"/>
+                <a:cs typeface="Calibri" panose="020F0502020204030204" pitchFamily="34" charset="0"/>
+              </a:rPr>
+              <a:t>fiche_solution</a:t>
+            </a:r>
+            <a:r>
+              <a:rPr lang="fr-FR" sz="1200" dirty="0">
+                <a:solidFill>
+                  <a:srgbClr val="161616"/>
+                </a:solidFill>
+                <a:latin typeface="Calibri" panose="020F0502020204030204" pitchFamily="34" charset="0"/>
+                <a:ea typeface="Calibri" panose="020F0502020204030204" pitchFamily="34" charset="0"/>
+                <a:cs typeface="Calibri" panose="020F0502020204030204" pitchFamily="34" charset="0"/>
+              </a:rPr>
+              <a:t>}}</a:t>
+            </a:r>
+            <a:endParaRPr lang="fr-FR" sz="1200" dirty="0">
+              <a:latin typeface="Calibri" panose="020F0502020204030204" pitchFamily="34" charset="0"/>
+              <a:ea typeface="Calibri" panose="020F0502020204030204" pitchFamily="34" charset="0"/>
+              <a:cs typeface="Calibri" panose="020F0502020204030204" pitchFamily="34" charset="0"/>
+            </a:endParaRPr>
           </a:p>
         </p:txBody>
       </p:sp>
     </p:spTree>
     <p:extLst>
       <p:ext uri="{BB962C8B-B14F-4D97-AF65-F5344CB8AC3E}">
-        <p14:creationId xmlns:p14="http://schemas.microsoft.com/office/powerpoint/2010/main" val="2491613"/>
+        <p14:creationId xmlns:p14="http://schemas.microsoft.com/office/powerpoint/2010/main" val="1015688024"/>
       </p:ext>
     </p:extLst>
   </p:cSld>

</xml_diff>

<commit_message>
feat: Rajout des ressources utiles pour les fiches solution
</commit_message>
<xml_diff>
--- a/public/templates/template_synthese_projet.pptx
+++ b/public/templates/template_synthese_projet.pptx
@@ -213,7 +213,7 @@
           <a:p>
             <a:fld id="{4C638A9C-6ED0-4718-B5E7-9D405962C144}" type="datetimeFigureOut">
               <a:rPr lang="fr-FR" smtClean="0"/>
-              <a:t>09/09/2026</a:t>
+              <a:t>11/09/2026</a:t>
             </a:fld>
             <a:endParaRPr lang="fr-FR"/>
           </a:p>
@@ -951,7 +951,7 @@
           <a:p>
             <a:fld id="{82E7F8B9-DFDB-4965-877D-C04A580740C9}" type="datetimeFigureOut">
               <a:rPr lang="fr-FR" smtClean="0"/>
-              <a:t>09/09/2026</a:t>
+              <a:t>11/09/2026</a:t>
             </a:fld>
             <a:endParaRPr lang="fr-FR"/>
           </a:p>
@@ -1149,7 +1149,7 @@
           <a:p>
             <a:fld id="{82E7F8B9-DFDB-4965-877D-C04A580740C9}" type="datetimeFigureOut">
               <a:rPr lang="fr-FR" smtClean="0"/>
-              <a:t>09/09/2026</a:t>
+              <a:t>11/09/2026</a:t>
             </a:fld>
             <a:endParaRPr lang="fr-FR"/>
           </a:p>
@@ -1357,7 +1357,7 @@
           <a:p>
             <a:fld id="{82E7F8B9-DFDB-4965-877D-C04A580740C9}" type="datetimeFigureOut">
               <a:rPr lang="fr-FR" smtClean="0"/>
-              <a:t>09/09/2026</a:t>
+              <a:t>11/09/2026</a:t>
             </a:fld>
             <a:endParaRPr lang="fr-FR"/>
           </a:p>
@@ -1590,7 +1590,7 @@
           <a:p>
             <a:fld id="{82E7F8B9-DFDB-4965-877D-C04A580740C9}" type="datetimeFigureOut">
               <a:rPr lang="fr-FR" smtClean="0"/>
-              <a:t>09/09/2026</a:t>
+              <a:t>11/09/2026</a:t>
             </a:fld>
             <a:endParaRPr lang="fr-FR"/>
           </a:p>
@@ -1865,7 +1865,7 @@
           <a:p>
             <a:fld id="{82E7F8B9-DFDB-4965-877D-C04A580740C9}" type="datetimeFigureOut">
               <a:rPr lang="fr-FR" smtClean="0"/>
-              <a:t>09/09/2026</a:t>
+              <a:t>11/09/2026</a:t>
             </a:fld>
             <a:endParaRPr lang="fr-FR"/>
           </a:p>
@@ -2130,7 +2130,7 @@
           <a:p>
             <a:fld id="{82E7F8B9-DFDB-4965-877D-C04A580740C9}" type="datetimeFigureOut">
               <a:rPr lang="fr-FR" smtClean="0"/>
-              <a:t>09/09/2026</a:t>
+              <a:t>11/09/2026</a:t>
             </a:fld>
             <a:endParaRPr lang="fr-FR"/>
           </a:p>
@@ -2542,7 +2542,7 @@
           <a:p>
             <a:fld id="{82E7F8B9-DFDB-4965-877D-C04A580740C9}" type="datetimeFigureOut">
               <a:rPr lang="fr-FR" smtClean="0"/>
-              <a:t>09/09/2026</a:t>
+              <a:t>11/09/2026</a:t>
             </a:fld>
             <a:endParaRPr lang="fr-FR"/>
           </a:p>
@@ -2683,7 +2683,7 @@
           <a:p>
             <a:fld id="{82E7F8B9-DFDB-4965-877D-C04A580740C9}" type="datetimeFigureOut">
               <a:rPr lang="fr-FR" smtClean="0"/>
-              <a:t>09/09/2026</a:t>
+              <a:t>11/09/2026</a:t>
             </a:fld>
             <a:endParaRPr lang="fr-FR"/>
           </a:p>
@@ -2796,7 +2796,7 @@
           <a:p>
             <a:fld id="{82E7F8B9-DFDB-4965-877D-C04A580740C9}" type="datetimeFigureOut">
               <a:rPr lang="fr-FR" smtClean="0"/>
-              <a:t>09/09/2026</a:t>
+              <a:t>11/09/2026</a:t>
             </a:fld>
             <a:endParaRPr lang="fr-FR"/>
           </a:p>
@@ -3107,7 +3107,7 @@
           <a:p>
             <a:fld id="{82E7F8B9-DFDB-4965-877D-C04A580740C9}" type="datetimeFigureOut">
               <a:rPr lang="fr-FR" smtClean="0"/>
-              <a:t>09/09/2026</a:t>
+              <a:t>11/09/2026</a:t>
             </a:fld>
             <a:endParaRPr lang="fr-FR"/>
           </a:p>
@@ -3395,7 +3395,7 @@
           <a:p>
             <a:fld id="{82E7F8B9-DFDB-4965-877D-C04A580740C9}" type="datetimeFigureOut">
               <a:rPr lang="fr-FR" smtClean="0"/>
-              <a:t>09/09/2026</a:t>
+              <a:t>11/09/2026</a:t>
             </a:fld>
             <a:endParaRPr lang="fr-FR"/>
           </a:p>
@@ -3636,7 +3636,7 @@
           <a:p>
             <a:fld id="{82E7F8B9-DFDB-4965-877D-C04A580740C9}" type="datetimeFigureOut">
               <a:rPr lang="fr-FR" smtClean="0"/>
-              <a:t>09/09/2026</a:t>
+              <a:t>11/09/2026</a:t>
             </a:fld>
             <a:endParaRPr lang="fr-FR"/>
           </a:p>
@@ -9322,7 +9322,7 @@
       </p:pic>
       <p:sp>
         <p:nvSpPr>
-          <p:cNvPr id="7" name="zone_titre_fiche_solution">
+          <p:cNvPr id="7" name="zone_ressources_fiche_solution">
             <a:extLst>
               <a:ext uri="{FF2B5EF4-FFF2-40B4-BE49-F238E27FC236}">
                 <a16:creationId xmlns:a16="http://schemas.microsoft.com/office/drawing/2014/main" id="{67927841-950D-B96E-D880-93E461963945}"/>
@@ -9360,7 +9360,7 @@
               <a:t>{{</a:t>
             </a:r>
             <a:r>
-              <a:rPr lang="fr-FR" sz="1200">
+              <a:rPr lang="fr-FR" sz="1200" dirty="0" err="1">
                 <a:solidFill>
                   <a:srgbClr val="161616"/>
                 </a:solidFill>
@@ -9368,18 +9368,7 @@
                 <a:ea typeface="Calibri" panose="020F0502020204030204" pitchFamily="34" charset="0"/>
                 <a:cs typeface="Calibri" panose="020F0502020204030204" pitchFamily="34" charset="0"/>
               </a:rPr>
-              <a:t>ressources_utiles_</a:t>
-            </a:r>
-            <a:r>
-              <a:rPr lang="fr-FR" sz="1200" dirty="0" err="1">
-                <a:solidFill>
-                  <a:srgbClr val="161616"/>
-                </a:solidFill>
-                <a:latin typeface="Calibri" panose="020F0502020204030204" pitchFamily="34" charset="0"/>
-                <a:ea typeface="Calibri" panose="020F0502020204030204" pitchFamily="34" charset="0"/>
-                <a:cs typeface="Calibri" panose="020F0502020204030204" pitchFamily="34" charset="0"/>
-              </a:rPr>
-              <a:t>fiche_solution</a:t>
+              <a:t>ressources_utiles_fiche_solution</a:t>
             </a:r>
             <a:r>
               <a:rPr lang="fr-FR" sz="1200" dirty="0">

</xml_diff>

<commit_message>
feat: utilisation de la police Marianne
</commit_message>
<xml_diff>
--- a/public/templates/template_synthese_projet.pptx
+++ b/public/templates/template_synthese_projet.pptx
@@ -213,7 +213,7 @@
           <a:p>
             <a:fld id="{4C638A9C-6ED0-4718-B5E7-9D405962C144}" type="datetimeFigureOut">
               <a:rPr lang="fr-FR" smtClean="0"/>
-              <a:t>11/09/2026</a:t>
+              <a:t>14/09/2026</a:t>
             </a:fld>
             <a:endParaRPr lang="fr-FR"/>
           </a:p>
@@ -951,7 +951,7 @@
           <a:p>
             <a:fld id="{82E7F8B9-DFDB-4965-877D-C04A580740C9}" type="datetimeFigureOut">
               <a:rPr lang="fr-FR" smtClean="0"/>
-              <a:t>11/09/2026</a:t>
+              <a:t>14/09/2026</a:t>
             </a:fld>
             <a:endParaRPr lang="fr-FR"/>
           </a:p>
@@ -1149,7 +1149,7 @@
           <a:p>
             <a:fld id="{82E7F8B9-DFDB-4965-877D-C04A580740C9}" type="datetimeFigureOut">
               <a:rPr lang="fr-FR" smtClean="0"/>
-              <a:t>11/09/2026</a:t>
+              <a:t>14/09/2026</a:t>
             </a:fld>
             <a:endParaRPr lang="fr-FR"/>
           </a:p>
@@ -1357,7 +1357,7 @@
           <a:p>
             <a:fld id="{82E7F8B9-DFDB-4965-877D-C04A580740C9}" type="datetimeFigureOut">
               <a:rPr lang="fr-FR" smtClean="0"/>
-              <a:t>11/09/2026</a:t>
+              <a:t>14/09/2026</a:t>
             </a:fld>
             <a:endParaRPr lang="fr-FR"/>
           </a:p>
@@ -1590,7 +1590,7 @@
           <a:p>
             <a:fld id="{82E7F8B9-DFDB-4965-877D-C04A580740C9}" type="datetimeFigureOut">
               <a:rPr lang="fr-FR" smtClean="0"/>
-              <a:t>11/09/2026</a:t>
+              <a:t>14/09/2026</a:t>
             </a:fld>
             <a:endParaRPr lang="fr-FR"/>
           </a:p>
@@ -1865,7 +1865,7 @@
           <a:p>
             <a:fld id="{82E7F8B9-DFDB-4965-877D-C04A580740C9}" type="datetimeFigureOut">
               <a:rPr lang="fr-FR" smtClean="0"/>
-              <a:t>11/09/2026</a:t>
+              <a:t>14/09/2026</a:t>
             </a:fld>
             <a:endParaRPr lang="fr-FR"/>
           </a:p>
@@ -2130,7 +2130,7 @@
           <a:p>
             <a:fld id="{82E7F8B9-DFDB-4965-877D-C04A580740C9}" type="datetimeFigureOut">
               <a:rPr lang="fr-FR" smtClean="0"/>
-              <a:t>11/09/2026</a:t>
+              <a:t>14/09/2026</a:t>
             </a:fld>
             <a:endParaRPr lang="fr-FR"/>
           </a:p>
@@ -2542,7 +2542,7 @@
           <a:p>
             <a:fld id="{82E7F8B9-DFDB-4965-877D-C04A580740C9}" type="datetimeFigureOut">
               <a:rPr lang="fr-FR" smtClean="0"/>
-              <a:t>11/09/2026</a:t>
+              <a:t>14/09/2026</a:t>
             </a:fld>
             <a:endParaRPr lang="fr-FR"/>
           </a:p>
@@ -2683,7 +2683,7 @@
           <a:p>
             <a:fld id="{82E7F8B9-DFDB-4965-877D-C04A580740C9}" type="datetimeFigureOut">
               <a:rPr lang="fr-FR" smtClean="0"/>
-              <a:t>11/09/2026</a:t>
+              <a:t>14/09/2026</a:t>
             </a:fld>
             <a:endParaRPr lang="fr-FR"/>
           </a:p>
@@ -2796,7 +2796,7 @@
           <a:p>
             <a:fld id="{82E7F8B9-DFDB-4965-877D-C04A580740C9}" type="datetimeFigureOut">
               <a:rPr lang="fr-FR" smtClean="0"/>
-              <a:t>11/09/2026</a:t>
+              <a:t>14/09/2026</a:t>
             </a:fld>
             <a:endParaRPr lang="fr-FR"/>
           </a:p>
@@ -3107,7 +3107,7 @@
           <a:p>
             <a:fld id="{82E7F8B9-DFDB-4965-877D-C04A580740C9}" type="datetimeFigureOut">
               <a:rPr lang="fr-FR" smtClean="0"/>
-              <a:t>11/09/2026</a:t>
+              <a:t>14/09/2026</a:t>
             </a:fld>
             <a:endParaRPr lang="fr-FR"/>
           </a:p>
@@ -3395,7 +3395,7 @@
           <a:p>
             <a:fld id="{82E7F8B9-DFDB-4965-877D-C04A580740C9}" type="datetimeFigureOut">
               <a:rPr lang="fr-FR" smtClean="0"/>
-              <a:t>11/09/2026</a:t>
+              <a:t>14/09/2026</a:t>
             </a:fld>
             <a:endParaRPr lang="fr-FR"/>
           </a:p>
@@ -3636,7 +3636,7 @@
           <a:p>
             <a:fld id="{82E7F8B9-DFDB-4965-877D-C04A580740C9}" type="datetimeFigureOut">
               <a:rPr lang="fr-FR" smtClean="0"/>
-              <a:t>11/09/2026</a:t>
+              <a:t>14/09/2026</a:t>
             </a:fld>
             <a:endParaRPr lang="fr-FR"/>
           </a:p>
@@ -4084,7 +4084,7 @@
           <a:p>
             <a:r>
               <a:rPr lang="fr-FR" sz="3800" dirty="0">
-                <a:latin typeface="Calibri" panose="020F0502020204030204" pitchFamily="34" charset="0"/>
+                <a:latin typeface="Marianne" panose="02000000000000000000" pitchFamily="50" charset="0"/>
                 <a:ea typeface="Calibri" panose="020F0502020204030204" pitchFamily="34" charset="0"/>
                 <a:cs typeface="Calibri" panose="020F0502020204030204" pitchFamily="34" charset="0"/>
               </a:rPr>
@@ -4092,7 +4092,7 @@
             </a:r>
             <a:r>
               <a:rPr lang="fr-FR" sz="3800" dirty="0" err="1">
-                <a:latin typeface="Calibri" panose="020F0502020204030204" pitchFamily="34" charset="0"/>
+                <a:latin typeface="Marianne" panose="02000000000000000000" pitchFamily="50" charset="0"/>
                 <a:ea typeface="Calibri" panose="020F0502020204030204" pitchFamily="34" charset="0"/>
                 <a:cs typeface="Calibri" panose="020F0502020204030204" pitchFamily="34" charset="0"/>
               </a:rPr>
@@ -4100,7 +4100,7 @@
             </a:r>
             <a:r>
               <a:rPr lang="fr-FR" sz="3800" dirty="0">
-                <a:latin typeface="Calibri" panose="020F0502020204030204" pitchFamily="34" charset="0"/>
+                <a:latin typeface="Marianne" panose="02000000000000000000" pitchFamily="50" charset="0"/>
                 <a:ea typeface="Calibri" panose="020F0502020204030204" pitchFamily="34" charset="0"/>
                 <a:cs typeface="Calibri" panose="020F0502020204030204" pitchFamily="34" charset="0"/>
               </a:rPr>
@@ -4139,7 +4139,7 @@
           <a:p>
             <a:r>
               <a:rPr lang="fr-FR" sz="1600" dirty="0">
-                <a:latin typeface="Calibri" panose="020F0502020204030204" pitchFamily="34" charset="0"/>
+                <a:latin typeface="Marianne" panose="02000000000000000000" pitchFamily="50" charset="0"/>
                 <a:ea typeface="Calibri" panose="020F0502020204030204" pitchFamily="34" charset="0"/>
                 <a:cs typeface="Calibri" panose="020F0502020204030204" pitchFamily="34" charset="0"/>
               </a:rPr>
@@ -4147,7 +4147,7 @@
             </a:r>
             <a:r>
               <a:rPr lang="fr-FR" sz="1600" dirty="0" err="1">
-                <a:latin typeface="Calibri" panose="020F0502020204030204" pitchFamily="34" charset="0"/>
+                <a:latin typeface="Marianne" panose="02000000000000000000" pitchFamily="50" charset="0"/>
                 <a:ea typeface="Calibri" panose="020F0502020204030204" pitchFamily="34" charset="0"/>
                 <a:cs typeface="Calibri" panose="020F0502020204030204" pitchFamily="34" charset="0"/>
               </a:rPr>
@@ -4155,7 +4155,7 @@
             </a:r>
             <a:r>
               <a:rPr lang="fr-FR" sz="1600" dirty="0">
-                <a:latin typeface="Calibri" panose="020F0502020204030204" pitchFamily="34" charset="0"/>
+                <a:latin typeface="Marianne" panose="02000000000000000000" pitchFamily="50" charset="0"/>
                 <a:ea typeface="Calibri" panose="020F0502020204030204" pitchFamily="34" charset="0"/>
                 <a:cs typeface="Calibri" panose="020F0502020204030204" pitchFamily="34" charset="0"/>
               </a:rPr>
@@ -4163,7 +4163,7 @@
             </a:r>
             <a:r>
               <a:rPr lang="fr-FR" sz="1600" dirty="0" err="1">
-                <a:latin typeface="Calibri" panose="020F0502020204030204" pitchFamily="34" charset="0"/>
+                <a:latin typeface="Marianne" panose="02000000000000000000" pitchFamily="50" charset="0"/>
                 <a:ea typeface="Calibri" panose="020F0502020204030204" pitchFamily="34" charset="0"/>
                 <a:cs typeface="Calibri" panose="020F0502020204030204" pitchFamily="34" charset="0"/>
               </a:rPr>
@@ -4171,7 +4171,7 @@
             </a:r>
             <a:r>
               <a:rPr lang="fr-FR" sz="1600" dirty="0">
-                <a:latin typeface="Calibri" panose="020F0502020204030204" pitchFamily="34" charset="0"/>
+                <a:latin typeface="Marianne" panose="02000000000000000000" pitchFamily="50" charset="0"/>
                 <a:ea typeface="Calibri" panose="020F0502020204030204" pitchFamily="34" charset="0"/>
                 <a:cs typeface="Calibri" panose="020F0502020204030204" pitchFamily="34" charset="0"/>
               </a:rPr>
@@ -4181,7 +4181,7 @@
           <a:p>
             <a:r>
               <a:rPr lang="fr-FR" sz="1600" dirty="0">
-                <a:latin typeface="Calibri" panose="020F0502020204030204" pitchFamily="34" charset="0"/>
+                <a:latin typeface="Marianne" panose="02000000000000000000" pitchFamily="50" charset="0"/>
                 <a:ea typeface="Calibri" panose="020F0502020204030204" pitchFamily="34" charset="0"/>
                 <a:cs typeface="Calibri" panose="020F0502020204030204" pitchFamily="34" charset="0"/>
               </a:rPr>
@@ -4189,7 +4189,7 @@
             </a:r>
             <a:r>
               <a:rPr lang="fr-FR" sz="1600" dirty="0" err="1">
-                <a:latin typeface="Calibri" panose="020F0502020204030204" pitchFamily="34" charset="0"/>
+                <a:latin typeface="Marianne" panose="02000000000000000000" pitchFamily="50" charset="0"/>
                 <a:ea typeface="Calibri" panose="020F0502020204030204" pitchFamily="34" charset="0"/>
                 <a:cs typeface="Calibri" panose="020F0502020204030204" pitchFamily="34" charset="0"/>
               </a:rPr>
@@ -4197,7 +4197,7 @@
             </a:r>
             <a:r>
               <a:rPr lang="fr-FR" sz="1600" dirty="0">
-                <a:latin typeface="Calibri" panose="020F0502020204030204" pitchFamily="34" charset="0"/>
+                <a:latin typeface="Marianne" panose="02000000000000000000" pitchFamily="50" charset="0"/>
                 <a:ea typeface="Calibri" panose="020F0502020204030204" pitchFamily="34" charset="0"/>
                 <a:cs typeface="Calibri" panose="020F0502020204030204" pitchFamily="34" charset="0"/>
               </a:rPr>
@@ -4271,7 +4271,7 @@
                 <a:solidFill>
                   <a:srgbClr val="A0A0A0"/>
                 </a:solidFill>
-                <a:latin typeface="Calibri" pitchFamily="34" charset="0"/>
+                <a:latin typeface="Marianne" panose="02000000000000000000" pitchFamily="50" charset="0"/>
                 <a:ea typeface="Calibri" pitchFamily="34" charset="-122"/>
                 <a:cs typeface="Calibri" pitchFamily="34" charset="-120"/>
               </a:rPr>
@@ -4282,7 +4282,7 @@
                 <a:solidFill>
                   <a:srgbClr val="A0A0A0"/>
                 </a:solidFill>
-                <a:latin typeface="Calibri" pitchFamily="34" charset="0"/>
+                <a:latin typeface="Marianne" panose="02000000000000000000" pitchFamily="50" charset="0"/>
                 <a:ea typeface="Calibri" pitchFamily="34" charset="-122"/>
                 <a:cs typeface="Calibri" pitchFamily="34" charset="-120"/>
               </a:rPr>
@@ -4293,7 +4293,7 @@
                 <a:solidFill>
                   <a:srgbClr val="A0A0A0"/>
                 </a:solidFill>
-                <a:latin typeface="Calibri" pitchFamily="34" charset="0"/>
+                <a:latin typeface="Marianne" panose="02000000000000000000" pitchFamily="50" charset="0"/>
                 <a:ea typeface="Calibri" pitchFamily="34" charset="-122"/>
                 <a:cs typeface="Calibri" pitchFamily="34" charset="-120"/>
               </a:rPr>
@@ -4304,7 +4304,7 @@
                 <a:solidFill>
                   <a:srgbClr val="A0A0A0"/>
                 </a:solidFill>
-                <a:latin typeface="Calibri" pitchFamily="34" charset="0"/>
+                <a:latin typeface="Marianne" panose="02000000000000000000" pitchFamily="50" charset="0"/>
                 <a:ea typeface="Calibri" pitchFamily="34" charset="-122"/>
                 <a:cs typeface="Calibri" pitchFamily="34" charset="-120"/>
               </a:rPr>
@@ -4315,7 +4315,7 @@
                 <a:solidFill>
                   <a:srgbClr val="A0A0A0"/>
                 </a:solidFill>
-                <a:latin typeface="Calibri" pitchFamily="34" charset="0"/>
+                <a:latin typeface="Marianne" panose="02000000000000000000" pitchFamily="50" charset="0"/>
                 <a:ea typeface="Calibri" pitchFamily="34" charset="-122"/>
                 <a:cs typeface="Calibri" pitchFamily="34" charset="-120"/>
               </a:rPr>
@@ -4326,7 +4326,7 @@
                 <a:solidFill>
                   <a:srgbClr val="A0A0A0"/>
                 </a:solidFill>
-                <a:latin typeface="Calibri" pitchFamily="34" charset="0"/>
+                <a:latin typeface="Marianne" panose="02000000000000000000" pitchFamily="50" charset="0"/>
                 <a:ea typeface="Calibri" pitchFamily="34" charset="-122"/>
                 <a:cs typeface="Calibri" pitchFamily="34" charset="-120"/>
               </a:rPr>
@@ -4337,7 +4337,7 @@
                 <a:solidFill>
                   <a:srgbClr val="A0A0A0"/>
                 </a:solidFill>
-                <a:latin typeface="Calibri" pitchFamily="34" charset="0"/>
+                <a:latin typeface="Marianne" panose="02000000000000000000" pitchFamily="50" charset="0"/>
                 <a:ea typeface="Calibri" pitchFamily="34" charset="-122"/>
                 <a:cs typeface="Calibri" pitchFamily="34" charset="-120"/>
               </a:rPr>
@@ -4348,7 +4348,7 @@
                 <a:solidFill>
                   <a:srgbClr val="A0A0A0"/>
                 </a:solidFill>
-                <a:latin typeface="Calibri" pitchFamily="34" charset="0"/>
+                <a:latin typeface="Marianne" panose="02000000000000000000" pitchFamily="50" charset="0"/>
                 <a:ea typeface="Calibri" pitchFamily="34" charset="-122"/>
                 <a:cs typeface="Calibri" pitchFamily="34" charset="-120"/>
               </a:rPr>
@@ -4359,7 +4359,7 @@
                 <a:solidFill>
                   <a:srgbClr val="A0A0A0"/>
                 </a:solidFill>
-                <a:latin typeface="Calibri" pitchFamily="34" charset="0"/>
+                <a:latin typeface="Marianne" panose="02000000000000000000" pitchFamily="50" charset="0"/>
                 <a:ea typeface="Calibri" pitchFamily="34" charset="-122"/>
                 <a:cs typeface="Calibri" pitchFamily="34" charset="-120"/>
               </a:rPr>
@@ -4370,13 +4370,15 @@
                 <a:solidFill>
                   <a:srgbClr val="A0A0A0"/>
                 </a:solidFill>
-                <a:latin typeface="Calibri" pitchFamily="34" charset="0"/>
+                <a:latin typeface="Marianne" panose="02000000000000000000" pitchFamily="50" charset="0"/>
                 <a:ea typeface="Calibri" pitchFamily="34" charset="-122"/>
                 <a:cs typeface="Calibri" pitchFamily="34" charset="-120"/>
               </a:rPr>
               <a:t> (ADEME)</a:t>
             </a:r>
-            <a:endParaRPr lang="en-US" sz="1000" dirty="0"/>
+            <a:endParaRPr lang="en-US" sz="1000" dirty="0">
+              <a:latin typeface="Marianne" panose="02000000000000000000" pitchFamily="50" charset="0"/>
+            </a:endParaRPr>
           </a:p>
         </p:txBody>
       </p:sp>
@@ -4474,7 +4476,7 @@
           <a:lstStyle/>
           <a:p>
             <a:endParaRPr lang="en-US" sz="13333" dirty="0">
-              <a:latin typeface="Calibri" panose="020F0502020204030204" pitchFamily="34" charset="0"/>
+              <a:latin typeface="Marianne" panose="02000000000000000000" pitchFamily="50" charset="0"/>
               <a:ea typeface="Calibri" panose="020F0502020204030204" pitchFamily="34" charset="0"/>
               <a:cs typeface="Calibri" panose="020F0502020204030204" pitchFamily="34" charset="0"/>
             </a:endParaRPr>
@@ -4513,7 +4515,7 @@
                 <a:solidFill>
                   <a:srgbClr val="1A1A1A"/>
                 </a:solidFill>
-                <a:latin typeface="Calibri" panose="020F0502020204030204" pitchFamily="34" charset="0"/>
+                <a:latin typeface="Marianne" panose="02000000000000000000" pitchFamily="50" charset="0"/>
                 <a:ea typeface="Calibri" panose="020F0502020204030204" pitchFamily="34" charset="0"/>
                 <a:cs typeface="Calibri" panose="020F0502020204030204" pitchFamily="34" charset="0"/>
               </a:rPr>
@@ -4524,7 +4526,7 @@
                 <a:solidFill>
                   <a:srgbClr val="1A1A1A"/>
                 </a:solidFill>
-                <a:latin typeface="Calibri" panose="020F0502020204030204" pitchFamily="34" charset="0"/>
+                <a:latin typeface="Marianne" panose="02000000000000000000" pitchFamily="50" charset="0"/>
                 <a:ea typeface="Calibri" panose="020F0502020204030204" pitchFamily="34" charset="0"/>
                 <a:cs typeface="Calibri" panose="020F0502020204030204" pitchFamily="34" charset="0"/>
               </a:rPr>
@@ -4535,7 +4537,7 @@
                 <a:solidFill>
                   <a:srgbClr val="1A1A1A"/>
                 </a:solidFill>
-                <a:latin typeface="Calibri" panose="020F0502020204030204" pitchFamily="34" charset="0"/>
+                <a:latin typeface="Marianne" panose="02000000000000000000" pitchFamily="50" charset="0"/>
                 <a:ea typeface="Calibri" panose="020F0502020204030204" pitchFamily="34" charset="0"/>
                 <a:cs typeface="Calibri" panose="020F0502020204030204" pitchFamily="34" charset="0"/>
               </a:rPr>
@@ -4546,14 +4548,14 @@
                 <a:solidFill>
                   <a:srgbClr val="1A1A1A"/>
                 </a:solidFill>
-                <a:latin typeface="Calibri" panose="020F0502020204030204" pitchFamily="34" charset="0"/>
+                <a:latin typeface="Marianne" panose="02000000000000000000" pitchFamily="50" charset="0"/>
                 <a:ea typeface="Calibri" panose="020F0502020204030204" pitchFamily="34" charset="0"/>
                 <a:cs typeface="Calibri" panose="020F0502020204030204" pitchFamily="34" charset="0"/>
               </a:rPr>
               <a:t>retenues</a:t>
             </a:r>
             <a:endParaRPr lang="en-US" sz="3733" dirty="0">
-              <a:latin typeface="Calibri" panose="020F0502020204030204" pitchFamily="34" charset="0"/>
+              <a:latin typeface="Marianne" panose="02000000000000000000" pitchFamily="50" charset="0"/>
               <a:ea typeface="Calibri" panose="020F0502020204030204" pitchFamily="34" charset="0"/>
               <a:cs typeface="Calibri" panose="020F0502020204030204" pitchFamily="34" charset="0"/>
             </a:endParaRPr>
@@ -4595,7 +4597,7 @@
           <a:lstStyle/>
           <a:p>
             <a:endParaRPr lang="fr-FR" sz="2400">
-              <a:latin typeface="Calibri" panose="020F0502020204030204" pitchFamily="34" charset="0"/>
+              <a:latin typeface="Marianne" panose="02000000000000000000" pitchFamily="50" charset="0"/>
               <a:ea typeface="Calibri" panose="020F0502020204030204" pitchFamily="34" charset="0"/>
               <a:cs typeface="Calibri" panose="020F0502020204030204" pitchFamily="34" charset="0"/>
             </a:endParaRPr>
@@ -4638,7 +4640,7 @@
                 <a:solidFill>
                   <a:srgbClr val="5C5C5C"/>
                 </a:solidFill>
-                <a:latin typeface="Calibri" panose="020F0502020204030204" pitchFamily="34" charset="0"/>
+                <a:latin typeface="Marianne" panose="02000000000000000000" pitchFamily="50" charset="0"/>
                 <a:ea typeface="Calibri" panose="020F0502020204030204" pitchFamily="34" charset="0"/>
                 <a:cs typeface="Calibri" panose="020F0502020204030204" pitchFamily="34" charset="0"/>
               </a:rPr>
@@ -4649,7 +4651,7 @@
                 <a:solidFill>
                   <a:srgbClr val="5C5C5C"/>
                 </a:solidFill>
-                <a:latin typeface="Calibri" panose="020F0502020204030204" pitchFamily="34" charset="0"/>
+                <a:latin typeface="Marianne" panose="02000000000000000000" pitchFamily="50" charset="0"/>
                 <a:ea typeface="Calibri" panose="020F0502020204030204" pitchFamily="34" charset="0"/>
                 <a:cs typeface="Calibri" panose="020F0502020204030204" pitchFamily="34" charset="0"/>
               </a:rPr>
@@ -4660,7 +4662,7 @@
                 <a:solidFill>
                   <a:srgbClr val="5C5C5C"/>
                 </a:solidFill>
-                <a:latin typeface="Calibri" panose="020F0502020204030204" pitchFamily="34" charset="0"/>
+                <a:latin typeface="Marianne" panose="02000000000000000000" pitchFamily="50" charset="0"/>
                 <a:ea typeface="Calibri" panose="020F0502020204030204" pitchFamily="34" charset="0"/>
                 <a:cs typeface="Calibri" panose="020F0502020204030204" pitchFamily="34" charset="0"/>
               </a:rPr>
@@ -4749,14 +4751,14 @@
                 <a:solidFill>
                   <a:srgbClr val="A0A0A0"/>
                 </a:solidFill>
-                <a:latin typeface="Calibri" panose="020F0502020204030204" pitchFamily="34" charset="0"/>
+                <a:latin typeface="Marianne" panose="02000000000000000000" pitchFamily="50" charset="0"/>
                 <a:ea typeface="Calibri" panose="020F0502020204030204" pitchFamily="34" charset="0"/>
                 <a:cs typeface="Calibri" panose="020F0502020204030204" pitchFamily="34" charset="0"/>
               </a:rPr>
               <a:t>Données issues de Plus fraîche ma ville (ADEME)</a:t>
             </a:r>
             <a:endParaRPr lang="en-US" sz="1000">
-              <a:latin typeface="Calibri" panose="020F0502020204030204" pitchFamily="34" charset="0"/>
+              <a:latin typeface="Marianne" panose="02000000000000000000" pitchFamily="50" charset="0"/>
               <a:ea typeface="Calibri" panose="020F0502020204030204" pitchFamily="34" charset="0"/>
               <a:cs typeface="Calibri" panose="020F0502020204030204" pitchFamily="34" charset="0"/>
             </a:endParaRPr>
@@ -4891,7 +4893,7 @@
             </a:pPr>
             <a:r>
               <a:rPr lang="en-US" sz="3200" dirty="0">
-                <a:latin typeface="Calibri" panose="020F0502020204030204" pitchFamily="34" charset="0"/>
+                <a:latin typeface="Marianne" panose="02000000000000000000" pitchFamily="50" charset="0"/>
                 <a:ea typeface="Calibri" panose="020F0502020204030204" pitchFamily="34" charset="0"/>
                 <a:cs typeface="Calibri" panose="020F0502020204030204" pitchFamily="34" charset="0"/>
               </a:rPr>
@@ -4899,7 +4901,7 @@
             </a:r>
             <a:r>
               <a:rPr lang="en-US" sz="3200" dirty="0" err="1">
-                <a:latin typeface="Calibri" panose="020F0502020204030204" pitchFamily="34" charset="0"/>
+                <a:latin typeface="Marianne" panose="02000000000000000000" pitchFamily="50" charset="0"/>
                 <a:ea typeface="Calibri" panose="020F0502020204030204" pitchFamily="34" charset="0"/>
                 <a:cs typeface="Calibri" panose="020F0502020204030204" pitchFamily="34" charset="0"/>
               </a:rPr>
@@ -4907,7 +4909,7 @@
             </a:r>
             <a:r>
               <a:rPr lang="en-US" sz="3200" dirty="0">
-                <a:latin typeface="Calibri" panose="020F0502020204030204" pitchFamily="34" charset="0"/>
+                <a:latin typeface="Marianne" panose="02000000000000000000" pitchFamily="50" charset="0"/>
                 <a:ea typeface="Calibri" panose="020F0502020204030204" pitchFamily="34" charset="0"/>
                 <a:cs typeface="Calibri" panose="020F0502020204030204" pitchFamily="34" charset="0"/>
               </a:rPr>
@@ -4915,7 +4917,7 @@
             </a:r>
             <a:r>
               <a:rPr lang="en-US" sz="3200" dirty="0" err="1">
-                <a:latin typeface="Calibri" panose="020F0502020204030204" pitchFamily="34" charset="0"/>
+                <a:latin typeface="Marianne" panose="02000000000000000000" pitchFamily="50" charset="0"/>
                 <a:ea typeface="Calibri" panose="020F0502020204030204" pitchFamily="34" charset="0"/>
                 <a:cs typeface="Calibri" panose="020F0502020204030204" pitchFamily="34" charset="0"/>
               </a:rPr>
@@ -4923,7 +4925,7 @@
             </a:r>
             <a:r>
               <a:rPr lang="en-US" sz="3200" dirty="0">
-                <a:latin typeface="Calibri" panose="020F0502020204030204" pitchFamily="34" charset="0"/>
+                <a:latin typeface="Marianne" panose="02000000000000000000" pitchFamily="50" charset="0"/>
                 <a:ea typeface="Calibri" panose="020F0502020204030204" pitchFamily="34" charset="0"/>
                 <a:cs typeface="Calibri" panose="020F0502020204030204" pitchFamily="34" charset="0"/>
               </a:rPr>
@@ -4965,7 +4967,7 @@
                 <a:solidFill>
                   <a:srgbClr val="161616"/>
                 </a:solidFill>
-                <a:latin typeface="Calibri" panose="020F0502020204030204" pitchFamily="34" charset="0"/>
+                <a:latin typeface="Marianne" panose="02000000000000000000" pitchFamily="50" charset="0"/>
                 <a:ea typeface="Calibri" panose="020F0502020204030204" pitchFamily="34" charset="0"/>
                 <a:cs typeface="Calibri" panose="020F0502020204030204" pitchFamily="34" charset="0"/>
               </a:rPr>
@@ -4976,7 +4978,7 @@
                 <a:solidFill>
                   <a:srgbClr val="161616"/>
                 </a:solidFill>
-                <a:latin typeface="Calibri" panose="020F0502020204030204" pitchFamily="34" charset="0"/>
+                <a:latin typeface="Marianne" panose="02000000000000000000" pitchFamily="50" charset="0"/>
                 <a:ea typeface="Calibri" panose="020F0502020204030204" pitchFamily="34" charset="0"/>
                 <a:cs typeface="Calibri" panose="020F0502020204030204" pitchFamily="34" charset="0"/>
               </a:rPr>
@@ -4987,14 +4989,14 @@
                 <a:solidFill>
                   <a:srgbClr val="161616"/>
                 </a:solidFill>
-                <a:latin typeface="Calibri" panose="020F0502020204030204" pitchFamily="34" charset="0"/>
+                <a:latin typeface="Marianne" panose="02000000000000000000" pitchFamily="50" charset="0"/>
                 <a:ea typeface="Calibri" panose="020F0502020204030204" pitchFamily="34" charset="0"/>
                 <a:cs typeface="Calibri" panose="020F0502020204030204" pitchFamily="34" charset="0"/>
               </a:rPr>
               <a:t>}}</a:t>
             </a:r>
             <a:endParaRPr lang="fr-FR" sz="2000" dirty="0">
-              <a:latin typeface="Calibri" panose="020F0502020204030204" pitchFamily="34" charset="0"/>
+              <a:latin typeface="Marianne" panose="02000000000000000000" pitchFamily="50" charset="0"/>
               <a:ea typeface="Calibri" panose="020F0502020204030204" pitchFamily="34" charset="0"/>
               <a:cs typeface="Calibri" panose="020F0502020204030204" pitchFamily="34" charset="0"/>
             </a:endParaRPr>
@@ -5078,7 +5080,7 @@
             </a:pPr>
             <a:r>
               <a:rPr lang="en-US" b="1" kern="0" spc="150" dirty="0">
-                <a:latin typeface="Calibri" panose="020F0502020204030204" pitchFamily="34" charset="0"/>
+                <a:latin typeface="Marianne" panose="02000000000000000000" pitchFamily="50" charset="0"/>
                 <a:ea typeface="Calibri" panose="020F0502020204030204" pitchFamily="34" charset="0"/>
                 <a:cs typeface="Calibri" panose="020F0502020204030204" pitchFamily="34" charset="0"/>
               </a:rPr>
@@ -5086,7 +5088,7 @@
             </a:r>
             <a:r>
               <a:rPr lang="en-US" b="1" kern="0" spc="150" dirty="0" err="1">
-                <a:latin typeface="Calibri" panose="020F0502020204030204" pitchFamily="34" charset="0"/>
+                <a:latin typeface="Marianne" panose="02000000000000000000" pitchFamily="50" charset="0"/>
                 <a:ea typeface="Calibri" panose="020F0502020204030204" pitchFamily="34" charset="0"/>
                 <a:cs typeface="Calibri" panose="020F0502020204030204" pitchFamily="34" charset="0"/>
               </a:rPr>
@@ -5094,14 +5096,14 @@
             </a:r>
             <a:r>
               <a:rPr lang="en-US" b="1" kern="0" spc="150" dirty="0">
-                <a:latin typeface="Calibri" panose="020F0502020204030204" pitchFamily="34" charset="0"/>
+                <a:latin typeface="Marianne" panose="02000000000000000000" pitchFamily="50" charset="0"/>
                 <a:ea typeface="Calibri" panose="020F0502020204030204" pitchFamily="34" charset="0"/>
                 <a:cs typeface="Calibri" panose="020F0502020204030204" pitchFamily="34" charset="0"/>
               </a:rPr>
               <a:t> oeuvre</a:t>
             </a:r>
             <a:endParaRPr lang="en-US" dirty="0">
-              <a:latin typeface="Calibri" panose="020F0502020204030204" pitchFamily="34" charset="0"/>
+              <a:latin typeface="Marianne" panose="02000000000000000000" pitchFamily="50" charset="0"/>
               <a:ea typeface="Calibri" panose="020F0502020204030204" pitchFamily="34" charset="0"/>
               <a:cs typeface="Calibri" panose="020F0502020204030204" pitchFamily="34" charset="0"/>
             </a:endParaRPr>
@@ -5140,7 +5142,7 @@
             </a:pPr>
             <a:r>
               <a:rPr lang="en-US" b="1" kern="0" spc="150" dirty="0" err="1">
-                <a:latin typeface="Calibri" panose="020F0502020204030204" pitchFamily="34" charset="0"/>
+                <a:latin typeface="Marianne" panose="02000000000000000000" pitchFamily="50" charset="0"/>
                 <a:ea typeface="Calibri" panose="020F0502020204030204" pitchFamily="34" charset="0"/>
                 <a:cs typeface="Calibri" panose="020F0502020204030204" pitchFamily="34" charset="0"/>
               </a:rPr>
@@ -5148,7 +5150,7 @@
             </a:r>
             <a:r>
               <a:rPr lang="en-US" b="1" kern="0" spc="150" dirty="0">
-                <a:latin typeface="Calibri" panose="020F0502020204030204" pitchFamily="34" charset="0"/>
+                <a:latin typeface="Marianne" panose="02000000000000000000" pitchFamily="50" charset="0"/>
                 <a:ea typeface="Calibri" panose="020F0502020204030204" pitchFamily="34" charset="0"/>
                 <a:cs typeface="Calibri" panose="020F0502020204030204" pitchFamily="34" charset="0"/>
               </a:rPr>
@@ -5156,14 +5158,14 @@
             </a:r>
             <a:r>
               <a:rPr lang="en-US" b="1" kern="0" spc="150" dirty="0" err="1">
-                <a:latin typeface="Calibri" panose="020F0502020204030204" pitchFamily="34" charset="0"/>
+                <a:latin typeface="Marianne" panose="02000000000000000000" pitchFamily="50" charset="0"/>
                 <a:ea typeface="Calibri" panose="020F0502020204030204" pitchFamily="34" charset="0"/>
                 <a:cs typeface="Calibri" panose="020F0502020204030204" pitchFamily="34" charset="0"/>
               </a:rPr>
               <a:t>attendu</a:t>
             </a:r>
             <a:endParaRPr lang="en-US" dirty="0">
-              <a:latin typeface="Calibri" panose="020F0502020204030204" pitchFamily="34" charset="0"/>
+              <a:latin typeface="Marianne" panose="02000000000000000000" pitchFamily="50" charset="0"/>
               <a:ea typeface="Calibri" panose="020F0502020204030204" pitchFamily="34" charset="0"/>
               <a:cs typeface="Calibri" panose="020F0502020204030204" pitchFamily="34" charset="0"/>
             </a:endParaRPr>
@@ -5202,14 +5204,14 @@
             </a:pPr>
             <a:r>
               <a:rPr lang="en-US" b="1" kern="0" spc="150" dirty="0" err="1">
-                <a:latin typeface="Calibri" panose="020F0502020204030204" pitchFamily="34" charset="0"/>
+                <a:latin typeface="Marianne" panose="02000000000000000000" pitchFamily="50" charset="0"/>
                 <a:ea typeface="Calibri" panose="020F0502020204030204" pitchFamily="34" charset="0"/>
                 <a:cs typeface="Calibri" panose="020F0502020204030204" pitchFamily="34" charset="0"/>
               </a:rPr>
               <a:t>Cobénéfices</a:t>
             </a:r>
             <a:endParaRPr lang="en-US" dirty="0">
-              <a:latin typeface="Calibri" panose="020F0502020204030204" pitchFamily="34" charset="0"/>
+              <a:latin typeface="Marianne" panose="02000000000000000000" pitchFamily="50" charset="0"/>
               <a:ea typeface="Calibri" panose="020F0502020204030204" pitchFamily="34" charset="0"/>
               <a:cs typeface="Calibri" panose="020F0502020204030204" pitchFamily="34" charset="0"/>
             </a:endParaRPr>
@@ -5296,7 +5298,7 @@
                 <a:solidFill>
                   <a:srgbClr val="A0A0A0"/>
                 </a:solidFill>
-                <a:latin typeface="Calibri" panose="020F0502020204030204" pitchFamily="34" charset="0"/>
+                <a:latin typeface="Marianne" panose="02000000000000000000" pitchFamily="50" charset="0"/>
                 <a:ea typeface="Calibri" panose="020F0502020204030204" pitchFamily="34" charset="0"/>
                 <a:cs typeface="Calibri" panose="020F0502020204030204" pitchFamily="34" charset="0"/>
               </a:rPr>
@@ -5307,7 +5309,7 @@
                 <a:solidFill>
                   <a:srgbClr val="A0A0A0"/>
                 </a:solidFill>
-                <a:latin typeface="Calibri" panose="020F0502020204030204" pitchFamily="34" charset="0"/>
+                <a:latin typeface="Marianne" panose="02000000000000000000" pitchFamily="50" charset="0"/>
                 <a:ea typeface="Calibri" panose="020F0502020204030204" pitchFamily="34" charset="0"/>
                 <a:cs typeface="Calibri" panose="020F0502020204030204" pitchFamily="34" charset="0"/>
               </a:rPr>
@@ -5318,7 +5320,7 @@
                 <a:solidFill>
                   <a:srgbClr val="A0A0A0"/>
                 </a:solidFill>
-                <a:latin typeface="Calibri" panose="020F0502020204030204" pitchFamily="34" charset="0"/>
+                <a:latin typeface="Marianne" panose="02000000000000000000" pitchFamily="50" charset="0"/>
                 <a:ea typeface="Calibri" panose="020F0502020204030204" pitchFamily="34" charset="0"/>
                 <a:cs typeface="Calibri" panose="020F0502020204030204" pitchFamily="34" charset="0"/>
               </a:rPr>
@@ -5329,7 +5331,7 @@
                 <a:solidFill>
                   <a:srgbClr val="A0A0A0"/>
                 </a:solidFill>
-                <a:latin typeface="Calibri" panose="020F0502020204030204" pitchFamily="34" charset="0"/>
+                <a:latin typeface="Marianne" panose="02000000000000000000" pitchFamily="50" charset="0"/>
                 <a:ea typeface="Calibri" panose="020F0502020204030204" pitchFamily="34" charset="0"/>
                 <a:cs typeface="Calibri" panose="020F0502020204030204" pitchFamily="34" charset="0"/>
               </a:rPr>
@@ -5340,14 +5342,14 @@
                 <a:solidFill>
                   <a:srgbClr val="A0A0A0"/>
                 </a:solidFill>
-                <a:latin typeface="Calibri" panose="020F0502020204030204" pitchFamily="34" charset="0"/>
+                <a:latin typeface="Marianne" panose="02000000000000000000" pitchFamily="50" charset="0"/>
                 <a:ea typeface="Calibri" panose="020F0502020204030204" pitchFamily="34" charset="0"/>
                 <a:cs typeface="Calibri" panose="020F0502020204030204" pitchFamily="34" charset="0"/>
               </a:rPr>
               <a:t> (ADEME)</a:t>
             </a:r>
             <a:endParaRPr lang="en-US" sz="1000" dirty="0">
-              <a:latin typeface="Calibri" panose="020F0502020204030204" pitchFamily="34" charset="0"/>
+              <a:latin typeface="Marianne" panose="02000000000000000000" pitchFamily="50" charset="0"/>
               <a:ea typeface="Calibri" panose="020F0502020204030204" pitchFamily="34" charset="0"/>
               <a:cs typeface="Calibri" panose="020F0502020204030204" pitchFamily="34" charset="0"/>
             </a:endParaRPr>
@@ -5428,7 +5430,7 @@
         <p:spPr>
           <a:xfrm>
             <a:off x="762150" y="4370216"/>
-            <a:ext cx="763315" cy="369332"/>
+            <a:ext cx="1006138" cy="369332"/>
           </a:xfrm>
           <a:prstGeom prst="rect">
             <a:avLst/>
@@ -5449,7 +5451,7 @@
                     <a:lumOff val="35000"/>
                   </a:schemeClr>
                 </a:solidFill>
-                <a:latin typeface="Calibri" panose="020F0502020204030204" pitchFamily="34" charset="0"/>
+                <a:latin typeface="Marianne" panose="02000000000000000000" pitchFamily="50" charset="0"/>
                 <a:ea typeface="Calibri" panose="020F0502020204030204" pitchFamily="34" charset="0"/>
                 <a:cs typeface="Calibri" panose="020F0502020204030204" pitchFamily="34" charset="0"/>
               </a:rPr>
@@ -5462,7 +5464,7 @@
                   <a:lumOff val="35000"/>
                 </a:schemeClr>
               </a:solidFill>
-              <a:latin typeface="Calibri" panose="020F0502020204030204" pitchFamily="34" charset="0"/>
+              <a:latin typeface="Marianne" panose="02000000000000000000" pitchFamily="50" charset="0"/>
               <a:ea typeface="Calibri" panose="020F0502020204030204" pitchFamily="34" charset="0"/>
               <a:cs typeface="Calibri" panose="020F0502020204030204" pitchFamily="34" charset="0"/>
             </a:endParaRPr>
@@ -5484,7 +5486,7 @@
         <p:spPr>
           <a:xfrm>
             <a:off x="2860182" y="2347002"/>
-            <a:ext cx="1861606" cy="1938992"/>
+            <a:ext cx="1861606" cy="2554545"/>
           </a:xfrm>
           <a:prstGeom prst="rect">
             <a:avLst/>
@@ -5502,7 +5504,7 @@
                 <a:solidFill>
                   <a:srgbClr val="002060"/>
                 </a:solidFill>
-                <a:latin typeface="Calibri" panose="020F0502020204030204" pitchFamily="34" charset="0"/>
+                <a:latin typeface="Marianne" panose="02000000000000000000" pitchFamily="50" charset="0"/>
                 <a:ea typeface="Calibri" panose="020F0502020204030204" pitchFamily="34" charset="0"/>
                 <a:cs typeface="Calibri" panose="020F0502020204030204" pitchFamily="34" charset="0"/>
               </a:rPr>
@@ -5513,7 +5515,7 @@
                 <a:solidFill>
                   <a:srgbClr val="002060"/>
                 </a:solidFill>
-                <a:latin typeface="Calibri" panose="020F0502020204030204" pitchFamily="34" charset="0"/>
+                <a:latin typeface="Marianne" panose="02000000000000000000" pitchFamily="50" charset="0"/>
                 <a:ea typeface="Calibri" panose="020F0502020204030204" pitchFamily="34" charset="0"/>
                 <a:cs typeface="Calibri" panose="020F0502020204030204" pitchFamily="34" charset="0"/>
               </a:rPr>
@@ -5524,7 +5526,7 @@
                 <a:solidFill>
                   <a:srgbClr val="002060"/>
                 </a:solidFill>
-                <a:latin typeface="Calibri" panose="020F0502020204030204" pitchFamily="34" charset="0"/>
+                <a:latin typeface="Marianne" panose="02000000000000000000" pitchFamily="50" charset="0"/>
                 <a:ea typeface="Calibri" panose="020F0502020204030204" pitchFamily="34" charset="0"/>
                 <a:cs typeface="Calibri" panose="020F0502020204030204" pitchFamily="34" charset="0"/>
               </a:rPr>
@@ -5584,7 +5586,7 @@
         <p:spPr>
           <a:xfrm>
             <a:off x="8085069" y="2634521"/>
-            <a:ext cx="3963324" cy="369332"/>
+            <a:ext cx="3963324" cy="338554"/>
           </a:xfrm>
           <a:prstGeom prst="rect">
             <a:avLst/>
@@ -5598,14 +5600,14 @@
           <a:lstStyle/>
           <a:p>
             <a:r>
-              <a:rPr lang="fr-FR" dirty="0">
+              <a:rPr lang="fr-FR" sz="1600" dirty="0">
                 <a:solidFill>
                   <a:schemeClr val="tx1">
                     <a:lumMod val="65000"/>
                     <a:lumOff val="35000"/>
                   </a:schemeClr>
                 </a:solidFill>
-                <a:latin typeface="Calibri" panose="020F0502020204030204" pitchFamily="34" charset="0"/>
+                <a:latin typeface="Marianne" panose="02000000000000000000" pitchFamily="50" charset="0"/>
                 <a:ea typeface="Calibri" panose="020F0502020204030204" pitchFamily="34" charset="0"/>
                 <a:cs typeface="Calibri" panose="020F0502020204030204" pitchFamily="34" charset="0"/>
               </a:rPr>
@@ -5809,7 +5811,7 @@
         <p:spPr>
           <a:xfrm>
             <a:off x="8085069" y="3225817"/>
-            <a:ext cx="3963324" cy="369332"/>
+            <a:ext cx="3963324" cy="338554"/>
           </a:xfrm>
           <a:prstGeom prst="rect">
             <a:avLst/>
@@ -5823,14 +5825,14 @@
           <a:lstStyle/>
           <a:p>
             <a:r>
-              <a:rPr lang="fr-FR" dirty="0">
+              <a:rPr lang="fr-FR" sz="1600" dirty="0">
                 <a:solidFill>
                   <a:schemeClr val="tx1">
                     <a:lumMod val="65000"/>
                     <a:lumOff val="35000"/>
                   </a:schemeClr>
                 </a:solidFill>
-                <a:latin typeface="Calibri" panose="020F0502020204030204" pitchFamily="34" charset="0"/>
+                <a:latin typeface="Marianne" panose="02000000000000000000" pitchFamily="50" charset="0"/>
                 <a:ea typeface="Calibri" panose="020F0502020204030204" pitchFamily="34" charset="0"/>
                 <a:cs typeface="Calibri" panose="020F0502020204030204" pitchFamily="34" charset="0"/>
               </a:rPr>
@@ -5854,7 +5856,7 @@
         <p:spPr>
           <a:xfrm>
             <a:off x="8082875" y="3804872"/>
-            <a:ext cx="3963324" cy="369332"/>
+            <a:ext cx="3963324" cy="338554"/>
           </a:xfrm>
           <a:prstGeom prst="rect">
             <a:avLst/>
@@ -5868,14 +5870,14 @@
           <a:lstStyle/>
           <a:p>
             <a:r>
-              <a:rPr lang="fr-FR" dirty="0">
+              <a:rPr lang="fr-FR" sz="1600" dirty="0">
                 <a:solidFill>
                   <a:schemeClr val="tx1">
                     <a:lumMod val="65000"/>
                     <a:lumOff val="35000"/>
                   </a:schemeClr>
                 </a:solidFill>
-                <a:latin typeface="Calibri" panose="020F0502020204030204" pitchFamily="34" charset="0"/>
+                <a:latin typeface="Marianne" panose="02000000000000000000" pitchFamily="50" charset="0"/>
                 <a:ea typeface="Calibri" panose="020F0502020204030204" pitchFamily="34" charset="0"/>
                 <a:cs typeface="Calibri" panose="020F0502020204030204" pitchFamily="34" charset="0"/>
               </a:rPr>
@@ -5899,7 +5901,7 @@
         <p:spPr>
           <a:xfrm>
             <a:off x="8090359" y="4383927"/>
-            <a:ext cx="3963324" cy="369332"/>
+            <a:ext cx="3963324" cy="338554"/>
           </a:xfrm>
           <a:prstGeom prst="rect">
             <a:avLst/>
@@ -5913,14 +5915,14 @@
           <a:lstStyle/>
           <a:p>
             <a:r>
-              <a:rPr lang="fr-FR" dirty="0">
+              <a:rPr lang="fr-FR" sz="1600" dirty="0">
                 <a:solidFill>
                   <a:schemeClr val="tx1">
                     <a:lumMod val="65000"/>
                     <a:lumOff val="35000"/>
                   </a:schemeClr>
                 </a:solidFill>
-                <a:latin typeface="Calibri" panose="020F0502020204030204" pitchFamily="34" charset="0"/>
+                <a:latin typeface="Marianne" panose="02000000000000000000" pitchFamily="50" charset="0"/>
                 <a:ea typeface="Calibri" panose="020F0502020204030204" pitchFamily="34" charset="0"/>
                 <a:cs typeface="Calibri" panose="020F0502020204030204" pitchFamily="34" charset="0"/>
               </a:rPr>
@@ -5944,7 +5946,7 @@
         <p:spPr>
           <a:xfrm>
             <a:off x="8082875" y="4977224"/>
-            <a:ext cx="3963324" cy="369332"/>
+            <a:ext cx="3963324" cy="338554"/>
           </a:xfrm>
           <a:prstGeom prst="rect">
             <a:avLst/>
@@ -5958,14 +5960,14 @@
           <a:lstStyle/>
           <a:p>
             <a:r>
-              <a:rPr lang="fr-FR" dirty="0">
+              <a:rPr lang="fr-FR" sz="1600" dirty="0">
                 <a:solidFill>
                   <a:schemeClr val="tx1">
                     <a:lumMod val="65000"/>
                     <a:lumOff val="35000"/>
                   </a:schemeClr>
                 </a:solidFill>
-                <a:latin typeface="Calibri" panose="020F0502020204030204" pitchFamily="34" charset="0"/>
+                <a:latin typeface="Marianne" panose="02000000000000000000" pitchFamily="50" charset="0"/>
                 <a:ea typeface="Calibri" panose="020F0502020204030204" pitchFamily="34" charset="0"/>
                 <a:cs typeface="Calibri" panose="020F0502020204030204" pitchFamily="34" charset="0"/>
               </a:rPr>
@@ -6010,7 +6012,7 @@
                     <a:lumOff val="35000"/>
                   </a:schemeClr>
                 </a:solidFill>
-                <a:latin typeface="Calibri" panose="020F0502020204030204" pitchFamily="34" charset="0"/>
+                <a:latin typeface="Marianne" panose="02000000000000000000" pitchFamily="50" charset="0"/>
                 <a:ea typeface="Calibri" panose="020F0502020204030204" pitchFamily="34" charset="0"/>
                 <a:cs typeface="Calibri" panose="020F0502020204030204" pitchFamily="34" charset="0"/>
               </a:rPr>
@@ -6024,7 +6026,7 @@
                     <a:lumOff val="35000"/>
                   </a:schemeClr>
                 </a:solidFill>
-                <a:latin typeface="Calibri" panose="020F0502020204030204" pitchFamily="34" charset="0"/>
+                <a:latin typeface="Marianne" panose="02000000000000000000" pitchFamily="50" charset="0"/>
                 <a:ea typeface="Calibri" panose="020F0502020204030204" pitchFamily="34" charset="0"/>
                 <a:cs typeface="Calibri" panose="020F0502020204030204" pitchFamily="34" charset="0"/>
               </a:rPr>
@@ -6038,7 +6040,7 @@
                     <a:lumOff val="35000"/>
                   </a:schemeClr>
                 </a:solidFill>
-                <a:latin typeface="Calibri" panose="020F0502020204030204" pitchFamily="34" charset="0"/>
+                <a:latin typeface="Marianne" panose="02000000000000000000" pitchFamily="50" charset="0"/>
                 <a:ea typeface="Calibri" panose="020F0502020204030204" pitchFamily="34" charset="0"/>
                 <a:cs typeface="Calibri" panose="020F0502020204030204" pitchFamily="34" charset="0"/>
               </a:rPr>
@@ -6051,7 +6053,7 @@
                   <a:lumOff val="35000"/>
                 </a:schemeClr>
               </a:solidFill>
-              <a:latin typeface="Calibri" panose="020F0502020204030204" pitchFamily="34" charset="0"/>
+              <a:latin typeface="Marianne" panose="02000000000000000000" pitchFamily="50" charset="0"/>
               <a:ea typeface="Calibri" panose="020F0502020204030204" pitchFamily="34" charset="0"/>
               <a:cs typeface="Calibri" panose="020F0502020204030204" pitchFamily="34" charset="0"/>
             </a:endParaRPr>
@@ -6064,7 +6066,7 @@
                   <a:lumOff val="35000"/>
                 </a:schemeClr>
               </a:solidFill>
-              <a:latin typeface="Calibri" panose="020F0502020204030204" pitchFamily="34" charset="0"/>
+              <a:latin typeface="Marianne" panose="02000000000000000000" pitchFamily="50" charset="0"/>
               <a:ea typeface="Calibri" panose="020F0502020204030204" pitchFamily="34" charset="0"/>
               <a:cs typeface="Calibri" panose="020F0502020204030204" pitchFamily="34" charset="0"/>
             </a:endParaRPr>
@@ -6085,8 +6087,8 @@
         </p:nvSpPr>
         <p:spPr>
           <a:xfrm>
-            <a:off x="754275" y="4853531"/>
-            <a:ext cx="1944964" cy="369332"/>
+            <a:off x="754274" y="4853531"/>
+            <a:ext cx="2293647" cy="369332"/>
           </a:xfrm>
           <a:prstGeom prst="rect">
             <a:avLst/>
@@ -6107,7 +6109,7 @@
                     <a:lumOff val="35000"/>
                   </a:schemeClr>
                 </a:solidFill>
-                <a:latin typeface="Calibri" panose="020F0502020204030204" pitchFamily="34" charset="0"/>
+                <a:latin typeface="Marianne" panose="02000000000000000000" pitchFamily="50" charset="0"/>
                 <a:ea typeface="Calibri" panose="020F0502020204030204" pitchFamily="34" charset="0"/>
                 <a:cs typeface="Calibri" panose="020F0502020204030204" pitchFamily="34" charset="0"/>
               </a:rPr>
@@ -6120,7 +6122,7 @@
                   <a:lumOff val="35000"/>
                 </a:schemeClr>
               </a:solidFill>
-              <a:latin typeface="Calibri" panose="020F0502020204030204" pitchFamily="34" charset="0"/>
+              <a:latin typeface="Marianne" panose="02000000000000000000" pitchFamily="50" charset="0"/>
               <a:ea typeface="Calibri" panose="020F0502020204030204" pitchFamily="34" charset="0"/>
               <a:cs typeface="Calibri" panose="020F0502020204030204" pitchFamily="34" charset="0"/>
             </a:endParaRPr>
@@ -6141,7 +6143,7 @@
         </p:nvSpPr>
         <p:spPr>
           <a:xfrm>
-            <a:off x="2581955" y="4877899"/>
+            <a:off x="2884517" y="4877899"/>
             <a:ext cx="2609903" cy="338554"/>
           </a:xfrm>
           <a:prstGeom prst="rect">
@@ -6163,7 +6165,7 @@
                     <a:lumOff val="35000"/>
                   </a:schemeClr>
                 </a:solidFill>
-                <a:latin typeface="Calibri" panose="020F0502020204030204" pitchFamily="34" charset="0"/>
+                <a:latin typeface="Marianne" panose="02000000000000000000" pitchFamily="50" charset="0"/>
                 <a:ea typeface="Calibri" panose="020F0502020204030204" pitchFamily="34" charset="0"/>
                 <a:cs typeface="Calibri" panose="020F0502020204030204" pitchFamily="34" charset="0"/>
               </a:rPr>
@@ -6177,7 +6179,7 @@
                     <a:lumOff val="35000"/>
                   </a:schemeClr>
                 </a:solidFill>
-                <a:latin typeface="Calibri" panose="020F0502020204030204" pitchFamily="34" charset="0"/>
+                <a:latin typeface="Marianne" panose="02000000000000000000" pitchFamily="50" charset="0"/>
                 <a:ea typeface="Calibri" panose="020F0502020204030204" pitchFamily="34" charset="0"/>
                 <a:cs typeface="Calibri" panose="020F0502020204030204" pitchFamily="34" charset="0"/>
               </a:rPr>
@@ -6191,7 +6193,7 @@
                     <a:lumOff val="35000"/>
                   </a:schemeClr>
                 </a:solidFill>
-                <a:latin typeface="Calibri" panose="020F0502020204030204" pitchFamily="34" charset="0"/>
+                <a:latin typeface="Marianne" panose="02000000000000000000" pitchFamily="50" charset="0"/>
                 <a:ea typeface="Calibri" panose="020F0502020204030204" pitchFamily="34" charset="0"/>
                 <a:cs typeface="Calibri" panose="020F0502020204030204" pitchFamily="34" charset="0"/>
               </a:rPr>
@@ -6214,7 +6216,7 @@
         </p:nvSpPr>
         <p:spPr>
           <a:xfrm>
-            <a:off x="1377409" y="4386098"/>
+            <a:off x="1491713" y="4386098"/>
             <a:ext cx="3814449" cy="338554"/>
           </a:xfrm>
           <a:prstGeom prst="rect">
@@ -6236,7 +6238,7 @@
                     <a:lumOff val="35000"/>
                   </a:schemeClr>
                 </a:solidFill>
-                <a:latin typeface="Calibri" panose="020F0502020204030204" pitchFamily="34" charset="0"/>
+                <a:latin typeface="Marianne" panose="02000000000000000000" pitchFamily="50" charset="0"/>
                 <a:ea typeface="Calibri" panose="020F0502020204030204" pitchFamily="34" charset="0"/>
                 <a:cs typeface="Calibri" panose="020F0502020204030204" pitchFamily="34" charset="0"/>
               </a:rPr>
@@ -6250,7 +6252,7 @@
                     <a:lumOff val="35000"/>
                   </a:schemeClr>
                 </a:solidFill>
-                <a:latin typeface="Calibri" panose="020F0502020204030204" pitchFamily="34" charset="0"/>
+                <a:latin typeface="Marianne" panose="02000000000000000000" pitchFamily="50" charset="0"/>
                 <a:ea typeface="Calibri" panose="020F0502020204030204" pitchFamily="34" charset="0"/>
                 <a:cs typeface="Calibri" panose="020F0502020204030204" pitchFamily="34" charset="0"/>
               </a:rPr>
@@ -6264,7 +6266,7 @@
                     <a:lumOff val="35000"/>
                   </a:schemeClr>
                 </a:solidFill>
-                <a:latin typeface="Calibri" panose="020F0502020204030204" pitchFamily="34" charset="0"/>
+                <a:latin typeface="Marianne" panose="02000000000000000000" pitchFamily="50" charset="0"/>
                 <a:ea typeface="Calibri" panose="020F0502020204030204" pitchFamily="34" charset="0"/>
                 <a:cs typeface="Calibri" panose="020F0502020204030204" pitchFamily="34" charset="0"/>
               </a:rPr>
@@ -6324,7 +6326,7 @@
         <p:spPr>
           <a:xfrm>
             <a:off x="576263" y="1137583"/>
-            <a:ext cx="10187724" cy="369332"/>
+            <a:ext cx="10187724" cy="646331"/>
           </a:xfrm>
           <a:prstGeom prst="rect">
             <a:avLst/>
@@ -6343,7 +6345,7 @@
                   <a:srgbClr val="161616"/>
                 </a:solidFill>
                 <a:effectLst/>
-                <a:latin typeface="Aptos" panose="020B0004020202020204" pitchFamily="34" charset="0"/>
+                <a:latin typeface="Marianne" panose="02000000000000000000" pitchFamily="50" charset="0"/>
               </a:rPr>
               <a:t>Équipements, matériaux et systèmes retenus pour le projet {{</a:t>
             </a:r>
@@ -6353,7 +6355,7 @@
                   <a:srgbClr val="161616"/>
                 </a:solidFill>
                 <a:effectLst/>
-                <a:latin typeface="Aptos" panose="020B0004020202020204" pitchFamily="34" charset="0"/>
+                <a:latin typeface="Marianne" panose="02000000000000000000" pitchFamily="50" charset="0"/>
               </a:rPr>
               <a:t>pagination_solution_materiaux</a:t>
             </a:r>
@@ -6363,12 +6365,12 @@
                   <a:srgbClr val="161616"/>
                 </a:solidFill>
                 <a:effectLst/>
-                <a:latin typeface="Aptos" panose="020B0004020202020204" pitchFamily="34" charset="0"/>
+                <a:latin typeface="Marianne" panose="02000000000000000000" pitchFamily="50" charset="0"/>
               </a:rPr>
               <a:t>}}</a:t>
             </a:r>
             <a:endParaRPr lang="fr-FR" dirty="0">
-              <a:latin typeface="Aptos" panose="020B0004020202020204" pitchFamily="34" charset="0"/>
+              <a:latin typeface="Marianne" panose="02000000000000000000" pitchFamily="50" charset="0"/>
             </a:endParaRPr>
           </a:p>
         </p:txBody>
@@ -6416,7 +6418,9 @@
           <a:bodyPr/>
           <a:lstStyle/>
           <a:p>
-            <a:endParaRPr lang="fr-FR"/>
+            <a:endParaRPr lang="fr-FR">
+              <a:latin typeface="Marianne" panose="02000000000000000000" pitchFamily="50" charset="0"/>
+            </a:endParaRPr>
           </a:p>
         </p:txBody>
       </p:sp>
@@ -6451,26 +6455,26 @@
             <a:r>
               <a:rPr lang="fr-FR" sz="1400" b="1" i="0" dirty="0">
                 <a:effectLst/>
-                <a:latin typeface="Aptos" panose="020B0004020202020204" pitchFamily="34" charset="0"/>
+                <a:latin typeface="Marianne" panose="02000000000000000000" pitchFamily="50" charset="0"/>
               </a:rPr>
               <a:t>{{</a:t>
             </a:r>
             <a:r>
               <a:rPr lang="fr-FR" sz="1400" b="1" i="0" dirty="0" err="1">
                 <a:effectLst/>
-                <a:latin typeface="Aptos" panose="020B0004020202020204" pitchFamily="34" charset="0"/>
+                <a:latin typeface="Marianne" panose="02000000000000000000" pitchFamily="50" charset="0"/>
               </a:rPr>
               <a:t>titre_materiau</a:t>
             </a:r>
             <a:r>
               <a:rPr lang="fr-FR" sz="1400" b="1" i="0" dirty="0">
                 <a:effectLst/>
-                <a:latin typeface="Aptos" panose="020B0004020202020204" pitchFamily="34" charset="0"/>
+                <a:latin typeface="Marianne" panose="02000000000000000000" pitchFamily="50" charset="0"/>
               </a:rPr>
               <a:t>}}</a:t>
             </a:r>
             <a:endParaRPr lang="fr-FR" sz="1400" b="1" dirty="0">
-              <a:latin typeface="Aptos" panose="020B0004020202020204" pitchFamily="34" charset="0"/>
+              <a:latin typeface="Marianne" panose="02000000000000000000" pitchFamily="50" charset="0"/>
             </a:endParaRPr>
           </a:p>
         </p:txBody>
@@ -6489,8 +6493,8 @@
         </p:nvSpPr>
         <p:spPr>
           <a:xfrm>
-            <a:off x="8538776" y="1974626"/>
-            <a:ext cx="1625783" cy="307777"/>
+            <a:off x="8256494" y="1974626"/>
+            <a:ext cx="1908065" cy="307777"/>
           </a:xfrm>
           <a:prstGeom prst="rect">
             <a:avLst/>
@@ -6510,7 +6514,7 @@
                 <a:solidFill>
                   <a:srgbClr val="5C5C5C"/>
                 </a:solidFill>
-                <a:latin typeface="Calibri" pitchFamily="34" charset="0"/>
+                <a:latin typeface="Marianne" panose="02000000000000000000" pitchFamily="50" charset="0"/>
                 <a:ea typeface="Calibri" pitchFamily="34" charset="-122"/>
                 <a:cs typeface="Calibri" pitchFamily="34" charset="-120"/>
               </a:rPr>
@@ -6521,7 +6525,7 @@
                 <a:solidFill>
                   <a:srgbClr val="5C5C5C"/>
                 </a:solidFill>
-                <a:latin typeface="Calibri" pitchFamily="34" charset="0"/>
+                <a:latin typeface="Marianne" panose="02000000000000000000" pitchFamily="50" charset="0"/>
                 <a:ea typeface="Calibri" pitchFamily="34" charset="-122"/>
                 <a:cs typeface="Calibri" pitchFamily="34" charset="-120"/>
               </a:rPr>
@@ -6532,13 +6536,15 @@
                 <a:solidFill>
                   <a:srgbClr val="5C5C5C"/>
                 </a:solidFill>
-                <a:latin typeface="Calibri" pitchFamily="34" charset="0"/>
+                <a:latin typeface="Marianne" panose="02000000000000000000" pitchFamily="50" charset="0"/>
                 <a:ea typeface="Calibri" pitchFamily="34" charset="-122"/>
                 <a:cs typeface="Calibri" pitchFamily="34" charset="-120"/>
               </a:rPr>
               <a:t>}}</a:t>
             </a:r>
-            <a:endParaRPr lang="en-US" sz="1300" dirty="0"/>
+            <a:endParaRPr lang="en-US" sz="1300" dirty="0">
+              <a:latin typeface="Marianne" panose="02000000000000000000" pitchFamily="50" charset="0"/>
+            </a:endParaRPr>
           </a:p>
         </p:txBody>
       </p:sp>
@@ -6602,19 +6608,19 @@
           <a:p>
             <a:r>
               <a:rPr lang="fr-FR" sz="1300" dirty="0">
-                <a:latin typeface="Aptos"/>
+                <a:latin typeface="Marianne" panose="02000000000000000000" pitchFamily="50" charset="0"/>
               </a:rPr>
               <a:t>{{</a:t>
             </a:r>
             <a:r>
               <a:rPr lang="fr-FR" sz="1300" dirty="0" err="1">
-                <a:latin typeface="Aptos"/>
+                <a:latin typeface="Marianne" panose="02000000000000000000" pitchFamily="50" charset="0"/>
               </a:rPr>
               <a:t>description_materiau</a:t>
             </a:r>
             <a:r>
               <a:rPr lang="fr-FR" sz="1300" dirty="0">
-                <a:latin typeface="Aptos"/>
+                <a:latin typeface="Marianne" panose="02000000000000000000" pitchFamily="50" charset="0"/>
               </a:rPr>
               <a:t>}}</a:t>
             </a:r>
@@ -6657,7 +6663,7 @@
                 <a:solidFill>
                   <a:srgbClr val="2C2C2C"/>
                 </a:solidFill>
-                <a:latin typeface="Calibri" pitchFamily="34" charset="0"/>
+                <a:latin typeface="Marianne" panose="02000000000000000000" pitchFamily="50" charset="0"/>
                 <a:ea typeface="Calibri" pitchFamily="34" charset="-122"/>
                 <a:cs typeface="Calibri" pitchFamily="34" charset="-120"/>
               </a:rPr>
@@ -6668,7 +6674,7 @@
                 <a:solidFill>
                   <a:srgbClr val="2C2C2C"/>
                 </a:solidFill>
-                <a:latin typeface="Calibri" pitchFamily="34" charset="0"/>
+                <a:latin typeface="Marianne" panose="02000000000000000000" pitchFamily="50" charset="0"/>
                 <a:ea typeface="Calibri" pitchFamily="34" charset="-122"/>
                 <a:cs typeface="Calibri" pitchFamily="34" charset="-120"/>
               </a:rPr>
@@ -6679,7 +6685,7 @@
                 <a:solidFill>
                   <a:srgbClr val="2C2C2C"/>
                 </a:solidFill>
-                <a:latin typeface="Calibri" pitchFamily="34" charset="0"/>
+                <a:latin typeface="Marianne" panose="02000000000000000000" pitchFamily="50" charset="0"/>
                 <a:ea typeface="Calibri" pitchFamily="34" charset="-122"/>
                 <a:cs typeface="Calibri" pitchFamily="34" charset="-120"/>
               </a:rPr>
@@ -6690,7 +6696,7 @@
                 <a:solidFill>
                   <a:srgbClr val="2C2C2C"/>
                 </a:solidFill>
-                <a:latin typeface="Calibri" pitchFamily="34" charset="0"/>
+                <a:latin typeface="Marianne" panose="02000000000000000000" pitchFamily="50" charset="0"/>
                 <a:ea typeface="Calibri" pitchFamily="34" charset="-122"/>
                 <a:cs typeface="Calibri" pitchFamily="34" charset="-120"/>
               </a:rPr>
@@ -6701,7 +6707,7 @@
                 <a:solidFill>
                   <a:srgbClr val="2C2C2C"/>
                 </a:solidFill>
-                <a:latin typeface="Calibri" pitchFamily="34" charset="0"/>
+                <a:latin typeface="Marianne" panose="02000000000000000000" pitchFamily="50" charset="0"/>
                 <a:ea typeface="Calibri" pitchFamily="34" charset="-122"/>
                 <a:cs typeface="Calibri" pitchFamily="34" charset="-120"/>
               </a:rPr>
@@ -6712,13 +6718,15 @@
                 <a:solidFill>
                   <a:srgbClr val="2C2C2C"/>
                 </a:solidFill>
-                <a:latin typeface="Calibri" pitchFamily="34" charset="0"/>
+                <a:latin typeface="Marianne" panose="02000000000000000000" pitchFamily="50" charset="0"/>
                 <a:ea typeface="Calibri" pitchFamily="34" charset="-122"/>
                 <a:cs typeface="Calibri" pitchFamily="34" charset="-120"/>
               </a:rPr>
               <a:t>}}</a:t>
             </a:r>
-            <a:endParaRPr lang="en-US" sz="1200" dirty="0"/>
+            <a:endParaRPr lang="en-US" sz="1200" dirty="0">
+              <a:latin typeface="Marianne" panose="02000000000000000000" pitchFamily="50" charset="0"/>
+            </a:endParaRPr>
           </a:p>
         </p:txBody>
       </p:sp>
@@ -6771,7 +6779,7 @@
           <a:p>
             <a:r>
               <a:rPr lang="en-US" sz="3200" dirty="0">
-                <a:latin typeface="Calibri" panose="020F0502020204030204" pitchFamily="34" charset="0"/>
+                <a:latin typeface="Marianne" panose="02000000000000000000" pitchFamily="50" charset="0"/>
                 <a:ea typeface="Calibri" panose="020F0502020204030204" pitchFamily="34" charset="0"/>
                 <a:cs typeface="Calibri" panose="020F0502020204030204" pitchFamily="34" charset="0"/>
               </a:rPr>
@@ -6779,7 +6787,7 @@
             </a:r>
             <a:r>
               <a:rPr lang="en-US" sz="3200" dirty="0" err="1">
-                <a:latin typeface="Calibri" panose="020F0502020204030204" pitchFamily="34" charset="0"/>
+                <a:latin typeface="Marianne" panose="02000000000000000000" pitchFamily="50" charset="0"/>
                 <a:ea typeface="Calibri" panose="020F0502020204030204" pitchFamily="34" charset="0"/>
                 <a:cs typeface="Calibri" panose="020F0502020204030204" pitchFamily="34" charset="0"/>
               </a:rPr>
@@ -6787,7 +6795,7 @@
             </a:r>
             <a:r>
               <a:rPr lang="en-US" sz="3200" dirty="0">
-                <a:latin typeface="Calibri" panose="020F0502020204030204" pitchFamily="34" charset="0"/>
+                <a:latin typeface="Marianne" panose="02000000000000000000" pitchFamily="50" charset="0"/>
                 <a:ea typeface="Calibri" panose="020F0502020204030204" pitchFamily="34" charset="0"/>
                 <a:cs typeface="Calibri" panose="020F0502020204030204" pitchFamily="34" charset="0"/>
               </a:rPr>
@@ -6795,7 +6803,7 @@
             </a:r>
             <a:r>
               <a:rPr lang="en-US" sz="3200" dirty="0" err="1">
-                <a:latin typeface="Calibri" panose="020F0502020204030204" pitchFamily="34" charset="0"/>
+                <a:latin typeface="Marianne" panose="02000000000000000000" pitchFamily="50" charset="0"/>
                 <a:ea typeface="Calibri" panose="020F0502020204030204" pitchFamily="34" charset="0"/>
                 <a:cs typeface="Calibri" panose="020F0502020204030204" pitchFamily="34" charset="0"/>
               </a:rPr>
@@ -6803,13 +6811,15 @@
             </a:r>
             <a:r>
               <a:rPr lang="en-US" sz="3200" dirty="0">
-                <a:latin typeface="Calibri" panose="020F0502020204030204" pitchFamily="34" charset="0"/>
+                <a:latin typeface="Marianne" panose="02000000000000000000" pitchFamily="50" charset="0"/>
                 <a:ea typeface="Calibri" panose="020F0502020204030204" pitchFamily="34" charset="0"/>
                 <a:cs typeface="Calibri" panose="020F0502020204030204" pitchFamily="34" charset="0"/>
               </a:rPr>
               <a:t>}}</a:t>
             </a:r>
-            <a:endParaRPr lang="en-US" sz="3200" dirty="0"/>
+            <a:endParaRPr lang="en-US" sz="3200" dirty="0">
+              <a:latin typeface="Marianne" panose="02000000000000000000" pitchFamily="50" charset="0"/>
+            </a:endParaRPr>
           </a:p>
         </p:txBody>
       </p:sp>
@@ -6981,7 +6991,7 @@
           <a:lstStyle/>
           <a:p>
             <a:endParaRPr lang="en-US" sz="13333" dirty="0">
-              <a:latin typeface="Calibri" panose="020F0502020204030204" pitchFamily="34" charset="0"/>
+              <a:latin typeface="Marianne" panose="02000000000000000000" pitchFamily="50" charset="0"/>
               <a:ea typeface="Calibri" panose="020F0502020204030204" pitchFamily="34" charset="0"/>
               <a:cs typeface="Calibri" panose="020F0502020204030204" pitchFamily="34" charset="0"/>
             </a:endParaRPr>
@@ -7020,7 +7030,7 @@
                 <a:solidFill>
                   <a:srgbClr val="1A1A1A"/>
                 </a:solidFill>
-                <a:latin typeface="Calibri" panose="020F0502020204030204" pitchFamily="34" charset="0"/>
+                <a:latin typeface="Marianne" panose="02000000000000000000" pitchFamily="50" charset="0"/>
                 <a:ea typeface="Calibri" panose="020F0502020204030204" pitchFamily="34" charset="0"/>
                 <a:cs typeface="Calibri" panose="020F0502020204030204" pitchFamily="34" charset="0"/>
               </a:rPr>
@@ -7031,14 +7041,14 @@
                 <a:solidFill>
                   <a:srgbClr val="1A1A1A"/>
                 </a:solidFill>
-                <a:latin typeface="Calibri" panose="020F0502020204030204" pitchFamily="34" charset="0"/>
+                <a:latin typeface="Marianne" panose="02000000000000000000" pitchFamily="50" charset="0"/>
                 <a:ea typeface="Calibri" panose="020F0502020204030204" pitchFamily="34" charset="0"/>
                 <a:cs typeface="Calibri" panose="020F0502020204030204" pitchFamily="34" charset="0"/>
               </a:rPr>
               <a:t>budgétaire</a:t>
             </a:r>
             <a:endParaRPr lang="en-US" sz="3733" dirty="0">
-              <a:latin typeface="Calibri" panose="020F0502020204030204" pitchFamily="34" charset="0"/>
+              <a:latin typeface="Marianne" panose="02000000000000000000" pitchFamily="50" charset="0"/>
               <a:ea typeface="Calibri" panose="020F0502020204030204" pitchFamily="34" charset="0"/>
               <a:cs typeface="Calibri" panose="020F0502020204030204" pitchFamily="34" charset="0"/>
             </a:endParaRPr>
@@ -7080,7 +7090,7 @@
           <a:lstStyle/>
           <a:p>
             <a:endParaRPr lang="fr-FR" sz="2400">
-              <a:latin typeface="Calibri" panose="020F0502020204030204" pitchFamily="34" charset="0"/>
+              <a:latin typeface="Marianne" panose="02000000000000000000" pitchFamily="50" charset="0"/>
               <a:ea typeface="Calibri" panose="020F0502020204030204" pitchFamily="34" charset="0"/>
               <a:cs typeface="Calibri" panose="020F0502020204030204" pitchFamily="34" charset="0"/>
             </a:endParaRPr>
@@ -7119,7 +7129,7 @@
                 <a:solidFill>
                   <a:srgbClr val="5C5C5C"/>
                 </a:solidFill>
-                <a:latin typeface="Calibri" pitchFamily="34" charset="0"/>
+                <a:latin typeface="Marianne" panose="02000000000000000000" pitchFamily="50" charset="0"/>
                 <a:ea typeface="Calibri" pitchFamily="34" charset="-122"/>
                 <a:cs typeface="Calibri" pitchFamily="34" charset="-120"/>
               </a:rPr>
@@ -7130,7 +7140,7 @@
                 <a:solidFill>
                   <a:srgbClr val="5C5C5C"/>
                 </a:solidFill>
-                <a:latin typeface="Calibri" pitchFamily="34" charset="0"/>
+                <a:latin typeface="Marianne" panose="02000000000000000000" pitchFamily="50" charset="0"/>
                 <a:ea typeface="Calibri" pitchFamily="34" charset="-122"/>
                 <a:cs typeface="Calibri" pitchFamily="34" charset="-120"/>
               </a:rPr>
@@ -7141,7 +7151,7 @@
                 <a:solidFill>
                   <a:srgbClr val="5C5C5C"/>
                 </a:solidFill>
-                <a:latin typeface="Calibri" pitchFamily="34" charset="0"/>
+                <a:latin typeface="Marianne" panose="02000000000000000000" pitchFamily="50" charset="0"/>
                 <a:ea typeface="Calibri" pitchFamily="34" charset="-122"/>
                 <a:cs typeface="Calibri" pitchFamily="34" charset="-120"/>
               </a:rPr>
@@ -7152,7 +7162,7 @@
                 <a:solidFill>
                   <a:srgbClr val="5C5C5C"/>
                 </a:solidFill>
-                <a:latin typeface="Calibri" pitchFamily="34" charset="0"/>
+                <a:latin typeface="Marianne" panose="02000000000000000000" pitchFamily="50" charset="0"/>
                 <a:ea typeface="Calibri" pitchFamily="34" charset="-122"/>
                 <a:cs typeface="Calibri" pitchFamily="34" charset="-120"/>
               </a:rPr>
@@ -7163,7 +7173,7 @@
                 <a:solidFill>
                   <a:srgbClr val="5C5C5C"/>
                 </a:solidFill>
-                <a:latin typeface="Calibri" pitchFamily="34" charset="0"/>
+                <a:latin typeface="Marianne" panose="02000000000000000000" pitchFamily="50" charset="0"/>
                 <a:ea typeface="Calibri" pitchFamily="34" charset="-122"/>
                 <a:cs typeface="Calibri" pitchFamily="34" charset="-120"/>
               </a:rPr>
@@ -7174,7 +7184,7 @@
                 <a:solidFill>
                   <a:srgbClr val="5C5C5C"/>
                 </a:solidFill>
-                <a:latin typeface="Calibri" pitchFamily="34" charset="0"/>
+                <a:latin typeface="Marianne" panose="02000000000000000000" pitchFamily="50" charset="0"/>
                 <a:ea typeface="Calibri" pitchFamily="34" charset="-122"/>
                 <a:cs typeface="Calibri" pitchFamily="34" charset="-120"/>
               </a:rPr>
@@ -7185,13 +7195,15 @@
                 <a:solidFill>
                   <a:srgbClr val="5C5C5C"/>
                 </a:solidFill>
-                <a:latin typeface="Calibri" pitchFamily="34" charset="0"/>
+                <a:latin typeface="Marianne" panose="02000000000000000000" pitchFamily="50" charset="0"/>
                 <a:ea typeface="Calibri" pitchFamily="34" charset="-122"/>
                 <a:cs typeface="Calibri" pitchFamily="34" charset="-120"/>
               </a:rPr>
               <a:t>annuels</a:t>
             </a:r>
-            <a:endParaRPr lang="en-US" sz="1600" dirty="0"/>
+            <a:endParaRPr lang="en-US" sz="1600" dirty="0">
+              <a:latin typeface="Marianne" panose="02000000000000000000" pitchFamily="50" charset="0"/>
+            </a:endParaRPr>
           </a:p>
         </p:txBody>
       </p:sp>
@@ -7275,14 +7287,14 @@
                 <a:solidFill>
                   <a:srgbClr val="A0A0A0"/>
                 </a:solidFill>
-                <a:latin typeface="Calibri" panose="020F0502020204030204" pitchFamily="34" charset="0"/>
+                <a:latin typeface="Marianne" panose="02000000000000000000" pitchFamily="50" charset="0"/>
                 <a:ea typeface="Calibri" panose="020F0502020204030204" pitchFamily="34" charset="0"/>
                 <a:cs typeface="Calibri" panose="020F0502020204030204" pitchFamily="34" charset="0"/>
               </a:rPr>
               <a:t>Données issues de Plus fraîche ma ville (ADEME)</a:t>
             </a:r>
             <a:endParaRPr lang="en-US" sz="1000">
-              <a:latin typeface="Calibri" panose="020F0502020204030204" pitchFamily="34" charset="0"/>
+              <a:latin typeface="Marianne" panose="02000000000000000000" pitchFamily="50" charset="0"/>
               <a:ea typeface="Calibri" panose="020F0502020204030204" pitchFamily="34" charset="0"/>
               <a:cs typeface="Calibri" panose="020F0502020204030204" pitchFamily="34" charset="0"/>
             </a:endParaRPr>
@@ -7434,7 +7446,9 @@
           <a:lstStyle/>
           <a:p>
             <a:pPr algn="ctr"/>
-            <a:endParaRPr lang="fr-FR"/>
+            <a:endParaRPr lang="fr-FR">
+              <a:latin typeface="Marianne" panose="02000000000000000000" pitchFamily="50" charset="0"/>
+            </a:endParaRPr>
           </a:p>
         </p:txBody>
       </p:sp>
@@ -7469,26 +7483,26 @@
             <a:r>
               <a:rPr lang="fr-FR" sz="1200" b="1" i="0" dirty="0">
                 <a:effectLst/>
-                <a:latin typeface="Aptos" panose="020B0004020202020204" pitchFamily="34" charset="0"/>
+                <a:latin typeface="Marianne" panose="02000000000000000000" pitchFamily="50" charset="0"/>
               </a:rPr>
               <a:t>{{</a:t>
             </a:r>
             <a:r>
               <a:rPr lang="fr-FR" sz="1200" b="1" i="0" dirty="0" err="1">
                 <a:effectLst/>
-                <a:latin typeface="Aptos" panose="020B0004020202020204" pitchFamily="34" charset="0"/>
+                <a:latin typeface="Marianne" panose="02000000000000000000" pitchFamily="50" charset="0"/>
               </a:rPr>
               <a:t>titre_materiau</a:t>
             </a:r>
             <a:r>
               <a:rPr lang="fr-FR" sz="1200" b="1" i="0" dirty="0">
                 <a:effectLst/>
-                <a:latin typeface="Aptos" panose="020B0004020202020204" pitchFamily="34" charset="0"/>
+                <a:latin typeface="Marianne" panose="02000000000000000000" pitchFamily="50" charset="0"/>
               </a:rPr>
               <a:t>}}</a:t>
             </a:r>
             <a:endParaRPr lang="fr-FR" sz="1200" b="1" dirty="0">
-              <a:latin typeface="Aptos" panose="020B0004020202020204" pitchFamily="34" charset="0"/>
+              <a:latin typeface="Marianne" panose="02000000000000000000" pitchFamily="50" charset="0"/>
             </a:endParaRPr>
           </a:p>
         </p:txBody>
@@ -7538,7 +7552,7 @@
         <p:spPr>
           <a:xfrm>
             <a:off x="7417711" y="1632102"/>
-            <a:ext cx="3603447" cy="461665"/>
+            <a:ext cx="3603447" cy="646331"/>
           </a:xfrm>
           <a:prstGeom prst="rect">
             <a:avLst/>
@@ -7559,7 +7573,7 @@
                 <a:solidFill>
                   <a:srgbClr val="2C2C2C"/>
                 </a:solidFill>
-                <a:latin typeface="Calibri" pitchFamily="34" charset="0"/>
+                <a:latin typeface="Marianne" panose="02000000000000000000" pitchFamily="50" charset="0"/>
                 <a:ea typeface="Calibri" pitchFamily="34" charset="-122"/>
                 <a:cs typeface="Calibri" pitchFamily="34" charset="-120"/>
               </a:rPr>
@@ -7570,7 +7584,7 @@
                 <a:solidFill>
                   <a:srgbClr val="2C2C2C"/>
                 </a:solidFill>
-                <a:latin typeface="Calibri" pitchFamily="34" charset="0"/>
+                <a:latin typeface="Marianne" panose="02000000000000000000" pitchFamily="50" charset="0"/>
                 <a:ea typeface="Calibri" pitchFamily="34" charset="-122"/>
                 <a:cs typeface="Calibri" pitchFamily="34" charset="-120"/>
               </a:rPr>
@@ -7581,7 +7595,7 @@
                 <a:solidFill>
                   <a:srgbClr val="2C2C2C"/>
                 </a:solidFill>
-                <a:latin typeface="Calibri" pitchFamily="34" charset="0"/>
+                <a:latin typeface="Marianne" panose="02000000000000000000" pitchFamily="50" charset="0"/>
                 <a:ea typeface="Calibri" pitchFamily="34" charset="-122"/>
                 <a:cs typeface="Calibri" pitchFamily="34" charset="-120"/>
               </a:rPr>
@@ -7592,7 +7606,7 @@
                 <a:solidFill>
                   <a:srgbClr val="2C2C2C"/>
                 </a:solidFill>
-                <a:latin typeface="Calibri" pitchFamily="34" charset="0"/>
+                <a:latin typeface="Marianne" panose="02000000000000000000" pitchFamily="50" charset="0"/>
                 <a:ea typeface="Calibri" pitchFamily="34" charset="-122"/>
                 <a:cs typeface="Calibri" pitchFamily="34" charset="-120"/>
               </a:rPr>
@@ -7608,7 +7622,7 @@
                 <a:solidFill>
                   <a:srgbClr val="2C2C2C"/>
                 </a:solidFill>
-                <a:latin typeface="Calibri" pitchFamily="34" charset="0"/>
+                <a:latin typeface="Marianne" panose="02000000000000000000" pitchFamily="50" charset="0"/>
                 <a:ea typeface="Calibri" pitchFamily="34" charset="-122"/>
                 <a:cs typeface="Calibri" pitchFamily="34" charset="-120"/>
               </a:rPr>
@@ -7619,7 +7633,7 @@
                 <a:solidFill>
                   <a:srgbClr val="2C2C2C"/>
                 </a:solidFill>
-                <a:latin typeface="Calibri" pitchFamily="34" charset="0"/>
+                <a:latin typeface="Marianne" panose="02000000000000000000" pitchFamily="50" charset="0"/>
                 <a:ea typeface="Calibri" pitchFamily="34" charset="-122"/>
                 <a:cs typeface="Calibri" pitchFamily="34" charset="-120"/>
               </a:rPr>
@@ -7630,13 +7644,15 @@
                 <a:solidFill>
                   <a:srgbClr val="2C2C2C"/>
                 </a:solidFill>
-                <a:latin typeface="Calibri" pitchFamily="34" charset="0"/>
+                <a:latin typeface="Marianne" panose="02000000000000000000" pitchFamily="50" charset="0"/>
                 <a:ea typeface="Calibri" pitchFamily="34" charset="-122"/>
                 <a:cs typeface="Calibri" pitchFamily="34" charset="-120"/>
               </a:rPr>
               <a:t>}}</a:t>
             </a:r>
-            <a:endParaRPr lang="en-US" sz="1200" dirty="0"/>
+            <a:endParaRPr lang="en-US" sz="1200" dirty="0">
+              <a:latin typeface="Marianne" panose="02000000000000000000" pitchFamily="50" charset="0"/>
+            </a:endParaRPr>
           </a:p>
         </p:txBody>
       </p:sp>
@@ -7665,7 +7681,7 @@
         </p:spPr>
         <p:txBody>
           <a:bodyPr vert="horz" lIns="91440" tIns="45720" rIns="91440" bIns="45720" rtlCol="0" anchor="ctr">
-            <a:normAutofit/>
+            <a:normAutofit fontScale="85000" lnSpcReduction="10000"/>
           </a:bodyPr>
           <a:lstStyle>
             <a:lvl1pPr algn="l" defTabSz="914400" rtl="0" eaLnBrk="1" latinLnBrk="0" hangingPunct="1">
@@ -7689,7 +7705,7 @@
           <a:p>
             <a:r>
               <a:rPr lang="en-US" sz="3200" dirty="0" err="1">
-                <a:latin typeface="Calibri" panose="020F0502020204030204" pitchFamily="34" charset="0"/>
+                <a:latin typeface="Marianne" panose="02000000000000000000" pitchFamily="50" charset="0"/>
                 <a:ea typeface="Calibri" panose="020F0502020204030204" pitchFamily="34" charset="0"/>
                 <a:cs typeface="Calibri" panose="020F0502020204030204" pitchFamily="34" charset="0"/>
               </a:rPr>
@@ -7697,7 +7713,7 @@
             </a:r>
             <a:r>
               <a:rPr lang="en-US" sz="3200" dirty="0">
-                <a:latin typeface="Calibri" panose="020F0502020204030204" pitchFamily="34" charset="0"/>
+                <a:latin typeface="Marianne" panose="02000000000000000000" pitchFamily="50" charset="0"/>
                 <a:ea typeface="Calibri" panose="020F0502020204030204" pitchFamily="34" charset="0"/>
                 <a:cs typeface="Calibri" panose="020F0502020204030204" pitchFamily="34" charset="0"/>
               </a:rPr>
@@ -7705,7 +7721,7 @@
             </a:r>
             <a:r>
               <a:rPr lang="en-US" sz="3200" dirty="0" err="1">
-                <a:latin typeface="Calibri" panose="020F0502020204030204" pitchFamily="34" charset="0"/>
+                <a:latin typeface="Marianne" panose="02000000000000000000" pitchFamily="50" charset="0"/>
                 <a:ea typeface="Calibri" panose="020F0502020204030204" pitchFamily="34" charset="0"/>
                 <a:cs typeface="Calibri" panose="020F0502020204030204" pitchFamily="34" charset="0"/>
               </a:rPr>
@@ -7713,7 +7729,7 @@
             </a:r>
             <a:r>
               <a:rPr lang="en-US" sz="3200" dirty="0">
-                <a:latin typeface="Calibri" panose="020F0502020204030204" pitchFamily="34" charset="0"/>
+                <a:latin typeface="Marianne" panose="02000000000000000000" pitchFamily="50" charset="0"/>
                 <a:ea typeface="Calibri" panose="020F0502020204030204" pitchFamily="34" charset="0"/>
                 <a:cs typeface="Calibri" panose="020F0502020204030204" pitchFamily="34" charset="0"/>
               </a:rPr>
@@ -7721,7 +7737,7 @@
             </a:r>
             <a:r>
               <a:rPr lang="en-US" sz="3200" dirty="0" err="1">
-                <a:latin typeface="Calibri" panose="020F0502020204030204" pitchFamily="34" charset="0"/>
+                <a:latin typeface="Marianne" panose="02000000000000000000" pitchFamily="50" charset="0"/>
                 <a:ea typeface="Calibri" panose="020F0502020204030204" pitchFamily="34" charset="0"/>
                 <a:cs typeface="Calibri" panose="020F0502020204030204" pitchFamily="34" charset="0"/>
               </a:rPr>
@@ -7729,14 +7745,14 @@
             </a:r>
             <a:r>
               <a:rPr lang="en-US" sz="3200" dirty="0">
-                <a:latin typeface="Calibri" panose="020F0502020204030204" pitchFamily="34" charset="0"/>
+                <a:latin typeface="Marianne" panose="02000000000000000000" pitchFamily="50" charset="0"/>
                 <a:ea typeface="Calibri" panose="020F0502020204030204" pitchFamily="34" charset="0"/>
                 <a:cs typeface="Calibri" panose="020F0502020204030204" pitchFamily="34" charset="0"/>
               </a:rPr>
               <a:t>}}</a:t>
             </a:r>
             <a:endParaRPr lang="fr-FR" sz="1200" dirty="0">
-              <a:latin typeface="Aptos" panose="020B0004020202020204" pitchFamily="34" charset="0"/>
+              <a:latin typeface="Marianne" panose="02000000000000000000" pitchFamily="50" charset="0"/>
             </a:endParaRPr>
           </a:p>
         </p:txBody>
@@ -7876,26 +7892,26 @@
             <a:r>
               <a:rPr lang="fr-FR" sz="1400" b="1" i="0" dirty="0">
                 <a:effectLst/>
-                <a:latin typeface="Aptos" panose="020B0004020202020204" pitchFamily="34" charset="0"/>
+                <a:latin typeface="Marianne" panose="02000000000000000000" pitchFamily="50" charset="0"/>
               </a:rPr>
               <a:t>{{</a:t>
             </a:r>
             <a:r>
               <a:rPr lang="fr-FR" sz="1400" b="1" i="0" dirty="0" err="1">
                 <a:effectLst/>
-                <a:latin typeface="Aptos" panose="020B0004020202020204" pitchFamily="34" charset="0"/>
+                <a:latin typeface="Marianne" panose="02000000000000000000" pitchFamily="50" charset="0"/>
               </a:rPr>
               <a:t>titre_fiche_solution</a:t>
             </a:r>
             <a:r>
               <a:rPr lang="fr-FR" sz="1400" b="1" i="0" dirty="0">
                 <a:effectLst/>
-                <a:latin typeface="Aptos" panose="020B0004020202020204" pitchFamily="34" charset="0"/>
+                <a:latin typeface="Marianne" panose="02000000000000000000" pitchFamily="50" charset="0"/>
               </a:rPr>
               <a:t>}}</a:t>
             </a:r>
             <a:endParaRPr lang="fr-FR" sz="1400" b="1" dirty="0">
-              <a:latin typeface="Aptos" panose="020B0004020202020204" pitchFamily="34" charset="0"/>
+              <a:latin typeface="Marianne" panose="02000000000000000000" pitchFamily="50" charset="0"/>
             </a:endParaRPr>
           </a:p>
         </p:txBody>
@@ -7936,7 +7952,7 @@
                 <a:solidFill>
                   <a:srgbClr val="2C2C2C"/>
                 </a:solidFill>
-                <a:latin typeface="Calibri" pitchFamily="34" charset="0"/>
+                <a:latin typeface="Marianne" panose="02000000000000000000" pitchFamily="50" charset="0"/>
                 <a:ea typeface="Calibri" pitchFamily="34" charset="-122"/>
                 <a:cs typeface="Calibri" pitchFamily="34" charset="-120"/>
               </a:rPr>
@@ -7947,7 +7963,7 @@
                 <a:solidFill>
                   <a:srgbClr val="2C2C2C"/>
                 </a:solidFill>
-                <a:latin typeface="Calibri" pitchFamily="34" charset="0"/>
+                <a:latin typeface="Marianne" panose="02000000000000000000" pitchFamily="50" charset="0"/>
                 <a:ea typeface="Calibri" pitchFamily="34" charset="-122"/>
                 <a:cs typeface="Calibri" pitchFamily="34" charset="-120"/>
               </a:rPr>
@@ -7966,7 +7982,7 @@
                     <a:lumOff val="25000"/>
                   </a:schemeClr>
                 </a:solidFill>
-                <a:latin typeface="Calibri" pitchFamily="34" charset="0"/>
+                <a:latin typeface="Marianne" panose="02000000000000000000" pitchFamily="50" charset="0"/>
                 <a:ea typeface="Calibri" pitchFamily="34" charset="-122"/>
                 <a:cs typeface="Calibri" pitchFamily="34" charset="-120"/>
               </a:rPr>
@@ -7979,6 +7995,7 @@
                   <a:lumOff val="25000"/>
                 </a:schemeClr>
               </a:solidFill>
+              <a:latin typeface="Marianne" panose="02000000000000000000" pitchFamily="50" charset="0"/>
             </a:endParaRPr>
           </a:p>
         </p:txBody>
@@ -8019,7 +8036,7 @@
                 <a:solidFill>
                   <a:srgbClr val="2C2C2C"/>
                 </a:solidFill>
-                <a:latin typeface="Calibri" pitchFamily="34" charset="0"/>
+                <a:latin typeface="Marianne" panose="02000000000000000000" pitchFamily="50" charset="0"/>
                 <a:ea typeface="Calibri" pitchFamily="34" charset="-122"/>
                 <a:cs typeface="Calibri" pitchFamily="34" charset="-120"/>
               </a:rPr>
@@ -8030,7 +8047,7 @@
                 <a:solidFill>
                   <a:srgbClr val="2C2C2C"/>
                 </a:solidFill>
-                <a:latin typeface="Calibri" pitchFamily="34" charset="0"/>
+                <a:latin typeface="Marianne" panose="02000000000000000000" pitchFamily="50" charset="0"/>
                 <a:ea typeface="Calibri" pitchFamily="34" charset="-122"/>
                 <a:cs typeface="Calibri" pitchFamily="34" charset="-120"/>
               </a:rPr>
@@ -8041,7 +8058,7 @@
                 <a:solidFill>
                   <a:srgbClr val="2C2C2C"/>
                 </a:solidFill>
-                <a:latin typeface="Calibri" pitchFamily="34" charset="0"/>
+                <a:latin typeface="Marianne" panose="02000000000000000000" pitchFamily="50" charset="0"/>
                 <a:ea typeface="Calibri" pitchFamily="34" charset="-122"/>
                 <a:cs typeface="Calibri" pitchFamily="34" charset="-120"/>
               </a:rPr>
@@ -8057,7 +8074,7 @@
                 <a:solidFill>
                   <a:srgbClr val="2C2C2C"/>
                 </a:solidFill>
-                <a:latin typeface="Calibri" pitchFamily="34" charset="0"/>
+                <a:latin typeface="Marianne" panose="02000000000000000000" pitchFamily="50" charset="0"/>
                 <a:ea typeface="Calibri" pitchFamily="34" charset="-122"/>
                 <a:cs typeface="Calibri" pitchFamily="34" charset="-120"/>
               </a:rPr>
@@ -8068,7 +8085,7 @@
                 <a:solidFill>
                   <a:srgbClr val="2C2C2C"/>
                 </a:solidFill>
-                <a:latin typeface="Calibri" pitchFamily="34" charset="0"/>
+                <a:latin typeface="Marianne" panose="02000000000000000000" pitchFamily="50" charset="0"/>
                 <a:ea typeface="Calibri" pitchFamily="34" charset="-122"/>
                 <a:cs typeface="Calibri" pitchFamily="34" charset="-120"/>
               </a:rPr>
@@ -8079,13 +8096,15 @@
                 <a:solidFill>
                   <a:srgbClr val="2C2C2C"/>
                 </a:solidFill>
-                <a:latin typeface="Calibri" pitchFamily="34" charset="0"/>
+                <a:latin typeface="Marianne" panose="02000000000000000000" pitchFamily="50" charset="0"/>
                 <a:ea typeface="Calibri" pitchFamily="34" charset="-122"/>
                 <a:cs typeface="Calibri" pitchFamily="34" charset="-120"/>
               </a:rPr>
               <a:t>}}</a:t>
             </a:r>
-            <a:endParaRPr lang="en-US" sz="1000" dirty="0"/>
+            <a:endParaRPr lang="en-US" sz="1000" dirty="0">
+              <a:latin typeface="Marianne" panose="02000000000000000000" pitchFamily="50" charset="0"/>
+            </a:endParaRPr>
           </a:p>
         </p:txBody>
       </p:sp>
@@ -8104,7 +8123,7 @@
         <p:spPr>
           <a:xfrm>
             <a:off x="1097292" y="3955732"/>
-            <a:ext cx="6059347" cy="523220"/>
+            <a:ext cx="6059347" cy="692497"/>
           </a:xfrm>
           <a:prstGeom prst="rect">
             <a:avLst/>
@@ -8120,7 +8139,7 @@
             <a:r>
               <a:rPr lang="fr-FR" sz="1400" b="1" i="0" dirty="0">
                 <a:effectLst/>
-                <a:latin typeface="Aptos" panose="020B0004020202020204" pitchFamily="34" charset="0"/>
+                <a:latin typeface="Marianne" panose="02000000000000000000" pitchFamily="50" charset="0"/>
               </a:rPr>
               <a:t>Estimation totale des solutions envisagées</a:t>
             </a:r>
@@ -8133,7 +8152,7 @@
                   <a:srgbClr val="666666"/>
                 </a:solidFill>
                 <a:effectLst/>
-                <a:latin typeface="Calibri" panose="020F0502020204030204" pitchFamily="34" charset="0"/>
+                <a:latin typeface="Marianne" panose="02000000000000000000" pitchFamily="50" charset="0"/>
                 <a:ea typeface="Calibri" panose="020F0502020204030204" pitchFamily="34" charset="0"/>
                 <a:cs typeface="Calibri" panose="020F0502020204030204" pitchFamily="34" charset="0"/>
               </a:rPr>
@@ -8141,7 +8160,7 @@
             </a:r>
             <a:r>
               <a:rPr lang="fr-FR" sz="1400" b="1" dirty="0">
-                <a:latin typeface="Aptos" panose="020B0004020202020204" pitchFamily="34" charset="0"/>
+                <a:latin typeface="Marianne" panose="02000000000000000000" pitchFamily="50" charset="0"/>
               </a:rPr>
               <a:t> </a:t>
             </a:r>
@@ -8184,7 +8203,7 @@
                 <a:solidFill>
                   <a:srgbClr val="2C2C2C"/>
                 </a:solidFill>
-                <a:latin typeface="Calibri" pitchFamily="34" charset="0"/>
+                <a:latin typeface="Marianne" panose="02000000000000000000" pitchFamily="50" charset="0"/>
                 <a:ea typeface="Calibri" pitchFamily="34" charset="-122"/>
                 <a:cs typeface="Calibri" pitchFamily="34" charset="-120"/>
               </a:rPr>
@@ -8195,7 +8214,7 @@
                 <a:solidFill>
                   <a:srgbClr val="2C2C2C"/>
                 </a:solidFill>
-                <a:latin typeface="Calibri" pitchFamily="34" charset="0"/>
+                <a:latin typeface="Marianne" panose="02000000000000000000" pitchFamily="50" charset="0"/>
                 <a:ea typeface="Calibri" pitchFamily="34" charset="-122"/>
                 <a:cs typeface="Calibri" pitchFamily="34" charset="-120"/>
               </a:rPr>
@@ -8205,7 +8224,7 @@
               <a:solidFill>
                 <a:srgbClr val="2C2C2C"/>
               </a:solidFill>
-              <a:latin typeface="Calibri" pitchFamily="34" charset="0"/>
+              <a:latin typeface="Marianne" panose="02000000000000000000" pitchFamily="50" charset="0"/>
               <a:ea typeface="Calibri" pitchFamily="34" charset="-122"/>
               <a:cs typeface="Calibri" pitchFamily="34" charset="-120"/>
             </a:endParaRPr>
@@ -8222,7 +8241,7 @@
                     <a:lumOff val="25000"/>
                   </a:schemeClr>
                 </a:solidFill>
-                <a:latin typeface="Calibri" pitchFamily="34" charset="0"/>
+                <a:latin typeface="Marianne" panose="02000000000000000000" pitchFamily="50" charset="0"/>
                 <a:ea typeface="Calibri" pitchFamily="34" charset="-122"/>
                 <a:cs typeface="Calibri" pitchFamily="34" charset="-120"/>
               </a:rPr>
@@ -8235,6 +8254,7 @@
                   <a:lumOff val="25000"/>
                 </a:schemeClr>
               </a:solidFill>
+              <a:latin typeface="Marianne" panose="02000000000000000000" pitchFamily="50" charset="0"/>
             </a:endParaRPr>
           </a:p>
         </p:txBody>
@@ -8272,7 +8292,7 @@
                 <a:solidFill>
                   <a:srgbClr val="2C2C2C"/>
                 </a:solidFill>
-                <a:latin typeface="Calibri" pitchFamily="34" charset="0"/>
+                <a:latin typeface="Marianne" panose="02000000000000000000" pitchFamily="50" charset="0"/>
                 <a:ea typeface="Calibri" pitchFamily="34" charset="-122"/>
                 <a:cs typeface="Calibri" pitchFamily="34" charset="-120"/>
               </a:rPr>
@@ -8283,7 +8303,7 @@
                 <a:solidFill>
                   <a:srgbClr val="2C2C2C"/>
                 </a:solidFill>
-                <a:latin typeface="Calibri" pitchFamily="34" charset="0"/>
+                <a:latin typeface="Marianne" panose="02000000000000000000" pitchFamily="50" charset="0"/>
                 <a:ea typeface="Calibri" pitchFamily="34" charset="-122"/>
                 <a:cs typeface="Calibri" pitchFamily="34" charset="-120"/>
               </a:rPr>
@@ -8294,7 +8314,7 @@
                 <a:solidFill>
                   <a:srgbClr val="2C2C2C"/>
                 </a:solidFill>
-                <a:latin typeface="Calibri" pitchFamily="34" charset="0"/>
+                <a:latin typeface="Marianne" panose="02000000000000000000" pitchFamily="50" charset="0"/>
                 <a:ea typeface="Calibri" pitchFamily="34" charset="-122"/>
                 <a:cs typeface="Calibri" pitchFamily="34" charset="-120"/>
               </a:rPr>
@@ -8304,7 +8324,7 @@
               <a:solidFill>
                 <a:srgbClr val="2C2C2C"/>
               </a:solidFill>
-              <a:latin typeface="Calibri" pitchFamily="34" charset="0"/>
+              <a:latin typeface="Marianne" panose="02000000000000000000" pitchFamily="50" charset="0"/>
               <a:ea typeface="Calibri" pitchFamily="34" charset="-122"/>
               <a:cs typeface="Calibri" pitchFamily="34" charset="-120"/>
             </a:endParaRPr>
@@ -8321,7 +8341,7 @@
                     <a:lumOff val="25000"/>
                   </a:schemeClr>
                 </a:solidFill>
-                <a:latin typeface="Calibri" pitchFamily="34" charset="0"/>
+                <a:latin typeface="Marianne" panose="02000000000000000000" pitchFamily="50" charset="0"/>
                 <a:ea typeface="Calibri" pitchFamily="34" charset="-122"/>
                 <a:cs typeface="Calibri" pitchFamily="34" charset="-120"/>
               </a:rPr>
@@ -8335,7 +8355,7 @@
                     <a:lumOff val="25000"/>
                   </a:schemeClr>
                 </a:solidFill>
-                <a:latin typeface="Calibri" pitchFamily="34" charset="0"/>
+                <a:latin typeface="Marianne" panose="02000000000000000000" pitchFamily="50" charset="0"/>
                 <a:ea typeface="Calibri" pitchFamily="34" charset="-122"/>
                 <a:cs typeface="Calibri" pitchFamily="34" charset="-120"/>
               </a:rPr>
@@ -8349,7 +8369,7 @@
                     <a:lumOff val="25000"/>
                   </a:schemeClr>
                 </a:solidFill>
-                <a:latin typeface="Calibri" pitchFamily="34" charset="0"/>
+                <a:latin typeface="Marianne" panose="02000000000000000000" pitchFamily="50" charset="0"/>
                 <a:ea typeface="Calibri" pitchFamily="34" charset="-122"/>
                 <a:cs typeface="Calibri" pitchFamily="34" charset="-120"/>
               </a:rPr>
@@ -8362,6 +8382,7 @@
                   <a:lumOff val="25000"/>
                 </a:schemeClr>
               </a:solidFill>
+              <a:latin typeface="Marianne" panose="02000000000000000000" pitchFamily="50" charset="0"/>
             </a:endParaRPr>
           </a:p>
         </p:txBody>
@@ -8397,26 +8418,26 @@
             <a:r>
               <a:rPr lang="fr-FR" sz="1000" i="0" dirty="0">
                 <a:effectLst/>
-                <a:latin typeface="Aptos" panose="020B0004020202020204" pitchFamily="34" charset="0"/>
+                <a:latin typeface="Marianne" panose="02000000000000000000" pitchFamily="50" charset="0"/>
               </a:rPr>
               <a:t>{{</a:t>
             </a:r>
             <a:r>
               <a:rPr lang="fr-FR" sz="1000" i="0" dirty="0" err="1">
                 <a:effectLst/>
-                <a:latin typeface="Aptos" panose="020B0004020202020204" pitchFamily="34" charset="0"/>
+                <a:latin typeface="Marianne" panose="02000000000000000000" pitchFamily="50" charset="0"/>
               </a:rPr>
               <a:t>quantite_materiau</a:t>
             </a:r>
             <a:r>
               <a:rPr lang="fr-FR" sz="1000" i="0" dirty="0">
                 <a:effectLst/>
-                <a:latin typeface="Aptos" panose="020B0004020202020204" pitchFamily="34" charset="0"/>
+                <a:latin typeface="Marianne" panose="02000000000000000000" pitchFamily="50" charset="0"/>
               </a:rPr>
               <a:t>}}</a:t>
             </a:r>
             <a:endParaRPr lang="fr-FR" sz="1000" dirty="0">
-              <a:latin typeface="Aptos" panose="020B0004020202020204" pitchFamily="34" charset="0"/>
+              <a:latin typeface="Marianne" panose="02000000000000000000" pitchFamily="50" charset="0"/>
             </a:endParaRPr>
           </a:p>
         </p:txBody>
@@ -8501,14 +8522,14 @@
                 <a:solidFill>
                   <a:srgbClr val="A0A0A0"/>
                 </a:solidFill>
-                <a:latin typeface="Calibri" panose="020F0502020204030204" pitchFamily="34" charset="0"/>
+                <a:latin typeface="Marianne" panose="02000000000000000000" pitchFamily="50" charset="0"/>
                 <a:ea typeface="Calibri" panose="020F0502020204030204" pitchFamily="34" charset="0"/>
                 <a:cs typeface="Calibri" panose="020F0502020204030204" pitchFamily="34" charset="0"/>
               </a:rPr>
               <a:t>Données issues de Plus fraîche ma ville (ADEME)</a:t>
             </a:r>
             <a:endParaRPr lang="en-US" sz="1000">
-              <a:latin typeface="Calibri" panose="020F0502020204030204" pitchFamily="34" charset="0"/>
+              <a:latin typeface="Marianne" panose="02000000000000000000" pitchFamily="50" charset="0"/>
               <a:ea typeface="Calibri" panose="020F0502020204030204" pitchFamily="34" charset="0"/>
               <a:cs typeface="Calibri" panose="020F0502020204030204" pitchFamily="34" charset="0"/>
             </a:endParaRPr>
@@ -8579,7 +8600,7 @@
           <a:lstStyle/>
           <a:p>
             <a:endParaRPr lang="en-US" sz="13333" dirty="0">
-              <a:latin typeface="Calibri" panose="020F0502020204030204" pitchFamily="34" charset="0"/>
+              <a:latin typeface="Marianne" panose="02000000000000000000" pitchFamily="50" charset="0"/>
               <a:ea typeface="Calibri" panose="020F0502020204030204" pitchFamily="34" charset="0"/>
               <a:cs typeface="Calibri" panose="020F0502020204030204" pitchFamily="34" charset="0"/>
             </a:endParaRPr>
@@ -8618,7 +8639,7 @@
                 <a:solidFill>
                   <a:srgbClr val="1A1A1A"/>
                 </a:solidFill>
-                <a:latin typeface="Aptos" panose="020B0004020202020204" pitchFamily="34" charset="0"/>
+                <a:latin typeface="Marianne" panose="02000000000000000000" pitchFamily="50" charset="0"/>
                 <a:ea typeface="Calibri" pitchFamily="34" charset="-122"/>
                 <a:cs typeface="Calibri" pitchFamily="34" charset="-120"/>
               </a:rPr>
@@ -8629,7 +8650,7 @@
                 <a:solidFill>
                   <a:srgbClr val="1A1A1A"/>
                 </a:solidFill>
-                <a:latin typeface="Aptos" panose="020B0004020202020204" pitchFamily="34" charset="0"/>
+                <a:latin typeface="Marianne" panose="02000000000000000000" pitchFamily="50" charset="0"/>
                 <a:ea typeface="Calibri" pitchFamily="34" charset="-122"/>
                 <a:cs typeface="Calibri" pitchFamily="34" charset="-120"/>
               </a:rPr>
@@ -8640,14 +8661,14 @@
                 <a:solidFill>
                   <a:srgbClr val="1A1A1A"/>
                 </a:solidFill>
-                <a:latin typeface="Aptos" panose="020B0004020202020204" pitchFamily="34" charset="0"/>
+                <a:latin typeface="Marianne" panose="02000000000000000000" pitchFamily="50" charset="0"/>
                 <a:ea typeface="Calibri" pitchFamily="34" charset="-122"/>
                 <a:cs typeface="Calibri" pitchFamily="34" charset="-120"/>
               </a:rPr>
               <a:t>utiles</a:t>
             </a:r>
             <a:endParaRPr lang="en-US" sz="3733" dirty="0">
-              <a:latin typeface="Aptos" panose="020B0004020202020204" pitchFamily="34" charset="0"/>
+              <a:latin typeface="Marianne" panose="02000000000000000000" pitchFamily="50" charset="0"/>
             </a:endParaRPr>
           </a:p>
         </p:txBody>
@@ -8687,7 +8708,7 @@
           <a:lstStyle/>
           <a:p>
             <a:endParaRPr lang="fr-FR" sz="2400">
-              <a:latin typeface="Calibri" panose="020F0502020204030204" pitchFamily="34" charset="0"/>
+              <a:latin typeface="Marianne" panose="02000000000000000000" pitchFamily="50" charset="0"/>
               <a:ea typeface="Calibri" panose="020F0502020204030204" pitchFamily="34" charset="0"/>
               <a:cs typeface="Calibri" panose="020F0502020204030204" pitchFamily="34" charset="0"/>
             </a:endParaRPr>
@@ -8729,7 +8750,7 @@
                 <a:solidFill>
                   <a:srgbClr val="5C5C5C"/>
                 </a:solidFill>
-                <a:latin typeface="Calibri" pitchFamily="34" charset="0"/>
+                <a:latin typeface="Marianne" panose="02000000000000000000" pitchFamily="50" charset="0"/>
                 <a:ea typeface="Calibri" pitchFamily="34" charset="-122"/>
                 <a:cs typeface="Calibri" pitchFamily="34" charset="-120"/>
               </a:rPr>
@@ -8740,13 +8761,15 @@
                 <a:solidFill>
                   <a:srgbClr val="5C5C5C"/>
                 </a:solidFill>
-                <a:latin typeface="Calibri" pitchFamily="34" charset="0"/>
+                <a:latin typeface="Marianne" panose="02000000000000000000" pitchFamily="50" charset="0"/>
                 <a:ea typeface="Calibri" pitchFamily="34" charset="-122"/>
                 <a:cs typeface="Calibri" pitchFamily="34" charset="-120"/>
               </a:rPr>
               <a:t>complémentaire</a:t>
             </a:r>
-            <a:endParaRPr lang="en-US" sz="1600" dirty="0"/>
+            <a:endParaRPr lang="en-US" sz="1600" dirty="0">
+              <a:latin typeface="Marianne" panose="02000000000000000000" pitchFamily="50" charset="0"/>
+            </a:endParaRPr>
           </a:p>
         </p:txBody>
       </p:sp>
@@ -8830,14 +8853,14 @@
                 <a:solidFill>
                   <a:srgbClr val="A0A0A0"/>
                 </a:solidFill>
-                <a:latin typeface="Calibri" panose="020F0502020204030204" pitchFamily="34" charset="0"/>
+                <a:latin typeface="Marianne" panose="02000000000000000000" pitchFamily="50" charset="0"/>
                 <a:ea typeface="Calibri" panose="020F0502020204030204" pitchFamily="34" charset="0"/>
                 <a:cs typeface="Calibri" panose="020F0502020204030204" pitchFamily="34" charset="0"/>
               </a:rPr>
               <a:t>Données issues de Plus fraîche ma ville (ADEME)</a:t>
             </a:r>
             <a:endParaRPr lang="en-US" sz="1000">
-              <a:latin typeface="Calibri" panose="020F0502020204030204" pitchFamily="34" charset="0"/>
+              <a:latin typeface="Marianne" panose="02000000000000000000" pitchFamily="50" charset="0"/>
               <a:ea typeface="Calibri" panose="020F0502020204030204" pitchFamily="34" charset="0"/>
               <a:cs typeface="Calibri" panose="020F0502020204030204" pitchFamily="34" charset="0"/>
             </a:endParaRPr>
@@ -8971,20 +8994,26 @@
               <a:buNone/>
             </a:pPr>
             <a:r>
-              <a:rPr lang="en-US" sz="3200" dirty="0" err="1"/>
+              <a:rPr lang="en-US" sz="3200" dirty="0" err="1">
+                <a:latin typeface="Marianne" panose="02000000000000000000" pitchFamily="50" charset="0"/>
+              </a:rPr>
               <a:t>Ressources</a:t>
             </a:r>
             <a:r>
-              <a:rPr lang="en-US" sz="3200" dirty="0"/>
+              <a:rPr lang="en-US" sz="3200" dirty="0">
+                <a:latin typeface="Marianne" panose="02000000000000000000" pitchFamily="50" charset="0"/>
+              </a:rPr>
               <a:t> </a:t>
             </a:r>
             <a:r>
-              <a:rPr lang="en-US" sz="3200" dirty="0" err="1"/>
+              <a:rPr lang="en-US" sz="3200" dirty="0" err="1">
+                <a:latin typeface="Marianne" panose="02000000000000000000" pitchFamily="50" charset="0"/>
+              </a:rPr>
               <a:t>utiles</a:t>
             </a:r>
             <a:r>
               <a:rPr lang="en-US" sz="3200" dirty="0">
-                <a:latin typeface="Calibri" panose="020F0502020204030204" pitchFamily="34" charset="0"/>
+                <a:latin typeface="Marianne" panose="02000000000000000000" pitchFamily="50" charset="0"/>
                 <a:ea typeface="Calibri" panose="020F0502020204030204" pitchFamily="34" charset="0"/>
                 <a:cs typeface="Calibri" panose="020F0502020204030204" pitchFamily="34" charset="0"/>
               </a:rPr>
@@ -8992,7 +9021,7 @@
             </a:r>
             <a:r>
               <a:rPr lang="en-US" sz="3200" dirty="0" err="1">
-                <a:latin typeface="Calibri" panose="020F0502020204030204" pitchFamily="34" charset="0"/>
+                <a:latin typeface="Marianne" panose="02000000000000000000" pitchFamily="50" charset="0"/>
                 <a:ea typeface="Calibri" panose="020F0502020204030204" pitchFamily="34" charset="0"/>
                 <a:cs typeface="Calibri" panose="020F0502020204030204" pitchFamily="34" charset="0"/>
               </a:rPr>
@@ -9000,7 +9029,7 @@
             </a:r>
             <a:r>
               <a:rPr lang="en-US" sz="3200" dirty="0">
-                <a:latin typeface="Calibri" panose="020F0502020204030204" pitchFamily="34" charset="0"/>
+                <a:latin typeface="Marianne" panose="02000000000000000000" pitchFamily="50" charset="0"/>
                 <a:ea typeface="Calibri" panose="020F0502020204030204" pitchFamily="34" charset="0"/>
                 <a:cs typeface="Calibri" panose="020F0502020204030204" pitchFamily="34" charset="0"/>
               </a:rPr>
@@ -9042,7 +9071,7 @@
                 <a:solidFill>
                   <a:srgbClr val="161616"/>
                 </a:solidFill>
-                <a:latin typeface="Calibri" panose="020F0502020204030204" pitchFamily="34" charset="0"/>
+                <a:latin typeface="Marianne" panose="02000000000000000000" pitchFamily="50" charset="0"/>
                 <a:ea typeface="Calibri" panose="020F0502020204030204" pitchFamily="34" charset="0"/>
                 <a:cs typeface="Calibri" panose="020F0502020204030204" pitchFamily="34" charset="0"/>
               </a:rPr>
@@ -9053,7 +9082,7 @@
                 <a:solidFill>
                   <a:srgbClr val="161616"/>
                 </a:solidFill>
-                <a:latin typeface="Calibri" panose="020F0502020204030204" pitchFamily="34" charset="0"/>
+                <a:latin typeface="Marianne" panose="02000000000000000000" pitchFamily="50" charset="0"/>
                 <a:ea typeface="Calibri" panose="020F0502020204030204" pitchFamily="34" charset="0"/>
                 <a:cs typeface="Calibri" panose="020F0502020204030204" pitchFamily="34" charset="0"/>
               </a:rPr>
@@ -9064,14 +9093,14 @@
                 <a:solidFill>
                   <a:srgbClr val="161616"/>
                 </a:solidFill>
-                <a:latin typeface="Calibri" panose="020F0502020204030204" pitchFamily="34" charset="0"/>
+                <a:latin typeface="Marianne" panose="02000000000000000000" pitchFamily="50" charset="0"/>
                 <a:ea typeface="Calibri" panose="020F0502020204030204" pitchFamily="34" charset="0"/>
                 <a:cs typeface="Calibri" panose="020F0502020204030204" pitchFamily="34" charset="0"/>
               </a:rPr>
               <a:t>}}</a:t>
             </a:r>
             <a:endParaRPr lang="fr-FR" sz="2000" dirty="0">
-              <a:latin typeface="Calibri" panose="020F0502020204030204" pitchFamily="34" charset="0"/>
+              <a:latin typeface="Marianne" panose="02000000000000000000" pitchFamily="50" charset="0"/>
               <a:ea typeface="Calibri" panose="020F0502020204030204" pitchFamily="34" charset="0"/>
               <a:cs typeface="Calibri" panose="020F0502020204030204" pitchFamily="34" charset="0"/>
             </a:endParaRPr>
@@ -9203,7 +9232,7 @@
                 <a:solidFill>
                   <a:srgbClr val="A0A0A0"/>
                 </a:solidFill>
-                <a:latin typeface="Calibri" panose="020F0502020204030204" pitchFamily="34" charset="0"/>
+                <a:latin typeface="Marianne" panose="02000000000000000000" pitchFamily="50" charset="0"/>
                 <a:ea typeface="Calibri" panose="020F0502020204030204" pitchFamily="34" charset="0"/>
                 <a:cs typeface="Calibri" panose="020F0502020204030204" pitchFamily="34" charset="0"/>
               </a:rPr>
@@ -9214,7 +9243,7 @@
                 <a:solidFill>
                   <a:srgbClr val="A0A0A0"/>
                 </a:solidFill>
-                <a:latin typeface="Calibri" panose="020F0502020204030204" pitchFamily="34" charset="0"/>
+                <a:latin typeface="Marianne" panose="02000000000000000000" pitchFamily="50" charset="0"/>
                 <a:ea typeface="Calibri" panose="020F0502020204030204" pitchFamily="34" charset="0"/>
                 <a:cs typeface="Calibri" panose="020F0502020204030204" pitchFamily="34" charset="0"/>
               </a:rPr>
@@ -9225,7 +9254,7 @@
                 <a:solidFill>
                   <a:srgbClr val="A0A0A0"/>
                 </a:solidFill>
-                <a:latin typeface="Calibri" panose="020F0502020204030204" pitchFamily="34" charset="0"/>
+                <a:latin typeface="Marianne" panose="02000000000000000000" pitchFamily="50" charset="0"/>
                 <a:ea typeface="Calibri" panose="020F0502020204030204" pitchFamily="34" charset="0"/>
                 <a:cs typeface="Calibri" panose="020F0502020204030204" pitchFamily="34" charset="0"/>
               </a:rPr>
@@ -9236,7 +9265,7 @@
                 <a:solidFill>
                   <a:srgbClr val="A0A0A0"/>
                 </a:solidFill>
-                <a:latin typeface="Calibri" panose="020F0502020204030204" pitchFamily="34" charset="0"/>
+                <a:latin typeface="Marianne" panose="02000000000000000000" pitchFamily="50" charset="0"/>
                 <a:ea typeface="Calibri" panose="020F0502020204030204" pitchFamily="34" charset="0"/>
                 <a:cs typeface="Calibri" panose="020F0502020204030204" pitchFamily="34" charset="0"/>
               </a:rPr>
@@ -9247,14 +9276,14 @@
                 <a:solidFill>
                   <a:srgbClr val="A0A0A0"/>
                 </a:solidFill>
-                <a:latin typeface="Calibri" panose="020F0502020204030204" pitchFamily="34" charset="0"/>
+                <a:latin typeface="Marianne" panose="02000000000000000000" pitchFamily="50" charset="0"/>
                 <a:ea typeface="Calibri" panose="020F0502020204030204" pitchFamily="34" charset="0"/>
                 <a:cs typeface="Calibri" panose="020F0502020204030204" pitchFamily="34" charset="0"/>
               </a:rPr>
               <a:t> (ADEME)</a:t>
             </a:r>
             <a:endParaRPr lang="en-US" sz="1000" dirty="0">
-              <a:latin typeface="Calibri" panose="020F0502020204030204" pitchFamily="34" charset="0"/>
+              <a:latin typeface="Marianne" panose="02000000000000000000" pitchFamily="50" charset="0"/>
               <a:ea typeface="Calibri" panose="020F0502020204030204" pitchFamily="34" charset="0"/>
               <a:cs typeface="Calibri" panose="020F0502020204030204" pitchFamily="34" charset="0"/>
             </a:endParaRPr>
@@ -9353,7 +9382,7 @@
                 <a:solidFill>
                   <a:srgbClr val="161616"/>
                 </a:solidFill>
-                <a:latin typeface="Calibri" panose="020F0502020204030204" pitchFamily="34" charset="0"/>
+                <a:latin typeface="Marianne" panose="02000000000000000000" pitchFamily="50" charset="0"/>
                 <a:ea typeface="Calibri" panose="020F0502020204030204" pitchFamily="34" charset="0"/>
                 <a:cs typeface="Calibri" panose="020F0502020204030204" pitchFamily="34" charset="0"/>
               </a:rPr>
@@ -9364,7 +9393,7 @@
                 <a:solidFill>
                   <a:srgbClr val="161616"/>
                 </a:solidFill>
-                <a:latin typeface="Calibri" panose="020F0502020204030204" pitchFamily="34" charset="0"/>
+                <a:latin typeface="Marianne" panose="02000000000000000000" pitchFamily="50" charset="0"/>
                 <a:ea typeface="Calibri" panose="020F0502020204030204" pitchFamily="34" charset="0"/>
                 <a:cs typeface="Calibri" panose="020F0502020204030204" pitchFamily="34" charset="0"/>
               </a:rPr>
@@ -9375,14 +9404,14 @@
                 <a:solidFill>
                   <a:srgbClr val="161616"/>
                 </a:solidFill>
-                <a:latin typeface="Calibri" panose="020F0502020204030204" pitchFamily="34" charset="0"/>
+                <a:latin typeface="Marianne" panose="02000000000000000000" pitchFamily="50" charset="0"/>
                 <a:ea typeface="Calibri" panose="020F0502020204030204" pitchFamily="34" charset="0"/>
                 <a:cs typeface="Calibri" panose="020F0502020204030204" pitchFamily="34" charset="0"/>
               </a:rPr>
               <a:t>}}</a:t>
             </a:r>
             <a:endParaRPr lang="fr-FR" sz="1200" dirty="0">
-              <a:latin typeface="Calibri" panose="020F0502020204030204" pitchFamily="34" charset="0"/>
+              <a:latin typeface="Marianne" panose="02000000000000000000" pitchFamily="50" charset="0"/>
               <a:ea typeface="Calibri" panose="020F0502020204030204" pitchFamily="34" charset="0"/>
               <a:cs typeface="Calibri" panose="020F0502020204030204" pitchFamily="34" charset="0"/>
             </a:endParaRPr>

</xml_diff>

<commit_message>
feat: un peu de mise en page et couleur de baisse de température
</commit_message>
<xml_diff>
--- a/public/templates/template_synthese_projet.pptx
+++ b/public/templates/template_synthese_projet.pptx
@@ -4892,7 +4892,7 @@
               <a:buNone/>
             </a:pPr>
             <a:r>
-              <a:rPr lang="en-US" sz="3200" dirty="0">
+              <a:rPr lang="en-US" sz="2800" dirty="0">
                 <a:latin typeface="Marianne" panose="02000000000000000000" pitchFamily="50" charset="0"/>
                 <a:ea typeface="Calibri" panose="020F0502020204030204" pitchFamily="34" charset="0"/>
                 <a:cs typeface="Calibri" panose="020F0502020204030204" pitchFamily="34" charset="0"/>
@@ -4900,7 +4900,7 @@
               <a:t>Solution {{</a:t>
             </a:r>
             <a:r>
-              <a:rPr lang="en-US" sz="3200" dirty="0" err="1">
+              <a:rPr lang="en-US" sz="2800" dirty="0" err="1">
                 <a:latin typeface="Marianne" panose="02000000000000000000" pitchFamily="50" charset="0"/>
                 <a:ea typeface="Calibri" panose="020F0502020204030204" pitchFamily="34" charset="0"/>
                 <a:cs typeface="Calibri" panose="020F0502020204030204" pitchFamily="34" charset="0"/>
@@ -4908,7 +4908,7 @@
               <a:t>n°_solution</a:t>
             </a:r>
             <a:r>
-              <a:rPr lang="en-US" sz="3200" dirty="0">
+              <a:rPr lang="en-US" sz="2800" dirty="0">
                 <a:latin typeface="Marianne" panose="02000000000000000000" pitchFamily="50" charset="0"/>
                 <a:ea typeface="Calibri" panose="020F0502020204030204" pitchFamily="34" charset="0"/>
                 <a:cs typeface="Calibri" panose="020F0502020204030204" pitchFamily="34" charset="0"/>
@@ -4916,7 +4916,7 @@
               <a:t>}} : {{</a:t>
             </a:r>
             <a:r>
-              <a:rPr lang="en-US" sz="3200" dirty="0" err="1">
+              <a:rPr lang="en-US" sz="2800" dirty="0" err="1">
                 <a:latin typeface="Marianne" panose="02000000000000000000" pitchFamily="50" charset="0"/>
                 <a:ea typeface="Calibri" panose="020F0502020204030204" pitchFamily="34" charset="0"/>
                 <a:cs typeface="Calibri" panose="020F0502020204030204" pitchFamily="34" charset="0"/>
@@ -4924,7 +4924,7 @@
               <a:t>titre_fiche_solution</a:t>
             </a:r>
             <a:r>
-              <a:rPr lang="en-US" sz="3200" dirty="0">
+              <a:rPr lang="en-US" sz="2800" dirty="0">
                 <a:latin typeface="Marianne" panose="02000000000000000000" pitchFamily="50" charset="0"/>
                 <a:ea typeface="Calibri" panose="020F0502020204030204" pitchFamily="34" charset="0"/>
                 <a:cs typeface="Calibri" panose="020F0502020204030204" pitchFamily="34" charset="0"/>
@@ -5485,7 +5485,7 @@
         </p:nvSpPr>
         <p:spPr>
           <a:xfrm>
-            <a:off x="2860182" y="2347002"/>
+            <a:off x="2925782" y="2347002"/>
             <a:ext cx="1861606" cy="2554545"/>
           </a:xfrm>
           <a:prstGeom prst="rect">
@@ -5502,7 +5502,7 @@
             <a:r>
               <a:rPr lang="fr-FR" sz="4000" b="1" dirty="0">
                 <a:solidFill>
-                  <a:srgbClr val="002060"/>
+                  <a:srgbClr val="000091"/>
                 </a:solidFill>
                 <a:latin typeface="Marianne" panose="02000000000000000000" pitchFamily="50" charset="0"/>
                 <a:ea typeface="Calibri" panose="020F0502020204030204" pitchFamily="34" charset="0"/>
@@ -5513,7 +5513,7 @@
             <a:r>
               <a:rPr lang="fr-FR" sz="4000" b="1" dirty="0" err="1">
                 <a:solidFill>
-                  <a:srgbClr val="002060"/>
+                  <a:srgbClr val="000091"/>
                 </a:solidFill>
                 <a:latin typeface="Marianne" panose="02000000000000000000" pitchFamily="50" charset="0"/>
                 <a:ea typeface="Calibri" panose="020F0502020204030204" pitchFamily="34" charset="0"/>
@@ -5524,7 +5524,7 @@
             <a:r>
               <a:rPr lang="fr-FR" sz="4000" b="1" dirty="0">
                 <a:solidFill>
-                  <a:srgbClr val="002060"/>
+                  <a:srgbClr val="000091"/>
                 </a:solidFill>
                 <a:latin typeface="Marianne" panose="02000000000000000000" pitchFamily="50" charset="0"/>
                 <a:ea typeface="Calibri" panose="020F0502020204030204" pitchFamily="34" charset="0"/>
@@ -5810,7 +5810,7 @@
         </p:nvSpPr>
         <p:spPr>
           <a:xfrm>
-            <a:off x="8085069" y="3225817"/>
+            <a:off x="8085069" y="3234017"/>
             <a:ext cx="3963324" cy="338554"/>
           </a:xfrm>
           <a:prstGeom prst="rect">
@@ -5855,7 +5855,7 @@
         </p:nvSpPr>
         <p:spPr>
           <a:xfrm>
-            <a:off x="8082875" y="3804872"/>
+            <a:off x="8082875" y="3813072"/>
             <a:ext cx="3963324" cy="338554"/>
           </a:xfrm>
           <a:prstGeom prst="rect">
@@ -5900,7 +5900,7 @@
         </p:nvSpPr>
         <p:spPr>
           <a:xfrm>
-            <a:off x="8090359" y="4383927"/>
+            <a:off x="8090359" y="4392127"/>
             <a:ext cx="3963324" cy="338554"/>
           </a:xfrm>
           <a:prstGeom prst="rect">
@@ -5945,7 +5945,7 @@
         </p:nvSpPr>
         <p:spPr>
           <a:xfrm>
-            <a:off x="8082875" y="4977224"/>
+            <a:off x="8082875" y="4985424"/>
             <a:ext cx="3963324" cy="338554"/>
           </a:xfrm>
           <a:prstGeom prst="rect">
@@ -5990,8 +5990,8 @@
         </p:nvSpPr>
         <p:spPr>
           <a:xfrm>
-            <a:off x="762151" y="2395650"/>
-            <a:ext cx="1994034" cy="830997"/>
+            <a:off x="762150" y="2395650"/>
+            <a:ext cx="2170793" cy="553998"/>
           </a:xfrm>
           <a:prstGeom prst="rect">
             <a:avLst/>
@@ -6005,7 +6005,7 @@
           <a:lstStyle/>
           <a:p>
             <a:r>
-              <a:rPr lang="fr-FR" sz="1600" dirty="0">
+              <a:rPr lang="fr-FR" sz="1500" dirty="0">
                 <a:solidFill>
                   <a:schemeClr val="tx1">
                     <a:lumMod val="65000"/>
@@ -6019,7 +6019,7 @@
               <a:t>{{</a:t>
             </a:r>
             <a:r>
-              <a:rPr lang="fr-FR" sz="1600" dirty="0" err="1">
+              <a:rPr lang="fr-FR" sz="1500" dirty="0" err="1">
                 <a:solidFill>
                   <a:schemeClr val="tx1">
                     <a:lumMod val="65000"/>
@@ -6033,7 +6033,7 @@
               <a:t>portee_baisse_temperature</a:t>
             </a:r>
             <a:r>
-              <a:rPr lang="fr-FR" sz="1600" dirty="0">
+              <a:rPr lang="fr-FR" sz="1500" dirty="0">
                 <a:solidFill>
                   <a:schemeClr val="tx1">
                     <a:lumMod val="65000"/>
@@ -6046,30 +6046,6 @@
               </a:rPr>
               <a:t>}}</a:t>
             </a:r>
-            <a:endParaRPr lang="fr-FR" sz="1500" dirty="0">
-              <a:solidFill>
-                <a:schemeClr val="tx1">
-                  <a:lumMod val="65000"/>
-                  <a:lumOff val="35000"/>
-                </a:schemeClr>
-              </a:solidFill>
-              <a:latin typeface="Marianne" panose="02000000000000000000" pitchFamily="50" charset="0"/>
-              <a:ea typeface="Calibri" panose="020F0502020204030204" pitchFamily="34" charset="0"/>
-              <a:cs typeface="Calibri" panose="020F0502020204030204" pitchFamily="34" charset="0"/>
-            </a:endParaRPr>
-          </a:p>
-          <a:p>
-            <a:endParaRPr lang="fr-FR" sz="1600" dirty="0">
-              <a:solidFill>
-                <a:schemeClr val="tx1">
-                  <a:lumMod val="65000"/>
-                  <a:lumOff val="35000"/>
-                </a:schemeClr>
-              </a:solidFill>
-              <a:latin typeface="Marianne" panose="02000000000000000000" pitchFamily="50" charset="0"/>
-              <a:ea typeface="Calibri" panose="020F0502020204030204" pitchFamily="34" charset="0"/>
-              <a:cs typeface="Calibri" panose="020F0502020204030204" pitchFamily="34" charset="0"/>
-            </a:endParaRPr>
           </a:p>
         </p:txBody>
       </p:sp>
@@ -6778,7 +6754,7 @@
           </a:lstStyle>
           <a:p>
             <a:r>
-              <a:rPr lang="en-US" sz="3200" dirty="0">
+              <a:rPr lang="en-US" sz="2800" dirty="0">
                 <a:latin typeface="Marianne" panose="02000000000000000000" pitchFamily="50" charset="0"/>
                 <a:ea typeface="Calibri" panose="020F0502020204030204" pitchFamily="34" charset="0"/>
                 <a:cs typeface="Calibri" panose="020F0502020204030204" pitchFamily="34" charset="0"/>
@@ -6786,7 +6762,7 @@
               <a:t>Solution {{</a:t>
             </a:r>
             <a:r>
-              <a:rPr lang="en-US" sz="3200" dirty="0" err="1">
+              <a:rPr lang="en-US" sz="2800" dirty="0" err="1">
                 <a:latin typeface="Marianne" panose="02000000000000000000" pitchFamily="50" charset="0"/>
                 <a:ea typeface="Calibri" panose="020F0502020204030204" pitchFamily="34" charset="0"/>
                 <a:cs typeface="Calibri" panose="020F0502020204030204" pitchFamily="34" charset="0"/>
@@ -6794,7 +6770,7 @@
               <a:t>n°_solution</a:t>
             </a:r>
             <a:r>
-              <a:rPr lang="en-US" sz="3200" dirty="0">
+              <a:rPr lang="en-US" sz="2800" dirty="0">
                 <a:latin typeface="Marianne" panose="02000000000000000000" pitchFamily="50" charset="0"/>
                 <a:ea typeface="Calibri" panose="020F0502020204030204" pitchFamily="34" charset="0"/>
                 <a:cs typeface="Calibri" panose="020F0502020204030204" pitchFamily="34" charset="0"/>
@@ -6802,7 +6778,7 @@
               <a:t>}} : {{</a:t>
             </a:r>
             <a:r>
-              <a:rPr lang="en-US" sz="3200" dirty="0" err="1">
+              <a:rPr lang="en-US" sz="2800" dirty="0" err="1">
                 <a:latin typeface="Marianne" panose="02000000000000000000" pitchFamily="50" charset="0"/>
                 <a:ea typeface="Calibri" panose="020F0502020204030204" pitchFamily="34" charset="0"/>
                 <a:cs typeface="Calibri" panose="020F0502020204030204" pitchFamily="34" charset="0"/>
@@ -6810,14 +6786,14 @@
               <a:t>titre_fiche_solution</a:t>
             </a:r>
             <a:r>
-              <a:rPr lang="en-US" sz="3200" dirty="0">
+              <a:rPr lang="en-US" sz="2800" dirty="0">
                 <a:latin typeface="Marianne" panose="02000000000000000000" pitchFamily="50" charset="0"/>
                 <a:ea typeface="Calibri" panose="020F0502020204030204" pitchFamily="34" charset="0"/>
                 <a:cs typeface="Calibri" panose="020F0502020204030204" pitchFamily="34" charset="0"/>
               </a:rPr>
               <a:t>}}</a:t>
             </a:r>
-            <a:endParaRPr lang="en-US" sz="3200" dirty="0">
+            <a:endParaRPr lang="en-US" sz="2800" dirty="0">
               <a:latin typeface="Marianne" panose="02000000000000000000" pitchFamily="50" charset="0"/>
             </a:endParaRPr>
           </a:p>
@@ -7673,7 +7649,7 @@
         <p:spPr>
           <a:xfrm>
             <a:off x="576263" y="345395"/>
-            <a:ext cx="9706989" cy="615294"/>
+            <a:ext cx="10130008" cy="615294"/>
           </a:xfrm>
           <a:prstGeom prst="rect">
             <a:avLst/>
@@ -7681,7 +7657,7 @@
         </p:spPr>
         <p:txBody>
           <a:bodyPr vert="horz" lIns="91440" tIns="45720" rIns="91440" bIns="45720" rtlCol="0" anchor="ctr">
-            <a:normAutofit fontScale="85000" lnSpcReduction="10000"/>
+            <a:noAutofit/>
           </a:bodyPr>
           <a:lstStyle>
             <a:lvl1pPr algn="l" defTabSz="914400" rtl="0" eaLnBrk="1" latinLnBrk="0" hangingPunct="1">
@@ -7704,7 +7680,7 @@
           </a:lstStyle>
           <a:p>
             <a:r>
-              <a:rPr lang="en-US" sz="3200" dirty="0" err="1">
+              <a:rPr lang="en-US" sz="2800" dirty="0" err="1">
                 <a:latin typeface="Marianne" panose="02000000000000000000" pitchFamily="50" charset="0"/>
                 <a:ea typeface="Calibri" panose="020F0502020204030204" pitchFamily="34" charset="0"/>
                 <a:cs typeface="Calibri" panose="020F0502020204030204" pitchFamily="34" charset="0"/>
@@ -7712,7 +7688,7 @@
               <a:t>Récapitulatif</a:t>
             </a:r>
             <a:r>
-              <a:rPr lang="en-US" sz="3200" dirty="0">
+              <a:rPr lang="en-US" sz="2800" dirty="0">
                 <a:latin typeface="Marianne" panose="02000000000000000000" pitchFamily="50" charset="0"/>
                 <a:ea typeface="Calibri" panose="020F0502020204030204" pitchFamily="34" charset="0"/>
                 <a:cs typeface="Calibri" panose="020F0502020204030204" pitchFamily="34" charset="0"/>
@@ -7720,7 +7696,7 @@
               <a:t> </a:t>
             </a:r>
             <a:r>
-              <a:rPr lang="en-US" sz="3200" dirty="0" err="1">
+              <a:rPr lang="en-US" sz="2800" dirty="0" err="1">
                 <a:latin typeface="Marianne" panose="02000000000000000000" pitchFamily="50" charset="0"/>
                 <a:ea typeface="Calibri" panose="020F0502020204030204" pitchFamily="34" charset="0"/>
                 <a:cs typeface="Calibri" panose="020F0502020204030204" pitchFamily="34" charset="0"/>
@@ -7728,7 +7704,7 @@
               <a:t>budgétaire</a:t>
             </a:r>
             <a:r>
-              <a:rPr lang="en-US" sz="3200" dirty="0">
+              <a:rPr lang="en-US" sz="2800" dirty="0">
                 <a:latin typeface="Marianne" panose="02000000000000000000" pitchFamily="50" charset="0"/>
                 <a:ea typeface="Calibri" panose="020F0502020204030204" pitchFamily="34" charset="0"/>
                 <a:cs typeface="Calibri" panose="020F0502020204030204" pitchFamily="34" charset="0"/>
@@ -7736,7 +7712,7 @@
               <a:t> {{</a:t>
             </a:r>
             <a:r>
-              <a:rPr lang="en-US" sz="3200" dirty="0" err="1">
+              <a:rPr lang="en-US" sz="2800" dirty="0" err="1">
                 <a:latin typeface="Marianne" panose="02000000000000000000" pitchFamily="50" charset="0"/>
                 <a:ea typeface="Calibri" panose="020F0502020204030204" pitchFamily="34" charset="0"/>
                 <a:cs typeface="Calibri" panose="020F0502020204030204" pitchFamily="34" charset="0"/>
@@ -7744,14 +7720,14 @@
               <a:t>pagination_recap_estimation</a:t>
             </a:r>
             <a:r>
-              <a:rPr lang="en-US" sz="3200" dirty="0">
+              <a:rPr lang="en-US" sz="2800" dirty="0">
                 <a:latin typeface="Marianne" panose="02000000000000000000" pitchFamily="50" charset="0"/>
                 <a:ea typeface="Calibri" panose="020F0502020204030204" pitchFamily="34" charset="0"/>
                 <a:cs typeface="Calibri" panose="020F0502020204030204" pitchFamily="34" charset="0"/>
               </a:rPr>
               <a:t>}}</a:t>
             </a:r>
-            <a:endParaRPr lang="fr-FR" sz="1200" dirty="0">
+            <a:endParaRPr lang="fr-FR" sz="2800" dirty="0">
               <a:latin typeface="Marianne" panose="02000000000000000000" pitchFamily="50" charset="0"/>
             </a:endParaRPr>
           </a:p>
@@ -8123,7 +8099,7 @@
         <p:spPr>
           <a:xfrm>
             <a:off x="1097292" y="3955732"/>
-            <a:ext cx="6059347" cy="692497"/>
+            <a:ext cx="6250712" cy="523220"/>
           </a:xfrm>
           <a:prstGeom prst="rect">
             <a:avLst/>
@@ -8994,25 +8970,25 @@
               <a:buNone/>
             </a:pPr>
             <a:r>
-              <a:rPr lang="en-US" sz="3200" dirty="0" err="1">
+              <a:rPr lang="en-US" sz="2800" dirty="0" err="1">
                 <a:latin typeface="Marianne" panose="02000000000000000000" pitchFamily="50" charset="0"/>
               </a:rPr>
               <a:t>Ressources</a:t>
             </a:r>
             <a:r>
-              <a:rPr lang="en-US" sz="3200" dirty="0">
+              <a:rPr lang="en-US" sz="2800" dirty="0">
                 <a:latin typeface="Marianne" panose="02000000000000000000" pitchFamily="50" charset="0"/>
               </a:rPr>
               <a:t> </a:t>
             </a:r>
             <a:r>
-              <a:rPr lang="en-US" sz="3200" dirty="0" err="1">
+              <a:rPr lang="en-US" sz="2800" dirty="0" err="1">
                 <a:latin typeface="Marianne" panose="02000000000000000000" pitchFamily="50" charset="0"/>
               </a:rPr>
               <a:t>utiles</a:t>
             </a:r>
             <a:r>
-              <a:rPr lang="en-US" sz="3200" dirty="0">
+              <a:rPr lang="en-US" sz="2800" dirty="0">
                 <a:latin typeface="Marianne" panose="02000000000000000000" pitchFamily="50" charset="0"/>
                 <a:ea typeface="Calibri" panose="020F0502020204030204" pitchFamily="34" charset="0"/>
                 <a:cs typeface="Calibri" panose="020F0502020204030204" pitchFamily="34" charset="0"/>
@@ -9020,7 +8996,7 @@
               <a:t> {{</a:t>
             </a:r>
             <a:r>
-              <a:rPr lang="en-US" sz="3200" dirty="0" err="1">
+              <a:rPr lang="en-US" sz="2800" dirty="0" err="1">
                 <a:latin typeface="Marianne" panose="02000000000000000000" pitchFamily="50" charset="0"/>
                 <a:ea typeface="Calibri" panose="020F0502020204030204" pitchFamily="34" charset="0"/>
                 <a:cs typeface="Calibri" panose="020F0502020204030204" pitchFamily="34" charset="0"/>
@@ -9028,7 +9004,7 @@
               <a:t>pagination_ressources_utiles</a:t>
             </a:r>
             <a:r>
-              <a:rPr lang="en-US" sz="3200" dirty="0">
+              <a:rPr lang="en-US" sz="2800" dirty="0">
                 <a:latin typeface="Marianne" panose="02000000000000000000" pitchFamily="50" charset="0"/>
                 <a:ea typeface="Calibri" panose="020F0502020204030204" pitchFamily="34" charset="0"/>
                 <a:cs typeface="Calibri" panose="020F0502020204030204" pitchFamily="34" charset="0"/>

</xml_diff>

<commit_message>
feat: Nom du fichier ppt + ajustements mineurs
</commit_message>
<xml_diff>
--- a/public/templates/template_synthese_projet.pptx
+++ b/public/templates/template_synthese_projet.pptx
@@ -213,7 +213,7 @@
           <a:p>
             <a:fld id="{4C638A9C-6ED0-4718-B5E7-9D405962C144}" type="datetimeFigureOut">
               <a:rPr lang="fr-FR" smtClean="0"/>
-              <a:t>14/09/2026</a:t>
+              <a:t>15/09/2026</a:t>
             </a:fld>
             <a:endParaRPr lang="fr-FR"/>
           </a:p>
@@ -951,7 +951,7 @@
           <a:p>
             <a:fld id="{82E7F8B9-DFDB-4965-877D-C04A580740C9}" type="datetimeFigureOut">
               <a:rPr lang="fr-FR" smtClean="0"/>
-              <a:t>14/09/2026</a:t>
+              <a:t>15/09/2026</a:t>
             </a:fld>
             <a:endParaRPr lang="fr-FR"/>
           </a:p>
@@ -1149,7 +1149,7 @@
           <a:p>
             <a:fld id="{82E7F8B9-DFDB-4965-877D-C04A580740C9}" type="datetimeFigureOut">
               <a:rPr lang="fr-FR" smtClean="0"/>
-              <a:t>14/09/2026</a:t>
+              <a:t>15/09/2026</a:t>
             </a:fld>
             <a:endParaRPr lang="fr-FR"/>
           </a:p>
@@ -1357,7 +1357,7 @@
           <a:p>
             <a:fld id="{82E7F8B9-DFDB-4965-877D-C04A580740C9}" type="datetimeFigureOut">
               <a:rPr lang="fr-FR" smtClean="0"/>
-              <a:t>14/09/2026</a:t>
+              <a:t>15/09/2026</a:t>
             </a:fld>
             <a:endParaRPr lang="fr-FR"/>
           </a:p>
@@ -1590,7 +1590,7 @@
           <a:p>
             <a:fld id="{82E7F8B9-DFDB-4965-877D-C04A580740C9}" type="datetimeFigureOut">
               <a:rPr lang="fr-FR" smtClean="0"/>
-              <a:t>14/09/2026</a:t>
+              <a:t>15/09/2026</a:t>
             </a:fld>
             <a:endParaRPr lang="fr-FR"/>
           </a:p>
@@ -1865,7 +1865,7 @@
           <a:p>
             <a:fld id="{82E7F8B9-DFDB-4965-877D-C04A580740C9}" type="datetimeFigureOut">
               <a:rPr lang="fr-FR" smtClean="0"/>
-              <a:t>14/09/2026</a:t>
+              <a:t>15/09/2026</a:t>
             </a:fld>
             <a:endParaRPr lang="fr-FR"/>
           </a:p>
@@ -2130,7 +2130,7 @@
           <a:p>
             <a:fld id="{82E7F8B9-DFDB-4965-877D-C04A580740C9}" type="datetimeFigureOut">
               <a:rPr lang="fr-FR" smtClean="0"/>
-              <a:t>14/09/2026</a:t>
+              <a:t>15/09/2026</a:t>
             </a:fld>
             <a:endParaRPr lang="fr-FR"/>
           </a:p>
@@ -2542,7 +2542,7 @@
           <a:p>
             <a:fld id="{82E7F8B9-DFDB-4965-877D-C04A580740C9}" type="datetimeFigureOut">
               <a:rPr lang="fr-FR" smtClean="0"/>
-              <a:t>14/09/2026</a:t>
+              <a:t>15/09/2026</a:t>
             </a:fld>
             <a:endParaRPr lang="fr-FR"/>
           </a:p>
@@ -2683,7 +2683,7 @@
           <a:p>
             <a:fld id="{82E7F8B9-DFDB-4965-877D-C04A580740C9}" type="datetimeFigureOut">
               <a:rPr lang="fr-FR" smtClean="0"/>
-              <a:t>14/09/2026</a:t>
+              <a:t>15/09/2026</a:t>
             </a:fld>
             <a:endParaRPr lang="fr-FR"/>
           </a:p>
@@ -2796,7 +2796,7 @@
           <a:p>
             <a:fld id="{82E7F8B9-DFDB-4965-877D-C04A580740C9}" type="datetimeFigureOut">
               <a:rPr lang="fr-FR" smtClean="0"/>
-              <a:t>14/09/2026</a:t>
+              <a:t>15/09/2026</a:t>
             </a:fld>
             <a:endParaRPr lang="fr-FR"/>
           </a:p>
@@ -3107,7 +3107,7 @@
           <a:p>
             <a:fld id="{82E7F8B9-DFDB-4965-877D-C04A580740C9}" type="datetimeFigureOut">
               <a:rPr lang="fr-FR" smtClean="0"/>
-              <a:t>14/09/2026</a:t>
+              <a:t>15/09/2026</a:t>
             </a:fld>
             <a:endParaRPr lang="fr-FR"/>
           </a:p>
@@ -3395,7 +3395,7 @@
           <a:p>
             <a:fld id="{82E7F8B9-DFDB-4965-877D-C04A580740C9}" type="datetimeFigureOut">
               <a:rPr lang="fr-FR" smtClean="0"/>
-              <a:t>14/09/2026</a:t>
+              <a:t>15/09/2026</a:t>
             </a:fld>
             <a:endParaRPr lang="fr-FR"/>
           </a:p>
@@ -3636,7 +3636,7 @@
           <a:p>
             <a:fld id="{82E7F8B9-DFDB-4965-877D-C04A580740C9}" type="datetimeFigureOut">
               <a:rPr lang="fr-FR" smtClean="0"/>
-              <a:t>14/09/2026</a:t>
+              <a:t>15/09/2026</a:t>
             </a:fld>
             <a:endParaRPr lang="fr-FR"/>
           </a:p>
@@ -4628,7 +4628,7 @@
           <a:ln/>
         </p:spPr>
         <p:txBody>
-          <a:bodyPr wrap="square" lIns="0" tIns="0" rIns="0" bIns="0" rtlCol="0" anchor="t"/>
+          <a:bodyPr wrap="square" lIns="0" tIns="0" rIns="0" bIns="0" numCol="2" rtlCol="0" anchor="t"/>
           <a:lstStyle/>
           <a:p>
             <a:pPr marL="285750" indent="-285750">
@@ -4878,8 +4878,8 @@
         </p:nvSpPr>
         <p:spPr>
           <a:xfrm>
-            <a:off x="576263" y="345395"/>
-            <a:ext cx="10031656" cy="615294"/>
+            <a:off x="576262" y="345395"/>
+            <a:ext cx="10082262" cy="615294"/>
           </a:xfrm>
         </p:spPr>
         <p:txBody>
@@ -5585,8 +5585,8 @@
         </p:nvSpPr>
         <p:spPr>
           <a:xfrm>
-            <a:off x="8085069" y="2634521"/>
-            <a:ext cx="3963324" cy="338554"/>
+            <a:off x="8237469" y="3161732"/>
+            <a:ext cx="3861034" cy="476250"/>
           </a:xfrm>
           <a:prstGeom prst="rect">
             <a:avLst/>
@@ -5594,8 +5594,8 @@
           <a:noFill/>
         </p:spPr>
         <p:txBody>
-          <a:bodyPr wrap="square">
-            <a:spAutoFit/>
+          <a:bodyPr wrap="square" anchor="ctr" anchorCtr="0">
+            <a:noAutofit/>
           </a:bodyPr>
           <a:lstStyle/>
           <a:p>
@@ -5611,7 +5611,7 @@
                 <a:ea typeface="Calibri" panose="020F0502020204030204" pitchFamily="34" charset="0"/>
                 <a:cs typeface="Calibri" panose="020F0502020204030204" pitchFamily="34" charset="0"/>
               </a:rPr>
-              <a:t>{{cobenefice_1}}</a:t>
+              <a:t>{{cobenefice_2}}</a:t>
             </a:r>
           </a:p>
         </p:txBody>
@@ -5796,186 +5796,6 @@
           </a:prstGeom>
         </p:spPr>
       </p:pic>
-      <p:sp>
-        <p:nvSpPr>
-          <p:cNvPr id="19" name="ZoneTexte 18">
-            <a:extLst>
-              <a:ext uri="{FF2B5EF4-FFF2-40B4-BE49-F238E27FC236}">
-                <a16:creationId xmlns:a16="http://schemas.microsoft.com/office/drawing/2014/main" id="{6D631D5E-D07D-9DAE-EAC3-1A5DD2833A15}"/>
-              </a:ext>
-            </a:extLst>
-          </p:cNvPr>
-          <p:cNvSpPr txBox="1"/>
-          <p:nvPr/>
-        </p:nvSpPr>
-        <p:spPr>
-          <a:xfrm>
-            <a:off x="8085069" y="3234017"/>
-            <a:ext cx="3963324" cy="338554"/>
-          </a:xfrm>
-          <a:prstGeom prst="rect">
-            <a:avLst/>
-          </a:prstGeom>
-          <a:noFill/>
-        </p:spPr>
-        <p:txBody>
-          <a:bodyPr wrap="square">
-            <a:spAutoFit/>
-          </a:bodyPr>
-          <a:lstStyle/>
-          <a:p>
-            <a:r>
-              <a:rPr lang="fr-FR" sz="1600" dirty="0">
-                <a:solidFill>
-                  <a:schemeClr val="tx1">
-                    <a:lumMod val="65000"/>
-                    <a:lumOff val="35000"/>
-                  </a:schemeClr>
-                </a:solidFill>
-                <a:latin typeface="Marianne" panose="02000000000000000000" pitchFamily="50" charset="0"/>
-                <a:ea typeface="Calibri" panose="020F0502020204030204" pitchFamily="34" charset="0"/>
-                <a:cs typeface="Calibri" panose="020F0502020204030204" pitchFamily="34" charset="0"/>
-              </a:rPr>
-              <a:t>{{cobenefice_2}}</a:t>
-            </a:r>
-          </a:p>
-        </p:txBody>
-      </p:sp>
-      <p:sp>
-        <p:nvSpPr>
-          <p:cNvPr id="20" name="ZoneTexte 19">
-            <a:extLst>
-              <a:ext uri="{FF2B5EF4-FFF2-40B4-BE49-F238E27FC236}">
-                <a16:creationId xmlns:a16="http://schemas.microsoft.com/office/drawing/2014/main" id="{11E5E33C-8CFC-334B-4593-E730FD9EA6B7}"/>
-              </a:ext>
-            </a:extLst>
-          </p:cNvPr>
-          <p:cNvSpPr txBox="1"/>
-          <p:nvPr/>
-        </p:nvSpPr>
-        <p:spPr>
-          <a:xfrm>
-            <a:off x="8082875" y="3813072"/>
-            <a:ext cx="3963324" cy="338554"/>
-          </a:xfrm>
-          <a:prstGeom prst="rect">
-            <a:avLst/>
-          </a:prstGeom>
-          <a:noFill/>
-        </p:spPr>
-        <p:txBody>
-          <a:bodyPr wrap="square">
-            <a:spAutoFit/>
-          </a:bodyPr>
-          <a:lstStyle/>
-          <a:p>
-            <a:r>
-              <a:rPr lang="fr-FR" sz="1600" dirty="0">
-                <a:solidFill>
-                  <a:schemeClr val="tx1">
-                    <a:lumMod val="65000"/>
-                    <a:lumOff val="35000"/>
-                  </a:schemeClr>
-                </a:solidFill>
-                <a:latin typeface="Marianne" panose="02000000000000000000" pitchFamily="50" charset="0"/>
-                <a:ea typeface="Calibri" panose="020F0502020204030204" pitchFamily="34" charset="0"/>
-                <a:cs typeface="Calibri" panose="020F0502020204030204" pitchFamily="34" charset="0"/>
-              </a:rPr>
-              <a:t>{{cobenefice_3}}</a:t>
-            </a:r>
-          </a:p>
-        </p:txBody>
-      </p:sp>
-      <p:sp>
-        <p:nvSpPr>
-          <p:cNvPr id="21" name="ZoneTexte 20">
-            <a:extLst>
-              <a:ext uri="{FF2B5EF4-FFF2-40B4-BE49-F238E27FC236}">
-                <a16:creationId xmlns:a16="http://schemas.microsoft.com/office/drawing/2014/main" id="{C7B5A477-60D1-C184-143E-F283CFF41D85}"/>
-              </a:ext>
-            </a:extLst>
-          </p:cNvPr>
-          <p:cNvSpPr txBox="1"/>
-          <p:nvPr/>
-        </p:nvSpPr>
-        <p:spPr>
-          <a:xfrm>
-            <a:off x="8090359" y="4392127"/>
-            <a:ext cx="3963324" cy="338554"/>
-          </a:xfrm>
-          <a:prstGeom prst="rect">
-            <a:avLst/>
-          </a:prstGeom>
-          <a:noFill/>
-        </p:spPr>
-        <p:txBody>
-          <a:bodyPr wrap="square">
-            <a:spAutoFit/>
-          </a:bodyPr>
-          <a:lstStyle/>
-          <a:p>
-            <a:r>
-              <a:rPr lang="fr-FR" sz="1600" dirty="0">
-                <a:solidFill>
-                  <a:schemeClr val="tx1">
-                    <a:lumMod val="65000"/>
-                    <a:lumOff val="35000"/>
-                  </a:schemeClr>
-                </a:solidFill>
-                <a:latin typeface="Marianne" panose="02000000000000000000" pitchFamily="50" charset="0"/>
-                <a:ea typeface="Calibri" panose="020F0502020204030204" pitchFamily="34" charset="0"/>
-                <a:cs typeface="Calibri" panose="020F0502020204030204" pitchFamily="34" charset="0"/>
-              </a:rPr>
-              <a:t>{{cobenefice_4}}</a:t>
-            </a:r>
-          </a:p>
-        </p:txBody>
-      </p:sp>
-      <p:sp>
-        <p:nvSpPr>
-          <p:cNvPr id="22" name="ZoneTexte 21">
-            <a:extLst>
-              <a:ext uri="{FF2B5EF4-FFF2-40B4-BE49-F238E27FC236}">
-                <a16:creationId xmlns:a16="http://schemas.microsoft.com/office/drawing/2014/main" id="{3E0B2B88-CCE4-F3AD-BB3A-53328832BC06}"/>
-              </a:ext>
-            </a:extLst>
-          </p:cNvPr>
-          <p:cNvSpPr txBox="1"/>
-          <p:nvPr/>
-        </p:nvSpPr>
-        <p:spPr>
-          <a:xfrm>
-            <a:off x="8082875" y="4985424"/>
-            <a:ext cx="3963324" cy="338554"/>
-          </a:xfrm>
-          <a:prstGeom prst="rect">
-            <a:avLst/>
-          </a:prstGeom>
-          <a:noFill/>
-        </p:spPr>
-        <p:txBody>
-          <a:bodyPr wrap="square">
-            <a:spAutoFit/>
-          </a:bodyPr>
-          <a:lstStyle/>
-          <a:p>
-            <a:r>
-              <a:rPr lang="fr-FR" sz="1600" dirty="0">
-                <a:solidFill>
-                  <a:schemeClr val="tx1">
-                    <a:lumMod val="65000"/>
-                    <a:lumOff val="35000"/>
-                  </a:schemeClr>
-                </a:solidFill>
-                <a:latin typeface="Marianne" panose="02000000000000000000" pitchFamily="50" charset="0"/>
-                <a:ea typeface="Calibri" panose="020F0502020204030204" pitchFamily="34" charset="0"/>
-                <a:cs typeface="Calibri" panose="020F0502020204030204" pitchFamily="34" charset="0"/>
-              </a:rPr>
-              <a:t>{{cobenefice_5}}</a:t>
-            </a:r>
-          </a:p>
-        </p:txBody>
-      </p:sp>
       <p:sp>
         <p:nvSpPr>
           <p:cNvPr id="23" name="ZoneTexte 22">
@@ -6247,6 +6067,186 @@
                 <a:cs typeface="Calibri" panose="020F0502020204030204" pitchFamily="34" charset="0"/>
               </a:rPr>
               <a:t>}}</a:t>
+            </a:r>
+          </a:p>
+        </p:txBody>
+      </p:sp>
+      <p:sp>
+        <p:nvSpPr>
+          <p:cNvPr id="7" name="ZoneTexte 6">
+            <a:extLst>
+              <a:ext uri="{FF2B5EF4-FFF2-40B4-BE49-F238E27FC236}">
+                <a16:creationId xmlns:a16="http://schemas.microsoft.com/office/drawing/2014/main" id="{E72EFF39-F777-8E5F-FD01-D72F943C7979}"/>
+              </a:ext>
+            </a:extLst>
+          </p:cNvPr>
+          <p:cNvSpPr txBox="1"/>
+          <p:nvPr/>
+        </p:nvSpPr>
+        <p:spPr>
+          <a:xfrm>
+            <a:off x="8237469" y="2578202"/>
+            <a:ext cx="3861034" cy="476250"/>
+          </a:xfrm>
+          <a:prstGeom prst="rect">
+            <a:avLst/>
+          </a:prstGeom>
+          <a:noFill/>
+        </p:spPr>
+        <p:txBody>
+          <a:bodyPr wrap="square" anchor="ctr" anchorCtr="0">
+            <a:noAutofit/>
+          </a:bodyPr>
+          <a:lstStyle/>
+          <a:p>
+            <a:r>
+              <a:rPr lang="fr-FR" sz="1600" dirty="0">
+                <a:solidFill>
+                  <a:schemeClr val="tx1">
+                    <a:lumMod val="65000"/>
+                    <a:lumOff val="35000"/>
+                  </a:schemeClr>
+                </a:solidFill>
+                <a:latin typeface="Marianne" panose="02000000000000000000" pitchFamily="50" charset="0"/>
+                <a:ea typeface="Calibri" panose="020F0502020204030204" pitchFamily="34" charset="0"/>
+                <a:cs typeface="Calibri" panose="020F0502020204030204" pitchFamily="34" charset="0"/>
+              </a:rPr>
+              <a:t>{{cobenefice_1}}</a:t>
+            </a:r>
+          </a:p>
+        </p:txBody>
+      </p:sp>
+      <p:sp>
+        <p:nvSpPr>
+          <p:cNvPr id="10" name="ZoneTexte 9">
+            <a:extLst>
+              <a:ext uri="{FF2B5EF4-FFF2-40B4-BE49-F238E27FC236}">
+                <a16:creationId xmlns:a16="http://schemas.microsoft.com/office/drawing/2014/main" id="{4098E478-051C-0E99-FB36-5E8423C9D312}"/>
+              </a:ext>
+            </a:extLst>
+          </p:cNvPr>
+          <p:cNvSpPr txBox="1"/>
+          <p:nvPr/>
+        </p:nvSpPr>
+        <p:spPr>
+          <a:xfrm>
+            <a:off x="8237469" y="3745262"/>
+            <a:ext cx="3861034" cy="476250"/>
+          </a:xfrm>
+          <a:prstGeom prst="rect">
+            <a:avLst/>
+          </a:prstGeom>
+          <a:noFill/>
+        </p:spPr>
+        <p:txBody>
+          <a:bodyPr wrap="square" anchor="ctr" anchorCtr="0">
+            <a:noAutofit/>
+          </a:bodyPr>
+          <a:lstStyle/>
+          <a:p>
+            <a:r>
+              <a:rPr lang="fr-FR" sz="1600" dirty="0">
+                <a:solidFill>
+                  <a:schemeClr val="tx1">
+                    <a:lumMod val="65000"/>
+                    <a:lumOff val="35000"/>
+                  </a:schemeClr>
+                </a:solidFill>
+                <a:latin typeface="Marianne" panose="02000000000000000000" pitchFamily="50" charset="0"/>
+                <a:ea typeface="Calibri" panose="020F0502020204030204" pitchFamily="34" charset="0"/>
+                <a:cs typeface="Calibri" panose="020F0502020204030204" pitchFamily="34" charset="0"/>
+              </a:rPr>
+              <a:t>{{cobenefice_3}}</a:t>
+            </a:r>
+          </a:p>
+        </p:txBody>
+      </p:sp>
+      <p:sp>
+        <p:nvSpPr>
+          <p:cNvPr id="11" name="ZoneTexte 10">
+            <a:extLst>
+              <a:ext uri="{FF2B5EF4-FFF2-40B4-BE49-F238E27FC236}">
+                <a16:creationId xmlns:a16="http://schemas.microsoft.com/office/drawing/2014/main" id="{023D0C9A-6FEB-77DA-29C5-031AF616F917}"/>
+              </a:ext>
+            </a:extLst>
+          </p:cNvPr>
+          <p:cNvSpPr txBox="1"/>
+          <p:nvPr/>
+        </p:nvSpPr>
+        <p:spPr>
+          <a:xfrm>
+            <a:off x="8237469" y="4354922"/>
+            <a:ext cx="3861034" cy="476250"/>
+          </a:xfrm>
+          <a:prstGeom prst="rect">
+            <a:avLst/>
+          </a:prstGeom>
+          <a:noFill/>
+        </p:spPr>
+        <p:txBody>
+          <a:bodyPr wrap="square" anchor="ctr" anchorCtr="0">
+            <a:noAutofit/>
+          </a:bodyPr>
+          <a:lstStyle/>
+          <a:p>
+            <a:r>
+              <a:rPr lang="fr-FR" sz="1600" dirty="0">
+                <a:solidFill>
+                  <a:schemeClr val="tx1">
+                    <a:lumMod val="65000"/>
+                    <a:lumOff val="35000"/>
+                  </a:schemeClr>
+                </a:solidFill>
+                <a:latin typeface="Marianne" panose="02000000000000000000" pitchFamily="50" charset="0"/>
+                <a:ea typeface="Calibri" panose="020F0502020204030204" pitchFamily="34" charset="0"/>
+                <a:cs typeface="Calibri" panose="020F0502020204030204" pitchFamily="34" charset="0"/>
+              </a:rPr>
+              <a:t>{{cobenefice_4}}</a:t>
+            </a:r>
+          </a:p>
+        </p:txBody>
+      </p:sp>
+      <p:sp>
+        <p:nvSpPr>
+          <p:cNvPr id="12" name="ZoneTexte 11">
+            <a:extLst>
+              <a:ext uri="{FF2B5EF4-FFF2-40B4-BE49-F238E27FC236}">
+                <a16:creationId xmlns:a16="http://schemas.microsoft.com/office/drawing/2014/main" id="{59F8ACD8-1EDA-512F-86EF-594B0287BCB3}"/>
+              </a:ext>
+            </a:extLst>
+          </p:cNvPr>
+          <p:cNvSpPr txBox="1"/>
+          <p:nvPr/>
+        </p:nvSpPr>
+        <p:spPr>
+          <a:xfrm>
+            <a:off x="8237469" y="4917253"/>
+            <a:ext cx="3861034" cy="476250"/>
+          </a:xfrm>
+          <a:prstGeom prst="rect">
+            <a:avLst/>
+          </a:prstGeom>
+          <a:noFill/>
+        </p:spPr>
+        <p:txBody>
+          <a:bodyPr wrap="square" anchor="ctr" anchorCtr="0">
+            <a:noAutofit/>
+          </a:bodyPr>
+          <a:lstStyle/>
+          <a:p>
+            <a:r>
+              <a:rPr lang="fr-FR" sz="1600" dirty="0">
+                <a:solidFill>
+                  <a:schemeClr val="tx1">
+                    <a:lumMod val="65000"/>
+                    <a:lumOff val="35000"/>
+                  </a:schemeClr>
+                </a:solidFill>
+                <a:latin typeface="Marianne" panose="02000000000000000000" pitchFamily="50" charset="0"/>
+                <a:ea typeface="Calibri" panose="020F0502020204030204" pitchFamily="34" charset="0"/>
+                <a:cs typeface="Calibri" panose="020F0502020204030204" pitchFamily="34" charset="0"/>
+              </a:rPr>
+              <a:t>{{cobenefice_5}}</a:t>
             </a:r>
           </a:p>
         </p:txBody>
@@ -6568,8 +6568,8 @@
         </p:nvSpPr>
         <p:spPr>
           <a:xfrm>
-            <a:off x="2360736" y="2238962"/>
-            <a:ext cx="7173528" cy="292388"/>
+            <a:off x="2360736" y="2238961"/>
+            <a:ext cx="7349126" cy="632610"/>
           </a:xfrm>
           <a:prstGeom prst="rect">
             <a:avLst/>
@@ -6578,7 +6578,7 @@
         </p:spPr>
         <p:txBody>
           <a:bodyPr wrap="square" lIns="91440" tIns="45720" rIns="91440" bIns="45720" anchor="t">
-            <a:spAutoFit/>
+            <a:normAutofit/>
           </a:bodyPr>
           <a:lstStyle/>
           <a:p>
@@ -6722,8 +6722,8 @@
         </p:nvSpPr>
         <p:spPr>
           <a:xfrm>
-            <a:off x="576263" y="345395"/>
-            <a:ext cx="9706989" cy="615294"/>
+            <a:off x="576262" y="345395"/>
+            <a:ext cx="10082261" cy="615294"/>
           </a:xfrm>
           <a:prstGeom prst="rect">
             <a:avLst/>

</xml_diff>

<commit_message>
feat: remove test icon in template + linter
</commit_message>
<xml_diff>
--- a/public/templates/template_synthese_projet.pptx
+++ b/public/templates/template_synthese_projet.pptx
@@ -4448,41 +4448,36 @@
           <a:chExt cx="0" cy="0"/>
         </a:xfrm>
       </p:grpSpPr>
-      <p:sp>
-        <p:nvSpPr>
-          <p:cNvPr id="3" name="Text 1">
-            <a:extLst>
-              <a:ext uri="{FF2B5EF4-FFF2-40B4-BE49-F238E27FC236}">
-                <a16:creationId xmlns:a16="http://schemas.microsoft.com/office/drawing/2014/main" id="{2CE7C914-9BAE-BFF2-E2E6-8DFEAA338D00}"/>
-              </a:ext>
-            </a:extLst>
-          </p:cNvPr>
-          <p:cNvSpPr/>
+      <p:pic>
+        <p:nvPicPr>
+          <p:cNvPr id="10" name="Picture 9">
+            <a:extLst>
+              <a:ext uri="{FF2B5EF4-FFF2-40B4-BE49-F238E27FC236}">
+                <a16:creationId xmlns:a16="http://schemas.microsoft.com/office/drawing/2014/main" id="{E922595D-B49E-4187-3566-440EF1D1B583}"/>
+              </a:ext>
+            </a:extLst>
+          </p:cNvPr>
+          <p:cNvPicPr>
+            <a:picLocks noChangeAspect="1"/>
+          </p:cNvPicPr>
           <p:nvPr/>
-        </p:nvSpPr>
-        <p:spPr>
-          <a:xfrm>
-            <a:off x="609600" y="975360"/>
-            <a:ext cx="10972800" cy="1950720"/>
+        </p:nvPicPr>
+        <p:blipFill>
+          <a:blip r:embed="rId3"/>
+          <a:stretch>
+            <a:fillRect/>
+          </a:stretch>
+        </p:blipFill>
+        <p:spPr>
+          <a:xfrm>
+            <a:off x="10546452" y="104580"/>
+            <a:ext cx="1552051" cy="758533"/>
           </a:xfrm>
           <a:prstGeom prst="rect">
             <a:avLst/>
           </a:prstGeom>
-          <a:noFill/>
-          <a:ln/>
-        </p:spPr>
-        <p:txBody>
-          <a:bodyPr wrap="square" lIns="0" tIns="0" rIns="0" bIns="0" rtlCol="0" anchor="ctr"/>
-          <a:lstStyle/>
-          <a:p>
-            <a:endParaRPr lang="en-US" sz="13333" dirty="0">
-              <a:latin typeface="Marianne" panose="02000000000000000000" pitchFamily="50" charset="0"/>
-              <a:ea typeface="Calibri" panose="020F0502020204030204" pitchFamily="34" charset="0"/>
-              <a:cs typeface="Calibri" panose="020F0502020204030204" pitchFamily="34" charset="0"/>
-            </a:endParaRPr>
-          </a:p>
-        </p:txBody>
-      </p:sp>
+        </p:spPr>
+      </p:pic>
       <p:sp>
         <p:nvSpPr>
           <p:cNvPr id="4" name="Text 2">
@@ -4765,65 +4760,6 @@
           </a:p>
         </p:txBody>
       </p:sp>
-      <p:pic>
-        <p:nvPicPr>
-          <p:cNvPr id="9" name="Image 8" descr="Une image contenant Police, Graphique, logo, graphisme&#10;&#10;Description générée automatiquement">
-            <a:extLst>
-              <a:ext uri="{FF2B5EF4-FFF2-40B4-BE49-F238E27FC236}">
-                <a16:creationId xmlns:a16="http://schemas.microsoft.com/office/drawing/2014/main" id="{5FA40CA5-18D5-ABCF-9EE1-BF9C0AE210FD}"/>
-              </a:ext>
-            </a:extLst>
-          </p:cNvPr>
-          <p:cNvPicPr>
-            <a:picLocks noChangeAspect="1"/>
-          </p:cNvPicPr>
-          <p:nvPr/>
-        </p:nvPicPr>
-        <p:blipFill>
-          <a:blip r:embed="rId3"/>
-          <a:srcRect t="19804" b="18118"/>
-          <a:stretch/>
-        </p:blipFill>
-        <p:spPr>
-          <a:xfrm>
-            <a:off x="10763987" y="98854"/>
-            <a:ext cx="1229053" cy="762977"/>
-          </a:xfrm>
-          <a:prstGeom prst="rect">
-            <a:avLst/>
-          </a:prstGeom>
-        </p:spPr>
-      </p:pic>
-      <p:pic>
-        <p:nvPicPr>
-          <p:cNvPr id="10" name="Picture 9">
-            <a:extLst>
-              <a:ext uri="{FF2B5EF4-FFF2-40B4-BE49-F238E27FC236}">
-                <a16:creationId xmlns:a16="http://schemas.microsoft.com/office/drawing/2014/main" id="{E922595D-B49E-4187-3566-440EF1D1B583}"/>
-              </a:ext>
-            </a:extLst>
-          </p:cNvPr>
-          <p:cNvPicPr>
-            <a:picLocks noChangeAspect="1"/>
-          </p:cNvPicPr>
-          <p:nvPr/>
-        </p:nvPicPr>
-        <p:blipFill>
-          <a:blip r:embed="rId4"/>
-          <a:stretch>
-            <a:fillRect/>
-          </a:stretch>
-        </p:blipFill>
-        <p:spPr>
-          <a:xfrm>
-            <a:off x="10546452" y="104580"/>
-            <a:ext cx="1552051" cy="758533"/>
-          </a:xfrm>
-          <a:prstGeom prst="rect">
-            <a:avLst/>
-          </a:prstGeom>
-        </p:spPr>
-      </p:pic>
     </p:spTree>
     <p:extLst>
       <p:ext uri="{BB962C8B-B14F-4D97-AF65-F5344CB8AC3E}">
@@ -4860,6 +4796,36 @@
           <a:chExt cx="0" cy="0"/>
         </a:xfrm>
       </p:grpSpPr>
+      <p:pic>
+        <p:nvPicPr>
+          <p:cNvPr id="4" name="Picture 3">
+            <a:extLst>
+              <a:ext uri="{FF2B5EF4-FFF2-40B4-BE49-F238E27FC236}">
+                <a16:creationId xmlns:a16="http://schemas.microsoft.com/office/drawing/2014/main" id="{7D131FE9-968A-7934-D330-1035AA73A364}"/>
+              </a:ext>
+            </a:extLst>
+          </p:cNvPr>
+          <p:cNvPicPr>
+            <a:picLocks noChangeAspect="1"/>
+          </p:cNvPicPr>
+          <p:nvPr/>
+        </p:nvPicPr>
+        <p:blipFill>
+          <a:blip r:embed="rId2"/>
+          <a:stretch>
+            <a:fillRect/>
+          </a:stretch>
+        </p:blipFill>
+        <p:spPr>
+          <a:xfrm>
+            <a:off x="10546452" y="104580"/>
+            <a:ext cx="1552051" cy="758533"/>
+          </a:xfrm>
+          <a:prstGeom prst="rect">
+            <a:avLst/>
+          </a:prstGeom>
+        </p:spPr>
+      </p:pic>
       <p:sp>
         <p:nvSpPr>
           <p:cNvPr id="2" name="Titre 1">
@@ -5356,65 +5322,6 @@
           </a:p>
         </p:txBody>
       </p:sp>
-      <p:pic>
-        <p:nvPicPr>
-          <p:cNvPr id="57" name="Image 56" descr="Une image contenant Police, Graphique, logo, graphisme&#10;&#10;Description générée automatiquement">
-            <a:extLst>
-              <a:ext uri="{FF2B5EF4-FFF2-40B4-BE49-F238E27FC236}">
-                <a16:creationId xmlns:a16="http://schemas.microsoft.com/office/drawing/2014/main" id="{830EBC68-A5C6-15CA-95C1-839F0A7C9BA7}"/>
-              </a:ext>
-            </a:extLst>
-          </p:cNvPr>
-          <p:cNvPicPr>
-            <a:picLocks noChangeAspect="1"/>
-          </p:cNvPicPr>
-          <p:nvPr/>
-        </p:nvPicPr>
-        <p:blipFill>
-          <a:blip r:embed="rId2"/>
-          <a:srcRect t="19804" b="18118"/>
-          <a:stretch/>
-        </p:blipFill>
-        <p:spPr>
-          <a:xfrm>
-            <a:off x="10763987" y="98854"/>
-            <a:ext cx="1229053" cy="762977"/>
-          </a:xfrm>
-          <a:prstGeom prst="rect">
-            <a:avLst/>
-          </a:prstGeom>
-        </p:spPr>
-      </p:pic>
-      <p:pic>
-        <p:nvPicPr>
-          <p:cNvPr id="4" name="Picture 3">
-            <a:extLst>
-              <a:ext uri="{FF2B5EF4-FFF2-40B4-BE49-F238E27FC236}">
-                <a16:creationId xmlns:a16="http://schemas.microsoft.com/office/drawing/2014/main" id="{7D131FE9-968A-7934-D330-1035AA73A364}"/>
-              </a:ext>
-            </a:extLst>
-          </p:cNvPr>
-          <p:cNvPicPr>
-            <a:picLocks noChangeAspect="1"/>
-          </p:cNvPicPr>
-          <p:nvPr/>
-        </p:nvPicPr>
-        <p:blipFill>
-          <a:blip r:embed="rId3"/>
-          <a:stretch>
-            <a:fillRect/>
-          </a:stretch>
-        </p:blipFill>
-        <p:spPr>
-          <a:xfrm>
-            <a:off x="10546452" y="104580"/>
-            <a:ext cx="1552051" cy="758533"/>
-          </a:xfrm>
-          <a:prstGeom prst="rect">
-            <a:avLst/>
-          </a:prstGeom>
-        </p:spPr>
-      </p:pic>
       <p:sp>
         <p:nvSpPr>
           <p:cNvPr id="3" name="ZoneTexte 2">
@@ -5550,10 +5457,10 @@
           <p:nvPr/>
         </p:nvPicPr>
         <p:blipFill>
-          <a:blip r:embed="rId4">
+          <a:blip r:embed="rId3">
             <a:extLst>
               <a:ext uri="{96DAC541-7B7A-43D3-8B79-37D633B846F1}">
-                <asvg:svgBlip xmlns:asvg="http://schemas.microsoft.com/office/drawing/2016/SVG/main" r:embed="rId5"/>
+                <asvg:svgBlip xmlns:asvg="http://schemas.microsoft.com/office/drawing/2016/SVG/main" r:embed="rId4"/>
               </a:ext>
             </a:extLst>
           </a:blip>
@@ -5631,10 +5538,10 @@
           <p:nvPr/>
         </p:nvPicPr>
         <p:blipFill>
-          <a:blip r:embed="rId6">
+          <a:blip r:embed="rId5">
             <a:extLst>
               <a:ext uri="{96DAC541-7B7A-43D3-8B79-37D633B846F1}">
-                <asvg:svgBlip xmlns:asvg="http://schemas.microsoft.com/office/drawing/2016/SVG/main" r:embed="rId7"/>
+                <asvg:svgBlip xmlns:asvg="http://schemas.microsoft.com/office/drawing/2016/SVG/main" r:embed="rId6"/>
               </a:ext>
             </a:extLst>
           </a:blip>
@@ -5667,10 +5574,10 @@
           <p:nvPr/>
         </p:nvPicPr>
         <p:blipFill>
-          <a:blip r:embed="rId6">
+          <a:blip r:embed="rId5">
             <a:extLst>
               <a:ext uri="{96DAC541-7B7A-43D3-8B79-37D633B846F1}">
-                <asvg:svgBlip xmlns:asvg="http://schemas.microsoft.com/office/drawing/2016/SVG/main" r:embed="rId7"/>
+                <asvg:svgBlip xmlns:asvg="http://schemas.microsoft.com/office/drawing/2016/SVG/main" r:embed="rId6"/>
               </a:ext>
             </a:extLst>
           </a:blip>
@@ -5703,10 +5610,10 @@
           <p:nvPr/>
         </p:nvPicPr>
         <p:blipFill>
-          <a:blip r:embed="rId6">
+          <a:blip r:embed="rId5">
             <a:extLst>
               <a:ext uri="{96DAC541-7B7A-43D3-8B79-37D633B846F1}">
-                <asvg:svgBlip xmlns:asvg="http://schemas.microsoft.com/office/drawing/2016/SVG/main" r:embed="rId7"/>
+                <asvg:svgBlip xmlns:asvg="http://schemas.microsoft.com/office/drawing/2016/SVG/main" r:embed="rId6"/>
               </a:ext>
             </a:extLst>
           </a:blip>
@@ -5739,10 +5646,10 @@
           <p:nvPr/>
         </p:nvPicPr>
         <p:blipFill>
-          <a:blip r:embed="rId6">
+          <a:blip r:embed="rId5">
             <a:extLst>
               <a:ext uri="{96DAC541-7B7A-43D3-8B79-37D633B846F1}">
-                <asvg:svgBlip xmlns:asvg="http://schemas.microsoft.com/office/drawing/2016/SVG/main" r:embed="rId7"/>
+                <asvg:svgBlip xmlns:asvg="http://schemas.microsoft.com/office/drawing/2016/SVG/main" r:embed="rId6"/>
               </a:ext>
             </a:extLst>
           </a:blip>
@@ -5775,10 +5682,10 @@
           <p:nvPr/>
         </p:nvPicPr>
         <p:blipFill>
-          <a:blip r:embed="rId6">
+          <a:blip r:embed="rId5">
             <a:extLst>
               <a:ext uri="{96DAC541-7B7A-43D3-8B79-37D633B846F1}">
-                <asvg:svgBlip xmlns:asvg="http://schemas.microsoft.com/office/drawing/2016/SVG/main" r:embed="rId7"/>
+                <asvg:svgBlip xmlns:asvg="http://schemas.microsoft.com/office/drawing/2016/SVG/main" r:embed="rId6"/>
               </a:ext>
             </a:extLst>
           </a:blip>
@@ -6287,6 +6194,36 @@
           <a:chExt cx="0" cy="0"/>
         </a:xfrm>
       </p:grpSpPr>
+      <p:pic>
+        <p:nvPicPr>
+          <p:cNvPr id="5" name="Picture 4">
+            <a:extLst>
+              <a:ext uri="{FF2B5EF4-FFF2-40B4-BE49-F238E27FC236}">
+                <a16:creationId xmlns:a16="http://schemas.microsoft.com/office/drawing/2014/main" id="{DDFE2676-551D-F9A9-1060-DC00E3F770F9}"/>
+              </a:ext>
+            </a:extLst>
+          </p:cNvPr>
+          <p:cNvPicPr>
+            <a:picLocks noChangeAspect="1"/>
+          </p:cNvPicPr>
+          <p:nvPr/>
+        </p:nvPicPr>
+        <p:blipFill>
+          <a:blip r:embed="rId2"/>
+          <a:stretch>
+            <a:fillRect/>
+          </a:stretch>
+        </p:blipFill>
+        <p:spPr>
+          <a:xfrm>
+            <a:off x="10546452" y="104580"/>
+            <a:ext cx="1552051" cy="758533"/>
+          </a:xfrm>
+          <a:prstGeom prst="rect">
+            <a:avLst/>
+          </a:prstGeom>
+        </p:spPr>
+      </p:pic>
       <p:sp>
         <p:nvSpPr>
           <p:cNvPr id="7" name="ZoneTexte 6">
@@ -6539,7 +6476,7 @@
           <p:nvPr/>
         </p:nvPicPr>
         <p:blipFill>
-          <a:blip r:embed="rId2"/>
+          <a:blip r:embed="rId3"/>
           <a:stretch>
             <a:fillRect/>
           </a:stretch>
@@ -6844,65 +6781,6 @@
           </a:fontRef>
         </p:style>
       </p:cxnSp>
-      <p:pic>
-        <p:nvPicPr>
-          <p:cNvPr id="14" name="Image 13" descr="Une image contenant Police, Graphique, logo, graphisme&#10;&#10;Description générée automatiquement">
-            <a:extLst>
-              <a:ext uri="{FF2B5EF4-FFF2-40B4-BE49-F238E27FC236}">
-                <a16:creationId xmlns:a16="http://schemas.microsoft.com/office/drawing/2014/main" id="{AD69CEB4-74D5-E3C0-685B-527FC6C4A3EF}"/>
-              </a:ext>
-            </a:extLst>
-          </p:cNvPr>
-          <p:cNvPicPr>
-            <a:picLocks noChangeAspect="1"/>
-          </p:cNvPicPr>
-          <p:nvPr/>
-        </p:nvPicPr>
-        <p:blipFill>
-          <a:blip r:embed="rId3"/>
-          <a:srcRect t="19804" b="18118"/>
-          <a:stretch/>
-        </p:blipFill>
-        <p:spPr>
-          <a:xfrm>
-            <a:off x="10763987" y="98854"/>
-            <a:ext cx="1229053" cy="762977"/>
-          </a:xfrm>
-          <a:prstGeom prst="rect">
-            <a:avLst/>
-          </a:prstGeom>
-        </p:spPr>
-      </p:pic>
-      <p:pic>
-        <p:nvPicPr>
-          <p:cNvPr id="5" name="Picture 4">
-            <a:extLst>
-              <a:ext uri="{FF2B5EF4-FFF2-40B4-BE49-F238E27FC236}">
-                <a16:creationId xmlns:a16="http://schemas.microsoft.com/office/drawing/2014/main" id="{DDFE2676-551D-F9A9-1060-DC00E3F770F9}"/>
-              </a:ext>
-            </a:extLst>
-          </p:cNvPr>
-          <p:cNvPicPr>
-            <a:picLocks noChangeAspect="1"/>
-          </p:cNvPicPr>
-          <p:nvPr/>
-        </p:nvPicPr>
-        <p:blipFill>
-          <a:blip r:embed="rId4"/>
-          <a:stretch>
-            <a:fillRect/>
-          </a:stretch>
-        </p:blipFill>
-        <p:spPr>
-          <a:xfrm>
-            <a:off x="10546452" y="104580"/>
-            <a:ext cx="1552051" cy="758533"/>
-          </a:xfrm>
-          <a:prstGeom prst="rect">
-            <a:avLst/>
-          </a:prstGeom>
-        </p:spPr>
-      </p:pic>
     </p:spTree>
     <p:extLst>
       <p:ext uri="{BB962C8B-B14F-4D97-AF65-F5344CB8AC3E}">
@@ -6939,41 +6817,36 @@
           <a:chExt cx="0" cy="0"/>
         </a:xfrm>
       </p:grpSpPr>
-      <p:sp>
-        <p:nvSpPr>
-          <p:cNvPr id="3" name="Text 1">
-            <a:extLst>
-              <a:ext uri="{FF2B5EF4-FFF2-40B4-BE49-F238E27FC236}">
-                <a16:creationId xmlns:a16="http://schemas.microsoft.com/office/drawing/2014/main" id="{2CE7C914-9BAE-BFF2-E2E6-8DFEAA338D00}"/>
-              </a:ext>
-            </a:extLst>
-          </p:cNvPr>
-          <p:cNvSpPr/>
+      <p:pic>
+        <p:nvPicPr>
+          <p:cNvPr id="10" name="Picture 9">
+            <a:extLst>
+              <a:ext uri="{FF2B5EF4-FFF2-40B4-BE49-F238E27FC236}">
+                <a16:creationId xmlns:a16="http://schemas.microsoft.com/office/drawing/2014/main" id="{E922595D-B49E-4187-3566-440EF1D1B583}"/>
+              </a:ext>
+            </a:extLst>
+          </p:cNvPr>
+          <p:cNvPicPr>
+            <a:picLocks noChangeAspect="1"/>
+          </p:cNvPicPr>
           <p:nvPr/>
-        </p:nvSpPr>
-        <p:spPr>
-          <a:xfrm>
-            <a:off x="609600" y="975360"/>
-            <a:ext cx="10972800" cy="1950720"/>
+        </p:nvPicPr>
+        <p:blipFill>
+          <a:blip r:embed="rId3"/>
+          <a:stretch>
+            <a:fillRect/>
+          </a:stretch>
+        </p:blipFill>
+        <p:spPr>
+          <a:xfrm>
+            <a:off x="10546452" y="104580"/>
+            <a:ext cx="1552051" cy="758533"/>
           </a:xfrm>
           <a:prstGeom prst="rect">
             <a:avLst/>
           </a:prstGeom>
-          <a:noFill/>
-          <a:ln/>
-        </p:spPr>
-        <p:txBody>
-          <a:bodyPr wrap="square" lIns="0" tIns="0" rIns="0" bIns="0" rtlCol="0" anchor="ctr"/>
-          <a:lstStyle/>
-          <a:p>
-            <a:endParaRPr lang="en-US" sz="13333" dirty="0">
-              <a:latin typeface="Marianne" panose="02000000000000000000" pitchFamily="50" charset="0"/>
-              <a:ea typeface="Calibri" panose="020F0502020204030204" pitchFamily="34" charset="0"/>
-              <a:cs typeface="Calibri" panose="020F0502020204030204" pitchFamily="34" charset="0"/>
-            </a:endParaRPr>
-          </a:p>
-        </p:txBody>
-      </p:sp>
+        </p:spPr>
+      </p:pic>
       <p:sp>
         <p:nvSpPr>
           <p:cNvPr id="4" name="Text 2">
@@ -7277,65 +7150,6 @@
           </a:p>
         </p:txBody>
       </p:sp>
-      <p:pic>
-        <p:nvPicPr>
-          <p:cNvPr id="9" name="Image 8" descr="Une image contenant Police, Graphique, logo, graphisme&#10;&#10;Description générée automatiquement">
-            <a:extLst>
-              <a:ext uri="{FF2B5EF4-FFF2-40B4-BE49-F238E27FC236}">
-                <a16:creationId xmlns:a16="http://schemas.microsoft.com/office/drawing/2014/main" id="{5FA40CA5-18D5-ABCF-9EE1-BF9C0AE210FD}"/>
-              </a:ext>
-            </a:extLst>
-          </p:cNvPr>
-          <p:cNvPicPr>
-            <a:picLocks noChangeAspect="1"/>
-          </p:cNvPicPr>
-          <p:nvPr/>
-        </p:nvPicPr>
-        <p:blipFill>
-          <a:blip r:embed="rId3"/>
-          <a:srcRect t="19804" b="18118"/>
-          <a:stretch/>
-        </p:blipFill>
-        <p:spPr>
-          <a:xfrm>
-            <a:off x="10763987" y="98854"/>
-            <a:ext cx="1229053" cy="762977"/>
-          </a:xfrm>
-          <a:prstGeom prst="rect">
-            <a:avLst/>
-          </a:prstGeom>
-        </p:spPr>
-      </p:pic>
-      <p:pic>
-        <p:nvPicPr>
-          <p:cNvPr id="10" name="Picture 9">
-            <a:extLst>
-              <a:ext uri="{FF2B5EF4-FFF2-40B4-BE49-F238E27FC236}">
-                <a16:creationId xmlns:a16="http://schemas.microsoft.com/office/drawing/2014/main" id="{E922595D-B49E-4187-3566-440EF1D1B583}"/>
-              </a:ext>
-            </a:extLst>
-          </p:cNvPr>
-          <p:cNvPicPr>
-            <a:picLocks noChangeAspect="1"/>
-          </p:cNvPicPr>
-          <p:nvPr/>
-        </p:nvPicPr>
-        <p:blipFill>
-          <a:blip r:embed="rId4"/>
-          <a:stretch>
-            <a:fillRect/>
-          </a:stretch>
-        </p:blipFill>
-        <p:spPr>
-          <a:xfrm>
-            <a:off x="10546452" y="104580"/>
-            <a:ext cx="1552051" cy="758533"/>
-          </a:xfrm>
-          <a:prstGeom prst="rect">
-            <a:avLst/>
-          </a:prstGeom>
-        </p:spPr>
-      </p:pic>
     </p:spTree>
     <p:extLst>
       <p:ext uri="{BB962C8B-B14F-4D97-AF65-F5344CB8AC3E}">
@@ -7778,65 +7592,6 @@
           </a:fontRef>
         </p:style>
       </p:cxnSp>
-      <p:pic>
-        <p:nvPicPr>
-          <p:cNvPr id="14" name="Image 13" descr="Une image contenant Police, Graphique, logo, graphisme&#10;&#10;Description générée automatiquement">
-            <a:extLst>
-              <a:ext uri="{FF2B5EF4-FFF2-40B4-BE49-F238E27FC236}">
-                <a16:creationId xmlns:a16="http://schemas.microsoft.com/office/drawing/2014/main" id="{AD69CEB4-74D5-E3C0-685B-527FC6C4A3EF}"/>
-              </a:ext>
-            </a:extLst>
-          </p:cNvPr>
-          <p:cNvPicPr>
-            <a:picLocks noChangeAspect="1"/>
-          </p:cNvPicPr>
-          <p:nvPr/>
-        </p:nvPicPr>
-        <p:blipFill>
-          <a:blip r:embed="rId3"/>
-          <a:srcRect t="19804" b="18118"/>
-          <a:stretch/>
-        </p:blipFill>
-        <p:spPr>
-          <a:xfrm>
-            <a:off x="10763987" y="98854"/>
-            <a:ext cx="1229053" cy="762977"/>
-          </a:xfrm>
-          <a:prstGeom prst="rect">
-            <a:avLst/>
-          </a:prstGeom>
-        </p:spPr>
-      </p:pic>
-      <p:pic>
-        <p:nvPicPr>
-          <p:cNvPr id="5" name="Picture 4">
-            <a:extLst>
-              <a:ext uri="{FF2B5EF4-FFF2-40B4-BE49-F238E27FC236}">
-                <a16:creationId xmlns:a16="http://schemas.microsoft.com/office/drawing/2014/main" id="{DDFE2676-551D-F9A9-1060-DC00E3F770F9}"/>
-              </a:ext>
-            </a:extLst>
-          </p:cNvPr>
-          <p:cNvPicPr>
-            <a:picLocks noChangeAspect="1"/>
-          </p:cNvPicPr>
-          <p:nvPr/>
-        </p:nvPicPr>
-        <p:blipFill>
-          <a:blip r:embed="rId4"/>
-          <a:stretch>
-            <a:fillRect/>
-          </a:stretch>
-        </p:blipFill>
-        <p:spPr>
-          <a:xfrm>
-            <a:off x="10546452" y="104580"/>
-            <a:ext cx="1552051" cy="758533"/>
-          </a:xfrm>
-          <a:prstGeom prst="rect">
-            <a:avLst/>
-          </a:prstGeom>
-        </p:spPr>
-      </p:pic>
       <p:sp>
         <p:nvSpPr>
           <p:cNvPr id="2" name="zone_titre_fs_recap_estimation">
@@ -8512,6 +8267,36 @@
           </a:p>
         </p:txBody>
       </p:sp>
+      <p:pic>
+        <p:nvPicPr>
+          <p:cNvPr id="5" name="Picture 4">
+            <a:extLst>
+              <a:ext uri="{FF2B5EF4-FFF2-40B4-BE49-F238E27FC236}">
+                <a16:creationId xmlns:a16="http://schemas.microsoft.com/office/drawing/2014/main" id="{DDFE2676-551D-F9A9-1060-DC00E3F770F9}"/>
+              </a:ext>
+            </a:extLst>
+          </p:cNvPr>
+          <p:cNvPicPr>
+            <a:picLocks noChangeAspect="1"/>
+          </p:cNvPicPr>
+          <p:nvPr/>
+        </p:nvPicPr>
+        <p:blipFill>
+          <a:blip r:embed="rId3"/>
+          <a:stretch>
+            <a:fillRect/>
+          </a:stretch>
+        </p:blipFill>
+        <p:spPr>
+          <a:xfrm>
+            <a:off x="10546452" y="104580"/>
+            <a:ext cx="1552051" cy="758533"/>
+          </a:xfrm>
+          <a:prstGeom prst="rect">
+            <a:avLst/>
+          </a:prstGeom>
+        </p:spPr>
+      </p:pic>
     </p:spTree>
     <p:extLst>
       <p:ext uri="{BB962C8B-B14F-4D97-AF65-F5344CB8AC3E}">
@@ -8550,41 +8335,6 @@
       </p:grpSpPr>
       <p:sp>
         <p:nvSpPr>
-          <p:cNvPr id="3" name="Text 1">
-            <a:extLst>
-              <a:ext uri="{FF2B5EF4-FFF2-40B4-BE49-F238E27FC236}">
-                <a16:creationId xmlns:a16="http://schemas.microsoft.com/office/drawing/2014/main" id="{2CE7C914-9BAE-BFF2-E2E6-8DFEAA338D00}"/>
-              </a:ext>
-            </a:extLst>
-          </p:cNvPr>
-          <p:cNvSpPr/>
-          <p:nvPr/>
-        </p:nvSpPr>
-        <p:spPr>
-          <a:xfrm>
-            <a:off x="609600" y="975360"/>
-            <a:ext cx="10972800" cy="1950720"/>
-          </a:xfrm>
-          <a:prstGeom prst="rect">
-            <a:avLst/>
-          </a:prstGeom>
-          <a:noFill/>
-          <a:ln/>
-        </p:spPr>
-        <p:txBody>
-          <a:bodyPr wrap="square" lIns="0" tIns="0" rIns="0" bIns="0" rtlCol="0" anchor="ctr"/>
-          <a:lstStyle/>
-          <a:p>
-            <a:endParaRPr lang="en-US" sz="13333" dirty="0">
-              <a:latin typeface="Marianne" panose="02000000000000000000" pitchFamily="50" charset="0"/>
-              <a:ea typeface="Calibri" panose="020F0502020204030204" pitchFamily="34" charset="0"/>
-              <a:cs typeface="Calibri" panose="020F0502020204030204" pitchFamily="34" charset="0"/>
-            </a:endParaRPr>
-          </a:p>
-        </p:txBody>
-      </p:sp>
-      <p:sp>
-        <p:nvSpPr>
           <p:cNvPr id="4" name="Text 2">
             <a:extLst>
               <a:ext uri="{FF2B5EF4-FFF2-40B4-BE49-F238E27FC236}">
@@ -8845,10 +8595,10 @@
       </p:sp>
       <p:pic>
         <p:nvPicPr>
-          <p:cNvPr id="9" name="Image 8" descr="Une image contenant Police, Graphique, logo, graphisme&#10;&#10;Description générée automatiquement">
-            <a:extLst>
-              <a:ext uri="{FF2B5EF4-FFF2-40B4-BE49-F238E27FC236}">
-                <a16:creationId xmlns:a16="http://schemas.microsoft.com/office/drawing/2014/main" id="{5FA40CA5-18D5-ABCF-9EE1-BF9C0AE210FD}"/>
+          <p:cNvPr id="7" name="Picture 9">
+            <a:extLst>
+              <a:ext uri="{FF2B5EF4-FFF2-40B4-BE49-F238E27FC236}">
+                <a16:creationId xmlns:a16="http://schemas.microsoft.com/office/drawing/2014/main" id="{E922595D-B49E-4187-3566-440EF1D1B583}"/>
               </a:ext>
             </a:extLst>
           </p:cNvPr>
@@ -8859,35 +8609,6 @@
         </p:nvPicPr>
         <p:blipFill>
           <a:blip r:embed="rId3"/>
-          <a:srcRect t="19804" b="18118"/>
-          <a:stretch/>
-        </p:blipFill>
-        <p:spPr>
-          <a:xfrm>
-            <a:off x="10763987" y="98854"/>
-            <a:ext cx="1229053" cy="762977"/>
-          </a:xfrm>
-          <a:prstGeom prst="rect">
-            <a:avLst/>
-          </a:prstGeom>
-        </p:spPr>
-      </p:pic>
-      <p:pic>
-        <p:nvPicPr>
-          <p:cNvPr id="10" name="Picture 9">
-            <a:extLst>
-              <a:ext uri="{FF2B5EF4-FFF2-40B4-BE49-F238E27FC236}">
-                <a16:creationId xmlns:a16="http://schemas.microsoft.com/office/drawing/2014/main" id="{E922595D-B49E-4187-3566-440EF1D1B583}"/>
-              </a:ext>
-            </a:extLst>
-          </p:cNvPr>
-          <p:cNvPicPr>
-            <a:picLocks noChangeAspect="1"/>
-          </p:cNvPicPr>
-          <p:nvPr/>
-        </p:nvPicPr>
-        <p:blipFill>
-          <a:blip r:embed="rId4"/>
           <a:stretch>
             <a:fillRect/>
           </a:stretch>
@@ -9266,12 +8987,81 @@
           </a:p>
         </p:txBody>
       </p:sp>
+      <p:sp>
+        <p:nvSpPr>
+          <p:cNvPr id="7" name="zone_ressources_fiche_solution">
+            <a:extLst>
+              <a:ext uri="{FF2B5EF4-FFF2-40B4-BE49-F238E27FC236}">
+                <a16:creationId xmlns:a16="http://schemas.microsoft.com/office/drawing/2014/main" id="{67927841-950D-B96E-D880-93E461963945}"/>
+              </a:ext>
+            </a:extLst>
+          </p:cNvPr>
+          <p:cNvSpPr txBox="1"/>
+          <p:nvPr/>
+        </p:nvSpPr>
+        <p:spPr>
+          <a:xfrm>
+            <a:off x="839464" y="1626616"/>
+            <a:ext cx="9706988" cy="276999"/>
+          </a:xfrm>
+          <a:prstGeom prst="rect">
+            <a:avLst/>
+          </a:prstGeom>
+          <a:noFill/>
+        </p:spPr>
+        <p:txBody>
+          <a:bodyPr wrap="square">
+            <a:spAutoFit/>
+          </a:bodyPr>
+          <a:lstStyle/>
+          <a:p>
+            <a:r>
+              <a:rPr lang="fr-FR" sz="1200" dirty="0">
+                <a:solidFill>
+                  <a:srgbClr val="161616"/>
+                </a:solidFill>
+                <a:latin typeface="Marianne" panose="02000000000000000000" pitchFamily="50" charset="0"/>
+                <a:ea typeface="Calibri" panose="020F0502020204030204" pitchFamily="34" charset="0"/>
+                <a:cs typeface="Calibri" panose="020F0502020204030204" pitchFamily="34" charset="0"/>
+              </a:rPr>
+              <a:t>{{</a:t>
+            </a:r>
+            <a:r>
+              <a:rPr lang="fr-FR" sz="1200" dirty="0" err="1">
+                <a:solidFill>
+                  <a:srgbClr val="161616"/>
+                </a:solidFill>
+                <a:latin typeface="Marianne" panose="02000000000000000000" pitchFamily="50" charset="0"/>
+                <a:ea typeface="Calibri" panose="020F0502020204030204" pitchFamily="34" charset="0"/>
+                <a:cs typeface="Calibri" panose="020F0502020204030204" pitchFamily="34" charset="0"/>
+              </a:rPr>
+              <a:t>ressources_utiles_fiche_solution</a:t>
+            </a:r>
+            <a:r>
+              <a:rPr lang="fr-FR" sz="1200" dirty="0">
+                <a:solidFill>
+                  <a:srgbClr val="161616"/>
+                </a:solidFill>
+                <a:latin typeface="Marianne" panose="02000000000000000000" pitchFamily="50" charset="0"/>
+                <a:ea typeface="Calibri" panose="020F0502020204030204" pitchFamily="34" charset="0"/>
+                <a:cs typeface="Calibri" panose="020F0502020204030204" pitchFamily="34" charset="0"/>
+              </a:rPr>
+              <a:t>}}</a:t>
+            </a:r>
+            <a:endParaRPr lang="fr-FR" sz="1200" dirty="0">
+              <a:latin typeface="Marianne" panose="02000000000000000000" pitchFamily="50" charset="0"/>
+              <a:ea typeface="Calibri" panose="020F0502020204030204" pitchFamily="34" charset="0"/>
+              <a:cs typeface="Calibri" panose="020F0502020204030204" pitchFamily="34" charset="0"/>
+            </a:endParaRPr>
+          </a:p>
+        </p:txBody>
+      </p:sp>
       <p:pic>
         <p:nvPicPr>
-          <p:cNvPr id="57" name="Image 56" descr="Une image contenant Police, Graphique, logo, graphisme&#10;&#10;Description générée automatiquement">
-            <a:extLst>
-              <a:ext uri="{FF2B5EF4-FFF2-40B4-BE49-F238E27FC236}">
-                <a16:creationId xmlns:a16="http://schemas.microsoft.com/office/drawing/2014/main" id="{830EBC68-A5C6-15CA-95C1-839F0A7C9BA7}"/>
+          <p:cNvPr id="3" name="Picture 3">
+            <a:extLst>
+              <a:ext uri="{FF2B5EF4-FFF2-40B4-BE49-F238E27FC236}">
+                <a16:creationId xmlns:a16="http://schemas.microsoft.com/office/drawing/2014/main" id="{7D131FE9-968A-7934-D330-1035AA73A364}"/>
               </a:ext>
             </a:extLst>
           </p:cNvPr>
@@ -9282,35 +9072,6 @@
         </p:nvPicPr>
         <p:blipFill>
           <a:blip r:embed="rId2"/>
-          <a:srcRect t="19804" b="18118"/>
-          <a:stretch/>
-        </p:blipFill>
-        <p:spPr>
-          <a:xfrm>
-            <a:off x="10763987" y="98854"/>
-            <a:ext cx="1229053" cy="762977"/>
-          </a:xfrm>
-          <a:prstGeom prst="rect">
-            <a:avLst/>
-          </a:prstGeom>
-        </p:spPr>
-      </p:pic>
-      <p:pic>
-        <p:nvPicPr>
-          <p:cNvPr id="4" name="Picture 3">
-            <a:extLst>
-              <a:ext uri="{FF2B5EF4-FFF2-40B4-BE49-F238E27FC236}">
-                <a16:creationId xmlns:a16="http://schemas.microsoft.com/office/drawing/2014/main" id="{7D131FE9-968A-7934-D330-1035AA73A364}"/>
-              </a:ext>
-            </a:extLst>
-          </p:cNvPr>
-          <p:cNvPicPr>
-            <a:picLocks noChangeAspect="1"/>
-          </p:cNvPicPr>
-          <p:nvPr/>
-        </p:nvPicPr>
-        <p:blipFill>
-          <a:blip r:embed="rId3"/>
           <a:stretch>
             <a:fillRect/>
           </a:stretch>
@@ -9325,75 +9086,6 @@
           </a:prstGeom>
         </p:spPr>
       </p:pic>
-      <p:sp>
-        <p:nvSpPr>
-          <p:cNvPr id="7" name="zone_ressources_fiche_solution">
-            <a:extLst>
-              <a:ext uri="{FF2B5EF4-FFF2-40B4-BE49-F238E27FC236}">
-                <a16:creationId xmlns:a16="http://schemas.microsoft.com/office/drawing/2014/main" id="{67927841-950D-B96E-D880-93E461963945}"/>
-              </a:ext>
-            </a:extLst>
-          </p:cNvPr>
-          <p:cNvSpPr txBox="1"/>
-          <p:nvPr/>
-        </p:nvSpPr>
-        <p:spPr>
-          <a:xfrm>
-            <a:off x="839464" y="1626616"/>
-            <a:ext cx="9706988" cy="276999"/>
-          </a:xfrm>
-          <a:prstGeom prst="rect">
-            <a:avLst/>
-          </a:prstGeom>
-          <a:noFill/>
-        </p:spPr>
-        <p:txBody>
-          <a:bodyPr wrap="square">
-            <a:spAutoFit/>
-          </a:bodyPr>
-          <a:lstStyle/>
-          <a:p>
-            <a:r>
-              <a:rPr lang="fr-FR" sz="1200" dirty="0">
-                <a:solidFill>
-                  <a:srgbClr val="161616"/>
-                </a:solidFill>
-                <a:latin typeface="Marianne" panose="02000000000000000000" pitchFamily="50" charset="0"/>
-                <a:ea typeface="Calibri" panose="020F0502020204030204" pitchFamily="34" charset="0"/>
-                <a:cs typeface="Calibri" panose="020F0502020204030204" pitchFamily="34" charset="0"/>
-              </a:rPr>
-              <a:t>{{</a:t>
-            </a:r>
-            <a:r>
-              <a:rPr lang="fr-FR" sz="1200" dirty="0" err="1">
-                <a:solidFill>
-                  <a:srgbClr val="161616"/>
-                </a:solidFill>
-                <a:latin typeface="Marianne" panose="02000000000000000000" pitchFamily="50" charset="0"/>
-                <a:ea typeface="Calibri" panose="020F0502020204030204" pitchFamily="34" charset="0"/>
-                <a:cs typeface="Calibri" panose="020F0502020204030204" pitchFamily="34" charset="0"/>
-              </a:rPr>
-              <a:t>ressources_utiles_fiche_solution</a:t>
-            </a:r>
-            <a:r>
-              <a:rPr lang="fr-FR" sz="1200" dirty="0">
-                <a:solidFill>
-                  <a:srgbClr val="161616"/>
-                </a:solidFill>
-                <a:latin typeface="Marianne" panose="02000000000000000000" pitchFamily="50" charset="0"/>
-                <a:ea typeface="Calibri" panose="020F0502020204030204" pitchFamily="34" charset="0"/>
-                <a:cs typeface="Calibri" panose="020F0502020204030204" pitchFamily="34" charset="0"/>
-              </a:rPr>
-              <a:t>}}</a:t>
-            </a:r>
-            <a:endParaRPr lang="fr-FR" sz="1200" dirty="0">
-              <a:latin typeface="Marianne" panose="02000000000000000000" pitchFamily="50" charset="0"/>
-              <a:ea typeface="Calibri" panose="020F0502020204030204" pitchFamily="34" charset="0"/>
-              <a:cs typeface="Calibri" panose="020F0502020204030204" pitchFamily="34" charset="0"/>
-            </a:endParaRPr>
-          </a:p>
-        </p:txBody>
-      </p:sp>
     </p:spTree>
     <p:extLst>
       <p:ext uri="{BB962C8B-B14F-4D97-AF65-F5344CB8AC3E}">

</xml_diff>

<commit_message>
feat: rajout des slides pour les aides
</commit_message>
<xml_diff>
--- a/public/templates/template_synthese_projet.pptx
+++ b/public/templates/template_synthese_projet.pptx
@@ -5,7 +5,7 @@
     <p:sldMasterId id="2147483648" r:id="rId1"/>
   </p:sldMasterIdLst>
   <p:notesMasterIdLst>
-    <p:notesMasterId r:id="rId10"/>
+    <p:notesMasterId r:id="rId12"/>
   </p:notesMasterIdLst>
   <p:sldIdLst>
     <p:sldId id="256" r:id="rId2"/>
@@ -14,8 +14,10 @@
     <p:sldId id="270" r:id="rId5"/>
     <p:sldId id="274" r:id="rId6"/>
     <p:sldId id="275" r:id="rId7"/>
-    <p:sldId id="276" r:id="rId8"/>
-    <p:sldId id="277" r:id="rId9"/>
+    <p:sldId id="278" r:id="rId8"/>
+    <p:sldId id="265" r:id="rId9"/>
+    <p:sldId id="276" r:id="rId10"/>
+    <p:sldId id="277" r:id="rId11"/>
   </p:sldIdLst>
   <p:sldSz cx="12192000" cy="6858000"/>
   <p:notesSz cx="6858000" cy="9144000"/>
@@ -213,7 +215,7 @@
           <a:p>
             <a:fld id="{4C638A9C-6ED0-4718-B5E7-9D405962C144}" type="datetimeFigureOut">
               <a:rPr lang="fr-FR" smtClean="0"/>
-              <a:t>15/09/2026</a:t>
+              <a:t>18/09/2026</a:t>
             </a:fld>
             <a:endParaRPr lang="fr-FR"/>
           </a:p>
@@ -794,6 +796,114 @@
     </p:spTree>
     <p:extLst>
       <p:ext uri="{BB962C8B-B14F-4D97-AF65-F5344CB8AC3E}">
+        <p14:creationId xmlns:p14="http://schemas.microsoft.com/office/powerpoint/2010/main" val="3046060735"/>
+      </p:ext>
+    </p:extLst>
+  </p:cSld>
+  <p:clrMapOvr>
+    <a:masterClrMapping/>
+  </p:clrMapOvr>
+</p:notes>
+</file>
+
+<file path=ppt/notesSlides/notesSlide4.xml><?xml version="1.0" encoding="utf-8"?>
+<p:notes xmlns:a="http://schemas.openxmlformats.org/drawingml/2006/main" xmlns:r="http://schemas.openxmlformats.org/officeDocument/2006/relationships" xmlns:p="http://schemas.openxmlformats.org/presentationml/2006/main">
+  <p:cSld>
+    <p:spTree>
+      <p:nvGrpSpPr>
+        <p:cNvPr id="1" name="">
+          <a:extLst>
+            <a:ext uri="{FF2B5EF4-FFF2-40B4-BE49-F238E27FC236}">
+              <a16:creationId xmlns:a16="http://schemas.microsoft.com/office/drawing/2014/main" id="{048D1F06-EBEC-48E7-718E-679E9C7AB652}"/>
+            </a:ext>
+          </a:extLst>
+        </p:cNvPr>
+        <p:cNvGrpSpPr/>
+        <p:nvPr/>
+      </p:nvGrpSpPr>
+      <p:grpSpPr>
+        <a:xfrm>
+          <a:off x="0" y="0"/>
+          <a:ext cx="0" cy="0"/>
+          <a:chOff x="0" y="0"/>
+          <a:chExt cx="0" cy="0"/>
+        </a:xfrm>
+      </p:grpSpPr>
+      <p:sp>
+        <p:nvSpPr>
+          <p:cNvPr id="2" name="Slide Image Placeholder 1">
+            <a:extLst>
+              <a:ext uri="{FF2B5EF4-FFF2-40B4-BE49-F238E27FC236}">
+                <a16:creationId xmlns:a16="http://schemas.microsoft.com/office/drawing/2014/main" id="{15188976-03C7-BDC5-F35A-502E38D967CC}"/>
+              </a:ext>
+            </a:extLst>
+          </p:cNvPr>
+          <p:cNvSpPr>
+            <a:spLocks noGrp="1" noRot="1" noChangeAspect="1"/>
+          </p:cNvSpPr>
+          <p:nvPr>
+            <p:ph type="sldImg"/>
+          </p:nvPr>
+        </p:nvSpPr>
+        <p:spPr/>
+      </p:sp>
+      <p:sp>
+        <p:nvSpPr>
+          <p:cNvPr id="3" name="Notes Placeholder 2">
+            <a:extLst>
+              <a:ext uri="{FF2B5EF4-FFF2-40B4-BE49-F238E27FC236}">
+                <a16:creationId xmlns:a16="http://schemas.microsoft.com/office/drawing/2014/main" id="{32392900-84C4-792B-45B3-9A38832A4769}"/>
+              </a:ext>
+            </a:extLst>
+          </p:cNvPr>
+          <p:cNvSpPr>
+            <a:spLocks noGrp="1"/>
+          </p:cNvSpPr>
+          <p:nvPr>
+            <p:ph type="body" idx="1"/>
+          </p:nvPr>
+        </p:nvSpPr>
+        <p:spPr/>
+        <p:txBody>
+          <a:bodyPr/>
+          <a:lstStyle/>
+          <a:p>
+            <a:endParaRPr lang="en-US"/>
+          </a:p>
+        </p:txBody>
+      </p:sp>
+      <p:sp>
+        <p:nvSpPr>
+          <p:cNvPr id="4" name="Slide Number Placeholder 3">
+            <a:extLst>
+              <a:ext uri="{FF2B5EF4-FFF2-40B4-BE49-F238E27FC236}">
+                <a16:creationId xmlns:a16="http://schemas.microsoft.com/office/drawing/2014/main" id="{FD3A749C-0CD8-8944-6CB6-BFC00D52AF73}"/>
+              </a:ext>
+            </a:extLst>
+          </p:cNvPr>
+          <p:cNvSpPr>
+            <a:spLocks noGrp="1"/>
+          </p:cNvSpPr>
+          <p:nvPr>
+            <p:ph type="sldNum" sz="quarter" idx="10"/>
+          </p:nvPr>
+        </p:nvSpPr>
+        <p:spPr/>
+        <p:txBody>
+          <a:bodyPr/>
+          <a:lstStyle/>
+          <a:p>
+            <a:fld id="{F7021451-1387-4CA6-816F-3879F97B5CBC}" type="slidenum">
+              <a:rPr lang="en-US"/>
+              <a:t>9</a:t>
+            </a:fld>
+            <a:endParaRPr lang="en-US"/>
+          </a:p>
+        </p:txBody>
+      </p:sp>
+    </p:spTree>
+    <p:extLst>
+      <p:ext uri="{BB962C8B-B14F-4D97-AF65-F5344CB8AC3E}">
         <p14:creationId xmlns:p14="http://schemas.microsoft.com/office/powerpoint/2010/main" val="1503641096"/>
       </p:ext>
     </p:extLst>
@@ -951,7 +1061,7 @@
           <a:p>
             <a:fld id="{82E7F8B9-DFDB-4965-877D-C04A580740C9}" type="datetimeFigureOut">
               <a:rPr lang="fr-FR" smtClean="0"/>
-              <a:t>15/09/2026</a:t>
+              <a:t>18/09/2026</a:t>
             </a:fld>
             <a:endParaRPr lang="fr-FR"/>
           </a:p>
@@ -1149,7 +1259,7 @@
           <a:p>
             <a:fld id="{82E7F8B9-DFDB-4965-877D-C04A580740C9}" type="datetimeFigureOut">
               <a:rPr lang="fr-FR" smtClean="0"/>
-              <a:t>15/09/2026</a:t>
+              <a:t>18/09/2026</a:t>
             </a:fld>
             <a:endParaRPr lang="fr-FR"/>
           </a:p>
@@ -1357,7 +1467,7 @@
           <a:p>
             <a:fld id="{82E7F8B9-DFDB-4965-877D-C04A580740C9}" type="datetimeFigureOut">
               <a:rPr lang="fr-FR" smtClean="0"/>
-              <a:t>15/09/2026</a:t>
+              <a:t>18/09/2026</a:t>
             </a:fld>
             <a:endParaRPr lang="fr-FR"/>
           </a:p>
@@ -1590,7 +1700,7 @@
           <a:p>
             <a:fld id="{82E7F8B9-DFDB-4965-877D-C04A580740C9}" type="datetimeFigureOut">
               <a:rPr lang="fr-FR" smtClean="0"/>
-              <a:t>15/09/2026</a:t>
+              <a:t>18/09/2026</a:t>
             </a:fld>
             <a:endParaRPr lang="fr-FR"/>
           </a:p>
@@ -1865,7 +1975,7 @@
           <a:p>
             <a:fld id="{82E7F8B9-DFDB-4965-877D-C04A580740C9}" type="datetimeFigureOut">
               <a:rPr lang="fr-FR" smtClean="0"/>
-              <a:t>15/09/2026</a:t>
+              <a:t>18/09/2026</a:t>
             </a:fld>
             <a:endParaRPr lang="fr-FR"/>
           </a:p>
@@ -2130,7 +2240,7 @@
           <a:p>
             <a:fld id="{82E7F8B9-DFDB-4965-877D-C04A580740C9}" type="datetimeFigureOut">
               <a:rPr lang="fr-FR" smtClean="0"/>
-              <a:t>15/09/2026</a:t>
+              <a:t>18/09/2026</a:t>
             </a:fld>
             <a:endParaRPr lang="fr-FR"/>
           </a:p>
@@ -2542,7 +2652,7 @@
           <a:p>
             <a:fld id="{82E7F8B9-DFDB-4965-877D-C04A580740C9}" type="datetimeFigureOut">
               <a:rPr lang="fr-FR" smtClean="0"/>
-              <a:t>15/09/2026</a:t>
+              <a:t>18/09/2026</a:t>
             </a:fld>
             <a:endParaRPr lang="fr-FR"/>
           </a:p>
@@ -2683,7 +2793,7 @@
           <a:p>
             <a:fld id="{82E7F8B9-DFDB-4965-877D-C04A580740C9}" type="datetimeFigureOut">
               <a:rPr lang="fr-FR" smtClean="0"/>
-              <a:t>15/09/2026</a:t>
+              <a:t>18/09/2026</a:t>
             </a:fld>
             <a:endParaRPr lang="fr-FR"/>
           </a:p>
@@ -2796,7 +2906,7 @@
           <a:p>
             <a:fld id="{82E7F8B9-DFDB-4965-877D-C04A580740C9}" type="datetimeFigureOut">
               <a:rPr lang="fr-FR" smtClean="0"/>
-              <a:t>15/09/2026</a:t>
+              <a:t>18/09/2026</a:t>
             </a:fld>
             <a:endParaRPr lang="fr-FR"/>
           </a:p>
@@ -3107,7 +3217,7 @@
           <a:p>
             <a:fld id="{82E7F8B9-DFDB-4965-877D-C04A580740C9}" type="datetimeFigureOut">
               <a:rPr lang="fr-FR" smtClean="0"/>
-              <a:t>15/09/2026</a:t>
+              <a:t>18/09/2026</a:t>
             </a:fld>
             <a:endParaRPr lang="fr-FR"/>
           </a:p>
@@ -3395,7 +3505,7 @@
           <a:p>
             <a:fld id="{82E7F8B9-DFDB-4965-877D-C04A580740C9}" type="datetimeFigureOut">
               <a:rPr lang="fr-FR" smtClean="0"/>
-              <a:t>15/09/2026</a:t>
+              <a:t>18/09/2026</a:t>
             </a:fld>
             <a:endParaRPr lang="fr-FR"/>
           </a:p>
@@ -3636,7 +3746,7 @@
           <a:p>
             <a:fld id="{82E7F8B9-DFDB-4965-877D-C04A580740C9}" type="datetimeFigureOut">
               <a:rPr lang="fr-FR" smtClean="0"/>
-              <a:t>15/09/2026</a:t>
+              <a:t>18/09/2026</a:t>
             </a:fld>
             <a:endParaRPr lang="fr-FR"/>
           </a:p>
@@ -4425,6 +4535,469 @@
 </p:sld>
 </file>
 
+<file path=ppt/slides/slide10.xml><?xml version="1.0" encoding="utf-8"?>
+<p:sld xmlns:a="http://schemas.openxmlformats.org/drawingml/2006/main" xmlns:r="http://schemas.openxmlformats.org/officeDocument/2006/relationships" xmlns:p="http://schemas.openxmlformats.org/presentationml/2006/main">
+  <p:cSld>
+    <p:spTree>
+      <p:nvGrpSpPr>
+        <p:cNvPr id="1" name="">
+          <a:extLst>
+            <a:ext uri="{FF2B5EF4-FFF2-40B4-BE49-F238E27FC236}">
+              <a16:creationId xmlns:a16="http://schemas.microsoft.com/office/drawing/2014/main" id="{1917CAA9-6ECD-8F49-8289-13579AAE1FB7}"/>
+            </a:ext>
+          </a:extLst>
+        </p:cNvPr>
+        <p:cNvGrpSpPr/>
+        <p:nvPr/>
+      </p:nvGrpSpPr>
+      <p:grpSpPr>
+        <a:xfrm>
+          <a:off x="0" y="0"/>
+          <a:ext cx="0" cy="0"/>
+          <a:chOff x="0" y="0"/>
+          <a:chExt cx="0" cy="0"/>
+        </a:xfrm>
+      </p:grpSpPr>
+      <p:sp>
+        <p:nvSpPr>
+          <p:cNvPr id="2" name="Titre 1">
+            <a:extLst>
+              <a:ext uri="{FF2B5EF4-FFF2-40B4-BE49-F238E27FC236}">
+                <a16:creationId xmlns:a16="http://schemas.microsoft.com/office/drawing/2014/main" id="{474A7BA3-D950-9097-DDDD-F688CBFCCB67}"/>
+              </a:ext>
+            </a:extLst>
+          </p:cNvPr>
+          <p:cNvSpPr>
+            <a:spLocks noGrp="1"/>
+          </p:cNvSpPr>
+          <p:nvPr>
+            <p:ph type="title"/>
+          </p:nvPr>
+        </p:nvSpPr>
+        <p:spPr>
+          <a:xfrm>
+            <a:off x="576263" y="345395"/>
+            <a:ext cx="10031656" cy="615294"/>
+          </a:xfrm>
+        </p:spPr>
+        <p:txBody>
+          <a:bodyPr>
+            <a:normAutofit/>
+          </a:bodyPr>
+          <a:lstStyle/>
+          <a:p>
+            <a:pPr marL="0" indent="0">
+              <a:buNone/>
+            </a:pPr>
+            <a:r>
+              <a:rPr lang="en-US" sz="2800" dirty="0" err="1">
+                <a:latin typeface="Marianne" panose="02000000000000000000" pitchFamily="50" charset="0"/>
+              </a:rPr>
+              <a:t>Ressources</a:t>
+            </a:r>
+            <a:r>
+              <a:rPr lang="en-US" sz="2800" dirty="0">
+                <a:latin typeface="Marianne" panose="02000000000000000000" pitchFamily="50" charset="0"/>
+              </a:rPr>
+              <a:t> </a:t>
+            </a:r>
+            <a:r>
+              <a:rPr lang="en-US" sz="2800" dirty="0" err="1">
+                <a:latin typeface="Marianne" panose="02000000000000000000" pitchFamily="50" charset="0"/>
+              </a:rPr>
+              <a:t>utiles</a:t>
+            </a:r>
+            <a:r>
+              <a:rPr lang="en-US" sz="2800" dirty="0">
+                <a:latin typeface="Marianne" panose="02000000000000000000" pitchFamily="50" charset="0"/>
+                <a:ea typeface="Calibri" panose="020F0502020204030204" pitchFamily="34" charset="0"/>
+                <a:cs typeface="Calibri" panose="020F0502020204030204" pitchFamily="34" charset="0"/>
+              </a:rPr>
+              <a:t> {{</a:t>
+            </a:r>
+            <a:r>
+              <a:rPr lang="en-US" sz="2800" dirty="0" err="1">
+                <a:latin typeface="Marianne" panose="02000000000000000000" pitchFamily="50" charset="0"/>
+                <a:ea typeface="Calibri" panose="020F0502020204030204" pitchFamily="34" charset="0"/>
+                <a:cs typeface="Calibri" panose="020F0502020204030204" pitchFamily="34" charset="0"/>
+              </a:rPr>
+              <a:t>pagination_ressources_utiles</a:t>
+            </a:r>
+            <a:r>
+              <a:rPr lang="en-US" sz="2800" dirty="0">
+                <a:latin typeface="Marianne" panose="02000000000000000000" pitchFamily="50" charset="0"/>
+                <a:ea typeface="Calibri" panose="020F0502020204030204" pitchFamily="34" charset="0"/>
+                <a:cs typeface="Calibri" panose="020F0502020204030204" pitchFamily="34" charset="0"/>
+              </a:rPr>
+              <a:t>}}</a:t>
+            </a:r>
+          </a:p>
+        </p:txBody>
+      </p:sp>
+      <p:sp>
+        <p:nvSpPr>
+          <p:cNvPr id="5" name="zone_titre_fiche_solution">
+            <a:extLst>
+              <a:ext uri="{FF2B5EF4-FFF2-40B4-BE49-F238E27FC236}">
+                <a16:creationId xmlns:a16="http://schemas.microsoft.com/office/drawing/2014/main" id="{C76718D3-101C-1B45-FD71-3691F60DE7E5}"/>
+              </a:ext>
+            </a:extLst>
+          </p:cNvPr>
+          <p:cNvSpPr txBox="1"/>
+          <p:nvPr/>
+        </p:nvSpPr>
+        <p:spPr>
+          <a:xfrm>
+            <a:off x="576263" y="1093598"/>
+            <a:ext cx="9706988" cy="400110"/>
+          </a:xfrm>
+          <a:prstGeom prst="rect">
+            <a:avLst/>
+          </a:prstGeom>
+          <a:noFill/>
+        </p:spPr>
+        <p:txBody>
+          <a:bodyPr wrap="square">
+            <a:spAutoFit/>
+          </a:bodyPr>
+          <a:lstStyle/>
+          <a:p>
+            <a:r>
+              <a:rPr lang="fr-FR" sz="2000" b="1" dirty="0">
+                <a:solidFill>
+                  <a:srgbClr val="161616"/>
+                </a:solidFill>
+                <a:latin typeface="Marianne" panose="02000000000000000000" pitchFamily="50" charset="0"/>
+                <a:ea typeface="Calibri" panose="020F0502020204030204" pitchFamily="34" charset="0"/>
+                <a:cs typeface="Calibri" panose="020F0502020204030204" pitchFamily="34" charset="0"/>
+              </a:rPr>
+              <a:t>{{</a:t>
+            </a:r>
+            <a:r>
+              <a:rPr lang="fr-FR" sz="2000" b="1" dirty="0" err="1">
+                <a:solidFill>
+                  <a:srgbClr val="161616"/>
+                </a:solidFill>
+                <a:latin typeface="Marianne" panose="02000000000000000000" pitchFamily="50" charset="0"/>
+                <a:ea typeface="Calibri" panose="020F0502020204030204" pitchFamily="34" charset="0"/>
+                <a:cs typeface="Calibri" panose="020F0502020204030204" pitchFamily="34" charset="0"/>
+              </a:rPr>
+              <a:t>titre_fiche_solution</a:t>
+            </a:r>
+            <a:r>
+              <a:rPr lang="fr-FR" sz="2000" b="1" dirty="0">
+                <a:solidFill>
+                  <a:srgbClr val="161616"/>
+                </a:solidFill>
+                <a:latin typeface="Marianne" panose="02000000000000000000" pitchFamily="50" charset="0"/>
+                <a:ea typeface="Calibri" panose="020F0502020204030204" pitchFamily="34" charset="0"/>
+                <a:cs typeface="Calibri" panose="020F0502020204030204" pitchFamily="34" charset="0"/>
+              </a:rPr>
+              <a:t>}}</a:t>
+            </a:r>
+            <a:endParaRPr lang="fr-FR" sz="2000" dirty="0">
+              <a:latin typeface="Marianne" panose="02000000000000000000" pitchFamily="50" charset="0"/>
+              <a:ea typeface="Calibri" panose="020F0502020204030204" pitchFamily="34" charset="0"/>
+              <a:cs typeface="Calibri" panose="020F0502020204030204" pitchFamily="34" charset="0"/>
+            </a:endParaRPr>
+          </a:p>
+        </p:txBody>
+      </p:sp>
+      <p:cxnSp>
+        <p:nvCxnSpPr>
+          <p:cNvPr id="34" name="Connecteur droit 33">
+            <a:extLst>
+              <a:ext uri="{FF2B5EF4-FFF2-40B4-BE49-F238E27FC236}">
+                <a16:creationId xmlns:a16="http://schemas.microsoft.com/office/drawing/2014/main" id="{B62F42A1-9E9E-D546-190A-5C7D09368113}"/>
+              </a:ext>
+            </a:extLst>
+          </p:cNvPr>
+          <p:cNvCxnSpPr>
+            <a:cxnSpLocks/>
+          </p:cNvCxnSpPr>
+          <p:nvPr/>
+        </p:nvCxnSpPr>
+        <p:spPr>
+          <a:xfrm>
+            <a:off x="576263" y="960689"/>
+            <a:ext cx="11615737" cy="0"/>
+          </a:xfrm>
+          <a:prstGeom prst="line">
+            <a:avLst/>
+          </a:prstGeom>
+          <a:ln>
+            <a:solidFill>
+              <a:schemeClr val="bg1">
+                <a:lumMod val="85000"/>
+              </a:schemeClr>
+            </a:solidFill>
+          </a:ln>
+        </p:spPr>
+        <p:style>
+          <a:lnRef idx="2">
+            <a:schemeClr val="accent1"/>
+          </a:lnRef>
+          <a:fillRef idx="0">
+            <a:schemeClr val="accent1"/>
+          </a:fillRef>
+          <a:effectRef idx="1">
+            <a:schemeClr val="accent1"/>
+          </a:effectRef>
+          <a:fontRef idx="minor">
+            <a:schemeClr val="tx1"/>
+          </a:fontRef>
+        </p:style>
+      </p:cxnSp>
+      <p:cxnSp>
+        <p:nvCxnSpPr>
+          <p:cNvPr id="55" name="Connecteur droit 54">
+            <a:extLst>
+              <a:ext uri="{FF2B5EF4-FFF2-40B4-BE49-F238E27FC236}">
+                <a16:creationId xmlns:a16="http://schemas.microsoft.com/office/drawing/2014/main" id="{BFBD2EB6-34B6-54D8-319B-95BBA847CB21}"/>
+              </a:ext>
+            </a:extLst>
+          </p:cNvPr>
+          <p:cNvCxnSpPr>
+            <a:cxnSpLocks/>
+          </p:cNvCxnSpPr>
+          <p:nvPr/>
+        </p:nvCxnSpPr>
+        <p:spPr>
+          <a:xfrm>
+            <a:off x="576263" y="6512991"/>
+            <a:ext cx="11615737" cy="0"/>
+          </a:xfrm>
+          <a:prstGeom prst="line">
+            <a:avLst/>
+          </a:prstGeom>
+          <a:ln>
+            <a:solidFill>
+              <a:schemeClr val="bg1">
+                <a:lumMod val="85000"/>
+              </a:schemeClr>
+            </a:solidFill>
+          </a:ln>
+        </p:spPr>
+        <p:style>
+          <a:lnRef idx="2">
+            <a:schemeClr val="accent1"/>
+          </a:lnRef>
+          <a:fillRef idx="0">
+            <a:schemeClr val="accent1"/>
+          </a:fillRef>
+          <a:effectRef idx="1">
+            <a:schemeClr val="accent1"/>
+          </a:effectRef>
+          <a:fontRef idx="minor">
+            <a:schemeClr val="tx1"/>
+          </a:fontRef>
+        </p:style>
+      </p:cxnSp>
+      <p:sp>
+        <p:nvSpPr>
+          <p:cNvPr id="56" name="Text 3">
+            <a:extLst>
+              <a:ext uri="{FF2B5EF4-FFF2-40B4-BE49-F238E27FC236}">
+                <a16:creationId xmlns:a16="http://schemas.microsoft.com/office/drawing/2014/main" id="{8B657D20-7F9C-8851-0BA6-B35DF1DB8D17}"/>
+              </a:ext>
+            </a:extLst>
+          </p:cNvPr>
+          <p:cNvSpPr/>
+          <p:nvPr/>
+        </p:nvSpPr>
+        <p:spPr>
+          <a:xfrm>
+            <a:off x="576263" y="6598217"/>
+            <a:ext cx="8229600" cy="182880"/>
+          </a:xfrm>
+          <a:prstGeom prst="rect">
+            <a:avLst/>
+          </a:prstGeom>
+          <a:noFill/>
+          <a:ln/>
+        </p:spPr>
+        <p:txBody>
+          <a:bodyPr wrap="square" lIns="0" tIns="0" rIns="0" bIns="0" rtlCol="0" anchor="ctr"/>
+          <a:lstStyle/>
+          <a:p>
+            <a:pPr marL="0" indent="0">
+              <a:buNone/>
+            </a:pPr>
+            <a:r>
+              <a:rPr lang="en-US" sz="1000" i="1" dirty="0">
+                <a:solidFill>
+                  <a:srgbClr val="A0A0A0"/>
+                </a:solidFill>
+                <a:latin typeface="Marianne" panose="02000000000000000000" pitchFamily="50" charset="0"/>
+                <a:ea typeface="Calibri" panose="020F0502020204030204" pitchFamily="34" charset="0"/>
+                <a:cs typeface="Calibri" panose="020F0502020204030204" pitchFamily="34" charset="0"/>
+              </a:rPr>
+              <a:t>Données issues de Plus </a:t>
+            </a:r>
+            <a:r>
+              <a:rPr lang="en-US" sz="1000" i="1" dirty="0" err="1">
+                <a:solidFill>
+                  <a:srgbClr val="A0A0A0"/>
+                </a:solidFill>
+                <a:latin typeface="Marianne" panose="02000000000000000000" pitchFamily="50" charset="0"/>
+                <a:ea typeface="Calibri" panose="020F0502020204030204" pitchFamily="34" charset="0"/>
+                <a:cs typeface="Calibri" panose="020F0502020204030204" pitchFamily="34" charset="0"/>
+              </a:rPr>
+              <a:t>fraîche</a:t>
+            </a:r>
+            <a:r>
+              <a:rPr lang="en-US" sz="1000" i="1" dirty="0">
+                <a:solidFill>
+                  <a:srgbClr val="A0A0A0"/>
+                </a:solidFill>
+                <a:latin typeface="Marianne" panose="02000000000000000000" pitchFamily="50" charset="0"/>
+                <a:ea typeface="Calibri" panose="020F0502020204030204" pitchFamily="34" charset="0"/>
+                <a:cs typeface="Calibri" panose="020F0502020204030204" pitchFamily="34" charset="0"/>
+              </a:rPr>
+              <a:t> ma </a:t>
+            </a:r>
+            <a:r>
+              <a:rPr lang="en-US" sz="1000" i="1" dirty="0" err="1">
+                <a:solidFill>
+                  <a:srgbClr val="A0A0A0"/>
+                </a:solidFill>
+                <a:latin typeface="Marianne" panose="02000000000000000000" pitchFamily="50" charset="0"/>
+                <a:ea typeface="Calibri" panose="020F0502020204030204" pitchFamily="34" charset="0"/>
+                <a:cs typeface="Calibri" panose="020F0502020204030204" pitchFamily="34" charset="0"/>
+              </a:rPr>
+              <a:t>ville</a:t>
+            </a:r>
+            <a:r>
+              <a:rPr lang="en-US" sz="1000" i="1" dirty="0">
+                <a:solidFill>
+                  <a:srgbClr val="A0A0A0"/>
+                </a:solidFill>
+                <a:latin typeface="Marianne" panose="02000000000000000000" pitchFamily="50" charset="0"/>
+                <a:ea typeface="Calibri" panose="020F0502020204030204" pitchFamily="34" charset="0"/>
+                <a:cs typeface="Calibri" panose="020F0502020204030204" pitchFamily="34" charset="0"/>
+              </a:rPr>
+              <a:t> (ADEME)</a:t>
+            </a:r>
+            <a:endParaRPr lang="en-US" sz="1000" dirty="0">
+              <a:latin typeface="Marianne" panose="02000000000000000000" pitchFamily="50" charset="0"/>
+              <a:ea typeface="Calibri" panose="020F0502020204030204" pitchFamily="34" charset="0"/>
+              <a:cs typeface="Calibri" panose="020F0502020204030204" pitchFamily="34" charset="0"/>
+            </a:endParaRPr>
+          </a:p>
+        </p:txBody>
+      </p:sp>
+      <p:sp>
+        <p:nvSpPr>
+          <p:cNvPr id="7" name="zone_ressources_fiche_solution">
+            <a:extLst>
+              <a:ext uri="{FF2B5EF4-FFF2-40B4-BE49-F238E27FC236}">
+                <a16:creationId xmlns:a16="http://schemas.microsoft.com/office/drawing/2014/main" id="{67927841-950D-B96E-D880-93E461963945}"/>
+              </a:ext>
+            </a:extLst>
+          </p:cNvPr>
+          <p:cNvSpPr txBox="1"/>
+          <p:nvPr/>
+        </p:nvSpPr>
+        <p:spPr>
+          <a:xfrm>
+            <a:off x="839464" y="1626616"/>
+            <a:ext cx="9706988" cy="276999"/>
+          </a:xfrm>
+          <a:prstGeom prst="rect">
+            <a:avLst/>
+          </a:prstGeom>
+          <a:noFill/>
+        </p:spPr>
+        <p:txBody>
+          <a:bodyPr wrap="square">
+            <a:spAutoFit/>
+          </a:bodyPr>
+          <a:lstStyle/>
+          <a:p>
+            <a:r>
+              <a:rPr lang="fr-FR" sz="1200" dirty="0">
+                <a:solidFill>
+                  <a:srgbClr val="161616"/>
+                </a:solidFill>
+                <a:latin typeface="Marianne" panose="02000000000000000000" pitchFamily="50" charset="0"/>
+                <a:ea typeface="Calibri" panose="020F0502020204030204" pitchFamily="34" charset="0"/>
+                <a:cs typeface="Calibri" panose="020F0502020204030204" pitchFamily="34" charset="0"/>
+              </a:rPr>
+              <a:t>{{</a:t>
+            </a:r>
+            <a:r>
+              <a:rPr lang="fr-FR" sz="1200" dirty="0" err="1">
+                <a:solidFill>
+                  <a:srgbClr val="161616"/>
+                </a:solidFill>
+                <a:latin typeface="Marianne" panose="02000000000000000000" pitchFamily="50" charset="0"/>
+                <a:ea typeface="Calibri" panose="020F0502020204030204" pitchFamily="34" charset="0"/>
+                <a:cs typeface="Calibri" panose="020F0502020204030204" pitchFamily="34" charset="0"/>
+              </a:rPr>
+              <a:t>ressources_utiles_fiche_solution</a:t>
+            </a:r>
+            <a:r>
+              <a:rPr lang="fr-FR" sz="1200" dirty="0">
+                <a:solidFill>
+                  <a:srgbClr val="161616"/>
+                </a:solidFill>
+                <a:latin typeface="Marianne" panose="02000000000000000000" pitchFamily="50" charset="0"/>
+                <a:ea typeface="Calibri" panose="020F0502020204030204" pitchFamily="34" charset="0"/>
+                <a:cs typeface="Calibri" panose="020F0502020204030204" pitchFamily="34" charset="0"/>
+              </a:rPr>
+              <a:t>}}</a:t>
+            </a:r>
+            <a:endParaRPr lang="fr-FR" sz="1200" dirty="0">
+              <a:latin typeface="Marianne" panose="02000000000000000000" pitchFamily="50" charset="0"/>
+              <a:ea typeface="Calibri" panose="020F0502020204030204" pitchFamily="34" charset="0"/>
+              <a:cs typeface="Calibri" panose="020F0502020204030204" pitchFamily="34" charset="0"/>
+            </a:endParaRPr>
+          </a:p>
+        </p:txBody>
+      </p:sp>
+      <p:pic>
+        <p:nvPicPr>
+          <p:cNvPr id="3" name="Picture 3">
+            <a:extLst>
+              <a:ext uri="{FF2B5EF4-FFF2-40B4-BE49-F238E27FC236}">
+                <a16:creationId xmlns:a16="http://schemas.microsoft.com/office/drawing/2014/main" id="{7D131FE9-968A-7934-D330-1035AA73A364}"/>
+              </a:ext>
+            </a:extLst>
+          </p:cNvPr>
+          <p:cNvPicPr>
+            <a:picLocks noChangeAspect="1"/>
+          </p:cNvPicPr>
+          <p:nvPr/>
+        </p:nvPicPr>
+        <p:blipFill>
+          <a:blip r:embed="rId2"/>
+          <a:stretch>
+            <a:fillRect/>
+          </a:stretch>
+        </p:blipFill>
+        <p:spPr>
+          <a:xfrm>
+            <a:off x="10546452" y="104580"/>
+            <a:ext cx="1552051" cy="758533"/>
+          </a:xfrm>
+          <a:prstGeom prst="rect">
+            <a:avLst/>
+          </a:prstGeom>
+        </p:spPr>
+      </p:pic>
+    </p:spTree>
+    <p:extLst>
+      <p:ext uri="{BB962C8B-B14F-4D97-AF65-F5344CB8AC3E}">
+        <p14:creationId xmlns:p14="http://schemas.microsoft.com/office/powerpoint/2010/main" val="1015688024"/>
+      </p:ext>
+    </p:extLst>
+  </p:cSld>
+  <p:clrMapOvr>
+    <a:masterClrMapping/>
+  </p:clrMapOvr>
+</p:sld>
+</file>
+
 <file path=ppt/slides/slide2.xml><?xml version="1.0" encoding="utf-8"?>
 <p:sld xmlns:a="http://schemas.openxmlformats.org/drawingml/2006/main" xmlns:r="http://schemas.openxmlformats.org/officeDocument/2006/relationships" xmlns:p="http://schemas.openxmlformats.org/presentationml/2006/main">
   <p:cSld>
@@ -6302,8 +6875,8 @@
         </p:nvSpPr>
         <p:spPr>
           <a:xfrm>
-            <a:off x="958362" y="1914130"/>
-            <a:ext cx="9324890" cy="1234440"/>
+            <a:off x="958362" y="1914129"/>
+            <a:ext cx="9324890" cy="1414017"/>
           </a:xfrm>
           <a:prstGeom prst="roundRect">
             <a:avLst>
@@ -6483,8 +7056,8 @@
         </p:blipFill>
         <p:spPr>
           <a:xfrm>
-            <a:off x="1255554" y="2108376"/>
-            <a:ext cx="876038" cy="902585"/>
+            <a:off x="1137626" y="2083397"/>
+            <a:ext cx="1043847" cy="1075479"/>
           </a:xfrm>
           <a:prstGeom prst="rect">
             <a:avLst/>
@@ -6554,7 +7127,7 @@
         </p:nvSpPr>
         <p:spPr>
           <a:xfrm>
-            <a:off x="2360736" y="2874034"/>
+            <a:off x="2360736" y="2947998"/>
             <a:ext cx="7188518" cy="276999"/>
           </a:xfrm>
           <a:prstGeom prst="rect">
@@ -8333,6 +8906,36 @@
           <a:chExt cx="0" cy="0"/>
         </a:xfrm>
       </p:grpSpPr>
+      <p:pic>
+        <p:nvPicPr>
+          <p:cNvPr id="10" name="Picture 9">
+            <a:extLst>
+              <a:ext uri="{FF2B5EF4-FFF2-40B4-BE49-F238E27FC236}">
+                <a16:creationId xmlns:a16="http://schemas.microsoft.com/office/drawing/2014/main" id="{E922595D-B49E-4187-3566-440EF1D1B583}"/>
+              </a:ext>
+            </a:extLst>
+          </p:cNvPr>
+          <p:cNvPicPr>
+            <a:picLocks noChangeAspect="1"/>
+          </p:cNvPicPr>
+          <p:nvPr/>
+        </p:nvPicPr>
+        <p:blipFill>
+          <a:blip r:embed="rId3"/>
+          <a:stretch>
+            <a:fillRect/>
+          </a:stretch>
+        </p:blipFill>
+        <p:spPr>
+          <a:xfrm>
+            <a:off x="10546452" y="104580"/>
+            <a:ext cx="1552051" cy="758533"/>
+          </a:xfrm>
+          <a:prstGeom prst="rect">
+            <a:avLst/>
+          </a:prstGeom>
+        </p:spPr>
+      </p:pic>
       <p:sp>
         <p:nvSpPr>
           <p:cNvPr id="4" name="Text 2">
@@ -8361,15 +8964,26 @@
           <a:lstStyle/>
           <a:p>
             <a:r>
+              <a:rPr lang="en-US" sz="3733" b="1" dirty="0">
+                <a:solidFill>
+                  <a:srgbClr val="1A1A1A"/>
+                </a:solidFill>
+                <a:latin typeface="Marianne" panose="02000000000000000000" pitchFamily="50" charset="0"/>
+                <a:ea typeface="Calibri" panose="020F0502020204030204" pitchFamily="34" charset="0"/>
+                <a:cs typeface="Calibri" panose="020F0502020204030204" pitchFamily="34" charset="0"/>
+              </a:rPr>
+              <a:t>Aides </a:t>
+            </a:r>
+            <a:r>
               <a:rPr lang="en-US" sz="3733" b="1" dirty="0" err="1">
                 <a:solidFill>
                   <a:srgbClr val="1A1A1A"/>
                 </a:solidFill>
                 <a:latin typeface="Marianne" panose="02000000000000000000" pitchFamily="50" charset="0"/>
-                <a:ea typeface="Calibri" pitchFamily="34" charset="-122"/>
-                <a:cs typeface="Calibri" pitchFamily="34" charset="-120"/>
-              </a:rPr>
-              <a:t>Ressources</a:t>
+                <a:ea typeface="Calibri" panose="020F0502020204030204" pitchFamily="34" charset="0"/>
+                <a:cs typeface="Calibri" panose="020F0502020204030204" pitchFamily="34" charset="0"/>
+              </a:rPr>
+              <a:t>financières</a:t>
             </a:r>
             <a:r>
               <a:rPr lang="en-US" sz="3733" b="1" dirty="0">
@@ -8377,8 +8991,30 @@
                   <a:srgbClr val="1A1A1A"/>
                 </a:solidFill>
                 <a:latin typeface="Marianne" panose="02000000000000000000" pitchFamily="50" charset="0"/>
-                <a:ea typeface="Calibri" pitchFamily="34" charset="-122"/>
-                <a:cs typeface="Calibri" pitchFamily="34" charset="-120"/>
+                <a:ea typeface="Calibri" panose="020F0502020204030204" pitchFamily="34" charset="0"/>
+                <a:cs typeface="Calibri" panose="020F0502020204030204" pitchFamily="34" charset="0"/>
+              </a:rPr>
+              <a:t> et </a:t>
+            </a:r>
+            <a:r>
+              <a:rPr lang="en-US" sz="3733" b="1" dirty="0" err="1">
+                <a:solidFill>
+                  <a:srgbClr val="1A1A1A"/>
+                </a:solidFill>
+                <a:latin typeface="Marianne" panose="02000000000000000000" pitchFamily="50" charset="0"/>
+                <a:ea typeface="Calibri" panose="020F0502020204030204" pitchFamily="34" charset="0"/>
+                <a:cs typeface="Calibri" panose="020F0502020204030204" pitchFamily="34" charset="0"/>
+              </a:rPr>
+              <a:t>en</a:t>
+            </a:r>
+            <a:r>
+              <a:rPr lang="en-US" sz="3733" b="1" dirty="0">
+                <a:solidFill>
+                  <a:srgbClr val="1A1A1A"/>
+                </a:solidFill>
+                <a:latin typeface="Marianne" panose="02000000000000000000" pitchFamily="50" charset="0"/>
+                <a:ea typeface="Calibri" panose="020F0502020204030204" pitchFamily="34" charset="0"/>
+                <a:cs typeface="Calibri" panose="020F0502020204030204" pitchFamily="34" charset="0"/>
               </a:rPr>
               <a:t> </a:t>
             </a:r>
@@ -8388,13 +9024,15 @@
                   <a:srgbClr val="1A1A1A"/>
                 </a:solidFill>
                 <a:latin typeface="Marianne" panose="02000000000000000000" pitchFamily="50" charset="0"/>
-                <a:ea typeface="Calibri" pitchFamily="34" charset="-122"/>
-                <a:cs typeface="Calibri" pitchFamily="34" charset="-120"/>
-              </a:rPr>
-              <a:t>utiles</a:t>
+                <a:ea typeface="Calibri" panose="020F0502020204030204" pitchFamily="34" charset="0"/>
+                <a:cs typeface="Calibri" panose="020F0502020204030204" pitchFamily="34" charset="0"/>
+              </a:rPr>
+              <a:t>ingénierie</a:t>
             </a:r>
             <a:endParaRPr lang="en-US" sz="3733" dirty="0">
               <a:latin typeface="Marianne" panose="02000000000000000000" pitchFamily="50" charset="0"/>
+              <a:ea typeface="Calibri" panose="020F0502020204030204" pitchFamily="34" charset="0"/>
+              <a:cs typeface="Calibri" panose="020F0502020204030204" pitchFamily="34" charset="0"/>
             </a:endParaRPr>
           </a:p>
         </p:txBody>
@@ -8468,9 +9106,6 @@
           <a:bodyPr wrap="square" lIns="0" tIns="0" rIns="0" bIns="0" rtlCol="0" anchor="t"/>
           <a:lstStyle/>
           <a:p>
-            <a:pPr marL="0" indent="0">
-              <a:buNone/>
-            </a:pPr>
             <a:r>
               <a:rPr lang="en-US" sz="1600" dirty="0">
                 <a:solidFill>
@@ -8480,7 +9115,7 @@
                 <a:ea typeface="Calibri" pitchFamily="34" charset="-122"/>
                 <a:cs typeface="Calibri" pitchFamily="34" charset="-120"/>
               </a:rPr>
-              <a:t>Documentation </a:t>
+              <a:t>Aides </a:t>
             </a:r>
             <a:r>
               <a:rPr lang="en-US" sz="1600" dirty="0" err="1">
@@ -8491,7 +9126,7 @@
                 <a:ea typeface="Calibri" pitchFamily="34" charset="-122"/>
                 <a:cs typeface="Calibri" pitchFamily="34" charset="-120"/>
               </a:rPr>
-              <a:t>complémentaire</a:t>
+              <a:t>mobilisables</a:t>
             </a:r>
             <a:endParaRPr lang="en-US" sz="1600" dirty="0">
               <a:latin typeface="Marianne" panose="02000000000000000000" pitchFamily="50" charset="0"/>
@@ -8593,40 +9228,10 @@
           </a:p>
         </p:txBody>
       </p:sp>
-      <p:pic>
-        <p:nvPicPr>
-          <p:cNvPr id="7" name="Picture 9">
-            <a:extLst>
-              <a:ext uri="{FF2B5EF4-FFF2-40B4-BE49-F238E27FC236}">
-                <a16:creationId xmlns:a16="http://schemas.microsoft.com/office/drawing/2014/main" id="{E922595D-B49E-4187-3566-440EF1D1B583}"/>
-              </a:ext>
-            </a:extLst>
-          </p:cNvPr>
-          <p:cNvPicPr>
-            <a:picLocks noChangeAspect="1"/>
-          </p:cNvPicPr>
-          <p:nvPr/>
-        </p:nvPicPr>
-        <p:blipFill>
-          <a:blip r:embed="rId3"/>
-          <a:stretch>
-            <a:fillRect/>
-          </a:stretch>
-        </p:blipFill>
-        <p:spPr>
-          <a:xfrm>
-            <a:off x="10546452" y="104580"/>
-            <a:ext cx="1552051" cy="758533"/>
-          </a:xfrm>
-          <a:prstGeom prst="rect">
-            <a:avLst/>
-          </a:prstGeom>
-        </p:spPr>
-      </p:pic>
     </p:spTree>
     <p:extLst>
       <p:ext uri="{BB962C8B-B14F-4D97-AF65-F5344CB8AC3E}">
-        <p14:creationId xmlns:p14="http://schemas.microsoft.com/office/powerpoint/2010/main" val="2848617555"/>
+        <p14:creationId xmlns:p14="http://schemas.microsoft.com/office/powerpoint/2010/main" val="3325200477"/>
       </p:ext>
     </p:extLst>
   </p:cSld>
@@ -8644,7 +9249,7 @@
         <p:cNvPr id="1" name="">
           <a:extLst>
             <a:ext uri="{FF2B5EF4-FFF2-40B4-BE49-F238E27FC236}">
-              <a16:creationId xmlns:a16="http://schemas.microsoft.com/office/drawing/2014/main" id="{1917CAA9-6ECD-8F49-8289-13579AAE1FB7}"/>
+              <a16:creationId xmlns:a16="http://schemas.microsoft.com/office/drawing/2014/main" id="{1CAD5EDA-690E-3CC6-C42C-06C82CED1E1D}"/>
             </a:ext>
           </a:extLst>
         </p:cNvPr>
@@ -8659,12 +9264,42 @@
           <a:chExt cx="0" cy="0"/>
         </a:xfrm>
       </p:grpSpPr>
+      <p:pic>
+        <p:nvPicPr>
+          <p:cNvPr id="4" name="Picture 3">
+            <a:extLst>
+              <a:ext uri="{FF2B5EF4-FFF2-40B4-BE49-F238E27FC236}">
+                <a16:creationId xmlns:a16="http://schemas.microsoft.com/office/drawing/2014/main" id="{AAAAE1D7-6F33-E157-3225-75B1CCD5D9BA}"/>
+              </a:ext>
+            </a:extLst>
+          </p:cNvPr>
+          <p:cNvPicPr>
+            <a:picLocks noChangeAspect="1"/>
+          </p:cNvPicPr>
+          <p:nvPr/>
+        </p:nvPicPr>
+        <p:blipFill>
+          <a:blip r:embed="rId2"/>
+          <a:stretch>
+            <a:fillRect/>
+          </a:stretch>
+        </p:blipFill>
+        <p:spPr>
+          <a:xfrm>
+            <a:off x="10546452" y="104580"/>
+            <a:ext cx="1552051" cy="758533"/>
+          </a:xfrm>
+          <a:prstGeom prst="rect">
+            <a:avLst/>
+          </a:prstGeom>
+        </p:spPr>
+      </p:pic>
       <p:sp>
         <p:nvSpPr>
           <p:cNvPr id="2" name="Titre 1">
             <a:extLst>
               <a:ext uri="{FF2B5EF4-FFF2-40B4-BE49-F238E27FC236}">
-                <a16:creationId xmlns:a16="http://schemas.microsoft.com/office/drawing/2014/main" id="{474A7BA3-D950-9097-DDDD-F688CBFCCB67}"/>
+                <a16:creationId xmlns:a16="http://schemas.microsoft.com/office/drawing/2014/main" id="{84441D3F-C0C4-D64F-E9FD-151DD76BDA28}"/>
               </a:ext>
             </a:extLst>
           </p:cNvPr>
@@ -8678,12 +9313,12 @@
         <p:spPr>
           <a:xfrm>
             <a:off x="576263" y="345395"/>
-            <a:ext cx="10031656" cy="615294"/>
+            <a:ext cx="9706989" cy="615294"/>
           </a:xfrm>
         </p:spPr>
         <p:txBody>
           <a:bodyPr>
-            <a:normAutofit/>
+            <a:normAutofit fontScale="90000"/>
           </a:bodyPr>
           <a:lstStyle/>
           <a:p>
@@ -8691,125 +9326,381 @@
               <a:buNone/>
             </a:pPr>
             <a:r>
-              <a:rPr lang="en-US" sz="2800" dirty="0" err="1">
-                <a:latin typeface="Marianne" panose="02000000000000000000" pitchFamily="50" charset="0"/>
-              </a:rPr>
-              <a:t>Ressources</a:t>
-            </a:r>
-            <a:r>
-              <a:rPr lang="en-US" sz="2800" dirty="0">
+              <a:rPr lang="en-US" sz="3200" dirty="0">
+                <a:latin typeface="Marianne" panose="02000000000000000000" pitchFamily="50" charset="0"/>
+              </a:rPr>
+              <a:t>Aides </a:t>
+            </a:r>
+            <a:r>
+              <a:rPr lang="en-US" sz="3200" dirty="0" err="1">
+                <a:latin typeface="Marianne" panose="02000000000000000000" pitchFamily="50" charset="0"/>
+              </a:rPr>
+              <a:t>financières</a:t>
+            </a:r>
+            <a:r>
+              <a:rPr lang="en-US" sz="3200" dirty="0">
+                <a:latin typeface="Marianne" panose="02000000000000000000" pitchFamily="50" charset="0"/>
+              </a:rPr>
+              <a:t> et </a:t>
+            </a:r>
+            <a:r>
+              <a:rPr lang="en-US" sz="3200" dirty="0" err="1">
+                <a:latin typeface="Marianne" panose="02000000000000000000" pitchFamily="50" charset="0"/>
+              </a:rPr>
+              <a:t>en</a:t>
+            </a:r>
+            <a:r>
+              <a:rPr lang="en-US" sz="3200" dirty="0">
                 <a:latin typeface="Marianne" panose="02000000000000000000" pitchFamily="50" charset="0"/>
               </a:rPr>
               <a:t> </a:t>
             </a:r>
             <a:r>
-              <a:rPr lang="en-US" sz="2800" dirty="0" err="1">
-                <a:latin typeface="Marianne" panose="02000000000000000000" pitchFamily="50" charset="0"/>
-              </a:rPr>
-              <a:t>utiles</a:t>
-            </a:r>
-            <a:r>
-              <a:rPr lang="en-US" sz="2800" dirty="0">
+              <a:rPr lang="en-US" sz="3200" dirty="0" err="1">
+                <a:latin typeface="Marianne" panose="02000000000000000000" pitchFamily="50" charset="0"/>
+              </a:rPr>
+              <a:t>ingénierie</a:t>
+            </a:r>
+            <a:r>
+              <a:rPr lang="en-US" sz="3200" dirty="0">
+                <a:latin typeface="Marianne" panose="02000000000000000000" pitchFamily="50" charset="0"/>
+              </a:rPr>
+              <a:t> </a:t>
+            </a:r>
+            <a:r>
+              <a:rPr lang="en-US" sz="3200" dirty="0">
                 <a:latin typeface="Marianne" panose="02000000000000000000" pitchFamily="50" charset="0"/>
                 <a:ea typeface="Calibri" panose="020F0502020204030204" pitchFamily="34" charset="0"/>
                 <a:cs typeface="Calibri" panose="020F0502020204030204" pitchFamily="34" charset="0"/>
               </a:rPr>
-              <a:t> {{</a:t>
-            </a:r>
-            <a:r>
-              <a:rPr lang="en-US" sz="2800" dirty="0" err="1">
+              <a:t>{{</a:t>
+            </a:r>
+            <a:r>
+              <a:rPr lang="en-US" sz="3200" dirty="0" err="1">
                 <a:latin typeface="Marianne" panose="02000000000000000000" pitchFamily="50" charset="0"/>
                 <a:ea typeface="Calibri" panose="020F0502020204030204" pitchFamily="34" charset="0"/>
                 <a:cs typeface="Calibri" panose="020F0502020204030204" pitchFamily="34" charset="0"/>
               </a:rPr>
-              <a:t>pagination_ressources_utiles</a:t>
-            </a:r>
-            <a:r>
-              <a:rPr lang="en-US" sz="2800" dirty="0">
+              <a:t>pagination_aides</a:t>
+            </a:r>
+            <a:r>
+              <a:rPr lang="en-US" sz="3200" dirty="0">
                 <a:latin typeface="Marianne" panose="02000000000000000000" pitchFamily="50" charset="0"/>
                 <a:ea typeface="Calibri" panose="020F0502020204030204" pitchFamily="34" charset="0"/>
                 <a:cs typeface="Calibri" panose="020F0502020204030204" pitchFamily="34" charset="0"/>
               </a:rPr>
               <a:t>}}</a:t>
             </a:r>
-          </a:p>
-        </p:txBody>
-      </p:sp>
-      <p:sp>
-        <p:nvSpPr>
-          <p:cNvPr id="5" name="zone_titre_fiche_solution">
-            <a:extLst>
-              <a:ext uri="{FF2B5EF4-FFF2-40B4-BE49-F238E27FC236}">
-                <a16:creationId xmlns:a16="http://schemas.microsoft.com/office/drawing/2014/main" id="{C76718D3-101C-1B45-FD71-3691F60DE7E5}"/>
-              </a:ext>
-            </a:extLst>
-          </p:cNvPr>
-          <p:cNvSpPr txBox="1"/>
+            <a:endParaRPr lang="en-US" sz="3200" dirty="0">
+              <a:latin typeface="Marianne" panose="02000000000000000000" pitchFamily="50" charset="0"/>
+            </a:endParaRPr>
+          </a:p>
+        </p:txBody>
+      </p:sp>
+      <p:sp>
+        <p:nvSpPr>
+          <p:cNvPr id="31" name="contour_aide">
+            <a:extLst>
+              <a:ext uri="{FF2B5EF4-FFF2-40B4-BE49-F238E27FC236}">
+                <a16:creationId xmlns:a16="http://schemas.microsoft.com/office/drawing/2014/main" id="{6F190980-5A7F-CFD0-DB5F-2885D8DD4262}"/>
+              </a:ext>
+            </a:extLst>
+          </p:cNvPr>
+          <p:cNvSpPr/>
           <p:nvPr/>
         </p:nvSpPr>
         <p:spPr>
           <a:xfrm>
-            <a:off x="576263" y="1093598"/>
-            <a:ext cx="9706988" cy="400110"/>
+            <a:off x="576263" y="1436010"/>
+            <a:ext cx="10581312" cy="1319489"/>
+          </a:xfrm>
+          <a:prstGeom prst="roundRect">
+            <a:avLst>
+              <a:gd name="adj" fmla="val 5932"/>
+            </a:avLst>
+          </a:prstGeom>
+          <a:solidFill>
+            <a:srgbClr val="FFFFFF"/>
+          </a:solidFill>
+          <a:ln w="12700">
+            <a:solidFill>
+              <a:srgbClr val="E0E0E0"/>
+            </a:solidFill>
+            <a:prstDash val="solid"/>
+          </a:ln>
+        </p:spPr>
+        <p:txBody>
+          <a:bodyPr/>
+          <a:lstStyle/>
+          <a:p>
+            <a:endParaRPr lang="fr-FR" sz="2400">
+              <a:latin typeface="Marianne" panose="02000000000000000000" pitchFamily="50" charset="0"/>
+            </a:endParaRPr>
+          </a:p>
+        </p:txBody>
+      </p:sp>
+      <p:sp>
+        <p:nvSpPr>
+          <p:cNvPr id="32" name="Text 6">
+            <a:extLst>
+              <a:ext uri="{FF2B5EF4-FFF2-40B4-BE49-F238E27FC236}">
+                <a16:creationId xmlns:a16="http://schemas.microsoft.com/office/drawing/2014/main" id="{CA13F4C7-9C9C-5D69-7ABF-29ED7E1E953C}"/>
+              </a:ext>
+            </a:extLst>
+          </p:cNvPr>
+          <p:cNvSpPr/>
+          <p:nvPr/>
+        </p:nvSpPr>
+        <p:spPr>
+          <a:xfrm>
+            <a:off x="759144" y="1527451"/>
+            <a:ext cx="7955280" cy="201168"/>
           </a:xfrm>
           <a:prstGeom prst="rect">
             <a:avLst/>
           </a:prstGeom>
           <a:noFill/>
-        </p:spPr>
-        <p:txBody>
-          <a:bodyPr wrap="square">
-            <a:spAutoFit/>
-          </a:bodyPr>
-          <a:lstStyle/>
-          <a:p>
-            <a:r>
-              <a:rPr lang="fr-FR" sz="2000" b="1" dirty="0">
-                <a:solidFill>
-                  <a:srgbClr val="161616"/>
-                </a:solidFill>
-                <a:latin typeface="Marianne" panose="02000000000000000000" pitchFamily="50" charset="0"/>
-                <a:ea typeface="Calibri" panose="020F0502020204030204" pitchFamily="34" charset="0"/>
-                <a:cs typeface="Calibri" panose="020F0502020204030204" pitchFamily="34" charset="0"/>
+          <a:ln/>
+        </p:spPr>
+        <p:txBody>
+          <a:bodyPr wrap="square" lIns="0" tIns="0" rIns="0" bIns="0" rtlCol="0" anchor="ctr"/>
+          <a:lstStyle/>
+          <a:p>
+            <a:pPr marL="0" indent="0">
+              <a:buNone/>
+            </a:pPr>
+            <a:r>
+              <a:rPr lang="en-US" sz="900" kern="0" spc="150" dirty="0">
+                <a:solidFill>
+                  <a:schemeClr val="tx1">
+                    <a:lumMod val="65000"/>
+                    <a:lumOff val="35000"/>
+                  </a:schemeClr>
+                </a:solidFill>
+                <a:latin typeface="Marianne" panose="02000000000000000000" pitchFamily="50" charset="0"/>
+                <a:ea typeface="Calibri" pitchFamily="34" charset="-122"/>
+                <a:cs typeface="Calibri" pitchFamily="34" charset="-120"/>
               </a:rPr>
               <a:t>{{</a:t>
             </a:r>
             <a:r>
-              <a:rPr lang="fr-FR" sz="2000" b="1" dirty="0" err="1">
-                <a:solidFill>
-                  <a:srgbClr val="161616"/>
-                </a:solidFill>
-                <a:latin typeface="Marianne" panose="02000000000000000000" pitchFamily="50" charset="0"/>
-                <a:ea typeface="Calibri" panose="020F0502020204030204" pitchFamily="34" charset="0"/>
-                <a:cs typeface="Calibri" panose="020F0502020204030204" pitchFamily="34" charset="0"/>
-              </a:rPr>
-              <a:t>titre_fiche_solution</a:t>
-            </a:r>
-            <a:r>
-              <a:rPr lang="fr-FR" sz="2000" b="1" dirty="0">
-                <a:solidFill>
-                  <a:srgbClr val="161616"/>
-                </a:solidFill>
-                <a:latin typeface="Marianne" panose="02000000000000000000" pitchFamily="50" charset="0"/>
-                <a:ea typeface="Calibri" panose="020F0502020204030204" pitchFamily="34" charset="0"/>
-                <a:cs typeface="Calibri" panose="020F0502020204030204" pitchFamily="34" charset="0"/>
+              <a:rPr lang="en-US" sz="900" kern="0" spc="150" dirty="0" err="1">
+                <a:solidFill>
+                  <a:schemeClr val="tx1">
+                    <a:lumMod val="65000"/>
+                    <a:lumOff val="35000"/>
+                  </a:schemeClr>
+                </a:solidFill>
+                <a:latin typeface="Marianne" panose="02000000000000000000" pitchFamily="50" charset="0"/>
+                <a:ea typeface="Calibri" pitchFamily="34" charset="-122"/>
+                <a:cs typeface="Calibri" pitchFamily="34" charset="-120"/>
+              </a:rPr>
+              <a:t>aide_type</a:t>
+            </a:r>
+            <a:r>
+              <a:rPr lang="en-US" sz="900" kern="0" spc="150" dirty="0">
+                <a:solidFill>
+                  <a:schemeClr val="tx1">
+                    <a:lumMod val="65000"/>
+                    <a:lumOff val="35000"/>
+                  </a:schemeClr>
+                </a:solidFill>
+                <a:latin typeface="Marianne" panose="02000000000000000000" pitchFamily="50" charset="0"/>
+                <a:ea typeface="Calibri" pitchFamily="34" charset="-122"/>
+                <a:cs typeface="Calibri" pitchFamily="34" charset="-120"/>
               </a:rPr>
               <a:t>}}</a:t>
             </a:r>
-            <a:endParaRPr lang="fr-FR" sz="2000" dirty="0">
+            <a:endParaRPr lang="en-US" sz="900" dirty="0">
+              <a:solidFill>
+                <a:schemeClr val="tx1">
+                  <a:lumMod val="65000"/>
+                  <a:lumOff val="35000"/>
+                </a:schemeClr>
+              </a:solidFill>
               <a:latin typeface="Marianne" panose="02000000000000000000" pitchFamily="50" charset="0"/>
-              <a:ea typeface="Calibri" panose="020F0502020204030204" pitchFamily="34" charset="0"/>
-              <a:cs typeface="Calibri" panose="020F0502020204030204" pitchFamily="34" charset="0"/>
             </a:endParaRPr>
+          </a:p>
+        </p:txBody>
+      </p:sp>
+      <p:sp>
+        <p:nvSpPr>
+          <p:cNvPr id="33" name="Text 7">
+            <a:extLst>
+              <a:ext uri="{FF2B5EF4-FFF2-40B4-BE49-F238E27FC236}">
+                <a16:creationId xmlns:a16="http://schemas.microsoft.com/office/drawing/2014/main" id="{3A009836-E679-1A4E-868D-C41048F4DF96}"/>
+              </a:ext>
+            </a:extLst>
+          </p:cNvPr>
+          <p:cNvSpPr/>
+          <p:nvPr/>
+        </p:nvSpPr>
+        <p:spPr>
+          <a:xfrm>
+            <a:off x="759143" y="1710331"/>
+            <a:ext cx="9981503" cy="347472"/>
+          </a:xfrm>
+          <a:prstGeom prst="rect">
+            <a:avLst/>
+          </a:prstGeom>
+          <a:noFill/>
+          <a:ln/>
+        </p:spPr>
+        <p:txBody>
+          <a:bodyPr wrap="square" lIns="0" tIns="0" rIns="0" bIns="0" rtlCol="0" anchor="ctr"/>
+          <a:lstStyle/>
+          <a:p>
+            <a:pPr marL="0" indent="0">
+              <a:buNone/>
+            </a:pPr>
+            <a:r>
+              <a:rPr lang="en-US" sz="1600" b="1" dirty="0">
+                <a:latin typeface="Marianne" panose="02000000000000000000" pitchFamily="50" charset="0"/>
+              </a:rPr>
+              <a:t>{{</a:t>
+            </a:r>
+            <a:r>
+              <a:rPr lang="en-US" sz="1600" b="1" dirty="0" err="1">
+                <a:latin typeface="Marianne" panose="02000000000000000000" pitchFamily="50" charset="0"/>
+              </a:rPr>
+              <a:t>aide_nom</a:t>
+            </a:r>
+            <a:r>
+              <a:rPr lang="en-US" sz="1600" b="1" dirty="0">
+                <a:latin typeface="Marianne" panose="02000000000000000000" pitchFamily="50" charset="0"/>
+              </a:rPr>
+              <a:t>}}</a:t>
+            </a:r>
+          </a:p>
+        </p:txBody>
+      </p:sp>
+      <p:sp>
+        <p:nvSpPr>
+          <p:cNvPr id="34" name="Text 8">
+            <a:extLst>
+              <a:ext uri="{FF2B5EF4-FFF2-40B4-BE49-F238E27FC236}">
+                <a16:creationId xmlns:a16="http://schemas.microsoft.com/office/drawing/2014/main" id="{63CA8282-153C-FA82-28E2-0A7385CED3A7}"/>
+              </a:ext>
+            </a:extLst>
+          </p:cNvPr>
+          <p:cNvSpPr/>
+          <p:nvPr/>
+        </p:nvSpPr>
+        <p:spPr>
+          <a:xfrm>
+            <a:off x="759144" y="2174069"/>
+            <a:ext cx="9981502" cy="320040"/>
+          </a:xfrm>
+          <a:prstGeom prst="rect">
+            <a:avLst/>
+          </a:prstGeom>
+          <a:noFill/>
+          <a:ln/>
+        </p:spPr>
+        <p:txBody>
+          <a:bodyPr wrap="square" lIns="0" tIns="0" rIns="0" bIns="0" rtlCol="0" anchor="ctr"/>
+          <a:lstStyle/>
+          <a:p>
+            <a:pPr marL="0" indent="0">
+              <a:buNone/>
+            </a:pPr>
+            <a:r>
+              <a:rPr lang="en-US" sz="1100" dirty="0" err="1">
+                <a:solidFill>
+                  <a:srgbClr val="5C5C5C"/>
+                </a:solidFill>
+                <a:latin typeface="Marianne" panose="02000000000000000000" pitchFamily="50" charset="0"/>
+                <a:ea typeface="Calibri" pitchFamily="34" charset="-122"/>
+                <a:cs typeface="Calibri" pitchFamily="34" charset="-120"/>
+              </a:rPr>
+              <a:t>Porteur</a:t>
+            </a:r>
+            <a:r>
+              <a:rPr lang="en-US" sz="1100" dirty="0">
+                <a:solidFill>
+                  <a:srgbClr val="5C5C5C"/>
+                </a:solidFill>
+                <a:latin typeface="Marianne" panose="02000000000000000000" pitchFamily="50" charset="0"/>
+                <a:ea typeface="Calibri" pitchFamily="34" charset="-122"/>
+                <a:cs typeface="Calibri" pitchFamily="34" charset="-120"/>
+              </a:rPr>
+              <a:t> : {{</a:t>
+            </a:r>
+            <a:r>
+              <a:rPr lang="en-US" sz="1100" dirty="0" err="1">
+                <a:solidFill>
+                  <a:srgbClr val="5C5C5C"/>
+                </a:solidFill>
+                <a:latin typeface="Marianne" panose="02000000000000000000" pitchFamily="50" charset="0"/>
+                <a:ea typeface="Calibri" pitchFamily="34" charset="-122"/>
+                <a:cs typeface="Calibri" pitchFamily="34" charset="-120"/>
+              </a:rPr>
+              <a:t>aide_financiers</a:t>
+            </a:r>
+            <a:r>
+              <a:rPr lang="en-US" sz="1100" dirty="0">
+                <a:solidFill>
+                  <a:srgbClr val="5C5C5C"/>
+                </a:solidFill>
+                <a:latin typeface="Marianne" panose="02000000000000000000" pitchFamily="50" charset="0"/>
+                <a:ea typeface="Calibri" pitchFamily="34" charset="-122"/>
+                <a:cs typeface="Calibri" pitchFamily="34" charset="-120"/>
+              </a:rPr>
+              <a:t>}}  ·  </a:t>
+            </a:r>
+            <a:r>
+              <a:rPr lang="en-US" sz="1100" dirty="0" err="1">
+                <a:solidFill>
+                  <a:srgbClr val="5C5C5C"/>
+                </a:solidFill>
+                <a:latin typeface="Marianne" panose="02000000000000000000" pitchFamily="50" charset="0"/>
+                <a:ea typeface="Calibri" pitchFamily="34" charset="-122"/>
+                <a:cs typeface="Calibri" pitchFamily="34" charset="-120"/>
+              </a:rPr>
+              <a:t>Échéance</a:t>
+            </a:r>
+            <a:r>
+              <a:rPr lang="en-US" sz="1100" dirty="0">
+                <a:solidFill>
+                  <a:srgbClr val="5C5C5C"/>
+                </a:solidFill>
+                <a:latin typeface="Marianne" panose="02000000000000000000" pitchFamily="50" charset="0"/>
+                <a:ea typeface="Calibri" pitchFamily="34" charset="-122"/>
+                <a:cs typeface="Calibri" pitchFamily="34" charset="-120"/>
+              </a:rPr>
+              <a:t> : {{</a:t>
+            </a:r>
+            <a:r>
+              <a:rPr lang="en-US" sz="1100" dirty="0" err="1">
+                <a:solidFill>
+                  <a:srgbClr val="5C5C5C"/>
+                </a:solidFill>
+                <a:latin typeface="Marianne" panose="02000000000000000000" pitchFamily="50" charset="0"/>
+                <a:ea typeface="Calibri" pitchFamily="34" charset="-122"/>
+                <a:cs typeface="Calibri" pitchFamily="34" charset="-120"/>
+              </a:rPr>
+              <a:t>aide_echeance</a:t>
+            </a:r>
+            <a:r>
+              <a:rPr lang="en-US" sz="1100" dirty="0">
+                <a:solidFill>
+                  <a:srgbClr val="5C5C5C"/>
+                </a:solidFill>
+                <a:latin typeface="Marianne" panose="02000000000000000000" pitchFamily="50" charset="0"/>
+                <a:ea typeface="Calibri" pitchFamily="34" charset="-122"/>
+                <a:cs typeface="Calibri" pitchFamily="34" charset="-120"/>
+              </a:rPr>
+              <a:t>}}</a:t>
+            </a:r>
           </a:p>
         </p:txBody>
       </p:sp>
       <p:cxnSp>
         <p:nvCxnSpPr>
-          <p:cNvPr id="34" name="Connecteur droit 33">
-            <a:extLst>
-              <a:ext uri="{FF2B5EF4-FFF2-40B4-BE49-F238E27FC236}">
-                <a16:creationId xmlns:a16="http://schemas.microsoft.com/office/drawing/2014/main" id="{B62F42A1-9E9E-D546-190A-5C7D09368113}"/>
+          <p:cNvPr id="39" name="Connecteur droit 38">
+            <a:extLst>
+              <a:ext uri="{FF2B5EF4-FFF2-40B4-BE49-F238E27FC236}">
+                <a16:creationId xmlns:a16="http://schemas.microsoft.com/office/drawing/2014/main" id="{4372EE40-FFB9-5091-F127-1A16325D4B91}"/>
               </a:ext>
             </a:extLst>
           </p:cNvPr>
@@ -8820,7 +9711,7 @@
         </p:nvCxnSpPr>
         <p:spPr>
           <a:xfrm>
-            <a:off x="576263" y="960689"/>
+            <a:off x="576263" y="6512991"/>
             <a:ext cx="11615737" cy="0"/>
           </a:xfrm>
           <a:prstGeom prst="line">
@@ -8849,12 +9740,59 @@
           </a:fontRef>
         </p:style>
       </p:cxnSp>
+      <p:sp>
+        <p:nvSpPr>
+          <p:cNvPr id="40" name="Text 3">
+            <a:extLst>
+              <a:ext uri="{FF2B5EF4-FFF2-40B4-BE49-F238E27FC236}">
+                <a16:creationId xmlns:a16="http://schemas.microsoft.com/office/drawing/2014/main" id="{380279C3-3129-980B-2687-34A5CF7BD239}"/>
+              </a:ext>
+            </a:extLst>
+          </p:cNvPr>
+          <p:cNvSpPr/>
+          <p:nvPr/>
+        </p:nvSpPr>
+        <p:spPr>
+          <a:xfrm>
+            <a:off x="576263" y="6598217"/>
+            <a:ext cx="8229600" cy="182880"/>
+          </a:xfrm>
+          <a:prstGeom prst="rect">
+            <a:avLst/>
+          </a:prstGeom>
+          <a:noFill/>
+          <a:ln/>
+        </p:spPr>
+        <p:txBody>
+          <a:bodyPr wrap="square" lIns="0" tIns="0" rIns="0" bIns="0" rtlCol="0" anchor="ctr"/>
+          <a:lstStyle/>
+          <a:p>
+            <a:pPr marL="0" indent="0">
+              <a:buNone/>
+            </a:pPr>
+            <a:r>
+              <a:rPr lang="en-US" sz="1000" i="1">
+                <a:solidFill>
+                  <a:srgbClr val="A0A0A0"/>
+                </a:solidFill>
+                <a:latin typeface="Marianne" panose="02000000000000000000" pitchFamily="50" charset="0"/>
+                <a:ea typeface="Calibri" pitchFamily="34" charset="-122"/>
+                <a:cs typeface="Calibri" pitchFamily="34" charset="-120"/>
+              </a:rPr>
+              <a:t>Données issues de Plus fraîche ma ville (ADEME)</a:t>
+            </a:r>
+            <a:endParaRPr lang="en-US" sz="1000">
+              <a:latin typeface="Marianne" panose="02000000000000000000" pitchFamily="50" charset="0"/>
+            </a:endParaRPr>
+          </a:p>
+        </p:txBody>
+      </p:sp>
       <p:cxnSp>
         <p:nvCxnSpPr>
-          <p:cNvPr id="55" name="Connecteur droit 54">
-            <a:extLst>
-              <a:ext uri="{FF2B5EF4-FFF2-40B4-BE49-F238E27FC236}">
-                <a16:creationId xmlns:a16="http://schemas.microsoft.com/office/drawing/2014/main" id="{BFBD2EB6-34B6-54D8-319B-95BBA847CB21}"/>
+          <p:cNvPr id="41" name="Connecteur droit 40">
+            <a:extLst>
+              <a:ext uri="{FF2B5EF4-FFF2-40B4-BE49-F238E27FC236}">
+                <a16:creationId xmlns:a16="http://schemas.microsoft.com/office/drawing/2014/main" id="{023BEAE7-454A-8F1A-3121-9FE3AF0D1D26}"/>
               </a:ext>
             </a:extLst>
           </p:cNvPr>
@@ -8865,7 +9803,7 @@
         </p:nvCxnSpPr>
         <p:spPr>
           <a:xfrm>
-            <a:off x="576263" y="6512991"/>
+            <a:off x="576263" y="960689"/>
             <a:ext cx="11615737" cy="0"/>
           </a:xfrm>
           <a:prstGeom prst="line">
@@ -8896,10 +9834,10 @@
       </p:cxnSp>
       <p:sp>
         <p:nvSpPr>
-          <p:cNvPr id="56" name="Text 3">
-            <a:extLst>
-              <a:ext uri="{FF2B5EF4-FFF2-40B4-BE49-F238E27FC236}">
-                <a16:creationId xmlns:a16="http://schemas.microsoft.com/office/drawing/2014/main" id="{8B657D20-7F9C-8851-0BA6-B35DF1DB8D17}"/>
+          <p:cNvPr id="7" name="Text 8">
+            <a:extLst>
+              <a:ext uri="{FF2B5EF4-FFF2-40B4-BE49-F238E27FC236}">
+                <a16:creationId xmlns:a16="http://schemas.microsoft.com/office/drawing/2014/main" id="{00ED1968-10CF-E3DC-940B-6214BFEF0E99}"/>
               </a:ext>
             </a:extLst>
           </p:cNvPr>
@@ -8908,8 +9846,8 @@
         </p:nvSpPr>
         <p:spPr>
           <a:xfrm>
-            <a:off x="576263" y="6598217"/>
-            <a:ext cx="8229600" cy="182880"/>
+            <a:off x="759143" y="2417168"/>
+            <a:ext cx="1466775" cy="320040"/>
           </a:xfrm>
           <a:prstGeom prst="rect">
             <a:avLst/>
@@ -8925,61 +9863,196 @@
               <a:buNone/>
             </a:pPr>
             <a:r>
-              <a:rPr lang="en-US" sz="1000" i="1" dirty="0">
-                <a:solidFill>
-                  <a:srgbClr val="A0A0A0"/>
-                </a:solidFill>
-                <a:latin typeface="Marianne" panose="02000000000000000000" pitchFamily="50" charset="0"/>
-                <a:ea typeface="Calibri" panose="020F0502020204030204" pitchFamily="34" charset="0"/>
-                <a:cs typeface="Calibri" panose="020F0502020204030204" pitchFamily="34" charset="0"/>
-              </a:rPr>
-              <a:t>Données issues de Plus </a:t>
-            </a:r>
-            <a:r>
-              <a:rPr lang="en-US" sz="1000" i="1" dirty="0" err="1">
-                <a:solidFill>
-                  <a:srgbClr val="A0A0A0"/>
-                </a:solidFill>
-                <a:latin typeface="Marianne" panose="02000000000000000000" pitchFamily="50" charset="0"/>
-                <a:ea typeface="Calibri" panose="020F0502020204030204" pitchFamily="34" charset="0"/>
-                <a:cs typeface="Calibri" panose="020F0502020204030204" pitchFamily="34" charset="0"/>
-              </a:rPr>
-              <a:t>fraîche</a:t>
-            </a:r>
-            <a:r>
-              <a:rPr lang="en-US" sz="1000" i="1" dirty="0">
-                <a:solidFill>
-                  <a:srgbClr val="A0A0A0"/>
-                </a:solidFill>
-                <a:latin typeface="Marianne" panose="02000000000000000000" pitchFamily="50" charset="0"/>
-                <a:ea typeface="Calibri" panose="020F0502020204030204" pitchFamily="34" charset="0"/>
-                <a:cs typeface="Calibri" panose="020F0502020204030204" pitchFamily="34" charset="0"/>
-              </a:rPr>
-              <a:t> ma </a:t>
-            </a:r>
-            <a:r>
-              <a:rPr lang="en-US" sz="1000" i="1" dirty="0" err="1">
-                <a:solidFill>
-                  <a:srgbClr val="A0A0A0"/>
-                </a:solidFill>
-                <a:latin typeface="Marianne" panose="02000000000000000000" pitchFamily="50" charset="0"/>
-                <a:ea typeface="Calibri" panose="020F0502020204030204" pitchFamily="34" charset="0"/>
-                <a:cs typeface="Calibri" panose="020F0502020204030204" pitchFamily="34" charset="0"/>
-              </a:rPr>
-              <a:t>ville</a:t>
-            </a:r>
-            <a:r>
-              <a:rPr lang="en-US" sz="1000" i="1" dirty="0">
-                <a:solidFill>
-                  <a:srgbClr val="A0A0A0"/>
-                </a:solidFill>
-                <a:latin typeface="Marianne" panose="02000000000000000000" pitchFamily="50" charset="0"/>
-                <a:ea typeface="Calibri" panose="020F0502020204030204" pitchFamily="34" charset="0"/>
-                <a:cs typeface="Calibri" panose="020F0502020204030204" pitchFamily="34" charset="0"/>
-              </a:rPr>
-              <a:t> (ADEME)</a:t>
-            </a:r>
-            <a:endParaRPr lang="en-US" sz="1000" dirty="0">
+              <a:rPr lang="en-US" sz="1100" dirty="0">
+                <a:solidFill>
+                  <a:srgbClr val="5C5C5C"/>
+                </a:solidFill>
+                <a:latin typeface="Marianne" panose="02000000000000000000" pitchFamily="50" charset="0"/>
+                <a:ea typeface="Calibri" pitchFamily="34" charset="-122"/>
+                <a:cs typeface="Calibri" pitchFamily="34" charset="-120"/>
+                <a:hlinkClick r:id="rId3" action="ppaction://hlinkfile"/>
+              </a:rPr>
+              <a:t>Lien </a:t>
+            </a:r>
+            <a:r>
+              <a:rPr lang="en-US" sz="1100" dirty="0" err="1">
+                <a:solidFill>
+                  <a:srgbClr val="5C5C5C"/>
+                </a:solidFill>
+                <a:latin typeface="Marianne" panose="02000000000000000000" pitchFamily="50" charset="0"/>
+                <a:ea typeface="Calibri" pitchFamily="34" charset="-122"/>
+                <a:cs typeface="Calibri" pitchFamily="34" charset="-120"/>
+                <a:hlinkClick r:id="rId3" action="ppaction://hlinkfile"/>
+              </a:rPr>
+              <a:t>vers</a:t>
+            </a:r>
+            <a:r>
+              <a:rPr lang="en-US" sz="1100" dirty="0">
+                <a:solidFill>
+                  <a:srgbClr val="5C5C5C"/>
+                </a:solidFill>
+                <a:latin typeface="Marianne" panose="02000000000000000000" pitchFamily="50" charset="0"/>
+                <a:ea typeface="Calibri" pitchFamily="34" charset="-122"/>
+                <a:cs typeface="Calibri" pitchFamily="34" charset="-120"/>
+                <a:hlinkClick r:id="rId3" action="ppaction://hlinkfile"/>
+              </a:rPr>
+              <a:t> </a:t>
+            </a:r>
+            <a:r>
+              <a:rPr lang="en-US" sz="1100" dirty="0" err="1">
+                <a:solidFill>
+                  <a:srgbClr val="5C5C5C"/>
+                </a:solidFill>
+                <a:latin typeface="Marianne" panose="02000000000000000000" pitchFamily="50" charset="0"/>
+                <a:ea typeface="Calibri" pitchFamily="34" charset="-122"/>
+                <a:cs typeface="Calibri" pitchFamily="34" charset="-120"/>
+                <a:hlinkClick r:id="rId3" action="ppaction://hlinkfile"/>
+              </a:rPr>
+              <a:t>l’aide</a:t>
+            </a:r>
+            <a:endParaRPr lang="en-US" sz="1100" dirty="0">
+              <a:latin typeface="Marianne" panose="02000000000000000000" pitchFamily="50" charset="0"/>
+            </a:endParaRPr>
+          </a:p>
+        </p:txBody>
+      </p:sp>
+    </p:spTree>
+    <p:extLst>
+      <p:ext uri="{BB962C8B-B14F-4D97-AF65-F5344CB8AC3E}">
+        <p14:creationId xmlns:p14="http://schemas.microsoft.com/office/powerpoint/2010/main" val="3917010723"/>
+      </p:ext>
+    </p:extLst>
+  </p:cSld>
+  <p:clrMapOvr>
+    <a:masterClrMapping/>
+  </p:clrMapOvr>
+</p:sld>
+</file>
+
+<file path=ppt/slides/slide9.xml><?xml version="1.0" encoding="utf-8"?>
+<p:sld xmlns:a="http://schemas.openxmlformats.org/drawingml/2006/main" xmlns:r="http://schemas.openxmlformats.org/officeDocument/2006/relationships" xmlns:p="http://schemas.openxmlformats.org/presentationml/2006/main">
+  <p:cSld>
+    <p:spTree>
+      <p:nvGrpSpPr>
+        <p:cNvPr id="1" name="">
+          <a:extLst>
+            <a:ext uri="{FF2B5EF4-FFF2-40B4-BE49-F238E27FC236}">
+              <a16:creationId xmlns:a16="http://schemas.microsoft.com/office/drawing/2014/main" id="{955CEECE-80BD-24F5-29ED-51D02A8DC5DD}"/>
+            </a:ext>
+          </a:extLst>
+        </p:cNvPr>
+        <p:cNvGrpSpPr/>
+        <p:nvPr/>
+      </p:nvGrpSpPr>
+      <p:grpSpPr>
+        <a:xfrm>
+          <a:off x="0" y="0"/>
+          <a:ext cx="0" cy="0"/>
+          <a:chOff x="0" y="0"/>
+          <a:chExt cx="0" cy="0"/>
+        </a:xfrm>
+      </p:grpSpPr>
+      <p:sp>
+        <p:nvSpPr>
+          <p:cNvPr id="4" name="Text 2">
+            <a:extLst>
+              <a:ext uri="{FF2B5EF4-FFF2-40B4-BE49-F238E27FC236}">
+                <a16:creationId xmlns:a16="http://schemas.microsoft.com/office/drawing/2014/main" id="{3AA7DA23-AC46-53C2-5481-F11CF1FF75EA}"/>
+              </a:ext>
+            </a:extLst>
+          </p:cNvPr>
+          <p:cNvSpPr/>
+          <p:nvPr/>
+        </p:nvSpPr>
+        <p:spPr>
+          <a:xfrm>
+            <a:off x="609600" y="2202220"/>
+            <a:ext cx="10972800" cy="792480"/>
+          </a:xfrm>
+          <a:prstGeom prst="rect">
+            <a:avLst/>
+          </a:prstGeom>
+          <a:noFill/>
+          <a:ln/>
+        </p:spPr>
+        <p:txBody>
+          <a:bodyPr wrap="square" lIns="0" tIns="0" rIns="0" bIns="0" rtlCol="0" anchor="ctr"/>
+          <a:lstStyle/>
+          <a:p>
+            <a:r>
+              <a:rPr lang="en-US" sz="3733" b="1" dirty="0" err="1">
+                <a:solidFill>
+                  <a:srgbClr val="1A1A1A"/>
+                </a:solidFill>
+                <a:latin typeface="Marianne" panose="02000000000000000000" pitchFamily="50" charset="0"/>
+                <a:ea typeface="Calibri" pitchFamily="34" charset="-122"/>
+                <a:cs typeface="Calibri" pitchFamily="34" charset="-120"/>
+              </a:rPr>
+              <a:t>Ressources</a:t>
+            </a:r>
+            <a:r>
+              <a:rPr lang="en-US" sz="3733" b="1" dirty="0">
+                <a:solidFill>
+                  <a:srgbClr val="1A1A1A"/>
+                </a:solidFill>
+                <a:latin typeface="Marianne" panose="02000000000000000000" pitchFamily="50" charset="0"/>
+                <a:ea typeface="Calibri" pitchFamily="34" charset="-122"/>
+                <a:cs typeface="Calibri" pitchFamily="34" charset="-120"/>
+              </a:rPr>
+              <a:t> </a:t>
+            </a:r>
+            <a:r>
+              <a:rPr lang="en-US" sz="3733" b="1" dirty="0" err="1">
+                <a:solidFill>
+                  <a:srgbClr val="1A1A1A"/>
+                </a:solidFill>
+                <a:latin typeface="Marianne" panose="02000000000000000000" pitchFamily="50" charset="0"/>
+                <a:ea typeface="Calibri" pitchFamily="34" charset="-122"/>
+                <a:cs typeface="Calibri" pitchFamily="34" charset="-120"/>
+              </a:rPr>
+              <a:t>utiles</a:t>
+            </a:r>
+            <a:endParaRPr lang="en-US" sz="3733" dirty="0">
+              <a:latin typeface="Marianne" panose="02000000000000000000" pitchFamily="50" charset="0"/>
+            </a:endParaRPr>
+          </a:p>
+        </p:txBody>
+      </p:sp>
+      <p:sp>
+        <p:nvSpPr>
+          <p:cNvPr id="5" name="Shape 3">
+            <a:extLst>
+              <a:ext uri="{FF2B5EF4-FFF2-40B4-BE49-F238E27FC236}">
+                <a16:creationId xmlns:a16="http://schemas.microsoft.com/office/drawing/2014/main" id="{302F78CA-65FF-9043-6070-1584BC6D4D54}"/>
+              </a:ext>
+            </a:extLst>
+          </p:cNvPr>
+          <p:cNvSpPr/>
+          <p:nvPr/>
+        </p:nvSpPr>
+        <p:spPr>
+          <a:xfrm>
+            <a:off x="609600" y="3080044"/>
+            <a:ext cx="731520" cy="48768"/>
+          </a:xfrm>
+          <a:prstGeom prst="rect">
+            <a:avLst/>
+          </a:prstGeom>
+          <a:solidFill>
+            <a:srgbClr val="1A1A1A"/>
+          </a:solidFill>
+          <a:ln w="12700">
+            <a:solidFill>
+              <a:srgbClr val="1A1A1A"/>
+            </a:solidFill>
+            <a:prstDash val="solid"/>
+          </a:ln>
+        </p:spPr>
+        <p:txBody>
+          <a:bodyPr/>
+          <a:lstStyle/>
+          <a:p>
+            <a:endParaRPr lang="fr-FR" sz="2400">
               <a:latin typeface="Marianne" panose="02000000000000000000" pitchFamily="50" charset="0"/>
               <a:ea typeface="Calibri" panose="020F0502020204030204" pitchFamily="34" charset="0"/>
               <a:cs typeface="Calibri" panose="020F0502020204030204" pitchFamily="34" charset="0"/>
@@ -8989,66 +10062,149 @@
       </p:sp>
       <p:sp>
         <p:nvSpPr>
-          <p:cNvPr id="7" name="zone_ressources_fiche_solution">
-            <a:extLst>
-              <a:ext uri="{FF2B5EF4-FFF2-40B4-BE49-F238E27FC236}">
-                <a16:creationId xmlns:a16="http://schemas.microsoft.com/office/drawing/2014/main" id="{67927841-950D-B96E-D880-93E461963945}"/>
-              </a:ext>
-            </a:extLst>
-          </p:cNvPr>
-          <p:cNvSpPr txBox="1"/>
+          <p:cNvPr id="6" name="Text 4">
+            <a:extLst>
+              <a:ext uri="{FF2B5EF4-FFF2-40B4-BE49-F238E27FC236}">
+                <a16:creationId xmlns:a16="http://schemas.microsoft.com/office/drawing/2014/main" id="{9328B9A3-CC8F-11E9-FAB1-0824EF7E88D7}"/>
+              </a:ext>
+            </a:extLst>
+          </p:cNvPr>
+          <p:cNvSpPr/>
           <p:nvPr/>
         </p:nvSpPr>
         <p:spPr>
           <a:xfrm>
-            <a:off x="839464" y="1626616"/>
-            <a:ext cx="9706988" cy="276999"/>
+            <a:off x="609600" y="3398401"/>
+            <a:ext cx="10972800" cy="2879386"/>
           </a:xfrm>
           <a:prstGeom prst="rect">
             <a:avLst/>
           </a:prstGeom>
           <a:noFill/>
-        </p:spPr>
-        <p:txBody>
-          <a:bodyPr wrap="square">
-            <a:spAutoFit/>
-          </a:bodyPr>
-          <a:lstStyle/>
-          <a:p>
-            <a:r>
-              <a:rPr lang="fr-FR" sz="1200" dirty="0">
-                <a:solidFill>
-                  <a:srgbClr val="161616"/>
+          <a:ln/>
+        </p:spPr>
+        <p:txBody>
+          <a:bodyPr wrap="square" lIns="0" tIns="0" rIns="0" bIns="0" rtlCol="0" anchor="t"/>
+          <a:lstStyle/>
+          <a:p>
+            <a:pPr marL="0" indent="0">
+              <a:buNone/>
+            </a:pPr>
+            <a:r>
+              <a:rPr lang="en-US" sz="1600" dirty="0">
+                <a:solidFill>
+                  <a:srgbClr val="5C5C5C"/>
+                </a:solidFill>
+                <a:latin typeface="Marianne" panose="02000000000000000000" pitchFamily="50" charset="0"/>
+                <a:ea typeface="Calibri" pitchFamily="34" charset="-122"/>
+                <a:cs typeface="Calibri" pitchFamily="34" charset="-120"/>
+              </a:rPr>
+              <a:t>Documentation </a:t>
+            </a:r>
+            <a:r>
+              <a:rPr lang="en-US" sz="1600" dirty="0" err="1">
+                <a:solidFill>
+                  <a:srgbClr val="5C5C5C"/>
+                </a:solidFill>
+                <a:latin typeface="Marianne" panose="02000000000000000000" pitchFamily="50" charset="0"/>
+                <a:ea typeface="Calibri" pitchFamily="34" charset="-122"/>
+                <a:cs typeface="Calibri" pitchFamily="34" charset="-120"/>
+              </a:rPr>
+              <a:t>complémentaire</a:t>
+            </a:r>
+            <a:endParaRPr lang="en-US" sz="1600" dirty="0">
+              <a:latin typeface="Marianne" panose="02000000000000000000" pitchFamily="50" charset="0"/>
+            </a:endParaRPr>
+          </a:p>
+        </p:txBody>
+      </p:sp>
+      <p:cxnSp>
+        <p:nvCxnSpPr>
+          <p:cNvPr id="2" name="Connecteur droit 1">
+            <a:extLst>
+              <a:ext uri="{FF2B5EF4-FFF2-40B4-BE49-F238E27FC236}">
+                <a16:creationId xmlns:a16="http://schemas.microsoft.com/office/drawing/2014/main" id="{A3CAC41A-66B0-361D-B372-62D87EE7A9F8}"/>
+              </a:ext>
+            </a:extLst>
+          </p:cNvPr>
+          <p:cNvCxnSpPr>
+            <a:cxnSpLocks/>
+          </p:cNvCxnSpPr>
+          <p:nvPr/>
+        </p:nvCxnSpPr>
+        <p:spPr>
+          <a:xfrm>
+            <a:off x="576263" y="6512991"/>
+            <a:ext cx="11615737" cy="0"/>
+          </a:xfrm>
+          <a:prstGeom prst="line">
+            <a:avLst/>
+          </a:prstGeom>
+          <a:ln>
+            <a:solidFill>
+              <a:schemeClr val="bg1">
+                <a:lumMod val="85000"/>
+              </a:schemeClr>
+            </a:solidFill>
+          </a:ln>
+        </p:spPr>
+        <p:style>
+          <a:lnRef idx="2">
+            <a:schemeClr val="accent1"/>
+          </a:lnRef>
+          <a:fillRef idx="0">
+            <a:schemeClr val="accent1"/>
+          </a:fillRef>
+          <a:effectRef idx="1">
+            <a:schemeClr val="accent1"/>
+          </a:effectRef>
+          <a:fontRef idx="minor">
+            <a:schemeClr val="tx1"/>
+          </a:fontRef>
+        </p:style>
+      </p:cxnSp>
+      <p:sp>
+        <p:nvSpPr>
+          <p:cNvPr id="8" name="Text 3">
+            <a:extLst>
+              <a:ext uri="{FF2B5EF4-FFF2-40B4-BE49-F238E27FC236}">
+                <a16:creationId xmlns:a16="http://schemas.microsoft.com/office/drawing/2014/main" id="{515558A7-65FA-3B23-4336-CA7CF66783E3}"/>
+              </a:ext>
+            </a:extLst>
+          </p:cNvPr>
+          <p:cNvSpPr/>
+          <p:nvPr/>
+        </p:nvSpPr>
+        <p:spPr>
+          <a:xfrm>
+            <a:off x="576263" y="6598217"/>
+            <a:ext cx="8229600" cy="182880"/>
+          </a:xfrm>
+          <a:prstGeom prst="rect">
+            <a:avLst/>
+          </a:prstGeom>
+          <a:noFill/>
+          <a:ln/>
+        </p:spPr>
+        <p:txBody>
+          <a:bodyPr wrap="square" lIns="0" tIns="0" rIns="0" bIns="0" rtlCol="0" anchor="ctr"/>
+          <a:lstStyle/>
+          <a:p>
+            <a:pPr marL="0" indent="0">
+              <a:buNone/>
+            </a:pPr>
+            <a:r>
+              <a:rPr lang="en-US" sz="1000" i="1">
+                <a:solidFill>
+                  <a:srgbClr val="A0A0A0"/>
                 </a:solidFill>
                 <a:latin typeface="Marianne" panose="02000000000000000000" pitchFamily="50" charset="0"/>
                 <a:ea typeface="Calibri" panose="020F0502020204030204" pitchFamily="34" charset="0"/>
                 <a:cs typeface="Calibri" panose="020F0502020204030204" pitchFamily="34" charset="0"/>
               </a:rPr>
-              <a:t>{{</a:t>
-            </a:r>
-            <a:r>
-              <a:rPr lang="fr-FR" sz="1200" dirty="0" err="1">
-                <a:solidFill>
-                  <a:srgbClr val="161616"/>
-                </a:solidFill>
-                <a:latin typeface="Marianne" panose="02000000000000000000" pitchFamily="50" charset="0"/>
-                <a:ea typeface="Calibri" panose="020F0502020204030204" pitchFamily="34" charset="0"/>
-                <a:cs typeface="Calibri" panose="020F0502020204030204" pitchFamily="34" charset="0"/>
-              </a:rPr>
-              <a:t>ressources_utiles_fiche_solution</a:t>
-            </a:r>
-            <a:r>
-              <a:rPr lang="fr-FR" sz="1200" dirty="0">
-                <a:solidFill>
-                  <a:srgbClr val="161616"/>
-                </a:solidFill>
-                <a:latin typeface="Marianne" panose="02000000000000000000" pitchFamily="50" charset="0"/>
-                <a:ea typeface="Calibri" panose="020F0502020204030204" pitchFamily="34" charset="0"/>
-                <a:cs typeface="Calibri" panose="020F0502020204030204" pitchFamily="34" charset="0"/>
-              </a:rPr>
-              <a:t>}}</a:t>
-            </a:r>
-            <a:endParaRPr lang="fr-FR" sz="1200" dirty="0">
+              <a:t>Données issues de Plus fraîche ma ville (ADEME)</a:t>
+            </a:r>
+            <a:endParaRPr lang="en-US" sz="1000">
               <a:latin typeface="Marianne" panose="02000000000000000000" pitchFamily="50" charset="0"/>
               <a:ea typeface="Calibri" panose="020F0502020204030204" pitchFamily="34" charset="0"/>
               <a:cs typeface="Calibri" panose="020F0502020204030204" pitchFamily="34" charset="0"/>
@@ -9058,10 +10214,10 @@
       </p:sp>
       <p:pic>
         <p:nvPicPr>
-          <p:cNvPr id="3" name="Picture 3">
-            <a:extLst>
-              <a:ext uri="{FF2B5EF4-FFF2-40B4-BE49-F238E27FC236}">
-                <a16:creationId xmlns:a16="http://schemas.microsoft.com/office/drawing/2014/main" id="{7D131FE9-968A-7934-D330-1035AA73A364}"/>
+          <p:cNvPr id="7" name="Picture 9">
+            <a:extLst>
+              <a:ext uri="{FF2B5EF4-FFF2-40B4-BE49-F238E27FC236}">
+                <a16:creationId xmlns:a16="http://schemas.microsoft.com/office/drawing/2014/main" id="{E922595D-B49E-4187-3566-440EF1D1B583}"/>
               </a:ext>
             </a:extLst>
           </p:cNvPr>
@@ -9071,7 +10227,7 @@
           <p:nvPr/>
         </p:nvPicPr>
         <p:blipFill>
-          <a:blip r:embed="rId2"/>
+          <a:blip r:embed="rId3"/>
           <a:stretch>
             <a:fillRect/>
           </a:stretch>
@@ -9089,7 +10245,7 @@
     </p:spTree>
     <p:extLst>
       <p:ext uri="{BB962C8B-B14F-4D97-AF65-F5344CB8AC3E}">
-        <p14:creationId xmlns:p14="http://schemas.microsoft.com/office/powerpoint/2010/main" val="1015688024"/>
+        <p14:creationId xmlns:p14="http://schemas.microsoft.com/office/powerpoint/2010/main" val="2848617555"/>
       </p:ext>
     </p:extLst>
   </p:cSld>

</xml_diff>

<commit_message>
feat: Rajout des aides dans l'export ppt
</commit_message>
<xml_diff>
--- a/public/templates/template_synthese_projet.pptx
+++ b/public/templates/template_synthese_projet.pptx
@@ -9441,7 +9441,7 @@
       </p:sp>
       <p:sp>
         <p:nvSpPr>
-          <p:cNvPr id="32" name="Text 6">
+          <p:cNvPr id="32" name="zone_aide_type">
             <a:extLst>
               <a:ext uri="{FF2B5EF4-FFF2-40B4-BE49-F238E27FC236}">
                 <a16:creationId xmlns:a16="http://schemas.microsoft.com/office/drawing/2014/main" id="{CA13F4C7-9C9C-5D69-7ABF-29ED7E1E953C}"/>
@@ -9453,7 +9453,7 @@
         </p:nvSpPr>
         <p:spPr>
           <a:xfrm>
-            <a:off x="759144" y="1527451"/>
+            <a:off x="759144" y="1502851"/>
             <a:ext cx="7955280" cy="201168"/>
           </a:xfrm>
           <a:prstGeom prst="rect">
@@ -9525,7 +9525,7 @@
       </p:sp>
       <p:sp>
         <p:nvSpPr>
-          <p:cNvPr id="33" name="Text 7">
+          <p:cNvPr id="33" name="zone_aide_titre">
             <a:extLst>
               <a:ext uri="{FF2B5EF4-FFF2-40B4-BE49-F238E27FC236}">
                 <a16:creationId xmlns:a16="http://schemas.microsoft.com/office/drawing/2014/main" id="{3A009836-E679-1A4E-868D-C41048F4DF96}"/>
@@ -9538,7 +9538,7 @@
         <p:spPr>
           <a:xfrm>
             <a:off x="759143" y="1710331"/>
-            <a:ext cx="9981503" cy="347472"/>
+            <a:ext cx="10187280" cy="407154"/>
           </a:xfrm>
           <a:prstGeom prst="rect">
             <a:avLst/>
@@ -9547,148 +9547,24 @@
           <a:ln/>
         </p:spPr>
         <p:txBody>
-          <a:bodyPr wrap="square" lIns="0" tIns="0" rIns="0" bIns="0" rtlCol="0" anchor="ctr"/>
-          <a:lstStyle/>
-          <a:p>
-            <a:pPr marL="0" indent="0">
-              <a:buNone/>
-            </a:pPr>
-            <a:r>
-              <a:rPr lang="en-US" sz="1600" b="1" dirty="0">
+          <a:bodyPr wrap="square" lIns="0" tIns="0" rIns="0" bIns="0" rtlCol="0" anchor="t"/>
+          <a:lstStyle/>
+          <a:p>
+            <a:r>
+              <a:rPr lang="en-US" sz="1400" b="1" dirty="0">
                 <a:latin typeface="Marianne" panose="02000000000000000000" pitchFamily="50" charset="0"/>
               </a:rPr>
               <a:t>{{</a:t>
             </a:r>
             <a:r>
-              <a:rPr lang="en-US" sz="1600" b="1" dirty="0" err="1">
+              <a:rPr lang="en-US" sz="1400" b="1" dirty="0" err="1">
                 <a:latin typeface="Marianne" panose="02000000000000000000" pitchFamily="50" charset="0"/>
               </a:rPr>
               <a:t>aide_nom</a:t>
             </a:r>
             <a:r>
-              <a:rPr lang="en-US" sz="1600" b="1" dirty="0">
-                <a:latin typeface="Marianne" panose="02000000000000000000" pitchFamily="50" charset="0"/>
-              </a:rPr>
-              <a:t>}}</a:t>
-            </a:r>
-          </a:p>
-        </p:txBody>
-      </p:sp>
-      <p:sp>
-        <p:nvSpPr>
-          <p:cNvPr id="34" name="Text 8">
-            <a:extLst>
-              <a:ext uri="{FF2B5EF4-FFF2-40B4-BE49-F238E27FC236}">
-                <a16:creationId xmlns:a16="http://schemas.microsoft.com/office/drawing/2014/main" id="{63CA8282-153C-FA82-28E2-0A7385CED3A7}"/>
-              </a:ext>
-            </a:extLst>
-          </p:cNvPr>
-          <p:cNvSpPr/>
-          <p:nvPr/>
-        </p:nvSpPr>
-        <p:spPr>
-          <a:xfrm>
-            <a:off x="759144" y="2174069"/>
-            <a:ext cx="9981502" cy="320040"/>
-          </a:xfrm>
-          <a:prstGeom prst="rect">
-            <a:avLst/>
-          </a:prstGeom>
-          <a:noFill/>
-          <a:ln/>
-        </p:spPr>
-        <p:txBody>
-          <a:bodyPr wrap="square" lIns="0" tIns="0" rIns="0" bIns="0" rtlCol="0" anchor="ctr"/>
-          <a:lstStyle/>
-          <a:p>
-            <a:pPr marL="0" indent="0">
-              <a:buNone/>
-            </a:pPr>
-            <a:r>
-              <a:rPr lang="en-US" sz="1100" dirty="0" err="1">
-                <a:solidFill>
-                  <a:srgbClr val="5C5C5C"/>
-                </a:solidFill>
-                <a:latin typeface="Marianne" panose="02000000000000000000" pitchFamily="50" charset="0"/>
-                <a:ea typeface="Calibri" pitchFamily="34" charset="-122"/>
-                <a:cs typeface="Calibri" pitchFamily="34" charset="-120"/>
-              </a:rPr>
-              <a:t>Porteur</a:t>
-            </a:r>
-            <a:r>
-              <a:rPr lang="en-US" sz="1100" dirty="0">
-                <a:solidFill>
-                  <a:srgbClr val="5C5C5C"/>
-                </a:solidFill>
-                <a:latin typeface="Marianne" panose="02000000000000000000" pitchFamily="50" charset="0"/>
-                <a:ea typeface="Calibri" pitchFamily="34" charset="-122"/>
-                <a:cs typeface="Calibri" pitchFamily="34" charset="-120"/>
-              </a:rPr>
-              <a:t> : {{</a:t>
-            </a:r>
-            <a:r>
-              <a:rPr lang="en-US" sz="1100" dirty="0" err="1">
-                <a:solidFill>
-                  <a:srgbClr val="5C5C5C"/>
-                </a:solidFill>
-                <a:latin typeface="Marianne" panose="02000000000000000000" pitchFamily="50" charset="0"/>
-                <a:ea typeface="Calibri" pitchFamily="34" charset="-122"/>
-                <a:cs typeface="Calibri" pitchFamily="34" charset="-120"/>
-              </a:rPr>
-              <a:t>aide_financiers</a:t>
-            </a:r>
-            <a:r>
-              <a:rPr lang="en-US" sz="1100" dirty="0">
-                <a:solidFill>
-                  <a:srgbClr val="5C5C5C"/>
-                </a:solidFill>
-                <a:latin typeface="Marianne" panose="02000000000000000000" pitchFamily="50" charset="0"/>
-                <a:ea typeface="Calibri" pitchFamily="34" charset="-122"/>
-                <a:cs typeface="Calibri" pitchFamily="34" charset="-120"/>
-              </a:rPr>
-              <a:t>}}  ·  </a:t>
-            </a:r>
-            <a:r>
-              <a:rPr lang="en-US" sz="1100" dirty="0" err="1">
-                <a:solidFill>
-                  <a:srgbClr val="5C5C5C"/>
-                </a:solidFill>
-                <a:latin typeface="Marianne" panose="02000000000000000000" pitchFamily="50" charset="0"/>
-                <a:ea typeface="Calibri" pitchFamily="34" charset="-122"/>
-                <a:cs typeface="Calibri" pitchFamily="34" charset="-120"/>
-              </a:rPr>
-              <a:t>Échéance</a:t>
-            </a:r>
-            <a:r>
-              <a:rPr lang="en-US" sz="1100" dirty="0">
-                <a:solidFill>
-                  <a:srgbClr val="5C5C5C"/>
-                </a:solidFill>
-                <a:latin typeface="Marianne" panose="02000000000000000000" pitchFamily="50" charset="0"/>
-                <a:ea typeface="Calibri" pitchFamily="34" charset="-122"/>
-                <a:cs typeface="Calibri" pitchFamily="34" charset="-120"/>
-              </a:rPr>
-              <a:t> : {{</a:t>
-            </a:r>
-            <a:r>
-              <a:rPr lang="en-US" sz="1100" dirty="0" err="1">
-                <a:solidFill>
-                  <a:srgbClr val="5C5C5C"/>
-                </a:solidFill>
-                <a:latin typeface="Marianne" panose="02000000000000000000" pitchFamily="50" charset="0"/>
-                <a:ea typeface="Calibri" pitchFamily="34" charset="-122"/>
-                <a:cs typeface="Calibri" pitchFamily="34" charset="-120"/>
-              </a:rPr>
-              <a:t>aide_echeance</a:t>
-            </a:r>
-            <a:r>
-              <a:rPr lang="en-US" sz="1100" dirty="0">
-                <a:solidFill>
-                  <a:srgbClr val="5C5C5C"/>
-                </a:solidFill>
-                <a:latin typeface="Marianne" panose="02000000000000000000" pitchFamily="50" charset="0"/>
-                <a:ea typeface="Calibri" pitchFamily="34" charset="-122"/>
-                <a:cs typeface="Calibri" pitchFamily="34" charset="-120"/>
+              <a:rPr lang="en-US" sz="1400" b="1" dirty="0">
+                <a:latin typeface="Marianne" panose="02000000000000000000" pitchFamily="50" charset="0"/>
               </a:rPr>
               <a:t>}}</a:t>
             </a:r>
@@ -9834,7 +9710,7 @@
       </p:cxnSp>
       <p:sp>
         <p:nvSpPr>
-          <p:cNvPr id="7" name="Text 8">
+          <p:cNvPr id="7" name="zone_aide_lien">
             <a:extLst>
               <a:ext uri="{FF2B5EF4-FFF2-40B4-BE49-F238E27FC236}">
                 <a16:creationId xmlns:a16="http://schemas.microsoft.com/office/drawing/2014/main" id="{00ED1968-10CF-E3DC-940B-6214BFEF0E99}"/>
@@ -9846,8 +9722,8 @@
         </p:nvSpPr>
         <p:spPr>
           <a:xfrm>
-            <a:off x="759143" y="2417168"/>
-            <a:ext cx="1466775" cy="320040"/>
+            <a:off x="759143" y="2448390"/>
+            <a:ext cx="1466775" cy="288818"/>
           </a:xfrm>
           <a:prstGeom prst="rect">
             <a:avLst/>
@@ -9872,7 +9748,7 @@
                 <a:cs typeface="Calibri" pitchFamily="34" charset="-120"/>
                 <a:hlinkClick r:id="rId3" action="ppaction://hlinkfile"/>
               </a:rPr>
-              <a:t>Lien </a:t>
+              <a:t>{{</a:t>
             </a:r>
             <a:r>
               <a:rPr lang="en-US" sz="1100" dirty="0" err="1">
@@ -9884,7 +9760,7 @@
                 <a:cs typeface="Calibri" pitchFamily="34" charset="-120"/>
                 <a:hlinkClick r:id="rId3" action="ppaction://hlinkfile"/>
               </a:rPr>
-              <a:t>vers</a:t>
+              <a:t>aide_lien</a:t>
             </a:r>
             <a:r>
               <a:rPr lang="en-US" sz="1100" dirty="0">
@@ -9896,23 +9772,129 @@
                 <a:cs typeface="Calibri" pitchFamily="34" charset="-120"/>
                 <a:hlinkClick r:id="rId3" action="ppaction://hlinkfile"/>
               </a:rPr>
-              <a:t> </a:t>
-            </a:r>
-            <a:r>
-              <a:rPr lang="en-US" sz="1100" dirty="0" err="1">
-                <a:solidFill>
-                  <a:srgbClr val="5C5C5C"/>
-                </a:solidFill>
-                <a:latin typeface="Marianne" panose="02000000000000000000" pitchFamily="50" charset="0"/>
-                <a:ea typeface="Calibri" pitchFamily="34" charset="-122"/>
-                <a:cs typeface="Calibri" pitchFamily="34" charset="-120"/>
-                <a:hlinkClick r:id="rId3" action="ppaction://hlinkfile"/>
-              </a:rPr>
-              <a:t>l’aide</a:t>
+              <a:t>}}</a:t>
             </a:r>
             <a:endParaRPr lang="en-US" sz="1100" dirty="0">
               <a:latin typeface="Marianne" panose="02000000000000000000" pitchFamily="50" charset="0"/>
             </a:endParaRPr>
+          </a:p>
+        </p:txBody>
+      </p:sp>
+      <p:sp>
+        <p:nvSpPr>
+          <p:cNvPr id="3" name="zone_aide_details">
+            <a:extLst>
+              <a:ext uri="{FF2B5EF4-FFF2-40B4-BE49-F238E27FC236}">
+                <a16:creationId xmlns:a16="http://schemas.microsoft.com/office/drawing/2014/main" id="{245A9113-DBB3-676F-614B-19E985C21046}"/>
+              </a:ext>
+            </a:extLst>
+          </p:cNvPr>
+          <p:cNvSpPr/>
+          <p:nvPr/>
+        </p:nvSpPr>
+        <p:spPr>
+          <a:xfrm>
+            <a:off x="759143" y="2139464"/>
+            <a:ext cx="10187280" cy="397115"/>
+          </a:xfrm>
+          <a:prstGeom prst="rect">
+            <a:avLst/>
+          </a:prstGeom>
+          <a:noFill/>
+          <a:ln/>
+        </p:spPr>
+        <p:txBody>
+          <a:bodyPr wrap="square" lIns="0" tIns="0" rIns="0" bIns="0" rtlCol="0" anchor="t"/>
+          <a:lstStyle/>
+          <a:p>
+            <a:r>
+              <a:rPr lang="en-US" sz="1100" dirty="0" err="1">
+                <a:solidFill>
+                  <a:srgbClr val="5C5C5C"/>
+                </a:solidFill>
+                <a:latin typeface="Marianne" panose="02000000000000000000" pitchFamily="50" charset="0"/>
+                <a:ea typeface="Calibri" pitchFamily="34" charset="-122"/>
+                <a:cs typeface="Calibri" pitchFamily="34" charset="-120"/>
+              </a:rPr>
+              <a:t>Porteur</a:t>
+            </a:r>
+            <a:r>
+              <a:rPr lang="en-US" sz="1100" dirty="0">
+                <a:solidFill>
+                  <a:srgbClr val="5C5C5C"/>
+                </a:solidFill>
+                <a:latin typeface="Marianne" panose="02000000000000000000" pitchFamily="50" charset="0"/>
+                <a:ea typeface="Calibri" pitchFamily="34" charset="-122"/>
+                <a:cs typeface="Calibri" pitchFamily="34" charset="-120"/>
+              </a:rPr>
+              <a:t> : {{</a:t>
+            </a:r>
+            <a:r>
+              <a:rPr lang="en-US" sz="1100" dirty="0" err="1">
+                <a:solidFill>
+                  <a:srgbClr val="5C5C5C"/>
+                </a:solidFill>
+                <a:latin typeface="Marianne" panose="02000000000000000000" pitchFamily="50" charset="0"/>
+                <a:ea typeface="Calibri" pitchFamily="34" charset="-122"/>
+                <a:cs typeface="Calibri" pitchFamily="34" charset="-120"/>
+              </a:rPr>
+              <a:t>aide_financiers</a:t>
+            </a:r>
+            <a:r>
+              <a:rPr lang="en-US" sz="1100" dirty="0">
+                <a:solidFill>
+                  <a:srgbClr val="5C5C5C"/>
+                </a:solidFill>
+                <a:latin typeface="Marianne" panose="02000000000000000000" pitchFamily="50" charset="0"/>
+                <a:ea typeface="Calibri" pitchFamily="34" charset="-122"/>
+                <a:cs typeface="Calibri" pitchFamily="34" charset="-120"/>
+              </a:rPr>
+              <a:t>}}  ·  </a:t>
+            </a:r>
+            <a:r>
+              <a:rPr lang="en-US" sz="1100" dirty="0" err="1">
+                <a:solidFill>
+                  <a:srgbClr val="5C5C5C"/>
+                </a:solidFill>
+                <a:latin typeface="Marianne" panose="02000000000000000000" pitchFamily="50" charset="0"/>
+                <a:ea typeface="Calibri" pitchFamily="34" charset="-122"/>
+                <a:cs typeface="Calibri" pitchFamily="34" charset="-120"/>
+              </a:rPr>
+              <a:t>Échéance</a:t>
+            </a:r>
+            <a:r>
+              <a:rPr lang="en-US" sz="1100" dirty="0">
+                <a:solidFill>
+                  <a:srgbClr val="5C5C5C"/>
+                </a:solidFill>
+                <a:latin typeface="Marianne" panose="02000000000000000000" pitchFamily="50" charset="0"/>
+                <a:ea typeface="Calibri" pitchFamily="34" charset="-122"/>
+                <a:cs typeface="Calibri" pitchFamily="34" charset="-120"/>
+              </a:rPr>
+              <a:t> : {{</a:t>
+            </a:r>
+            <a:r>
+              <a:rPr lang="en-US" sz="1100" dirty="0" err="1">
+                <a:solidFill>
+                  <a:srgbClr val="5C5C5C"/>
+                </a:solidFill>
+                <a:latin typeface="Marianne" panose="02000000000000000000" pitchFamily="50" charset="0"/>
+                <a:ea typeface="Calibri" pitchFamily="34" charset="-122"/>
+                <a:cs typeface="Calibri" pitchFamily="34" charset="-120"/>
+              </a:rPr>
+              <a:t>aide_echeance</a:t>
+            </a:r>
+            <a:r>
+              <a:rPr lang="en-US" sz="1100" dirty="0">
+                <a:solidFill>
+                  <a:srgbClr val="5C5C5C"/>
+                </a:solidFill>
+                <a:latin typeface="Marianne" panose="02000000000000000000" pitchFamily="50" charset="0"/>
+                <a:ea typeface="Calibri" pitchFamily="34" charset="-122"/>
+                <a:cs typeface="Calibri" pitchFamily="34" charset="-120"/>
+              </a:rPr>
+              <a:t>}}</a:t>
+            </a:r>
           </a:p>
         </p:txBody>
       </p:sp>

</xml_diff>

<commit_message>
feat: Rajout d'un spinner pendant la génération du ppt
</commit_message>
<xml_diff>
--- a/public/templates/template_synthese_projet.pptx
+++ b/public/templates/template_synthese_projet.pptx
@@ -6875,7 +6875,7 @@
         </p:nvSpPr>
         <p:spPr>
           <a:xfrm>
-            <a:off x="958362" y="1914129"/>
+            <a:off x="958362" y="1852627"/>
             <a:ext cx="9324890" cy="1414017"/>
           </a:xfrm>
           <a:prstGeom prst="roundRect">
@@ -6924,7 +6924,7 @@
         </p:nvSpPr>
         <p:spPr>
           <a:xfrm>
-            <a:off x="2360736" y="1974626"/>
+            <a:off x="2360736" y="1913124"/>
             <a:ext cx="6059347" cy="307777"/>
           </a:xfrm>
           <a:prstGeom prst="rect">
@@ -6979,7 +6979,7 @@
         </p:nvSpPr>
         <p:spPr>
           <a:xfrm>
-            <a:off x="8256494" y="1974626"/>
+            <a:off x="8256494" y="1913124"/>
             <a:ext cx="1908065" cy="307777"/>
           </a:xfrm>
           <a:prstGeom prst="rect">
@@ -7056,7 +7056,7 @@
         </p:blipFill>
         <p:spPr>
           <a:xfrm>
-            <a:off x="1137626" y="2083397"/>
+            <a:off x="1137626" y="2021895"/>
             <a:ext cx="1043847" cy="1075479"/>
           </a:xfrm>
           <a:prstGeom prst="rect">
@@ -7078,7 +7078,7 @@
         </p:nvSpPr>
         <p:spPr>
           <a:xfrm>
-            <a:off x="2360736" y="2238961"/>
+            <a:off x="2360736" y="2177459"/>
             <a:ext cx="7349126" cy="632610"/>
           </a:xfrm>
           <a:prstGeom prst="rect">
@@ -7127,7 +7127,7 @@
         </p:nvSpPr>
         <p:spPr>
           <a:xfrm>
-            <a:off x="2360736" y="2947998"/>
+            <a:off x="2360736" y="2886496"/>
             <a:ext cx="7188518" cy="276999"/>
           </a:xfrm>
           <a:prstGeom prst="rect">

</xml_diff>

<commit_message>
feat: utiliser la police Mariane dans les ressources utiles
</commit_message>
<xml_diff>
--- a/public/templates/template_synthese_projet.pptx
+++ b/public/templates/template_synthese_projet.pptx
@@ -215,7 +215,7 @@
           <a:p>
             <a:fld id="{4C638A9C-6ED0-4718-B5E7-9D405962C144}" type="datetimeFigureOut">
               <a:rPr lang="fr-FR" smtClean="0"/>
-              <a:t>18/09/2026</a:t>
+              <a:t>22/09/2026</a:t>
             </a:fld>
             <a:endParaRPr lang="fr-FR"/>
           </a:p>
@@ -1061,7 +1061,7 @@
           <a:p>
             <a:fld id="{82E7F8B9-DFDB-4965-877D-C04A580740C9}" type="datetimeFigureOut">
               <a:rPr lang="fr-FR" smtClean="0"/>
-              <a:t>18/09/2026</a:t>
+              <a:t>22/09/2026</a:t>
             </a:fld>
             <a:endParaRPr lang="fr-FR"/>
           </a:p>
@@ -1259,7 +1259,7 @@
           <a:p>
             <a:fld id="{82E7F8B9-DFDB-4965-877D-C04A580740C9}" type="datetimeFigureOut">
               <a:rPr lang="fr-FR" smtClean="0"/>
-              <a:t>18/09/2026</a:t>
+              <a:t>22/09/2026</a:t>
             </a:fld>
             <a:endParaRPr lang="fr-FR"/>
           </a:p>
@@ -1467,7 +1467,7 @@
           <a:p>
             <a:fld id="{82E7F8B9-DFDB-4965-877D-C04A580740C9}" type="datetimeFigureOut">
               <a:rPr lang="fr-FR" smtClean="0"/>
-              <a:t>18/09/2026</a:t>
+              <a:t>22/09/2026</a:t>
             </a:fld>
             <a:endParaRPr lang="fr-FR"/>
           </a:p>
@@ -1700,7 +1700,7 @@
           <a:p>
             <a:fld id="{82E7F8B9-DFDB-4965-877D-C04A580740C9}" type="datetimeFigureOut">
               <a:rPr lang="fr-FR" smtClean="0"/>
-              <a:t>18/09/2026</a:t>
+              <a:t>22/09/2026</a:t>
             </a:fld>
             <a:endParaRPr lang="fr-FR"/>
           </a:p>
@@ -1975,7 +1975,7 @@
           <a:p>
             <a:fld id="{82E7F8B9-DFDB-4965-877D-C04A580740C9}" type="datetimeFigureOut">
               <a:rPr lang="fr-FR" smtClean="0"/>
-              <a:t>18/09/2026</a:t>
+              <a:t>22/09/2026</a:t>
             </a:fld>
             <a:endParaRPr lang="fr-FR"/>
           </a:p>
@@ -2240,7 +2240,7 @@
           <a:p>
             <a:fld id="{82E7F8B9-DFDB-4965-877D-C04A580740C9}" type="datetimeFigureOut">
               <a:rPr lang="fr-FR" smtClean="0"/>
-              <a:t>18/09/2026</a:t>
+              <a:t>22/09/2026</a:t>
             </a:fld>
             <a:endParaRPr lang="fr-FR"/>
           </a:p>
@@ -2652,7 +2652,7 @@
           <a:p>
             <a:fld id="{82E7F8B9-DFDB-4965-877D-C04A580740C9}" type="datetimeFigureOut">
               <a:rPr lang="fr-FR" smtClean="0"/>
-              <a:t>18/09/2026</a:t>
+              <a:t>22/09/2026</a:t>
             </a:fld>
             <a:endParaRPr lang="fr-FR"/>
           </a:p>
@@ -2793,7 +2793,7 @@
           <a:p>
             <a:fld id="{82E7F8B9-DFDB-4965-877D-C04A580740C9}" type="datetimeFigureOut">
               <a:rPr lang="fr-FR" smtClean="0"/>
-              <a:t>18/09/2026</a:t>
+              <a:t>22/09/2026</a:t>
             </a:fld>
             <a:endParaRPr lang="fr-FR"/>
           </a:p>
@@ -2906,7 +2906,7 @@
           <a:p>
             <a:fld id="{82E7F8B9-DFDB-4965-877D-C04A580740C9}" type="datetimeFigureOut">
               <a:rPr lang="fr-FR" smtClean="0"/>
-              <a:t>18/09/2026</a:t>
+              <a:t>22/09/2026</a:t>
             </a:fld>
             <a:endParaRPr lang="fr-FR"/>
           </a:p>
@@ -3217,7 +3217,7 @@
           <a:p>
             <a:fld id="{82E7F8B9-DFDB-4965-877D-C04A580740C9}" type="datetimeFigureOut">
               <a:rPr lang="fr-FR" smtClean="0"/>
-              <a:t>18/09/2026</a:t>
+              <a:t>22/09/2026</a:t>
             </a:fld>
             <a:endParaRPr lang="fr-FR"/>
           </a:p>
@@ -3505,7 +3505,7 @@
           <a:p>
             <a:fld id="{82E7F8B9-DFDB-4965-877D-C04A580740C9}" type="datetimeFigureOut">
               <a:rPr lang="fr-FR" smtClean="0"/>
-              <a:t>18/09/2026</a:t>
+              <a:t>22/09/2026</a:t>
             </a:fld>
             <a:endParaRPr lang="fr-FR"/>
           </a:p>
@@ -3746,7 +3746,7 @@
           <a:p>
             <a:fld id="{82E7F8B9-DFDB-4965-877D-C04A580740C9}" type="datetimeFigureOut">
               <a:rPr lang="fr-FR" smtClean="0"/>
-              <a:t>18/09/2026</a:t>
+              <a:t>22/09/2026</a:t>
             </a:fld>
             <a:endParaRPr lang="fr-FR"/>
           </a:p>
@@ -9537,7 +9537,7 @@
         </p:nvSpPr>
         <p:spPr>
           <a:xfrm>
-            <a:off x="759143" y="1710331"/>
+            <a:off x="759143" y="1719567"/>
             <a:ext cx="10187280" cy="407154"/>
           </a:xfrm>
           <a:prstGeom prst="rect">
@@ -9547,9 +9547,16 @@
           <a:ln/>
         </p:spPr>
         <p:txBody>
-          <a:bodyPr wrap="square" lIns="0" tIns="0" rIns="0" bIns="0" rtlCol="0" anchor="t"/>
-          <a:lstStyle/>
-          <a:p>
+          <a:bodyPr wrap="square" lIns="0" tIns="0" rIns="0" bIns="0" rtlCol="0" anchor="t">
+            <a:normAutofit/>
+          </a:bodyPr>
+          <a:lstStyle/>
+          <a:p>
+            <a:pPr>
+              <a:lnSpc>
+                <a:spcPts val="1400"/>
+              </a:lnSpc>
+            </a:pPr>
             <a:r>
               <a:rPr lang="en-US" sz="1400" b="1" dirty="0">
                 <a:latin typeface="Marianne" panose="02000000000000000000" pitchFamily="50" charset="0"/>
@@ -9563,11 +9570,14 @@
               <a:t>aide_nom</a:t>
             </a:r>
             <a:r>
-              <a:rPr lang="en-US" sz="1400" b="1" dirty="0">
+              <a:rPr lang="en-US" sz="1400" b="1">
                 <a:latin typeface="Marianne" panose="02000000000000000000" pitchFamily="50" charset="0"/>
               </a:rPr>
               <a:t>}}</a:t>
             </a:r>
+            <a:endParaRPr lang="en-US" sz="1400" b="1" dirty="0">
+              <a:latin typeface="Marianne" panose="02000000000000000000" pitchFamily="50" charset="0"/>
+            </a:endParaRPr>
           </a:p>
         </p:txBody>
       </p:sp>

</xml_diff>

<commit_message>
feat: Rajout du logo RF + aides mobilisables => dispositifs mobilisables
</commit_message>
<xml_diff>
--- a/public/templates/template_synthese_projet.pptx
+++ b/public/templates/template_synthese_projet.pptx
@@ -4338,7 +4338,7 @@
         </p:blipFill>
         <p:spPr>
           <a:xfrm>
-            <a:off x="307189" y="193063"/>
+            <a:off x="1170788" y="104580"/>
             <a:ext cx="777534" cy="916916"/>
           </a:xfrm>
           <a:prstGeom prst="rect">
@@ -4520,6 +4520,53 @@
           <a:prstGeom prst="rect">
             <a:avLst/>
           </a:prstGeom>
+        </p:spPr>
+      </p:pic>
+      <p:pic>
+        <p:nvPicPr>
+          <p:cNvPr id="1026" name="Picture 2">
+            <a:extLst>
+              <a:ext uri="{FF2B5EF4-FFF2-40B4-BE49-F238E27FC236}">
+                <a16:creationId xmlns:a16="http://schemas.microsoft.com/office/drawing/2014/main" id="{400E88AC-0844-103F-0759-EAAA7C2FE3F5}"/>
+              </a:ext>
+            </a:extLst>
+          </p:cNvPr>
+          <p:cNvPicPr>
+            <a:picLocks noChangeAspect="1" noChangeArrowheads="1"/>
+          </p:cNvPicPr>
+          <p:nvPr/>
+        </p:nvPicPr>
+        <p:blipFill>
+          <a:blip r:embed="rId4">
+            <a:extLst>
+              <a:ext uri="{28A0092B-C50C-407E-A947-70E740481C1C}">
+                <a14:useLocalDpi xmlns:a14="http://schemas.microsoft.com/office/drawing/2010/main" val="0"/>
+              </a:ext>
+            </a:extLst>
+          </a:blip>
+          <a:srcRect/>
+          <a:stretch>
+            <a:fillRect/>
+          </a:stretch>
+        </p:blipFill>
+        <p:spPr bwMode="auto">
+          <a:xfrm>
+            <a:off x="126384" y="104580"/>
+            <a:ext cx="896540" cy="916916"/>
+          </a:xfrm>
+          <a:prstGeom prst="rect">
+            <a:avLst/>
+          </a:prstGeom>
+          <a:noFill/>
+          <a:extLst>
+            <a:ext uri="{909E8E84-426E-40DD-AFC4-6F175D3DCCD1}">
+              <a14:hiddenFill xmlns:a14="http://schemas.microsoft.com/office/drawing/2010/main">
+                <a:solidFill>
+                  <a:srgbClr val="FFFFFF"/>
+                </a:solidFill>
+              </a14:hiddenFill>
+            </a:ext>
+          </a:extLst>
         </p:spPr>
       </p:pic>
     </p:spTree>
@@ -9107,7 +9154,7 @@
           <a:lstStyle/>
           <a:p>
             <a:r>
-              <a:rPr lang="en-US" sz="1600" dirty="0">
+              <a:rPr lang="en-US" sz="1600">
                 <a:solidFill>
                   <a:srgbClr val="5C5C5C"/>
                 </a:solidFill>
@@ -9115,7 +9162,7 @@
                 <a:ea typeface="Calibri" pitchFamily="34" charset="-122"/>
                 <a:cs typeface="Calibri" pitchFamily="34" charset="-120"/>
               </a:rPr>
-              <a:t>Aides </a:t>
+              <a:t>Dispositifs </a:t>
             </a:r>
             <a:r>
               <a:rPr lang="en-US" sz="1600" dirty="0" err="1">
@@ -9570,14 +9617,11 @@
               <a:t>aide_nom</a:t>
             </a:r>
             <a:r>
-              <a:rPr lang="en-US" sz="1400" b="1">
+              <a:rPr lang="en-US" sz="1400" b="1" dirty="0">
                 <a:latin typeface="Marianne" panose="02000000000000000000" pitchFamily="50" charset="0"/>
               </a:rPr>
               <a:t>}}</a:t>
             </a:r>
-            <a:endParaRPr lang="en-US" sz="1400" b="1" dirty="0">
-              <a:latin typeface="Marianne" panose="02000000000000000000" pitchFamily="50" charset="0"/>
-            </a:endParaRPr>
           </a:p>
         </p:txBody>
       </p:sp>

</xml_diff>

<commit_message>
feat: alignement du logo RF
</commit_message>
<xml_diff>
--- a/public/templates/template_synthese_projet.pptx
+++ b/public/templates/template_synthese_projet.pptx
@@ -4338,8 +4338,8 @@
         </p:blipFill>
         <p:spPr>
           <a:xfrm>
-            <a:off x="1170788" y="104580"/>
-            <a:ext cx="777534" cy="916916"/>
+            <a:off x="1313951" y="131647"/>
+            <a:ext cx="686944" cy="810086"/>
           </a:xfrm>
           <a:prstGeom prst="rect">
             <a:avLst/>
@@ -4551,8 +4551,8 @@
         </p:blipFill>
         <p:spPr bwMode="auto">
           <a:xfrm>
-            <a:off x="126384" y="104580"/>
-            <a:ext cx="896540" cy="916916"/>
+            <a:off x="93497" y="469"/>
+            <a:ext cx="1048610" cy="1072442"/>
           </a:xfrm>
           <a:prstGeom prst="rect">
             <a:avLst/>
@@ -9154,7 +9154,7 @@
           <a:lstStyle/>
           <a:p>
             <a:r>
-              <a:rPr lang="en-US" sz="1600">
+              <a:rPr lang="en-US" sz="1600" dirty="0" err="1">
                 <a:solidFill>
                   <a:srgbClr val="5C5C5C"/>
                 </a:solidFill>
@@ -9162,7 +9162,18 @@
                 <a:ea typeface="Calibri" pitchFamily="34" charset="-122"/>
                 <a:cs typeface="Calibri" pitchFamily="34" charset="-120"/>
               </a:rPr>
-              <a:t>Dispositifs </a:t>
+              <a:t>Dispositifs</a:t>
+            </a:r>
+            <a:r>
+              <a:rPr lang="en-US" sz="1600" dirty="0">
+                <a:solidFill>
+                  <a:srgbClr val="5C5C5C"/>
+                </a:solidFill>
+                <a:latin typeface="Marianne" panose="02000000000000000000" pitchFamily="50" charset="0"/>
+                <a:ea typeface="Calibri" pitchFamily="34" charset="-122"/>
+                <a:cs typeface="Calibri" pitchFamily="34" charset="-120"/>
+              </a:rPr>
+              <a:t> </a:t>
             </a:r>
             <a:r>
               <a:rPr lang="en-US" sz="1600" dirty="0" err="1">

</xml_diff>

<commit_message>
feat: refacto slide aides
</commit_message>
<xml_diff>
--- a/public/templates/template_synthese_projet.pptx
+++ b/public/templates/template_synthese_projet.pptx
@@ -9457,10 +9457,10 @@
       </p:sp>
       <p:sp>
         <p:nvSpPr>
-          <p:cNvPr id="31" name="contour_aide">
-            <a:extLst>
-              <a:ext uri="{FF2B5EF4-FFF2-40B4-BE49-F238E27FC236}">
-                <a16:creationId xmlns:a16="http://schemas.microsoft.com/office/drawing/2014/main" id="{6F190980-5A7F-CFD0-DB5F-2885D8DD4262}"/>
+          <p:cNvPr id="33" name="zone_aide">
+            <a:extLst>
+              <a:ext uri="{FF2B5EF4-FFF2-40B4-BE49-F238E27FC236}">
+                <a16:creationId xmlns:a16="http://schemas.microsoft.com/office/drawing/2014/main" id="{3A009836-E679-1A4E-868D-C41048F4DF96}"/>
               </a:ext>
             </a:extLst>
           </p:cNvPr>
@@ -9469,50 +9469,8 @@
         </p:nvSpPr>
         <p:spPr>
           <a:xfrm>
-            <a:off x="576263" y="1436010"/>
-            <a:ext cx="10581312" cy="1319489"/>
-          </a:xfrm>
-          <a:prstGeom prst="roundRect">
-            <a:avLst>
-              <a:gd name="adj" fmla="val 5932"/>
-            </a:avLst>
-          </a:prstGeom>
-          <a:solidFill>
-            <a:srgbClr val="FFFFFF"/>
-          </a:solidFill>
-          <a:ln w="12700">
-            <a:solidFill>
-              <a:srgbClr val="E0E0E0"/>
-            </a:solidFill>
-            <a:prstDash val="solid"/>
-          </a:ln>
-        </p:spPr>
-        <p:txBody>
-          <a:bodyPr/>
-          <a:lstStyle/>
-          <a:p>
-            <a:endParaRPr lang="fr-FR" sz="2400">
-              <a:latin typeface="Marianne" panose="02000000000000000000" pitchFamily="50" charset="0"/>
-            </a:endParaRPr>
-          </a:p>
-        </p:txBody>
-      </p:sp>
-      <p:sp>
-        <p:nvSpPr>
-          <p:cNvPr id="32" name="zone_aide_type">
-            <a:extLst>
-              <a:ext uri="{FF2B5EF4-FFF2-40B4-BE49-F238E27FC236}">
-                <a16:creationId xmlns:a16="http://schemas.microsoft.com/office/drawing/2014/main" id="{CA13F4C7-9C9C-5D69-7ABF-29ED7E1E953C}"/>
-              </a:ext>
-            </a:extLst>
-          </p:cNvPr>
-          <p:cNvSpPr/>
-          <p:nvPr/>
-        </p:nvSpPr>
-        <p:spPr>
-          <a:xfrm>
-            <a:off x="759144" y="1502851"/>
-            <a:ext cx="7955280" cy="201168"/>
+            <a:off x="576263" y="1359255"/>
+            <a:ext cx="10187280" cy="4922847"/>
           </a:xfrm>
           <a:prstGeom prst="rect">
             <a:avLst/>
@@ -9521,14 +9479,46 @@
           <a:ln/>
         </p:spPr>
         <p:txBody>
-          <a:bodyPr wrap="square" lIns="0" tIns="0" rIns="0" bIns="0" rtlCol="0" anchor="ctr"/>
-          <a:lstStyle/>
-          <a:p>
-            <a:pPr marL="0" indent="0">
-              <a:buNone/>
+          <a:bodyPr wrap="square" lIns="0" tIns="0" rIns="0" bIns="0" rtlCol="0" anchor="t">
+            <a:normAutofit/>
+          </a:bodyPr>
+          <a:lstStyle/>
+          <a:p>
+            <a:pPr marL="285750" indent="-285750">
+              <a:lnSpc>
+                <a:spcPts val="1800"/>
+              </a:lnSpc>
+              <a:spcBef>
+                <a:spcPts val="2500"/>
+              </a:spcBef>
+              <a:buFont typeface="Arial" panose="020B0604020202020204" pitchFamily="34" charset="0"/>
+              <a:buChar char="•"/>
             </a:pPr>
             <a:r>
-              <a:rPr lang="en-US" sz="900" kern="0" spc="150" dirty="0">
+              <a:rPr lang="en-US" sz="1400" b="1" dirty="0">
+                <a:latin typeface="Marianne" panose="02000000000000000000" pitchFamily="50" charset="0"/>
+              </a:rPr>
+              <a:t>{{</a:t>
+            </a:r>
+            <a:r>
+              <a:rPr lang="en-US" sz="1400" b="1" dirty="0" err="1">
+                <a:latin typeface="Marianne" panose="02000000000000000000" pitchFamily="50" charset="0"/>
+              </a:rPr>
+              <a:t>aide_nom</a:t>
+            </a:r>
+            <a:r>
+              <a:rPr lang="en-US" sz="1400" b="1" dirty="0">
+                <a:latin typeface="Marianne" panose="02000000000000000000" pitchFamily="50" charset="0"/>
+              </a:rPr>
+              <a:t>}}</a:t>
+            </a:r>
+            <a:br>
+              <a:rPr lang="en-US" sz="1400" b="1" dirty="0">
+                <a:latin typeface="Marianne" panose="02000000000000000000" pitchFamily="50" charset="0"/>
+              </a:rPr>
+            </a:br>
+            <a:r>
+              <a:rPr lang="en-US" sz="1100" dirty="0">
                 <a:solidFill>
                   <a:schemeClr val="tx1">
                     <a:lumMod val="65000"/>
@@ -9536,13 +9526,11 @@
                   </a:schemeClr>
                 </a:solidFill>
                 <a:latin typeface="Marianne" panose="02000000000000000000" pitchFamily="50" charset="0"/>
-                <a:ea typeface="Calibri" pitchFamily="34" charset="-122"/>
-                <a:cs typeface="Calibri" pitchFamily="34" charset="-120"/>
               </a:rPr>
               <a:t>{{</a:t>
             </a:r>
             <a:r>
-              <a:rPr lang="en-US" sz="900" kern="0" spc="150" dirty="0" err="1">
+              <a:rPr lang="en-US" sz="1100" dirty="0" err="1">
                 <a:solidFill>
                   <a:schemeClr val="tx1">
                     <a:lumMod val="65000"/>
@@ -9550,13 +9538,11 @@
                   </a:schemeClr>
                 </a:solidFill>
                 <a:latin typeface="Marianne" panose="02000000000000000000" pitchFamily="50" charset="0"/>
-                <a:ea typeface="Calibri" pitchFamily="34" charset="-122"/>
-                <a:cs typeface="Calibri" pitchFamily="34" charset="-120"/>
               </a:rPr>
               <a:t>aide_type</a:t>
             </a:r>
             <a:r>
-              <a:rPr lang="en-US" sz="900" kern="0" spc="150" dirty="0">
+              <a:rPr lang="en-US" sz="1100" dirty="0">
                 <a:solidFill>
                   <a:schemeClr val="tx1">
                     <a:lumMod val="65000"/>
@@ -9564,75 +9550,171 @@
                   </a:schemeClr>
                 </a:solidFill>
                 <a:latin typeface="Marianne" panose="02000000000000000000" pitchFamily="50" charset="0"/>
+              </a:rPr>
+              <a:t>}}</a:t>
+            </a:r>
+          </a:p>
+          <a:p>
+            <a:pPr marL="628650" lvl="1" indent="-171450">
+              <a:lnSpc>
+                <a:spcPct val="150000"/>
+              </a:lnSpc>
+              <a:buFont typeface="Arial" panose="020B0604020202020204" pitchFamily="34" charset="0"/>
+              <a:buChar char="•"/>
+            </a:pPr>
+            <a:r>
+              <a:rPr lang="en-US" sz="1100" b="1" dirty="0" err="1">
+                <a:solidFill>
+                  <a:schemeClr val="tx1">
+                    <a:lumMod val="65000"/>
+                    <a:lumOff val="35000"/>
+                  </a:schemeClr>
+                </a:solidFill>
+                <a:latin typeface="Marianne" panose="02000000000000000000" pitchFamily="50" charset="0"/>
                 <a:ea typeface="Calibri" pitchFamily="34" charset="-122"/>
                 <a:cs typeface="Calibri" pitchFamily="34" charset="-120"/>
               </a:rPr>
+              <a:t>Porteur</a:t>
+            </a:r>
+            <a:r>
+              <a:rPr lang="en-US" sz="1100" dirty="0">
+                <a:solidFill>
+                  <a:srgbClr val="5C5C5C"/>
+                </a:solidFill>
+                <a:latin typeface="Marianne" panose="02000000000000000000" pitchFamily="50" charset="0"/>
+                <a:ea typeface="Calibri" pitchFamily="34" charset="-122"/>
+                <a:cs typeface="Calibri" pitchFamily="34" charset="-120"/>
+              </a:rPr>
+              <a:t> : {{</a:t>
+            </a:r>
+            <a:r>
+              <a:rPr lang="en-US" sz="1100" dirty="0" err="1">
+                <a:solidFill>
+                  <a:srgbClr val="5C5C5C"/>
+                </a:solidFill>
+                <a:latin typeface="Marianne" panose="02000000000000000000" pitchFamily="50" charset="0"/>
+                <a:ea typeface="Calibri" pitchFamily="34" charset="-122"/>
+                <a:cs typeface="Calibri" pitchFamily="34" charset="-120"/>
+              </a:rPr>
+              <a:t>aide_financiers</a:t>
+            </a:r>
+            <a:r>
+              <a:rPr lang="en-US" sz="1100" dirty="0">
+                <a:solidFill>
+                  <a:srgbClr val="5C5C5C"/>
+                </a:solidFill>
+                <a:latin typeface="Marianne" panose="02000000000000000000" pitchFamily="50" charset="0"/>
+                <a:ea typeface="Calibri" pitchFamily="34" charset="-122"/>
+                <a:cs typeface="Calibri" pitchFamily="34" charset="-120"/>
+              </a:rPr>
               <a:t>}}</a:t>
             </a:r>
-            <a:endParaRPr lang="en-US" sz="900" dirty="0">
+          </a:p>
+          <a:p>
+            <a:pPr marL="628650" lvl="1" indent="-171450">
+              <a:lnSpc>
+                <a:spcPct val="150000"/>
+              </a:lnSpc>
+              <a:buFont typeface="Arial" panose="020B0604020202020204" pitchFamily="34" charset="0"/>
+              <a:buChar char="•"/>
+            </a:pPr>
+            <a:r>
+              <a:rPr lang="en-US" sz="1100" b="1" dirty="0" err="1">
+                <a:solidFill>
+                  <a:srgbClr val="5C5C5C"/>
+                </a:solidFill>
+                <a:latin typeface="Marianne" panose="02000000000000000000" pitchFamily="50" charset="0"/>
+                <a:ea typeface="Calibri" pitchFamily="34" charset="-122"/>
+                <a:cs typeface="Calibri" pitchFamily="34" charset="-120"/>
+              </a:rPr>
+              <a:t>Échéance</a:t>
+            </a:r>
+            <a:r>
+              <a:rPr lang="en-US" sz="1100" dirty="0">
+                <a:solidFill>
+                  <a:srgbClr val="5C5C5C"/>
+                </a:solidFill>
+                <a:latin typeface="Marianne" panose="02000000000000000000" pitchFamily="50" charset="0"/>
+                <a:ea typeface="Calibri" pitchFamily="34" charset="-122"/>
+                <a:cs typeface="Calibri" pitchFamily="34" charset="-120"/>
+              </a:rPr>
+              <a:t> : {{</a:t>
+            </a:r>
+            <a:r>
+              <a:rPr lang="en-US" sz="1100" dirty="0" err="1">
+                <a:solidFill>
+                  <a:srgbClr val="5C5C5C"/>
+                </a:solidFill>
+                <a:latin typeface="Marianne" panose="02000000000000000000" pitchFamily="50" charset="0"/>
+                <a:ea typeface="Calibri" pitchFamily="34" charset="-122"/>
+                <a:cs typeface="Calibri" pitchFamily="34" charset="-120"/>
+              </a:rPr>
+              <a:t>aide_echeance</a:t>
+            </a:r>
+            <a:r>
+              <a:rPr lang="en-US" sz="1100" dirty="0">
+                <a:solidFill>
+                  <a:srgbClr val="5C5C5C"/>
+                </a:solidFill>
+                <a:latin typeface="Marianne" panose="02000000000000000000" pitchFamily="50" charset="0"/>
+                <a:ea typeface="Calibri" pitchFamily="34" charset="-122"/>
+                <a:cs typeface="Calibri" pitchFamily="34" charset="-120"/>
+              </a:rPr>
+              <a:t>}}</a:t>
+            </a:r>
+          </a:p>
+          <a:p>
+            <a:pPr marL="628650" lvl="1" indent="-171450">
+              <a:lnSpc>
+                <a:spcPct val="150000"/>
+              </a:lnSpc>
+              <a:buFont typeface="Arial" panose="020B0604020202020204" pitchFamily="34" charset="0"/>
+              <a:buChar char="•"/>
+            </a:pPr>
+            <a:r>
+              <a:rPr lang="en-US" sz="1100" dirty="0">
+                <a:solidFill>
+                  <a:srgbClr val="5C5C5C"/>
+                </a:solidFill>
+                <a:latin typeface="Marianne" panose="02000000000000000000" pitchFamily="50" charset="0"/>
+                <a:ea typeface="Calibri" pitchFamily="34" charset="-122"/>
+                <a:cs typeface="Calibri" pitchFamily="34" charset="-120"/>
+                <a:hlinkClick r:id="rId3" action="ppaction://hlinkfile"/>
+              </a:rPr>
+              <a:t>{{</a:t>
+            </a:r>
+            <a:r>
+              <a:rPr lang="en-US" sz="1100" dirty="0" err="1">
+                <a:solidFill>
+                  <a:srgbClr val="5C5C5C"/>
+                </a:solidFill>
+                <a:latin typeface="Marianne" panose="02000000000000000000" pitchFamily="50" charset="0"/>
+                <a:ea typeface="Calibri" pitchFamily="34" charset="-122"/>
+                <a:cs typeface="Calibri" pitchFamily="34" charset="-120"/>
+                <a:hlinkClick r:id="rId3" action="ppaction://hlinkfile"/>
+              </a:rPr>
+              <a:t>aide_lien</a:t>
+            </a:r>
+            <a:r>
+              <a:rPr lang="en-US" sz="1100" dirty="0">
+                <a:solidFill>
+                  <a:srgbClr val="5C5C5C"/>
+                </a:solidFill>
+                <a:latin typeface="Marianne" panose="02000000000000000000" pitchFamily="50" charset="0"/>
+                <a:ea typeface="Calibri" pitchFamily="34" charset="-122"/>
+                <a:cs typeface="Calibri" pitchFamily="34" charset="-120"/>
+                <a:hlinkClick r:id="rId3" action="ppaction://hlinkfile"/>
+              </a:rPr>
+              <a:t>}}</a:t>
+            </a:r>
+            <a:endParaRPr lang="en-US" sz="1100" dirty="0">
               <a:solidFill>
-                <a:schemeClr val="tx1">
-                  <a:lumMod val="65000"/>
-                  <a:lumOff val="35000"/>
-                </a:schemeClr>
+                <a:srgbClr val="5C5C5C"/>
               </a:solidFill>
               <a:latin typeface="Marianne" panose="02000000000000000000" pitchFamily="50" charset="0"/>
+              <a:ea typeface="Calibri" pitchFamily="34" charset="-122"/>
+              <a:cs typeface="Calibri" pitchFamily="34" charset="-120"/>
             </a:endParaRPr>
-          </a:p>
-        </p:txBody>
-      </p:sp>
-      <p:sp>
-        <p:nvSpPr>
-          <p:cNvPr id="33" name="zone_aide_titre">
-            <a:extLst>
-              <a:ext uri="{FF2B5EF4-FFF2-40B4-BE49-F238E27FC236}">
-                <a16:creationId xmlns:a16="http://schemas.microsoft.com/office/drawing/2014/main" id="{3A009836-E679-1A4E-868D-C41048F4DF96}"/>
-              </a:ext>
-            </a:extLst>
-          </p:cNvPr>
-          <p:cNvSpPr/>
-          <p:nvPr/>
-        </p:nvSpPr>
-        <p:spPr>
-          <a:xfrm>
-            <a:off x="759143" y="1719567"/>
-            <a:ext cx="10187280" cy="407154"/>
-          </a:xfrm>
-          <a:prstGeom prst="rect">
-            <a:avLst/>
-          </a:prstGeom>
-          <a:noFill/>
-          <a:ln/>
-        </p:spPr>
-        <p:txBody>
-          <a:bodyPr wrap="square" lIns="0" tIns="0" rIns="0" bIns="0" rtlCol="0" anchor="t">
-            <a:normAutofit/>
-          </a:bodyPr>
-          <a:lstStyle/>
-          <a:p>
-            <a:pPr>
-              <a:lnSpc>
-                <a:spcPts val="1400"/>
-              </a:lnSpc>
-            </a:pPr>
-            <a:r>
-              <a:rPr lang="en-US" sz="1400" b="1" dirty="0">
-                <a:latin typeface="Marianne" panose="02000000000000000000" pitchFamily="50" charset="0"/>
-              </a:rPr>
-              <a:t>{{</a:t>
-            </a:r>
-            <a:r>
-              <a:rPr lang="en-US" sz="1400" b="1" dirty="0" err="1">
-                <a:latin typeface="Marianne" panose="02000000000000000000" pitchFamily="50" charset="0"/>
-              </a:rPr>
-              <a:t>aide_nom</a:t>
-            </a:r>
-            <a:r>
-              <a:rPr lang="en-US" sz="1400" b="1" dirty="0">
-                <a:latin typeface="Marianne" panose="02000000000000000000" pitchFamily="50" charset="0"/>
-              </a:rPr>
-              <a:t>}}</a:t>
-            </a:r>
           </a:p>
         </p:txBody>
       </p:sp>
@@ -9773,196 +9855,6 @@
           </a:fontRef>
         </p:style>
       </p:cxnSp>
-      <p:sp>
-        <p:nvSpPr>
-          <p:cNvPr id="7" name="zone_aide_lien">
-            <a:extLst>
-              <a:ext uri="{FF2B5EF4-FFF2-40B4-BE49-F238E27FC236}">
-                <a16:creationId xmlns:a16="http://schemas.microsoft.com/office/drawing/2014/main" id="{00ED1968-10CF-E3DC-940B-6214BFEF0E99}"/>
-              </a:ext>
-            </a:extLst>
-          </p:cNvPr>
-          <p:cNvSpPr/>
-          <p:nvPr/>
-        </p:nvSpPr>
-        <p:spPr>
-          <a:xfrm>
-            <a:off x="759143" y="2448390"/>
-            <a:ext cx="1466775" cy="288818"/>
-          </a:xfrm>
-          <a:prstGeom prst="rect">
-            <a:avLst/>
-          </a:prstGeom>
-          <a:noFill/>
-          <a:ln/>
-        </p:spPr>
-        <p:txBody>
-          <a:bodyPr wrap="square" lIns="0" tIns="0" rIns="0" bIns="0" rtlCol="0" anchor="ctr"/>
-          <a:lstStyle/>
-          <a:p>
-            <a:pPr marL="0" indent="0">
-              <a:buNone/>
-            </a:pPr>
-            <a:r>
-              <a:rPr lang="en-US" sz="1100" dirty="0">
-                <a:solidFill>
-                  <a:srgbClr val="5C5C5C"/>
-                </a:solidFill>
-                <a:latin typeface="Marianne" panose="02000000000000000000" pitchFamily="50" charset="0"/>
-                <a:ea typeface="Calibri" pitchFamily="34" charset="-122"/>
-                <a:cs typeface="Calibri" pitchFamily="34" charset="-120"/>
-                <a:hlinkClick r:id="rId3" action="ppaction://hlinkfile"/>
-              </a:rPr>
-              <a:t>{{</a:t>
-            </a:r>
-            <a:r>
-              <a:rPr lang="en-US" sz="1100" dirty="0" err="1">
-                <a:solidFill>
-                  <a:srgbClr val="5C5C5C"/>
-                </a:solidFill>
-                <a:latin typeface="Marianne" panose="02000000000000000000" pitchFamily="50" charset="0"/>
-                <a:ea typeface="Calibri" pitchFamily="34" charset="-122"/>
-                <a:cs typeface="Calibri" pitchFamily="34" charset="-120"/>
-                <a:hlinkClick r:id="rId3" action="ppaction://hlinkfile"/>
-              </a:rPr>
-              <a:t>aide_lien</a:t>
-            </a:r>
-            <a:r>
-              <a:rPr lang="en-US" sz="1100" dirty="0">
-                <a:solidFill>
-                  <a:srgbClr val="5C5C5C"/>
-                </a:solidFill>
-                <a:latin typeface="Marianne" panose="02000000000000000000" pitchFamily="50" charset="0"/>
-                <a:ea typeface="Calibri" pitchFamily="34" charset="-122"/>
-                <a:cs typeface="Calibri" pitchFamily="34" charset="-120"/>
-                <a:hlinkClick r:id="rId3" action="ppaction://hlinkfile"/>
-              </a:rPr>
-              <a:t>}}</a:t>
-            </a:r>
-            <a:endParaRPr lang="en-US" sz="1100" dirty="0">
-              <a:latin typeface="Marianne" panose="02000000000000000000" pitchFamily="50" charset="0"/>
-            </a:endParaRPr>
-          </a:p>
-        </p:txBody>
-      </p:sp>
-      <p:sp>
-        <p:nvSpPr>
-          <p:cNvPr id="3" name="zone_aide_details">
-            <a:extLst>
-              <a:ext uri="{FF2B5EF4-FFF2-40B4-BE49-F238E27FC236}">
-                <a16:creationId xmlns:a16="http://schemas.microsoft.com/office/drawing/2014/main" id="{245A9113-DBB3-676F-614B-19E985C21046}"/>
-              </a:ext>
-            </a:extLst>
-          </p:cNvPr>
-          <p:cNvSpPr/>
-          <p:nvPr/>
-        </p:nvSpPr>
-        <p:spPr>
-          <a:xfrm>
-            <a:off x="759143" y="2139464"/>
-            <a:ext cx="10187280" cy="397115"/>
-          </a:xfrm>
-          <a:prstGeom prst="rect">
-            <a:avLst/>
-          </a:prstGeom>
-          <a:noFill/>
-          <a:ln/>
-        </p:spPr>
-        <p:txBody>
-          <a:bodyPr wrap="square" lIns="0" tIns="0" rIns="0" bIns="0" rtlCol="0" anchor="t"/>
-          <a:lstStyle/>
-          <a:p>
-            <a:r>
-              <a:rPr lang="en-US" sz="1100" dirty="0" err="1">
-                <a:solidFill>
-                  <a:srgbClr val="5C5C5C"/>
-                </a:solidFill>
-                <a:latin typeface="Marianne" panose="02000000000000000000" pitchFamily="50" charset="0"/>
-                <a:ea typeface="Calibri" pitchFamily="34" charset="-122"/>
-                <a:cs typeface="Calibri" pitchFamily="34" charset="-120"/>
-              </a:rPr>
-              <a:t>Porteur</a:t>
-            </a:r>
-            <a:r>
-              <a:rPr lang="en-US" sz="1100" dirty="0">
-                <a:solidFill>
-                  <a:srgbClr val="5C5C5C"/>
-                </a:solidFill>
-                <a:latin typeface="Marianne" panose="02000000000000000000" pitchFamily="50" charset="0"/>
-                <a:ea typeface="Calibri" pitchFamily="34" charset="-122"/>
-                <a:cs typeface="Calibri" pitchFamily="34" charset="-120"/>
-              </a:rPr>
-              <a:t> : {{</a:t>
-            </a:r>
-            <a:r>
-              <a:rPr lang="en-US" sz="1100" dirty="0" err="1">
-                <a:solidFill>
-                  <a:srgbClr val="5C5C5C"/>
-                </a:solidFill>
-                <a:latin typeface="Marianne" panose="02000000000000000000" pitchFamily="50" charset="0"/>
-                <a:ea typeface="Calibri" pitchFamily="34" charset="-122"/>
-                <a:cs typeface="Calibri" pitchFamily="34" charset="-120"/>
-              </a:rPr>
-              <a:t>aide_financiers</a:t>
-            </a:r>
-            <a:r>
-              <a:rPr lang="en-US" sz="1100" dirty="0">
-                <a:solidFill>
-                  <a:srgbClr val="5C5C5C"/>
-                </a:solidFill>
-                <a:latin typeface="Marianne" panose="02000000000000000000" pitchFamily="50" charset="0"/>
-                <a:ea typeface="Calibri" pitchFamily="34" charset="-122"/>
-                <a:cs typeface="Calibri" pitchFamily="34" charset="-120"/>
-              </a:rPr>
-              <a:t>}}  ·  </a:t>
-            </a:r>
-            <a:r>
-              <a:rPr lang="en-US" sz="1100" dirty="0" err="1">
-                <a:solidFill>
-                  <a:srgbClr val="5C5C5C"/>
-                </a:solidFill>
-                <a:latin typeface="Marianne" panose="02000000000000000000" pitchFamily="50" charset="0"/>
-                <a:ea typeface="Calibri" pitchFamily="34" charset="-122"/>
-                <a:cs typeface="Calibri" pitchFamily="34" charset="-120"/>
-              </a:rPr>
-              <a:t>Échéance</a:t>
-            </a:r>
-            <a:r>
-              <a:rPr lang="en-US" sz="1100" dirty="0">
-                <a:solidFill>
-                  <a:srgbClr val="5C5C5C"/>
-                </a:solidFill>
-                <a:latin typeface="Marianne" panose="02000000000000000000" pitchFamily="50" charset="0"/>
-                <a:ea typeface="Calibri" pitchFamily="34" charset="-122"/>
-                <a:cs typeface="Calibri" pitchFamily="34" charset="-120"/>
-              </a:rPr>
-              <a:t> : {{</a:t>
-            </a:r>
-            <a:r>
-              <a:rPr lang="en-US" sz="1100" dirty="0" err="1">
-                <a:solidFill>
-                  <a:srgbClr val="5C5C5C"/>
-                </a:solidFill>
-                <a:latin typeface="Marianne" panose="02000000000000000000" pitchFamily="50" charset="0"/>
-                <a:ea typeface="Calibri" pitchFamily="34" charset="-122"/>
-                <a:cs typeface="Calibri" pitchFamily="34" charset="-120"/>
-              </a:rPr>
-              <a:t>aide_echeance</a:t>
-            </a:r>
-            <a:r>
-              <a:rPr lang="en-US" sz="1100" dirty="0">
-                <a:solidFill>
-                  <a:srgbClr val="5C5C5C"/>
-                </a:solidFill>
-                <a:latin typeface="Marianne" panose="02000000000000000000" pitchFamily="50" charset="0"/>
-                <a:ea typeface="Calibri" pitchFamily="34" charset="-122"/>
-                <a:cs typeface="Calibri" pitchFamily="34" charset="-120"/>
-              </a:rPr>
-              <a:t>}}</a:t>
-            </a:r>
-          </a:p>
-        </p:txBody>
-      </p:sp>
     </p:spTree>
     <p:extLst>
       <p:ext uri="{BB962C8B-B14F-4D97-AF65-F5344CB8AC3E}">

</xml_diff>

<commit_message>
feat: Ajout de l'export de l'analyse simplifiée (que le coeff ru pour le moment)
</commit_message>
<xml_diff>
--- a/public/templates/template_synthese_projet.pptx
+++ b/public/templates/template_synthese_projet.pptx
@@ -5,21 +5,22 @@
     <p:sldMasterId id="2147483648" r:id="rId1"/>
   </p:sldMasterIdLst>
   <p:notesMasterIdLst>
-    <p:notesMasterId r:id="rId14"/>
+    <p:notesMasterId r:id="rId15"/>
   </p:notesMasterIdLst>
   <p:sldIdLst>
     <p:sldId id="256" r:id="rId2"/>
     <p:sldId id="264" r:id="rId3"/>
-    <p:sldId id="266" r:id="rId4"/>
-    <p:sldId id="279" r:id="rId5"/>
-    <p:sldId id="280" r:id="rId6"/>
-    <p:sldId id="270" r:id="rId7"/>
-    <p:sldId id="274" r:id="rId8"/>
-    <p:sldId id="275" r:id="rId9"/>
-    <p:sldId id="278" r:id="rId10"/>
-    <p:sldId id="265" r:id="rId11"/>
-    <p:sldId id="276" r:id="rId12"/>
-    <p:sldId id="277" r:id="rId13"/>
+    <p:sldId id="282" r:id="rId4"/>
+    <p:sldId id="281" r:id="rId5"/>
+    <p:sldId id="279" r:id="rId6"/>
+    <p:sldId id="280" r:id="rId7"/>
+    <p:sldId id="270" r:id="rId8"/>
+    <p:sldId id="274" r:id="rId9"/>
+    <p:sldId id="275" r:id="rId10"/>
+    <p:sldId id="278" r:id="rId11"/>
+    <p:sldId id="265" r:id="rId12"/>
+    <p:sldId id="276" r:id="rId13"/>
+    <p:sldId id="277" r:id="rId14"/>
   </p:sldIdLst>
   <p:sldSz cx="12192000" cy="6858000"/>
   <p:notesSz cx="6858000" cy="9144000"/>
@@ -217,7 +218,7 @@
           <a:p>
             <a:fld id="{4C638A9C-6ED0-4718-B5E7-9D405962C144}" type="datetimeFigureOut">
               <a:rPr lang="fr-FR" smtClean="0"/>
-              <a:t>30/09/2026</a:t>
+              <a:t>02/10/2026</a:t>
             </a:fld>
             <a:endParaRPr lang="fr-FR"/>
           </a:p>
@@ -681,7 +682,7 @@
           <a:p>
             <a:fld id="{F7021451-1387-4CA6-816F-3879F97B5CBC}" type="slidenum">
               <a:rPr lang="en-US"/>
-              <a:t>4</a:t>
+              <a:t>5</a:t>
             </a:fld>
             <a:endParaRPr lang="en-US"/>
           </a:p>
@@ -789,7 +790,7 @@
           <a:p>
             <a:fld id="{F7021451-1387-4CA6-816F-3879F97B5CBC}" type="slidenum">
               <a:rPr lang="en-US"/>
-              <a:t>7</a:t>
+              <a:t>8</a:t>
             </a:fld>
             <a:endParaRPr lang="en-US"/>
           </a:p>
@@ -897,7 +898,7 @@
           <a:p>
             <a:fld id="{F7021451-1387-4CA6-816F-3879F97B5CBC}" type="slidenum">
               <a:rPr lang="en-US"/>
-              <a:t>9</a:t>
+              <a:t>10</a:t>
             </a:fld>
             <a:endParaRPr lang="en-US"/>
           </a:p>
@@ -1005,7 +1006,7 @@
           <a:p>
             <a:fld id="{F7021451-1387-4CA6-816F-3879F97B5CBC}" type="slidenum">
               <a:rPr lang="en-US"/>
-              <a:t>11</a:t>
+              <a:t>12</a:t>
             </a:fld>
             <a:endParaRPr lang="en-US"/>
           </a:p>
@@ -1171,7 +1172,7 @@
           <a:p>
             <a:fld id="{82E7F8B9-DFDB-4965-877D-C04A580740C9}" type="datetimeFigureOut">
               <a:rPr lang="fr-FR" smtClean="0"/>
-              <a:t>30/09/2026</a:t>
+              <a:t>02/10/2026</a:t>
             </a:fld>
             <a:endParaRPr lang="fr-FR"/>
           </a:p>
@@ -1369,7 +1370,7 @@
           <a:p>
             <a:fld id="{82E7F8B9-DFDB-4965-877D-C04A580740C9}" type="datetimeFigureOut">
               <a:rPr lang="fr-FR" smtClean="0"/>
-              <a:t>30/09/2026</a:t>
+              <a:t>02/10/2026</a:t>
             </a:fld>
             <a:endParaRPr lang="fr-FR"/>
           </a:p>
@@ -1577,7 +1578,7 @@
           <a:p>
             <a:fld id="{82E7F8B9-DFDB-4965-877D-C04A580740C9}" type="datetimeFigureOut">
               <a:rPr lang="fr-FR" smtClean="0"/>
-              <a:t>30/09/2026</a:t>
+              <a:t>02/10/2026</a:t>
             </a:fld>
             <a:endParaRPr lang="fr-FR"/>
           </a:p>
@@ -1810,7 +1811,7 @@
           <a:p>
             <a:fld id="{82E7F8B9-DFDB-4965-877D-C04A580740C9}" type="datetimeFigureOut">
               <a:rPr lang="fr-FR" smtClean="0"/>
-              <a:t>30/09/2026</a:t>
+              <a:t>02/10/2026</a:t>
             </a:fld>
             <a:endParaRPr lang="fr-FR"/>
           </a:p>
@@ -2085,7 +2086,7 @@
           <a:p>
             <a:fld id="{82E7F8B9-DFDB-4965-877D-C04A580740C9}" type="datetimeFigureOut">
               <a:rPr lang="fr-FR" smtClean="0"/>
-              <a:t>30/09/2026</a:t>
+              <a:t>02/10/2026</a:t>
             </a:fld>
             <a:endParaRPr lang="fr-FR"/>
           </a:p>
@@ -2350,7 +2351,7 @@
           <a:p>
             <a:fld id="{82E7F8B9-DFDB-4965-877D-C04A580740C9}" type="datetimeFigureOut">
               <a:rPr lang="fr-FR" smtClean="0"/>
-              <a:t>30/09/2026</a:t>
+              <a:t>02/10/2026</a:t>
             </a:fld>
             <a:endParaRPr lang="fr-FR"/>
           </a:p>
@@ -2762,7 +2763,7 @@
           <a:p>
             <a:fld id="{82E7F8B9-DFDB-4965-877D-C04A580740C9}" type="datetimeFigureOut">
               <a:rPr lang="fr-FR" smtClean="0"/>
-              <a:t>30/09/2026</a:t>
+              <a:t>02/10/2026</a:t>
             </a:fld>
             <a:endParaRPr lang="fr-FR"/>
           </a:p>
@@ -2903,7 +2904,7 @@
           <a:p>
             <a:fld id="{82E7F8B9-DFDB-4965-877D-C04A580740C9}" type="datetimeFigureOut">
               <a:rPr lang="fr-FR" smtClean="0"/>
-              <a:t>30/09/2026</a:t>
+              <a:t>02/10/2026</a:t>
             </a:fld>
             <a:endParaRPr lang="fr-FR"/>
           </a:p>
@@ -3016,7 +3017,7 @@
           <a:p>
             <a:fld id="{82E7F8B9-DFDB-4965-877D-C04A580740C9}" type="datetimeFigureOut">
               <a:rPr lang="fr-FR" smtClean="0"/>
-              <a:t>30/09/2026</a:t>
+              <a:t>02/10/2026</a:t>
             </a:fld>
             <a:endParaRPr lang="fr-FR"/>
           </a:p>
@@ -3327,7 +3328,7 @@
           <a:p>
             <a:fld id="{82E7F8B9-DFDB-4965-877D-C04A580740C9}" type="datetimeFigureOut">
               <a:rPr lang="fr-FR" smtClean="0"/>
-              <a:t>30/09/2026</a:t>
+              <a:t>02/10/2026</a:t>
             </a:fld>
             <a:endParaRPr lang="fr-FR"/>
           </a:p>
@@ -3615,7 +3616,7 @@
           <a:p>
             <a:fld id="{82E7F8B9-DFDB-4965-877D-C04A580740C9}" type="datetimeFigureOut">
               <a:rPr lang="fr-FR" smtClean="0"/>
-              <a:t>30/09/2026</a:t>
+              <a:t>02/10/2026</a:t>
             </a:fld>
             <a:endParaRPr lang="fr-FR"/>
           </a:p>
@@ -3856,7 +3857,7 @@
           <a:p>
             <a:fld id="{82E7F8B9-DFDB-4965-877D-C04A580740C9}" type="datetimeFigureOut">
               <a:rPr lang="fr-FR" smtClean="0"/>
-              <a:t>30/09/2026</a:t>
+              <a:t>02/10/2026</a:t>
             </a:fld>
             <a:endParaRPr lang="fr-FR"/>
           </a:p>
@@ -4700,6 +4701,375 @@
         <p:cNvPr id="1" name="">
           <a:extLst>
             <a:ext uri="{FF2B5EF4-FFF2-40B4-BE49-F238E27FC236}">
+              <a16:creationId xmlns:a16="http://schemas.microsoft.com/office/drawing/2014/main" id="{955CEECE-80BD-24F5-29ED-51D02A8DC5DD}"/>
+            </a:ext>
+          </a:extLst>
+        </p:cNvPr>
+        <p:cNvGrpSpPr/>
+        <p:nvPr/>
+      </p:nvGrpSpPr>
+      <p:grpSpPr>
+        <a:xfrm>
+          <a:off x="0" y="0"/>
+          <a:ext cx="0" cy="0"/>
+          <a:chOff x="0" y="0"/>
+          <a:chExt cx="0" cy="0"/>
+        </a:xfrm>
+      </p:grpSpPr>
+      <p:pic>
+        <p:nvPicPr>
+          <p:cNvPr id="10" name="Picture 9">
+            <a:extLst>
+              <a:ext uri="{FF2B5EF4-FFF2-40B4-BE49-F238E27FC236}">
+                <a16:creationId xmlns:a16="http://schemas.microsoft.com/office/drawing/2014/main" id="{E922595D-B49E-4187-3566-440EF1D1B583}"/>
+              </a:ext>
+            </a:extLst>
+          </p:cNvPr>
+          <p:cNvPicPr>
+            <a:picLocks noChangeAspect="1"/>
+          </p:cNvPicPr>
+          <p:nvPr/>
+        </p:nvPicPr>
+        <p:blipFill>
+          <a:blip r:embed="rId3"/>
+          <a:stretch>
+            <a:fillRect/>
+          </a:stretch>
+        </p:blipFill>
+        <p:spPr>
+          <a:xfrm>
+            <a:off x="10546452" y="104580"/>
+            <a:ext cx="1552051" cy="758533"/>
+          </a:xfrm>
+          <a:prstGeom prst="rect">
+            <a:avLst/>
+          </a:prstGeom>
+        </p:spPr>
+      </p:pic>
+      <p:sp>
+        <p:nvSpPr>
+          <p:cNvPr id="4" name="Text 2">
+            <a:extLst>
+              <a:ext uri="{FF2B5EF4-FFF2-40B4-BE49-F238E27FC236}">
+                <a16:creationId xmlns:a16="http://schemas.microsoft.com/office/drawing/2014/main" id="{3AA7DA23-AC46-53C2-5481-F11CF1FF75EA}"/>
+              </a:ext>
+            </a:extLst>
+          </p:cNvPr>
+          <p:cNvSpPr/>
+          <p:nvPr/>
+        </p:nvSpPr>
+        <p:spPr>
+          <a:xfrm>
+            <a:off x="609600" y="2202220"/>
+            <a:ext cx="10972800" cy="792480"/>
+          </a:xfrm>
+          <a:prstGeom prst="rect">
+            <a:avLst/>
+          </a:prstGeom>
+          <a:noFill/>
+          <a:ln/>
+        </p:spPr>
+        <p:txBody>
+          <a:bodyPr wrap="square" lIns="0" tIns="0" rIns="0" bIns="0" rtlCol="0" anchor="ctr"/>
+          <a:lstStyle/>
+          <a:p>
+            <a:r>
+              <a:rPr lang="en-US" sz="3733" b="1" dirty="0">
+                <a:solidFill>
+                  <a:srgbClr val="1A1A1A"/>
+                </a:solidFill>
+                <a:latin typeface="Marianne" panose="02000000000000000000" pitchFamily="50" charset="0"/>
+                <a:ea typeface="Calibri" panose="020F0502020204030204" pitchFamily="34" charset="0"/>
+                <a:cs typeface="Calibri" panose="020F0502020204030204" pitchFamily="34" charset="0"/>
+              </a:rPr>
+              <a:t>Aides </a:t>
+            </a:r>
+            <a:r>
+              <a:rPr lang="en-US" sz="3733" b="1" dirty="0" err="1">
+                <a:solidFill>
+                  <a:srgbClr val="1A1A1A"/>
+                </a:solidFill>
+                <a:latin typeface="Marianne" panose="02000000000000000000" pitchFamily="50" charset="0"/>
+                <a:ea typeface="Calibri" panose="020F0502020204030204" pitchFamily="34" charset="0"/>
+                <a:cs typeface="Calibri" panose="020F0502020204030204" pitchFamily="34" charset="0"/>
+              </a:rPr>
+              <a:t>financières</a:t>
+            </a:r>
+            <a:r>
+              <a:rPr lang="en-US" sz="3733" b="1" dirty="0">
+                <a:solidFill>
+                  <a:srgbClr val="1A1A1A"/>
+                </a:solidFill>
+                <a:latin typeface="Marianne" panose="02000000000000000000" pitchFamily="50" charset="0"/>
+                <a:ea typeface="Calibri" panose="020F0502020204030204" pitchFamily="34" charset="0"/>
+                <a:cs typeface="Calibri" panose="020F0502020204030204" pitchFamily="34" charset="0"/>
+              </a:rPr>
+              <a:t> et </a:t>
+            </a:r>
+            <a:r>
+              <a:rPr lang="en-US" sz="3733" b="1" dirty="0" err="1">
+                <a:solidFill>
+                  <a:srgbClr val="1A1A1A"/>
+                </a:solidFill>
+                <a:latin typeface="Marianne" panose="02000000000000000000" pitchFamily="50" charset="0"/>
+                <a:ea typeface="Calibri" panose="020F0502020204030204" pitchFamily="34" charset="0"/>
+                <a:cs typeface="Calibri" panose="020F0502020204030204" pitchFamily="34" charset="0"/>
+              </a:rPr>
+              <a:t>en</a:t>
+            </a:r>
+            <a:r>
+              <a:rPr lang="en-US" sz="3733" b="1" dirty="0">
+                <a:solidFill>
+                  <a:srgbClr val="1A1A1A"/>
+                </a:solidFill>
+                <a:latin typeface="Marianne" panose="02000000000000000000" pitchFamily="50" charset="0"/>
+                <a:ea typeface="Calibri" panose="020F0502020204030204" pitchFamily="34" charset="0"/>
+                <a:cs typeface="Calibri" panose="020F0502020204030204" pitchFamily="34" charset="0"/>
+              </a:rPr>
+              <a:t> </a:t>
+            </a:r>
+            <a:r>
+              <a:rPr lang="en-US" sz="3733" b="1" dirty="0" err="1">
+                <a:solidFill>
+                  <a:srgbClr val="1A1A1A"/>
+                </a:solidFill>
+                <a:latin typeface="Marianne" panose="02000000000000000000" pitchFamily="50" charset="0"/>
+                <a:ea typeface="Calibri" panose="020F0502020204030204" pitchFamily="34" charset="0"/>
+                <a:cs typeface="Calibri" panose="020F0502020204030204" pitchFamily="34" charset="0"/>
+              </a:rPr>
+              <a:t>ingénierie</a:t>
+            </a:r>
+            <a:endParaRPr lang="en-US" sz="3733" dirty="0">
+              <a:latin typeface="Marianne" panose="02000000000000000000" pitchFamily="50" charset="0"/>
+              <a:ea typeface="Calibri" panose="020F0502020204030204" pitchFamily="34" charset="0"/>
+              <a:cs typeface="Calibri" panose="020F0502020204030204" pitchFamily="34" charset="0"/>
+            </a:endParaRPr>
+          </a:p>
+        </p:txBody>
+      </p:sp>
+      <p:sp>
+        <p:nvSpPr>
+          <p:cNvPr id="5" name="Shape 3">
+            <a:extLst>
+              <a:ext uri="{FF2B5EF4-FFF2-40B4-BE49-F238E27FC236}">
+                <a16:creationId xmlns:a16="http://schemas.microsoft.com/office/drawing/2014/main" id="{302F78CA-65FF-9043-6070-1584BC6D4D54}"/>
+              </a:ext>
+            </a:extLst>
+          </p:cNvPr>
+          <p:cNvSpPr/>
+          <p:nvPr/>
+        </p:nvSpPr>
+        <p:spPr>
+          <a:xfrm>
+            <a:off x="609600" y="3080044"/>
+            <a:ext cx="731520" cy="48768"/>
+          </a:xfrm>
+          <a:prstGeom prst="rect">
+            <a:avLst/>
+          </a:prstGeom>
+          <a:solidFill>
+            <a:srgbClr val="1A1A1A"/>
+          </a:solidFill>
+          <a:ln w="12700">
+            <a:solidFill>
+              <a:srgbClr val="1A1A1A"/>
+            </a:solidFill>
+            <a:prstDash val="solid"/>
+          </a:ln>
+        </p:spPr>
+        <p:txBody>
+          <a:bodyPr/>
+          <a:lstStyle/>
+          <a:p>
+            <a:endParaRPr lang="fr-FR" sz="2400">
+              <a:latin typeface="Marianne" panose="02000000000000000000" pitchFamily="50" charset="0"/>
+              <a:ea typeface="Calibri" panose="020F0502020204030204" pitchFamily="34" charset="0"/>
+              <a:cs typeface="Calibri" panose="020F0502020204030204" pitchFamily="34" charset="0"/>
+            </a:endParaRPr>
+          </a:p>
+        </p:txBody>
+      </p:sp>
+      <p:sp>
+        <p:nvSpPr>
+          <p:cNvPr id="6" name="Text 4">
+            <a:extLst>
+              <a:ext uri="{FF2B5EF4-FFF2-40B4-BE49-F238E27FC236}">
+                <a16:creationId xmlns:a16="http://schemas.microsoft.com/office/drawing/2014/main" id="{9328B9A3-CC8F-11E9-FAB1-0824EF7E88D7}"/>
+              </a:ext>
+            </a:extLst>
+          </p:cNvPr>
+          <p:cNvSpPr/>
+          <p:nvPr/>
+        </p:nvSpPr>
+        <p:spPr>
+          <a:xfrm>
+            <a:off x="609600" y="3398401"/>
+            <a:ext cx="10972800" cy="2879386"/>
+          </a:xfrm>
+          <a:prstGeom prst="rect">
+            <a:avLst/>
+          </a:prstGeom>
+          <a:noFill/>
+          <a:ln/>
+        </p:spPr>
+        <p:txBody>
+          <a:bodyPr wrap="square" lIns="0" tIns="0" rIns="0" bIns="0" rtlCol="0" anchor="t"/>
+          <a:lstStyle/>
+          <a:p>
+            <a:r>
+              <a:rPr lang="en-US" sz="1600" dirty="0" err="1">
+                <a:solidFill>
+                  <a:srgbClr val="5C5C5C"/>
+                </a:solidFill>
+                <a:latin typeface="Marianne" panose="02000000000000000000" pitchFamily="50" charset="0"/>
+                <a:ea typeface="Calibri" pitchFamily="34" charset="-122"/>
+                <a:cs typeface="Calibri" pitchFamily="34" charset="-120"/>
+              </a:rPr>
+              <a:t>Dispositifs</a:t>
+            </a:r>
+            <a:r>
+              <a:rPr lang="en-US" sz="1600" dirty="0">
+                <a:solidFill>
+                  <a:srgbClr val="5C5C5C"/>
+                </a:solidFill>
+                <a:latin typeface="Marianne" panose="02000000000000000000" pitchFamily="50" charset="0"/>
+                <a:ea typeface="Calibri" pitchFamily="34" charset="-122"/>
+                <a:cs typeface="Calibri" pitchFamily="34" charset="-120"/>
+              </a:rPr>
+              <a:t> </a:t>
+            </a:r>
+            <a:r>
+              <a:rPr lang="en-US" sz="1600" dirty="0" err="1">
+                <a:solidFill>
+                  <a:srgbClr val="5C5C5C"/>
+                </a:solidFill>
+                <a:latin typeface="Marianne" panose="02000000000000000000" pitchFamily="50" charset="0"/>
+                <a:ea typeface="Calibri" pitchFamily="34" charset="-122"/>
+                <a:cs typeface="Calibri" pitchFamily="34" charset="-120"/>
+              </a:rPr>
+              <a:t>mobilisables</a:t>
+            </a:r>
+            <a:endParaRPr lang="en-US" sz="1600" dirty="0">
+              <a:latin typeface="Marianne" panose="02000000000000000000" pitchFamily="50" charset="0"/>
+            </a:endParaRPr>
+          </a:p>
+        </p:txBody>
+      </p:sp>
+      <p:cxnSp>
+        <p:nvCxnSpPr>
+          <p:cNvPr id="2" name="Connecteur droit 1">
+            <a:extLst>
+              <a:ext uri="{FF2B5EF4-FFF2-40B4-BE49-F238E27FC236}">
+                <a16:creationId xmlns:a16="http://schemas.microsoft.com/office/drawing/2014/main" id="{A3CAC41A-66B0-361D-B372-62D87EE7A9F8}"/>
+              </a:ext>
+            </a:extLst>
+          </p:cNvPr>
+          <p:cNvCxnSpPr>
+            <a:cxnSpLocks/>
+          </p:cNvCxnSpPr>
+          <p:nvPr/>
+        </p:nvCxnSpPr>
+        <p:spPr>
+          <a:xfrm>
+            <a:off x="576263" y="6512991"/>
+            <a:ext cx="11615737" cy="0"/>
+          </a:xfrm>
+          <a:prstGeom prst="line">
+            <a:avLst/>
+          </a:prstGeom>
+          <a:ln>
+            <a:solidFill>
+              <a:schemeClr val="bg1">
+                <a:lumMod val="85000"/>
+              </a:schemeClr>
+            </a:solidFill>
+          </a:ln>
+        </p:spPr>
+        <p:style>
+          <a:lnRef idx="2">
+            <a:schemeClr val="accent1"/>
+          </a:lnRef>
+          <a:fillRef idx="0">
+            <a:schemeClr val="accent1"/>
+          </a:fillRef>
+          <a:effectRef idx="1">
+            <a:schemeClr val="accent1"/>
+          </a:effectRef>
+          <a:fontRef idx="minor">
+            <a:schemeClr val="tx1"/>
+          </a:fontRef>
+        </p:style>
+      </p:cxnSp>
+      <p:sp>
+        <p:nvSpPr>
+          <p:cNvPr id="8" name="Text 3">
+            <a:extLst>
+              <a:ext uri="{FF2B5EF4-FFF2-40B4-BE49-F238E27FC236}">
+                <a16:creationId xmlns:a16="http://schemas.microsoft.com/office/drawing/2014/main" id="{515558A7-65FA-3B23-4336-CA7CF66783E3}"/>
+              </a:ext>
+            </a:extLst>
+          </p:cNvPr>
+          <p:cNvSpPr/>
+          <p:nvPr/>
+        </p:nvSpPr>
+        <p:spPr>
+          <a:xfrm>
+            <a:off x="576263" y="6598217"/>
+            <a:ext cx="8229600" cy="182880"/>
+          </a:xfrm>
+          <a:prstGeom prst="rect">
+            <a:avLst/>
+          </a:prstGeom>
+          <a:noFill/>
+          <a:ln/>
+        </p:spPr>
+        <p:txBody>
+          <a:bodyPr wrap="square" lIns="0" tIns="0" rIns="0" bIns="0" rtlCol="0" anchor="ctr"/>
+          <a:lstStyle/>
+          <a:p>
+            <a:pPr marL="0" indent="0">
+              <a:buNone/>
+            </a:pPr>
+            <a:r>
+              <a:rPr lang="en-US" sz="1000" i="1">
+                <a:solidFill>
+                  <a:srgbClr val="A0A0A0"/>
+                </a:solidFill>
+                <a:latin typeface="Marianne" panose="02000000000000000000" pitchFamily="50" charset="0"/>
+                <a:ea typeface="Calibri" panose="020F0502020204030204" pitchFamily="34" charset="0"/>
+                <a:cs typeface="Calibri" panose="020F0502020204030204" pitchFamily="34" charset="0"/>
+              </a:rPr>
+              <a:t>Données issues de Plus fraîche ma ville (ADEME)</a:t>
+            </a:r>
+            <a:endParaRPr lang="en-US" sz="1000">
+              <a:latin typeface="Marianne" panose="02000000000000000000" pitchFamily="50" charset="0"/>
+              <a:ea typeface="Calibri" panose="020F0502020204030204" pitchFamily="34" charset="0"/>
+              <a:cs typeface="Calibri" panose="020F0502020204030204" pitchFamily="34" charset="0"/>
+            </a:endParaRPr>
+          </a:p>
+        </p:txBody>
+      </p:sp>
+    </p:spTree>
+    <p:extLst>
+      <p:ext uri="{BB962C8B-B14F-4D97-AF65-F5344CB8AC3E}">
+        <p14:creationId xmlns:p14="http://schemas.microsoft.com/office/powerpoint/2010/main" val="3325200477"/>
+      </p:ext>
+    </p:extLst>
+  </p:cSld>
+  <p:clrMapOvr>
+    <a:masterClrMapping/>
+  </p:clrMapOvr>
+</p:sld>
+</file>
+
+<file path=ppt/slides/slide11.xml><?xml version="1.0" encoding="utf-8"?>
+<p:sld xmlns:a="http://schemas.openxmlformats.org/drawingml/2006/main" xmlns:r="http://schemas.openxmlformats.org/officeDocument/2006/relationships" xmlns:p="http://schemas.openxmlformats.org/presentationml/2006/main">
+  <p:cSld>
+    <p:spTree>
+      <p:nvGrpSpPr>
+        <p:cNvPr id="1" name="">
+          <a:extLst>
+            <a:ext uri="{FF2B5EF4-FFF2-40B4-BE49-F238E27FC236}">
               <a16:creationId xmlns:a16="http://schemas.microsoft.com/office/drawing/2014/main" id="{1CAD5EDA-690E-3CC6-C42C-06C82CED1E1D}"/>
             </a:ext>
           </a:extLst>
@@ -5261,7 +5631,7 @@
 </p:sld>
 </file>
 
-<file path=ppt/slides/slide11.xml><?xml version="1.0" encoding="utf-8"?>
+<file path=ppt/slides/slide12.xml><?xml version="1.0" encoding="utf-8"?>
 <p:sld xmlns:a="http://schemas.openxmlformats.org/drawingml/2006/main" xmlns:r="http://schemas.openxmlformats.org/officeDocument/2006/relationships" xmlns:p="http://schemas.openxmlformats.org/presentationml/2006/main">
   <p:cSld>
     <p:spTree>
@@ -5587,7 +5957,7 @@
 </p:sld>
 </file>
 
-<file path=ppt/slides/slide12.xml><?xml version="1.0" encoding="utf-8"?>
+<file path=ppt/slides/slide13.xml><?xml version="1.0" encoding="utf-8"?>
 <p:sld xmlns:a="http://schemas.openxmlformats.org/drawingml/2006/main" xmlns:r="http://schemas.openxmlformats.org/officeDocument/2006/relationships" xmlns:p="http://schemas.openxmlformats.org/presentationml/2006/main">
   <p:cSld>
     <p:spTree>
@@ -6459,7 +6829,7 @@
         <p:spPr>
           <a:xfrm>
             <a:off x="576262" y="345395"/>
-            <a:ext cx="10082262" cy="542307"/>
+            <a:ext cx="10082262" cy="615294"/>
           </a:xfrm>
         </p:spPr>
         <p:txBody>
@@ -6477,7 +6847,7 @@
                 <a:ea typeface="Calibri" panose="020F0502020204030204" pitchFamily="34" charset="0"/>
                 <a:cs typeface="Calibri" panose="020F0502020204030204" pitchFamily="34" charset="0"/>
               </a:rPr>
-              <a:t>Méthode</a:t>
+              <a:t>Analyse</a:t>
             </a:r>
             <a:r>
               <a:rPr lang="en-US" sz="2800" dirty="0">
@@ -6485,7 +6855,7 @@
                 <a:ea typeface="Calibri" panose="020F0502020204030204" pitchFamily="34" charset="0"/>
                 <a:cs typeface="Calibri" panose="020F0502020204030204" pitchFamily="34" charset="0"/>
               </a:rPr>
-              <a:t> {{</a:t>
+              <a:t> </a:t>
             </a:r>
             <a:r>
               <a:rPr lang="en-US" sz="2800" dirty="0" err="1">
@@ -6493,7 +6863,7 @@
                 <a:ea typeface="Calibri" panose="020F0502020204030204" pitchFamily="34" charset="0"/>
                 <a:cs typeface="Calibri" panose="020F0502020204030204" pitchFamily="34" charset="0"/>
               </a:rPr>
-              <a:t>n°_diagnostic</a:t>
+              <a:t>simplifiée</a:t>
             </a:r>
             <a:r>
               <a:rPr lang="en-US" sz="2800" dirty="0">
@@ -6501,7 +6871,7 @@
                 <a:ea typeface="Calibri" panose="020F0502020204030204" pitchFamily="34" charset="0"/>
                 <a:cs typeface="Calibri" panose="020F0502020204030204" pitchFamily="34" charset="0"/>
               </a:rPr>
-              <a:t>}} : {{</a:t>
+              <a:t> de la </a:t>
             </a:r>
             <a:r>
               <a:rPr lang="en-US" sz="2800" dirty="0" err="1">
@@ -6509,7 +6879,7 @@
                 <a:ea typeface="Calibri" panose="020F0502020204030204" pitchFamily="34" charset="0"/>
                 <a:cs typeface="Calibri" panose="020F0502020204030204" pitchFamily="34" charset="0"/>
               </a:rPr>
-              <a:t>titre_fiche_diagnostic</a:t>
+              <a:t>surchauffe</a:t>
             </a:r>
             <a:r>
               <a:rPr lang="en-US" sz="2800" dirty="0">
@@ -6517,8 +6887,37 @@
                 <a:ea typeface="Calibri" panose="020F0502020204030204" pitchFamily="34" charset="0"/>
                 <a:cs typeface="Calibri" panose="020F0502020204030204" pitchFamily="34" charset="0"/>
               </a:rPr>
-              <a:t>}}</a:t>
-            </a:r>
+              <a:t> de </a:t>
+            </a:r>
+            <a:r>
+              <a:rPr lang="en-US" sz="2800" dirty="0" err="1">
+                <a:latin typeface="Marianne" panose="02000000000000000000" pitchFamily="50" charset="0"/>
+                <a:ea typeface="Calibri" panose="020F0502020204030204" pitchFamily="34" charset="0"/>
+                <a:cs typeface="Calibri" panose="020F0502020204030204" pitchFamily="34" charset="0"/>
+              </a:rPr>
+              <a:t>l’espace</a:t>
+            </a:r>
+            <a:r>
+              <a:rPr lang="en-US" sz="2800" dirty="0">
+                <a:latin typeface="Marianne" panose="02000000000000000000" pitchFamily="50" charset="0"/>
+                <a:ea typeface="Calibri" panose="020F0502020204030204" pitchFamily="34" charset="0"/>
+                <a:cs typeface="Calibri" panose="020F0502020204030204" pitchFamily="34" charset="0"/>
+              </a:rPr>
+              <a:t> à </a:t>
+            </a:r>
+            <a:r>
+              <a:rPr lang="en-US" sz="2800" dirty="0" err="1">
+                <a:latin typeface="Marianne" panose="02000000000000000000" pitchFamily="50" charset="0"/>
+                <a:ea typeface="Calibri" panose="020F0502020204030204" pitchFamily="34" charset="0"/>
+                <a:cs typeface="Calibri" panose="020F0502020204030204" pitchFamily="34" charset="0"/>
+              </a:rPr>
+              <a:t>rafraîchir</a:t>
+            </a:r>
+            <a:endParaRPr lang="en-US" sz="2800" dirty="0">
+              <a:latin typeface="Marianne" panose="02000000000000000000" pitchFamily="50" charset="0"/>
+              <a:ea typeface="Calibri" panose="020F0502020204030204" pitchFamily="34" charset="0"/>
+              <a:cs typeface="Calibri" panose="020F0502020204030204" pitchFamily="34" charset="0"/>
+            </a:endParaRPr>
           </a:p>
         </p:txBody>
       </p:sp>
@@ -6569,10 +6968,10 @@
       </p:cxnSp>
       <p:sp>
         <p:nvSpPr>
-          <p:cNvPr id="43" name="Text 16">
-            <a:extLst>
-              <a:ext uri="{FF2B5EF4-FFF2-40B4-BE49-F238E27FC236}">
-                <a16:creationId xmlns:a16="http://schemas.microsoft.com/office/drawing/2014/main" id="{A300427D-EA15-7150-EA9C-A87450E6202D}"/>
+          <p:cNvPr id="44" name="Text 16">
+            <a:extLst>
+              <a:ext uri="{FF2B5EF4-FFF2-40B4-BE49-F238E27FC236}">
+                <a16:creationId xmlns:a16="http://schemas.microsoft.com/office/drawing/2014/main" id="{E91C9383-E765-31FC-91C1-919BA413B245}"/>
               </a:ext>
             </a:extLst>
           </p:cNvPr>
@@ -6581,8 +6980,8 @@
         </p:nvSpPr>
         <p:spPr>
           <a:xfrm>
-            <a:off x="7011736" y="1501320"/>
-            <a:ext cx="2220756" cy="293597"/>
+            <a:off x="1037765" y="1421116"/>
+            <a:ext cx="3244745" cy="293597"/>
           </a:xfrm>
           <a:prstGeom prst="rect">
             <a:avLst/>
@@ -6598,84 +6997,69 @@
               <a:buNone/>
             </a:pPr>
             <a:r>
-              <a:rPr lang="en-US" b="1" kern="0" spc="150" dirty="0">
-                <a:latin typeface="Marianne" panose="02000000000000000000" pitchFamily="50" charset="0"/>
-                <a:ea typeface="Calibri" panose="020F0502020204030204" pitchFamily="34" charset="0"/>
-                <a:cs typeface="Calibri" panose="020F0502020204030204" pitchFamily="34" charset="0"/>
-              </a:rPr>
-              <a:t>Mise </a:t>
-            </a:r>
-            <a:r>
-              <a:rPr lang="en-US" b="1" kern="0" spc="150" dirty="0" err="1">
-                <a:latin typeface="Marianne" panose="02000000000000000000" pitchFamily="50" charset="0"/>
-                <a:ea typeface="Calibri" panose="020F0502020204030204" pitchFamily="34" charset="0"/>
-                <a:cs typeface="Calibri" panose="020F0502020204030204" pitchFamily="34" charset="0"/>
-              </a:rPr>
-              <a:t>en</a:t>
-            </a:r>
-            <a:r>
-              <a:rPr lang="en-US" b="1" kern="0" spc="150" dirty="0">
-                <a:latin typeface="Marianne" panose="02000000000000000000" pitchFamily="50" charset="0"/>
-                <a:ea typeface="Calibri" panose="020F0502020204030204" pitchFamily="34" charset="0"/>
-                <a:cs typeface="Calibri" panose="020F0502020204030204" pitchFamily="34" charset="0"/>
-              </a:rPr>
-              <a:t> oeuvre</a:t>
-            </a:r>
-            <a:endParaRPr lang="en-US" dirty="0">
-              <a:latin typeface="Marianne" panose="02000000000000000000" pitchFamily="50" charset="0"/>
-              <a:ea typeface="Calibri" panose="020F0502020204030204" pitchFamily="34" charset="0"/>
-              <a:cs typeface="Calibri" panose="020F0502020204030204" pitchFamily="34" charset="0"/>
-            </a:endParaRPr>
-          </a:p>
-        </p:txBody>
-      </p:sp>
-      <p:sp>
-        <p:nvSpPr>
-          <p:cNvPr id="44" name="Text 16">
-            <a:extLst>
-              <a:ext uri="{FF2B5EF4-FFF2-40B4-BE49-F238E27FC236}">
-                <a16:creationId xmlns:a16="http://schemas.microsoft.com/office/drawing/2014/main" id="{E91C9383-E765-31FC-91C1-919BA413B245}"/>
-              </a:ext>
-            </a:extLst>
-          </p:cNvPr>
-          <p:cNvSpPr/>
-          <p:nvPr/>
-        </p:nvSpPr>
-        <p:spPr>
-          <a:xfrm>
-            <a:off x="645627" y="1501320"/>
-            <a:ext cx="3477347" cy="293597"/>
-          </a:xfrm>
-          <a:prstGeom prst="rect">
-            <a:avLst/>
-          </a:prstGeom>
-          <a:noFill/>
-          <a:ln/>
-        </p:spPr>
-        <p:txBody>
-          <a:bodyPr wrap="square" lIns="0" tIns="0" rIns="0" bIns="0" rtlCol="0" anchor="ctr"/>
-          <a:lstStyle/>
-          <a:p>
-            <a:pPr marL="0" indent="0">
-              <a:buNone/>
-            </a:pPr>
-            <a:r>
-              <a:rPr lang="en-US" b="1" kern="0" spc="150" dirty="0">
-                <a:latin typeface="Marianne" panose="02000000000000000000" pitchFamily="50" charset="0"/>
-                <a:ea typeface="Calibri" panose="020F0502020204030204" pitchFamily="34" charset="0"/>
-                <a:cs typeface="Calibri" panose="020F0502020204030204" pitchFamily="34" charset="0"/>
-              </a:rPr>
-              <a:t>Description de la </a:t>
-            </a:r>
-            <a:r>
-              <a:rPr lang="en-US" b="1" kern="0" spc="150" dirty="0" err="1">
-                <a:latin typeface="Marianne" panose="02000000000000000000" pitchFamily="50" charset="0"/>
-                <a:ea typeface="Calibri" panose="020F0502020204030204" pitchFamily="34" charset="0"/>
-                <a:cs typeface="Calibri" panose="020F0502020204030204" pitchFamily="34" charset="0"/>
-              </a:rPr>
-              <a:t>méthode</a:t>
-            </a:r>
-            <a:endParaRPr lang="en-US" dirty="0">
+              <a:rPr lang="en-US" sz="1400" kern="0" spc="150" dirty="0">
+                <a:solidFill>
+                  <a:schemeClr val="tx1">
+                    <a:lumMod val="65000"/>
+                    <a:lumOff val="35000"/>
+                  </a:schemeClr>
+                </a:solidFill>
+                <a:latin typeface="Marianne" panose="02000000000000000000" pitchFamily="50" charset="0"/>
+                <a:ea typeface="Calibri" panose="020F0502020204030204" pitchFamily="34" charset="0"/>
+                <a:cs typeface="Calibri" panose="020F0502020204030204" pitchFamily="34" charset="0"/>
+              </a:rPr>
+              <a:t>Coefficient de</a:t>
+            </a:r>
+            <a:br>
+              <a:rPr lang="en-US" sz="1400" kern="0" spc="150" dirty="0">
+                <a:solidFill>
+                  <a:schemeClr val="tx1">
+                    <a:lumMod val="65000"/>
+                    <a:lumOff val="35000"/>
+                  </a:schemeClr>
+                </a:solidFill>
+                <a:latin typeface="Marianne" panose="02000000000000000000" pitchFamily="50" charset="0"/>
+                <a:ea typeface="Calibri" panose="020F0502020204030204" pitchFamily="34" charset="0"/>
+                <a:cs typeface="Calibri" panose="020F0502020204030204" pitchFamily="34" charset="0"/>
+              </a:rPr>
+            </a:br>
+            <a:r>
+              <a:rPr lang="en-US" sz="1400" b="1" kern="0" spc="150" dirty="0" err="1">
+                <a:solidFill>
+                  <a:srgbClr val="000091"/>
+                </a:solidFill>
+                <a:latin typeface="Marianne" panose="02000000000000000000" pitchFamily="50" charset="0"/>
+                <a:ea typeface="Calibri" panose="020F0502020204030204" pitchFamily="34" charset="0"/>
+                <a:cs typeface="Calibri" panose="020F0502020204030204" pitchFamily="34" charset="0"/>
+              </a:rPr>
+              <a:t>Rafraîchissement</a:t>
+            </a:r>
+            <a:r>
+              <a:rPr lang="en-US" sz="1400" b="1" kern="0" spc="150" dirty="0">
+                <a:solidFill>
+                  <a:srgbClr val="000091"/>
+                </a:solidFill>
+                <a:latin typeface="Marianne" panose="02000000000000000000" pitchFamily="50" charset="0"/>
+                <a:ea typeface="Calibri" panose="020F0502020204030204" pitchFamily="34" charset="0"/>
+                <a:cs typeface="Calibri" panose="020F0502020204030204" pitchFamily="34" charset="0"/>
+              </a:rPr>
+              <a:t> </a:t>
+            </a:r>
+            <a:r>
+              <a:rPr lang="en-US" sz="1400" b="1" kern="0" spc="150" dirty="0" err="1">
+                <a:solidFill>
+                  <a:srgbClr val="000091"/>
+                </a:solidFill>
+                <a:latin typeface="Marianne" panose="02000000000000000000" pitchFamily="50" charset="0"/>
+                <a:ea typeface="Calibri" panose="020F0502020204030204" pitchFamily="34" charset="0"/>
+                <a:cs typeface="Calibri" panose="020F0502020204030204" pitchFamily="34" charset="0"/>
+              </a:rPr>
+              <a:t>urbain</a:t>
+            </a:r>
+            <a:endParaRPr lang="en-US" sz="1400" b="1" dirty="0">
+              <a:solidFill>
+                <a:srgbClr val="000091"/>
+              </a:solidFill>
               <a:latin typeface="Marianne" panose="02000000000000000000" pitchFamily="50" charset="0"/>
               <a:ea typeface="Calibri" panose="020F0502020204030204" pitchFamily="34" charset="0"/>
               <a:cs typeface="Calibri" panose="020F0502020204030204" pitchFamily="34" charset="0"/>
@@ -6835,6 +7219,2357 @@
         </p:nvSpPr>
         <p:spPr>
           <a:xfrm>
+            <a:off x="413637" y="2480540"/>
+            <a:ext cx="476250" cy="461665"/>
+          </a:xfrm>
+          <a:prstGeom prst="rect">
+            <a:avLst/>
+          </a:prstGeom>
+          <a:noFill/>
+        </p:spPr>
+        <p:txBody>
+          <a:bodyPr wrap="square">
+            <a:spAutoFit/>
+          </a:bodyPr>
+          <a:lstStyle/>
+          <a:p>
+            <a:pPr algn="ctr"/>
+            <a:r>
+              <a:rPr lang="fr-FR" sz="1200" b="1" dirty="0">
+                <a:solidFill>
+                  <a:schemeClr val="tx1">
+                    <a:lumMod val="65000"/>
+                    <a:lumOff val="35000"/>
+                  </a:schemeClr>
+                </a:solidFill>
+                <a:latin typeface="Marianne" panose="02000000000000000000" pitchFamily="50" charset="0"/>
+                <a:ea typeface="Calibri" panose="020F0502020204030204" pitchFamily="34" charset="0"/>
+                <a:cs typeface="Calibri" panose="020F0502020204030204" pitchFamily="34" charset="0"/>
+              </a:rPr>
+              <a:t>|</a:t>
+            </a:r>
+          </a:p>
+          <a:p>
+            <a:pPr algn="ctr"/>
+            <a:r>
+              <a:rPr lang="fr-FR" sz="1200" b="1" dirty="0">
+                <a:solidFill>
+                  <a:schemeClr val="tx1">
+                    <a:lumMod val="65000"/>
+                    <a:lumOff val="35000"/>
+                  </a:schemeClr>
+                </a:solidFill>
+                <a:latin typeface="Marianne" panose="02000000000000000000" pitchFamily="50" charset="0"/>
+                <a:ea typeface="Calibri" panose="020F0502020204030204" pitchFamily="34" charset="0"/>
+                <a:cs typeface="Calibri" panose="020F0502020204030204" pitchFamily="34" charset="0"/>
+              </a:rPr>
+              <a:t>0</a:t>
+            </a:r>
+            <a:endParaRPr lang="fr-FR" sz="1200" dirty="0">
+              <a:solidFill>
+                <a:schemeClr val="tx1">
+                  <a:lumMod val="65000"/>
+                  <a:lumOff val="35000"/>
+                </a:schemeClr>
+              </a:solidFill>
+              <a:latin typeface="Marianne" panose="02000000000000000000" pitchFamily="50" charset="0"/>
+              <a:ea typeface="Calibri" panose="020F0502020204030204" pitchFamily="34" charset="0"/>
+              <a:cs typeface="Calibri" panose="020F0502020204030204" pitchFamily="34" charset="0"/>
+            </a:endParaRPr>
+          </a:p>
+        </p:txBody>
+      </p:sp>
+      <p:sp>
+        <p:nvSpPr>
+          <p:cNvPr id="23" name="zone_coeff_ru_resultat">
+            <a:extLst>
+              <a:ext uri="{FF2B5EF4-FFF2-40B4-BE49-F238E27FC236}">
+                <a16:creationId xmlns:a16="http://schemas.microsoft.com/office/drawing/2014/main" id="{B8474404-E488-86F0-E047-048FC0C9776E}"/>
+              </a:ext>
+            </a:extLst>
+          </p:cNvPr>
+          <p:cNvSpPr txBox="1"/>
+          <p:nvPr/>
+        </p:nvSpPr>
+        <p:spPr>
+          <a:xfrm>
+            <a:off x="3217874" y="1337544"/>
+            <a:ext cx="2341356" cy="492443"/>
+          </a:xfrm>
+          <a:prstGeom prst="rect">
+            <a:avLst/>
+          </a:prstGeom>
+          <a:noFill/>
+        </p:spPr>
+        <p:txBody>
+          <a:bodyPr wrap="square">
+            <a:spAutoFit/>
+          </a:bodyPr>
+          <a:lstStyle/>
+          <a:p>
+            <a:pPr algn="r"/>
+            <a:r>
+              <a:rPr lang="fr-FR" sz="2600" b="1" dirty="0">
+                <a:solidFill>
+                  <a:schemeClr val="tx1">
+                    <a:lumMod val="65000"/>
+                    <a:lumOff val="35000"/>
+                  </a:schemeClr>
+                </a:solidFill>
+                <a:latin typeface="Marianne" panose="02000000000000000000" pitchFamily="50" charset="0"/>
+                <a:ea typeface="Calibri" panose="020F0502020204030204" pitchFamily="34" charset="0"/>
+                <a:cs typeface="Calibri" panose="020F0502020204030204" pitchFamily="34" charset="0"/>
+              </a:rPr>
+              <a:t>{{</a:t>
+            </a:r>
+            <a:r>
+              <a:rPr lang="fr-FR" sz="2600" b="1" dirty="0" err="1">
+                <a:solidFill>
+                  <a:schemeClr val="tx1">
+                    <a:lumMod val="65000"/>
+                    <a:lumOff val="35000"/>
+                  </a:schemeClr>
+                </a:solidFill>
+                <a:latin typeface="Marianne" panose="02000000000000000000" pitchFamily="50" charset="0"/>
+                <a:ea typeface="Calibri" panose="020F0502020204030204" pitchFamily="34" charset="0"/>
+                <a:cs typeface="Calibri" panose="020F0502020204030204" pitchFamily="34" charset="0"/>
+              </a:rPr>
+              <a:t>coeff_ru</a:t>
+            </a:r>
+            <a:r>
+              <a:rPr lang="fr-FR" sz="2600" b="1" dirty="0">
+                <a:solidFill>
+                  <a:schemeClr val="tx1">
+                    <a:lumMod val="65000"/>
+                    <a:lumOff val="35000"/>
+                  </a:schemeClr>
+                </a:solidFill>
+                <a:latin typeface="Marianne" panose="02000000000000000000" pitchFamily="50" charset="0"/>
+                <a:ea typeface="Calibri" panose="020F0502020204030204" pitchFamily="34" charset="0"/>
+                <a:cs typeface="Calibri" panose="020F0502020204030204" pitchFamily="34" charset="0"/>
+              </a:rPr>
+              <a:t>}}</a:t>
+            </a:r>
+            <a:r>
+              <a:rPr lang="fr-FR" sz="1500" dirty="0">
+                <a:solidFill>
+                  <a:schemeClr val="tx1">
+                    <a:lumMod val="65000"/>
+                    <a:lumOff val="35000"/>
+                  </a:schemeClr>
+                </a:solidFill>
+                <a:latin typeface="Marianne" panose="02000000000000000000" pitchFamily="50" charset="0"/>
+                <a:ea typeface="Calibri" panose="020F0502020204030204" pitchFamily="34" charset="0"/>
+                <a:cs typeface="Calibri" panose="020F0502020204030204" pitchFamily="34" charset="0"/>
+              </a:rPr>
+              <a:t> / 1</a:t>
+            </a:r>
+          </a:p>
+        </p:txBody>
+      </p:sp>
+      <p:sp>
+        <p:nvSpPr>
+          <p:cNvPr id="24" name="ZoneTexte 23">
+            <a:extLst>
+              <a:ext uri="{FF2B5EF4-FFF2-40B4-BE49-F238E27FC236}">
+                <a16:creationId xmlns:a16="http://schemas.microsoft.com/office/drawing/2014/main" id="{85DCA6C4-87A6-9194-C19C-D27B78EB3AD6}"/>
+              </a:ext>
+            </a:extLst>
+          </p:cNvPr>
+          <p:cNvSpPr txBox="1"/>
+          <p:nvPr/>
+        </p:nvSpPr>
+        <p:spPr>
+          <a:xfrm>
+            <a:off x="508248" y="2886968"/>
+            <a:ext cx="1570680" cy="400110"/>
+          </a:xfrm>
+          <a:prstGeom prst="rect">
+            <a:avLst/>
+          </a:prstGeom>
+          <a:noFill/>
+        </p:spPr>
+        <p:txBody>
+          <a:bodyPr wrap="square">
+            <a:spAutoFit/>
+          </a:bodyPr>
+          <a:lstStyle/>
+          <a:p>
+            <a:r>
+              <a:rPr lang="fr-FR" sz="1000" dirty="0">
+                <a:solidFill>
+                  <a:schemeClr val="tx1">
+                    <a:lumMod val="65000"/>
+                    <a:lumOff val="35000"/>
+                  </a:schemeClr>
+                </a:solidFill>
+                <a:latin typeface="Marianne" panose="02000000000000000000" pitchFamily="50" charset="0"/>
+                <a:ea typeface="Calibri" panose="020F0502020204030204" pitchFamily="34" charset="0"/>
+                <a:cs typeface="Calibri" panose="020F0502020204030204" pitchFamily="34" charset="0"/>
+              </a:rPr>
+              <a:t>Espace public très réchauffant</a:t>
+            </a:r>
+          </a:p>
+        </p:txBody>
+      </p:sp>
+      <p:sp>
+        <p:nvSpPr>
+          <p:cNvPr id="26" name="zone_coeff_ru_analyse">
+            <a:extLst>
+              <a:ext uri="{FF2B5EF4-FFF2-40B4-BE49-F238E27FC236}">
+                <a16:creationId xmlns:a16="http://schemas.microsoft.com/office/drawing/2014/main" id="{608F7C5C-B2A7-E255-DC57-2AE0D978AD00}"/>
+              </a:ext>
+            </a:extLst>
+          </p:cNvPr>
+          <p:cNvSpPr txBox="1"/>
+          <p:nvPr/>
+        </p:nvSpPr>
+        <p:spPr>
+          <a:xfrm>
+            <a:off x="508248" y="3510262"/>
+            <a:ext cx="5520587" cy="338554"/>
+          </a:xfrm>
+          <a:prstGeom prst="rect">
+            <a:avLst/>
+          </a:prstGeom>
+          <a:noFill/>
+        </p:spPr>
+        <p:txBody>
+          <a:bodyPr wrap="square">
+            <a:spAutoFit/>
+          </a:bodyPr>
+          <a:lstStyle/>
+          <a:p>
+            <a:r>
+              <a:rPr lang="fr-FR" sz="1600" dirty="0">
+                <a:solidFill>
+                  <a:schemeClr val="tx1">
+                    <a:lumMod val="65000"/>
+                    <a:lumOff val="35000"/>
+                  </a:schemeClr>
+                </a:solidFill>
+                <a:latin typeface="Marianne" panose="02000000000000000000" pitchFamily="50" charset="0"/>
+                <a:ea typeface="Calibri" panose="020F0502020204030204" pitchFamily="34" charset="0"/>
+                <a:cs typeface="Calibri" panose="020F0502020204030204" pitchFamily="34" charset="0"/>
+              </a:rPr>
+              <a:t>{{</a:t>
+            </a:r>
+            <a:r>
+              <a:rPr lang="fr-FR" sz="1600" dirty="0" err="1">
+                <a:solidFill>
+                  <a:schemeClr val="tx1">
+                    <a:lumMod val="65000"/>
+                    <a:lumOff val="35000"/>
+                  </a:schemeClr>
+                </a:solidFill>
+                <a:latin typeface="Marianne" panose="02000000000000000000" pitchFamily="50" charset="0"/>
+                <a:ea typeface="Calibri" panose="020F0502020204030204" pitchFamily="34" charset="0"/>
+                <a:cs typeface="Calibri" panose="020F0502020204030204" pitchFamily="34" charset="0"/>
+              </a:rPr>
+              <a:t>analyse_coeff_ru</a:t>
+            </a:r>
+            <a:r>
+              <a:rPr lang="fr-FR" sz="1600" dirty="0">
+                <a:solidFill>
+                  <a:schemeClr val="tx1">
+                    <a:lumMod val="65000"/>
+                    <a:lumOff val="35000"/>
+                  </a:schemeClr>
+                </a:solidFill>
+                <a:latin typeface="Marianne" panose="02000000000000000000" pitchFamily="50" charset="0"/>
+                <a:ea typeface="Calibri" panose="020F0502020204030204" pitchFamily="34" charset="0"/>
+                <a:cs typeface="Calibri" panose="020F0502020204030204" pitchFamily="34" charset="0"/>
+              </a:rPr>
+              <a:t>}}</a:t>
+            </a:r>
+          </a:p>
+        </p:txBody>
+      </p:sp>
+      <p:pic>
+        <p:nvPicPr>
+          <p:cNvPr id="19" name="Graphique 18">
+            <a:extLst>
+              <a:ext uri="{FF2B5EF4-FFF2-40B4-BE49-F238E27FC236}">
+                <a16:creationId xmlns:a16="http://schemas.microsoft.com/office/drawing/2014/main" id="{7F04C829-FC9E-0D50-4C89-B26887E9A256}"/>
+              </a:ext>
+            </a:extLst>
+          </p:cNvPr>
+          <p:cNvPicPr>
+            <a:picLocks noChangeAspect="1"/>
+          </p:cNvPicPr>
+          <p:nvPr/>
+        </p:nvPicPr>
+        <p:blipFill>
+          <a:blip r:embed="rId3">
+            <a:extLst>
+              <a:ext uri="{96DAC541-7B7A-43D3-8B79-37D633B846F1}">
+                <asvg:svgBlip xmlns:asvg="http://schemas.microsoft.com/office/drawing/2016/SVG/main" r:embed="rId4"/>
+              </a:ext>
+            </a:extLst>
+          </a:blip>
+          <a:stretch>
+            <a:fillRect/>
+          </a:stretch>
+        </p:blipFill>
+        <p:spPr>
+          <a:xfrm>
+            <a:off x="575412" y="1351292"/>
+            <a:ext cx="421353" cy="421353"/>
+          </a:xfrm>
+          <a:prstGeom prst="rect">
+            <a:avLst/>
+          </a:prstGeom>
+        </p:spPr>
+      </p:pic>
+      <p:pic>
+        <p:nvPicPr>
+          <p:cNvPr id="22" name="zone_coeff_ru_echelle">
+            <a:extLst>
+              <a:ext uri="{FF2B5EF4-FFF2-40B4-BE49-F238E27FC236}">
+                <a16:creationId xmlns:a16="http://schemas.microsoft.com/office/drawing/2014/main" id="{76E8F867-23AD-C898-638B-48FE80B6F75A}"/>
+              </a:ext>
+            </a:extLst>
+          </p:cNvPr>
+          <p:cNvPicPr>
+            <a:picLocks noChangeAspect="1"/>
+          </p:cNvPicPr>
+          <p:nvPr/>
+        </p:nvPicPr>
+        <p:blipFill>
+          <a:blip r:embed="rId5">
+            <a:extLst>
+              <a:ext uri="{96DAC541-7B7A-43D3-8B79-37D633B846F1}">
+                <asvg:svgBlip xmlns:asvg="http://schemas.microsoft.com/office/drawing/2016/SVG/main" r:embed="rId6"/>
+              </a:ext>
+            </a:extLst>
+          </a:blip>
+          <a:stretch>
+            <a:fillRect/>
+          </a:stretch>
+        </p:blipFill>
+        <p:spPr>
+          <a:xfrm>
+            <a:off x="651763" y="2259705"/>
+            <a:ext cx="4785652" cy="247650"/>
+          </a:xfrm>
+          <a:prstGeom prst="rect">
+            <a:avLst/>
+          </a:prstGeom>
+        </p:spPr>
+      </p:pic>
+      <p:sp>
+        <p:nvSpPr>
+          <p:cNvPr id="29" name="ZoneTexte 28">
+            <a:extLst>
+              <a:ext uri="{FF2B5EF4-FFF2-40B4-BE49-F238E27FC236}">
+                <a16:creationId xmlns:a16="http://schemas.microsoft.com/office/drawing/2014/main" id="{2CCBF05D-7C66-27DA-1E1D-7F954CC00891}"/>
+              </a:ext>
+            </a:extLst>
+          </p:cNvPr>
+          <p:cNvSpPr txBox="1"/>
+          <p:nvPr/>
+        </p:nvSpPr>
+        <p:spPr>
+          <a:xfrm>
+            <a:off x="5188647" y="2480540"/>
+            <a:ext cx="476250" cy="461665"/>
+          </a:xfrm>
+          <a:prstGeom prst="rect">
+            <a:avLst/>
+          </a:prstGeom>
+          <a:noFill/>
+        </p:spPr>
+        <p:txBody>
+          <a:bodyPr wrap="square">
+            <a:spAutoFit/>
+          </a:bodyPr>
+          <a:lstStyle/>
+          <a:p>
+            <a:pPr algn="ctr"/>
+            <a:r>
+              <a:rPr lang="fr-FR" sz="1200" b="1" dirty="0">
+                <a:solidFill>
+                  <a:schemeClr val="tx1">
+                    <a:lumMod val="65000"/>
+                    <a:lumOff val="35000"/>
+                  </a:schemeClr>
+                </a:solidFill>
+                <a:latin typeface="Marianne" panose="02000000000000000000" pitchFamily="50" charset="0"/>
+                <a:ea typeface="Calibri" panose="020F0502020204030204" pitchFamily="34" charset="0"/>
+                <a:cs typeface="Calibri" panose="020F0502020204030204" pitchFamily="34" charset="0"/>
+              </a:rPr>
+              <a:t>|</a:t>
+            </a:r>
+          </a:p>
+          <a:p>
+            <a:pPr algn="ctr"/>
+            <a:r>
+              <a:rPr lang="fr-FR" sz="1200" b="1" dirty="0">
+                <a:solidFill>
+                  <a:schemeClr val="tx1">
+                    <a:lumMod val="65000"/>
+                    <a:lumOff val="35000"/>
+                  </a:schemeClr>
+                </a:solidFill>
+                <a:latin typeface="Marianne" panose="02000000000000000000" pitchFamily="50" charset="0"/>
+                <a:ea typeface="Calibri" panose="020F0502020204030204" pitchFamily="34" charset="0"/>
+                <a:cs typeface="Calibri" panose="020F0502020204030204" pitchFamily="34" charset="0"/>
+              </a:rPr>
+              <a:t>1</a:t>
+            </a:r>
+            <a:endParaRPr lang="fr-FR" sz="1200" dirty="0">
+              <a:solidFill>
+                <a:schemeClr val="tx1">
+                  <a:lumMod val="65000"/>
+                  <a:lumOff val="35000"/>
+                </a:schemeClr>
+              </a:solidFill>
+              <a:latin typeface="Marianne" panose="02000000000000000000" pitchFamily="50" charset="0"/>
+              <a:ea typeface="Calibri" panose="020F0502020204030204" pitchFamily="34" charset="0"/>
+              <a:cs typeface="Calibri" panose="020F0502020204030204" pitchFamily="34" charset="0"/>
+            </a:endParaRPr>
+          </a:p>
+        </p:txBody>
+      </p:sp>
+      <p:sp>
+        <p:nvSpPr>
+          <p:cNvPr id="30" name="ZoneTexte 29">
+            <a:extLst>
+              <a:ext uri="{FF2B5EF4-FFF2-40B4-BE49-F238E27FC236}">
+                <a16:creationId xmlns:a16="http://schemas.microsoft.com/office/drawing/2014/main" id="{431BEB7D-AA3D-0C43-A325-16764A9732EB}"/>
+              </a:ext>
+            </a:extLst>
+          </p:cNvPr>
+          <p:cNvSpPr txBox="1"/>
+          <p:nvPr/>
+        </p:nvSpPr>
+        <p:spPr>
+          <a:xfrm>
+            <a:off x="3991909" y="2897891"/>
+            <a:ext cx="1570680" cy="400110"/>
+          </a:xfrm>
+          <a:prstGeom prst="rect">
+            <a:avLst/>
+          </a:prstGeom>
+          <a:noFill/>
+        </p:spPr>
+        <p:txBody>
+          <a:bodyPr wrap="square">
+            <a:spAutoFit/>
+          </a:bodyPr>
+          <a:lstStyle/>
+          <a:p>
+            <a:pPr algn="r"/>
+            <a:r>
+              <a:rPr lang="fr-FR" sz="1000" dirty="0">
+                <a:solidFill>
+                  <a:schemeClr val="tx1">
+                    <a:lumMod val="65000"/>
+                    <a:lumOff val="35000"/>
+                  </a:schemeClr>
+                </a:solidFill>
+                <a:latin typeface="Marianne" panose="02000000000000000000" pitchFamily="50" charset="0"/>
+                <a:ea typeface="Calibri" panose="020F0502020204030204" pitchFamily="34" charset="0"/>
+                <a:cs typeface="Calibri" panose="020F0502020204030204" pitchFamily="34" charset="0"/>
+              </a:rPr>
+              <a:t>Espace public très rafraîchissant</a:t>
+            </a:r>
+          </a:p>
+        </p:txBody>
+      </p:sp>
+      <p:pic>
+        <p:nvPicPr>
+          <p:cNvPr id="32" name="zone_coeff_ru_curseur">
+            <a:extLst>
+              <a:ext uri="{FF2B5EF4-FFF2-40B4-BE49-F238E27FC236}">
+                <a16:creationId xmlns:a16="http://schemas.microsoft.com/office/drawing/2014/main" id="{07E6566C-AE16-33FB-0B10-1897683DF483}"/>
+              </a:ext>
+            </a:extLst>
+          </p:cNvPr>
+          <p:cNvPicPr>
+            <a:picLocks noChangeAspect="1"/>
+          </p:cNvPicPr>
+          <p:nvPr/>
+        </p:nvPicPr>
+        <p:blipFill>
+          <a:blip r:embed="rId7">
+            <a:extLst>
+              <a:ext uri="{96DAC541-7B7A-43D3-8B79-37D633B846F1}">
+                <asvg:svgBlip xmlns:asvg="http://schemas.microsoft.com/office/drawing/2016/SVG/main" r:embed="rId8"/>
+              </a:ext>
+            </a:extLst>
+          </a:blip>
+          <a:stretch>
+            <a:fillRect/>
+          </a:stretch>
+        </p:blipFill>
+        <p:spPr>
+          <a:xfrm>
+            <a:off x="538547" y="2049705"/>
+            <a:ext cx="314325" cy="285750"/>
+          </a:xfrm>
+          <a:prstGeom prst="rect">
+            <a:avLst/>
+          </a:prstGeom>
+        </p:spPr>
+      </p:pic>
+      <p:sp>
+        <p:nvSpPr>
+          <p:cNvPr id="35" name="ZoneTexte 34">
+            <a:extLst>
+              <a:ext uri="{FF2B5EF4-FFF2-40B4-BE49-F238E27FC236}">
+                <a16:creationId xmlns:a16="http://schemas.microsoft.com/office/drawing/2014/main" id="{1F5DF589-1FD3-4B13-9BAB-E4814C1486FA}"/>
+              </a:ext>
+            </a:extLst>
+          </p:cNvPr>
+          <p:cNvSpPr txBox="1"/>
+          <p:nvPr/>
+        </p:nvSpPr>
+        <p:spPr>
+          <a:xfrm>
+            <a:off x="2810238" y="2480540"/>
+            <a:ext cx="476250" cy="461665"/>
+          </a:xfrm>
+          <a:prstGeom prst="rect">
+            <a:avLst/>
+          </a:prstGeom>
+          <a:noFill/>
+        </p:spPr>
+        <p:txBody>
+          <a:bodyPr wrap="square">
+            <a:spAutoFit/>
+          </a:bodyPr>
+          <a:lstStyle/>
+          <a:p>
+            <a:pPr algn="ctr"/>
+            <a:r>
+              <a:rPr lang="fr-FR" sz="1200" b="1" dirty="0">
+                <a:solidFill>
+                  <a:schemeClr val="tx1">
+                    <a:lumMod val="65000"/>
+                    <a:lumOff val="35000"/>
+                  </a:schemeClr>
+                </a:solidFill>
+                <a:latin typeface="Marianne" panose="02000000000000000000" pitchFamily="50" charset="0"/>
+                <a:ea typeface="Calibri" panose="020F0502020204030204" pitchFamily="34" charset="0"/>
+                <a:cs typeface="Calibri" panose="020F0502020204030204" pitchFamily="34" charset="0"/>
+              </a:rPr>
+              <a:t>|</a:t>
+            </a:r>
+          </a:p>
+          <a:p>
+            <a:pPr algn="ctr"/>
+            <a:r>
+              <a:rPr lang="fr-FR" sz="1200" b="1" dirty="0">
+                <a:solidFill>
+                  <a:schemeClr val="tx1">
+                    <a:lumMod val="65000"/>
+                    <a:lumOff val="35000"/>
+                  </a:schemeClr>
+                </a:solidFill>
+                <a:latin typeface="Marianne" panose="02000000000000000000" pitchFamily="50" charset="0"/>
+                <a:ea typeface="Calibri" panose="020F0502020204030204" pitchFamily="34" charset="0"/>
+                <a:cs typeface="Calibri" panose="020F0502020204030204" pitchFamily="34" charset="0"/>
+              </a:rPr>
+              <a:t>0,5</a:t>
+            </a:r>
+            <a:endParaRPr lang="fr-FR" sz="1200" dirty="0">
+              <a:solidFill>
+                <a:schemeClr val="tx1">
+                  <a:lumMod val="65000"/>
+                  <a:lumOff val="35000"/>
+                </a:schemeClr>
+              </a:solidFill>
+              <a:latin typeface="Marianne" panose="02000000000000000000" pitchFamily="50" charset="0"/>
+              <a:ea typeface="Calibri" panose="020F0502020204030204" pitchFamily="34" charset="0"/>
+              <a:cs typeface="Calibri" panose="020F0502020204030204" pitchFamily="34" charset="0"/>
+            </a:endParaRPr>
+          </a:p>
+        </p:txBody>
+      </p:sp>
+      <p:sp>
+        <p:nvSpPr>
+          <p:cNvPr id="38" name="Text 16">
+            <a:extLst>
+              <a:ext uri="{FF2B5EF4-FFF2-40B4-BE49-F238E27FC236}">
+                <a16:creationId xmlns:a16="http://schemas.microsoft.com/office/drawing/2014/main" id="{586A8838-E396-59E5-AC0F-DB258C9BB497}"/>
+              </a:ext>
+            </a:extLst>
+          </p:cNvPr>
+          <p:cNvSpPr/>
+          <p:nvPr/>
+        </p:nvSpPr>
+        <p:spPr>
+          <a:xfrm>
+            <a:off x="7708478" y="1421116"/>
+            <a:ext cx="1448705" cy="293597"/>
+          </a:xfrm>
+          <a:prstGeom prst="rect">
+            <a:avLst/>
+          </a:prstGeom>
+          <a:noFill/>
+          <a:ln/>
+        </p:spPr>
+        <p:txBody>
+          <a:bodyPr wrap="square" lIns="0" tIns="0" rIns="0" bIns="0" rtlCol="0" anchor="ctr"/>
+          <a:lstStyle/>
+          <a:p>
+            <a:pPr marL="0" indent="0">
+              <a:buNone/>
+            </a:pPr>
+            <a:r>
+              <a:rPr lang="en-US" sz="1200" kern="0" spc="150" dirty="0">
+                <a:solidFill>
+                  <a:schemeClr val="tx1">
+                    <a:lumMod val="65000"/>
+                    <a:lumOff val="35000"/>
+                  </a:schemeClr>
+                </a:solidFill>
+                <a:latin typeface="Marianne" panose="02000000000000000000" pitchFamily="50" charset="0"/>
+                <a:ea typeface="Calibri" panose="020F0502020204030204" pitchFamily="34" charset="0"/>
+                <a:cs typeface="Calibri" panose="020F0502020204030204" pitchFamily="34" charset="0"/>
+              </a:rPr>
+              <a:t>Coefficient de</a:t>
+            </a:r>
+            <a:br>
+              <a:rPr lang="en-US" sz="1200" kern="0" spc="150" dirty="0">
+                <a:solidFill>
+                  <a:schemeClr val="tx1">
+                    <a:lumMod val="65000"/>
+                    <a:lumOff val="35000"/>
+                  </a:schemeClr>
+                </a:solidFill>
+                <a:latin typeface="Marianne" panose="02000000000000000000" pitchFamily="50" charset="0"/>
+                <a:ea typeface="Calibri" panose="020F0502020204030204" pitchFamily="34" charset="0"/>
+                <a:cs typeface="Calibri" panose="020F0502020204030204" pitchFamily="34" charset="0"/>
+              </a:rPr>
+            </a:br>
+            <a:r>
+              <a:rPr lang="en-US" sz="1300" b="1" kern="0" spc="150" dirty="0" err="1">
+                <a:solidFill>
+                  <a:srgbClr val="3B87FF"/>
+                </a:solidFill>
+                <a:latin typeface="Marianne" panose="02000000000000000000" pitchFamily="50" charset="0"/>
+                <a:ea typeface="Calibri" panose="020F0502020204030204" pitchFamily="34" charset="0"/>
+                <a:cs typeface="Calibri" panose="020F0502020204030204" pitchFamily="34" charset="0"/>
+              </a:rPr>
+              <a:t>Perméabilité</a:t>
+            </a:r>
+            <a:endParaRPr lang="en-US" sz="1300" b="1" dirty="0">
+              <a:solidFill>
+                <a:srgbClr val="3B87FF"/>
+              </a:solidFill>
+              <a:latin typeface="Marianne" panose="02000000000000000000" pitchFamily="50" charset="0"/>
+              <a:ea typeface="Calibri" panose="020F0502020204030204" pitchFamily="34" charset="0"/>
+              <a:cs typeface="Calibri" panose="020F0502020204030204" pitchFamily="34" charset="0"/>
+            </a:endParaRPr>
+          </a:p>
+        </p:txBody>
+      </p:sp>
+      <p:sp>
+        <p:nvSpPr>
+          <p:cNvPr id="39" name="ZoneTexte 38">
+            <a:extLst>
+              <a:ext uri="{FF2B5EF4-FFF2-40B4-BE49-F238E27FC236}">
+                <a16:creationId xmlns:a16="http://schemas.microsoft.com/office/drawing/2014/main" id="{3B40908C-E01E-18F0-EE48-0E6C941956C2}"/>
+              </a:ext>
+            </a:extLst>
+          </p:cNvPr>
+          <p:cNvSpPr txBox="1"/>
+          <p:nvPr/>
+        </p:nvSpPr>
+        <p:spPr>
+          <a:xfrm>
+            <a:off x="7036396" y="2312372"/>
+            <a:ext cx="476250" cy="400110"/>
+          </a:xfrm>
+          <a:prstGeom prst="rect">
+            <a:avLst/>
+          </a:prstGeom>
+          <a:noFill/>
+        </p:spPr>
+        <p:txBody>
+          <a:bodyPr wrap="square">
+            <a:spAutoFit/>
+          </a:bodyPr>
+          <a:lstStyle/>
+          <a:p>
+            <a:pPr algn="ctr"/>
+            <a:r>
+              <a:rPr lang="fr-FR" sz="1000" b="1" dirty="0">
+                <a:solidFill>
+                  <a:schemeClr val="tx1">
+                    <a:lumMod val="65000"/>
+                    <a:lumOff val="35000"/>
+                  </a:schemeClr>
+                </a:solidFill>
+                <a:latin typeface="Marianne" panose="02000000000000000000" pitchFamily="50" charset="0"/>
+                <a:ea typeface="Calibri" panose="020F0502020204030204" pitchFamily="34" charset="0"/>
+                <a:cs typeface="Calibri" panose="020F0502020204030204" pitchFamily="34" charset="0"/>
+              </a:rPr>
+              <a:t>|</a:t>
+            </a:r>
+          </a:p>
+          <a:p>
+            <a:pPr algn="ctr"/>
+            <a:r>
+              <a:rPr lang="fr-FR" sz="1000" b="1" dirty="0">
+                <a:solidFill>
+                  <a:schemeClr val="tx1">
+                    <a:lumMod val="65000"/>
+                    <a:lumOff val="35000"/>
+                  </a:schemeClr>
+                </a:solidFill>
+                <a:latin typeface="Marianne" panose="02000000000000000000" pitchFamily="50" charset="0"/>
+                <a:ea typeface="Calibri" panose="020F0502020204030204" pitchFamily="34" charset="0"/>
+                <a:cs typeface="Calibri" panose="020F0502020204030204" pitchFamily="34" charset="0"/>
+              </a:rPr>
+              <a:t>0</a:t>
+            </a:r>
+            <a:endParaRPr lang="fr-FR" sz="1000" dirty="0">
+              <a:solidFill>
+                <a:schemeClr val="tx1">
+                  <a:lumMod val="65000"/>
+                  <a:lumOff val="35000"/>
+                </a:schemeClr>
+              </a:solidFill>
+              <a:latin typeface="Marianne" panose="02000000000000000000" pitchFamily="50" charset="0"/>
+              <a:ea typeface="Calibri" panose="020F0502020204030204" pitchFamily="34" charset="0"/>
+              <a:cs typeface="Calibri" panose="020F0502020204030204" pitchFamily="34" charset="0"/>
+            </a:endParaRPr>
+          </a:p>
+        </p:txBody>
+      </p:sp>
+      <p:sp>
+        <p:nvSpPr>
+          <p:cNvPr id="40" name="zone_coeff_perm_resultat">
+            <a:extLst>
+              <a:ext uri="{FF2B5EF4-FFF2-40B4-BE49-F238E27FC236}">
+                <a16:creationId xmlns:a16="http://schemas.microsoft.com/office/drawing/2014/main" id="{0C9F516E-8C48-ED2A-8BD0-085E0A2F73E6}"/>
+              </a:ext>
+            </a:extLst>
+          </p:cNvPr>
+          <p:cNvSpPr txBox="1"/>
+          <p:nvPr/>
+        </p:nvSpPr>
+        <p:spPr>
+          <a:xfrm>
+            <a:off x="9916038" y="1373443"/>
+            <a:ext cx="2114946" cy="384721"/>
+          </a:xfrm>
+          <a:prstGeom prst="rect">
+            <a:avLst/>
+          </a:prstGeom>
+          <a:noFill/>
+        </p:spPr>
+        <p:txBody>
+          <a:bodyPr wrap="square">
+            <a:spAutoFit/>
+          </a:bodyPr>
+          <a:lstStyle/>
+          <a:p>
+            <a:pPr algn="r"/>
+            <a:r>
+              <a:rPr lang="fr-FR" sz="1900" b="1" dirty="0">
+                <a:solidFill>
+                  <a:schemeClr val="tx1">
+                    <a:lumMod val="65000"/>
+                    <a:lumOff val="35000"/>
+                  </a:schemeClr>
+                </a:solidFill>
+                <a:latin typeface="Marianne" panose="02000000000000000000" pitchFamily="50" charset="0"/>
+                <a:ea typeface="Calibri" panose="020F0502020204030204" pitchFamily="34" charset="0"/>
+                <a:cs typeface="Calibri" panose="020F0502020204030204" pitchFamily="34" charset="0"/>
+              </a:rPr>
+              <a:t>{{</a:t>
+            </a:r>
+            <a:r>
+              <a:rPr lang="fr-FR" sz="1900" b="1" dirty="0" err="1">
+                <a:solidFill>
+                  <a:schemeClr val="tx1">
+                    <a:lumMod val="65000"/>
+                    <a:lumOff val="35000"/>
+                  </a:schemeClr>
+                </a:solidFill>
+                <a:latin typeface="Marianne" panose="02000000000000000000" pitchFamily="50" charset="0"/>
+                <a:ea typeface="Calibri" panose="020F0502020204030204" pitchFamily="34" charset="0"/>
+                <a:cs typeface="Calibri" panose="020F0502020204030204" pitchFamily="34" charset="0"/>
+              </a:rPr>
+              <a:t>coeff_perm</a:t>
+            </a:r>
+            <a:r>
+              <a:rPr lang="fr-FR" sz="1900" b="1" dirty="0">
+                <a:solidFill>
+                  <a:schemeClr val="tx1">
+                    <a:lumMod val="65000"/>
+                    <a:lumOff val="35000"/>
+                  </a:schemeClr>
+                </a:solidFill>
+                <a:latin typeface="Marianne" panose="02000000000000000000" pitchFamily="50" charset="0"/>
+                <a:ea typeface="Calibri" panose="020F0502020204030204" pitchFamily="34" charset="0"/>
+                <a:cs typeface="Calibri" panose="020F0502020204030204" pitchFamily="34" charset="0"/>
+              </a:rPr>
+              <a:t>}}</a:t>
+            </a:r>
+            <a:r>
+              <a:rPr lang="fr-FR" sz="1300" dirty="0">
+                <a:solidFill>
+                  <a:schemeClr val="tx1">
+                    <a:lumMod val="65000"/>
+                    <a:lumOff val="35000"/>
+                  </a:schemeClr>
+                </a:solidFill>
+                <a:latin typeface="Marianne" panose="02000000000000000000" pitchFamily="50" charset="0"/>
+                <a:ea typeface="Calibri" panose="020F0502020204030204" pitchFamily="34" charset="0"/>
+                <a:cs typeface="Calibri" panose="020F0502020204030204" pitchFamily="34" charset="0"/>
+              </a:rPr>
+              <a:t> / 1</a:t>
+            </a:r>
+          </a:p>
+        </p:txBody>
+      </p:sp>
+      <p:sp>
+        <p:nvSpPr>
+          <p:cNvPr id="41" name="ZoneTexte 40">
+            <a:extLst>
+              <a:ext uri="{FF2B5EF4-FFF2-40B4-BE49-F238E27FC236}">
+                <a16:creationId xmlns:a16="http://schemas.microsoft.com/office/drawing/2014/main" id="{EF0A19D3-B533-0DA6-2599-67AE29B1CA40}"/>
+              </a:ext>
+            </a:extLst>
+          </p:cNvPr>
+          <p:cNvSpPr txBox="1"/>
+          <p:nvPr/>
+        </p:nvSpPr>
+        <p:spPr>
+          <a:xfrm>
+            <a:off x="7117416" y="2640276"/>
+            <a:ext cx="1623565" cy="246221"/>
+          </a:xfrm>
+          <a:prstGeom prst="rect">
+            <a:avLst/>
+          </a:prstGeom>
+          <a:noFill/>
+        </p:spPr>
+        <p:txBody>
+          <a:bodyPr wrap="square">
+            <a:spAutoFit/>
+          </a:bodyPr>
+          <a:lstStyle/>
+          <a:p>
+            <a:r>
+              <a:rPr lang="fr-FR" sz="1000" dirty="0">
+                <a:solidFill>
+                  <a:schemeClr val="tx1">
+                    <a:lumMod val="65000"/>
+                    <a:lumOff val="35000"/>
+                  </a:schemeClr>
+                </a:solidFill>
+                <a:latin typeface="Marianne" panose="02000000000000000000" pitchFamily="50" charset="0"/>
+                <a:ea typeface="Calibri" panose="020F0502020204030204" pitchFamily="34" charset="0"/>
+                <a:cs typeface="Calibri" panose="020F0502020204030204" pitchFamily="34" charset="0"/>
+              </a:rPr>
+              <a:t>Sols très imperméables</a:t>
+            </a:r>
+          </a:p>
+        </p:txBody>
+      </p:sp>
+      <p:sp>
+        <p:nvSpPr>
+          <p:cNvPr id="42" name="zone_coeff_perm_analyse">
+            <a:extLst>
+              <a:ext uri="{FF2B5EF4-FFF2-40B4-BE49-F238E27FC236}">
+                <a16:creationId xmlns:a16="http://schemas.microsoft.com/office/drawing/2014/main" id="{D815779D-E063-1683-BE0A-93A969EED637}"/>
+              </a:ext>
+            </a:extLst>
+          </p:cNvPr>
+          <p:cNvSpPr txBox="1"/>
+          <p:nvPr/>
+        </p:nvSpPr>
+        <p:spPr>
+          <a:xfrm>
+            <a:off x="7117417" y="3015880"/>
+            <a:ext cx="3783575" cy="292388"/>
+          </a:xfrm>
+          <a:prstGeom prst="rect">
+            <a:avLst/>
+          </a:prstGeom>
+          <a:noFill/>
+        </p:spPr>
+        <p:txBody>
+          <a:bodyPr wrap="square">
+            <a:spAutoFit/>
+          </a:bodyPr>
+          <a:lstStyle/>
+          <a:p>
+            <a:r>
+              <a:rPr lang="fr-FR" sz="1300" dirty="0">
+                <a:solidFill>
+                  <a:schemeClr val="tx1">
+                    <a:lumMod val="65000"/>
+                    <a:lumOff val="35000"/>
+                  </a:schemeClr>
+                </a:solidFill>
+                <a:latin typeface="Marianne" panose="02000000000000000000" pitchFamily="50" charset="0"/>
+                <a:ea typeface="Calibri" panose="020F0502020204030204" pitchFamily="34" charset="0"/>
+                <a:cs typeface="Calibri" panose="020F0502020204030204" pitchFamily="34" charset="0"/>
+              </a:rPr>
+              <a:t>{{</a:t>
+            </a:r>
+            <a:r>
+              <a:rPr lang="fr-FR" sz="1300" dirty="0" err="1">
+                <a:solidFill>
+                  <a:schemeClr val="tx1">
+                    <a:lumMod val="65000"/>
+                    <a:lumOff val="35000"/>
+                  </a:schemeClr>
+                </a:solidFill>
+                <a:latin typeface="Marianne" panose="02000000000000000000" pitchFamily="50" charset="0"/>
+                <a:ea typeface="Calibri" panose="020F0502020204030204" pitchFamily="34" charset="0"/>
+                <a:cs typeface="Calibri" panose="020F0502020204030204" pitchFamily="34" charset="0"/>
+              </a:rPr>
+              <a:t>analyse_coeff_perm</a:t>
+            </a:r>
+            <a:r>
+              <a:rPr lang="fr-FR" sz="1300" dirty="0">
+                <a:solidFill>
+                  <a:schemeClr val="tx1">
+                    <a:lumMod val="65000"/>
+                    <a:lumOff val="35000"/>
+                  </a:schemeClr>
+                </a:solidFill>
+                <a:latin typeface="Marianne" panose="02000000000000000000" pitchFamily="50" charset="0"/>
+                <a:ea typeface="Calibri" panose="020F0502020204030204" pitchFamily="34" charset="0"/>
+                <a:cs typeface="Calibri" panose="020F0502020204030204" pitchFamily="34" charset="0"/>
+              </a:rPr>
+              <a:t>}}</a:t>
+            </a:r>
+          </a:p>
+        </p:txBody>
+      </p:sp>
+      <p:sp>
+        <p:nvSpPr>
+          <p:cNvPr id="48" name="ZoneTexte 47">
+            <a:extLst>
+              <a:ext uri="{FF2B5EF4-FFF2-40B4-BE49-F238E27FC236}">
+                <a16:creationId xmlns:a16="http://schemas.microsoft.com/office/drawing/2014/main" id="{4155C661-08F5-D72C-6159-534478BB643B}"/>
+              </a:ext>
+            </a:extLst>
+          </p:cNvPr>
+          <p:cNvSpPr txBox="1"/>
+          <p:nvPr/>
+        </p:nvSpPr>
+        <p:spPr>
+          <a:xfrm>
+            <a:off x="11677801" y="2312372"/>
+            <a:ext cx="476250" cy="400110"/>
+          </a:xfrm>
+          <a:prstGeom prst="rect">
+            <a:avLst/>
+          </a:prstGeom>
+          <a:noFill/>
+        </p:spPr>
+        <p:txBody>
+          <a:bodyPr wrap="square">
+            <a:spAutoFit/>
+          </a:bodyPr>
+          <a:lstStyle/>
+          <a:p>
+            <a:pPr algn="ctr"/>
+            <a:r>
+              <a:rPr lang="fr-FR" sz="1000" b="1" dirty="0">
+                <a:solidFill>
+                  <a:schemeClr val="tx1">
+                    <a:lumMod val="65000"/>
+                    <a:lumOff val="35000"/>
+                  </a:schemeClr>
+                </a:solidFill>
+                <a:latin typeface="Marianne" panose="02000000000000000000" pitchFamily="50" charset="0"/>
+                <a:ea typeface="Calibri" panose="020F0502020204030204" pitchFamily="34" charset="0"/>
+                <a:cs typeface="Calibri" panose="020F0502020204030204" pitchFamily="34" charset="0"/>
+              </a:rPr>
+              <a:t>|</a:t>
+            </a:r>
+          </a:p>
+          <a:p>
+            <a:pPr algn="ctr"/>
+            <a:r>
+              <a:rPr lang="fr-FR" sz="1000" b="1" dirty="0">
+                <a:solidFill>
+                  <a:schemeClr val="tx1">
+                    <a:lumMod val="65000"/>
+                    <a:lumOff val="35000"/>
+                  </a:schemeClr>
+                </a:solidFill>
+                <a:latin typeface="Marianne" panose="02000000000000000000" pitchFamily="50" charset="0"/>
+                <a:ea typeface="Calibri" panose="020F0502020204030204" pitchFamily="34" charset="0"/>
+                <a:cs typeface="Calibri" panose="020F0502020204030204" pitchFamily="34" charset="0"/>
+              </a:rPr>
+              <a:t>1</a:t>
+            </a:r>
+            <a:endParaRPr lang="fr-FR" sz="1000" dirty="0">
+              <a:solidFill>
+                <a:schemeClr val="tx1">
+                  <a:lumMod val="65000"/>
+                  <a:lumOff val="35000"/>
+                </a:schemeClr>
+              </a:solidFill>
+              <a:latin typeface="Marianne" panose="02000000000000000000" pitchFamily="50" charset="0"/>
+              <a:ea typeface="Calibri" panose="020F0502020204030204" pitchFamily="34" charset="0"/>
+              <a:cs typeface="Calibri" panose="020F0502020204030204" pitchFamily="34" charset="0"/>
+            </a:endParaRPr>
+          </a:p>
+        </p:txBody>
+      </p:sp>
+      <p:sp>
+        <p:nvSpPr>
+          <p:cNvPr id="49" name="ZoneTexte 48">
+            <a:extLst>
+              <a:ext uri="{FF2B5EF4-FFF2-40B4-BE49-F238E27FC236}">
+                <a16:creationId xmlns:a16="http://schemas.microsoft.com/office/drawing/2014/main" id="{3B861828-3789-1227-5D24-D929840053A3}"/>
+              </a:ext>
+            </a:extLst>
+          </p:cNvPr>
+          <p:cNvSpPr txBox="1"/>
+          <p:nvPr/>
+        </p:nvSpPr>
+        <p:spPr>
+          <a:xfrm>
+            <a:off x="10460304" y="2673476"/>
+            <a:ext cx="1570680" cy="246221"/>
+          </a:xfrm>
+          <a:prstGeom prst="rect">
+            <a:avLst/>
+          </a:prstGeom>
+          <a:noFill/>
+        </p:spPr>
+        <p:txBody>
+          <a:bodyPr wrap="square">
+            <a:spAutoFit/>
+          </a:bodyPr>
+          <a:lstStyle/>
+          <a:p>
+            <a:pPr algn="r"/>
+            <a:r>
+              <a:rPr lang="fr-FR" sz="1000" dirty="0">
+                <a:solidFill>
+                  <a:schemeClr val="tx1">
+                    <a:lumMod val="65000"/>
+                    <a:lumOff val="35000"/>
+                  </a:schemeClr>
+                </a:solidFill>
+                <a:latin typeface="Marianne" panose="02000000000000000000" pitchFamily="50" charset="0"/>
+                <a:ea typeface="Calibri" panose="020F0502020204030204" pitchFamily="34" charset="0"/>
+                <a:cs typeface="Calibri" panose="020F0502020204030204" pitchFamily="34" charset="0"/>
+              </a:rPr>
+              <a:t>Sols très perméables</a:t>
+            </a:r>
+          </a:p>
+        </p:txBody>
+      </p:sp>
+      <p:sp>
+        <p:nvSpPr>
+          <p:cNvPr id="51" name="ZoneTexte 50">
+            <a:extLst>
+              <a:ext uri="{FF2B5EF4-FFF2-40B4-BE49-F238E27FC236}">
+                <a16:creationId xmlns:a16="http://schemas.microsoft.com/office/drawing/2014/main" id="{678F3BB8-CE4E-9740-E494-B41572EA3E7A}"/>
+              </a:ext>
+            </a:extLst>
+          </p:cNvPr>
+          <p:cNvSpPr txBox="1"/>
+          <p:nvPr/>
+        </p:nvSpPr>
+        <p:spPr>
+          <a:xfrm>
+            <a:off x="9362518" y="2313475"/>
+            <a:ext cx="476250" cy="400110"/>
+          </a:xfrm>
+          <a:prstGeom prst="rect">
+            <a:avLst/>
+          </a:prstGeom>
+          <a:noFill/>
+        </p:spPr>
+        <p:txBody>
+          <a:bodyPr wrap="square">
+            <a:spAutoFit/>
+          </a:bodyPr>
+          <a:lstStyle/>
+          <a:p>
+            <a:pPr algn="ctr"/>
+            <a:r>
+              <a:rPr lang="fr-FR" sz="1000" b="1" dirty="0">
+                <a:solidFill>
+                  <a:schemeClr val="tx1">
+                    <a:lumMod val="65000"/>
+                    <a:lumOff val="35000"/>
+                  </a:schemeClr>
+                </a:solidFill>
+                <a:latin typeface="Marianne" panose="02000000000000000000" pitchFamily="50" charset="0"/>
+                <a:ea typeface="Calibri" panose="020F0502020204030204" pitchFamily="34" charset="0"/>
+                <a:cs typeface="Calibri" panose="020F0502020204030204" pitchFamily="34" charset="0"/>
+              </a:rPr>
+              <a:t>|</a:t>
+            </a:r>
+          </a:p>
+          <a:p>
+            <a:pPr algn="ctr"/>
+            <a:r>
+              <a:rPr lang="fr-FR" sz="1000" b="1" dirty="0">
+                <a:solidFill>
+                  <a:schemeClr val="tx1">
+                    <a:lumMod val="65000"/>
+                    <a:lumOff val="35000"/>
+                  </a:schemeClr>
+                </a:solidFill>
+                <a:latin typeface="Marianne" panose="02000000000000000000" pitchFamily="50" charset="0"/>
+                <a:ea typeface="Calibri" panose="020F0502020204030204" pitchFamily="34" charset="0"/>
+                <a:cs typeface="Calibri" panose="020F0502020204030204" pitchFamily="34" charset="0"/>
+              </a:rPr>
+              <a:t>0,5</a:t>
+            </a:r>
+            <a:endParaRPr lang="fr-FR" sz="1000" dirty="0">
+              <a:solidFill>
+                <a:schemeClr val="tx1">
+                  <a:lumMod val="65000"/>
+                  <a:lumOff val="35000"/>
+                </a:schemeClr>
+              </a:solidFill>
+              <a:latin typeface="Marianne" panose="02000000000000000000" pitchFamily="50" charset="0"/>
+              <a:ea typeface="Calibri" panose="020F0502020204030204" pitchFamily="34" charset="0"/>
+              <a:cs typeface="Calibri" panose="020F0502020204030204" pitchFamily="34" charset="0"/>
+            </a:endParaRPr>
+          </a:p>
+        </p:txBody>
+      </p:sp>
+      <p:pic>
+        <p:nvPicPr>
+          <p:cNvPr id="53" name="Graphique 52">
+            <a:extLst>
+              <a:ext uri="{FF2B5EF4-FFF2-40B4-BE49-F238E27FC236}">
+                <a16:creationId xmlns:a16="http://schemas.microsoft.com/office/drawing/2014/main" id="{6C268903-4805-4D69-25F9-A7CAA99CCA32}"/>
+              </a:ext>
+            </a:extLst>
+          </p:cNvPr>
+          <p:cNvPicPr>
+            <a:picLocks noChangeAspect="1"/>
+          </p:cNvPicPr>
+          <p:nvPr/>
+        </p:nvPicPr>
+        <p:blipFill>
+          <a:blip r:embed="rId9">
+            <a:extLst>
+              <a:ext uri="{96DAC541-7B7A-43D3-8B79-37D633B846F1}">
+                <asvg:svgBlip xmlns:asvg="http://schemas.microsoft.com/office/drawing/2016/SVG/main" r:embed="rId10"/>
+              </a:ext>
+            </a:extLst>
+          </a:blip>
+          <a:stretch>
+            <a:fillRect/>
+          </a:stretch>
+        </p:blipFill>
+        <p:spPr>
+          <a:xfrm>
+            <a:off x="7260931" y="1410222"/>
+            <a:ext cx="341505" cy="341505"/>
+          </a:xfrm>
+          <a:prstGeom prst="rect">
+            <a:avLst/>
+          </a:prstGeom>
+        </p:spPr>
+      </p:pic>
+      <p:pic>
+        <p:nvPicPr>
+          <p:cNvPr id="57" name="zone_coeff_perm_echelle">
+            <a:extLst>
+              <a:ext uri="{FF2B5EF4-FFF2-40B4-BE49-F238E27FC236}">
+                <a16:creationId xmlns:a16="http://schemas.microsoft.com/office/drawing/2014/main" id="{EF0F536C-1764-1056-48BC-43AB3887574C}"/>
+              </a:ext>
+            </a:extLst>
+          </p:cNvPr>
+          <p:cNvPicPr>
+            <a:picLocks noChangeAspect="1"/>
+          </p:cNvPicPr>
+          <p:nvPr/>
+        </p:nvPicPr>
+        <p:blipFill>
+          <a:blip r:embed="rId11">
+            <a:extLst>
+              <a:ext uri="{96DAC541-7B7A-43D3-8B79-37D633B846F1}">
+                <asvg:svgBlip xmlns:asvg="http://schemas.microsoft.com/office/drawing/2016/SVG/main" r:embed="rId12"/>
+              </a:ext>
+            </a:extLst>
+          </a:blip>
+          <a:stretch>
+            <a:fillRect/>
+          </a:stretch>
+        </p:blipFill>
+        <p:spPr>
+          <a:xfrm>
+            <a:off x="7274521" y="2086826"/>
+            <a:ext cx="4652244" cy="234744"/>
+          </a:xfrm>
+          <a:prstGeom prst="rect">
+            <a:avLst/>
+          </a:prstGeom>
+        </p:spPr>
+      </p:pic>
+      <p:pic>
+        <p:nvPicPr>
+          <p:cNvPr id="50" name="zone_coeff_perm_curseur">
+            <a:extLst>
+              <a:ext uri="{FF2B5EF4-FFF2-40B4-BE49-F238E27FC236}">
+                <a16:creationId xmlns:a16="http://schemas.microsoft.com/office/drawing/2014/main" id="{3BA044A5-E7AE-D86E-2624-A658E6201EAA}"/>
+              </a:ext>
+            </a:extLst>
+          </p:cNvPr>
+          <p:cNvPicPr>
+            <a:picLocks noChangeAspect="1"/>
+          </p:cNvPicPr>
+          <p:nvPr/>
+        </p:nvPicPr>
+        <p:blipFill>
+          <a:blip r:embed="rId7">
+            <a:extLst>
+              <a:ext uri="{96DAC541-7B7A-43D3-8B79-37D633B846F1}">
+                <asvg:svgBlip xmlns:asvg="http://schemas.microsoft.com/office/drawing/2016/SVG/main" r:embed="rId8"/>
+              </a:ext>
+            </a:extLst>
+          </a:blip>
+          <a:stretch>
+            <a:fillRect/>
+          </a:stretch>
+        </p:blipFill>
+        <p:spPr>
+          <a:xfrm>
+            <a:off x="7235688" y="1950732"/>
+            <a:ext cx="224536" cy="204124"/>
+          </a:xfrm>
+          <a:prstGeom prst="rect">
+            <a:avLst/>
+          </a:prstGeom>
+        </p:spPr>
+      </p:pic>
+      <p:sp>
+        <p:nvSpPr>
+          <p:cNvPr id="69" name="Text 16">
+            <a:extLst>
+              <a:ext uri="{FF2B5EF4-FFF2-40B4-BE49-F238E27FC236}">
+                <a16:creationId xmlns:a16="http://schemas.microsoft.com/office/drawing/2014/main" id="{FDD54181-1A52-1FB0-8094-240DCA72BF57}"/>
+              </a:ext>
+            </a:extLst>
+          </p:cNvPr>
+          <p:cNvSpPr/>
+          <p:nvPr/>
+        </p:nvSpPr>
+        <p:spPr>
+          <a:xfrm>
+            <a:off x="7708478" y="4136354"/>
+            <a:ext cx="1448705" cy="293597"/>
+          </a:xfrm>
+          <a:prstGeom prst="rect">
+            <a:avLst/>
+          </a:prstGeom>
+          <a:noFill/>
+          <a:ln/>
+        </p:spPr>
+        <p:txBody>
+          <a:bodyPr wrap="square" lIns="0" tIns="0" rIns="0" bIns="0" rtlCol="0" anchor="ctr"/>
+          <a:lstStyle/>
+          <a:p>
+            <a:pPr marL="0" indent="0">
+              <a:buNone/>
+            </a:pPr>
+            <a:r>
+              <a:rPr lang="en-US" sz="1200" kern="0" spc="150" dirty="0">
+                <a:solidFill>
+                  <a:schemeClr val="tx1">
+                    <a:lumMod val="65000"/>
+                    <a:lumOff val="35000"/>
+                  </a:schemeClr>
+                </a:solidFill>
+                <a:latin typeface="Marianne" panose="02000000000000000000" pitchFamily="50" charset="0"/>
+                <a:ea typeface="Calibri" panose="020F0502020204030204" pitchFamily="34" charset="0"/>
+                <a:cs typeface="Calibri" panose="020F0502020204030204" pitchFamily="34" charset="0"/>
+              </a:rPr>
+              <a:t>Coefficient de</a:t>
+            </a:r>
+            <a:br>
+              <a:rPr lang="en-US" sz="1200" kern="0" spc="150" dirty="0">
+                <a:solidFill>
+                  <a:schemeClr val="tx1">
+                    <a:lumMod val="65000"/>
+                    <a:lumOff val="35000"/>
+                  </a:schemeClr>
+                </a:solidFill>
+                <a:latin typeface="Marianne" panose="02000000000000000000" pitchFamily="50" charset="0"/>
+                <a:ea typeface="Calibri" panose="020F0502020204030204" pitchFamily="34" charset="0"/>
+                <a:cs typeface="Calibri" panose="020F0502020204030204" pitchFamily="34" charset="0"/>
+              </a:rPr>
+            </a:br>
+            <a:r>
+              <a:rPr lang="en-US" sz="1300" b="1" kern="0" spc="150" dirty="0" err="1">
+                <a:solidFill>
+                  <a:srgbClr val="29A31E"/>
+                </a:solidFill>
+                <a:latin typeface="Marianne" panose="02000000000000000000" pitchFamily="50" charset="0"/>
+                <a:ea typeface="Calibri" panose="020F0502020204030204" pitchFamily="34" charset="0"/>
+                <a:cs typeface="Calibri" panose="020F0502020204030204" pitchFamily="34" charset="0"/>
+              </a:rPr>
+              <a:t>Biodiversité</a:t>
+            </a:r>
+            <a:endParaRPr lang="en-US" sz="1300" b="1" dirty="0">
+              <a:solidFill>
+                <a:srgbClr val="29A31E"/>
+              </a:solidFill>
+              <a:latin typeface="Marianne" panose="02000000000000000000" pitchFamily="50" charset="0"/>
+              <a:ea typeface="Calibri" panose="020F0502020204030204" pitchFamily="34" charset="0"/>
+              <a:cs typeface="Calibri" panose="020F0502020204030204" pitchFamily="34" charset="0"/>
+            </a:endParaRPr>
+          </a:p>
+        </p:txBody>
+      </p:sp>
+      <p:sp>
+        <p:nvSpPr>
+          <p:cNvPr id="70" name="ZoneTexte 69">
+            <a:extLst>
+              <a:ext uri="{FF2B5EF4-FFF2-40B4-BE49-F238E27FC236}">
+                <a16:creationId xmlns:a16="http://schemas.microsoft.com/office/drawing/2014/main" id="{F2C5F969-AE63-3128-F3BB-7DC5604B47A5}"/>
+              </a:ext>
+            </a:extLst>
+          </p:cNvPr>
+          <p:cNvSpPr txBox="1"/>
+          <p:nvPr/>
+        </p:nvSpPr>
+        <p:spPr>
+          <a:xfrm>
+            <a:off x="7036396" y="5027610"/>
+            <a:ext cx="476250" cy="400110"/>
+          </a:xfrm>
+          <a:prstGeom prst="rect">
+            <a:avLst/>
+          </a:prstGeom>
+          <a:noFill/>
+        </p:spPr>
+        <p:txBody>
+          <a:bodyPr wrap="square">
+            <a:spAutoFit/>
+          </a:bodyPr>
+          <a:lstStyle/>
+          <a:p>
+            <a:pPr algn="ctr"/>
+            <a:r>
+              <a:rPr lang="fr-FR" sz="1000" b="1" dirty="0">
+                <a:solidFill>
+                  <a:schemeClr val="tx1">
+                    <a:lumMod val="65000"/>
+                    <a:lumOff val="35000"/>
+                  </a:schemeClr>
+                </a:solidFill>
+                <a:latin typeface="Marianne" panose="02000000000000000000" pitchFamily="50" charset="0"/>
+                <a:ea typeface="Calibri" panose="020F0502020204030204" pitchFamily="34" charset="0"/>
+                <a:cs typeface="Calibri" panose="020F0502020204030204" pitchFamily="34" charset="0"/>
+              </a:rPr>
+              <a:t>|</a:t>
+            </a:r>
+          </a:p>
+          <a:p>
+            <a:pPr algn="ctr"/>
+            <a:r>
+              <a:rPr lang="fr-FR" sz="1000" b="1" dirty="0">
+                <a:solidFill>
+                  <a:schemeClr val="tx1">
+                    <a:lumMod val="65000"/>
+                    <a:lumOff val="35000"/>
+                  </a:schemeClr>
+                </a:solidFill>
+                <a:latin typeface="Marianne" panose="02000000000000000000" pitchFamily="50" charset="0"/>
+                <a:ea typeface="Calibri" panose="020F0502020204030204" pitchFamily="34" charset="0"/>
+                <a:cs typeface="Calibri" panose="020F0502020204030204" pitchFamily="34" charset="0"/>
+              </a:rPr>
+              <a:t>0</a:t>
+            </a:r>
+            <a:endParaRPr lang="fr-FR" sz="1000" dirty="0">
+              <a:solidFill>
+                <a:schemeClr val="tx1">
+                  <a:lumMod val="65000"/>
+                  <a:lumOff val="35000"/>
+                </a:schemeClr>
+              </a:solidFill>
+              <a:latin typeface="Marianne" panose="02000000000000000000" pitchFamily="50" charset="0"/>
+              <a:ea typeface="Calibri" panose="020F0502020204030204" pitchFamily="34" charset="0"/>
+              <a:cs typeface="Calibri" panose="020F0502020204030204" pitchFamily="34" charset="0"/>
+            </a:endParaRPr>
+          </a:p>
+        </p:txBody>
+      </p:sp>
+      <p:sp>
+        <p:nvSpPr>
+          <p:cNvPr id="71" name="zone_coeff_bio_resultat">
+            <a:extLst>
+              <a:ext uri="{FF2B5EF4-FFF2-40B4-BE49-F238E27FC236}">
+                <a16:creationId xmlns:a16="http://schemas.microsoft.com/office/drawing/2014/main" id="{4AB29B46-26F9-32EF-1FA1-8E9998B06F53}"/>
+              </a:ext>
+            </a:extLst>
+          </p:cNvPr>
+          <p:cNvSpPr txBox="1"/>
+          <p:nvPr/>
+        </p:nvSpPr>
+        <p:spPr>
+          <a:xfrm>
+            <a:off x="9916038" y="4088681"/>
+            <a:ext cx="2114946" cy="384721"/>
+          </a:xfrm>
+          <a:prstGeom prst="rect">
+            <a:avLst/>
+          </a:prstGeom>
+          <a:noFill/>
+        </p:spPr>
+        <p:txBody>
+          <a:bodyPr wrap="square">
+            <a:spAutoFit/>
+          </a:bodyPr>
+          <a:lstStyle/>
+          <a:p>
+            <a:pPr algn="r"/>
+            <a:r>
+              <a:rPr lang="fr-FR" sz="1900" b="1" dirty="0">
+                <a:solidFill>
+                  <a:schemeClr val="tx1">
+                    <a:lumMod val="65000"/>
+                    <a:lumOff val="35000"/>
+                  </a:schemeClr>
+                </a:solidFill>
+                <a:latin typeface="Marianne" panose="02000000000000000000" pitchFamily="50" charset="0"/>
+                <a:ea typeface="Calibri" panose="020F0502020204030204" pitchFamily="34" charset="0"/>
+                <a:cs typeface="Calibri" panose="020F0502020204030204" pitchFamily="34" charset="0"/>
+              </a:rPr>
+              <a:t>{{</a:t>
+            </a:r>
+            <a:r>
+              <a:rPr lang="fr-FR" sz="1900" b="1" dirty="0" err="1">
+                <a:solidFill>
+                  <a:schemeClr val="tx1">
+                    <a:lumMod val="65000"/>
+                    <a:lumOff val="35000"/>
+                  </a:schemeClr>
+                </a:solidFill>
+                <a:latin typeface="Marianne" panose="02000000000000000000" pitchFamily="50" charset="0"/>
+                <a:ea typeface="Calibri" panose="020F0502020204030204" pitchFamily="34" charset="0"/>
+                <a:cs typeface="Calibri" panose="020F0502020204030204" pitchFamily="34" charset="0"/>
+              </a:rPr>
+              <a:t>coeff_bio</a:t>
+            </a:r>
+            <a:r>
+              <a:rPr lang="fr-FR" sz="1900" b="1" dirty="0">
+                <a:solidFill>
+                  <a:schemeClr val="tx1">
+                    <a:lumMod val="65000"/>
+                    <a:lumOff val="35000"/>
+                  </a:schemeClr>
+                </a:solidFill>
+                <a:latin typeface="Marianne" panose="02000000000000000000" pitchFamily="50" charset="0"/>
+                <a:ea typeface="Calibri" panose="020F0502020204030204" pitchFamily="34" charset="0"/>
+                <a:cs typeface="Calibri" panose="020F0502020204030204" pitchFamily="34" charset="0"/>
+              </a:rPr>
+              <a:t>}}</a:t>
+            </a:r>
+            <a:r>
+              <a:rPr lang="fr-FR" sz="1300" dirty="0">
+                <a:solidFill>
+                  <a:schemeClr val="tx1">
+                    <a:lumMod val="65000"/>
+                    <a:lumOff val="35000"/>
+                  </a:schemeClr>
+                </a:solidFill>
+                <a:latin typeface="Marianne" panose="02000000000000000000" pitchFamily="50" charset="0"/>
+                <a:ea typeface="Calibri" panose="020F0502020204030204" pitchFamily="34" charset="0"/>
+                <a:cs typeface="Calibri" panose="020F0502020204030204" pitchFamily="34" charset="0"/>
+              </a:rPr>
+              <a:t> / 1</a:t>
+            </a:r>
+          </a:p>
+        </p:txBody>
+      </p:sp>
+      <p:sp>
+        <p:nvSpPr>
+          <p:cNvPr id="72" name="ZoneTexte 71">
+            <a:extLst>
+              <a:ext uri="{FF2B5EF4-FFF2-40B4-BE49-F238E27FC236}">
+                <a16:creationId xmlns:a16="http://schemas.microsoft.com/office/drawing/2014/main" id="{C9205A4B-479A-F86A-1319-61FAC62C125B}"/>
+              </a:ext>
+            </a:extLst>
+          </p:cNvPr>
+          <p:cNvSpPr txBox="1"/>
+          <p:nvPr/>
+        </p:nvSpPr>
+        <p:spPr>
+          <a:xfrm>
+            <a:off x="7117416" y="5355514"/>
+            <a:ext cx="1623565" cy="246221"/>
+          </a:xfrm>
+          <a:prstGeom prst="rect">
+            <a:avLst/>
+          </a:prstGeom>
+          <a:noFill/>
+        </p:spPr>
+        <p:txBody>
+          <a:bodyPr wrap="square">
+            <a:spAutoFit/>
+          </a:bodyPr>
+          <a:lstStyle/>
+          <a:p>
+            <a:r>
+              <a:rPr lang="fr-FR" sz="1000" dirty="0">
+                <a:solidFill>
+                  <a:schemeClr val="tx1">
+                    <a:lumMod val="65000"/>
+                    <a:lumOff val="35000"/>
+                  </a:schemeClr>
+                </a:solidFill>
+                <a:latin typeface="Marianne" panose="02000000000000000000" pitchFamily="50" charset="0"/>
+                <a:ea typeface="Calibri" panose="020F0502020204030204" pitchFamily="34" charset="0"/>
+                <a:cs typeface="Calibri" panose="020F0502020204030204" pitchFamily="34" charset="0"/>
+              </a:rPr>
+              <a:t>Biodiversité inexistante</a:t>
+            </a:r>
+          </a:p>
+        </p:txBody>
+      </p:sp>
+      <p:sp>
+        <p:nvSpPr>
+          <p:cNvPr id="73" name="zone_coeff_bio_analyse">
+            <a:extLst>
+              <a:ext uri="{FF2B5EF4-FFF2-40B4-BE49-F238E27FC236}">
+                <a16:creationId xmlns:a16="http://schemas.microsoft.com/office/drawing/2014/main" id="{165C3EED-35E8-A107-2A5B-A5E12189F11F}"/>
+              </a:ext>
+            </a:extLst>
+          </p:cNvPr>
+          <p:cNvSpPr txBox="1"/>
+          <p:nvPr/>
+        </p:nvSpPr>
+        <p:spPr>
+          <a:xfrm>
+            <a:off x="7117417" y="5731118"/>
+            <a:ext cx="3783575" cy="292388"/>
+          </a:xfrm>
+          <a:prstGeom prst="rect">
+            <a:avLst/>
+          </a:prstGeom>
+          <a:noFill/>
+        </p:spPr>
+        <p:txBody>
+          <a:bodyPr wrap="square">
+            <a:spAutoFit/>
+          </a:bodyPr>
+          <a:lstStyle/>
+          <a:p>
+            <a:r>
+              <a:rPr lang="fr-FR" sz="1300" dirty="0">
+                <a:solidFill>
+                  <a:schemeClr val="tx1">
+                    <a:lumMod val="65000"/>
+                    <a:lumOff val="35000"/>
+                  </a:schemeClr>
+                </a:solidFill>
+                <a:latin typeface="Marianne" panose="02000000000000000000" pitchFamily="50" charset="0"/>
+                <a:ea typeface="Calibri" panose="020F0502020204030204" pitchFamily="34" charset="0"/>
+                <a:cs typeface="Calibri" panose="020F0502020204030204" pitchFamily="34" charset="0"/>
+              </a:rPr>
+              <a:t>{{</a:t>
+            </a:r>
+            <a:r>
+              <a:rPr lang="fr-FR" sz="1300" dirty="0" err="1">
+                <a:solidFill>
+                  <a:schemeClr val="tx1">
+                    <a:lumMod val="65000"/>
+                    <a:lumOff val="35000"/>
+                  </a:schemeClr>
+                </a:solidFill>
+                <a:latin typeface="Marianne" panose="02000000000000000000" pitchFamily="50" charset="0"/>
+                <a:ea typeface="Calibri" panose="020F0502020204030204" pitchFamily="34" charset="0"/>
+                <a:cs typeface="Calibri" panose="020F0502020204030204" pitchFamily="34" charset="0"/>
+              </a:rPr>
+              <a:t>analyse_coeff_bio</a:t>
+            </a:r>
+            <a:r>
+              <a:rPr lang="fr-FR" sz="1300" dirty="0">
+                <a:solidFill>
+                  <a:schemeClr val="tx1">
+                    <a:lumMod val="65000"/>
+                    <a:lumOff val="35000"/>
+                  </a:schemeClr>
+                </a:solidFill>
+                <a:latin typeface="Marianne" panose="02000000000000000000" pitchFamily="50" charset="0"/>
+                <a:ea typeface="Calibri" panose="020F0502020204030204" pitchFamily="34" charset="0"/>
+                <a:cs typeface="Calibri" panose="020F0502020204030204" pitchFamily="34" charset="0"/>
+              </a:rPr>
+              <a:t>}}</a:t>
+            </a:r>
+          </a:p>
+        </p:txBody>
+      </p:sp>
+      <p:sp>
+        <p:nvSpPr>
+          <p:cNvPr id="74" name="ZoneTexte 73">
+            <a:extLst>
+              <a:ext uri="{FF2B5EF4-FFF2-40B4-BE49-F238E27FC236}">
+                <a16:creationId xmlns:a16="http://schemas.microsoft.com/office/drawing/2014/main" id="{4226318D-0873-1A75-0DCA-C5F273BA3CCD}"/>
+              </a:ext>
+            </a:extLst>
+          </p:cNvPr>
+          <p:cNvSpPr txBox="1"/>
+          <p:nvPr/>
+        </p:nvSpPr>
+        <p:spPr>
+          <a:xfrm>
+            <a:off x="11677801" y="5027610"/>
+            <a:ext cx="476250" cy="400110"/>
+          </a:xfrm>
+          <a:prstGeom prst="rect">
+            <a:avLst/>
+          </a:prstGeom>
+          <a:noFill/>
+        </p:spPr>
+        <p:txBody>
+          <a:bodyPr wrap="square">
+            <a:spAutoFit/>
+          </a:bodyPr>
+          <a:lstStyle/>
+          <a:p>
+            <a:pPr algn="ctr"/>
+            <a:r>
+              <a:rPr lang="fr-FR" sz="1000" b="1" dirty="0">
+                <a:solidFill>
+                  <a:schemeClr val="tx1">
+                    <a:lumMod val="65000"/>
+                    <a:lumOff val="35000"/>
+                  </a:schemeClr>
+                </a:solidFill>
+                <a:latin typeface="Marianne" panose="02000000000000000000" pitchFamily="50" charset="0"/>
+                <a:ea typeface="Calibri" panose="020F0502020204030204" pitchFamily="34" charset="0"/>
+                <a:cs typeface="Calibri" panose="020F0502020204030204" pitchFamily="34" charset="0"/>
+              </a:rPr>
+              <a:t>|</a:t>
+            </a:r>
+          </a:p>
+          <a:p>
+            <a:pPr algn="ctr"/>
+            <a:r>
+              <a:rPr lang="fr-FR" sz="1000" b="1" dirty="0">
+                <a:solidFill>
+                  <a:schemeClr val="tx1">
+                    <a:lumMod val="65000"/>
+                    <a:lumOff val="35000"/>
+                  </a:schemeClr>
+                </a:solidFill>
+                <a:latin typeface="Marianne" panose="02000000000000000000" pitchFamily="50" charset="0"/>
+                <a:ea typeface="Calibri" panose="020F0502020204030204" pitchFamily="34" charset="0"/>
+                <a:cs typeface="Calibri" panose="020F0502020204030204" pitchFamily="34" charset="0"/>
+              </a:rPr>
+              <a:t>1</a:t>
+            </a:r>
+            <a:endParaRPr lang="fr-FR" sz="1000" dirty="0">
+              <a:solidFill>
+                <a:schemeClr val="tx1">
+                  <a:lumMod val="65000"/>
+                  <a:lumOff val="35000"/>
+                </a:schemeClr>
+              </a:solidFill>
+              <a:latin typeface="Marianne" panose="02000000000000000000" pitchFamily="50" charset="0"/>
+              <a:ea typeface="Calibri" panose="020F0502020204030204" pitchFamily="34" charset="0"/>
+              <a:cs typeface="Calibri" panose="020F0502020204030204" pitchFamily="34" charset="0"/>
+            </a:endParaRPr>
+          </a:p>
+        </p:txBody>
+      </p:sp>
+      <p:sp>
+        <p:nvSpPr>
+          <p:cNvPr id="75" name="ZoneTexte 74">
+            <a:extLst>
+              <a:ext uri="{FF2B5EF4-FFF2-40B4-BE49-F238E27FC236}">
+                <a16:creationId xmlns:a16="http://schemas.microsoft.com/office/drawing/2014/main" id="{7FEB726F-451B-12CF-95E2-3B95D18FBBAD}"/>
+              </a:ext>
+            </a:extLst>
+          </p:cNvPr>
+          <p:cNvSpPr txBox="1"/>
+          <p:nvPr/>
+        </p:nvSpPr>
+        <p:spPr>
+          <a:xfrm>
+            <a:off x="10058401" y="5388714"/>
+            <a:ext cx="1972584" cy="246221"/>
+          </a:xfrm>
+          <a:prstGeom prst="rect">
+            <a:avLst/>
+          </a:prstGeom>
+          <a:noFill/>
+        </p:spPr>
+        <p:txBody>
+          <a:bodyPr wrap="square">
+            <a:spAutoFit/>
+          </a:bodyPr>
+          <a:lstStyle/>
+          <a:p>
+            <a:pPr algn="r"/>
+            <a:r>
+              <a:rPr lang="fr-FR" sz="1000" dirty="0">
+                <a:solidFill>
+                  <a:schemeClr val="tx1">
+                    <a:lumMod val="65000"/>
+                    <a:lumOff val="35000"/>
+                  </a:schemeClr>
+                </a:solidFill>
+                <a:latin typeface="Marianne" panose="02000000000000000000" pitchFamily="50" charset="0"/>
+                <a:ea typeface="Calibri" panose="020F0502020204030204" pitchFamily="34" charset="0"/>
+                <a:cs typeface="Calibri" panose="020F0502020204030204" pitchFamily="34" charset="0"/>
+              </a:rPr>
+              <a:t>Potentiel écosystème-relais</a:t>
+            </a:r>
+          </a:p>
+        </p:txBody>
+      </p:sp>
+      <p:sp>
+        <p:nvSpPr>
+          <p:cNvPr id="76" name="ZoneTexte 75">
+            <a:extLst>
+              <a:ext uri="{FF2B5EF4-FFF2-40B4-BE49-F238E27FC236}">
+                <a16:creationId xmlns:a16="http://schemas.microsoft.com/office/drawing/2014/main" id="{5E1DF01C-0F14-B74F-F7CB-666DD3A739BC}"/>
+              </a:ext>
+            </a:extLst>
+          </p:cNvPr>
+          <p:cNvSpPr txBox="1"/>
+          <p:nvPr/>
+        </p:nvSpPr>
+        <p:spPr>
+          <a:xfrm>
+            <a:off x="9362518" y="5028713"/>
+            <a:ext cx="476250" cy="400110"/>
+          </a:xfrm>
+          <a:prstGeom prst="rect">
+            <a:avLst/>
+          </a:prstGeom>
+          <a:noFill/>
+        </p:spPr>
+        <p:txBody>
+          <a:bodyPr wrap="square">
+            <a:spAutoFit/>
+          </a:bodyPr>
+          <a:lstStyle/>
+          <a:p>
+            <a:pPr algn="ctr"/>
+            <a:r>
+              <a:rPr lang="fr-FR" sz="1000" b="1" dirty="0">
+                <a:solidFill>
+                  <a:schemeClr val="tx1">
+                    <a:lumMod val="65000"/>
+                    <a:lumOff val="35000"/>
+                  </a:schemeClr>
+                </a:solidFill>
+                <a:latin typeface="Marianne" panose="02000000000000000000" pitchFamily="50" charset="0"/>
+                <a:ea typeface="Calibri" panose="020F0502020204030204" pitchFamily="34" charset="0"/>
+                <a:cs typeface="Calibri" panose="020F0502020204030204" pitchFamily="34" charset="0"/>
+              </a:rPr>
+              <a:t>|</a:t>
+            </a:r>
+          </a:p>
+          <a:p>
+            <a:pPr algn="ctr"/>
+            <a:r>
+              <a:rPr lang="fr-FR" sz="1000" b="1" dirty="0">
+                <a:solidFill>
+                  <a:schemeClr val="tx1">
+                    <a:lumMod val="65000"/>
+                    <a:lumOff val="35000"/>
+                  </a:schemeClr>
+                </a:solidFill>
+                <a:latin typeface="Marianne" panose="02000000000000000000" pitchFamily="50" charset="0"/>
+                <a:ea typeface="Calibri" panose="020F0502020204030204" pitchFamily="34" charset="0"/>
+                <a:cs typeface="Calibri" panose="020F0502020204030204" pitchFamily="34" charset="0"/>
+              </a:rPr>
+              <a:t>0,5</a:t>
+            </a:r>
+            <a:endParaRPr lang="fr-FR" sz="1000" dirty="0">
+              <a:solidFill>
+                <a:schemeClr val="tx1">
+                  <a:lumMod val="65000"/>
+                  <a:lumOff val="35000"/>
+                </a:schemeClr>
+              </a:solidFill>
+              <a:latin typeface="Marianne" panose="02000000000000000000" pitchFamily="50" charset="0"/>
+              <a:ea typeface="Calibri" panose="020F0502020204030204" pitchFamily="34" charset="0"/>
+              <a:cs typeface="Calibri" panose="020F0502020204030204" pitchFamily="34" charset="0"/>
+            </a:endParaRPr>
+          </a:p>
+        </p:txBody>
+      </p:sp>
+      <p:pic>
+        <p:nvPicPr>
+          <p:cNvPr id="81" name="zone_coeff_bio_echelle">
+            <a:extLst>
+              <a:ext uri="{FF2B5EF4-FFF2-40B4-BE49-F238E27FC236}">
+                <a16:creationId xmlns:a16="http://schemas.microsoft.com/office/drawing/2014/main" id="{E05A7EC6-5813-390D-C513-B8F343743BCB}"/>
+              </a:ext>
+            </a:extLst>
+          </p:cNvPr>
+          <p:cNvPicPr>
+            <a:picLocks noChangeAspect="1"/>
+          </p:cNvPicPr>
+          <p:nvPr/>
+        </p:nvPicPr>
+        <p:blipFill>
+          <a:blip r:embed="rId13">
+            <a:extLst>
+              <a:ext uri="{96DAC541-7B7A-43D3-8B79-37D633B846F1}">
+                <asvg:svgBlip xmlns:asvg="http://schemas.microsoft.com/office/drawing/2016/SVG/main" r:embed="rId14"/>
+              </a:ext>
+            </a:extLst>
+          </a:blip>
+          <a:stretch>
+            <a:fillRect/>
+          </a:stretch>
+        </p:blipFill>
+        <p:spPr>
+          <a:xfrm>
+            <a:off x="7274522" y="4801306"/>
+            <a:ext cx="4652243" cy="241049"/>
+          </a:xfrm>
+          <a:prstGeom prst="rect">
+            <a:avLst/>
+          </a:prstGeom>
+        </p:spPr>
+      </p:pic>
+      <p:pic>
+        <p:nvPicPr>
+          <p:cNvPr id="79" name="zone_coeff_bio_curseur">
+            <a:extLst>
+              <a:ext uri="{FF2B5EF4-FFF2-40B4-BE49-F238E27FC236}">
+                <a16:creationId xmlns:a16="http://schemas.microsoft.com/office/drawing/2014/main" id="{6E922DBF-EC40-62AE-5811-0C7DA85797E1}"/>
+              </a:ext>
+            </a:extLst>
+          </p:cNvPr>
+          <p:cNvPicPr>
+            <a:picLocks noChangeAspect="1"/>
+          </p:cNvPicPr>
+          <p:nvPr/>
+        </p:nvPicPr>
+        <p:blipFill>
+          <a:blip r:embed="rId7">
+            <a:extLst>
+              <a:ext uri="{96DAC541-7B7A-43D3-8B79-37D633B846F1}">
+                <asvg:svgBlip xmlns:asvg="http://schemas.microsoft.com/office/drawing/2016/SVG/main" r:embed="rId8"/>
+              </a:ext>
+            </a:extLst>
+          </a:blip>
+          <a:stretch>
+            <a:fillRect/>
+          </a:stretch>
+        </p:blipFill>
+        <p:spPr>
+          <a:xfrm>
+            <a:off x="7235688" y="4665970"/>
+            <a:ext cx="224536" cy="204124"/>
+          </a:xfrm>
+          <a:prstGeom prst="rect">
+            <a:avLst/>
+          </a:prstGeom>
+        </p:spPr>
+      </p:pic>
+      <p:pic>
+        <p:nvPicPr>
+          <p:cNvPr id="83" name="Graphique 82">
+            <a:extLst>
+              <a:ext uri="{FF2B5EF4-FFF2-40B4-BE49-F238E27FC236}">
+                <a16:creationId xmlns:a16="http://schemas.microsoft.com/office/drawing/2014/main" id="{F4830C2E-47F8-242B-E106-D059B106FBEE}"/>
+              </a:ext>
+            </a:extLst>
+          </p:cNvPr>
+          <p:cNvPicPr>
+            <a:picLocks noChangeAspect="1"/>
+          </p:cNvPicPr>
+          <p:nvPr/>
+        </p:nvPicPr>
+        <p:blipFill>
+          <a:blip r:embed="rId15">
+            <a:extLst>
+              <a:ext uri="{96DAC541-7B7A-43D3-8B79-37D633B846F1}">
+                <asvg:svgBlip xmlns:asvg="http://schemas.microsoft.com/office/drawing/2016/SVG/main" r:embed="rId16"/>
+              </a:ext>
+            </a:extLst>
+          </a:blip>
+          <a:stretch>
+            <a:fillRect/>
+          </a:stretch>
+        </p:blipFill>
+        <p:spPr>
+          <a:xfrm>
+            <a:off x="7282033" y="4085263"/>
+            <a:ext cx="356382" cy="356382"/>
+          </a:xfrm>
+          <a:prstGeom prst="rect">
+            <a:avLst/>
+          </a:prstGeom>
+        </p:spPr>
+      </p:pic>
+    </p:spTree>
+    <p:extLst>
+      <p:ext uri="{BB962C8B-B14F-4D97-AF65-F5344CB8AC3E}">
+        <p14:creationId xmlns:p14="http://schemas.microsoft.com/office/powerpoint/2010/main" val="330985702"/>
+      </p:ext>
+    </p:extLst>
+  </p:cSld>
+  <p:clrMapOvr>
+    <a:masterClrMapping/>
+  </p:clrMapOvr>
+</p:sld>
+</file>
+
+<file path=ppt/slides/slide4.xml><?xml version="1.0" encoding="utf-8"?>
+<p:sld xmlns:a="http://schemas.openxmlformats.org/drawingml/2006/main" xmlns:r="http://schemas.openxmlformats.org/officeDocument/2006/relationships" xmlns:p="http://schemas.openxmlformats.org/presentationml/2006/main">
+  <p:cSld>
+    <p:spTree>
+      <p:nvGrpSpPr>
+        <p:cNvPr id="1" name="">
+          <a:extLst>
+            <a:ext uri="{FF2B5EF4-FFF2-40B4-BE49-F238E27FC236}">
+              <a16:creationId xmlns:a16="http://schemas.microsoft.com/office/drawing/2014/main" id="{1917CAA9-6ECD-8F49-8289-13579AAE1FB7}"/>
+            </a:ext>
+          </a:extLst>
+        </p:cNvPr>
+        <p:cNvGrpSpPr/>
+        <p:nvPr/>
+      </p:nvGrpSpPr>
+      <p:grpSpPr>
+        <a:xfrm>
+          <a:off x="0" y="0"/>
+          <a:ext cx="0" cy="0"/>
+          <a:chOff x="0" y="0"/>
+          <a:chExt cx="0" cy="0"/>
+        </a:xfrm>
+      </p:grpSpPr>
+      <p:pic>
+        <p:nvPicPr>
+          <p:cNvPr id="4" name="Picture 3">
+            <a:extLst>
+              <a:ext uri="{FF2B5EF4-FFF2-40B4-BE49-F238E27FC236}">
+                <a16:creationId xmlns:a16="http://schemas.microsoft.com/office/drawing/2014/main" id="{7D131FE9-968A-7934-D330-1035AA73A364}"/>
+              </a:ext>
+            </a:extLst>
+          </p:cNvPr>
+          <p:cNvPicPr>
+            <a:picLocks noChangeAspect="1"/>
+          </p:cNvPicPr>
+          <p:nvPr/>
+        </p:nvPicPr>
+        <p:blipFill>
+          <a:blip r:embed="rId2"/>
+          <a:stretch>
+            <a:fillRect/>
+          </a:stretch>
+        </p:blipFill>
+        <p:spPr>
+          <a:xfrm>
+            <a:off x="10546452" y="104580"/>
+            <a:ext cx="1552051" cy="758533"/>
+          </a:xfrm>
+          <a:prstGeom prst="rect">
+            <a:avLst/>
+          </a:prstGeom>
+        </p:spPr>
+      </p:pic>
+      <p:sp>
+        <p:nvSpPr>
+          <p:cNvPr id="2" name="Titre 1">
+            <a:extLst>
+              <a:ext uri="{FF2B5EF4-FFF2-40B4-BE49-F238E27FC236}">
+                <a16:creationId xmlns:a16="http://schemas.microsoft.com/office/drawing/2014/main" id="{474A7BA3-D950-9097-DDDD-F688CBFCCB67}"/>
+              </a:ext>
+            </a:extLst>
+          </p:cNvPr>
+          <p:cNvSpPr>
+            <a:spLocks noGrp="1"/>
+          </p:cNvSpPr>
+          <p:nvPr>
+            <p:ph type="title"/>
+          </p:nvPr>
+        </p:nvSpPr>
+        <p:spPr>
+          <a:xfrm>
+            <a:off x="576262" y="345395"/>
+            <a:ext cx="10082262" cy="542307"/>
+          </a:xfrm>
+        </p:spPr>
+        <p:txBody>
+          <a:bodyPr>
+            <a:normAutofit/>
+          </a:bodyPr>
+          <a:lstStyle/>
+          <a:p>
+            <a:pPr marL="0" indent="0">
+              <a:buNone/>
+            </a:pPr>
+            <a:r>
+              <a:rPr lang="en-US" sz="2800" dirty="0" err="1">
+                <a:latin typeface="Marianne" panose="02000000000000000000" pitchFamily="50" charset="0"/>
+                <a:ea typeface="Calibri" panose="020F0502020204030204" pitchFamily="34" charset="0"/>
+                <a:cs typeface="Calibri" panose="020F0502020204030204" pitchFamily="34" charset="0"/>
+              </a:rPr>
+              <a:t>Méthode</a:t>
+            </a:r>
+            <a:r>
+              <a:rPr lang="en-US" sz="2800" dirty="0">
+                <a:latin typeface="Marianne" panose="02000000000000000000" pitchFamily="50" charset="0"/>
+                <a:ea typeface="Calibri" panose="020F0502020204030204" pitchFamily="34" charset="0"/>
+                <a:cs typeface="Calibri" panose="020F0502020204030204" pitchFamily="34" charset="0"/>
+              </a:rPr>
+              <a:t> {{</a:t>
+            </a:r>
+            <a:r>
+              <a:rPr lang="en-US" sz="2800" dirty="0" err="1">
+                <a:latin typeface="Marianne" panose="02000000000000000000" pitchFamily="50" charset="0"/>
+                <a:ea typeface="Calibri" panose="020F0502020204030204" pitchFamily="34" charset="0"/>
+                <a:cs typeface="Calibri" panose="020F0502020204030204" pitchFamily="34" charset="0"/>
+              </a:rPr>
+              <a:t>n°_diagnostic</a:t>
+            </a:r>
+            <a:r>
+              <a:rPr lang="en-US" sz="2800" dirty="0">
+                <a:latin typeface="Marianne" panose="02000000000000000000" pitchFamily="50" charset="0"/>
+                <a:ea typeface="Calibri" panose="020F0502020204030204" pitchFamily="34" charset="0"/>
+                <a:cs typeface="Calibri" panose="020F0502020204030204" pitchFamily="34" charset="0"/>
+              </a:rPr>
+              <a:t>}} : {{</a:t>
+            </a:r>
+            <a:r>
+              <a:rPr lang="en-US" sz="2800" dirty="0" err="1">
+                <a:latin typeface="Marianne" panose="02000000000000000000" pitchFamily="50" charset="0"/>
+                <a:ea typeface="Calibri" panose="020F0502020204030204" pitchFamily="34" charset="0"/>
+                <a:cs typeface="Calibri" panose="020F0502020204030204" pitchFamily="34" charset="0"/>
+              </a:rPr>
+              <a:t>titre_fiche_diagnostic</a:t>
+            </a:r>
+            <a:r>
+              <a:rPr lang="en-US" sz="2800" dirty="0">
+                <a:latin typeface="Marianne" panose="02000000000000000000" pitchFamily="50" charset="0"/>
+                <a:ea typeface="Calibri" panose="020F0502020204030204" pitchFamily="34" charset="0"/>
+                <a:cs typeface="Calibri" panose="020F0502020204030204" pitchFamily="34" charset="0"/>
+              </a:rPr>
+              <a:t>}}</a:t>
+            </a:r>
+          </a:p>
+        </p:txBody>
+      </p:sp>
+      <p:cxnSp>
+        <p:nvCxnSpPr>
+          <p:cNvPr id="34" name="Connecteur droit 33">
+            <a:extLst>
+              <a:ext uri="{FF2B5EF4-FFF2-40B4-BE49-F238E27FC236}">
+                <a16:creationId xmlns:a16="http://schemas.microsoft.com/office/drawing/2014/main" id="{B62F42A1-9E9E-D546-190A-5C7D09368113}"/>
+              </a:ext>
+            </a:extLst>
+          </p:cNvPr>
+          <p:cNvCxnSpPr>
+            <a:cxnSpLocks/>
+          </p:cNvCxnSpPr>
+          <p:nvPr/>
+        </p:nvCxnSpPr>
+        <p:spPr>
+          <a:xfrm>
+            <a:off x="576263" y="960689"/>
+            <a:ext cx="11615737" cy="0"/>
+          </a:xfrm>
+          <a:prstGeom prst="line">
+            <a:avLst/>
+          </a:prstGeom>
+          <a:ln>
+            <a:solidFill>
+              <a:schemeClr val="bg1">
+                <a:lumMod val="85000"/>
+              </a:schemeClr>
+            </a:solidFill>
+          </a:ln>
+        </p:spPr>
+        <p:style>
+          <a:lnRef idx="2">
+            <a:schemeClr val="accent1"/>
+          </a:lnRef>
+          <a:fillRef idx="0">
+            <a:schemeClr val="accent1"/>
+          </a:fillRef>
+          <a:effectRef idx="1">
+            <a:schemeClr val="accent1"/>
+          </a:effectRef>
+          <a:fontRef idx="minor">
+            <a:schemeClr val="tx1"/>
+          </a:fontRef>
+        </p:style>
+      </p:cxnSp>
+      <p:sp>
+        <p:nvSpPr>
+          <p:cNvPr id="43" name="Text 16">
+            <a:extLst>
+              <a:ext uri="{FF2B5EF4-FFF2-40B4-BE49-F238E27FC236}">
+                <a16:creationId xmlns:a16="http://schemas.microsoft.com/office/drawing/2014/main" id="{A300427D-EA15-7150-EA9C-A87450E6202D}"/>
+              </a:ext>
+            </a:extLst>
+          </p:cNvPr>
+          <p:cNvSpPr/>
+          <p:nvPr/>
+        </p:nvSpPr>
+        <p:spPr>
+          <a:xfrm>
+            <a:off x="7011736" y="1501320"/>
+            <a:ext cx="2220756" cy="293597"/>
+          </a:xfrm>
+          <a:prstGeom prst="rect">
+            <a:avLst/>
+          </a:prstGeom>
+          <a:noFill/>
+          <a:ln/>
+        </p:spPr>
+        <p:txBody>
+          <a:bodyPr wrap="square" lIns="0" tIns="0" rIns="0" bIns="0" rtlCol="0" anchor="ctr"/>
+          <a:lstStyle/>
+          <a:p>
+            <a:pPr marL="0" indent="0">
+              <a:buNone/>
+            </a:pPr>
+            <a:r>
+              <a:rPr lang="en-US" b="1" kern="0" spc="150" dirty="0">
+                <a:latin typeface="Marianne" panose="02000000000000000000" pitchFamily="50" charset="0"/>
+                <a:ea typeface="Calibri" panose="020F0502020204030204" pitchFamily="34" charset="0"/>
+                <a:cs typeface="Calibri" panose="020F0502020204030204" pitchFamily="34" charset="0"/>
+              </a:rPr>
+              <a:t>Mise </a:t>
+            </a:r>
+            <a:r>
+              <a:rPr lang="en-US" b="1" kern="0" spc="150" dirty="0" err="1">
+                <a:latin typeface="Marianne" panose="02000000000000000000" pitchFamily="50" charset="0"/>
+                <a:ea typeface="Calibri" panose="020F0502020204030204" pitchFamily="34" charset="0"/>
+                <a:cs typeface="Calibri" panose="020F0502020204030204" pitchFamily="34" charset="0"/>
+              </a:rPr>
+              <a:t>en</a:t>
+            </a:r>
+            <a:r>
+              <a:rPr lang="en-US" b="1" kern="0" spc="150" dirty="0">
+                <a:latin typeface="Marianne" panose="02000000000000000000" pitchFamily="50" charset="0"/>
+                <a:ea typeface="Calibri" panose="020F0502020204030204" pitchFamily="34" charset="0"/>
+                <a:cs typeface="Calibri" panose="020F0502020204030204" pitchFamily="34" charset="0"/>
+              </a:rPr>
+              <a:t> oeuvre</a:t>
+            </a:r>
+            <a:endParaRPr lang="en-US" dirty="0">
+              <a:latin typeface="Marianne" panose="02000000000000000000" pitchFamily="50" charset="0"/>
+              <a:ea typeface="Calibri" panose="020F0502020204030204" pitchFamily="34" charset="0"/>
+              <a:cs typeface="Calibri" panose="020F0502020204030204" pitchFamily="34" charset="0"/>
+            </a:endParaRPr>
+          </a:p>
+        </p:txBody>
+      </p:sp>
+      <p:sp>
+        <p:nvSpPr>
+          <p:cNvPr id="44" name="Text 16">
+            <a:extLst>
+              <a:ext uri="{FF2B5EF4-FFF2-40B4-BE49-F238E27FC236}">
+                <a16:creationId xmlns:a16="http://schemas.microsoft.com/office/drawing/2014/main" id="{E91C9383-E765-31FC-91C1-919BA413B245}"/>
+              </a:ext>
+            </a:extLst>
+          </p:cNvPr>
+          <p:cNvSpPr/>
+          <p:nvPr/>
+        </p:nvSpPr>
+        <p:spPr>
+          <a:xfrm>
+            <a:off x="645627" y="1501320"/>
+            <a:ext cx="3477347" cy="293597"/>
+          </a:xfrm>
+          <a:prstGeom prst="rect">
+            <a:avLst/>
+          </a:prstGeom>
+          <a:noFill/>
+          <a:ln/>
+        </p:spPr>
+        <p:txBody>
+          <a:bodyPr wrap="square" lIns="0" tIns="0" rIns="0" bIns="0" rtlCol="0" anchor="ctr"/>
+          <a:lstStyle/>
+          <a:p>
+            <a:pPr marL="0" indent="0">
+              <a:buNone/>
+            </a:pPr>
+            <a:r>
+              <a:rPr lang="en-US" b="1" kern="0" spc="150" dirty="0">
+                <a:latin typeface="Marianne" panose="02000000000000000000" pitchFamily="50" charset="0"/>
+                <a:ea typeface="Calibri" panose="020F0502020204030204" pitchFamily="34" charset="0"/>
+                <a:cs typeface="Calibri" panose="020F0502020204030204" pitchFamily="34" charset="0"/>
+              </a:rPr>
+              <a:t>Description de la </a:t>
+            </a:r>
+            <a:r>
+              <a:rPr lang="en-US" b="1" kern="0" spc="150" dirty="0" err="1">
+                <a:latin typeface="Marianne" panose="02000000000000000000" pitchFamily="50" charset="0"/>
+                <a:ea typeface="Calibri" panose="020F0502020204030204" pitchFamily="34" charset="0"/>
+                <a:cs typeface="Calibri" panose="020F0502020204030204" pitchFamily="34" charset="0"/>
+              </a:rPr>
+              <a:t>méthode</a:t>
+            </a:r>
+            <a:endParaRPr lang="en-US" dirty="0">
+              <a:latin typeface="Marianne" panose="02000000000000000000" pitchFamily="50" charset="0"/>
+              <a:ea typeface="Calibri" panose="020F0502020204030204" pitchFamily="34" charset="0"/>
+              <a:cs typeface="Calibri" panose="020F0502020204030204" pitchFamily="34" charset="0"/>
+            </a:endParaRPr>
+          </a:p>
+        </p:txBody>
+      </p:sp>
+      <p:cxnSp>
+        <p:nvCxnSpPr>
+          <p:cNvPr id="55" name="Connecteur droit 54">
+            <a:extLst>
+              <a:ext uri="{FF2B5EF4-FFF2-40B4-BE49-F238E27FC236}">
+                <a16:creationId xmlns:a16="http://schemas.microsoft.com/office/drawing/2014/main" id="{BFBD2EB6-34B6-54D8-319B-95BBA847CB21}"/>
+              </a:ext>
+            </a:extLst>
+          </p:cNvPr>
+          <p:cNvCxnSpPr>
+            <a:cxnSpLocks/>
+          </p:cNvCxnSpPr>
+          <p:nvPr/>
+        </p:nvCxnSpPr>
+        <p:spPr>
+          <a:xfrm>
+            <a:off x="576263" y="6512991"/>
+            <a:ext cx="11615737" cy="0"/>
+          </a:xfrm>
+          <a:prstGeom prst="line">
+            <a:avLst/>
+          </a:prstGeom>
+          <a:ln>
+            <a:solidFill>
+              <a:schemeClr val="bg1">
+                <a:lumMod val="85000"/>
+              </a:schemeClr>
+            </a:solidFill>
+          </a:ln>
+        </p:spPr>
+        <p:style>
+          <a:lnRef idx="2">
+            <a:schemeClr val="accent1"/>
+          </a:lnRef>
+          <a:fillRef idx="0">
+            <a:schemeClr val="accent1"/>
+          </a:fillRef>
+          <a:effectRef idx="1">
+            <a:schemeClr val="accent1"/>
+          </a:effectRef>
+          <a:fontRef idx="minor">
+            <a:schemeClr val="tx1"/>
+          </a:fontRef>
+        </p:style>
+      </p:cxnSp>
+      <p:sp>
+        <p:nvSpPr>
+          <p:cNvPr id="56" name="Text 3">
+            <a:extLst>
+              <a:ext uri="{FF2B5EF4-FFF2-40B4-BE49-F238E27FC236}">
+                <a16:creationId xmlns:a16="http://schemas.microsoft.com/office/drawing/2014/main" id="{8B657D20-7F9C-8851-0BA6-B35DF1DB8D17}"/>
+              </a:ext>
+            </a:extLst>
+          </p:cNvPr>
+          <p:cNvSpPr/>
+          <p:nvPr/>
+        </p:nvSpPr>
+        <p:spPr>
+          <a:xfrm>
+            <a:off x="576263" y="6598217"/>
+            <a:ext cx="8229600" cy="182880"/>
+          </a:xfrm>
+          <a:prstGeom prst="rect">
+            <a:avLst/>
+          </a:prstGeom>
+          <a:noFill/>
+          <a:ln/>
+        </p:spPr>
+        <p:txBody>
+          <a:bodyPr wrap="square" lIns="0" tIns="0" rIns="0" bIns="0" rtlCol="0" anchor="ctr"/>
+          <a:lstStyle/>
+          <a:p>
+            <a:pPr marL="0" indent="0">
+              <a:buNone/>
+            </a:pPr>
+            <a:r>
+              <a:rPr lang="en-US" sz="1000" i="1" dirty="0">
+                <a:solidFill>
+                  <a:srgbClr val="A0A0A0"/>
+                </a:solidFill>
+                <a:latin typeface="Marianne" panose="02000000000000000000" pitchFamily="50" charset="0"/>
+                <a:ea typeface="Calibri" panose="020F0502020204030204" pitchFamily="34" charset="0"/>
+                <a:cs typeface="Calibri" panose="020F0502020204030204" pitchFamily="34" charset="0"/>
+              </a:rPr>
+              <a:t>Données issues de Plus </a:t>
+            </a:r>
+            <a:r>
+              <a:rPr lang="en-US" sz="1000" i="1" dirty="0" err="1">
+                <a:solidFill>
+                  <a:srgbClr val="A0A0A0"/>
+                </a:solidFill>
+                <a:latin typeface="Marianne" panose="02000000000000000000" pitchFamily="50" charset="0"/>
+                <a:ea typeface="Calibri" panose="020F0502020204030204" pitchFamily="34" charset="0"/>
+                <a:cs typeface="Calibri" panose="020F0502020204030204" pitchFamily="34" charset="0"/>
+              </a:rPr>
+              <a:t>fraîche</a:t>
+            </a:r>
+            <a:r>
+              <a:rPr lang="en-US" sz="1000" i="1" dirty="0">
+                <a:solidFill>
+                  <a:srgbClr val="A0A0A0"/>
+                </a:solidFill>
+                <a:latin typeface="Marianne" panose="02000000000000000000" pitchFamily="50" charset="0"/>
+                <a:ea typeface="Calibri" panose="020F0502020204030204" pitchFamily="34" charset="0"/>
+                <a:cs typeface="Calibri" panose="020F0502020204030204" pitchFamily="34" charset="0"/>
+              </a:rPr>
+              <a:t> ma </a:t>
+            </a:r>
+            <a:r>
+              <a:rPr lang="en-US" sz="1000" i="1" dirty="0" err="1">
+                <a:solidFill>
+                  <a:srgbClr val="A0A0A0"/>
+                </a:solidFill>
+                <a:latin typeface="Marianne" panose="02000000000000000000" pitchFamily="50" charset="0"/>
+                <a:ea typeface="Calibri" panose="020F0502020204030204" pitchFamily="34" charset="0"/>
+                <a:cs typeface="Calibri" panose="020F0502020204030204" pitchFamily="34" charset="0"/>
+              </a:rPr>
+              <a:t>ville</a:t>
+            </a:r>
+            <a:r>
+              <a:rPr lang="en-US" sz="1000" i="1" dirty="0">
+                <a:solidFill>
+                  <a:srgbClr val="A0A0A0"/>
+                </a:solidFill>
+                <a:latin typeface="Marianne" panose="02000000000000000000" pitchFamily="50" charset="0"/>
+                <a:ea typeface="Calibri" panose="020F0502020204030204" pitchFamily="34" charset="0"/>
+                <a:cs typeface="Calibri" panose="020F0502020204030204" pitchFamily="34" charset="0"/>
+              </a:rPr>
+              <a:t> (ADEME)</a:t>
+            </a:r>
+            <a:endParaRPr lang="en-US" sz="1000" dirty="0">
+              <a:latin typeface="Marianne" panose="02000000000000000000" pitchFamily="50" charset="0"/>
+              <a:ea typeface="Calibri" panose="020F0502020204030204" pitchFamily="34" charset="0"/>
+              <a:cs typeface="Calibri" panose="020F0502020204030204" pitchFamily="34" charset="0"/>
+            </a:endParaRPr>
+          </a:p>
+        </p:txBody>
+      </p:sp>
+      <p:sp>
+        <p:nvSpPr>
+          <p:cNvPr id="3" name="ZoneTexte 2">
+            <a:extLst>
+              <a:ext uri="{FF2B5EF4-FFF2-40B4-BE49-F238E27FC236}">
+                <a16:creationId xmlns:a16="http://schemas.microsoft.com/office/drawing/2014/main" id="{283396D7-68F3-FCA6-1DDE-493C9D9A712C}"/>
+              </a:ext>
+            </a:extLst>
+          </p:cNvPr>
+          <p:cNvSpPr txBox="1"/>
+          <p:nvPr/>
+        </p:nvSpPr>
+        <p:spPr>
+          <a:xfrm>
             <a:off x="7061698" y="1950796"/>
             <a:ext cx="1006138" cy="369332"/>
           </a:xfrm>
@@ -7408,7 +10143,7 @@
     </p:spTree>
     <p:extLst>
       <p:ext uri="{BB962C8B-B14F-4D97-AF65-F5344CB8AC3E}">
-        <p14:creationId xmlns:p14="http://schemas.microsoft.com/office/powerpoint/2010/main" val="452405676"/>
+        <p14:creationId xmlns:p14="http://schemas.microsoft.com/office/powerpoint/2010/main" val="910928531"/>
       </p:ext>
     </p:extLst>
   </p:cSld>
@@ -7418,7 +10153,7 @@
 </p:sld>
 </file>
 
-<file path=ppt/slides/slide4.xml><?xml version="1.0" encoding="utf-8"?>
+<file path=ppt/slides/slide5.xml><?xml version="1.0" encoding="utf-8"?>
 <p:sld xmlns:a="http://schemas.openxmlformats.org/drawingml/2006/main" xmlns:r="http://schemas.openxmlformats.org/officeDocument/2006/relationships" xmlns:p="http://schemas.openxmlformats.org/presentationml/2006/main">
   <p:cSld>
     <p:spTree>
@@ -7766,7 +10501,7 @@
 </p:sld>
 </file>
 
-<file path=ppt/slides/slide5.xml><?xml version="1.0" encoding="utf-8"?>
+<file path=ppt/slides/slide6.xml><?xml version="1.0" encoding="utf-8"?>
 <p:sld xmlns:a="http://schemas.openxmlformats.org/drawingml/2006/main" xmlns:r="http://schemas.openxmlformats.org/officeDocument/2006/relationships" xmlns:p="http://schemas.openxmlformats.org/presentationml/2006/main">
   <p:cSld>
     <p:spTree>
@@ -9164,7 +11899,7 @@
 </p:sld>
 </file>
 
-<file path=ppt/slides/slide6.xml><?xml version="1.0" encoding="utf-8"?>
+<file path=ppt/slides/slide7.xml><?xml version="1.0" encoding="utf-8"?>
 <p:sld xmlns:a="http://schemas.openxmlformats.org/drawingml/2006/main" xmlns:r="http://schemas.openxmlformats.org/officeDocument/2006/relationships" xmlns:p="http://schemas.openxmlformats.org/presentationml/2006/main">
   <p:cSld>
     <p:spTree>
@@ -9787,7 +12522,7 @@
 </p:sld>
 </file>
 
-<file path=ppt/slides/slide7.xml><?xml version="1.0" encoding="utf-8"?>
+<file path=ppt/slides/slide8.xml><?xml version="1.0" encoding="utf-8"?>
 <p:sld xmlns:a="http://schemas.openxmlformats.org/drawingml/2006/main" xmlns:r="http://schemas.openxmlformats.org/officeDocument/2006/relationships" xmlns:p="http://schemas.openxmlformats.org/presentationml/2006/main">
   <p:cSld>
     <p:spTree>
@@ -10156,7 +12891,7 @@
 </p:sld>
 </file>
 
-<file path=ppt/slides/slide8.xml><?xml version="1.0" encoding="utf-8"?>
+<file path=ppt/slides/slide9.xml><?xml version="1.0" encoding="utf-8"?>
 <p:sld xmlns:a="http://schemas.openxmlformats.org/drawingml/2006/main" xmlns:r="http://schemas.openxmlformats.org/officeDocument/2006/relationships" xmlns:p="http://schemas.openxmlformats.org/presentationml/2006/main">
   <p:cSld>
     <p:spTree>
@@ -11294,375 +14029,6 @@
     <p:extLst>
       <p:ext uri="{BB962C8B-B14F-4D97-AF65-F5344CB8AC3E}">
         <p14:creationId xmlns:p14="http://schemas.microsoft.com/office/powerpoint/2010/main" val="2086438628"/>
-      </p:ext>
-    </p:extLst>
-  </p:cSld>
-  <p:clrMapOvr>
-    <a:masterClrMapping/>
-  </p:clrMapOvr>
-</p:sld>
-</file>
-
-<file path=ppt/slides/slide9.xml><?xml version="1.0" encoding="utf-8"?>
-<p:sld xmlns:a="http://schemas.openxmlformats.org/drawingml/2006/main" xmlns:r="http://schemas.openxmlformats.org/officeDocument/2006/relationships" xmlns:p="http://schemas.openxmlformats.org/presentationml/2006/main">
-  <p:cSld>
-    <p:spTree>
-      <p:nvGrpSpPr>
-        <p:cNvPr id="1" name="">
-          <a:extLst>
-            <a:ext uri="{FF2B5EF4-FFF2-40B4-BE49-F238E27FC236}">
-              <a16:creationId xmlns:a16="http://schemas.microsoft.com/office/drawing/2014/main" id="{955CEECE-80BD-24F5-29ED-51D02A8DC5DD}"/>
-            </a:ext>
-          </a:extLst>
-        </p:cNvPr>
-        <p:cNvGrpSpPr/>
-        <p:nvPr/>
-      </p:nvGrpSpPr>
-      <p:grpSpPr>
-        <a:xfrm>
-          <a:off x="0" y="0"/>
-          <a:ext cx="0" cy="0"/>
-          <a:chOff x="0" y="0"/>
-          <a:chExt cx="0" cy="0"/>
-        </a:xfrm>
-      </p:grpSpPr>
-      <p:pic>
-        <p:nvPicPr>
-          <p:cNvPr id="10" name="Picture 9">
-            <a:extLst>
-              <a:ext uri="{FF2B5EF4-FFF2-40B4-BE49-F238E27FC236}">
-                <a16:creationId xmlns:a16="http://schemas.microsoft.com/office/drawing/2014/main" id="{E922595D-B49E-4187-3566-440EF1D1B583}"/>
-              </a:ext>
-            </a:extLst>
-          </p:cNvPr>
-          <p:cNvPicPr>
-            <a:picLocks noChangeAspect="1"/>
-          </p:cNvPicPr>
-          <p:nvPr/>
-        </p:nvPicPr>
-        <p:blipFill>
-          <a:blip r:embed="rId3"/>
-          <a:stretch>
-            <a:fillRect/>
-          </a:stretch>
-        </p:blipFill>
-        <p:spPr>
-          <a:xfrm>
-            <a:off x="10546452" y="104580"/>
-            <a:ext cx="1552051" cy="758533"/>
-          </a:xfrm>
-          <a:prstGeom prst="rect">
-            <a:avLst/>
-          </a:prstGeom>
-        </p:spPr>
-      </p:pic>
-      <p:sp>
-        <p:nvSpPr>
-          <p:cNvPr id="4" name="Text 2">
-            <a:extLst>
-              <a:ext uri="{FF2B5EF4-FFF2-40B4-BE49-F238E27FC236}">
-                <a16:creationId xmlns:a16="http://schemas.microsoft.com/office/drawing/2014/main" id="{3AA7DA23-AC46-53C2-5481-F11CF1FF75EA}"/>
-              </a:ext>
-            </a:extLst>
-          </p:cNvPr>
-          <p:cNvSpPr/>
-          <p:nvPr/>
-        </p:nvSpPr>
-        <p:spPr>
-          <a:xfrm>
-            <a:off x="609600" y="2202220"/>
-            <a:ext cx="10972800" cy="792480"/>
-          </a:xfrm>
-          <a:prstGeom prst="rect">
-            <a:avLst/>
-          </a:prstGeom>
-          <a:noFill/>
-          <a:ln/>
-        </p:spPr>
-        <p:txBody>
-          <a:bodyPr wrap="square" lIns="0" tIns="0" rIns="0" bIns="0" rtlCol="0" anchor="ctr"/>
-          <a:lstStyle/>
-          <a:p>
-            <a:r>
-              <a:rPr lang="en-US" sz="3733" b="1" dirty="0">
-                <a:solidFill>
-                  <a:srgbClr val="1A1A1A"/>
-                </a:solidFill>
-                <a:latin typeface="Marianne" panose="02000000000000000000" pitchFamily="50" charset="0"/>
-                <a:ea typeface="Calibri" panose="020F0502020204030204" pitchFamily="34" charset="0"/>
-                <a:cs typeface="Calibri" panose="020F0502020204030204" pitchFamily="34" charset="0"/>
-              </a:rPr>
-              <a:t>Aides </a:t>
-            </a:r>
-            <a:r>
-              <a:rPr lang="en-US" sz="3733" b="1" dirty="0" err="1">
-                <a:solidFill>
-                  <a:srgbClr val="1A1A1A"/>
-                </a:solidFill>
-                <a:latin typeface="Marianne" panose="02000000000000000000" pitchFamily="50" charset="0"/>
-                <a:ea typeface="Calibri" panose="020F0502020204030204" pitchFamily="34" charset="0"/>
-                <a:cs typeface="Calibri" panose="020F0502020204030204" pitchFamily="34" charset="0"/>
-              </a:rPr>
-              <a:t>financières</a:t>
-            </a:r>
-            <a:r>
-              <a:rPr lang="en-US" sz="3733" b="1" dirty="0">
-                <a:solidFill>
-                  <a:srgbClr val="1A1A1A"/>
-                </a:solidFill>
-                <a:latin typeface="Marianne" panose="02000000000000000000" pitchFamily="50" charset="0"/>
-                <a:ea typeface="Calibri" panose="020F0502020204030204" pitchFamily="34" charset="0"/>
-                <a:cs typeface="Calibri" panose="020F0502020204030204" pitchFamily="34" charset="0"/>
-              </a:rPr>
-              <a:t> et </a:t>
-            </a:r>
-            <a:r>
-              <a:rPr lang="en-US" sz="3733" b="1" dirty="0" err="1">
-                <a:solidFill>
-                  <a:srgbClr val="1A1A1A"/>
-                </a:solidFill>
-                <a:latin typeface="Marianne" panose="02000000000000000000" pitchFamily="50" charset="0"/>
-                <a:ea typeface="Calibri" panose="020F0502020204030204" pitchFamily="34" charset="0"/>
-                <a:cs typeface="Calibri" panose="020F0502020204030204" pitchFamily="34" charset="0"/>
-              </a:rPr>
-              <a:t>en</a:t>
-            </a:r>
-            <a:r>
-              <a:rPr lang="en-US" sz="3733" b="1" dirty="0">
-                <a:solidFill>
-                  <a:srgbClr val="1A1A1A"/>
-                </a:solidFill>
-                <a:latin typeface="Marianne" panose="02000000000000000000" pitchFamily="50" charset="0"/>
-                <a:ea typeface="Calibri" panose="020F0502020204030204" pitchFamily="34" charset="0"/>
-                <a:cs typeface="Calibri" panose="020F0502020204030204" pitchFamily="34" charset="0"/>
-              </a:rPr>
-              <a:t> </a:t>
-            </a:r>
-            <a:r>
-              <a:rPr lang="en-US" sz="3733" b="1" dirty="0" err="1">
-                <a:solidFill>
-                  <a:srgbClr val="1A1A1A"/>
-                </a:solidFill>
-                <a:latin typeface="Marianne" panose="02000000000000000000" pitchFamily="50" charset="0"/>
-                <a:ea typeface="Calibri" panose="020F0502020204030204" pitchFamily="34" charset="0"/>
-                <a:cs typeface="Calibri" panose="020F0502020204030204" pitchFamily="34" charset="0"/>
-              </a:rPr>
-              <a:t>ingénierie</a:t>
-            </a:r>
-            <a:endParaRPr lang="en-US" sz="3733" dirty="0">
-              <a:latin typeface="Marianne" panose="02000000000000000000" pitchFamily="50" charset="0"/>
-              <a:ea typeface="Calibri" panose="020F0502020204030204" pitchFamily="34" charset="0"/>
-              <a:cs typeface="Calibri" panose="020F0502020204030204" pitchFamily="34" charset="0"/>
-            </a:endParaRPr>
-          </a:p>
-        </p:txBody>
-      </p:sp>
-      <p:sp>
-        <p:nvSpPr>
-          <p:cNvPr id="5" name="Shape 3">
-            <a:extLst>
-              <a:ext uri="{FF2B5EF4-FFF2-40B4-BE49-F238E27FC236}">
-                <a16:creationId xmlns:a16="http://schemas.microsoft.com/office/drawing/2014/main" id="{302F78CA-65FF-9043-6070-1584BC6D4D54}"/>
-              </a:ext>
-            </a:extLst>
-          </p:cNvPr>
-          <p:cNvSpPr/>
-          <p:nvPr/>
-        </p:nvSpPr>
-        <p:spPr>
-          <a:xfrm>
-            <a:off x="609600" y="3080044"/>
-            <a:ext cx="731520" cy="48768"/>
-          </a:xfrm>
-          <a:prstGeom prst="rect">
-            <a:avLst/>
-          </a:prstGeom>
-          <a:solidFill>
-            <a:srgbClr val="1A1A1A"/>
-          </a:solidFill>
-          <a:ln w="12700">
-            <a:solidFill>
-              <a:srgbClr val="1A1A1A"/>
-            </a:solidFill>
-            <a:prstDash val="solid"/>
-          </a:ln>
-        </p:spPr>
-        <p:txBody>
-          <a:bodyPr/>
-          <a:lstStyle/>
-          <a:p>
-            <a:endParaRPr lang="fr-FR" sz="2400">
-              <a:latin typeface="Marianne" panose="02000000000000000000" pitchFamily="50" charset="0"/>
-              <a:ea typeface="Calibri" panose="020F0502020204030204" pitchFamily="34" charset="0"/>
-              <a:cs typeface="Calibri" panose="020F0502020204030204" pitchFamily="34" charset="0"/>
-            </a:endParaRPr>
-          </a:p>
-        </p:txBody>
-      </p:sp>
-      <p:sp>
-        <p:nvSpPr>
-          <p:cNvPr id="6" name="Text 4">
-            <a:extLst>
-              <a:ext uri="{FF2B5EF4-FFF2-40B4-BE49-F238E27FC236}">
-                <a16:creationId xmlns:a16="http://schemas.microsoft.com/office/drawing/2014/main" id="{9328B9A3-CC8F-11E9-FAB1-0824EF7E88D7}"/>
-              </a:ext>
-            </a:extLst>
-          </p:cNvPr>
-          <p:cNvSpPr/>
-          <p:nvPr/>
-        </p:nvSpPr>
-        <p:spPr>
-          <a:xfrm>
-            <a:off x="609600" y="3398401"/>
-            <a:ext cx="10972800" cy="2879386"/>
-          </a:xfrm>
-          <a:prstGeom prst="rect">
-            <a:avLst/>
-          </a:prstGeom>
-          <a:noFill/>
-          <a:ln/>
-        </p:spPr>
-        <p:txBody>
-          <a:bodyPr wrap="square" lIns="0" tIns="0" rIns="0" bIns="0" rtlCol="0" anchor="t"/>
-          <a:lstStyle/>
-          <a:p>
-            <a:r>
-              <a:rPr lang="en-US" sz="1600" dirty="0" err="1">
-                <a:solidFill>
-                  <a:srgbClr val="5C5C5C"/>
-                </a:solidFill>
-                <a:latin typeface="Marianne" panose="02000000000000000000" pitchFamily="50" charset="0"/>
-                <a:ea typeface="Calibri" pitchFamily="34" charset="-122"/>
-                <a:cs typeface="Calibri" pitchFamily="34" charset="-120"/>
-              </a:rPr>
-              <a:t>Dispositifs</a:t>
-            </a:r>
-            <a:r>
-              <a:rPr lang="en-US" sz="1600" dirty="0">
-                <a:solidFill>
-                  <a:srgbClr val="5C5C5C"/>
-                </a:solidFill>
-                <a:latin typeface="Marianne" panose="02000000000000000000" pitchFamily="50" charset="0"/>
-                <a:ea typeface="Calibri" pitchFamily="34" charset="-122"/>
-                <a:cs typeface="Calibri" pitchFamily="34" charset="-120"/>
-              </a:rPr>
-              <a:t> </a:t>
-            </a:r>
-            <a:r>
-              <a:rPr lang="en-US" sz="1600" dirty="0" err="1">
-                <a:solidFill>
-                  <a:srgbClr val="5C5C5C"/>
-                </a:solidFill>
-                <a:latin typeface="Marianne" panose="02000000000000000000" pitchFamily="50" charset="0"/>
-                <a:ea typeface="Calibri" pitchFamily="34" charset="-122"/>
-                <a:cs typeface="Calibri" pitchFamily="34" charset="-120"/>
-              </a:rPr>
-              <a:t>mobilisables</a:t>
-            </a:r>
-            <a:endParaRPr lang="en-US" sz="1600" dirty="0">
-              <a:latin typeface="Marianne" panose="02000000000000000000" pitchFamily="50" charset="0"/>
-            </a:endParaRPr>
-          </a:p>
-        </p:txBody>
-      </p:sp>
-      <p:cxnSp>
-        <p:nvCxnSpPr>
-          <p:cNvPr id="2" name="Connecteur droit 1">
-            <a:extLst>
-              <a:ext uri="{FF2B5EF4-FFF2-40B4-BE49-F238E27FC236}">
-                <a16:creationId xmlns:a16="http://schemas.microsoft.com/office/drawing/2014/main" id="{A3CAC41A-66B0-361D-B372-62D87EE7A9F8}"/>
-              </a:ext>
-            </a:extLst>
-          </p:cNvPr>
-          <p:cNvCxnSpPr>
-            <a:cxnSpLocks/>
-          </p:cNvCxnSpPr>
-          <p:nvPr/>
-        </p:nvCxnSpPr>
-        <p:spPr>
-          <a:xfrm>
-            <a:off x="576263" y="6512991"/>
-            <a:ext cx="11615737" cy="0"/>
-          </a:xfrm>
-          <a:prstGeom prst="line">
-            <a:avLst/>
-          </a:prstGeom>
-          <a:ln>
-            <a:solidFill>
-              <a:schemeClr val="bg1">
-                <a:lumMod val="85000"/>
-              </a:schemeClr>
-            </a:solidFill>
-          </a:ln>
-        </p:spPr>
-        <p:style>
-          <a:lnRef idx="2">
-            <a:schemeClr val="accent1"/>
-          </a:lnRef>
-          <a:fillRef idx="0">
-            <a:schemeClr val="accent1"/>
-          </a:fillRef>
-          <a:effectRef idx="1">
-            <a:schemeClr val="accent1"/>
-          </a:effectRef>
-          <a:fontRef idx="minor">
-            <a:schemeClr val="tx1"/>
-          </a:fontRef>
-        </p:style>
-      </p:cxnSp>
-      <p:sp>
-        <p:nvSpPr>
-          <p:cNvPr id="8" name="Text 3">
-            <a:extLst>
-              <a:ext uri="{FF2B5EF4-FFF2-40B4-BE49-F238E27FC236}">
-                <a16:creationId xmlns:a16="http://schemas.microsoft.com/office/drawing/2014/main" id="{515558A7-65FA-3B23-4336-CA7CF66783E3}"/>
-              </a:ext>
-            </a:extLst>
-          </p:cNvPr>
-          <p:cNvSpPr/>
-          <p:nvPr/>
-        </p:nvSpPr>
-        <p:spPr>
-          <a:xfrm>
-            <a:off x="576263" y="6598217"/>
-            <a:ext cx="8229600" cy="182880"/>
-          </a:xfrm>
-          <a:prstGeom prst="rect">
-            <a:avLst/>
-          </a:prstGeom>
-          <a:noFill/>
-          <a:ln/>
-        </p:spPr>
-        <p:txBody>
-          <a:bodyPr wrap="square" lIns="0" tIns="0" rIns="0" bIns="0" rtlCol="0" anchor="ctr"/>
-          <a:lstStyle/>
-          <a:p>
-            <a:pPr marL="0" indent="0">
-              <a:buNone/>
-            </a:pPr>
-            <a:r>
-              <a:rPr lang="en-US" sz="1000" i="1">
-                <a:solidFill>
-                  <a:srgbClr val="A0A0A0"/>
-                </a:solidFill>
-                <a:latin typeface="Marianne" panose="02000000000000000000" pitchFamily="50" charset="0"/>
-                <a:ea typeface="Calibri" panose="020F0502020204030204" pitchFamily="34" charset="0"/>
-                <a:cs typeface="Calibri" panose="020F0502020204030204" pitchFamily="34" charset="0"/>
-              </a:rPr>
-              <a:t>Données issues de Plus fraîche ma ville (ADEME)</a:t>
-            </a:r>
-            <a:endParaRPr lang="en-US" sz="1000">
-              <a:latin typeface="Marianne" panose="02000000000000000000" pitchFamily="50" charset="0"/>
-              <a:ea typeface="Calibri" panose="020F0502020204030204" pitchFamily="34" charset="0"/>
-              <a:cs typeface="Calibri" panose="020F0502020204030204" pitchFamily="34" charset="0"/>
-            </a:endParaRPr>
-          </a:p>
-        </p:txBody>
-      </p:sp>
-    </p:spTree>
-    <p:extLst>
-      <p:ext uri="{BB962C8B-B14F-4D97-AF65-F5344CB8AC3E}">
-        <p14:creationId xmlns:p14="http://schemas.microsoft.com/office/powerpoint/2010/main" val="3325200477"/>
       </p:ext>
     </p:extLst>
   </p:cSld>

</xml_diff>

<commit_message>
feat: Ajout du coefficient de biodiversité et de perméabilité
</commit_message>
<xml_diff>
--- a/public/templates/template_synthese_projet.pptx
+++ b/public/templates/template_synthese_projet.pptx
@@ -6780,6 +6780,153 @@
           <a:chExt cx="0" cy="0"/>
         </a:xfrm>
       </p:grpSpPr>
+      <p:sp>
+        <p:nvSpPr>
+          <p:cNvPr id="85" name="contour_perm">
+            <a:extLst>
+              <a:ext uri="{FF2B5EF4-FFF2-40B4-BE49-F238E27FC236}">
+                <a16:creationId xmlns:a16="http://schemas.microsoft.com/office/drawing/2014/main" id="{D8AB42B7-DFFF-113D-D131-7B6AAD2B2A4C}"/>
+              </a:ext>
+            </a:extLst>
+          </p:cNvPr>
+          <p:cNvSpPr/>
+          <p:nvPr/>
+        </p:nvSpPr>
+        <p:spPr>
+          <a:xfrm>
+            <a:off x="6765679" y="1071248"/>
+            <a:ext cx="5203163" cy="2512121"/>
+          </a:xfrm>
+          <a:prstGeom prst="roundRect">
+            <a:avLst>
+              <a:gd name="adj" fmla="val 5926"/>
+            </a:avLst>
+          </a:prstGeom>
+          <a:solidFill>
+            <a:srgbClr val="FFFFFF"/>
+          </a:solidFill>
+          <a:ln w="8890">
+            <a:solidFill>
+              <a:srgbClr val="DADADA"/>
+            </a:solidFill>
+            <a:prstDash val="solid"/>
+          </a:ln>
+          <a:effectLst>
+            <a:outerShdw blurRad="76200" dist="25400" dir="2700000" algn="bl" rotWithShape="0">
+              <a:srgbClr val="000000">
+                <a:alpha val="8000"/>
+              </a:srgbClr>
+            </a:outerShdw>
+          </a:effectLst>
+        </p:spPr>
+        <p:txBody>
+          <a:bodyPr/>
+          <a:lstStyle/>
+          <a:p>
+            <a:endParaRPr lang="fr-FR">
+              <a:latin typeface="Marianne" panose="02000000000000000000" pitchFamily="50" charset="0"/>
+            </a:endParaRPr>
+          </a:p>
+        </p:txBody>
+      </p:sp>
+      <p:sp>
+        <p:nvSpPr>
+          <p:cNvPr id="86" name="contour_bio">
+            <a:extLst>
+              <a:ext uri="{FF2B5EF4-FFF2-40B4-BE49-F238E27FC236}">
+                <a16:creationId xmlns:a16="http://schemas.microsoft.com/office/drawing/2014/main" id="{4D12FAD2-60A4-A6E4-0DB5-C47B2328B29F}"/>
+              </a:ext>
+            </a:extLst>
+          </p:cNvPr>
+          <p:cNvSpPr/>
+          <p:nvPr/>
+        </p:nvSpPr>
+        <p:spPr>
+          <a:xfrm>
+            <a:off x="6765680" y="3850116"/>
+            <a:ext cx="5203162" cy="2526413"/>
+          </a:xfrm>
+          <a:prstGeom prst="roundRect">
+            <a:avLst>
+              <a:gd name="adj" fmla="val 5926"/>
+            </a:avLst>
+          </a:prstGeom>
+          <a:solidFill>
+            <a:srgbClr val="FFFFFF"/>
+          </a:solidFill>
+          <a:ln w="8890">
+            <a:solidFill>
+              <a:srgbClr val="DADADA"/>
+            </a:solidFill>
+            <a:prstDash val="solid"/>
+          </a:ln>
+          <a:effectLst>
+            <a:outerShdw blurRad="76200" dist="25400" dir="2700000" algn="bl" rotWithShape="0">
+              <a:srgbClr val="000000">
+                <a:alpha val="8000"/>
+              </a:srgbClr>
+            </a:outerShdw>
+          </a:effectLst>
+        </p:spPr>
+        <p:txBody>
+          <a:bodyPr/>
+          <a:lstStyle/>
+          <a:p>
+            <a:endParaRPr lang="fr-FR">
+              <a:latin typeface="Marianne" panose="02000000000000000000" pitchFamily="50" charset="0"/>
+            </a:endParaRPr>
+          </a:p>
+        </p:txBody>
+      </p:sp>
+      <p:sp>
+        <p:nvSpPr>
+          <p:cNvPr id="84" name="contour_materiau">
+            <a:extLst>
+              <a:ext uri="{FF2B5EF4-FFF2-40B4-BE49-F238E27FC236}">
+                <a16:creationId xmlns:a16="http://schemas.microsoft.com/office/drawing/2014/main" id="{CBC5F1D2-8720-ABCF-DB73-04E78162FDA4}"/>
+              </a:ext>
+            </a:extLst>
+          </p:cNvPr>
+          <p:cNvSpPr/>
+          <p:nvPr/>
+        </p:nvSpPr>
+        <p:spPr>
+          <a:xfrm>
+            <a:off x="293261" y="1080537"/>
+            <a:ext cx="5639453" cy="3132233"/>
+          </a:xfrm>
+          <a:prstGeom prst="roundRect">
+            <a:avLst>
+              <a:gd name="adj" fmla="val 5926"/>
+            </a:avLst>
+          </a:prstGeom>
+          <a:solidFill>
+            <a:srgbClr val="FFFFFF"/>
+          </a:solidFill>
+          <a:ln w="8890">
+            <a:solidFill>
+              <a:srgbClr val="DADADA"/>
+            </a:solidFill>
+            <a:prstDash val="solid"/>
+          </a:ln>
+          <a:effectLst>
+            <a:outerShdw blurRad="76200" dist="25400" dir="2700000" algn="bl" rotWithShape="0">
+              <a:srgbClr val="000000">
+                <a:alpha val="8000"/>
+              </a:srgbClr>
+            </a:outerShdw>
+          </a:effectLst>
+        </p:spPr>
+        <p:txBody>
+          <a:bodyPr/>
+          <a:lstStyle/>
+          <a:p>
+            <a:endParaRPr lang="fr-FR">
+              <a:latin typeface="Marianne" panose="02000000000000000000" pitchFamily="50" charset="0"/>
+            </a:endParaRPr>
+          </a:p>
+        </p:txBody>
+      </p:sp>
       <p:pic>
         <p:nvPicPr>
           <p:cNvPr id="4" name="Picture 3">
@@ -6980,7 +7127,7 @@
         </p:nvSpPr>
         <p:spPr>
           <a:xfrm>
-            <a:off x="1037765" y="1421116"/>
+            <a:off x="1037765" y="1361243"/>
             <a:ext cx="3244745" cy="293597"/>
           </a:xfrm>
           <a:prstGeom prst="rect">
@@ -7219,7 +7366,7 @@
         </p:nvSpPr>
         <p:spPr>
           <a:xfrm>
-            <a:off x="413637" y="2480540"/>
+            <a:off x="413637" y="2300921"/>
             <a:ext cx="476250" cy="461665"/>
           </a:xfrm>
           <a:prstGeom prst="rect">
@@ -7293,8 +7440,8 @@
         </p:nvSpPr>
         <p:spPr>
           <a:xfrm>
-            <a:off x="3217874" y="1337544"/>
-            <a:ext cx="2341356" cy="492443"/>
+            <a:off x="2759529" y="1277671"/>
+            <a:ext cx="2799701" cy="553998"/>
           </a:xfrm>
           <a:prstGeom prst="rect">
             <a:avLst/>
@@ -7309,7 +7456,7 @@
           <a:p>
             <a:pPr algn="r"/>
             <a:r>
-              <a:rPr lang="fr-FR" sz="2600" b="1" dirty="0">
+              <a:rPr lang="fr-FR" sz="3000" b="1" dirty="0">
                 <a:solidFill>
                   <a:schemeClr val="tx1">
                     <a:lumMod val="65000"/>
@@ -7323,7 +7470,7 @@
               <a:t>{{</a:t>
             </a:r>
             <a:r>
-              <a:rPr lang="fr-FR" sz="2600" b="1" dirty="0" err="1">
+              <a:rPr lang="fr-FR" sz="3000" b="1" dirty="0" err="1">
                 <a:solidFill>
                   <a:schemeClr val="tx1">
                     <a:lumMod val="65000"/>
@@ -7337,7 +7484,7 @@
               <a:t>coeff_ru</a:t>
             </a:r>
             <a:r>
-              <a:rPr lang="fr-FR" sz="2600" b="1" dirty="0">
+              <a:rPr lang="fr-FR" sz="3000" b="1" dirty="0">
                 <a:solidFill>
                   <a:schemeClr val="tx1">
                     <a:lumMod val="65000"/>
@@ -7381,7 +7528,7 @@
         </p:nvSpPr>
         <p:spPr>
           <a:xfrm>
-            <a:off x="508248" y="2886968"/>
+            <a:off x="508248" y="2707349"/>
             <a:ext cx="1570680" cy="400110"/>
           </a:xfrm>
           <a:prstGeom prst="rect">
@@ -7426,8 +7573,8 @@
         </p:nvSpPr>
         <p:spPr>
           <a:xfrm>
-            <a:off x="508248" y="3510262"/>
-            <a:ext cx="5520587" cy="338554"/>
+            <a:off x="508248" y="3270769"/>
+            <a:ext cx="4929167" cy="772073"/>
           </a:xfrm>
           <a:prstGeom prst="rect">
             <a:avLst/>
@@ -7435,13 +7582,13 @@
           <a:noFill/>
         </p:spPr>
         <p:txBody>
-          <a:bodyPr wrap="square">
-            <a:spAutoFit/>
+          <a:bodyPr wrap="square" anchor="ctr">
+            <a:noAutofit/>
           </a:bodyPr>
           <a:lstStyle/>
           <a:p>
             <a:r>
-              <a:rPr lang="fr-FR" sz="1600" dirty="0">
+              <a:rPr lang="fr-FR" sz="1400" dirty="0">
                 <a:solidFill>
                   <a:schemeClr val="tx1">
                     <a:lumMod val="65000"/>
@@ -7455,7 +7602,7 @@
               <a:t>{{</a:t>
             </a:r>
             <a:r>
-              <a:rPr lang="fr-FR" sz="1600" dirty="0" err="1">
+              <a:rPr lang="fr-FR" sz="1400" dirty="0" err="1">
                 <a:solidFill>
                   <a:schemeClr val="tx1">
                     <a:lumMod val="65000"/>
@@ -7469,7 +7616,7 @@
               <a:t>analyse_coeff_ru</a:t>
             </a:r>
             <a:r>
-              <a:rPr lang="fr-FR" sz="1600" dirty="0">
+              <a:rPr lang="fr-FR" sz="1400" dirty="0">
                 <a:solidFill>
                   <a:schemeClr val="tx1">
                     <a:lumMod val="65000"/>
@@ -7513,7 +7660,7 @@
         </p:blipFill>
         <p:spPr>
           <a:xfrm>
-            <a:off x="575412" y="1351292"/>
+            <a:off x="575412" y="1291419"/>
             <a:ext cx="421353" cy="421353"/>
           </a:xfrm>
           <a:prstGeom prst="rect">
@@ -7531,7 +7678,7 @@
             </a:extLst>
           </p:cNvPr>
           <p:cNvPicPr>
-            <a:picLocks noChangeAspect="1"/>
+            <a:picLocks/>
           </p:cNvPicPr>
           <p:nvPr/>
         </p:nvPicPr>
@@ -7549,8 +7696,8 @@
         </p:blipFill>
         <p:spPr>
           <a:xfrm>
-            <a:off x="651763" y="2259705"/>
-            <a:ext cx="4785652" cy="247650"/>
+            <a:off x="651764" y="2123630"/>
+            <a:ext cx="4800145" cy="216000"/>
           </a:xfrm>
           <a:prstGeom prst="rect">
             <a:avLst/>
@@ -7571,7 +7718,7 @@
         </p:nvSpPr>
         <p:spPr>
           <a:xfrm>
-            <a:off x="5188647" y="2480540"/>
+            <a:off x="5188647" y="2300921"/>
             <a:ext cx="476250" cy="461665"/>
           </a:xfrm>
           <a:prstGeom prst="rect">
@@ -7645,7 +7792,7 @@
         </p:nvSpPr>
         <p:spPr>
           <a:xfrm>
-            <a:off x="3991909" y="2897891"/>
+            <a:off x="3991909" y="2718272"/>
             <a:ext cx="1570680" cy="400110"/>
           </a:xfrm>
           <a:prstGeom prst="rect">
@@ -7705,8 +7852,8 @@
         </p:blipFill>
         <p:spPr>
           <a:xfrm>
-            <a:off x="538547" y="2049705"/>
-            <a:ext cx="314325" cy="285750"/>
+            <a:off x="669178" y="1978946"/>
+            <a:ext cx="216000" cy="196364"/>
           </a:xfrm>
           <a:prstGeom prst="rect">
             <a:avLst/>
@@ -7727,7 +7874,7 @@
         </p:nvSpPr>
         <p:spPr>
           <a:xfrm>
-            <a:off x="2810238" y="2480540"/>
+            <a:off x="2810238" y="2300921"/>
             <a:ext cx="476250" cy="461665"/>
           </a:xfrm>
           <a:prstGeom prst="rect">
@@ -7801,7 +7948,7 @@
         </p:nvSpPr>
         <p:spPr>
           <a:xfrm>
-            <a:off x="7708478" y="1421116"/>
+            <a:off x="7521963" y="1373542"/>
             <a:ext cx="1448705" cy="293597"/>
           </a:xfrm>
           <a:prstGeom prst="rect">
@@ -7880,7 +8027,7 @@
         </p:nvSpPr>
         <p:spPr>
           <a:xfrm>
-            <a:off x="7036396" y="2312372"/>
+            <a:off x="6796915" y="2040230"/>
             <a:ext cx="476250" cy="400110"/>
           </a:xfrm>
           <a:prstGeom prst="rect">
@@ -7954,7 +8101,7 @@
         </p:nvSpPr>
         <p:spPr>
           <a:xfrm>
-            <a:off x="9916038" y="1373443"/>
+            <a:off x="9676557" y="1313570"/>
             <a:ext cx="2114946" cy="384721"/>
           </a:xfrm>
           <a:prstGeom prst="rect">
@@ -8042,7 +8189,7 @@
         </p:nvSpPr>
         <p:spPr>
           <a:xfrm>
-            <a:off x="7117416" y="2640276"/>
+            <a:off x="6877935" y="2361601"/>
             <a:ext cx="1623565" cy="246221"/>
           </a:xfrm>
           <a:prstGeom prst="rect">
@@ -8087,8 +8234,8 @@
         </p:nvSpPr>
         <p:spPr>
           <a:xfrm>
-            <a:off x="7117417" y="3015880"/>
-            <a:ext cx="3783575" cy="292388"/>
+            <a:off x="6877936" y="2800168"/>
+            <a:ext cx="4802440" cy="626666"/>
           </a:xfrm>
           <a:prstGeom prst="rect">
             <a:avLst/>
@@ -8096,8 +8243,8 @@
           <a:noFill/>
         </p:spPr>
         <p:txBody>
-          <a:bodyPr wrap="square">
-            <a:spAutoFit/>
+          <a:bodyPr wrap="square" anchor="ctr">
+            <a:noAutofit/>
           </a:bodyPr>
           <a:lstStyle/>
           <a:p>
@@ -8160,7 +8307,7 @@
         </p:nvSpPr>
         <p:spPr>
           <a:xfrm>
-            <a:off x="11677801" y="2312372"/>
+            <a:off x="11438320" y="2020092"/>
             <a:ext cx="476250" cy="400110"/>
           </a:xfrm>
           <a:prstGeom prst="rect">
@@ -8234,7 +8381,7 @@
         </p:nvSpPr>
         <p:spPr>
           <a:xfrm>
-            <a:off x="10460304" y="2673476"/>
+            <a:off x="10220823" y="2394801"/>
             <a:ext cx="1570680" cy="246221"/>
           </a:xfrm>
           <a:prstGeom prst="rect">
@@ -8280,7 +8427,7 @@
         </p:nvSpPr>
         <p:spPr>
           <a:xfrm>
-            <a:off x="9362518" y="2313475"/>
+            <a:off x="9123037" y="2034800"/>
             <a:ext cx="476250" cy="400110"/>
           </a:xfrm>
           <a:prstGeom prst="rect">
@@ -8368,7 +8515,7 @@
         </p:blipFill>
         <p:spPr>
           <a:xfrm>
-            <a:off x="7260931" y="1410222"/>
+            <a:off x="7021450" y="1350349"/>
             <a:ext cx="341505" cy="341505"/>
           </a:xfrm>
           <a:prstGeom prst="rect">
@@ -8404,8 +8551,8 @@
         </p:blipFill>
         <p:spPr>
           <a:xfrm>
-            <a:off x="7274521" y="2086826"/>
-            <a:ext cx="4652244" cy="234744"/>
+            <a:off x="7035040" y="1936062"/>
+            <a:ext cx="4645336" cy="144000"/>
           </a:xfrm>
           <a:prstGeom prst="rect">
             <a:avLst/>
@@ -8440,8 +8587,8 @@
         </p:blipFill>
         <p:spPr>
           <a:xfrm>
-            <a:off x="7235688" y="1950732"/>
-            <a:ext cx="224536" cy="204124"/>
+            <a:off x="6996207" y="1817384"/>
+            <a:ext cx="158400" cy="144000"/>
           </a:xfrm>
           <a:prstGeom prst="rect">
             <a:avLst/>
@@ -8462,7 +8609,7 @@
         </p:nvSpPr>
         <p:spPr>
           <a:xfrm>
-            <a:off x="7708478" y="4136354"/>
+            <a:off x="7521962" y="4084174"/>
             <a:ext cx="1448705" cy="293597"/>
           </a:xfrm>
           <a:prstGeom prst="rect">
@@ -8541,7 +8688,7 @@
         </p:nvSpPr>
         <p:spPr>
           <a:xfrm>
-            <a:off x="7036396" y="5027610"/>
+            <a:off x="6796915" y="4793569"/>
             <a:ext cx="476250" cy="400110"/>
           </a:xfrm>
           <a:prstGeom prst="rect">
@@ -8615,7 +8762,7 @@
         </p:nvSpPr>
         <p:spPr>
           <a:xfrm>
-            <a:off x="9916038" y="4088681"/>
+            <a:off x="9676557" y="4054207"/>
             <a:ext cx="2114946" cy="384721"/>
           </a:xfrm>
           <a:prstGeom prst="rect">
@@ -8703,7 +8850,7 @@
         </p:nvSpPr>
         <p:spPr>
           <a:xfrm>
-            <a:off x="7117416" y="5355514"/>
+            <a:off x="6877935" y="5148688"/>
             <a:ext cx="1623565" cy="246221"/>
           </a:xfrm>
           <a:prstGeom prst="rect">
@@ -8748,8 +8895,8 @@
         </p:nvSpPr>
         <p:spPr>
           <a:xfrm>
-            <a:off x="7117417" y="5731118"/>
-            <a:ext cx="3783575" cy="292388"/>
+            <a:off x="6877936" y="5611372"/>
+            <a:ext cx="4802440" cy="626400"/>
           </a:xfrm>
           <a:prstGeom prst="rect">
             <a:avLst/>
@@ -8757,8 +8904,8 @@
           <a:noFill/>
         </p:spPr>
         <p:txBody>
-          <a:bodyPr wrap="square">
-            <a:spAutoFit/>
+          <a:bodyPr wrap="square" anchor="ctr">
+            <a:noAutofit/>
           </a:bodyPr>
           <a:lstStyle/>
           <a:p>
@@ -8821,7 +8968,7 @@
         </p:nvSpPr>
         <p:spPr>
           <a:xfrm>
-            <a:off x="11677801" y="5027610"/>
+            <a:off x="11438320" y="4791141"/>
             <a:ext cx="476250" cy="400110"/>
           </a:xfrm>
           <a:prstGeom prst="rect">
@@ -8895,7 +9042,7 @@
         </p:nvSpPr>
         <p:spPr>
           <a:xfrm>
-            <a:off x="10058401" y="5388714"/>
+            <a:off x="9818920" y="5146779"/>
             <a:ext cx="1972584" cy="246221"/>
           </a:xfrm>
           <a:prstGeom prst="rect">
@@ -8941,7 +9088,7 @@
         </p:nvSpPr>
         <p:spPr>
           <a:xfrm>
-            <a:off x="9362518" y="5028713"/>
+            <a:off x="9123037" y="4794672"/>
             <a:ext cx="476250" cy="400110"/>
           </a:xfrm>
           <a:prstGeom prst="rect">
@@ -9029,8 +9176,8 @@
         </p:blipFill>
         <p:spPr>
           <a:xfrm>
-            <a:off x="7274522" y="4801306"/>
-            <a:ext cx="4652243" cy="241049"/>
+            <a:off x="7035041" y="4681560"/>
+            <a:ext cx="4645335" cy="144000"/>
           </a:xfrm>
           <a:prstGeom prst="rect">
             <a:avLst/>
@@ -9065,8 +9212,8 @@
         </p:blipFill>
         <p:spPr>
           <a:xfrm>
-            <a:off x="7235688" y="4665970"/>
-            <a:ext cx="224536" cy="204124"/>
+            <a:off x="6996207" y="4572348"/>
+            <a:ext cx="158400" cy="144000"/>
           </a:xfrm>
           <a:prstGeom prst="rect">
             <a:avLst/>
@@ -9101,7 +9248,7 @@
         </p:blipFill>
         <p:spPr>
           <a:xfrm>
-            <a:off x="7282033" y="4085263"/>
+            <a:off x="6996207" y="4054303"/>
             <a:ext cx="356382" cy="356382"/>
           </a:xfrm>
           <a:prstGeom prst="rect">

</xml_diff>

<commit_message>
feat: Ajout de la répartions des sols de l'analyse simplifiée
</commit_message>
<xml_diff>
--- a/public/templates/template_synthese_projet.pptx
+++ b/public/templates/template_synthese_projet.pptx
@@ -136,6 +136,831 @@
 </p188:authorLst>
 </file>
 
+<file path=ppt/charts/chart1.xml><?xml version="1.0" encoding="utf-8"?>
+<c:chartSpace xmlns:c="http://schemas.openxmlformats.org/drawingml/2006/chart" xmlns:a="http://schemas.openxmlformats.org/drawingml/2006/main" xmlns:r="http://schemas.openxmlformats.org/officeDocument/2006/relationships" xmlns:c16r2="http://schemas.microsoft.com/office/drawing/2015/06/chart">
+  <c:date1904 val="0"/>
+  <c:lang val="fr-FR"/>
+  <c:roundedCorners val="0"/>
+  <mc:AlternateContent xmlns:mc="http://schemas.openxmlformats.org/markup-compatibility/2006">
+    <mc:Choice xmlns:c14="http://schemas.microsoft.com/office/drawing/2007/8/2/chart" Requires="c14">
+      <c14:style val="102"/>
+    </mc:Choice>
+    <mc:Fallback>
+      <c:style val="2"/>
+    </mc:Fallback>
+  </mc:AlternateContent>
+  <c:chart>
+    <c:autoTitleDeleted val="1"/>
+    <c:plotArea>
+      <c:layout>
+        <c:manualLayout>
+          <c:layoutTarget val="inner"/>
+          <c:xMode val="edge"/>
+          <c:yMode val="edge"/>
+          <c:x val="1.9846415985298734E-2"/>
+          <c:y val="8.0223408122376008E-2"/>
+          <c:w val="0.23616668023587156"/>
+          <c:h val="0.83955318375524801"/>
+        </c:manualLayout>
+      </c:layout>
+      <c:pieChart>
+        <c:varyColors val="1"/>
+        <c:ser>
+          <c:idx val="0"/>
+          <c:order val="0"/>
+          <c:tx>
+            <c:strRef>
+              <c:f>Feuil1!$B$1</c:f>
+              <c:strCache>
+                <c:ptCount val="1"/>
+                <c:pt idx="0">
+                  <c:v>Part de la surface</c:v>
+                </c:pt>
+              </c:strCache>
+            </c:strRef>
+          </c:tx>
+          <c:dPt>
+            <c:idx val="0"/>
+            <c:bubble3D val="0"/>
+            <c:spPr>
+              <a:solidFill>
+                <a:srgbClr val="68687B"/>
+              </a:solidFill>
+              <a:ln w="19050">
+                <a:solidFill>
+                  <a:schemeClr val="lt1"/>
+                </a:solidFill>
+              </a:ln>
+              <a:effectLst/>
+            </c:spPr>
+            <c:extLst>
+              <c:ext xmlns:c16="http://schemas.microsoft.com/office/drawing/2014/chart" uri="{C3380CC4-5D6E-409C-BE32-E72D297353CC}">
+                <c16:uniqueId val="{00000001-5CDE-45E8-9302-526826EE6F41}"/>
+              </c:ext>
+            </c:extLst>
+          </c:dPt>
+          <c:dPt>
+            <c:idx val="1"/>
+            <c:bubble3D val="0"/>
+            <c:spPr>
+              <a:solidFill>
+                <a:srgbClr val="3B87FF"/>
+              </a:solidFill>
+              <a:ln w="19050">
+                <a:solidFill>
+                  <a:schemeClr val="lt1"/>
+                </a:solidFill>
+              </a:ln>
+              <a:effectLst/>
+            </c:spPr>
+            <c:extLst>
+              <c:ext xmlns:c16="http://schemas.microsoft.com/office/drawing/2014/chart" uri="{C3380CC4-5D6E-409C-BE32-E72D297353CC}">
+                <c16:uniqueId val="{00000003-5CDE-45E8-9302-526826EE6F41}"/>
+              </c:ext>
+            </c:extLst>
+          </c:dPt>
+          <c:dPt>
+            <c:idx val="2"/>
+            <c:bubble3D val="0"/>
+            <c:spPr>
+              <a:solidFill>
+                <a:srgbClr val="00A95F"/>
+              </a:solidFill>
+              <a:ln w="19050">
+                <a:solidFill>
+                  <a:schemeClr val="lt1"/>
+                </a:solidFill>
+              </a:ln>
+              <a:effectLst/>
+            </c:spPr>
+            <c:extLst>
+              <c:ext xmlns:c16="http://schemas.microsoft.com/office/drawing/2014/chart" uri="{C3380CC4-5D6E-409C-BE32-E72D297353CC}">
+                <c16:uniqueId val="{00000005-5CDE-45E8-9302-526826EE6F41}"/>
+              </c:ext>
+            </c:extLst>
+          </c:dPt>
+          <c:dPt>
+            <c:idx val="3"/>
+            <c:bubble3D val="0"/>
+            <c:spPr>
+              <a:solidFill>
+                <a:srgbClr val="B7B7D5"/>
+              </a:solidFill>
+              <a:ln w="19050">
+                <a:solidFill>
+                  <a:schemeClr val="lt1"/>
+                </a:solidFill>
+              </a:ln>
+              <a:effectLst/>
+            </c:spPr>
+            <c:extLst>
+              <c:ext xmlns:c16="http://schemas.microsoft.com/office/drawing/2014/chart" uri="{C3380CC4-5D6E-409C-BE32-E72D297353CC}">
+                <c16:uniqueId val="{00000007-5CDE-45E8-9302-526826EE6F41}"/>
+              </c:ext>
+            </c:extLst>
+          </c:dPt>
+          <c:cat>
+            <c:strRef>
+              <c:f>Feuil1!$A$2:$A$5</c:f>
+              <c:strCache>
+                <c:ptCount val="4"/>
+                <c:pt idx="0">
+                  <c:v>Revêtement de sol</c:v>
+                </c:pt>
+                <c:pt idx="1">
+                  <c:v>Fontainerie, bassins en eau</c:v>
+                </c:pt>
+                <c:pt idx="2">
+                  <c:v>Surface végétalisées au sol</c:v>
+                </c:pt>
+                <c:pt idx="3">
+                  <c:v>Toitures</c:v>
+                </c:pt>
+              </c:strCache>
+            </c:strRef>
+          </c:cat>
+          <c:val>
+            <c:numRef>
+              <c:f>Feuil1!$B$2:$B$5</c:f>
+              <c:numCache>
+                <c:formatCode>General</c:formatCode>
+                <c:ptCount val="4"/>
+                <c:pt idx="0">
+                  <c:v>8.1999999999999993</c:v>
+                </c:pt>
+                <c:pt idx="1">
+                  <c:v>3.2</c:v>
+                </c:pt>
+                <c:pt idx="2">
+                  <c:v>1.4</c:v>
+                </c:pt>
+                <c:pt idx="3">
+                  <c:v>1.2</c:v>
+                </c:pt>
+              </c:numCache>
+            </c:numRef>
+          </c:val>
+          <c:extLst>
+            <c:ext xmlns:c16="http://schemas.microsoft.com/office/drawing/2014/chart" uri="{C3380CC4-5D6E-409C-BE32-E72D297353CC}">
+              <c16:uniqueId val="{00000008-5CDE-45E8-9302-526826EE6F41}"/>
+            </c:ext>
+          </c:extLst>
+        </c:ser>
+        <c:dLbls>
+          <c:showLegendKey val="0"/>
+          <c:showVal val="0"/>
+          <c:showCatName val="0"/>
+          <c:showSerName val="0"/>
+          <c:showPercent val="0"/>
+          <c:showBubbleSize val="0"/>
+          <c:showLeaderLines val="1"/>
+        </c:dLbls>
+        <c:firstSliceAng val="0"/>
+      </c:pieChart>
+      <c:spPr>
+        <a:noFill/>
+        <a:ln>
+          <a:noFill/>
+        </a:ln>
+        <a:effectLst/>
+      </c:spPr>
+    </c:plotArea>
+    <c:legend>
+      <c:legendPos val="l"/>
+      <c:layout>
+        <c:manualLayout>
+          <c:xMode val="edge"/>
+          <c:yMode val="edge"/>
+          <c:x val="0.14162194394752534"/>
+          <c:y val="6.7400870685264097E-2"/>
+          <c:w val="0.79298350228582781"/>
+          <c:h val="0.85061161017051345"/>
+        </c:manualLayout>
+      </c:layout>
+      <c:overlay val="0"/>
+      <c:spPr>
+        <a:noFill/>
+        <a:ln>
+          <a:noFill/>
+        </a:ln>
+        <a:effectLst/>
+      </c:spPr>
+      <c:txPr>
+        <a:bodyPr rot="0" spcFirstLastPara="1" vertOverflow="ellipsis" vert="horz" wrap="square" anchor="ctr" anchorCtr="1"/>
+        <a:lstStyle/>
+        <a:p>
+          <a:pPr>
+            <a:defRPr sz="1197" b="0" i="0" u="none" strike="noStrike" kern="1200" baseline="0">
+              <a:solidFill>
+                <a:schemeClr val="tx1">
+                  <a:lumMod val="65000"/>
+                  <a:lumOff val="35000"/>
+                </a:schemeClr>
+              </a:solidFill>
+              <a:latin typeface="Marianne" panose="02000000000000000000" pitchFamily="50" charset="0"/>
+              <a:ea typeface="+mn-ea"/>
+              <a:cs typeface="+mn-cs"/>
+            </a:defRPr>
+          </a:pPr>
+          <a:endParaRPr lang="fr-FR"/>
+        </a:p>
+      </c:txPr>
+    </c:legend>
+    <c:plotVisOnly val="1"/>
+    <c:dispBlanksAs val="gap"/>
+    <c:extLst>
+      <c:ext xmlns:c16r3="http://schemas.microsoft.com/office/drawing/2017/03/chart" uri="{56B9EC1D-385E-4148-901F-78D8002777C0}">
+        <c16r3:dataDisplayOptions16>
+          <c16r3:dispNaAsBlank val="1"/>
+        </c16r3:dataDisplayOptions16>
+      </c:ext>
+    </c:extLst>
+    <c:showDLblsOverMax val="0"/>
+  </c:chart>
+  <c:spPr>
+    <a:noFill/>
+    <a:ln>
+      <a:noFill/>
+    </a:ln>
+    <a:effectLst/>
+  </c:spPr>
+  <c:txPr>
+    <a:bodyPr/>
+    <a:lstStyle/>
+    <a:p>
+      <a:pPr>
+        <a:defRPr>
+          <a:latin typeface="Marianne" panose="02000000000000000000" pitchFamily="50" charset="0"/>
+        </a:defRPr>
+      </a:pPr>
+      <a:endParaRPr lang="fr-FR"/>
+    </a:p>
+  </c:txPr>
+  <c:externalData r:id="rId3">
+    <c:autoUpdate val="0"/>
+  </c:externalData>
+</c:chartSpace>
+</file>
+
+<file path=ppt/charts/colors1.xml><?xml version="1.0" encoding="utf-8"?>
+<cs:colorStyle xmlns:cs="http://schemas.microsoft.com/office/drawing/2012/chartStyle" xmlns:a="http://schemas.openxmlformats.org/drawingml/2006/main" meth="cycle" id="10">
+  <a:schemeClr val="accent1"/>
+  <a:schemeClr val="accent2"/>
+  <a:schemeClr val="accent3"/>
+  <a:schemeClr val="accent4"/>
+  <a:schemeClr val="accent5"/>
+  <a:schemeClr val="accent6"/>
+  <cs:variation/>
+  <cs:variation>
+    <a:lumMod val="60000"/>
+  </cs:variation>
+  <cs:variation>
+    <a:lumMod val="80000"/>
+    <a:lumOff val="20000"/>
+  </cs:variation>
+  <cs:variation>
+    <a:lumMod val="80000"/>
+  </cs:variation>
+  <cs:variation>
+    <a:lumMod val="60000"/>
+    <a:lumOff val="40000"/>
+  </cs:variation>
+  <cs:variation>
+    <a:lumMod val="50000"/>
+  </cs:variation>
+  <cs:variation>
+    <a:lumMod val="70000"/>
+    <a:lumOff val="30000"/>
+  </cs:variation>
+  <cs:variation>
+    <a:lumMod val="70000"/>
+  </cs:variation>
+  <cs:variation>
+    <a:lumMod val="50000"/>
+    <a:lumOff val="50000"/>
+  </cs:variation>
+</cs:colorStyle>
+</file>
+
+<file path=ppt/charts/style1.xml><?xml version="1.0" encoding="utf-8"?>
+<cs:chartStyle xmlns:cs="http://schemas.microsoft.com/office/drawing/2012/chartStyle" xmlns:a="http://schemas.openxmlformats.org/drawingml/2006/main" id="251">
+  <cs:axisTitle>
+    <cs:lnRef idx="0"/>
+    <cs:fillRef idx="0"/>
+    <cs:effectRef idx="0"/>
+    <cs:fontRef idx="minor">
+      <a:schemeClr val="tx1">
+        <a:lumMod val="65000"/>
+        <a:lumOff val="35000"/>
+      </a:schemeClr>
+    </cs:fontRef>
+    <cs:defRPr sz="1330" kern="1200"/>
+  </cs:axisTitle>
+  <cs:categoryAxis>
+    <cs:lnRef idx="0"/>
+    <cs:fillRef idx="0"/>
+    <cs:effectRef idx="0"/>
+    <cs:fontRef idx="minor">
+      <a:schemeClr val="tx1">
+        <a:lumMod val="65000"/>
+        <a:lumOff val="35000"/>
+      </a:schemeClr>
+    </cs:fontRef>
+    <cs:spPr>
+      <a:ln w="9525" cap="flat" cmpd="sng" algn="ctr">
+        <a:solidFill>
+          <a:schemeClr val="tx1">
+            <a:lumMod val="15000"/>
+            <a:lumOff val="85000"/>
+          </a:schemeClr>
+        </a:solidFill>
+        <a:round/>
+      </a:ln>
+    </cs:spPr>
+    <cs:defRPr sz="1197" kern="1200"/>
+  </cs:categoryAxis>
+  <cs:chartArea mods="allowNoFillOverride allowNoLineOverride">
+    <cs:lnRef idx="0"/>
+    <cs:fillRef idx="0"/>
+    <cs:effectRef idx="0"/>
+    <cs:fontRef idx="minor">
+      <a:schemeClr val="tx1"/>
+    </cs:fontRef>
+    <cs:spPr>
+      <a:solidFill>
+        <a:schemeClr val="bg1"/>
+      </a:solidFill>
+      <a:ln w="9525" cap="flat" cmpd="sng" algn="ctr">
+        <a:solidFill>
+          <a:schemeClr val="tx1">
+            <a:lumMod val="15000"/>
+            <a:lumOff val="85000"/>
+          </a:schemeClr>
+        </a:solidFill>
+        <a:round/>
+      </a:ln>
+    </cs:spPr>
+    <cs:defRPr sz="1197" kern="1200"/>
+  </cs:chartArea>
+  <cs:dataLabel>
+    <cs:lnRef idx="0"/>
+    <cs:fillRef idx="0"/>
+    <cs:effectRef idx="0"/>
+    <cs:fontRef idx="minor">
+      <a:schemeClr val="tx1">
+        <a:lumMod val="75000"/>
+        <a:lumOff val="25000"/>
+      </a:schemeClr>
+    </cs:fontRef>
+    <cs:defRPr sz="1197" kern="1200"/>
+  </cs:dataLabel>
+  <cs:dataLabelCallout>
+    <cs:lnRef idx="0"/>
+    <cs:fillRef idx="0"/>
+    <cs:effectRef idx="0"/>
+    <cs:fontRef idx="minor">
+      <a:schemeClr val="dk1">
+        <a:lumMod val="65000"/>
+        <a:lumOff val="35000"/>
+      </a:schemeClr>
+    </cs:fontRef>
+    <cs:spPr>
+      <a:solidFill>
+        <a:schemeClr val="lt1"/>
+      </a:solidFill>
+      <a:ln>
+        <a:solidFill>
+          <a:schemeClr val="dk1">
+            <a:lumMod val="25000"/>
+            <a:lumOff val="75000"/>
+          </a:schemeClr>
+        </a:solidFill>
+      </a:ln>
+    </cs:spPr>
+    <cs:defRPr sz="1197" kern="1200"/>
+    <cs:bodyPr rot="0" spcFirstLastPara="1" vertOverflow="clip" horzOverflow="clip" vert="horz" wrap="square" lIns="36576" tIns="18288" rIns="36576" bIns="18288" anchor="ctr" anchorCtr="1">
+      <a:spAutoFit/>
+    </cs:bodyPr>
+  </cs:dataLabelCallout>
+  <cs:dataPoint>
+    <cs:lnRef idx="0"/>
+    <cs:fillRef idx="1">
+      <cs:styleClr val="auto"/>
+    </cs:fillRef>
+    <cs:effectRef idx="0"/>
+    <cs:fontRef idx="minor">
+      <a:schemeClr val="tx1"/>
+    </cs:fontRef>
+    <cs:spPr>
+      <a:ln w="19050">
+        <a:solidFill>
+          <a:schemeClr val="lt1"/>
+        </a:solidFill>
+      </a:ln>
+    </cs:spPr>
+  </cs:dataPoint>
+  <cs:dataPoint3D>
+    <cs:lnRef idx="0"/>
+    <cs:fillRef idx="1">
+      <cs:styleClr val="auto"/>
+    </cs:fillRef>
+    <cs:effectRef idx="0"/>
+    <cs:fontRef idx="minor">
+      <a:schemeClr val="tx1"/>
+    </cs:fontRef>
+    <cs:spPr>
+      <a:ln w="25400">
+        <a:solidFill>
+          <a:schemeClr val="lt1"/>
+        </a:solidFill>
+      </a:ln>
+    </cs:spPr>
+  </cs:dataPoint3D>
+  <cs:dataPointLine>
+    <cs:lnRef idx="0">
+      <cs:styleClr val="auto"/>
+    </cs:lnRef>
+    <cs:fillRef idx="0"/>
+    <cs:effectRef idx="0"/>
+    <cs:fontRef idx="minor">
+      <a:schemeClr val="tx1"/>
+    </cs:fontRef>
+    <cs:spPr>
+      <a:ln w="28575" cap="rnd">
+        <a:solidFill>
+          <a:schemeClr val="phClr"/>
+        </a:solidFill>
+        <a:round/>
+      </a:ln>
+    </cs:spPr>
+  </cs:dataPointLine>
+  <cs:dataPointMarker>
+    <cs:lnRef idx="0">
+      <cs:styleClr val="auto"/>
+    </cs:lnRef>
+    <cs:fillRef idx="1">
+      <cs:styleClr val="auto"/>
+    </cs:fillRef>
+    <cs:effectRef idx="0"/>
+    <cs:fontRef idx="minor">
+      <a:schemeClr val="tx1"/>
+    </cs:fontRef>
+    <cs:spPr>
+      <a:ln w="9525">
+        <a:solidFill>
+          <a:schemeClr val="phClr"/>
+        </a:solidFill>
+      </a:ln>
+    </cs:spPr>
+  </cs:dataPointMarker>
+  <cs:dataPointMarkerLayout symbol="circle" size="5"/>
+  <cs:dataPointWireframe>
+    <cs:lnRef idx="0">
+      <cs:styleClr val="auto"/>
+    </cs:lnRef>
+    <cs:fillRef idx="0"/>
+    <cs:effectRef idx="0"/>
+    <cs:fontRef idx="minor">
+      <a:schemeClr val="tx1"/>
+    </cs:fontRef>
+    <cs:spPr>
+      <a:ln w="9525" cap="rnd">
+        <a:solidFill>
+          <a:schemeClr val="phClr"/>
+        </a:solidFill>
+        <a:round/>
+      </a:ln>
+    </cs:spPr>
+  </cs:dataPointWireframe>
+  <cs:dataTable>
+    <cs:lnRef idx="0"/>
+    <cs:fillRef idx="0"/>
+    <cs:effectRef idx="0"/>
+    <cs:fontRef idx="minor">
+      <a:schemeClr val="tx1">
+        <a:lumMod val="65000"/>
+        <a:lumOff val="35000"/>
+      </a:schemeClr>
+    </cs:fontRef>
+    <cs:spPr>
+      <a:noFill/>
+      <a:ln w="9525" cap="flat" cmpd="sng" algn="ctr">
+        <a:solidFill>
+          <a:schemeClr val="tx1">
+            <a:lumMod val="15000"/>
+            <a:lumOff val="85000"/>
+          </a:schemeClr>
+        </a:solidFill>
+        <a:round/>
+      </a:ln>
+    </cs:spPr>
+    <cs:defRPr sz="1197" kern="1200"/>
+  </cs:dataTable>
+  <cs:downBar>
+    <cs:lnRef idx="0"/>
+    <cs:fillRef idx="0"/>
+    <cs:effectRef idx="0"/>
+    <cs:fontRef idx="minor">
+      <a:schemeClr val="tx1"/>
+    </cs:fontRef>
+    <cs:spPr>
+      <a:solidFill>
+        <a:schemeClr val="dk1">
+          <a:lumMod val="75000"/>
+          <a:lumOff val="25000"/>
+        </a:schemeClr>
+      </a:solidFill>
+      <a:ln w="9525" cap="flat" cmpd="sng" algn="ctr">
+        <a:solidFill>
+          <a:schemeClr val="tx1">
+            <a:lumMod val="65000"/>
+            <a:lumOff val="35000"/>
+          </a:schemeClr>
+        </a:solidFill>
+        <a:round/>
+      </a:ln>
+    </cs:spPr>
+  </cs:downBar>
+  <cs:dropLine>
+    <cs:lnRef idx="0"/>
+    <cs:fillRef idx="0"/>
+    <cs:effectRef idx="0"/>
+    <cs:fontRef idx="minor">
+      <a:schemeClr val="tx1"/>
+    </cs:fontRef>
+    <cs:spPr>
+      <a:ln w="9525" cap="flat" cmpd="sng" algn="ctr">
+        <a:solidFill>
+          <a:schemeClr val="tx1">
+            <a:lumMod val="35000"/>
+            <a:lumOff val="65000"/>
+          </a:schemeClr>
+        </a:solidFill>
+        <a:round/>
+      </a:ln>
+    </cs:spPr>
+  </cs:dropLine>
+  <cs:errorBar>
+    <cs:lnRef idx="0"/>
+    <cs:fillRef idx="0"/>
+    <cs:effectRef idx="0"/>
+    <cs:fontRef idx="minor">
+      <a:schemeClr val="tx1"/>
+    </cs:fontRef>
+    <cs:spPr>
+      <a:ln w="9525" cap="flat" cmpd="sng" algn="ctr">
+        <a:solidFill>
+          <a:schemeClr val="tx1">
+            <a:lumMod val="65000"/>
+            <a:lumOff val="35000"/>
+          </a:schemeClr>
+        </a:solidFill>
+        <a:round/>
+      </a:ln>
+    </cs:spPr>
+  </cs:errorBar>
+  <cs:floor>
+    <cs:lnRef idx="0"/>
+    <cs:fillRef idx="0"/>
+    <cs:effectRef idx="0"/>
+    <cs:fontRef idx="minor">
+      <a:schemeClr val="tx1"/>
+    </cs:fontRef>
+    <cs:spPr>
+      <a:noFill/>
+      <a:ln>
+        <a:noFill/>
+      </a:ln>
+    </cs:spPr>
+  </cs:floor>
+  <cs:gridlineMajor>
+    <cs:lnRef idx="0"/>
+    <cs:fillRef idx="0"/>
+    <cs:effectRef idx="0"/>
+    <cs:fontRef idx="minor">
+      <a:schemeClr val="tx1"/>
+    </cs:fontRef>
+    <cs:spPr>
+      <a:ln w="9525" cap="flat" cmpd="sng" algn="ctr">
+        <a:solidFill>
+          <a:schemeClr val="tx1">
+            <a:lumMod val="15000"/>
+            <a:lumOff val="85000"/>
+          </a:schemeClr>
+        </a:solidFill>
+        <a:round/>
+      </a:ln>
+    </cs:spPr>
+  </cs:gridlineMajor>
+  <cs:gridlineMinor>
+    <cs:lnRef idx="0"/>
+    <cs:fillRef idx="0"/>
+    <cs:effectRef idx="0"/>
+    <cs:fontRef idx="minor">
+      <a:schemeClr val="tx1"/>
+    </cs:fontRef>
+    <cs:spPr>
+      <a:ln w="9525" cap="flat" cmpd="sng" algn="ctr">
+        <a:solidFill>
+          <a:schemeClr val="tx1">
+            <a:lumMod val="5000"/>
+            <a:lumOff val="95000"/>
+          </a:schemeClr>
+        </a:solidFill>
+        <a:round/>
+      </a:ln>
+    </cs:spPr>
+  </cs:gridlineMinor>
+  <cs:hiLoLine>
+    <cs:lnRef idx="0"/>
+    <cs:fillRef idx="0"/>
+    <cs:effectRef idx="0"/>
+    <cs:fontRef idx="minor">
+      <a:schemeClr val="tx1"/>
+    </cs:fontRef>
+    <cs:spPr>
+      <a:ln w="9525" cap="flat" cmpd="sng" algn="ctr">
+        <a:solidFill>
+          <a:schemeClr val="tx1">
+            <a:lumMod val="50000"/>
+            <a:lumOff val="50000"/>
+          </a:schemeClr>
+        </a:solidFill>
+        <a:round/>
+      </a:ln>
+    </cs:spPr>
+  </cs:hiLoLine>
+  <cs:leaderLine>
+    <cs:lnRef idx="0"/>
+    <cs:fillRef idx="0"/>
+    <cs:effectRef idx="0"/>
+    <cs:fontRef idx="minor">
+      <a:schemeClr val="tx1"/>
+    </cs:fontRef>
+    <cs:spPr>
+      <a:ln w="9525" cap="flat" cmpd="sng" algn="ctr">
+        <a:solidFill>
+          <a:schemeClr val="tx1">
+            <a:lumMod val="35000"/>
+            <a:lumOff val="65000"/>
+          </a:schemeClr>
+        </a:solidFill>
+        <a:round/>
+      </a:ln>
+    </cs:spPr>
+  </cs:leaderLine>
+  <cs:legend>
+    <cs:lnRef idx="0"/>
+    <cs:fillRef idx="0"/>
+    <cs:effectRef idx="0"/>
+    <cs:fontRef idx="minor">
+      <a:schemeClr val="tx1">
+        <a:lumMod val="65000"/>
+        <a:lumOff val="35000"/>
+      </a:schemeClr>
+    </cs:fontRef>
+    <cs:defRPr sz="1197" kern="1200"/>
+  </cs:legend>
+  <cs:plotArea mods="allowNoFillOverride allowNoLineOverride">
+    <cs:lnRef idx="0"/>
+    <cs:fillRef idx="0"/>
+    <cs:effectRef idx="0"/>
+    <cs:fontRef idx="minor">
+      <a:schemeClr val="tx1"/>
+    </cs:fontRef>
+  </cs:plotArea>
+  <cs:plotArea3D mods="allowNoFillOverride allowNoLineOverride">
+    <cs:lnRef idx="0"/>
+    <cs:fillRef idx="0"/>
+    <cs:effectRef idx="0"/>
+    <cs:fontRef idx="minor">
+      <a:schemeClr val="tx1"/>
+    </cs:fontRef>
+  </cs:plotArea3D>
+  <cs:seriesAxis>
+    <cs:lnRef idx="0"/>
+    <cs:fillRef idx="0"/>
+    <cs:effectRef idx="0"/>
+    <cs:fontRef idx="minor">
+      <a:schemeClr val="tx1">
+        <a:lumMod val="65000"/>
+        <a:lumOff val="35000"/>
+      </a:schemeClr>
+    </cs:fontRef>
+    <cs:defRPr sz="1197" kern="1200"/>
+  </cs:seriesAxis>
+  <cs:seriesLine>
+    <cs:lnRef idx="0"/>
+    <cs:fillRef idx="0"/>
+    <cs:effectRef idx="0"/>
+    <cs:fontRef idx="minor">
+      <a:schemeClr val="tx1"/>
+    </cs:fontRef>
+    <cs:spPr>
+      <a:ln w="9525" cap="flat" cmpd="sng" algn="ctr">
+        <a:solidFill>
+          <a:schemeClr val="tx1">
+            <a:lumMod val="35000"/>
+            <a:lumOff val="65000"/>
+          </a:schemeClr>
+        </a:solidFill>
+        <a:round/>
+      </a:ln>
+    </cs:spPr>
+  </cs:seriesLine>
+  <cs:title>
+    <cs:lnRef idx="0"/>
+    <cs:fillRef idx="0"/>
+    <cs:effectRef idx="0"/>
+    <cs:fontRef idx="minor">
+      <a:schemeClr val="tx1">
+        <a:lumMod val="65000"/>
+        <a:lumOff val="35000"/>
+      </a:schemeClr>
+    </cs:fontRef>
+    <cs:defRPr sz="1862" b="0" kern="1200" spc="0" baseline="0"/>
+  </cs:title>
+  <cs:trendline>
+    <cs:lnRef idx="0">
+      <cs:styleClr val="auto"/>
+    </cs:lnRef>
+    <cs:fillRef idx="0"/>
+    <cs:effectRef idx="0"/>
+    <cs:fontRef idx="minor">
+      <a:schemeClr val="tx1"/>
+    </cs:fontRef>
+    <cs:spPr>
+      <a:ln w="19050" cap="rnd">
+        <a:solidFill>
+          <a:schemeClr val="phClr"/>
+        </a:solidFill>
+        <a:prstDash val="sysDot"/>
+      </a:ln>
+    </cs:spPr>
+  </cs:trendline>
+  <cs:trendlineLabel>
+    <cs:lnRef idx="0"/>
+    <cs:fillRef idx="0"/>
+    <cs:effectRef idx="0"/>
+    <cs:fontRef idx="minor">
+      <a:schemeClr val="tx1">
+        <a:lumMod val="65000"/>
+        <a:lumOff val="35000"/>
+      </a:schemeClr>
+    </cs:fontRef>
+    <cs:defRPr sz="1197" kern="1200"/>
+  </cs:trendlineLabel>
+  <cs:upBar>
+    <cs:lnRef idx="0"/>
+    <cs:fillRef idx="0"/>
+    <cs:effectRef idx="0"/>
+    <cs:fontRef idx="minor">
+      <a:schemeClr val="tx1"/>
+    </cs:fontRef>
+    <cs:spPr>
+      <a:solidFill>
+        <a:schemeClr val="lt1"/>
+      </a:solidFill>
+      <a:ln w="9525" cap="flat" cmpd="sng" algn="ctr">
+        <a:solidFill>
+          <a:schemeClr val="tx1">
+            <a:lumMod val="65000"/>
+            <a:lumOff val="35000"/>
+          </a:schemeClr>
+        </a:solidFill>
+        <a:round/>
+      </a:ln>
+    </cs:spPr>
+  </cs:upBar>
+  <cs:valueAxis>
+    <cs:lnRef idx="0"/>
+    <cs:fillRef idx="0"/>
+    <cs:effectRef idx="0"/>
+    <cs:fontRef idx="minor">
+      <a:schemeClr val="tx1">
+        <a:lumMod val="65000"/>
+        <a:lumOff val="35000"/>
+      </a:schemeClr>
+    </cs:fontRef>
+    <cs:defRPr sz="1197" kern="1200"/>
+  </cs:valueAxis>
+  <cs:wall>
+    <cs:lnRef idx="0"/>
+    <cs:fillRef idx="0"/>
+    <cs:effectRef idx="0"/>
+    <cs:fontRef idx="minor">
+      <a:schemeClr val="tx1"/>
+    </cs:fontRef>
+    <cs:spPr>
+      <a:noFill/>
+      <a:ln>
+        <a:noFill/>
+      </a:ln>
+    </cs:spPr>
+  </cs:wall>
+</cs:chartStyle>
+</file>
+
 <file path=ppt/notesMasters/notesMaster1.xml><?xml version="1.0" encoding="utf-8"?>
 <p:notesMaster xmlns:a="http://schemas.openxmlformats.org/drawingml/2006/main" xmlns:r="http://schemas.openxmlformats.org/officeDocument/2006/relationships" xmlns:p="http://schemas.openxmlformats.org/presentationml/2006/main">
   <p:cSld>
@@ -218,7 +1043,7 @@
           <a:p>
             <a:fld id="{4C638A9C-6ED0-4718-B5E7-9D405962C144}" type="datetimeFigureOut">
               <a:rPr lang="fr-FR" smtClean="0"/>
-              <a:t>02/10/2026</a:t>
+              <a:t>05/10/2026</a:t>
             </a:fld>
             <a:endParaRPr lang="fr-FR"/>
           </a:p>
@@ -1172,7 +1997,7 @@
           <a:p>
             <a:fld id="{82E7F8B9-DFDB-4965-877D-C04A580740C9}" type="datetimeFigureOut">
               <a:rPr lang="fr-FR" smtClean="0"/>
-              <a:t>02/10/2026</a:t>
+              <a:t>05/10/2026</a:t>
             </a:fld>
             <a:endParaRPr lang="fr-FR"/>
           </a:p>
@@ -1370,7 +2195,7 @@
           <a:p>
             <a:fld id="{82E7F8B9-DFDB-4965-877D-C04A580740C9}" type="datetimeFigureOut">
               <a:rPr lang="fr-FR" smtClean="0"/>
-              <a:t>02/10/2026</a:t>
+              <a:t>05/10/2026</a:t>
             </a:fld>
             <a:endParaRPr lang="fr-FR"/>
           </a:p>
@@ -1578,7 +2403,7 @@
           <a:p>
             <a:fld id="{82E7F8B9-DFDB-4965-877D-C04A580740C9}" type="datetimeFigureOut">
               <a:rPr lang="fr-FR" smtClean="0"/>
-              <a:t>02/10/2026</a:t>
+              <a:t>05/10/2026</a:t>
             </a:fld>
             <a:endParaRPr lang="fr-FR"/>
           </a:p>
@@ -1811,7 +2636,7 @@
           <a:p>
             <a:fld id="{82E7F8B9-DFDB-4965-877D-C04A580740C9}" type="datetimeFigureOut">
               <a:rPr lang="fr-FR" smtClean="0"/>
-              <a:t>02/10/2026</a:t>
+              <a:t>05/10/2026</a:t>
             </a:fld>
             <a:endParaRPr lang="fr-FR"/>
           </a:p>
@@ -2086,7 +2911,7 @@
           <a:p>
             <a:fld id="{82E7F8B9-DFDB-4965-877D-C04A580740C9}" type="datetimeFigureOut">
               <a:rPr lang="fr-FR" smtClean="0"/>
-              <a:t>02/10/2026</a:t>
+              <a:t>05/10/2026</a:t>
             </a:fld>
             <a:endParaRPr lang="fr-FR"/>
           </a:p>
@@ -2351,7 +3176,7 @@
           <a:p>
             <a:fld id="{82E7F8B9-DFDB-4965-877D-C04A580740C9}" type="datetimeFigureOut">
               <a:rPr lang="fr-FR" smtClean="0"/>
-              <a:t>02/10/2026</a:t>
+              <a:t>05/10/2026</a:t>
             </a:fld>
             <a:endParaRPr lang="fr-FR"/>
           </a:p>
@@ -2763,7 +3588,7 @@
           <a:p>
             <a:fld id="{82E7F8B9-DFDB-4965-877D-C04A580740C9}" type="datetimeFigureOut">
               <a:rPr lang="fr-FR" smtClean="0"/>
-              <a:t>02/10/2026</a:t>
+              <a:t>05/10/2026</a:t>
             </a:fld>
             <a:endParaRPr lang="fr-FR"/>
           </a:p>
@@ -2904,7 +3729,7 @@
           <a:p>
             <a:fld id="{82E7F8B9-DFDB-4965-877D-C04A580740C9}" type="datetimeFigureOut">
               <a:rPr lang="fr-FR" smtClean="0"/>
-              <a:t>02/10/2026</a:t>
+              <a:t>05/10/2026</a:t>
             </a:fld>
             <a:endParaRPr lang="fr-FR"/>
           </a:p>
@@ -3017,7 +3842,7 @@
           <a:p>
             <a:fld id="{82E7F8B9-DFDB-4965-877D-C04A580740C9}" type="datetimeFigureOut">
               <a:rPr lang="fr-FR" smtClean="0"/>
-              <a:t>02/10/2026</a:t>
+              <a:t>05/10/2026</a:t>
             </a:fld>
             <a:endParaRPr lang="fr-FR"/>
           </a:p>
@@ -3328,7 +4153,7 @@
           <a:p>
             <a:fld id="{82E7F8B9-DFDB-4965-877D-C04A580740C9}" type="datetimeFigureOut">
               <a:rPr lang="fr-FR" smtClean="0"/>
-              <a:t>02/10/2026</a:t>
+              <a:t>05/10/2026</a:t>
             </a:fld>
             <a:endParaRPr lang="fr-FR"/>
           </a:p>
@@ -3616,7 +4441,7 @@
           <a:p>
             <a:fld id="{82E7F8B9-DFDB-4965-877D-C04A580740C9}" type="datetimeFigureOut">
               <a:rPr lang="fr-FR" smtClean="0"/>
-              <a:t>02/10/2026</a:t>
+              <a:t>05/10/2026</a:t>
             </a:fld>
             <a:endParaRPr lang="fr-FR"/>
           </a:p>
@@ -3857,7 +4682,7 @@
           <a:p>
             <a:fld id="{82E7F8B9-DFDB-4965-877D-C04A580740C9}" type="datetimeFigureOut">
               <a:rPr lang="fr-FR" smtClean="0"/>
-              <a:t>02/10/2026</a:t>
+              <a:t>05/10/2026</a:t>
             </a:fld>
             <a:endParaRPr lang="fr-FR"/>
           </a:p>
@@ -6782,10 +7607,10 @@
       </p:grpSpPr>
       <p:sp>
         <p:nvSpPr>
-          <p:cNvPr id="85" name="contour_perm">
-            <a:extLst>
-              <a:ext uri="{FF2B5EF4-FFF2-40B4-BE49-F238E27FC236}">
-                <a16:creationId xmlns:a16="http://schemas.microsoft.com/office/drawing/2014/main" id="{D8AB42B7-DFFF-113D-D131-7B6AAD2B2A4C}"/>
+          <p:cNvPr id="6" name="contour_repartition_sols">
+            <a:extLst>
+              <a:ext uri="{FF2B5EF4-FFF2-40B4-BE49-F238E27FC236}">
+                <a16:creationId xmlns:a16="http://schemas.microsoft.com/office/drawing/2014/main" id="{0D2AE75D-32A2-EB1F-7572-7DA83777F56E}"/>
               </a:ext>
             </a:extLst>
           </p:cNvPr>
@@ -6794,8 +7619,8 @@
         </p:nvSpPr>
         <p:spPr>
           <a:xfrm>
-            <a:off x="6765679" y="1071248"/>
-            <a:ext cx="5203163" cy="2512121"/>
+            <a:off x="297861" y="4332617"/>
+            <a:ext cx="5639453" cy="2010443"/>
           </a:xfrm>
           <a:prstGeom prst="roundRect">
             <a:avLst>
@@ -6831,10 +7656,10 @@
       </p:sp>
       <p:sp>
         <p:nvSpPr>
-          <p:cNvPr id="86" name="contour_bio">
-            <a:extLst>
-              <a:ext uri="{FF2B5EF4-FFF2-40B4-BE49-F238E27FC236}">
-                <a16:creationId xmlns:a16="http://schemas.microsoft.com/office/drawing/2014/main" id="{4D12FAD2-60A4-A6E4-0DB5-C47B2328B29F}"/>
+          <p:cNvPr id="85" name="contour_perm">
+            <a:extLst>
+              <a:ext uri="{FF2B5EF4-FFF2-40B4-BE49-F238E27FC236}">
+                <a16:creationId xmlns:a16="http://schemas.microsoft.com/office/drawing/2014/main" id="{D8AB42B7-DFFF-113D-D131-7B6AAD2B2A4C}"/>
               </a:ext>
             </a:extLst>
           </p:cNvPr>
@@ -6843,8 +7668,8 @@
         </p:nvSpPr>
         <p:spPr>
           <a:xfrm>
-            <a:off x="6765680" y="3850116"/>
-            <a:ext cx="5203162" cy="2526413"/>
+            <a:off x="6765679" y="1071248"/>
+            <a:ext cx="5203163" cy="2512121"/>
           </a:xfrm>
           <a:prstGeom prst="roundRect">
             <a:avLst>
@@ -6880,10 +7705,10 @@
       </p:sp>
       <p:sp>
         <p:nvSpPr>
-          <p:cNvPr id="84" name="contour_materiau">
-            <a:extLst>
-              <a:ext uri="{FF2B5EF4-FFF2-40B4-BE49-F238E27FC236}">
-                <a16:creationId xmlns:a16="http://schemas.microsoft.com/office/drawing/2014/main" id="{CBC5F1D2-8720-ABCF-DB73-04E78162FDA4}"/>
+          <p:cNvPr id="86" name="contour_bio">
+            <a:extLst>
+              <a:ext uri="{FF2B5EF4-FFF2-40B4-BE49-F238E27FC236}">
+                <a16:creationId xmlns:a16="http://schemas.microsoft.com/office/drawing/2014/main" id="{4D12FAD2-60A4-A6E4-0DB5-C47B2328B29F}"/>
               </a:ext>
             </a:extLst>
           </p:cNvPr>
@@ -6892,8 +7717,8 @@
         </p:nvSpPr>
         <p:spPr>
           <a:xfrm>
-            <a:off x="293261" y="1080537"/>
-            <a:ext cx="5639453" cy="3132233"/>
+            <a:off x="6765680" y="3850116"/>
+            <a:ext cx="5203162" cy="2526413"/>
           </a:xfrm>
           <a:prstGeom prst="roundRect">
             <a:avLst>
@@ -6927,6 +7752,55 @@
           </a:p>
         </p:txBody>
       </p:sp>
+      <p:sp>
+        <p:nvSpPr>
+          <p:cNvPr id="84" name="contour_materiau">
+            <a:extLst>
+              <a:ext uri="{FF2B5EF4-FFF2-40B4-BE49-F238E27FC236}">
+                <a16:creationId xmlns:a16="http://schemas.microsoft.com/office/drawing/2014/main" id="{CBC5F1D2-8720-ABCF-DB73-04E78162FDA4}"/>
+              </a:ext>
+            </a:extLst>
+          </p:cNvPr>
+          <p:cNvSpPr/>
+          <p:nvPr/>
+        </p:nvSpPr>
+        <p:spPr>
+          <a:xfrm>
+            <a:off x="293261" y="1080537"/>
+            <a:ext cx="5639453" cy="3132233"/>
+          </a:xfrm>
+          <a:prstGeom prst="roundRect">
+            <a:avLst>
+              <a:gd name="adj" fmla="val 5926"/>
+            </a:avLst>
+          </a:prstGeom>
+          <a:solidFill>
+            <a:srgbClr val="FFFFFF"/>
+          </a:solidFill>
+          <a:ln w="8890">
+            <a:solidFill>
+              <a:srgbClr val="DADADA"/>
+            </a:solidFill>
+            <a:prstDash val="solid"/>
+          </a:ln>
+          <a:effectLst>
+            <a:outerShdw blurRad="76200" dist="25400" dir="2700000" algn="bl" rotWithShape="0">
+              <a:srgbClr val="000000">
+                <a:alpha val="8000"/>
+              </a:srgbClr>
+            </a:outerShdw>
+          </a:effectLst>
+        </p:spPr>
+        <p:txBody>
+          <a:bodyPr/>
+          <a:lstStyle/>
+          <a:p>
+            <a:endParaRPr lang="fr-FR">
+              <a:latin typeface="Marianne" panose="02000000000000000000" pitchFamily="50" charset="0"/>
+            </a:endParaRPr>
+          </a:p>
+        </p:txBody>
+      </p:sp>
       <p:pic>
         <p:nvPicPr>
           <p:cNvPr id="4" name="Picture 3">
@@ -9256,6 +10130,34 @@
           </a:prstGeom>
         </p:spPr>
       </p:pic>
+      <p:graphicFrame>
+        <p:nvGraphicFramePr>
+          <p:cNvPr id="5" name="graph_repartition_sols">
+            <a:extLst>
+              <a:ext uri="{FF2B5EF4-FFF2-40B4-BE49-F238E27FC236}">
+                <a16:creationId xmlns:a16="http://schemas.microsoft.com/office/drawing/2014/main" id="{0AF920CF-9639-5B00-C9CB-30F812DB23D7}"/>
+              </a:ext>
+            </a:extLst>
+          </p:cNvPr>
+          <p:cNvGraphicFramePr/>
+          <p:nvPr>
+            <p:extLst>
+              <p:ext uri="{D42A27DB-BD31-4B8C-83A1-F6EECF244321}">
+                <p14:modId xmlns:p14="http://schemas.microsoft.com/office/powerpoint/2010/main" val="3062099625"/>
+              </p:ext>
+            </p:extLst>
+          </p:nvPr>
+        </p:nvGraphicFramePr>
+        <p:xfrm>
+          <a:off x="646093" y="4492187"/>
+          <a:ext cx="5111496" cy="1741387"/>
+        </p:xfrm>
+        <a:graphic>
+          <a:graphicData uri="http://schemas.openxmlformats.org/drawingml/2006/chart">
+            <c:chart xmlns:c="http://schemas.openxmlformats.org/drawingml/2006/chart" xmlns:r="http://schemas.openxmlformats.org/officeDocument/2006/relationships" r:id="rId17"/>
+          </a:graphicData>
+        </a:graphic>
+      </p:graphicFrame>
     </p:spTree>
     <p:extLst>
       <p:ext uri="{BB962C8B-B14F-4D97-AF65-F5344CB8AC3E}">

</xml_diff>

<commit_message>
feat: Ajout de la part de canopée et suppression des ligne vide dans la répartition des sols
</commit_message>
<xml_diff>
--- a/public/templates/template_synthese_projet.pptx
+++ b/public/templates/template_synthese_projet.pptx
@@ -7607,10 +7607,10 @@
       </p:grpSpPr>
       <p:sp>
         <p:nvSpPr>
-          <p:cNvPr id="6" name="contour_repartition_sols">
-            <a:extLst>
-              <a:ext uri="{FF2B5EF4-FFF2-40B4-BE49-F238E27FC236}">
-                <a16:creationId xmlns:a16="http://schemas.microsoft.com/office/drawing/2014/main" id="{0D2AE75D-32A2-EB1F-7572-7DA83777F56E}"/>
+          <p:cNvPr id="7" name="contour_canopee">
+            <a:extLst>
+              <a:ext uri="{FF2B5EF4-FFF2-40B4-BE49-F238E27FC236}">
+                <a16:creationId xmlns:a16="http://schemas.microsoft.com/office/drawing/2014/main" id="{F95FED42-B0A2-735D-296C-CFCC43A0A0FA}"/>
               </a:ext>
             </a:extLst>
           </p:cNvPr>
@@ -7619,8 +7619,58 @@
         </p:nvSpPr>
         <p:spPr>
           <a:xfrm>
-            <a:off x="297861" y="4332617"/>
-            <a:ext cx="5639453" cy="2010443"/>
+            <a:off x="6765679" y="5731684"/>
+            <a:ext cx="5224238" cy="635648"/>
+          </a:xfrm>
+          <a:prstGeom prst="roundRect">
+            <a:avLst>
+              <a:gd name="adj" fmla="val 14417"/>
+            </a:avLst>
+          </a:prstGeom>
+          <a:solidFill>
+            <a:srgbClr val="FFFFFF"/>
+          </a:solidFill>
+          <a:ln w="8890">
+            <a:solidFill>
+              <a:srgbClr val="DADADA"/>
+            </a:solidFill>
+            <a:prstDash val="solid"/>
+            <a:round/>
+          </a:ln>
+          <a:effectLst>
+            <a:outerShdw blurRad="76200" dist="25400" dir="2700000" algn="bl" rotWithShape="0">
+              <a:srgbClr val="000000">
+                <a:alpha val="8000"/>
+              </a:srgbClr>
+            </a:outerShdw>
+          </a:effectLst>
+        </p:spPr>
+        <p:txBody>
+          <a:bodyPr/>
+          <a:lstStyle/>
+          <a:p>
+            <a:endParaRPr lang="fr-FR" dirty="0">
+              <a:latin typeface="Marianne" panose="02000000000000000000" pitchFamily="50" charset="0"/>
+            </a:endParaRPr>
+          </a:p>
+        </p:txBody>
+      </p:sp>
+      <p:sp>
+        <p:nvSpPr>
+          <p:cNvPr id="6" name="contour_repartition_sols">
+            <a:extLst>
+              <a:ext uri="{FF2B5EF4-FFF2-40B4-BE49-F238E27FC236}">
+                <a16:creationId xmlns:a16="http://schemas.microsoft.com/office/drawing/2014/main" id="{0D2AE75D-32A2-EB1F-7572-7DA83777F56E}"/>
+              </a:ext>
+            </a:extLst>
+          </p:cNvPr>
+          <p:cNvSpPr/>
+          <p:nvPr/>
+        </p:nvSpPr>
+        <p:spPr>
+          <a:xfrm>
+            <a:off x="576019" y="4332617"/>
+            <a:ext cx="5639453" cy="2034716"/>
           </a:xfrm>
           <a:prstGeom prst="roundRect">
             <a:avLst>
@@ -7668,8 +7718,8 @@
         </p:nvSpPr>
         <p:spPr>
           <a:xfrm>
-            <a:off x="6765679" y="1071248"/>
-            <a:ext cx="5203163" cy="2512121"/>
+            <a:off x="6765679" y="1071249"/>
+            <a:ext cx="5203163" cy="2399096"/>
           </a:xfrm>
           <a:prstGeom prst="roundRect">
             <a:avLst>
@@ -7717,8 +7767,8 @@
         </p:nvSpPr>
         <p:spPr>
           <a:xfrm>
-            <a:off x="6765680" y="3850116"/>
-            <a:ext cx="5203162" cy="2526413"/>
+            <a:off x="6765680" y="3574989"/>
+            <a:ext cx="5203162" cy="2047194"/>
           </a:xfrm>
           <a:prstGeom prst="roundRect">
             <a:avLst>
@@ -7766,7 +7816,7 @@
         </p:nvSpPr>
         <p:spPr>
           <a:xfrm>
-            <a:off x="293261" y="1080537"/>
+            <a:off x="571419" y="1080537"/>
             <a:ext cx="5639453" cy="3132233"/>
           </a:xfrm>
           <a:prstGeom prst="roundRect">
@@ -8001,7 +8051,7 @@
         </p:nvSpPr>
         <p:spPr>
           <a:xfrm>
-            <a:off x="1037765" y="1361243"/>
+            <a:off x="1315923" y="1361243"/>
             <a:ext cx="3244745" cy="293597"/>
           </a:xfrm>
           <a:prstGeom prst="rect">
@@ -8240,7 +8290,7 @@
         </p:nvSpPr>
         <p:spPr>
           <a:xfrm>
-            <a:off x="413637" y="2300921"/>
+            <a:off x="691795" y="2300921"/>
             <a:ext cx="476250" cy="461665"/>
           </a:xfrm>
           <a:prstGeom prst="rect">
@@ -8314,7 +8364,7 @@
         </p:nvSpPr>
         <p:spPr>
           <a:xfrm>
-            <a:off x="2759529" y="1277671"/>
+            <a:off x="3037687" y="1277671"/>
             <a:ext cx="2799701" cy="553998"/>
           </a:xfrm>
           <a:prstGeom prst="rect">
@@ -8402,7 +8452,7 @@
         </p:nvSpPr>
         <p:spPr>
           <a:xfrm>
-            <a:off x="508248" y="2707349"/>
+            <a:off x="786406" y="2707349"/>
             <a:ext cx="1570680" cy="400110"/>
           </a:xfrm>
           <a:prstGeom prst="rect">
@@ -8447,7 +8497,7 @@
         </p:nvSpPr>
         <p:spPr>
           <a:xfrm>
-            <a:off x="508248" y="3270769"/>
+            <a:off x="786406" y="3270769"/>
             <a:ext cx="4929167" cy="772073"/>
           </a:xfrm>
           <a:prstGeom prst="rect">
@@ -8534,7 +8584,7 @@
         </p:blipFill>
         <p:spPr>
           <a:xfrm>
-            <a:off x="575412" y="1291419"/>
+            <a:off x="853570" y="1291419"/>
             <a:ext cx="421353" cy="421353"/>
           </a:xfrm>
           <a:prstGeom prst="rect">
@@ -8570,7 +8620,7 @@
         </p:blipFill>
         <p:spPr>
           <a:xfrm>
-            <a:off x="651764" y="2123630"/>
+            <a:off x="929922" y="2123630"/>
             <a:ext cx="4800145" cy="216000"/>
           </a:xfrm>
           <a:prstGeom prst="rect">
@@ -8592,7 +8642,7 @@
         </p:nvSpPr>
         <p:spPr>
           <a:xfrm>
-            <a:off x="5188647" y="2300921"/>
+            <a:off x="5466805" y="2300921"/>
             <a:ext cx="476250" cy="461665"/>
           </a:xfrm>
           <a:prstGeom prst="rect">
@@ -8666,7 +8716,7 @@
         </p:nvSpPr>
         <p:spPr>
           <a:xfrm>
-            <a:off x="3991909" y="2718272"/>
+            <a:off x="4270067" y="2718272"/>
             <a:ext cx="1570680" cy="400110"/>
           </a:xfrm>
           <a:prstGeom prst="rect">
@@ -8726,7 +8776,7 @@
         </p:blipFill>
         <p:spPr>
           <a:xfrm>
-            <a:off x="669178" y="1978946"/>
+            <a:off x="947336" y="1978946"/>
             <a:ext cx="216000" cy="196364"/>
           </a:xfrm>
           <a:prstGeom prst="rect">
@@ -8748,7 +8798,7 @@
         </p:nvSpPr>
         <p:spPr>
           <a:xfrm>
-            <a:off x="2810238" y="2300921"/>
+            <a:off x="3088396" y="2300921"/>
             <a:ext cx="476250" cy="461665"/>
           </a:xfrm>
           <a:prstGeom prst="rect">
@@ -8822,7 +8872,7 @@
         </p:nvSpPr>
         <p:spPr>
           <a:xfrm>
-            <a:off x="7521963" y="1373542"/>
+            <a:off x="7521963" y="1284530"/>
             <a:ext cx="1448705" cy="293597"/>
           </a:xfrm>
           <a:prstGeom prst="rect">
@@ -8901,7 +8951,7 @@
         </p:nvSpPr>
         <p:spPr>
           <a:xfrm>
-            <a:off x="6796915" y="2040230"/>
+            <a:off x="6796915" y="1951218"/>
             <a:ext cx="476250" cy="400110"/>
           </a:xfrm>
           <a:prstGeom prst="rect">
@@ -8975,7 +9025,7 @@
         </p:nvSpPr>
         <p:spPr>
           <a:xfrm>
-            <a:off x="9676557" y="1313570"/>
+            <a:off x="9676557" y="1224558"/>
             <a:ext cx="2114946" cy="384721"/>
           </a:xfrm>
           <a:prstGeom prst="rect">
@@ -9063,7 +9113,7 @@
         </p:nvSpPr>
         <p:spPr>
           <a:xfrm>
-            <a:off x="6877935" y="2361601"/>
+            <a:off x="6877935" y="2272589"/>
             <a:ext cx="1623565" cy="246221"/>
           </a:xfrm>
           <a:prstGeom prst="rect">
@@ -9108,8 +9158,8 @@
         </p:nvSpPr>
         <p:spPr>
           <a:xfrm>
-            <a:off x="6877936" y="2800168"/>
-            <a:ext cx="4802440" cy="626666"/>
+            <a:off x="6877935" y="2711156"/>
+            <a:ext cx="5020803" cy="626666"/>
           </a:xfrm>
           <a:prstGeom prst="rect">
             <a:avLst/>
@@ -9181,7 +9231,7 @@
         </p:nvSpPr>
         <p:spPr>
           <a:xfrm>
-            <a:off x="11438320" y="2020092"/>
+            <a:off x="11438320" y="1931080"/>
             <a:ext cx="476250" cy="400110"/>
           </a:xfrm>
           <a:prstGeom prst="rect">
@@ -9255,7 +9305,7 @@
         </p:nvSpPr>
         <p:spPr>
           <a:xfrm>
-            <a:off x="10220823" y="2394801"/>
+            <a:off x="10220823" y="2305789"/>
             <a:ext cx="1570680" cy="246221"/>
           </a:xfrm>
           <a:prstGeom prst="rect">
@@ -9301,7 +9351,7 @@
         </p:nvSpPr>
         <p:spPr>
           <a:xfrm>
-            <a:off x="9123037" y="2034800"/>
+            <a:off x="9123037" y="1945788"/>
             <a:ext cx="476250" cy="400110"/>
           </a:xfrm>
           <a:prstGeom prst="rect">
@@ -9389,7 +9439,7 @@
         </p:blipFill>
         <p:spPr>
           <a:xfrm>
-            <a:off x="7021450" y="1350349"/>
+            <a:off x="7021450" y="1261337"/>
             <a:ext cx="341505" cy="341505"/>
           </a:xfrm>
           <a:prstGeom prst="rect">
@@ -9425,7 +9475,7 @@
         </p:blipFill>
         <p:spPr>
           <a:xfrm>
-            <a:off x="7035040" y="1936062"/>
+            <a:off x="7035040" y="1847050"/>
             <a:ext cx="4645336" cy="144000"/>
           </a:xfrm>
           <a:prstGeom prst="rect">
@@ -9461,7 +9511,7 @@
         </p:blipFill>
         <p:spPr>
           <a:xfrm>
-            <a:off x="6996207" y="1817384"/>
+            <a:off x="6996207" y="1728372"/>
             <a:ext cx="158400" cy="144000"/>
           </a:xfrm>
           <a:prstGeom prst="rect">
@@ -9483,7 +9533,7 @@
         </p:nvSpPr>
         <p:spPr>
           <a:xfrm>
-            <a:off x="7521962" y="4084174"/>
+            <a:off x="7521962" y="3809046"/>
             <a:ext cx="1448705" cy="293597"/>
           </a:xfrm>
           <a:prstGeom prst="rect">
@@ -9562,7 +9612,7 @@
         </p:nvSpPr>
         <p:spPr>
           <a:xfrm>
-            <a:off x="6796915" y="4793569"/>
+            <a:off x="6796915" y="4518441"/>
             <a:ext cx="476250" cy="400110"/>
           </a:xfrm>
           <a:prstGeom prst="rect">
@@ -9636,7 +9686,7 @@
         </p:nvSpPr>
         <p:spPr>
           <a:xfrm>
-            <a:off x="9676557" y="4054207"/>
+            <a:off x="9676557" y="3779079"/>
             <a:ext cx="2114946" cy="384721"/>
           </a:xfrm>
           <a:prstGeom prst="rect">
@@ -9724,7 +9774,7 @@
         </p:nvSpPr>
         <p:spPr>
           <a:xfrm>
-            <a:off x="6877935" y="5148688"/>
+            <a:off x="6877935" y="4873560"/>
             <a:ext cx="1623565" cy="246221"/>
           </a:xfrm>
           <a:prstGeom prst="rect">
@@ -9769,8 +9819,8 @@
         </p:nvSpPr>
         <p:spPr>
           <a:xfrm>
-            <a:off x="6877936" y="5611372"/>
-            <a:ext cx="4802440" cy="626400"/>
+            <a:off x="6877936" y="5150128"/>
+            <a:ext cx="5036634" cy="400110"/>
           </a:xfrm>
           <a:prstGeom prst="rect">
             <a:avLst/>
@@ -9842,7 +9892,7 @@
         </p:nvSpPr>
         <p:spPr>
           <a:xfrm>
-            <a:off x="11438320" y="4791141"/>
+            <a:off x="11438320" y="4516013"/>
             <a:ext cx="476250" cy="400110"/>
           </a:xfrm>
           <a:prstGeom prst="rect">
@@ -9916,7 +9966,7 @@
         </p:nvSpPr>
         <p:spPr>
           <a:xfrm>
-            <a:off x="9818920" y="5146779"/>
+            <a:off x="9818920" y="4871651"/>
             <a:ext cx="1972584" cy="246221"/>
           </a:xfrm>
           <a:prstGeom prst="rect">
@@ -9962,7 +10012,7 @@
         </p:nvSpPr>
         <p:spPr>
           <a:xfrm>
-            <a:off x="9123037" y="4794672"/>
+            <a:off x="9123037" y="4519544"/>
             <a:ext cx="476250" cy="400110"/>
           </a:xfrm>
           <a:prstGeom prst="rect">
@@ -10050,7 +10100,7 @@
         </p:blipFill>
         <p:spPr>
           <a:xfrm>
-            <a:off x="7035041" y="4681560"/>
+            <a:off x="7035041" y="4406432"/>
             <a:ext cx="4645335" cy="144000"/>
           </a:xfrm>
           <a:prstGeom prst="rect">
@@ -10086,7 +10136,7 @@
         </p:blipFill>
         <p:spPr>
           <a:xfrm>
-            <a:off x="6996207" y="4572348"/>
+            <a:off x="6996207" y="4297220"/>
             <a:ext cx="158400" cy="144000"/>
           </a:xfrm>
           <a:prstGeom prst="rect">
@@ -10122,7 +10172,7 @@
         </p:blipFill>
         <p:spPr>
           <a:xfrm>
-            <a:off x="6996207" y="4054303"/>
+            <a:off x="6996207" y="3779175"/>
             <a:ext cx="356382" cy="356382"/>
           </a:xfrm>
           <a:prstGeom prst="rect">
@@ -10143,13 +10193,13 @@
           <p:nvPr>
             <p:extLst>
               <p:ext uri="{D42A27DB-BD31-4B8C-83A1-F6EECF244321}">
-                <p14:modId xmlns:p14="http://schemas.microsoft.com/office/powerpoint/2010/main" val="3062099625"/>
+                <p14:modId xmlns:p14="http://schemas.microsoft.com/office/powerpoint/2010/main" val="1063930955"/>
               </p:ext>
             </p:extLst>
           </p:nvPr>
         </p:nvGraphicFramePr>
         <p:xfrm>
-          <a:off x="646093" y="4492187"/>
+          <a:off x="924251" y="4492187"/>
           <a:ext cx="5111496" cy="1741387"/>
         </p:xfrm>
         <a:graphic>
@@ -10158,6 +10208,165 @@
           </a:graphicData>
         </a:graphic>
       </p:graphicFrame>
+      <p:pic>
+        <p:nvPicPr>
+          <p:cNvPr id="9" name="Graphique 8">
+            <a:extLst>
+              <a:ext uri="{FF2B5EF4-FFF2-40B4-BE49-F238E27FC236}">
+                <a16:creationId xmlns:a16="http://schemas.microsoft.com/office/drawing/2014/main" id="{9FC59258-4FDC-0D81-1836-EEE964C64B8A}"/>
+              </a:ext>
+            </a:extLst>
+          </p:cNvPr>
+          <p:cNvPicPr>
+            <a:picLocks noChangeAspect="1"/>
+          </p:cNvPicPr>
+          <p:nvPr/>
+        </p:nvPicPr>
+        <p:blipFill>
+          <a:blip r:embed="rId18">
+            <a:extLst>
+              <a:ext uri="{96DAC541-7B7A-43D3-8B79-37D633B846F1}">
+                <asvg:svgBlip xmlns:asvg="http://schemas.microsoft.com/office/drawing/2016/SVG/main" r:embed="rId19"/>
+              </a:ext>
+            </a:extLst>
+          </a:blip>
+          <a:stretch>
+            <a:fillRect/>
+          </a:stretch>
+        </p:blipFill>
+        <p:spPr>
+          <a:xfrm>
+            <a:off x="6972020" y="5868400"/>
+            <a:ext cx="365174" cy="365174"/>
+          </a:xfrm>
+          <a:prstGeom prst="rect">
+            <a:avLst/>
+          </a:prstGeom>
+        </p:spPr>
+      </p:pic>
+      <p:sp>
+        <p:nvSpPr>
+          <p:cNvPr id="10" name="zone_coeff_perm_resultat">
+            <a:extLst>
+              <a:ext uri="{FF2B5EF4-FFF2-40B4-BE49-F238E27FC236}">
+                <a16:creationId xmlns:a16="http://schemas.microsoft.com/office/drawing/2014/main" id="{47D0A265-4A87-0334-794C-6E4DEAD28CEB}"/>
+              </a:ext>
+            </a:extLst>
+          </p:cNvPr>
+          <p:cNvSpPr txBox="1"/>
+          <p:nvPr/>
+        </p:nvSpPr>
+        <p:spPr>
+          <a:xfrm>
+            <a:off x="7496273" y="5903314"/>
+            <a:ext cx="2114946" cy="292388"/>
+          </a:xfrm>
+          <a:prstGeom prst="rect">
+            <a:avLst/>
+          </a:prstGeom>
+          <a:noFill/>
+        </p:spPr>
+        <p:txBody>
+          <a:bodyPr wrap="square">
+            <a:spAutoFit/>
+          </a:bodyPr>
+          <a:lstStyle/>
+          <a:p>
+            <a:r>
+              <a:rPr lang="fr-FR" sz="1300" b="1" dirty="0">
+                <a:solidFill>
+                  <a:srgbClr val="78719E"/>
+                </a:solidFill>
+                <a:latin typeface="Marianne" panose="02000000000000000000" pitchFamily="50" charset="0"/>
+                <a:ea typeface="Calibri" panose="020F0502020204030204" pitchFamily="34" charset="0"/>
+                <a:cs typeface="Calibri" panose="020F0502020204030204" pitchFamily="34" charset="0"/>
+              </a:rPr>
+              <a:t>Part de canopée</a:t>
+            </a:r>
+            <a:endParaRPr lang="fr-FR" sz="1300" dirty="0">
+              <a:solidFill>
+                <a:srgbClr val="78719E"/>
+              </a:solidFill>
+              <a:latin typeface="Marianne" panose="02000000000000000000" pitchFamily="50" charset="0"/>
+              <a:ea typeface="Calibri" panose="020F0502020204030204" pitchFamily="34" charset="0"/>
+              <a:cs typeface="Calibri" panose="020F0502020204030204" pitchFamily="34" charset="0"/>
+            </a:endParaRPr>
+          </a:p>
+        </p:txBody>
+      </p:sp>
+      <p:sp>
+        <p:nvSpPr>
+          <p:cNvPr id="11" name="zone_part_canopee">
+            <a:extLst>
+              <a:ext uri="{FF2B5EF4-FFF2-40B4-BE49-F238E27FC236}">
+                <a16:creationId xmlns:a16="http://schemas.microsoft.com/office/drawing/2014/main" id="{86B3A8A4-B45A-AE9E-A72D-98678271ECC0}"/>
+              </a:ext>
+            </a:extLst>
+          </p:cNvPr>
+          <p:cNvSpPr txBox="1"/>
+          <p:nvPr/>
+        </p:nvSpPr>
+        <p:spPr>
+          <a:xfrm>
+            <a:off x="9313933" y="5857574"/>
+            <a:ext cx="2548752" cy="353943"/>
+          </a:xfrm>
+          <a:prstGeom prst="rect">
+            <a:avLst/>
+          </a:prstGeom>
+          <a:noFill/>
+        </p:spPr>
+        <p:txBody>
+          <a:bodyPr wrap="square">
+            <a:spAutoFit/>
+          </a:bodyPr>
+          <a:lstStyle/>
+          <a:p>
+            <a:pPr algn="r"/>
+            <a:r>
+              <a:rPr lang="fr-FR" sz="1700" b="1" dirty="0">
+                <a:solidFill>
+                  <a:srgbClr val="78719E"/>
+                </a:solidFill>
+                <a:latin typeface="Marianne" panose="02000000000000000000" pitchFamily="50" charset="0"/>
+                <a:ea typeface="Calibri" panose="020F0502020204030204" pitchFamily="34" charset="0"/>
+                <a:cs typeface="Calibri" panose="020F0502020204030204" pitchFamily="34" charset="0"/>
+              </a:rPr>
+              <a:t>{{</a:t>
+            </a:r>
+            <a:r>
+              <a:rPr lang="fr-FR" sz="1700" b="1" dirty="0" err="1">
+                <a:solidFill>
+                  <a:srgbClr val="78719E"/>
+                </a:solidFill>
+                <a:latin typeface="Marianne" panose="02000000000000000000" pitchFamily="50" charset="0"/>
+                <a:ea typeface="Calibri" panose="020F0502020204030204" pitchFamily="34" charset="0"/>
+                <a:cs typeface="Calibri" panose="020F0502020204030204" pitchFamily="34" charset="0"/>
+              </a:rPr>
+              <a:t>part_canopee</a:t>
+            </a:r>
+            <a:r>
+              <a:rPr lang="fr-FR" sz="1700" b="1" dirty="0">
+                <a:solidFill>
+                  <a:srgbClr val="78719E"/>
+                </a:solidFill>
+                <a:latin typeface="Marianne" panose="02000000000000000000" pitchFamily="50" charset="0"/>
+                <a:ea typeface="Calibri" panose="020F0502020204030204" pitchFamily="34" charset="0"/>
+                <a:cs typeface="Calibri" panose="020F0502020204030204" pitchFamily="34" charset="0"/>
+              </a:rPr>
+              <a:t>}} %</a:t>
+            </a:r>
+            <a:endParaRPr lang="fr-FR" sz="1700" dirty="0">
+              <a:solidFill>
+                <a:srgbClr val="78719E"/>
+              </a:solidFill>
+              <a:latin typeface="Marianne" panose="02000000000000000000" pitchFamily="50" charset="0"/>
+              <a:ea typeface="Calibri" panose="020F0502020204030204" pitchFamily="34" charset="0"/>
+              <a:cs typeface="Calibri" panose="020F0502020204030204" pitchFamily="34" charset="0"/>
+            </a:endParaRPr>
+          </a:p>
+        </p:txBody>
+      </p:sp>
     </p:spTree>
     <p:extLst>
       <p:ext uri="{BB962C8B-B14F-4D97-AF65-F5344CB8AC3E}">

</xml_diff>

<commit_message>
feat: correction du template ppt pour ouverture sur Mac
</commit_message>
<xml_diff>
--- a/public/templates/template_synthese_projet.pptx
+++ b/public/templates/template_synthese_projet.pptx
@@ -6895,8 +6895,8 @@
         </p:nvSpPr>
         <p:spPr>
           <a:xfrm>
-            <a:off x="576263" y="1093598"/>
-            <a:ext cx="9706988" cy="400110"/>
+            <a:off x="576262" y="1093598"/>
+            <a:ext cx="11040307" cy="400110"/>
           </a:xfrm>
           <a:prstGeom prst="rect">
             <a:avLst/>
@@ -7619,8 +7619,8 @@
         </p:nvSpPr>
         <p:spPr>
           <a:xfrm>
-            <a:off x="6765679" y="5731684"/>
-            <a:ext cx="5224238" cy="635648"/>
+            <a:off x="6765678" y="5731683"/>
+            <a:ext cx="5203163" cy="648121"/>
           </a:xfrm>
           <a:prstGeom prst="roundRect">
             <a:avLst>
@@ -7669,8 +7669,8 @@
         </p:nvSpPr>
         <p:spPr>
           <a:xfrm>
-            <a:off x="576019" y="4332617"/>
-            <a:ext cx="5639453" cy="2034716"/>
+            <a:off x="571419" y="4332616"/>
+            <a:ext cx="5644054" cy="2047191"/>
           </a:xfrm>
           <a:prstGeom prst="roundRect">
             <a:avLst>
@@ -7816,8 +7816,8 @@
         </p:nvSpPr>
         <p:spPr>
           <a:xfrm>
-            <a:off x="571419" y="1080537"/>
-            <a:ext cx="5639453" cy="3132233"/>
+            <a:off x="571420" y="1071249"/>
+            <a:ext cx="5644054" cy="3141521"/>
           </a:xfrm>
           <a:prstGeom prst="roundRect">
             <a:avLst>
@@ -8558,76 +8558,621 @@
       </p:sp>
       <p:pic>
         <p:nvPicPr>
-          <p:cNvPr id="19" name="Graphique 18">
-            <a:extLst>
-              <a:ext uri="{FF2B5EF4-FFF2-40B4-BE49-F238E27FC236}">
-                <a16:creationId xmlns:a16="http://schemas.microsoft.com/office/drawing/2014/main" id="{7F04C829-FC9E-0D50-4C89-B26887E9A256}"/>
+          <p:cNvPr id="16" name="zone_coeff_ru_echelle">
+            <a:extLst>
+              <a:ext uri="{FF2B5EF4-FFF2-40B4-BE49-F238E27FC236}">
+                <a16:creationId xmlns:a16="http://schemas.microsoft.com/office/drawing/2014/main" id="{E3986F26-9F61-CA16-0FD9-A0550DCD1CFD}"/>
               </a:ext>
             </a:extLst>
           </p:cNvPr>
           <p:cNvPicPr>
-            <a:picLocks noChangeAspect="1"/>
+            <a:picLocks/>
           </p:cNvPicPr>
           <p:nvPr/>
         </p:nvPicPr>
         <p:blipFill>
-          <a:blip r:embed="rId3">
-            <a:extLst>
-              <a:ext uri="{96DAC541-7B7A-43D3-8B79-37D633B846F1}">
-                <asvg:svgBlip xmlns:asvg="http://schemas.microsoft.com/office/drawing/2016/SVG/main" r:embed="rId4"/>
-              </a:ext>
-            </a:extLst>
-          </a:blip>
+          <a:blip r:embed="rId3"/>
           <a:stretch>
             <a:fillRect/>
           </a:stretch>
         </p:blipFill>
         <p:spPr>
           <a:xfrm>
-            <a:off x="853570" y="1291419"/>
-            <a:ext cx="421353" cy="421353"/>
+            <a:off x="928800" y="2124000"/>
+            <a:ext cx="4798800" cy="216000"/>
           </a:xfrm>
           <a:prstGeom prst="rect">
             <a:avLst/>
           </a:prstGeom>
         </p:spPr>
       </p:pic>
-      <p:pic>
-        <p:nvPicPr>
-          <p:cNvPr id="22" name="zone_coeff_ru_echelle">
-            <a:extLst>
-              <a:ext uri="{FF2B5EF4-FFF2-40B4-BE49-F238E27FC236}">
-                <a16:creationId xmlns:a16="http://schemas.microsoft.com/office/drawing/2014/main" id="{76E8F867-23AD-C898-638B-48FE80B6F75A}"/>
-              </a:ext>
-            </a:extLst>
-          </p:cNvPr>
-          <p:cNvPicPr>
-            <a:picLocks/>
-          </p:cNvPicPr>
+      <p:sp>
+        <p:nvSpPr>
+          <p:cNvPr id="17" name="Graphique 18">
+            <a:extLst>
+              <a:ext uri="{FF2B5EF4-FFF2-40B4-BE49-F238E27FC236}">
+                <a16:creationId xmlns:a16="http://schemas.microsoft.com/office/drawing/2014/main" id="{7F04C829-FC9E-0D50-4C89-B26887E9A256}"/>
+              </a:ext>
+            </a:extLst>
+          </p:cNvPr>
+          <p:cNvSpPr/>
           <p:nvPr/>
-        </p:nvPicPr>
-        <p:blipFill>
-          <a:blip r:embed="rId5">
-            <a:extLst>
-              <a:ext uri="{96DAC541-7B7A-43D3-8B79-37D633B846F1}">
-                <asvg:svgBlip xmlns:asvg="http://schemas.microsoft.com/office/drawing/2016/SVG/main" r:embed="rId6"/>
-              </a:ext>
-            </a:extLst>
-          </a:blip>
-          <a:stretch>
-            <a:fillRect/>
-          </a:stretch>
-        </p:blipFill>
+        </p:nvSpPr>
         <p:spPr>
           <a:xfrm>
-            <a:off x="929922" y="2123630"/>
-            <a:ext cx="4800145" cy="216000"/>
+            <a:off x="944450" y="1291419"/>
+            <a:ext cx="231331" cy="421352"/>
           </a:xfrm>
-          <a:prstGeom prst="rect">
+          <a:custGeom>
             <a:avLst/>
-          </a:prstGeom>
+            <a:gdLst>
+              <a:gd name="connsiteX0" fmla="*/ 168541 w 231331"/>
+              <a:gd name="connsiteY0" fmla="*/ 83444 h 421352"/>
+              <a:gd name="connsiteX1" fmla="*/ 158627 w 231331"/>
+              <a:gd name="connsiteY1" fmla="*/ 74356 h 421352"/>
+              <a:gd name="connsiteX2" fmla="*/ 168541 w 231331"/>
+              <a:gd name="connsiteY2" fmla="*/ 65268 h 421352"/>
+              <a:gd name="connsiteX3" fmla="*/ 221417 w 231331"/>
+              <a:gd name="connsiteY3" fmla="*/ 65268 h 421352"/>
+              <a:gd name="connsiteX4" fmla="*/ 231331 w 231331"/>
+              <a:gd name="connsiteY4" fmla="*/ 74356 h 421352"/>
+              <a:gd name="connsiteX5" fmla="*/ 221417 w 231331"/>
+              <a:gd name="connsiteY5" fmla="*/ 83444 h 421352"/>
+              <a:gd name="connsiteX6" fmla="*/ 26438 w 231331"/>
+              <a:gd name="connsiteY6" fmla="*/ 50397 h 421352"/>
+              <a:gd name="connsiteX7" fmla="*/ 82618 w 231331"/>
+              <a:gd name="connsiteY7" fmla="*/ 0 h 421352"/>
+              <a:gd name="connsiteX8" fmla="*/ 138799 w 231331"/>
+              <a:gd name="connsiteY8" fmla="*/ 50397 h 421352"/>
+              <a:gd name="connsiteX9" fmla="*/ 138799 w 231331"/>
+              <a:gd name="connsiteY9" fmla="*/ 292469 h 421352"/>
+              <a:gd name="connsiteX10" fmla="*/ 165236 w 231331"/>
+              <a:gd name="connsiteY10" fmla="*/ 346997 h 421352"/>
+              <a:gd name="connsiteX11" fmla="*/ 82618 w 231331"/>
+              <a:gd name="connsiteY11" fmla="*/ 421353 h 421352"/>
+              <a:gd name="connsiteX12" fmla="*/ 0 w 231331"/>
+              <a:gd name="connsiteY12" fmla="*/ 346997 h 421352"/>
+              <a:gd name="connsiteX13" fmla="*/ 26438 w 231331"/>
+              <a:gd name="connsiteY13" fmla="*/ 292469 h 421352"/>
+              <a:gd name="connsiteX14" fmla="*/ 46266 w 231331"/>
+              <a:gd name="connsiteY14" fmla="*/ 301557 h 421352"/>
+              <a:gd name="connsiteX15" fmla="*/ 42961 w 231331"/>
+              <a:gd name="connsiteY15" fmla="*/ 304035 h 421352"/>
+              <a:gd name="connsiteX16" fmla="*/ 19828 w 231331"/>
+              <a:gd name="connsiteY16" fmla="*/ 347823 h 421352"/>
+              <a:gd name="connsiteX17" fmla="*/ 82618 w 231331"/>
+              <a:gd name="connsiteY17" fmla="*/ 404003 h 421352"/>
+              <a:gd name="connsiteX18" fmla="*/ 145408 w 231331"/>
+              <a:gd name="connsiteY18" fmla="*/ 347823 h 421352"/>
+              <a:gd name="connsiteX19" fmla="*/ 122275 w 231331"/>
+              <a:gd name="connsiteY19" fmla="*/ 304035 h 421352"/>
+              <a:gd name="connsiteX20" fmla="*/ 118970 w 231331"/>
+              <a:gd name="connsiteY20" fmla="*/ 301557 h 421352"/>
+              <a:gd name="connsiteX21" fmla="*/ 118970 w 231331"/>
+              <a:gd name="connsiteY21" fmla="*/ 50397 h 421352"/>
+              <a:gd name="connsiteX22" fmla="*/ 82618 w 231331"/>
+              <a:gd name="connsiteY22" fmla="*/ 18176 h 421352"/>
+              <a:gd name="connsiteX23" fmla="*/ 46266 w 231331"/>
+              <a:gd name="connsiteY23" fmla="*/ 50397 h 421352"/>
+              <a:gd name="connsiteX24" fmla="*/ 46266 w 231331"/>
+              <a:gd name="connsiteY24" fmla="*/ 301557 h 421352"/>
+              <a:gd name="connsiteX25" fmla="*/ 167715 w 231331"/>
+              <a:gd name="connsiteY25" fmla="*/ 261074 h 421352"/>
+              <a:gd name="connsiteX26" fmla="*/ 157801 w 231331"/>
+              <a:gd name="connsiteY26" fmla="*/ 251986 h 421352"/>
+              <a:gd name="connsiteX27" fmla="*/ 167715 w 231331"/>
+              <a:gd name="connsiteY27" fmla="*/ 243724 h 421352"/>
+              <a:gd name="connsiteX28" fmla="*/ 220591 w 231331"/>
+              <a:gd name="connsiteY28" fmla="*/ 243724 h 421352"/>
+              <a:gd name="connsiteX29" fmla="*/ 231331 w 231331"/>
+              <a:gd name="connsiteY29" fmla="*/ 251986 h 421352"/>
+              <a:gd name="connsiteX30" fmla="*/ 220591 w 231331"/>
+              <a:gd name="connsiteY30" fmla="*/ 261074 h 421352"/>
+              <a:gd name="connsiteX31" fmla="*/ 167715 w 231331"/>
+              <a:gd name="connsiteY31" fmla="*/ 202415 h 421352"/>
+              <a:gd name="connsiteX32" fmla="*/ 157801 w 231331"/>
+              <a:gd name="connsiteY32" fmla="*/ 193327 h 421352"/>
+              <a:gd name="connsiteX33" fmla="*/ 167715 w 231331"/>
+              <a:gd name="connsiteY33" fmla="*/ 184239 h 421352"/>
+              <a:gd name="connsiteX34" fmla="*/ 221417 w 231331"/>
+              <a:gd name="connsiteY34" fmla="*/ 184239 h 421352"/>
+              <a:gd name="connsiteX35" fmla="*/ 231331 w 231331"/>
+              <a:gd name="connsiteY35" fmla="*/ 193327 h 421352"/>
+              <a:gd name="connsiteX36" fmla="*/ 221417 w 231331"/>
+              <a:gd name="connsiteY36" fmla="*/ 202415 h 421352"/>
+              <a:gd name="connsiteX37" fmla="*/ 167715 w 231331"/>
+              <a:gd name="connsiteY37" fmla="*/ 142930 h 421352"/>
+              <a:gd name="connsiteX38" fmla="*/ 156975 w 231331"/>
+              <a:gd name="connsiteY38" fmla="*/ 133842 h 421352"/>
+              <a:gd name="connsiteX39" fmla="*/ 167715 w 231331"/>
+              <a:gd name="connsiteY39" fmla="*/ 124754 h 421352"/>
+              <a:gd name="connsiteX40" fmla="*/ 220591 w 231331"/>
+              <a:gd name="connsiteY40" fmla="*/ 124754 h 421352"/>
+              <a:gd name="connsiteX41" fmla="*/ 230505 w 231331"/>
+              <a:gd name="connsiteY41" fmla="*/ 133842 h 421352"/>
+              <a:gd name="connsiteX42" fmla="*/ 220591 w 231331"/>
+              <a:gd name="connsiteY42" fmla="*/ 142930 h 421352"/>
+              <a:gd name="connsiteX43" fmla="*/ 71878 w 231331"/>
+              <a:gd name="connsiteY43" fmla="*/ 309818 h 421352"/>
+              <a:gd name="connsiteX44" fmla="*/ 71878 w 231331"/>
+              <a:gd name="connsiteY44" fmla="*/ 190022 h 421352"/>
+              <a:gd name="connsiteX45" fmla="*/ 81792 w 231331"/>
+              <a:gd name="connsiteY45" fmla="*/ 180934 h 421352"/>
+              <a:gd name="connsiteX46" fmla="*/ 91706 w 231331"/>
+              <a:gd name="connsiteY46" fmla="*/ 190022 h 421352"/>
+              <a:gd name="connsiteX47" fmla="*/ 91706 w 231331"/>
+              <a:gd name="connsiteY47" fmla="*/ 309818 h 421352"/>
+              <a:gd name="connsiteX48" fmla="*/ 124754 w 231331"/>
+              <a:gd name="connsiteY48" fmla="*/ 347823 h 421352"/>
+              <a:gd name="connsiteX49" fmla="*/ 81792 w 231331"/>
+              <a:gd name="connsiteY49" fmla="*/ 385827 h 421352"/>
+              <a:gd name="connsiteX50" fmla="*/ 38831 w 231331"/>
+              <a:gd name="connsiteY50" fmla="*/ 347823 h 421352"/>
+              <a:gd name="connsiteX51" fmla="*/ 71878 w 231331"/>
+              <a:gd name="connsiteY51" fmla="*/ 309818 h 421352"/>
+              <a:gd name="connsiteX52" fmla="*/ 81792 w 231331"/>
+              <a:gd name="connsiteY52" fmla="*/ 368477 h 421352"/>
+              <a:gd name="connsiteX53" fmla="*/ 104925 w 231331"/>
+              <a:gd name="connsiteY53" fmla="*/ 347823 h 421352"/>
+              <a:gd name="connsiteX54" fmla="*/ 81792 w 231331"/>
+              <a:gd name="connsiteY54" fmla="*/ 326342 h 421352"/>
+              <a:gd name="connsiteX55" fmla="*/ 58659 w 231331"/>
+              <a:gd name="connsiteY55" fmla="*/ 347823 h 421352"/>
+              <a:gd name="connsiteX56" fmla="*/ 81792 w 231331"/>
+              <a:gd name="connsiteY56" fmla="*/ 368477 h 421352"/>
+            </a:gdLst>
+            <a:ahLst/>
+            <a:cxnLst>
+              <a:cxn ang="0">
+                <a:pos x="connsiteX0" y="connsiteY0"/>
+              </a:cxn>
+              <a:cxn ang="0">
+                <a:pos x="connsiteX1" y="connsiteY1"/>
+              </a:cxn>
+              <a:cxn ang="0">
+                <a:pos x="connsiteX2" y="connsiteY2"/>
+              </a:cxn>
+              <a:cxn ang="0">
+                <a:pos x="connsiteX3" y="connsiteY3"/>
+              </a:cxn>
+              <a:cxn ang="0">
+                <a:pos x="connsiteX4" y="connsiteY4"/>
+              </a:cxn>
+              <a:cxn ang="0">
+                <a:pos x="connsiteX5" y="connsiteY5"/>
+              </a:cxn>
+              <a:cxn ang="0">
+                <a:pos x="connsiteX6" y="connsiteY6"/>
+              </a:cxn>
+              <a:cxn ang="0">
+                <a:pos x="connsiteX7" y="connsiteY7"/>
+              </a:cxn>
+              <a:cxn ang="0">
+                <a:pos x="connsiteX8" y="connsiteY8"/>
+              </a:cxn>
+              <a:cxn ang="0">
+                <a:pos x="connsiteX9" y="connsiteY9"/>
+              </a:cxn>
+              <a:cxn ang="0">
+                <a:pos x="connsiteX10" y="connsiteY10"/>
+              </a:cxn>
+              <a:cxn ang="0">
+                <a:pos x="connsiteX11" y="connsiteY11"/>
+              </a:cxn>
+              <a:cxn ang="0">
+                <a:pos x="connsiteX12" y="connsiteY12"/>
+              </a:cxn>
+              <a:cxn ang="0">
+                <a:pos x="connsiteX13" y="connsiteY13"/>
+              </a:cxn>
+              <a:cxn ang="0">
+                <a:pos x="connsiteX14" y="connsiteY14"/>
+              </a:cxn>
+              <a:cxn ang="0">
+                <a:pos x="connsiteX15" y="connsiteY15"/>
+              </a:cxn>
+              <a:cxn ang="0">
+                <a:pos x="connsiteX16" y="connsiteY16"/>
+              </a:cxn>
+              <a:cxn ang="0">
+                <a:pos x="connsiteX17" y="connsiteY17"/>
+              </a:cxn>
+              <a:cxn ang="0">
+                <a:pos x="connsiteX18" y="connsiteY18"/>
+              </a:cxn>
+              <a:cxn ang="0">
+                <a:pos x="connsiteX19" y="connsiteY19"/>
+              </a:cxn>
+              <a:cxn ang="0">
+                <a:pos x="connsiteX20" y="connsiteY20"/>
+              </a:cxn>
+              <a:cxn ang="0">
+                <a:pos x="connsiteX21" y="connsiteY21"/>
+              </a:cxn>
+              <a:cxn ang="0">
+                <a:pos x="connsiteX22" y="connsiteY22"/>
+              </a:cxn>
+              <a:cxn ang="0">
+                <a:pos x="connsiteX23" y="connsiteY23"/>
+              </a:cxn>
+              <a:cxn ang="0">
+                <a:pos x="connsiteX24" y="connsiteY24"/>
+              </a:cxn>
+              <a:cxn ang="0">
+                <a:pos x="connsiteX25" y="connsiteY25"/>
+              </a:cxn>
+              <a:cxn ang="0">
+                <a:pos x="connsiteX26" y="connsiteY26"/>
+              </a:cxn>
+              <a:cxn ang="0">
+                <a:pos x="connsiteX27" y="connsiteY27"/>
+              </a:cxn>
+              <a:cxn ang="0">
+                <a:pos x="connsiteX28" y="connsiteY28"/>
+              </a:cxn>
+              <a:cxn ang="0">
+                <a:pos x="connsiteX29" y="connsiteY29"/>
+              </a:cxn>
+              <a:cxn ang="0">
+                <a:pos x="connsiteX30" y="connsiteY30"/>
+              </a:cxn>
+              <a:cxn ang="0">
+                <a:pos x="connsiteX31" y="connsiteY31"/>
+              </a:cxn>
+              <a:cxn ang="0">
+                <a:pos x="connsiteX32" y="connsiteY32"/>
+              </a:cxn>
+              <a:cxn ang="0">
+                <a:pos x="connsiteX33" y="connsiteY33"/>
+              </a:cxn>
+              <a:cxn ang="0">
+                <a:pos x="connsiteX34" y="connsiteY34"/>
+              </a:cxn>
+              <a:cxn ang="0">
+                <a:pos x="connsiteX35" y="connsiteY35"/>
+              </a:cxn>
+              <a:cxn ang="0">
+                <a:pos x="connsiteX36" y="connsiteY36"/>
+              </a:cxn>
+              <a:cxn ang="0">
+                <a:pos x="connsiteX37" y="connsiteY37"/>
+              </a:cxn>
+              <a:cxn ang="0">
+                <a:pos x="connsiteX38" y="connsiteY38"/>
+              </a:cxn>
+              <a:cxn ang="0">
+                <a:pos x="connsiteX39" y="connsiteY39"/>
+              </a:cxn>
+              <a:cxn ang="0">
+                <a:pos x="connsiteX40" y="connsiteY40"/>
+              </a:cxn>
+              <a:cxn ang="0">
+                <a:pos x="connsiteX41" y="connsiteY41"/>
+              </a:cxn>
+              <a:cxn ang="0">
+                <a:pos x="connsiteX42" y="connsiteY42"/>
+              </a:cxn>
+              <a:cxn ang="0">
+                <a:pos x="connsiteX43" y="connsiteY43"/>
+              </a:cxn>
+              <a:cxn ang="0">
+                <a:pos x="connsiteX44" y="connsiteY44"/>
+              </a:cxn>
+              <a:cxn ang="0">
+                <a:pos x="connsiteX45" y="connsiteY45"/>
+              </a:cxn>
+              <a:cxn ang="0">
+                <a:pos x="connsiteX46" y="connsiteY46"/>
+              </a:cxn>
+              <a:cxn ang="0">
+                <a:pos x="connsiteX47" y="connsiteY47"/>
+              </a:cxn>
+              <a:cxn ang="0">
+                <a:pos x="connsiteX48" y="connsiteY48"/>
+              </a:cxn>
+              <a:cxn ang="0">
+                <a:pos x="connsiteX49" y="connsiteY49"/>
+              </a:cxn>
+              <a:cxn ang="0">
+                <a:pos x="connsiteX50" y="connsiteY50"/>
+              </a:cxn>
+              <a:cxn ang="0">
+                <a:pos x="connsiteX51" y="connsiteY51"/>
+              </a:cxn>
+              <a:cxn ang="0">
+                <a:pos x="connsiteX52" y="connsiteY52"/>
+              </a:cxn>
+              <a:cxn ang="0">
+                <a:pos x="connsiteX53" y="connsiteY53"/>
+              </a:cxn>
+              <a:cxn ang="0">
+                <a:pos x="connsiteX54" y="connsiteY54"/>
+              </a:cxn>
+              <a:cxn ang="0">
+                <a:pos x="connsiteX55" y="connsiteY55"/>
+              </a:cxn>
+              <a:cxn ang="0">
+                <a:pos x="connsiteX56" y="connsiteY56"/>
+              </a:cxn>
+            </a:cxnLst>
+            <a:rect l="l" t="t" r="r" b="b"/>
+            <a:pathLst>
+              <a:path w="231331" h="421352">
+                <a:moveTo>
+                  <a:pt x="168541" y="83444"/>
+                </a:moveTo>
+                <a:cubicBezTo>
+                  <a:pt x="162758" y="83444"/>
+                  <a:pt x="158627" y="79314"/>
+                  <a:pt x="158627" y="74356"/>
+                </a:cubicBezTo>
+                <a:cubicBezTo>
+                  <a:pt x="158627" y="69399"/>
+                  <a:pt x="162758" y="65268"/>
+                  <a:pt x="168541" y="65268"/>
+                </a:cubicBezTo>
+                <a:lnTo>
+                  <a:pt x="221417" y="65268"/>
+                </a:lnTo>
+                <a:cubicBezTo>
+                  <a:pt x="226374" y="65268"/>
+                  <a:pt x="231331" y="69399"/>
+                  <a:pt x="231331" y="74356"/>
+                </a:cubicBezTo>
+                <a:cubicBezTo>
+                  <a:pt x="231331" y="79314"/>
+                  <a:pt x="227200" y="83444"/>
+                  <a:pt x="221417" y="83444"/>
+                </a:cubicBezTo>
+                <a:close/>
+                <a:moveTo>
+                  <a:pt x="26438" y="50397"/>
+                </a:moveTo>
+                <a:cubicBezTo>
+                  <a:pt x="26438" y="22307"/>
+                  <a:pt x="51223" y="0"/>
+                  <a:pt x="82618" y="0"/>
+                </a:cubicBezTo>
+                <a:cubicBezTo>
+                  <a:pt x="113187" y="0"/>
+                  <a:pt x="138799" y="22307"/>
+                  <a:pt x="138799" y="50397"/>
+                </a:cubicBezTo>
+                <a:lnTo>
+                  <a:pt x="138799" y="292469"/>
+                </a:lnTo>
+                <a:cubicBezTo>
+                  <a:pt x="155322" y="306514"/>
+                  <a:pt x="165236" y="326342"/>
+                  <a:pt x="165236" y="346997"/>
+                </a:cubicBezTo>
+                <a:cubicBezTo>
+                  <a:pt x="165236" y="388306"/>
+                  <a:pt x="128058" y="421353"/>
+                  <a:pt x="82618" y="421353"/>
+                </a:cubicBezTo>
+                <a:cubicBezTo>
+                  <a:pt x="37178" y="421353"/>
+                  <a:pt x="0" y="388306"/>
+                  <a:pt x="0" y="346997"/>
+                </a:cubicBezTo>
+                <a:cubicBezTo>
+                  <a:pt x="0" y="326342"/>
+                  <a:pt x="9914" y="306514"/>
+                  <a:pt x="26438" y="292469"/>
+                </a:cubicBezTo>
+                <a:close/>
+                <a:moveTo>
+                  <a:pt x="46266" y="301557"/>
+                </a:moveTo>
+                <a:lnTo>
+                  <a:pt x="42961" y="304035"/>
+                </a:lnTo>
+                <a:cubicBezTo>
+                  <a:pt x="28090" y="314775"/>
+                  <a:pt x="19828" y="330473"/>
+                  <a:pt x="19828" y="347823"/>
+                </a:cubicBezTo>
+                <a:cubicBezTo>
+                  <a:pt x="19828" y="378392"/>
+                  <a:pt x="47919" y="404003"/>
+                  <a:pt x="82618" y="404003"/>
+                </a:cubicBezTo>
+                <a:cubicBezTo>
+                  <a:pt x="117318" y="404003"/>
+                  <a:pt x="145408" y="378392"/>
+                  <a:pt x="145408" y="347823"/>
+                </a:cubicBezTo>
+                <a:cubicBezTo>
+                  <a:pt x="145408" y="330473"/>
+                  <a:pt x="136320" y="314775"/>
+                  <a:pt x="122275" y="304035"/>
+                </a:cubicBezTo>
+                <a:lnTo>
+                  <a:pt x="118970" y="301557"/>
+                </a:lnTo>
+                <a:lnTo>
+                  <a:pt x="118970" y="50397"/>
+                </a:lnTo>
+                <a:cubicBezTo>
+                  <a:pt x="118970" y="33047"/>
+                  <a:pt x="102447" y="18176"/>
+                  <a:pt x="82618" y="18176"/>
+                </a:cubicBezTo>
+                <a:cubicBezTo>
+                  <a:pt x="61964" y="18176"/>
+                  <a:pt x="46266" y="33047"/>
+                  <a:pt x="46266" y="50397"/>
+                </a:cubicBezTo>
+                <a:lnTo>
+                  <a:pt x="46266" y="301557"/>
+                </a:lnTo>
+                <a:close/>
+                <a:moveTo>
+                  <a:pt x="167715" y="261074"/>
+                </a:moveTo>
+                <a:cubicBezTo>
+                  <a:pt x="162758" y="261074"/>
+                  <a:pt x="157801" y="257769"/>
+                  <a:pt x="157801" y="251986"/>
+                </a:cubicBezTo>
+                <a:cubicBezTo>
+                  <a:pt x="157801" y="247029"/>
+                  <a:pt x="162758" y="243724"/>
+                  <a:pt x="167715" y="243724"/>
+                </a:cubicBezTo>
+                <a:lnTo>
+                  <a:pt x="220591" y="243724"/>
+                </a:lnTo>
+                <a:cubicBezTo>
+                  <a:pt x="226374" y="243724"/>
+                  <a:pt x="231331" y="247029"/>
+                  <a:pt x="231331" y="251986"/>
+                </a:cubicBezTo>
+                <a:cubicBezTo>
+                  <a:pt x="231331" y="257769"/>
+                  <a:pt x="226374" y="261074"/>
+                  <a:pt x="220591" y="261074"/>
+                </a:cubicBezTo>
+                <a:close/>
+                <a:moveTo>
+                  <a:pt x="167715" y="202415"/>
+                </a:moveTo>
+                <a:cubicBezTo>
+                  <a:pt x="162758" y="202415"/>
+                  <a:pt x="157801" y="198284"/>
+                  <a:pt x="157801" y="193327"/>
+                </a:cubicBezTo>
+                <a:cubicBezTo>
+                  <a:pt x="157801" y="188370"/>
+                  <a:pt x="162758" y="184239"/>
+                  <a:pt x="167715" y="184239"/>
+                </a:cubicBezTo>
+                <a:lnTo>
+                  <a:pt x="221417" y="184239"/>
+                </a:lnTo>
+                <a:cubicBezTo>
+                  <a:pt x="226374" y="184239"/>
+                  <a:pt x="231331" y="188370"/>
+                  <a:pt x="231331" y="193327"/>
+                </a:cubicBezTo>
+                <a:cubicBezTo>
+                  <a:pt x="231331" y="198284"/>
+                  <a:pt x="226374" y="202415"/>
+                  <a:pt x="221417" y="202415"/>
+                </a:cubicBezTo>
+                <a:close/>
+                <a:moveTo>
+                  <a:pt x="167715" y="142930"/>
+                </a:moveTo>
+                <a:cubicBezTo>
+                  <a:pt x="161932" y="142930"/>
+                  <a:pt x="156975" y="138799"/>
+                  <a:pt x="156975" y="133842"/>
+                </a:cubicBezTo>
+                <a:cubicBezTo>
+                  <a:pt x="156975" y="128884"/>
+                  <a:pt x="161932" y="124754"/>
+                  <a:pt x="167715" y="124754"/>
+                </a:cubicBezTo>
+                <a:lnTo>
+                  <a:pt x="220591" y="124754"/>
+                </a:lnTo>
+                <a:cubicBezTo>
+                  <a:pt x="225548" y="124754"/>
+                  <a:pt x="230505" y="128884"/>
+                  <a:pt x="230505" y="133842"/>
+                </a:cubicBezTo>
+                <a:cubicBezTo>
+                  <a:pt x="230505" y="138799"/>
+                  <a:pt x="225548" y="142930"/>
+                  <a:pt x="220591" y="142930"/>
+                </a:cubicBezTo>
+                <a:close/>
+                <a:moveTo>
+                  <a:pt x="71878" y="309818"/>
+                </a:moveTo>
+                <a:lnTo>
+                  <a:pt x="71878" y="190022"/>
+                </a:lnTo>
+                <a:cubicBezTo>
+                  <a:pt x="71878" y="185065"/>
+                  <a:pt x="76009" y="180934"/>
+                  <a:pt x="81792" y="180934"/>
+                </a:cubicBezTo>
+                <a:cubicBezTo>
+                  <a:pt x="86749" y="180934"/>
+                  <a:pt x="91706" y="184239"/>
+                  <a:pt x="91706" y="190022"/>
+                </a:cubicBezTo>
+                <a:lnTo>
+                  <a:pt x="91706" y="309818"/>
+                </a:lnTo>
+                <a:cubicBezTo>
+                  <a:pt x="110708" y="313949"/>
+                  <a:pt x="124754" y="329647"/>
+                  <a:pt x="124754" y="347823"/>
+                </a:cubicBezTo>
+                <a:cubicBezTo>
+                  <a:pt x="124754" y="368477"/>
+                  <a:pt x="105751" y="385827"/>
+                  <a:pt x="81792" y="385827"/>
+                </a:cubicBezTo>
+                <a:cubicBezTo>
+                  <a:pt x="57833" y="385827"/>
+                  <a:pt x="38831" y="368477"/>
+                  <a:pt x="38831" y="347823"/>
+                </a:cubicBezTo>
+                <a:cubicBezTo>
+                  <a:pt x="38831" y="328821"/>
+                  <a:pt x="52876" y="313949"/>
+                  <a:pt x="71878" y="309818"/>
+                </a:cubicBezTo>
+                <a:close/>
+                <a:moveTo>
+                  <a:pt x="81792" y="368477"/>
+                </a:moveTo>
+                <a:cubicBezTo>
+                  <a:pt x="95011" y="368477"/>
+                  <a:pt x="104925" y="358563"/>
+                  <a:pt x="104925" y="347823"/>
+                </a:cubicBezTo>
+                <a:cubicBezTo>
+                  <a:pt x="104925" y="336256"/>
+                  <a:pt x="95011" y="326342"/>
+                  <a:pt x="81792" y="326342"/>
+                </a:cubicBezTo>
+                <a:cubicBezTo>
+                  <a:pt x="69399" y="326342"/>
+                  <a:pt x="58659" y="336256"/>
+                  <a:pt x="58659" y="347823"/>
+                </a:cubicBezTo>
+                <a:cubicBezTo>
+                  <a:pt x="58659" y="358563"/>
+                  <a:pt x="69399" y="368477"/>
+                  <a:pt x="81792" y="368477"/>
+                </a:cubicBezTo>
+                <a:close/>
+              </a:path>
+            </a:pathLst>
+          </a:custGeom>
+          <a:solidFill>
+            <a:srgbClr val="000091"/>
+          </a:solidFill>
+          <a:ln w="8218" cap="flat">
+            <a:noFill/>
+            <a:prstDash val="solid"/>
+            <a:miter/>
+          </a:ln>
         </p:spPr>
-      </p:pic>
+        <p:txBody>
+          <a:bodyPr rtlCol="0" anchor="ctr"/>
+          <a:lstStyle/>
+          <a:p>
+            <a:endParaRPr lang="fr-FR"/>
+          </a:p>
+        </p:txBody>
+      </p:sp>
       <p:sp>
         <p:nvSpPr>
           <p:cNvPr id="29" name="ZoneTexte 28">
@@ -8748,42 +9293,118 @@
           </a:p>
         </p:txBody>
       </p:sp>
-      <p:pic>
-        <p:nvPicPr>
-          <p:cNvPr id="32" name="zone_coeff_ru_curseur">
+      <p:sp>
+        <p:nvSpPr>
+          <p:cNvPr id="8" name="zone_coeff_ru_curseur">
             <a:extLst>
               <a:ext uri="{FF2B5EF4-FFF2-40B4-BE49-F238E27FC236}">
                 <a16:creationId xmlns:a16="http://schemas.microsoft.com/office/drawing/2014/main" id="{07E6566C-AE16-33FB-0B10-1897683DF483}"/>
               </a:ext>
             </a:extLst>
           </p:cNvPr>
-          <p:cNvPicPr>
-            <a:picLocks noChangeAspect="1"/>
-          </p:cNvPicPr>
+          <p:cNvSpPr/>
           <p:nvPr/>
-        </p:nvPicPr>
-        <p:blipFill>
-          <a:blip r:embed="rId7">
-            <a:extLst>
-              <a:ext uri="{96DAC541-7B7A-43D3-8B79-37D633B846F1}">
-                <asvg:svgBlip xmlns:asvg="http://schemas.microsoft.com/office/drawing/2016/SVG/main" r:embed="rId8"/>
-              </a:ext>
-            </a:extLst>
-          </a:blip>
-          <a:stretch>
-            <a:fillRect/>
-          </a:stretch>
-        </p:blipFill>
+        </p:nvSpPr>
         <p:spPr>
           <a:xfrm>
-            <a:off x="947336" y="1978946"/>
-            <a:ext cx="216000" cy="196364"/>
+            <a:off x="951085" y="1987127"/>
+            <a:ext cx="208500" cy="184909"/>
           </a:xfrm>
-          <a:prstGeom prst="rect">
+          <a:custGeom>
             <a:avLst/>
-          </a:prstGeom>
+            <a:gdLst>
+              <a:gd name="connsiteX0" fmla="*/ 90079 w 208500"/>
+              <a:gd name="connsiteY0" fmla="*/ 176728 h 184909"/>
+              <a:gd name="connsiteX1" fmla="*/ 118422 w 208500"/>
+              <a:gd name="connsiteY1" fmla="*/ 176728 h 184909"/>
+              <a:gd name="connsiteX2" fmla="*/ 206284 w 208500"/>
+              <a:gd name="connsiteY2" fmla="*/ 24546 h 184909"/>
+              <a:gd name="connsiteX3" fmla="*/ 192113 w 208500"/>
+              <a:gd name="connsiteY3" fmla="*/ 0 h 184909"/>
+              <a:gd name="connsiteX4" fmla="*/ 16388 w 208500"/>
+              <a:gd name="connsiteY4" fmla="*/ 0 h 184909"/>
+              <a:gd name="connsiteX5" fmla="*/ 2217 w 208500"/>
+              <a:gd name="connsiteY5" fmla="*/ 24546 h 184909"/>
+              <a:gd name="connsiteX6" fmla="*/ 90079 w 208500"/>
+              <a:gd name="connsiteY6" fmla="*/ 176728 h 184909"/>
+            </a:gdLst>
+            <a:ahLst/>
+            <a:cxnLst>
+              <a:cxn ang="0">
+                <a:pos x="connsiteX0" y="connsiteY0"/>
+              </a:cxn>
+              <a:cxn ang="0">
+                <a:pos x="connsiteX1" y="connsiteY1"/>
+              </a:cxn>
+              <a:cxn ang="0">
+                <a:pos x="connsiteX2" y="connsiteY2"/>
+              </a:cxn>
+              <a:cxn ang="0">
+                <a:pos x="connsiteX3" y="connsiteY3"/>
+              </a:cxn>
+              <a:cxn ang="0">
+                <a:pos x="connsiteX4" y="connsiteY4"/>
+              </a:cxn>
+              <a:cxn ang="0">
+                <a:pos x="connsiteX5" y="connsiteY5"/>
+              </a:cxn>
+              <a:cxn ang="0">
+                <a:pos x="connsiteX6" y="connsiteY6"/>
+              </a:cxn>
+            </a:cxnLst>
+            <a:rect l="l" t="t" r="r" b="b"/>
+            <a:pathLst>
+              <a:path w="208500" h="184909">
+                <a:moveTo>
+                  <a:pt x="90079" y="176728"/>
+                </a:moveTo>
+                <a:cubicBezTo>
+                  <a:pt x="96377" y="187637"/>
+                  <a:pt x="112123" y="187637"/>
+                  <a:pt x="118422" y="176728"/>
+                </a:cubicBezTo>
+                <a:lnTo>
+                  <a:pt x="206284" y="24546"/>
+                </a:lnTo>
+                <a:cubicBezTo>
+                  <a:pt x="212582" y="13636"/>
+                  <a:pt x="204709" y="0"/>
+                  <a:pt x="192113" y="0"/>
+                </a:cubicBezTo>
+                <a:lnTo>
+                  <a:pt x="16388" y="0"/>
+                </a:lnTo>
+                <a:cubicBezTo>
+                  <a:pt x="3791" y="0"/>
+                  <a:pt x="-4082" y="13636"/>
+                  <a:pt x="2217" y="24546"/>
+                </a:cubicBezTo>
+                <a:lnTo>
+                  <a:pt x="90079" y="176728"/>
+                </a:lnTo>
+                <a:close/>
+              </a:path>
+            </a:pathLst>
+          </a:custGeom>
+          <a:solidFill>
+            <a:srgbClr val="161616"/>
+          </a:solidFill>
+          <a:ln w="6350" cap="flat">
+            <a:solidFill>
+              <a:srgbClr val="FFFFFF"/>
+            </a:solidFill>
+            <a:prstDash val="solid"/>
+            <a:miter/>
+          </a:ln>
         </p:spPr>
-      </p:pic>
+        <p:txBody>
+          <a:bodyPr rtlCol="0" anchor="ctr"/>
+          <a:lstStyle/>
+          <a:p>
+            <a:endParaRPr lang="fr-FR"/>
+          </a:p>
+        </p:txBody>
+      </p:sp>
       <p:sp>
         <p:nvSpPr>
           <p:cNvPr id="35" name="ZoneTexte 34">
@@ -9413,112 +10034,146 @@
       </p:sp>
       <p:pic>
         <p:nvPicPr>
-          <p:cNvPr id="53" name="Graphique 52">
-            <a:extLst>
-              <a:ext uri="{FF2B5EF4-FFF2-40B4-BE49-F238E27FC236}">
-                <a16:creationId xmlns:a16="http://schemas.microsoft.com/office/drawing/2014/main" id="{6C268903-4805-4D69-25F9-A7CAA99CCA32}"/>
+          <p:cNvPr id="31" name="zone_coeff_perm_echelle">
+            <a:extLst>
+              <a:ext uri="{FF2B5EF4-FFF2-40B4-BE49-F238E27FC236}">
+                <a16:creationId xmlns:a16="http://schemas.microsoft.com/office/drawing/2014/main" id="{A36CD4A0-CE6B-2E5A-0169-6B8B117FD6AE}"/>
               </a:ext>
             </a:extLst>
           </p:cNvPr>
           <p:cNvPicPr>
-            <a:picLocks noChangeAspect="1"/>
+            <a:picLocks/>
           </p:cNvPicPr>
           <p:nvPr/>
         </p:nvPicPr>
         <p:blipFill>
-          <a:blip r:embed="rId9">
-            <a:extLst>
-              <a:ext uri="{96DAC541-7B7A-43D3-8B79-37D633B846F1}">
-                <asvg:svgBlip xmlns:asvg="http://schemas.microsoft.com/office/drawing/2016/SVG/main" r:embed="rId10"/>
-              </a:ext>
-            </a:extLst>
-          </a:blip>
+          <a:blip r:embed="rId4"/>
           <a:stretch>
             <a:fillRect/>
           </a:stretch>
         </p:blipFill>
         <p:spPr>
           <a:xfrm>
-            <a:off x="7021450" y="1261337"/>
-            <a:ext cx="341505" cy="341505"/>
+            <a:off x="7034400" y="1846800"/>
+            <a:ext cx="4644000" cy="144000"/>
           </a:xfrm>
           <a:prstGeom prst="rect">
             <a:avLst/>
           </a:prstGeom>
         </p:spPr>
       </p:pic>
-      <p:pic>
-        <p:nvPicPr>
-          <p:cNvPr id="57" name="zone_coeff_perm_echelle">
-            <a:extLst>
-              <a:ext uri="{FF2B5EF4-FFF2-40B4-BE49-F238E27FC236}">
-                <a16:creationId xmlns:a16="http://schemas.microsoft.com/office/drawing/2014/main" id="{EF0F536C-1764-1056-48BC-43AB3887574C}"/>
-              </a:ext>
-            </a:extLst>
-          </p:cNvPr>
-          <p:cNvPicPr>
-            <a:picLocks noChangeAspect="1"/>
-          </p:cNvPicPr>
+      <p:sp>
+        <p:nvSpPr>
+          <p:cNvPr id="12" name="zone_coeff_perm_curseur">
+            <a:extLst>
+              <a:ext uri="{FF2B5EF4-FFF2-40B4-BE49-F238E27FC236}">
+                <a16:creationId xmlns:a16="http://schemas.microsoft.com/office/drawing/2014/main" id="{3BA044A5-E7AE-D86E-2624-A658E6201EAA}"/>
+              </a:ext>
+            </a:extLst>
+          </p:cNvPr>
+          <p:cNvSpPr/>
           <p:nvPr/>
-        </p:nvPicPr>
-        <p:blipFill>
-          <a:blip r:embed="rId11">
-            <a:extLst>
-              <a:ext uri="{96DAC541-7B7A-43D3-8B79-37D633B846F1}">
-                <asvg:svgBlip xmlns:asvg="http://schemas.microsoft.com/office/drawing/2016/SVG/main" r:embed="rId12"/>
-              </a:ext>
-            </a:extLst>
-          </a:blip>
-          <a:stretch>
-            <a:fillRect/>
-          </a:stretch>
-        </p:blipFill>
+        </p:nvSpPr>
         <p:spPr>
           <a:xfrm>
-            <a:off x="7035040" y="1847050"/>
-            <a:ext cx="4645336" cy="144000"/>
+            <a:off x="6998956" y="1742572"/>
+            <a:ext cx="152900" cy="135600"/>
           </a:xfrm>
-          <a:prstGeom prst="rect">
+          <a:custGeom>
             <a:avLst/>
-          </a:prstGeom>
+            <a:gdLst>
+              <a:gd name="connsiteX0" fmla="*/ 66058 w 152900"/>
+              <a:gd name="connsiteY0" fmla="*/ 129600 h 135600"/>
+              <a:gd name="connsiteX1" fmla="*/ 86843 w 152900"/>
+              <a:gd name="connsiteY1" fmla="*/ 129600 h 135600"/>
+              <a:gd name="connsiteX2" fmla="*/ 151275 w 152900"/>
+              <a:gd name="connsiteY2" fmla="*/ 18000 h 135600"/>
+              <a:gd name="connsiteX3" fmla="*/ 140883 w 152900"/>
+              <a:gd name="connsiteY3" fmla="*/ 0 h 135600"/>
+              <a:gd name="connsiteX4" fmla="*/ 12018 w 152900"/>
+              <a:gd name="connsiteY4" fmla="*/ 0 h 135600"/>
+              <a:gd name="connsiteX5" fmla="*/ 1626 w 152900"/>
+              <a:gd name="connsiteY5" fmla="*/ 18000 h 135600"/>
+              <a:gd name="connsiteX6" fmla="*/ 66058 w 152900"/>
+              <a:gd name="connsiteY6" fmla="*/ 129600 h 135600"/>
+            </a:gdLst>
+            <a:ahLst/>
+            <a:cxnLst>
+              <a:cxn ang="0">
+                <a:pos x="connsiteX0" y="connsiteY0"/>
+              </a:cxn>
+              <a:cxn ang="0">
+                <a:pos x="connsiteX1" y="connsiteY1"/>
+              </a:cxn>
+              <a:cxn ang="0">
+                <a:pos x="connsiteX2" y="connsiteY2"/>
+              </a:cxn>
+              <a:cxn ang="0">
+                <a:pos x="connsiteX3" y="connsiteY3"/>
+              </a:cxn>
+              <a:cxn ang="0">
+                <a:pos x="connsiteX4" y="connsiteY4"/>
+              </a:cxn>
+              <a:cxn ang="0">
+                <a:pos x="connsiteX5" y="connsiteY5"/>
+              </a:cxn>
+              <a:cxn ang="0">
+                <a:pos x="connsiteX6" y="connsiteY6"/>
+              </a:cxn>
+            </a:cxnLst>
+            <a:rect l="l" t="t" r="r" b="b"/>
+            <a:pathLst>
+              <a:path w="152900" h="135600">
+                <a:moveTo>
+                  <a:pt x="66058" y="129600"/>
+                </a:moveTo>
+                <a:cubicBezTo>
+                  <a:pt x="70677" y="137600"/>
+                  <a:pt x="82224" y="137600"/>
+                  <a:pt x="86843" y="129600"/>
+                </a:cubicBezTo>
+                <a:lnTo>
+                  <a:pt x="151275" y="18000"/>
+                </a:lnTo>
+                <a:cubicBezTo>
+                  <a:pt x="155894" y="10000"/>
+                  <a:pt x="150120" y="0"/>
+                  <a:pt x="140883" y="0"/>
+                </a:cubicBezTo>
+                <a:lnTo>
+                  <a:pt x="12018" y="0"/>
+                </a:lnTo>
+                <a:cubicBezTo>
+                  <a:pt x="2780" y="0"/>
+                  <a:pt x="-2993" y="10000"/>
+                  <a:pt x="1626" y="18000"/>
+                </a:cubicBezTo>
+                <a:lnTo>
+                  <a:pt x="66058" y="129600"/>
+                </a:lnTo>
+                <a:close/>
+              </a:path>
+            </a:pathLst>
+          </a:custGeom>
+          <a:solidFill>
+            <a:srgbClr val="161616"/>
+          </a:solidFill>
+          <a:ln w="4618" cap="flat">
+            <a:solidFill>
+              <a:srgbClr val="FFFFFF"/>
+            </a:solidFill>
+            <a:prstDash val="solid"/>
+            <a:miter/>
+          </a:ln>
         </p:spPr>
-      </p:pic>
-      <p:pic>
-        <p:nvPicPr>
-          <p:cNvPr id="50" name="zone_coeff_perm_curseur">
-            <a:extLst>
-              <a:ext uri="{FF2B5EF4-FFF2-40B4-BE49-F238E27FC236}">
-                <a16:creationId xmlns:a16="http://schemas.microsoft.com/office/drawing/2014/main" id="{3BA044A5-E7AE-D86E-2624-A658E6201EAA}"/>
-              </a:ext>
-            </a:extLst>
-          </p:cNvPr>
-          <p:cNvPicPr>
-            <a:picLocks noChangeAspect="1"/>
-          </p:cNvPicPr>
-          <p:nvPr/>
-        </p:nvPicPr>
-        <p:blipFill>
-          <a:blip r:embed="rId7">
-            <a:extLst>
-              <a:ext uri="{96DAC541-7B7A-43D3-8B79-37D633B846F1}">
-                <asvg:svgBlip xmlns:asvg="http://schemas.microsoft.com/office/drawing/2016/SVG/main" r:embed="rId8"/>
-              </a:ext>
-            </a:extLst>
-          </a:blip>
-          <a:stretch>
-            <a:fillRect/>
-          </a:stretch>
-        </p:blipFill>
-        <p:spPr>
-          <a:xfrm>
-            <a:off x="6996207" y="1728372"/>
-            <a:ext cx="158400" cy="144000"/>
-          </a:xfrm>
-          <a:prstGeom prst="rect">
-            <a:avLst/>
-          </a:prstGeom>
-        </p:spPr>
-      </p:pic>
+        <p:txBody>
+          <a:bodyPr rtlCol="0" anchor="ctr"/>
+          <a:lstStyle/>
+          <a:p>
+            <a:endParaRPr lang="fr-FR"/>
+          </a:p>
+        </p:txBody>
+      </p:sp>
       <p:sp>
         <p:nvSpPr>
           <p:cNvPr id="69" name="Text 16">
@@ -10074,112 +10729,818 @@
       </p:sp>
       <p:pic>
         <p:nvPicPr>
-          <p:cNvPr id="81" name="zone_coeff_bio_echelle">
-            <a:extLst>
-              <a:ext uri="{FF2B5EF4-FFF2-40B4-BE49-F238E27FC236}">
-                <a16:creationId xmlns:a16="http://schemas.microsoft.com/office/drawing/2014/main" id="{E05A7EC6-5813-390D-C513-B8F343743BCB}"/>
+          <p:cNvPr id="36" name="zone_coeff_bio_echelle">
+            <a:extLst>
+              <a:ext uri="{FF2B5EF4-FFF2-40B4-BE49-F238E27FC236}">
+                <a16:creationId xmlns:a16="http://schemas.microsoft.com/office/drawing/2014/main" id="{08FB79B5-C6F2-3212-3353-C32C6970820B}"/>
               </a:ext>
             </a:extLst>
           </p:cNvPr>
           <p:cNvPicPr>
-            <a:picLocks noChangeAspect="1"/>
+            <a:picLocks/>
           </p:cNvPicPr>
           <p:nvPr/>
         </p:nvPicPr>
         <p:blipFill>
-          <a:blip r:embed="rId13">
-            <a:extLst>
-              <a:ext uri="{96DAC541-7B7A-43D3-8B79-37D633B846F1}">
-                <asvg:svgBlip xmlns:asvg="http://schemas.microsoft.com/office/drawing/2016/SVG/main" r:embed="rId14"/>
-              </a:ext>
-            </a:extLst>
-          </a:blip>
+          <a:blip r:embed="rId5"/>
           <a:stretch>
             <a:fillRect/>
           </a:stretch>
         </p:blipFill>
         <p:spPr>
           <a:xfrm>
-            <a:off x="7035041" y="4406432"/>
-            <a:ext cx="4645335" cy="144000"/>
+            <a:off x="7034400" y="4406400"/>
+            <a:ext cx="4644000" cy="144000"/>
           </a:xfrm>
           <a:prstGeom prst="rect">
             <a:avLst/>
           </a:prstGeom>
         </p:spPr>
       </p:pic>
-      <p:pic>
-        <p:nvPicPr>
-          <p:cNvPr id="79" name="zone_coeff_bio_curseur">
+      <p:sp>
+        <p:nvSpPr>
+          <p:cNvPr id="13" name="zone_coeff_bio_curseur">
             <a:extLst>
               <a:ext uri="{FF2B5EF4-FFF2-40B4-BE49-F238E27FC236}">
                 <a16:creationId xmlns:a16="http://schemas.microsoft.com/office/drawing/2014/main" id="{6E922DBF-EC40-62AE-5811-0C7DA85797E1}"/>
               </a:ext>
             </a:extLst>
           </p:cNvPr>
-          <p:cNvPicPr>
-            <a:picLocks noChangeAspect="1"/>
-          </p:cNvPicPr>
+          <p:cNvSpPr/>
           <p:nvPr/>
-        </p:nvPicPr>
-        <p:blipFill>
-          <a:blip r:embed="rId7">
-            <a:extLst>
-              <a:ext uri="{96DAC541-7B7A-43D3-8B79-37D633B846F1}">
-                <asvg:svgBlip xmlns:asvg="http://schemas.microsoft.com/office/drawing/2016/SVG/main" r:embed="rId8"/>
-              </a:ext>
-            </a:extLst>
-          </a:blip>
-          <a:stretch>
-            <a:fillRect/>
-          </a:stretch>
-        </p:blipFill>
+        </p:nvSpPr>
         <p:spPr>
           <a:xfrm>
-            <a:off x="6996207" y="4297220"/>
-            <a:ext cx="158400" cy="144000"/>
+            <a:off x="6998956" y="4311420"/>
+            <a:ext cx="152900" cy="135600"/>
           </a:xfrm>
-          <a:prstGeom prst="rect">
+          <a:custGeom>
             <a:avLst/>
-          </a:prstGeom>
+            <a:gdLst>
+              <a:gd name="connsiteX0" fmla="*/ 66058 w 152900"/>
+              <a:gd name="connsiteY0" fmla="*/ 129600 h 135600"/>
+              <a:gd name="connsiteX1" fmla="*/ 86843 w 152900"/>
+              <a:gd name="connsiteY1" fmla="*/ 129600 h 135600"/>
+              <a:gd name="connsiteX2" fmla="*/ 151275 w 152900"/>
+              <a:gd name="connsiteY2" fmla="*/ 18000 h 135600"/>
+              <a:gd name="connsiteX3" fmla="*/ 140883 w 152900"/>
+              <a:gd name="connsiteY3" fmla="*/ 0 h 135600"/>
+              <a:gd name="connsiteX4" fmla="*/ 12018 w 152900"/>
+              <a:gd name="connsiteY4" fmla="*/ 0 h 135600"/>
+              <a:gd name="connsiteX5" fmla="*/ 1626 w 152900"/>
+              <a:gd name="connsiteY5" fmla="*/ 18000 h 135600"/>
+              <a:gd name="connsiteX6" fmla="*/ 66058 w 152900"/>
+              <a:gd name="connsiteY6" fmla="*/ 129600 h 135600"/>
+            </a:gdLst>
+            <a:ahLst/>
+            <a:cxnLst>
+              <a:cxn ang="0">
+                <a:pos x="connsiteX0" y="connsiteY0"/>
+              </a:cxn>
+              <a:cxn ang="0">
+                <a:pos x="connsiteX1" y="connsiteY1"/>
+              </a:cxn>
+              <a:cxn ang="0">
+                <a:pos x="connsiteX2" y="connsiteY2"/>
+              </a:cxn>
+              <a:cxn ang="0">
+                <a:pos x="connsiteX3" y="connsiteY3"/>
+              </a:cxn>
+              <a:cxn ang="0">
+                <a:pos x="connsiteX4" y="connsiteY4"/>
+              </a:cxn>
+              <a:cxn ang="0">
+                <a:pos x="connsiteX5" y="connsiteY5"/>
+              </a:cxn>
+              <a:cxn ang="0">
+                <a:pos x="connsiteX6" y="connsiteY6"/>
+              </a:cxn>
+            </a:cxnLst>
+            <a:rect l="l" t="t" r="r" b="b"/>
+            <a:pathLst>
+              <a:path w="152900" h="135600">
+                <a:moveTo>
+                  <a:pt x="66058" y="129600"/>
+                </a:moveTo>
+                <a:cubicBezTo>
+                  <a:pt x="70677" y="137600"/>
+                  <a:pt x="82224" y="137600"/>
+                  <a:pt x="86843" y="129600"/>
+                </a:cubicBezTo>
+                <a:lnTo>
+                  <a:pt x="151275" y="18000"/>
+                </a:lnTo>
+                <a:cubicBezTo>
+                  <a:pt x="155894" y="10000"/>
+                  <a:pt x="150120" y="0"/>
+                  <a:pt x="140883" y="0"/>
+                </a:cubicBezTo>
+                <a:lnTo>
+                  <a:pt x="12018" y="0"/>
+                </a:lnTo>
+                <a:cubicBezTo>
+                  <a:pt x="2780" y="0"/>
+                  <a:pt x="-2993" y="10000"/>
+                  <a:pt x="1626" y="18000"/>
+                </a:cubicBezTo>
+                <a:lnTo>
+                  <a:pt x="66058" y="129600"/>
+                </a:lnTo>
+                <a:close/>
+              </a:path>
+            </a:pathLst>
+          </a:custGeom>
+          <a:solidFill>
+            <a:srgbClr val="161616"/>
+          </a:solidFill>
+          <a:ln w="4618" cap="flat">
+            <a:solidFill>
+              <a:srgbClr val="FFFFFF"/>
+            </a:solidFill>
+            <a:prstDash val="solid"/>
+            <a:miter/>
+          </a:ln>
         </p:spPr>
-      </p:pic>
-      <p:pic>
-        <p:nvPicPr>
-          <p:cNvPr id="83" name="Graphique 82">
+        <p:txBody>
+          <a:bodyPr rtlCol="0" anchor="ctr"/>
+          <a:lstStyle/>
+          <a:p>
+            <a:endParaRPr lang="fr-FR"/>
+          </a:p>
+        </p:txBody>
+      </p:sp>
+      <p:sp>
+        <p:nvSpPr>
+          <p:cNvPr id="25" name="Graphique 82">
             <a:extLst>
               <a:ext uri="{FF2B5EF4-FFF2-40B4-BE49-F238E27FC236}">
                 <a16:creationId xmlns:a16="http://schemas.microsoft.com/office/drawing/2014/main" id="{F4830C2E-47F8-242B-E106-D059B106FBEE}"/>
               </a:ext>
             </a:extLst>
           </p:cNvPr>
-          <p:cNvPicPr>
-            <a:picLocks noChangeAspect="1"/>
-          </p:cNvPicPr>
+          <p:cNvSpPr/>
           <p:nvPr/>
-        </p:nvPicPr>
-        <p:blipFill>
-          <a:blip r:embed="rId15">
-            <a:extLst>
-              <a:ext uri="{96DAC541-7B7A-43D3-8B79-37D633B846F1}">
-                <asvg:svgBlip xmlns:asvg="http://schemas.microsoft.com/office/drawing/2016/SVG/main" r:embed="rId16"/>
-              </a:ext>
-            </a:extLst>
-          </a:blip>
-          <a:stretch>
-            <a:fillRect/>
-          </a:stretch>
-        </p:blipFill>
+        </p:nvSpPr>
         <p:spPr>
           <a:xfrm>
-            <a:off x="6996207" y="3779175"/>
-            <a:ext cx="356382" cy="356382"/>
+            <a:off x="7017170" y="3786206"/>
+            <a:ext cx="314420" cy="342362"/>
           </a:xfrm>
-          <a:prstGeom prst="rect">
+          <a:custGeom>
             <a:avLst/>
-          </a:prstGeom>
+            <a:gdLst>
+              <a:gd name="connsiteX0" fmla="*/ 129276 w 314420"/>
+              <a:gd name="connsiteY0" fmla="*/ 228460 h 342362"/>
+              <a:gd name="connsiteX1" fmla="*/ 95734 w 314420"/>
+              <a:gd name="connsiteY1" fmla="*/ 199111 h 342362"/>
+              <a:gd name="connsiteX2" fmla="*/ 0 w 314420"/>
+              <a:gd name="connsiteY2" fmla="*/ 147401 h 342362"/>
+              <a:gd name="connsiteX3" fmla="*/ 55903 w 314420"/>
+              <a:gd name="connsiteY3" fmla="*/ 86606 h 342362"/>
+              <a:gd name="connsiteX4" fmla="*/ 97830 w 314420"/>
+              <a:gd name="connsiteY4" fmla="*/ 43980 h 342362"/>
+              <a:gd name="connsiteX5" fmla="*/ 227106 w 314420"/>
+              <a:gd name="connsiteY5" fmla="*/ 20221 h 342362"/>
+              <a:gd name="connsiteX6" fmla="*/ 254359 w 314420"/>
+              <a:gd name="connsiteY6" fmla="*/ 66341 h 342362"/>
+              <a:gd name="connsiteX7" fmla="*/ 292792 w 314420"/>
+              <a:gd name="connsiteY7" fmla="*/ 187232 h 342362"/>
+              <a:gd name="connsiteX8" fmla="*/ 215227 w 314420"/>
+              <a:gd name="connsiteY8" fmla="*/ 204003 h 342362"/>
+              <a:gd name="connsiteX9" fmla="*/ 183781 w 314420"/>
+              <a:gd name="connsiteY9" fmla="*/ 229159 h 342362"/>
+              <a:gd name="connsiteX10" fmla="*/ 206143 w 314420"/>
+              <a:gd name="connsiteY10" fmla="*/ 336074 h 342362"/>
+              <a:gd name="connsiteX11" fmla="*/ 200552 w 314420"/>
+              <a:gd name="connsiteY11" fmla="*/ 342363 h 342362"/>
+              <a:gd name="connsiteX12" fmla="*/ 113902 w 314420"/>
+              <a:gd name="connsiteY12" fmla="*/ 342363 h 342362"/>
+              <a:gd name="connsiteX13" fmla="*/ 108312 w 314420"/>
+              <a:gd name="connsiteY13" fmla="*/ 334676 h 342362"/>
+              <a:gd name="connsiteX14" fmla="*/ 122987 w 314420"/>
+              <a:gd name="connsiteY14" fmla="*/ 292050 h 342362"/>
+              <a:gd name="connsiteX15" fmla="*/ 92240 w 314420"/>
+              <a:gd name="connsiteY15" fmla="*/ 262701 h 342362"/>
+              <a:gd name="connsiteX16" fmla="*/ 92240 w 314420"/>
+              <a:gd name="connsiteY16" fmla="*/ 254315 h 342362"/>
+              <a:gd name="connsiteX17" fmla="*/ 108312 w 314420"/>
+              <a:gd name="connsiteY17" fmla="*/ 239641 h 342362"/>
+              <a:gd name="connsiteX18" fmla="*/ 117396 w 314420"/>
+              <a:gd name="connsiteY18" fmla="*/ 240340 h 342362"/>
+              <a:gd name="connsiteX19" fmla="*/ 128577 w 314420"/>
+              <a:gd name="connsiteY19" fmla="*/ 252219 h 342362"/>
+              <a:gd name="connsiteX20" fmla="*/ 129975 w 314420"/>
+              <a:gd name="connsiteY20" fmla="*/ 228460 h 342362"/>
+              <a:gd name="connsiteX21" fmla="*/ 140456 w 314420"/>
+              <a:gd name="connsiteY21" fmla="*/ 224267 h 342362"/>
+              <a:gd name="connsiteX22" fmla="*/ 138360 w 314420"/>
+              <a:gd name="connsiteY22" fmla="*/ 259207 h 342362"/>
+              <a:gd name="connsiteX23" fmla="*/ 157227 w 314420"/>
+              <a:gd name="connsiteY23" fmla="*/ 270387 h 342362"/>
+              <a:gd name="connsiteX24" fmla="*/ 150239 w 314420"/>
+              <a:gd name="connsiteY24" fmla="*/ 273881 h 342362"/>
+              <a:gd name="connsiteX25" fmla="*/ 111107 w 314420"/>
+              <a:gd name="connsiteY25" fmla="*/ 251520 h 342362"/>
+              <a:gd name="connsiteX26" fmla="*/ 104119 w 314420"/>
+              <a:gd name="connsiteY26" fmla="*/ 258508 h 342362"/>
+              <a:gd name="connsiteX27" fmla="*/ 132770 w 314420"/>
+              <a:gd name="connsiteY27" fmla="*/ 285761 h 342362"/>
+              <a:gd name="connsiteX28" fmla="*/ 134167 w 314420"/>
+              <a:gd name="connsiteY28" fmla="*/ 291351 h 342362"/>
+              <a:gd name="connsiteX29" fmla="*/ 121589 w 314420"/>
+              <a:gd name="connsiteY29" fmla="*/ 331182 h 342362"/>
+              <a:gd name="connsiteX30" fmla="*/ 193564 w 314420"/>
+              <a:gd name="connsiteY30" fmla="*/ 331182 h 342362"/>
+              <a:gd name="connsiteX31" fmla="*/ 170504 w 314420"/>
+              <a:gd name="connsiteY31" fmla="*/ 211689 h 342362"/>
+              <a:gd name="connsiteX32" fmla="*/ 192866 w 314420"/>
+              <a:gd name="connsiteY32" fmla="*/ 129232 h 342362"/>
+              <a:gd name="connsiteX33" fmla="*/ 185179 w 314420"/>
+              <a:gd name="connsiteY33" fmla="*/ 128533 h 342362"/>
+              <a:gd name="connsiteX34" fmla="*/ 169107 w 314420"/>
+              <a:gd name="connsiteY34" fmla="*/ 174653 h 342362"/>
+              <a:gd name="connsiteX35" fmla="*/ 143252 w 314420"/>
+              <a:gd name="connsiteY35" fmla="*/ 177449 h 342362"/>
+              <a:gd name="connsiteX36" fmla="*/ 128577 w 314420"/>
+              <a:gd name="connsiteY36" fmla="*/ 152991 h 342362"/>
+              <a:gd name="connsiteX37" fmla="*/ 118095 w 314420"/>
+              <a:gd name="connsiteY37" fmla="*/ 157184 h 342362"/>
+              <a:gd name="connsiteX38" fmla="*/ 141155 w 314420"/>
+              <a:gd name="connsiteY38" fmla="*/ 207497 h 342362"/>
+              <a:gd name="connsiteX39" fmla="*/ 140456 w 314420"/>
+              <a:gd name="connsiteY39" fmla="*/ 224267 h 342362"/>
+              <a:gd name="connsiteX40" fmla="*/ 182384 w 314420"/>
+              <a:gd name="connsiteY40" fmla="*/ 217280 h 342362"/>
+              <a:gd name="connsiteX41" fmla="*/ 215227 w 314420"/>
+              <a:gd name="connsiteY41" fmla="*/ 192123 h 342362"/>
+              <a:gd name="connsiteX42" fmla="*/ 302575 w 314420"/>
+              <a:gd name="connsiteY42" fmla="*/ 136919 h 342362"/>
+              <a:gd name="connsiteX43" fmla="*/ 286503 w 314420"/>
+              <a:gd name="connsiteY43" fmla="*/ 97088 h 342362"/>
+              <a:gd name="connsiteX44" fmla="*/ 248070 w 314420"/>
+              <a:gd name="connsiteY44" fmla="*/ 76823 h 342362"/>
+              <a:gd name="connsiteX45" fmla="*/ 242480 w 314420"/>
+              <a:gd name="connsiteY45" fmla="*/ 71932 h 342362"/>
+              <a:gd name="connsiteX46" fmla="*/ 132770 w 314420"/>
+              <a:gd name="connsiteY46" fmla="*/ 21619 h 342362"/>
+              <a:gd name="connsiteX47" fmla="*/ 100626 w 314420"/>
+              <a:gd name="connsiteY47" fmla="*/ 54462 h 342362"/>
+              <a:gd name="connsiteX48" fmla="*/ 66385 w 314420"/>
+              <a:gd name="connsiteY48" fmla="*/ 91498 h 342362"/>
+              <a:gd name="connsiteX49" fmla="*/ 25156 w 314420"/>
+              <a:gd name="connsiteY49" fmla="*/ 112461 h 342362"/>
+              <a:gd name="connsiteX50" fmla="*/ 62891 w 314420"/>
+              <a:gd name="connsiteY50" fmla="*/ 197015 h 342362"/>
+              <a:gd name="connsiteX51" fmla="*/ 93638 w 314420"/>
+              <a:gd name="connsiteY51" fmla="*/ 187232 h 342362"/>
+              <a:gd name="connsiteX52" fmla="*/ 102722 w 314420"/>
+              <a:gd name="connsiteY52" fmla="*/ 189328 h 342362"/>
+              <a:gd name="connsiteX53" fmla="*/ 129276 w 314420"/>
+              <a:gd name="connsiteY53" fmla="*/ 216581 h 342362"/>
+              <a:gd name="connsiteX54" fmla="*/ 115300 w 314420"/>
+              <a:gd name="connsiteY54" fmla="*/ 173955 h 342362"/>
+              <a:gd name="connsiteX55" fmla="*/ 129276 w 314420"/>
+              <a:gd name="connsiteY55" fmla="*/ 140413 h 342362"/>
+              <a:gd name="connsiteX56" fmla="*/ 136963 w 314420"/>
+              <a:gd name="connsiteY56" fmla="*/ 143208 h 342362"/>
+              <a:gd name="connsiteX57" fmla="*/ 154432 w 314420"/>
+              <a:gd name="connsiteY57" fmla="*/ 172557 h 342362"/>
+              <a:gd name="connsiteX58" fmla="*/ 157926 w 314420"/>
+              <a:gd name="connsiteY58" fmla="*/ 170461 h 342362"/>
+              <a:gd name="connsiteX59" fmla="*/ 175396 w 314420"/>
+              <a:gd name="connsiteY59" fmla="*/ 120847 h 342362"/>
+              <a:gd name="connsiteX60" fmla="*/ 181685 w 314420"/>
+              <a:gd name="connsiteY60" fmla="*/ 116654 h 342362"/>
+              <a:gd name="connsiteX61" fmla="*/ 199155 w 314420"/>
+              <a:gd name="connsiteY61" fmla="*/ 119449 h 342362"/>
+              <a:gd name="connsiteX62" fmla="*/ 204046 w 314420"/>
+              <a:gd name="connsiteY62" fmla="*/ 125040 h 342362"/>
+              <a:gd name="connsiteX63" fmla="*/ 182384 w 314420"/>
+              <a:gd name="connsiteY63" fmla="*/ 211689 h 342362"/>
+              <a:gd name="connsiteX64" fmla="*/ 182384 w 314420"/>
+              <a:gd name="connsiteY64" fmla="*/ 217280 h 342362"/>
+            </a:gdLst>
+            <a:ahLst/>
+            <a:cxnLst>
+              <a:cxn ang="0">
+                <a:pos x="connsiteX0" y="connsiteY0"/>
+              </a:cxn>
+              <a:cxn ang="0">
+                <a:pos x="connsiteX1" y="connsiteY1"/>
+              </a:cxn>
+              <a:cxn ang="0">
+                <a:pos x="connsiteX2" y="connsiteY2"/>
+              </a:cxn>
+              <a:cxn ang="0">
+                <a:pos x="connsiteX3" y="connsiteY3"/>
+              </a:cxn>
+              <a:cxn ang="0">
+                <a:pos x="connsiteX4" y="connsiteY4"/>
+              </a:cxn>
+              <a:cxn ang="0">
+                <a:pos x="connsiteX5" y="connsiteY5"/>
+              </a:cxn>
+              <a:cxn ang="0">
+                <a:pos x="connsiteX6" y="connsiteY6"/>
+              </a:cxn>
+              <a:cxn ang="0">
+                <a:pos x="connsiteX7" y="connsiteY7"/>
+              </a:cxn>
+              <a:cxn ang="0">
+                <a:pos x="connsiteX8" y="connsiteY8"/>
+              </a:cxn>
+              <a:cxn ang="0">
+                <a:pos x="connsiteX9" y="connsiteY9"/>
+              </a:cxn>
+              <a:cxn ang="0">
+                <a:pos x="connsiteX10" y="connsiteY10"/>
+              </a:cxn>
+              <a:cxn ang="0">
+                <a:pos x="connsiteX11" y="connsiteY11"/>
+              </a:cxn>
+              <a:cxn ang="0">
+                <a:pos x="connsiteX12" y="connsiteY12"/>
+              </a:cxn>
+              <a:cxn ang="0">
+                <a:pos x="connsiteX13" y="connsiteY13"/>
+              </a:cxn>
+              <a:cxn ang="0">
+                <a:pos x="connsiteX14" y="connsiteY14"/>
+              </a:cxn>
+              <a:cxn ang="0">
+                <a:pos x="connsiteX15" y="connsiteY15"/>
+              </a:cxn>
+              <a:cxn ang="0">
+                <a:pos x="connsiteX16" y="connsiteY16"/>
+              </a:cxn>
+              <a:cxn ang="0">
+                <a:pos x="connsiteX17" y="connsiteY17"/>
+              </a:cxn>
+              <a:cxn ang="0">
+                <a:pos x="connsiteX18" y="connsiteY18"/>
+              </a:cxn>
+              <a:cxn ang="0">
+                <a:pos x="connsiteX19" y="connsiteY19"/>
+              </a:cxn>
+              <a:cxn ang="0">
+                <a:pos x="connsiteX20" y="connsiteY20"/>
+              </a:cxn>
+              <a:cxn ang="0">
+                <a:pos x="connsiteX21" y="connsiteY21"/>
+              </a:cxn>
+              <a:cxn ang="0">
+                <a:pos x="connsiteX22" y="connsiteY22"/>
+              </a:cxn>
+              <a:cxn ang="0">
+                <a:pos x="connsiteX23" y="connsiteY23"/>
+              </a:cxn>
+              <a:cxn ang="0">
+                <a:pos x="connsiteX24" y="connsiteY24"/>
+              </a:cxn>
+              <a:cxn ang="0">
+                <a:pos x="connsiteX25" y="connsiteY25"/>
+              </a:cxn>
+              <a:cxn ang="0">
+                <a:pos x="connsiteX26" y="connsiteY26"/>
+              </a:cxn>
+              <a:cxn ang="0">
+                <a:pos x="connsiteX27" y="connsiteY27"/>
+              </a:cxn>
+              <a:cxn ang="0">
+                <a:pos x="connsiteX28" y="connsiteY28"/>
+              </a:cxn>
+              <a:cxn ang="0">
+                <a:pos x="connsiteX29" y="connsiteY29"/>
+              </a:cxn>
+              <a:cxn ang="0">
+                <a:pos x="connsiteX30" y="connsiteY30"/>
+              </a:cxn>
+              <a:cxn ang="0">
+                <a:pos x="connsiteX31" y="connsiteY31"/>
+              </a:cxn>
+              <a:cxn ang="0">
+                <a:pos x="connsiteX32" y="connsiteY32"/>
+              </a:cxn>
+              <a:cxn ang="0">
+                <a:pos x="connsiteX33" y="connsiteY33"/>
+              </a:cxn>
+              <a:cxn ang="0">
+                <a:pos x="connsiteX34" y="connsiteY34"/>
+              </a:cxn>
+              <a:cxn ang="0">
+                <a:pos x="connsiteX35" y="connsiteY35"/>
+              </a:cxn>
+              <a:cxn ang="0">
+                <a:pos x="connsiteX36" y="connsiteY36"/>
+              </a:cxn>
+              <a:cxn ang="0">
+                <a:pos x="connsiteX37" y="connsiteY37"/>
+              </a:cxn>
+              <a:cxn ang="0">
+                <a:pos x="connsiteX38" y="connsiteY38"/>
+              </a:cxn>
+              <a:cxn ang="0">
+                <a:pos x="connsiteX39" y="connsiteY39"/>
+              </a:cxn>
+              <a:cxn ang="0">
+                <a:pos x="connsiteX40" y="connsiteY40"/>
+              </a:cxn>
+              <a:cxn ang="0">
+                <a:pos x="connsiteX41" y="connsiteY41"/>
+              </a:cxn>
+              <a:cxn ang="0">
+                <a:pos x="connsiteX42" y="connsiteY42"/>
+              </a:cxn>
+              <a:cxn ang="0">
+                <a:pos x="connsiteX43" y="connsiteY43"/>
+              </a:cxn>
+              <a:cxn ang="0">
+                <a:pos x="connsiteX44" y="connsiteY44"/>
+              </a:cxn>
+              <a:cxn ang="0">
+                <a:pos x="connsiteX45" y="connsiteY45"/>
+              </a:cxn>
+              <a:cxn ang="0">
+                <a:pos x="connsiteX46" y="connsiteY46"/>
+              </a:cxn>
+              <a:cxn ang="0">
+                <a:pos x="connsiteX47" y="connsiteY47"/>
+              </a:cxn>
+              <a:cxn ang="0">
+                <a:pos x="connsiteX48" y="connsiteY48"/>
+              </a:cxn>
+              <a:cxn ang="0">
+                <a:pos x="connsiteX49" y="connsiteY49"/>
+              </a:cxn>
+              <a:cxn ang="0">
+                <a:pos x="connsiteX50" y="connsiteY50"/>
+              </a:cxn>
+              <a:cxn ang="0">
+                <a:pos x="connsiteX51" y="connsiteY51"/>
+              </a:cxn>
+              <a:cxn ang="0">
+                <a:pos x="connsiteX52" y="connsiteY52"/>
+              </a:cxn>
+              <a:cxn ang="0">
+                <a:pos x="connsiteX53" y="connsiteY53"/>
+              </a:cxn>
+              <a:cxn ang="0">
+                <a:pos x="connsiteX54" y="connsiteY54"/>
+              </a:cxn>
+              <a:cxn ang="0">
+                <a:pos x="connsiteX55" y="connsiteY55"/>
+              </a:cxn>
+              <a:cxn ang="0">
+                <a:pos x="connsiteX56" y="connsiteY56"/>
+              </a:cxn>
+              <a:cxn ang="0">
+                <a:pos x="connsiteX57" y="connsiteY57"/>
+              </a:cxn>
+              <a:cxn ang="0">
+                <a:pos x="connsiteX58" y="connsiteY58"/>
+              </a:cxn>
+              <a:cxn ang="0">
+                <a:pos x="connsiteX59" y="connsiteY59"/>
+              </a:cxn>
+              <a:cxn ang="0">
+                <a:pos x="connsiteX60" y="connsiteY60"/>
+              </a:cxn>
+              <a:cxn ang="0">
+                <a:pos x="connsiteX61" y="connsiteY61"/>
+              </a:cxn>
+              <a:cxn ang="0">
+                <a:pos x="connsiteX62" y="connsiteY62"/>
+              </a:cxn>
+              <a:cxn ang="0">
+                <a:pos x="connsiteX63" y="connsiteY63"/>
+              </a:cxn>
+              <a:cxn ang="0">
+                <a:pos x="connsiteX64" y="connsiteY64"/>
+              </a:cxn>
+            </a:cxnLst>
+            <a:rect l="l" t="t" r="r" b="b"/>
+            <a:pathLst>
+              <a:path w="314420" h="342362">
+                <a:moveTo>
+                  <a:pt x="129276" y="228460"/>
+                </a:moveTo>
+                <a:cubicBezTo>
+                  <a:pt x="115300" y="222171"/>
+                  <a:pt x="103421" y="212388"/>
+                  <a:pt x="95734" y="199111"/>
+                </a:cubicBezTo>
+                <a:cubicBezTo>
+                  <a:pt x="53807" y="223569"/>
+                  <a:pt x="0" y="194918"/>
+                  <a:pt x="0" y="147401"/>
+                </a:cubicBezTo>
+                <a:cubicBezTo>
+                  <a:pt x="0" y="115955"/>
+                  <a:pt x="24458" y="90100"/>
+                  <a:pt x="55903" y="86606"/>
+                </a:cubicBezTo>
+                <a:cubicBezTo>
+                  <a:pt x="57301" y="64944"/>
+                  <a:pt x="74770" y="46775"/>
+                  <a:pt x="97830" y="43980"/>
+                </a:cubicBezTo>
+                <a:cubicBezTo>
+                  <a:pt x="122288" y="-2839"/>
+                  <a:pt x="185878" y="-14718"/>
+                  <a:pt x="227106" y="20221"/>
+                </a:cubicBezTo>
+                <a:cubicBezTo>
+                  <a:pt x="241082" y="32101"/>
+                  <a:pt x="250865" y="48173"/>
+                  <a:pt x="254359" y="66341"/>
+                </a:cubicBezTo>
+                <a:cubicBezTo>
+                  <a:pt x="312358" y="76823"/>
+                  <a:pt x="334720" y="146702"/>
+                  <a:pt x="292792" y="187232"/>
+                </a:cubicBezTo>
+                <a:cubicBezTo>
+                  <a:pt x="272527" y="206798"/>
+                  <a:pt x="242480" y="213087"/>
+                  <a:pt x="215227" y="204003"/>
+                </a:cubicBezTo>
+                <a:cubicBezTo>
+                  <a:pt x="207540" y="215183"/>
+                  <a:pt x="196360" y="223569"/>
+                  <a:pt x="183781" y="229159"/>
+                </a:cubicBezTo>
+                <a:cubicBezTo>
+                  <a:pt x="187275" y="271086"/>
+                  <a:pt x="202649" y="296941"/>
+                  <a:pt x="206143" y="336074"/>
+                </a:cubicBezTo>
+                <a:cubicBezTo>
+                  <a:pt x="206841" y="339568"/>
+                  <a:pt x="204046" y="342363"/>
+                  <a:pt x="200552" y="342363"/>
+                </a:cubicBezTo>
+                <a:lnTo>
+                  <a:pt x="113902" y="342363"/>
+                </a:lnTo>
+                <a:cubicBezTo>
+                  <a:pt x="109710" y="342363"/>
+                  <a:pt x="106915" y="338170"/>
+                  <a:pt x="108312" y="334676"/>
+                </a:cubicBezTo>
+                <a:cubicBezTo>
+                  <a:pt x="114601" y="322098"/>
+                  <a:pt x="120192" y="304628"/>
+                  <a:pt x="122987" y="292050"/>
+                </a:cubicBezTo>
+                <a:lnTo>
+                  <a:pt x="92240" y="262701"/>
+                </a:lnTo>
+                <a:cubicBezTo>
+                  <a:pt x="90144" y="260604"/>
+                  <a:pt x="90144" y="257110"/>
+                  <a:pt x="92240" y="254315"/>
+                </a:cubicBezTo>
+                <a:lnTo>
+                  <a:pt x="108312" y="239641"/>
+                </a:lnTo>
+                <a:cubicBezTo>
+                  <a:pt x="111107" y="236846"/>
+                  <a:pt x="115300" y="237544"/>
+                  <a:pt x="117396" y="240340"/>
+                </a:cubicBezTo>
+                <a:cubicBezTo>
+                  <a:pt x="121123" y="245464"/>
+                  <a:pt x="124850" y="249424"/>
+                  <a:pt x="128577" y="252219"/>
+                </a:cubicBezTo>
+                <a:lnTo>
+                  <a:pt x="129975" y="228460"/>
+                </a:lnTo>
+                <a:close/>
+                <a:moveTo>
+                  <a:pt x="140456" y="224267"/>
+                </a:moveTo>
+                <a:lnTo>
+                  <a:pt x="138360" y="259207"/>
+                </a:lnTo>
+                <a:cubicBezTo>
+                  <a:pt x="148842" y="263400"/>
+                  <a:pt x="158625" y="262701"/>
+                  <a:pt x="157227" y="270387"/>
+                </a:cubicBezTo>
+                <a:cubicBezTo>
+                  <a:pt x="155830" y="273183"/>
+                  <a:pt x="153035" y="274580"/>
+                  <a:pt x="150239" y="273881"/>
+                </a:cubicBezTo>
+                <a:cubicBezTo>
+                  <a:pt x="134167" y="270387"/>
+                  <a:pt x="122288" y="264797"/>
+                  <a:pt x="111107" y="251520"/>
+                </a:cubicBezTo>
+                <a:lnTo>
+                  <a:pt x="104119" y="258508"/>
+                </a:lnTo>
+                <a:lnTo>
+                  <a:pt x="132770" y="285761"/>
+                </a:lnTo>
+                <a:cubicBezTo>
+                  <a:pt x="133469" y="287158"/>
+                  <a:pt x="134167" y="289255"/>
+                  <a:pt x="134167" y="291351"/>
+                </a:cubicBezTo>
+                <a:cubicBezTo>
+                  <a:pt x="131372" y="304628"/>
+                  <a:pt x="127179" y="317905"/>
+                  <a:pt x="121589" y="331182"/>
+                </a:cubicBezTo>
+                <a:lnTo>
+                  <a:pt x="193564" y="331182"/>
+                </a:lnTo>
+                <a:cubicBezTo>
+                  <a:pt x="187974" y="289255"/>
+                  <a:pt x="170504" y="264098"/>
+                  <a:pt x="170504" y="211689"/>
+                </a:cubicBezTo>
+                <a:cubicBezTo>
+                  <a:pt x="170504" y="183039"/>
+                  <a:pt x="189372" y="158581"/>
+                  <a:pt x="192866" y="129232"/>
+                </a:cubicBezTo>
+                <a:lnTo>
+                  <a:pt x="185179" y="128533"/>
+                </a:lnTo>
+                <a:cubicBezTo>
+                  <a:pt x="180986" y="145304"/>
+                  <a:pt x="174697" y="158581"/>
+                  <a:pt x="169107" y="174653"/>
+                </a:cubicBezTo>
+                <a:cubicBezTo>
+                  <a:pt x="164914" y="185135"/>
+                  <a:pt x="150239" y="186533"/>
+                  <a:pt x="143252" y="177449"/>
+                </a:cubicBezTo>
+                <a:cubicBezTo>
+                  <a:pt x="138360" y="169762"/>
+                  <a:pt x="132770" y="161377"/>
+                  <a:pt x="128577" y="152991"/>
+                </a:cubicBezTo>
+                <a:lnTo>
+                  <a:pt x="118095" y="157184"/>
+                </a:lnTo>
+                <a:cubicBezTo>
+                  <a:pt x="123686" y="169762"/>
+                  <a:pt x="141155" y="186533"/>
+                  <a:pt x="141155" y="207497"/>
+                </a:cubicBezTo>
+                <a:cubicBezTo>
+                  <a:pt x="140689" y="213553"/>
+                  <a:pt x="140456" y="219143"/>
+                  <a:pt x="140456" y="224267"/>
+                </a:cubicBezTo>
+                <a:close/>
+                <a:moveTo>
+                  <a:pt x="182384" y="217280"/>
+                </a:moveTo>
+                <a:cubicBezTo>
+                  <a:pt x="207540" y="205400"/>
+                  <a:pt x="205444" y="188629"/>
+                  <a:pt x="215227" y="192123"/>
+                </a:cubicBezTo>
+                <a:cubicBezTo>
+                  <a:pt x="255756" y="209593"/>
+                  <a:pt x="302575" y="180244"/>
+                  <a:pt x="302575" y="136919"/>
+                </a:cubicBezTo>
+                <a:cubicBezTo>
+                  <a:pt x="302575" y="121546"/>
+                  <a:pt x="296286" y="107570"/>
+                  <a:pt x="286503" y="97088"/>
+                </a:cubicBezTo>
+                <a:cubicBezTo>
+                  <a:pt x="277419" y="85907"/>
+                  <a:pt x="263443" y="78920"/>
+                  <a:pt x="248070" y="76823"/>
+                </a:cubicBezTo>
+                <a:cubicBezTo>
+                  <a:pt x="245275" y="76823"/>
+                  <a:pt x="243178" y="74727"/>
+                  <a:pt x="242480" y="71932"/>
+                </a:cubicBezTo>
+                <a:cubicBezTo>
+                  <a:pt x="236889" y="20920"/>
+                  <a:pt x="176793" y="-5634"/>
+                  <a:pt x="132770" y="21619"/>
+                </a:cubicBezTo>
+                <a:cubicBezTo>
+                  <a:pt x="106216" y="37691"/>
+                  <a:pt x="109011" y="54462"/>
+                  <a:pt x="100626" y="54462"/>
+                </a:cubicBezTo>
+                <a:cubicBezTo>
+                  <a:pt x="81059" y="55161"/>
+                  <a:pt x="64987" y="71932"/>
+                  <a:pt x="66385" y="91498"/>
+                </a:cubicBezTo>
+                <a:cubicBezTo>
+                  <a:pt x="67084" y="102678"/>
+                  <a:pt x="47518" y="90799"/>
+                  <a:pt x="25156" y="112461"/>
+                </a:cubicBezTo>
+                <a:cubicBezTo>
+                  <a:pt x="-6289" y="143907"/>
+                  <a:pt x="16771" y="197015"/>
+                  <a:pt x="62891" y="197015"/>
+                </a:cubicBezTo>
+                <a:cubicBezTo>
+                  <a:pt x="73373" y="197015"/>
+                  <a:pt x="85252" y="193521"/>
+                  <a:pt x="93638" y="187232"/>
+                </a:cubicBezTo>
+                <a:cubicBezTo>
+                  <a:pt x="96433" y="185135"/>
+                  <a:pt x="100626" y="185834"/>
+                  <a:pt x="102722" y="189328"/>
+                </a:cubicBezTo>
+                <a:cubicBezTo>
+                  <a:pt x="108312" y="200509"/>
+                  <a:pt x="117396" y="210292"/>
+                  <a:pt x="129276" y="216581"/>
+                </a:cubicBezTo>
+                <a:cubicBezTo>
+                  <a:pt x="129975" y="197015"/>
+                  <a:pt x="127878" y="193521"/>
+                  <a:pt x="115300" y="173955"/>
+                </a:cubicBezTo>
+                <a:cubicBezTo>
+                  <a:pt x="99228" y="149497"/>
+                  <a:pt x="104119" y="151593"/>
+                  <a:pt x="129276" y="140413"/>
+                </a:cubicBezTo>
+                <a:cubicBezTo>
+                  <a:pt x="132071" y="139015"/>
+                  <a:pt x="135565" y="140413"/>
+                  <a:pt x="136963" y="143208"/>
+                </a:cubicBezTo>
+                <a:cubicBezTo>
+                  <a:pt x="139059" y="149497"/>
+                  <a:pt x="150938" y="171160"/>
+                  <a:pt x="154432" y="172557"/>
+                </a:cubicBezTo>
+                <a:cubicBezTo>
+                  <a:pt x="155830" y="173256"/>
+                  <a:pt x="157227" y="172557"/>
+                  <a:pt x="157926" y="170461"/>
+                </a:cubicBezTo>
+                <a:cubicBezTo>
+                  <a:pt x="164215" y="154389"/>
+                  <a:pt x="171203" y="140413"/>
+                  <a:pt x="175396" y="120847"/>
+                </a:cubicBezTo>
+                <a:cubicBezTo>
+                  <a:pt x="175396" y="118052"/>
+                  <a:pt x="178191" y="115955"/>
+                  <a:pt x="181685" y="116654"/>
+                </a:cubicBezTo>
+                <a:lnTo>
+                  <a:pt x="199155" y="119449"/>
+                </a:lnTo>
+                <a:cubicBezTo>
+                  <a:pt x="202649" y="119449"/>
+                  <a:pt x="204745" y="122244"/>
+                  <a:pt x="204046" y="125040"/>
+                </a:cubicBezTo>
+                <a:cubicBezTo>
+                  <a:pt x="201251" y="161377"/>
+                  <a:pt x="182384" y="183738"/>
+                  <a:pt x="182384" y="211689"/>
+                </a:cubicBezTo>
+                <a:cubicBezTo>
+                  <a:pt x="182384" y="213553"/>
+                  <a:pt x="182384" y="215416"/>
+                  <a:pt x="182384" y="217280"/>
+                </a:cubicBezTo>
+                <a:close/>
+              </a:path>
+            </a:pathLst>
+          </a:custGeom>
+          <a:solidFill>
+            <a:srgbClr val="29A31E"/>
+          </a:solidFill>
+          <a:ln w="6910" cap="flat">
+            <a:noFill/>
+            <a:prstDash val="solid"/>
+            <a:miter/>
+          </a:ln>
         </p:spPr>
-      </p:pic>
+        <p:txBody>
+          <a:bodyPr rtlCol="0" anchor="ctr"/>
+          <a:lstStyle/>
+          <a:p>
+            <a:endParaRPr lang="fr-FR"/>
+          </a:p>
+        </p:txBody>
+      </p:sp>
       <p:graphicFrame>
         <p:nvGraphicFramePr>
           <p:cNvPr id="5" name="graph_repartition_sols">
@@ -10204,46 +11565,523 @@
         </p:xfrm>
         <a:graphic>
           <a:graphicData uri="http://schemas.openxmlformats.org/drawingml/2006/chart">
-            <c:chart xmlns:c="http://schemas.openxmlformats.org/drawingml/2006/chart" xmlns:r="http://schemas.openxmlformats.org/officeDocument/2006/relationships" r:id="rId17"/>
+            <c:chart xmlns:c="http://schemas.openxmlformats.org/drawingml/2006/chart" xmlns:r="http://schemas.openxmlformats.org/officeDocument/2006/relationships" r:id="rId6"/>
           </a:graphicData>
         </a:graphic>
       </p:graphicFrame>
-      <p:pic>
-        <p:nvPicPr>
-          <p:cNvPr id="9" name="Graphique 8">
+      <p:sp>
+        <p:nvSpPr>
+          <p:cNvPr id="27" name="Graphique 8">
             <a:extLst>
               <a:ext uri="{FF2B5EF4-FFF2-40B4-BE49-F238E27FC236}">
                 <a16:creationId xmlns:a16="http://schemas.microsoft.com/office/drawing/2014/main" id="{9FC59258-4FDC-0D81-1836-EEE964C64B8A}"/>
               </a:ext>
             </a:extLst>
           </p:cNvPr>
-          <p:cNvPicPr>
-            <a:picLocks noChangeAspect="1"/>
-          </p:cNvPicPr>
+          <p:cNvSpPr/>
           <p:nvPr/>
-        </p:nvPicPr>
-        <p:blipFill>
-          <a:blip r:embed="rId18">
-            <a:extLst>
-              <a:ext uri="{96DAC541-7B7A-43D3-8B79-37D633B846F1}">
-                <asvg:svgBlip xmlns:asvg="http://schemas.microsoft.com/office/drawing/2016/SVG/main" r:embed="rId19"/>
-              </a:ext>
-            </a:extLst>
-          </a:blip>
-          <a:stretch>
-            <a:fillRect/>
-          </a:stretch>
-        </p:blipFill>
+        </p:nvSpPr>
         <p:spPr>
           <a:xfrm>
-            <a:off x="6972020" y="5868400"/>
-            <a:ext cx="365174" cy="365174"/>
+            <a:off x="6972022" y="5868399"/>
+            <a:ext cx="365175" cy="365181"/>
           </a:xfrm>
-          <a:prstGeom prst="rect">
+          <a:custGeom>
             <a:avLst/>
-          </a:prstGeom>
+            <a:gdLst>
+              <a:gd name="connsiteX0" fmla="*/ 178542 w 365175"/>
+              <a:gd name="connsiteY0" fmla="*/ 124431 h 365181"/>
+              <a:gd name="connsiteX1" fmla="*/ 156546 w 365175"/>
+              <a:gd name="connsiteY1" fmla="*/ 85474 h 365181"/>
+              <a:gd name="connsiteX2" fmla="*/ 158772 w 365175"/>
+              <a:gd name="connsiteY2" fmla="*/ 70104 h 365181"/>
+              <a:gd name="connsiteX3" fmla="*/ 346901 w 365175"/>
+              <a:gd name="connsiteY3" fmla="*/ 258105 h 365181"/>
+              <a:gd name="connsiteX4" fmla="*/ 362039 w 365175"/>
+              <a:gd name="connsiteY4" fmla="*/ 258105 h 365181"/>
+              <a:gd name="connsiteX5" fmla="*/ 362039 w 365175"/>
+              <a:gd name="connsiteY5" fmla="*/ 242977 h 365181"/>
+              <a:gd name="connsiteX6" fmla="*/ 138875 w 365175"/>
+              <a:gd name="connsiteY6" fmla="*/ 19964 h 365181"/>
+              <a:gd name="connsiteX7" fmla="*/ 25006 w 365175"/>
+              <a:gd name="connsiteY7" fmla="*/ 85481 h 365181"/>
+              <a:gd name="connsiteX8" fmla="*/ 23207 w 365175"/>
+              <a:gd name="connsiteY8" fmla="*/ 209084 h 365181"/>
+              <a:gd name="connsiteX9" fmla="*/ 57143 w 365175"/>
+              <a:gd name="connsiteY9" fmla="*/ 276070 h 365181"/>
+              <a:gd name="connsiteX10" fmla="*/ 57143 w 365175"/>
+              <a:gd name="connsiteY10" fmla="*/ 354483 h 365181"/>
+              <a:gd name="connsiteX11" fmla="*/ 67849 w 365175"/>
+              <a:gd name="connsiteY11" fmla="*/ 365181 h 365181"/>
+              <a:gd name="connsiteX12" fmla="*/ 329480 w 365175"/>
+              <a:gd name="connsiteY12" fmla="*/ 365181 h 365181"/>
+              <a:gd name="connsiteX13" fmla="*/ 337045 w 365175"/>
+              <a:gd name="connsiteY13" fmla="*/ 346923 h 365181"/>
+              <a:gd name="connsiteX14" fmla="*/ 174316 w 365175"/>
+              <a:gd name="connsiteY14" fmla="*/ 184314 h 365181"/>
+              <a:gd name="connsiteX15" fmla="*/ 181275 w 365175"/>
+              <a:gd name="connsiteY15" fmla="*/ 157425 h 365181"/>
+              <a:gd name="connsiteX16" fmla="*/ 346901 w 365175"/>
+              <a:gd name="connsiteY16" fmla="*/ 322929 h 365181"/>
+              <a:gd name="connsiteX17" fmla="*/ 362039 w 365175"/>
+              <a:gd name="connsiteY17" fmla="*/ 322929 h 365181"/>
+              <a:gd name="connsiteX18" fmla="*/ 362039 w 365175"/>
+              <a:gd name="connsiteY18" fmla="*/ 307803 h 365181"/>
+              <a:gd name="connsiteX19" fmla="*/ 178542 w 365175"/>
+              <a:gd name="connsiteY19" fmla="*/ 124431 h 365181"/>
+              <a:gd name="connsiteX20" fmla="*/ 103005 w 365175"/>
+              <a:gd name="connsiteY20" fmla="*/ 343777 h 365181"/>
+              <a:gd name="connsiteX21" fmla="*/ 78554 w 365175"/>
+              <a:gd name="connsiteY21" fmla="*/ 343777 h 365181"/>
+              <a:gd name="connsiteX22" fmla="*/ 78554 w 365175"/>
+              <a:gd name="connsiteY22" fmla="*/ 283867 h 365181"/>
+              <a:gd name="connsiteX23" fmla="*/ 103005 w 365175"/>
+              <a:gd name="connsiteY23" fmla="*/ 283860 h 365181"/>
+              <a:gd name="connsiteX24" fmla="*/ 103005 w 365175"/>
+              <a:gd name="connsiteY24" fmla="*/ 343777 h 365181"/>
+              <a:gd name="connsiteX25" fmla="*/ 90772 w 365175"/>
+              <a:gd name="connsiteY25" fmla="*/ 263575 h 365181"/>
+              <a:gd name="connsiteX26" fmla="*/ 45089 w 365175"/>
+              <a:gd name="connsiteY26" fmla="*/ 207608 h 365181"/>
+              <a:gd name="connsiteX27" fmla="*/ 42091 w 365175"/>
+              <a:gd name="connsiteY27" fmla="*/ 197865 h 365181"/>
+              <a:gd name="connsiteX28" fmla="*/ 44375 w 365175"/>
+              <a:gd name="connsiteY28" fmla="*/ 96487 h 365181"/>
+              <a:gd name="connsiteX29" fmla="*/ 47216 w 365175"/>
+              <a:gd name="connsiteY29" fmla="*/ 84661 h 365181"/>
+              <a:gd name="connsiteX30" fmla="*/ 90772 w 365175"/>
+              <a:gd name="connsiteY30" fmla="*/ 21455 h 365181"/>
+              <a:gd name="connsiteX31" fmla="*/ 134329 w 365175"/>
+              <a:gd name="connsiteY31" fmla="*/ 84661 h 365181"/>
+              <a:gd name="connsiteX32" fmla="*/ 137170 w 365175"/>
+              <a:gd name="connsiteY32" fmla="*/ 96487 h 365181"/>
+              <a:gd name="connsiteX33" fmla="*/ 139453 w 365175"/>
+              <a:gd name="connsiteY33" fmla="*/ 197865 h 365181"/>
+              <a:gd name="connsiteX34" fmla="*/ 136455 w 365175"/>
+              <a:gd name="connsiteY34" fmla="*/ 207608 h 365181"/>
+              <a:gd name="connsiteX35" fmla="*/ 90772 w 365175"/>
+              <a:gd name="connsiteY35" fmla="*/ 263575 h 365181"/>
+              <a:gd name="connsiteX36" fmla="*/ 124408 w 365175"/>
+              <a:gd name="connsiteY36" fmla="*/ 343777 h 365181"/>
+              <a:gd name="connsiteX37" fmla="*/ 124408 w 365175"/>
+              <a:gd name="connsiteY37" fmla="*/ 295022 h 365181"/>
+              <a:gd name="connsiteX38" fmla="*/ 173211 w 365175"/>
+              <a:gd name="connsiteY38" fmla="*/ 343777 h 365181"/>
+              <a:gd name="connsiteX39" fmla="*/ 124408 w 365175"/>
+              <a:gd name="connsiteY39" fmla="*/ 343777 h 365181"/>
+              <a:gd name="connsiteX40" fmla="*/ 203493 w 365175"/>
+              <a:gd name="connsiteY40" fmla="*/ 343777 h 365181"/>
+              <a:gd name="connsiteX41" fmla="*/ 131238 w 365175"/>
+              <a:gd name="connsiteY41" fmla="*/ 271599 h 365181"/>
+              <a:gd name="connsiteX42" fmla="*/ 148245 w 365175"/>
+              <a:gd name="connsiteY42" fmla="*/ 253319 h 365181"/>
+              <a:gd name="connsiteX43" fmla="*/ 238742 w 365175"/>
+              <a:gd name="connsiteY43" fmla="*/ 343777 h 365181"/>
+              <a:gd name="connsiteX44" fmla="*/ 203493 w 365175"/>
+              <a:gd name="connsiteY44" fmla="*/ 343777 h 365181"/>
+              <a:gd name="connsiteX45" fmla="*/ 303631 w 365175"/>
+              <a:gd name="connsiteY45" fmla="*/ 343777 h 365181"/>
+              <a:gd name="connsiteX46" fmla="*/ 269017 w 365175"/>
+              <a:gd name="connsiteY46" fmla="*/ 343777 h 365181"/>
+              <a:gd name="connsiteX47" fmla="*/ 157139 w 365175"/>
+              <a:gd name="connsiteY47" fmla="*/ 231950 h 365181"/>
+              <a:gd name="connsiteX48" fmla="*/ 158345 w 365175"/>
+              <a:gd name="connsiteY48" fmla="*/ 209077 h 365181"/>
+              <a:gd name="connsiteX49" fmla="*/ 163104 w 365175"/>
+              <a:gd name="connsiteY49" fmla="*/ 203357 h 365181"/>
+              <a:gd name="connsiteX50" fmla="*/ 303631 w 365175"/>
+              <a:gd name="connsiteY50" fmla="*/ 343777 h 365181"/>
+            </a:gdLst>
+            <a:ahLst/>
+            <a:cxnLst>
+              <a:cxn ang="0">
+                <a:pos x="connsiteX0" y="connsiteY0"/>
+              </a:cxn>
+              <a:cxn ang="0">
+                <a:pos x="connsiteX1" y="connsiteY1"/>
+              </a:cxn>
+              <a:cxn ang="0">
+                <a:pos x="connsiteX2" y="connsiteY2"/>
+              </a:cxn>
+              <a:cxn ang="0">
+                <a:pos x="connsiteX3" y="connsiteY3"/>
+              </a:cxn>
+              <a:cxn ang="0">
+                <a:pos x="connsiteX4" y="connsiteY4"/>
+              </a:cxn>
+              <a:cxn ang="0">
+                <a:pos x="connsiteX5" y="connsiteY5"/>
+              </a:cxn>
+              <a:cxn ang="0">
+                <a:pos x="connsiteX6" y="connsiteY6"/>
+              </a:cxn>
+              <a:cxn ang="0">
+                <a:pos x="connsiteX7" y="connsiteY7"/>
+              </a:cxn>
+              <a:cxn ang="0">
+                <a:pos x="connsiteX8" y="connsiteY8"/>
+              </a:cxn>
+              <a:cxn ang="0">
+                <a:pos x="connsiteX9" y="connsiteY9"/>
+              </a:cxn>
+              <a:cxn ang="0">
+                <a:pos x="connsiteX10" y="connsiteY10"/>
+              </a:cxn>
+              <a:cxn ang="0">
+                <a:pos x="connsiteX11" y="connsiteY11"/>
+              </a:cxn>
+              <a:cxn ang="0">
+                <a:pos x="connsiteX12" y="connsiteY12"/>
+              </a:cxn>
+              <a:cxn ang="0">
+                <a:pos x="connsiteX13" y="connsiteY13"/>
+              </a:cxn>
+              <a:cxn ang="0">
+                <a:pos x="connsiteX14" y="connsiteY14"/>
+              </a:cxn>
+              <a:cxn ang="0">
+                <a:pos x="connsiteX15" y="connsiteY15"/>
+              </a:cxn>
+              <a:cxn ang="0">
+                <a:pos x="connsiteX16" y="connsiteY16"/>
+              </a:cxn>
+              <a:cxn ang="0">
+                <a:pos x="connsiteX17" y="connsiteY17"/>
+              </a:cxn>
+              <a:cxn ang="0">
+                <a:pos x="connsiteX18" y="connsiteY18"/>
+              </a:cxn>
+              <a:cxn ang="0">
+                <a:pos x="connsiteX19" y="connsiteY19"/>
+              </a:cxn>
+              <a:cxn ang="0">
+                <a:pos x="connsiteX20" y="connsiteY20"/>
+              </a:cxn>
+              <a:cxn ang="0">
+                <a:pos x="connsiteX21" y="connsiteY21"/>
+              </a:cxn>
+              <a:cxn ang="0">
+                <a:pos x="connsiteX22" y="connsiteY22"/>
+              </a:cxn>
+              <a:cxn ang="0">
+                <a:pos x="connsiteX23" y="connsiteY23"/>
+              </a:cxn>
+              <a:cxn ang="0">
+                <a:pos x="connsiteX24" y="connsiteY24"/>
+              </a:cxn>
+              <a:cxn ang="0">
+                <a:pos x="connsiteX25" y="connsiteY25"/>
+              </a:cxn>
+              <a:cxn ang="0">
+                <a:pos x="connsiteX26" y="connsiteY26"/>
+              </a:cxn>
+              <a:cxn ang="0">
+                <a:pos x="connsiteX27" y="connsiteY27"/>
+              </a:cxn>
+              <a:cxn ang="0">
+                <a:pos x="connsiteX28" y="connsiteY28"/>
+              </a:cxn>
+              <a:cxn ang="0">
+                <a:pos x="connsiteX29" y="connsiteY29"/>
+              </a:cxn>
+              <a:cxn ang="0">
+                <a:pos x="connsiteX30" y="connsiteY30"/>
+              </a:cxn>
+              <a:cxn ang="0">
+                <a:pos x="connsiteX31" y="connsiteY31"/>
+              </a:cxn>
+              <a:cxn ang="0">
+                <a:pos x="connsiteX32" y="connsiteY32"/>
+              </a:cxn>
+              <a:cxn ang="0">
+                <a:pos x="connsiteX33" y="connsiteY33"/>
+              </a:cxn>
+              <a:cxn ang="0">
+                <a:pos x="connsiteX34" y="connsiteY34"/>
+              </a:cxn>
+              <a:cxn ang="0">
+                <a:pos x="connsiteX35" y="connsiteY35"/>
+              </a:cxn>
+              <a:cxn ang="0">
+                <a:pos x="connsiteX36" y="connsiteY36"/>
+              </a:cxn>
+              <a:cxn ang="0">
+                <a:pos x="connsiteX37" y="connsiteY37"/>
+              </a:cxn>
+              <a:cxn ang="0">
+                <a:pos x="connsiteX38" y="connsiteY38"/>
+              </a:cxn>
+              <a:cxn ang="0">
+                <a:pos x="connsiteX39" y="connsiteY39"/>
+              </a:cxn>
+              <a:cxn ang="0">
+                <a:pos x="connsiteX40" y="connsiteY40"/>
+              </a:cxn>
+              <a:cxn ang="0">
+                <a:pos x="connsiteX41" y="connsiteY41"/>
+              </a:cxn>
+              <a:cxn ang="0">
+                <a:pos x="connsiteX42" y="connsiteY42"/>
+              </a:cxn>
+              <a:cxn ang="0">
+                <a:pos x="connsiteX43" y="connsiteY43"/>
+              </a:cxn>
+              <a:cxn ang="0">
+                <a:pos x="connsiteX44" y="connsiteY44"/>
+              </a:cxn>
+              <a:cxn ang="0">
+                <a:pos x="connsiteX45" y="connsiteY45"/>
+              </a:cxn>
+              <a:cxn ang="0">
+                <a:pos x="connsiteX46" y="connsiteY46"/>
+              </a:cxn>
+              <a:cxn ang="0">
+                <a:pos x="connsiteX47" y="connsiteY47"/>
+              </a:cxn>
+              <a:cxn ang="0">
+                <a:pos x="connsiteX48" y="connsiteY48"/>
+              </a:cxn>
+              <a:cxn ang="0">
+                <a:pos x="connsiteX49" y="connsiteY49"/>
+              </a:cxn>
+              <a:cxn ang="0">
+                <a:pos x="connsiteX50" y="connsiteY50"/>
+              </a:cxn>
+            </a:cxnLst>
+            <a:rect l="l" t="t" r="r" b="b"/>
+            <a:pathLst>
+              <a:path w="365175" h="365181">
+                <a:moveTo>
+                  <a:pt x="178542" y="124431"/>
+                </a:moveTo>
+                <a:cubicBezTo>
+                  <a:pt x="174588" y="109909"/>
+                  <a:pt x="167058" y="96487"/>
+                  <a:pt x="156546" y="85474"/>
+                </a:cubicBezTo>
+                <a:cubicBezTo>
+                  <a:pt x="157874" y="80489"/>
+                  <a:pt x="158615" y="75346"/>
+                  <a:pt x="158772" y="70104"/>
+                </a:cubicBezTo>
+                <a:lnTo>
+                  <a:pt x="346901" y="258105"/>
+                </a:lnTo>
+                <a:cubicBezTo>
+                  <a:pt x="351084" y="262284"/>
+                  <a:pt x="357857" y="262284"/>
+                  <a:pt x="362039" y="258105"/>
+                </a:cubicBezTo>
+                <a:cubicBezTo>
+                  <a:pt x="366222" y="253925"/>
+                  <a:pt x="366222" y="247156"/>
+                  <a:pt x="362039" y="242977"/>
+                </a:cubicBezTo>
+                <a:lnTo>
+                  <a:pt x="138875" y="19964"/>
+                </a:lnTo>
+                <a:cubicBezTo>
+                  <a:pt x="89795" y="-28450"/>
+                  <a:pt x="7863" y="18138"/>
+                  <a:pt x="25006" y="85481"/>
+                </a:cubicBezTo>
+                <a:cubicBezTo>
+                  <a:pt x="-7524" y="118276"/>
+                  <a:pt x="-8516" y="175427"/>
+                  <a:pt x="23207" y="209084"/>
+                </a:cubicBezTo>
+                <a:cubicBezTo>
+                  <a:pt x="19789" y="236479"/>
+                  <a:pt x="34355" y="263354"/>
+                  <a:pt x="57143" y="276070"/>
+                </a:cubicBezTo>
+                <a:lnTo>
+                  <a:pt x="57143" y="354483"/>
+                </a:lnTo>
+                <a:cubicBezTo>
+                  <a:pt x="57143" y="360389"/>
+                  <a:pt x="61932" y="365181"/>
+                  <a:pt x="67849" y="365181"/>
+                </a:cubicBezTo>
+                <a:lnTo>
+                  <a:pt x="329480" y="365181"/>
+                </a:lnTo>
+                <a:cubicBezTo>
+                  <a:pt x="338858" y="365281"/>
+                  <a:pt x="343797" y="353549"/>
+                  <a:pt x="337045" y="346923"/>
+                </a:cubicBezTo>
+                <a:lnTo>
+                  <a:pt x="174316" y="184314"/>
+                </a:lnTo>
+                <a:cubicBezTo>
+                  <a:pt x="177993" y="175826"/>
+                  <a:pt x="180341" y="166782"/>
+                  <a:pt x="181275" y="157425"/>
+                </a:cubicBezTo>
+                <a:lnTo>
+                  <a:pt x="346901" y="322929"/>
+                </a:lnTo>
+                <a:cubicBezTo>
+                  <a:pt x="351084" y="327110"/>
+                  <a:pt x="357857" y="327110"/>
+                  <a:pt x="362039" y="322929"/>
+                </a:cubicBezTo>
+                <a:cubicBezTo>
+                  <a:pt x="366222" y="318751"/>
+                  <a:pt x="366222" y="311982"/>
+                  <a:pt x="362039" y="307803"/>
+                </a:cubicBezTo>
+                <a:lnTo>
+                  <a:pt x="178542" y="124431"/>
+                </a:lnTo>
+                <a:close/>
+                <a:moveTo>
+                  <a:pt x="103005" y="343777"/>
+                </a:moveTo>
+                <a:lnTo>
+                  <a:pt x="78554" y="343777"/>
+                </a:lnTo>
+                <a:lnTo>
+                  <a:pt x="78554" y="283867"/>
+                </a:lnTo>
+                <a:cubicBezTo>
+                  <a:pt x="86447" y="285336"/>
+                  <a:pt x="95111" y="285329"/>
+                  <a:pt x="103005" y="283860"/>
+                </a:cubicBezTo>
+                <a:lnTo>
+                  <a:pt x="103005" y="343777"/>
+                </a:lnTo>
+                <a:close/>
+                <a:moveTo>
+                  <a:pt x="90772" y="263575"/>
+                </a:moveTo>
+                <a:cubicBezTo>
+                  <a:pt x="61647" y="263895"/>
+                  <a:pt x="38994" y="236016"/>
+                  <a:pt x="45089" y="207608"/>
+                </a:cubicBezTo>
+                <a:cubicBezTo>
+                  <a:pt x="45803" y="204063"/>
+                  <a:pt x="44675" y="200397"/>
+                  <a:pt x="42091" y="197865"/>
+                </a:cubicBezTo>
+                <a:cubicBezTo>
+                  <a:pt x="13530" y="171133"/>
+                  <a:pt x="14764" y="121949"/>
+                  <a:pt x="44375" y="96487"/>
+                </a:cubicBezTo>
+                <a:cubicBezTo>
+                  <a:pt x="47694" y="93520"/>
+                  <a:pt x="48822" y="88805"/>
+                  <a:pt x="47216" y="84661"/>
+                </a:cubicBezTo>
+                <a:cubicBezTo>
+                  <a:pt x="35297" y="55098"/>
+                  <a:pt x="58763" y="20820"/>
+                  <a:pt x="90772" y="21455"/>
+                </a:cubicBezTo>
+                <a:cubicBezTo>
+                  <a:pt x="122781" y="20827"/>
+                  <a:pt x="146261" y="55105"/>
+                  <a:pt x="134329" y="84661"/>
+                </a:cubicBezTo>
+                <a:cubicBezTo>
+                  <a:pt x="132723" y="88812"/>
+                  <a:pt x="133850" y="93520"/>
+                  <a:pt x="137170" y="96487"/>
+                </a:cubicBezTo>
+                <a:cubicBezTo>
+                  <a:pt x="166781" y="121956"/>
+                  <a:pt x="168015" y="171133"/>
+                  <a:pt x="139453" y="197865"/>
+                </a:cubicBezTo>
+                <a:cubicBezTo>
+                  <a:pt x="136869" y="200397"/>
+                  <a:pt x="135742" y="204063"/>
+                  <a:pt x="136455" y="207608"/>
+                </a:cubicBezTo>
+                <a:cubicBezTo>
+                  <a:pt x="142550" y="236023"/>
+                  <a:pt x="119898" y="263895"/>
+                  <a:pt x="90772" y="263575"/>
+                </a:cubicBezTo>
+                <a:close/>
+                <a:moveTo>
+                  <a:pt x="124408" y="343777"/>
+                </a:moveTo>
+                <a:lnTo>
+                  <a:pt x="124408" y="295022"/>
+                </a:lnTo>
+                <a:lnTo>
+                  <a:pt x="173211" y="343777"/>
+                </a:lnTo>
+                <a:lnTo>
+                  <a:pt x="124408" y="343777"/>
+                </a:lnTo>
+                <a:close/>
+                <a:moveTo>
+                  <a:pt x="203493" y="343777"/>
+                </a:moveTo>
+                <a:lnTo>
+                  <a:pt x="131238" y="271599"/>
+                </a:lnTo>
+                <a:cubicBezTo>
+                  <a:pt x="137968" y="266606"/>
+                  <a:pt x="143743" y="260408"/>
+                  <a:pt x="148245" y="253319"/>
+                </a:cubicBezTo>
+                <a:lnTo>
+                  <a:pt x="238742" y="343777"/>
+                </a:lnTo>
+                <a:lnTo>
+                  <a:pt x="203493" y="343777"/>
+                </a:lnTo>
+                <a:close/>
+                <a:moveTo>
+                  <a:pt x="303631" y="343777"/>
+                </a:moveTo>
+                <a:lnTo>
+                  <a:pt x="269017" y="343777"/>
+                </a:lnTo>
+                <a:lnTo>
+                  <a:pt x="157139" y="231950"/>
+                </a:lnTo>
+                <a:cubicBezTo>
+                  <a:pt x="158809" y="224639"/>
+                  <a:pt x="159243" y="216666"/>
+                  <a:pt x="158345" y="209077"/>
+                </a:cubicBezTo>
+                <a:cubicBezTo>
+                  <a:pt x="160015" y="207230"/>
+                  <a:pt x="161599" y="205318"/>
+                  <a:pt x="163104" y="203357"/>
+                </a:cubicBezTo>
+                <a:lnTo>
+                  <a:pt x="303631" y="343777"/>
+                </a:lnTo>
+                <a:close/>
+              </a:path>
+            </a:pathLst>
+          </a:custGeom>
+          <a:solidFill>
+            <a:srgbClr val="78719E"/>
+          </a:solidFill>
+          <a:ln w="12065" cap="flat">
+            <a:noFill/>
+            <a:prstDash val="solid"/>
+            <a:miter/>
+          </a:ln>
         </p:spPr>
-      </p:pic>
+        <p:txBody>
+          <a:bodyPr rtlCol="0" anchor="ctr"/>
+          <a:lstStyle/>
+          <a:p>
+            <a:endParaRPr lang="fr-FR"/>
+          </a:p>
+        </p:txBody>
+      </p:sp>
       <p:sp>
         <p:nvSpPr>
           <p:cNvPr id="10" name="zone_coeff_perm_resultat">
@@ -10367,6 +12205,830 @@
           </a:p>
         </p:txBody>
       </p:sp>
+      <p:grpSp>
+        <p:nvGrpSpPr>
+          <p:cNvPr id="18" name="Graphique 52">
+            <a:extLst>
+              <a:ext uri="{FF2B5EF4-FFF2-40B4-BE49-F238E27FC236}">
+                <a16:creationId xmlns:a16="http://schemas.microsoft.com/office/drawing/2014/main" id="{0E55B21E-96AC-A97D-5059-A3C250A169CD}"/>
+              </a:ext>
+            </a:extLst>
+          </p:cNvPr>
+          <p:cNvGrpSpPr/>
+          <p:nvPr/>
+        </p:nvGrpSpPr>
+        <p:grpSpPr>
+          <a:xfrm>
+            <a:off x="7021450" y="1274729"/>
+            <a:ext cx="334808" cy="308024"/>
+            <a:chOff x="7021450" y="1274729"/>
+            <a:chExt cx="334808" cy="308024"/>
+          </a:xfrm>
+          <a:solidFill>
+            <a:srgbClr val="3B87FF"/>
+          </a:solidFill>
+        </p:grpSpPr>
+        <p:sp>
+          <p:nvSpPr>
+            <p:cNvPr id="20" name="Forme libre : forme 19">
+              <a:extLst>
+                <a:ext uri="{FF2B5EF4-FFF2-40B4-BE49-F238E27FC236}">
+                  <a16:creationId xmlns:a16="http://schemas.microsoft.com/office/drawing/2014/main" id="{2F3875D5-2D0C-8C9E-793E-856F552EE1B3}"/>
+                </a:ext>
+              </a:extLst>
+            </p:cNvPr>
+            <p:cNvSpPr/>
+            <p:nvPr/>
+          </p:nvSpPr>
+          <p:spPr>
+            <a:xfrm>
+              <a:off x="7021450" y="1274729"/>
+              <a:ext cx="334808" cy="241731"/>
+            </a:xfrm>
+            <a:custGeom>
+              <a:avLst/>
+              <a:gdLst>
+                <a:gd name="connsiteX0" fmla="*/ 334809 w 334808"/>
+                <a:gd name="connsiteY0" fmla="*/ 136602 h 241731"/>
+                <a:gd name="connsiteX1" fmla="*/ 283248 w 334808"/>
+                <a:gd name="connsiteY1" fmla="*/ 84372 h 241731"/>
+                <a:gd name="connsiteX2" fmla="*/ 227000 w 334808"/>
+                <a:gd name="connsiteY2" fmla="*/ 34820 h 241731"/>
+                <a:gd name="connsiteX3" fmla="*/ 208921 w 334808"/>
+                <a:gd name="connsiteY3" fmla="*/ 37499 h 241731"/>
+                <a:gd name="connsiteX4" fmla="*/ 135263 w 334808"/>
+                <a:gd name="connsiteY4" fmla="*/ 0 h 241731"/>
+                <a:gd name="connsiteX5" fmla="*/ 46204 w 334808"/>
+                <a:gd name="connsiteY5" fmla="*/ 84372 h 241731"/>
+                <a:gd name="connsiteX6" fmla="*/ 15401 w 334808"/>
+                <a:gd name="connsiteY6" fmla="*/ 99773 h 241731"/>
+                <a:gd name="connsiteX7" fmla="*/ 0 w 334808"/>
+                <a:gd name="connsiteY7" fmla="*/ 136602 h 241731"/>
+                <a:gd name="connsiteX8" fmla="*/ 40177 w 334808"/>
+                <a:gd name="connsiteY8" fmla="*/ 186823 h 241731"/>
+                <a:gd name="connsiteX9" fmla="*/ 37499 w 334808"/>
+                <a:gd name="connsiteY9" fmla="*/ 191511 h 241731"/>
+                <a:gd name="connsiteX10" fmla="*/ 43525 w 334808"/>
+                <a:gd name="connsiteY10" fmla="*/ 231688 h 241731"/>
+                <a:gd name="connsiteX11" fmla="*/ 68301 w 334808"/>
+                <a:gd name="connsiteY11" fmla="*/ 241732 h 241731"/>
+                <a:gd name="connsiteX12" fmla="*/ 93077 w 334808"/>
+                <a:gd name="connsiteY12" fmla="*/ 231688 h 241731"/>
+                <a:gd name="connsiteX13" fmla="*/ 99103 w 334808"/>
+                <a:gd name="connsiteY13" fmla="*/ 191511 h 241731"/>
+                <a:gd name="connsiteX14" fmla="*/ 97764 w 334808"/>
+                <a:gd name="connsiteY14" fmla="*/ 188832 h 241731"/>
+                <a:gd name="connsiteX15" fmla="*/ 237045 w 334808"/>
+                <a:gd name="connsiteY15" fmla="*/ 188832 h 241731"/>
+                <a:gd name="connsiteX16" fmla="*/ 235705 w 334808"/>
+                <a:gd name="connsiteY16" fmla="*/ 191511 h 241731"/>
+                <a:gd name="connsiteX17" fmla="*/ 241732 w 334808"/>
+                <a:gd name="connsiteY17" fmla="*/ 231688 h 241731"/>
+                <a:gd name="connsiteX18" fmla="*/ 266508 w 334808"/>
+                <a:gd name="connsiteY18" fmla="*/ 241732 h 241731"/>
+                <a:gd name="connsiteX19" fmla="*/ 291284 w 334808"/>
+                <a:gd name="connsiteY19" fmla="*/ 231688 h 241731"/>
+                <a:gd name="connsiteX20" fmla="*/ 297310 w 334808"/>
+                <a:gd name="connsiteY20" fmla="*/ 191511 h 241731"/>
+                <a:gd name="connsiteX21" fmla="*/ 295301 w 334808"/>
+                <a:gd name="connsiteY21" fmla="*/ 186823 h 241731"/>
+                <a:gd name="connsiteX22" fmla="*/ 319408 w 334808"/>
+                <a:gd name="connsiteY22" fmla="*/ 173431 h 241731"/>
+                <a:gd name="connsiteX23" fmla="*/ 334809 w 334808"/>
+                <a:gd name="connsiteY23" fmla="*/ 136602 h 241731"/>
+                <a:gd name="connsiteX24" fmla="*/ 85041 w 334808"/>
+                <a:gd name="connsiteY24" fmla="*/ 222983 h 241731"/>
+                <a:gd name="connsiteX25" fmla="*/ 52230 w 334808"/>
+                <a:gd name="connsiteY25" fmla="*/ 222983 h 241731"/>
+                <a:gd name="connsiteX26" fmla="*/ 48212 w 334808"/>
+                <a:gd name="connsiteY26" fmla="*/ 196868 h 241731"/>
+                <a:gd name="connsiteX27" fmla="*/ 68301 w 334808"/>
+                <a:gd name="connsiteY27" fmla="*/ 159369 h 241731"/>
+                <a:gd name="connsiteX28" fmla="*/ 89059 w 334808"/>
+                <a:gd name="connsiteY28" fmla="*/ 196868 h 241731"/>
+                <a:gd name="connsiteX29" fmla="*/ 85041 w 334808"/>
+                <a:gd name="connsiteY29" fmla="*/ 222983 h 241731"/>
+                <a:gd name="connsiteX30" fmla="*/ 282579 w 334808"/>
+                <a:gd name="connsiteY30" fmla="*/ 222983 h 241731"/>
+                <a:gd name="connsiteX31" fmla="*/ 249767 w 334808"/>
+                <a:gd name="connsiteY31" fmla="*/ 222983 h 241731"/>
+                <a:gd name="connsiteX32" fmla="*/ 245750 w 334808"/>
+                <a:gd name="connsiteY32" fmla="*/ 196868 h 241731"/>
+                <a:gd name="connsiteX33" fmla="*/ 266508 w 334808"/>
+                <a:gd name="connsiteY33" fmla="*/ 159369 h 241731"/>
+                <a:gd name="connsiteX34" fmla="*/ 286596 w 334808"/>
+                <a:gd name="connsiteY34" fmla="*/ 196868 h 241731"/>
+                <a:gd name="connsiteX35" fmla="*/ 282579 w 334808"/>
+                <a:gd name="connsiteY35" fmla="*/ 222983 h 241731"/>
+                <a:gd name="connsiteX36" fmla="*/ 289275 w 334808"/>
+                <a:gd name="connsiteY36" fmla="*/ 176109 h 241731"/>
+                <a:gd name="connsiteX37" fmla="*/ 271865 w 334808"/>
+                <a:gd name="connsiteY37" fmla="*/ 143968 h 241731"/>
+                <a:gd name="connsiteX38" fmla="*/ 261151 w 334808"/>
+                <a:gd name="connsiteY38" fmla="*/ 143968 h 241731"/>
+                <a:gd name="connsiteX39" fmla="*/ 243071 w 334808"/>
+                <a:gd name="connsiteY39" fmla="*/ 176779 h 241731"/>
+                <a:gd name="connsiteX40" fmla="*/ 91738 w 334808"/>
+                <a:gd name="connsiteY40" fmla="*/ 176779 h 241731"/>
+                <a:gd name="connsiteX41" fmla="*/ 73658 w 334808"/>
+                <a:gd name="connsiteY41" fmla="*/ 143968 h 241731"/>
+                <a:gd name="connsiteX42" fmla="*/ 62944 w 334808"/>
+                <a:gd name="connsiteY42" fmla="*/ 143968 h 241731"/>
+                <a:gd name="connsiteX43" fmla="*/ 45534 w 334808"/>
+                <a:gd name="connsiteY43" fmla="*/ 176109 h 241731"/>
+                <a:gd name="connsiteX44" fmla="*/ 12053 w 334808"/>
+                <a:gd name="connsiteY44" fmla="*/ 136602 h 241731"/>
+                <a:gd name="connsiteX45" fmla="*/ 24106 w 334808"/>
+                <a:gd name="connsiteY45" fmla="*/ 107808 h 241731"/>
+                <a:gd name="connsiteX46" fmla="*/ 52900 w 334808"/>
+                <a:gd name="connsiteY46" fmla="*/ 95755 h 241731"/>
+                <a:gd name="connsiteX47" fmla="*/ 58257 w 334808"/>
+                <a:gd name="connsiteY47" fmla="*/ 89729 h 241731"/>
+                <a:gd name="connsiteX48" fmla="*/ 58257 w 334808"/>
+                <a:gd name="connsiteY48" fmla="*/ 87050 h 241731"/>
+                <a:gd name="connsiteX49" fmla="*/ 135263 w 334808"/>
+                <a:gd name="connsiteY49" fmla="*/ 11384 h 241731"/>
+                <a:gd name="connsiteX50" fmla="*/ 201555 w 334808"/>
+                <a:gd name="connsiteY50" fmla="*/ 47543 h 241731"/>
+                <a:gd name="connsiteX51" fmla="*/ 212938 w 334808"/>
+                <a:gd name="connsiteY51" fmla="*/ 87050 h 241731"/>
+                <a:gd name="connsiteX52" fmla="*/ 218295 w 334808"/>
+                <a:gd name="connsiteY52" fmla="*/ 92407 h 241731"/>
+                <a:gd name="connsiteX53" fmla="*/ 224322 w 334808"/>
+                <a:gd name="connsiteY53" fmla="*/ 87050 h 241731"/>
+                <a:gd name="connsiteX54" fmla="*/ 214947 w 334808"/>
+                <a:gd name="connsiteY54" fmla="*/ 48212 h 241731"/>
+                <a:gd name="connsiteX55" fmla="*/ 227000 w 334808"/>
+                <a:gd name="connsiteY55" fmla="*/ 46204 h 241731"/>
+                <a:gd name="connsiteX56" fmla="*/ 271865 w 334808"/>
+                <a:gd name="connsiteY56" fmla="*/ 89729 h 241731"/>
+                <a:gd name="connsiteX57" fmla="*/ 277891 w 334808"/>
+                <a:gd name="connsiteY57" fmla="*/ 95755 h 241731"/>
+                <a:gd name="connsiteX58" fmla="*/ 281239 w 334808"/>
+                <a:gd name="connsiteY58" fmla="*/ 95755 h 241731"/>
+                <a:gd name="connsiteX59" fmla="*/ 322756 w 334808"/>
+                <a:gd name="connsiteY59" fmla="*/ 136602 h 241731"/>
+                <a:gd name="connsiteX60" fmla="*/ 310703 w 334808"/>
+                <a:gd name="connsiteY60" fmla="*/ 165396 h 241731"/>
+                <a:gd name="connsiteX61" fmla="*/ 289275 w 334808"/>
+                <a:gd name="connsiteY61" fmla="*/ 176109 h 241731"/>
+              </a:gdLst>
+              <a:ahLst/>
+              <a:cxnLst>
+                <a:cxn ang="0">
+                  <a:pos x="connsiteX0" y="connsiteY0"/>
+                </a:cxn>
+                <a:cxn ang="0">
+                  <a:pos x="connsiteX1" y="connsiteY1"/>
+                </a:cxn>
+                <a:cxn ang="0">
+                  <a:pos x="connsiteX2" y="connsiteY2"/>
+                </a:cxn>
+                <a:cxn ang="0">
+                  <a:pos x="connsiteX3" y="connsiteY3"/>
+                </a:cxn>
+                <a:cxn ang="0">
+                  <a:pos x="connsiteX4" y="connsiteY4"/>
+                </a:cxn>
+                <a:cxn ang="0">
+                  <a:pos x="connsiteX5" y="connsiteY5"/>
+                </a:cxn>
+                <a:cxn ang="0">
+                  <a:pos x="connsiteX6" y="connsiteY6"/>
+                </a:cxn>
+                <a:cxn ang="0">
+                  <a:pos x="connsiteX7" y="connsiteY7"/>
+                </a:cxn>
+                <a:cxn ang="0">
+                  <a:pos x="connsiteX8" y="connsiteY8"/>
+                </a:cxn>
+                <a:cxn ang="0">
+                  <a:pos x="connsiteX9" y="connsiteY9"/>
+                </a:cxn>
+                <a:cxn ang="0">
+                  <a:pos x="connsiteX10" y="connsiteY10"/>
+                </a:cxn>
+                <a:cxn ang="0">
+                  <a:pos x="connsiteX11" y="connsiteY11"/>
+                </a:cxn>
+                <a:cxn ang="0">
+                  <a:pos x="connsiteX12" y="connsiteY12"/>
+                </a:cxn>
+                <a:cxn ang="0">
+                  <a:pos x="connsiteX13" y="connsiteY13"/>
+                </a:cxn>
+                <a:cxn ang="0">
+                  <a:pos x="connsiteX14" y="connsiteY14"/>
+                </a:cxn>
+                <a:cxn ang="0">
+                  <a:pos x="connsiteX15" y="connsiteY15"/>
+                </a:cxn>
+                <a:cxn ang="0">
+                  <a:pos x="connsiteX16" y="connsiteY16"/>
+                </a:cxn>
+                <a:cxn ang="0">
+                  <a:pos x="connsiteX17" y="connsiteY17"/>
+                </a:cxn>
+                <a:cxn ang="0">
+                  <a:pos x="connsiteX18" y="connsiteY18"/>
+                </a:cxn>
+                <a:cxn ang="0">
+                  <a:pos x="connsiteX19" y="connsiteY19"/>
+                </a:cxn>
+                <a:cxn ang="0">
+                  <a:pos x="connsiteX20" y="connsiteY20"/>
+                </a:cxn>
+                <a:cxn ang="0">
+                  <a:pos x="connsiteX21" y="connsiteY21"/>
+                </a:cxn>
+                <a:cxn ang="0">
+                  <a:pos x="connsiteX22" y="connsiteY22"/>
+                </a:cxn>
+                <a:cxn ang="0">
+                  <a:pos x="connsiteX23" y="connsiteY23"/>
+                </a:cxn>
+                <a:cxn ang="0">
+                  <a:pos x="connsiteX24" y="connsiteY24"/>
+                </a:cxn>
+                <a:cxn ang="0">
+                  <a:pos x="connsiteX25" y="connsiteY25"/>
+                </a:cxn>
+                <a:cxn ang="0">
+                  <a:pos x="connsiteX26" y="connsiteY26"/>
+                </a:cxn>
+                <a:cxn ang="0">
+                  <a:pos x="connsiteX27" y="connsiteY27"/>
+                </a:cxn>
+                <a:cxn ang="0">
+                  <a:pos x="connsiteX28" y="connsiteY28"/>
+                </a:cxn>
+                <a:cxn ang="0">
+                  <a:pos x="connsiteX29" y="connsiteY29"/>
+                </a:cxn>
+                <a:cxn ang="0">
+                  <a:pos x="connsiteX30" y="connsiteY30"/>
+                </a:cxn>
+                <a:cxn ang="0">
+                  <a:pos x="connsiteX31" y="connsiteY31"/>
+                </a:cxn>
+                <a:cxn ang="0">
+                  <a:pos x="connsiteX32" y="connsiteY32"/>
+                </a:cxn>
+                <a:cxn ang="0">
+                  <a:pos x="connsiteX33" y="connsiteY33"/>
+                </a:cxn>
+                <a:cxn ang="0">
+                  <a:pos x="connsiteX34" y="connsiteY34"/>
+                </a:cxn>
+                <a:cxn ang="0">
+                  <a:pos x="connsiteX35" y="connsiteY35"/>
+                </a:cxn>
+                <a:cxn ang="0">
+                  <a:pos x="connsiteX36" y="connsiteY36"/>
+                </a:cxn>
+                <a:cxn ang="0">
+                  <a:pos x="connsiteX37" y="connsiteY37"/>
+                </a:cxn>
+                <a:cxn ang="0">
+                  <a:pos x="connsiteX38" y="connsiteY38"/>
+                </a:cxn>
+                <a:cxn ang="0">
+                  <a:pos x="connsiteX39" y="connsiteY39"/>
+                </a:cxn>
+                <a:cxn ang="0">
+                  <a:pos x="connsiteX40" y="connsiteY40"/>
+                </a:cxn>
+                <a:cxn ang="0">
+                  <a:pos x="connsiteX41" y="connsiteY41"/>
+                </a:cxn>
+                <a:cxn ang="0">
+                  <a:pos x="connsiteX42" y="connsiteY42"/>
+                </a:cxn>
+                <a:cxn ang="0">
+                  <a:pos x="connsiteX43" y="connsiteY43"/>
+                </a:cxn>
+                <a:cxn ang="0">
+                  <a:pos x="connsiteX44" y="connsiteY44"/>
+                </a:cxn>
+                <a:cxn ang="0">
+                  <a:pos x="connsiteX45" y="connsiteY45"/>
+                </a:cxn>
+                <a:cxn ang="0">
+                  <a:pos x="connsiteX46" y="connsiteY46"/>
+                </a:cxn>
+                <a:cxn ang="0">
+                  <a:pos x="connsiteX47" y="connsiteY47"/>
+                </a:cxn>
+                <a:cxn ang="0">
+                  <a:pos x="connsiteX48" y="connsiteY48"/>
+                </a:cxn>
+                <a:cxn ang="0">
+                  <a:pos x="connsiteX49" y="connsiteY49"/>
+                </a:cxn>
+                <a:cxn ang="0">
+                  <a:pos x="connsiteX50" y="connsiteY50"/>
+                </a:cxn>
+                <a:cxn ang="0">
+                  <a:pos x="connsiteX51" y="connsiteY51"/>
+                </a:cxn>
+                <a:cxn ang="0">
+                  <a:pos x="connsiteX52" y="connsiteY52"/>
+                </a:cxn>
+                <a:cxn ang="0">
+                  <a:pos x="connsiteX53" y="connsiteY53"/>
+                </a:cxn>
+                <a:cxn ang="0">
+                  <a:pos x="connsiteX54" y="connsiteY54"/>
+                </a:cxn>
+                <a:cxn ang="0">
+                  <a:pos x="connsiteX55" y="connsiteY55"/>
+                </a:cxn>
+                <a:cxn ang="0">
+                  <a:pos x="connsiteX56" y="connsiteY56"/>
+                </a:cxn>
+                <a:cxn ang="0">
+                  <a:pos x="connsiteX57" y="connsiteY57"/>
+                </a:cxn>
+                <a:cxn ang="0">
+                  <a:pos x="connsiteX58" y="connsiteY58"/>
+                </a:cxn>
+                <a:cxn ang="0">
+                  <a:pos x="connsiteX59" y="connsiteY59"/>
+                </a:cxn>
+                <a:cxn ang="0">
+                  <a:pos x="connsiteX60" y="connsiteY60"/>
+                </a:cxn>
+                <a:cxn ang="0">
+                  <a:pos x="connsiteX61" y="connsiteY61"/>
+                </a:cxn>
+              </a:cxnLst>
+              <a:rect l="l" t="t" r="r" b="b"/>
+              <a:pathLst>
+                <a:path w="334808" h="241731">
+                  <a:moveTo>
+                    <a:pt x="334809" y="136602"/>
+                  </a:moveTo>
+                  <a:cubicBezTo>
+                    <a:pt x="334809" y="108478"/>
+                    <a:pt x="312042" y="85041"/>
+                    <a:pt x="283248" y="84372"/>
+                  </a:cubicBezTo>
+                  <a:cubicBezTo>
+                    <a:pt x="279900" y="56248"/>
+                    <a:pt x="255794" y="34820"/>
+                    <a:pt x="227000" y="34820"/>
+                  </a:cubicBezTo>
+                  <a:cubicBezTo>
+                    <a:pt x="220751" y="34820"/>
+                    <a:pt x="214724" y="35713"/>
+                    <a:pt x="208921" y="37499"/>
+                  </a:cubicBezTo>
+                  <a:cubicBezTo>
+                    <a:pt x="192180" y="14062"/>
+                    <a:pt x="164726" y="0"/>
+                    <a:pt x="135263" y="0"/>
+                  </a:cubicBezTo>
+                  <a:cubicBezTo>
+                    <a:pt x="87050" y="0"/>
+                    <a:pt x="47543" y="37499"/>
+                    <a:pt x="46204" y="84372"/>
+                  </a:cubicBezTo>
+                  <a:cubicBezTo>
+                    <a:pt x="34820" y="86381"/>
+                    <a:pt x="24106" y="91738"/>
+                    <a:pt x="15401" y="99773"/>
+                  </a:cubicBezTo>
+                  <a:cubicBezTo>
+                    <a:pt x="5357" y="109148"/>
+                    <a:pt x="0" y="122540"/>
+                    <a:pt x="0" y="136602"/>
+                  </a:cubicBezTo>
+                  <a:cubicBezTo>
+                    <a:pt x="0" y="160708"/>
+                    <a:pt x="16740" y="180797"/>
+                    <a:pt x="40177" y="186823"/>
+                  </a:cubicBezTo>
+                  <a:lnTo>
+                    <a:pt x="37499" y="191511"/>
+                  </a:lnTo>
+                  <a:cubicBezTo>
+                    <a:pt x="30133" y="204903"/>
+                    <a:pt x="32811" y="220974"/>
+                    <a:pt x="43525" y="231688"/>
+                  </a:cubicBezTo>
+                  <a:cubicBezTo>
+                    <a:pt x="50891" y="238384"/>
+                    <a:pt x="59596" y="241732"/>
+                    <a:pt x="68301" y="241732"/>
+                  </a:cubicBezTo>
+                  <a:cubicBezTo>
+                    <a:pt x="77676" y="241732"/>
+                    <a:pt x="86381" y="238384"/>
+                    <a:pt x="93077" y="231688"/>
+                  </a:cubicBezTo>
+                  <a:cubicBezTo>
+                    <a:pt x="103791" y="220974"/>
+                    <a:pt x="106469" y="204903"/>
+                    <a:pt x="99103" y="191511"/>
+                  </a:cubicBezTo>
+                  <a:lnTo>
+                    <a:pt x="97764" y="188832"/>
+                  </a:lnTo>
+                  <a:lnTo>
+                    <a:pt x="237045" y="188832"/>
+                  </a:lnTo>
+                  <a:lnTo>
+                    <a:pt x="235705" y="191511"/>
+                  </a:lnTo>
+                  <a:cubicBezTo>
+                    <a:pt x="228340" y="204903"/>
+                    <a:pt x="231018" y="220974"/>
+                    <a:pt x="241732" y="231688"/>
+                  </a:cubicBezTo>
+                  <a:cubicBezTo>
+                    <a:pt x="248428" y="237714"/>
+                    <a:pt x="257133" y="241732"/>
+                    <a:pt x="266508" y="241732"/>
+                  </a:cubicBezTo>
+                  <a:cubicBezTo>
+                    <a:pt x="275882" y="241732"/>
+                    <a:pt x="284588" y="237714"/>
+                    <a:pt x="291284" y="231688"/>
+                  </a:cubicBezTo>
+                  <a:cubicBezTo>
+                    <a:pt x="301998" y="220974"/>
+                    <a:pt x="304676" y="204903"/>
+                    <a:pt x="297310" y="191511"/>
+                  </a:cubicBezTo>
+                  <a:lnTo>
+                    <a:pt x="295301" y="186823"/>
+                  </a:lnTo>
+                  <a:cubicBezTo>
+                    <a:pt x="304006" y="184814"/>
+                    <a:pt x="312711" y="180127"/>
+                    <a:pt x="319408" y="173431"/>
+                  </a:cubicBezTo>
+                  <a:cubicBezTo>
+                    <a:pt x="329452" y="163387"/>
+                    <a:pt x="334809" y="150664"/>
+                    <a:pt x="334809" y="136602"/>
+                  </a:cubicBezTo>
+                  <a:close/>
+                  <a:moveTo>
+                    <a:pt x="85041" y="222983"/>
+                  </a:moveTo>
+                  <a:cubicBezTo>
+                    <a:pt x="75667" y="232357"/>
+                    <a:pt x="60935" y="232357"/>
+                    <a:pt x="52230" y="222983"/>
+                  </a:cubicBezTo>
+                  <a:cubicBezTo>
+                    <a:pt x="44864" y="216287"/>
+                    <a:pt x="43525" y="205573"/>
+                    <a:pt x="48212" y="196868"/>
+                  </a:cubicBezTo>
+                  <a:lnTo>
+                    <a:pt x="68301" y="159369"/>
+                  </a:lnTo>
+                  <a:lnTo>
+                    <a:pt x="89059" y="196868"/>
+                  </a:lnTo>
+                  <a:cubicBezTo>
+                    <a:pt x="93746" y="205573"/>
+                    <a:pt x="91738" y="216287"/>
+                    <a:pt x="85041" y="222983"/>
+                  </a:cubicBezTo>
+                  <a:close/>
+                  <a:moveTo>
+                    <a:pt x="282579" y="222983"/>
+                  </a:moveTo>
+                  <a:cubicBezTo>
+                    <a:pt x="273874" y="231688"/>
+                    <a:pt x="258472" y="231688"/>
+                    <a:pt x="249767" y="222983"/>
+                  </a:cubicBezTo>
+                  <a:cubicBezTo>
+                    <a:pt x="243071" y="216287"/>
+                    <a:pt x="241062" y="205573"/>
+                    <a:pt x="245750" y="196868"/>
+                  </a:cubicBezTo>
+                  <a:lnTo>
+                    <a:pt x="266508" y="159369"/>
+                  </a:lnTo>
+                  <a:lnTo>
+                    <a:pt x="286596" y="196868"/>
+                  </a:lnTo>
+                  <a:cubicBezTo>
+                    <a:pt x="291953" y="205573"/>
+                    <a:pt x="289944" y="216287"/>
+                    <a:pt x="282579" y="222983"/>
+                  </a:cubicBezTo>
+                  <a:close/>
+                  <a:moveTo>
+                    <a:pt x="289275" y="176109"/>
+                  </a:moveTo>
+                  <a:lnTo>
+                    <a:pt x="271865" y="143968"/>
+                  </a:lnTo>
+                  <a:cubicBezTo>
+                    <a:pt x="269856" y="139950"/>
+                    <a:pt x="263160" y="139950"/>
+                    <a:pt x="261151" y="143968"/>
+                  </a:cubicBezTo>
+                  <a:lnTo>
+                    <a:pt x="243071" y="176779"/>
+                  </a:lnTo>
+                  <a:lnTo>
+                    <a:pt x="91738" y="176779"/>
+                  </a:lnTo>
+                  <a:lnTo>
+                    <a:pt x="73658" y="143968"/>
+                  </a:lnTo>
+                  <a:cubicBezTo>
+                    <a:pt x="71649" y="139950"/>
+                    <a:pt x="64953" y="139950"/>
+                    <a:pt x="62944" y="143968"/>
+                  </a:cubicBezTo>
+                  <a:lnTo>
+                    <a:pt x="45534" y="176109"/>
+                  </a:lnTo>
+                  <a:cubicBezTo>
+                    <a:pt x="26115" y="172761"/>
+                    <a:pt x="12053" y="156021"/>
+                    <a:pt x="12053" y="136602"/>
+                  </a:cubicBezTo>
+                  <a:cubicBezTo>
+                    <a:pt x="12053" y="125888"/>
+                    <a:pt x="16071" y="115174"/>
+                    <a:pt x="24106" y="107808"/>
+                  </a:cubicBezTo>
+                  <a:cubicBezTo>
+                    <a:pt x="31472" y="100443"/>
+                    <a:pt x="41516" y="96425"/>
+                    <a:pt x="52900" y="95755"/>
+                  </a:cubicBezTo>
+                  <a:cubicBezTo>
+                    <a:pt x="55578" y="95755"/>
+                    <a:pt x="58257" y="93077"/>
+                    <a:pt x="58257" y="89729"/>
+                  </a:cubicBezTo>
+                  <a:lnTo>
+                    <a:pt x="58257" y="87050"/>
+                  </a:lnTo>
+                  <a:cubicBezTo>
+                    <a:pt x="58257" y="45534"/>
+                    <a:pt x="93077" y="11384"/>
+                    <a:pt x="135263" y="11384"/>
+                  </a:cubicBezTo>
+                  <a:cubicBezTo>
+                    <a:pt x="162717" y="11384"/>
+                    <a:pt x="187493" y="24776"/>
+                    <a:pt x="201555" y="47543"/>
+                  </a:cubicBezTo>
+                  <a:cubicBezTo>
+                    <a:pt x="208921" y="59596"/>
+                    <a:pt x="212938" y="72988"/>
+                    <a:pt x="212938" y="87050"/>
+                  </a:cubicBezTo>
+                  <a:cubicBezTo>
+                    <a:pt x="212938" y="90398"/>
+                    <a:pt x="215617" y="92407"/>
+                    <a:pt x="218295" y="92407"/>
+                  </a:cubicBezTo>
+                  <a:cubicBezTo>
+                    <a:pt x="221643" y="92407"/>
+                    <a:pt x="224322" y="90398"/>
+                    <a:pt x="224322" y="87050"/>
+                  </a:cubicBezTo>
+                  <a:cubicBezTo>
+                    <a:pt x="224322" y="72988"/>
+                    <a:pt x="220974" y="60266"/>
+                    <a:pt x="214947" y="48212"/>
+                  </a:cubicBezTo>
+                  <a:cubicBezTo>
+                    <a:pt x="218965" y="46873"/>
+                    <a:pt x="222983" y="46204"/>
+                    <a:pt x="227000" y="46204"/>
+                  </a:cubicBezTo>
+                  <a:cubicBezTo>
+                    <a:pt x="251776" y="46204"/>
+                    <a:pt x="271865" y="66292"/>
+                    <a:pt x="271865" y="89729"/>
+                  </a:cubicBezTo>
+                  <a:cubicBezTo>
+                    <a:pt x="271865" y="93077"/>
+                    <a:pt x="274543" y="95755"/>
+                    <a:pt x="277891" y="95755"/>
+                  </a:cubicBezTo>
+                  <a:lnTo>
+                    <a:pt x="281239" y="95755"/>
+                  </a:lnTo>
+                  <a:cubicBezTo>
+                    <a:pt x="304006" y="95755"/>
+                    <a:pt x="322756" y="113835"/>
+                    <a:pt x="322756" y="136602"/>
+                  </a:cubicBezTo>
+                  <a:cubicBezTo>
+                    <a:pt x="322756" y="147316"/>
+                    <a:pt x="318738" y="157360"/>
+                    <a:pt x="310703" y="165396"/>
+                  </a:cubicBezTo>
+                  <a:cubicBezTo>
+                    <a:pt x="304676" y="170753"/>
+                    <a:pt x="297310" y="174770"/>
+                    <a:pt x="289275" y="176109"/>
+                  </a:cubicBezTo>
+                  <a:close/>
+                </a:path>
+              </a:pathLst>
+            </a:custGeom>
+            <a:solidFill>
+              <a:srgbClr val="3B87FF"/>
+            </a:solidFill>
+            <a:ln w="6537" cap="flat">
+              <a:noFill/>
+              <a:prstDash val="solid"/>
+              <a:miter/>
+            </a:ln>
+          </p:spPr>
+          <p:txBody>
+            <a:bodyPr rtlCol="0" anchor="ctr"/>
+            <a:lstStyle/>
+            <a:p>
+              <a:endParaRPr lang="fr-FR"/>
+            </a:p>
+          </p:txBody>
+        </p:sp>
+        <p:sp>
+          <p:nvSpPr>
+            <p:cNvPr id="21" name="Forme libre : forme 20">
+              <a:extLst>
+                <a:ext uri="{FF2B5EF4-FFF2-40B4-BE49-F238E27FC236}">
+                  <a16:creationId xmlns:a16="http://schemas.microsoft.com/office/drawing/2014/main" id="{F2C4F611-F2F1-2744-1AF6-4F98758CC782}"/>
+                </a:ext>
+              </a:extLst>
+            </p:cNvPr>
+            <p:cNvSpPr/>
+            <p:nvPr/>
+          </p:nvSpPr>
+          <p:spPr>
+            <a:xfrm>
+              <a:off x="7153895" y="1482478"/>
+              <a:ext cx="69917" cy="100275"/>
+            </a:xfrm>
+            <a:custGeom>
+              <a:avLst/>
+              <a:gdLst>
+                <a:gd name="connsiteX0" fmla="*/ 40315 w 69917"/>
+                <a:gd name="connsiteY0" fmla="*/ 2511 h 100275"/>
+                <a:gd name="connsiteX1" fmla="*/ 29602 w 69917"/>
+                <a:gd name="connsiteY1" fmla="*/ 2511 h 100275"/>
+                <a:gd name="connsiteX2" fmla="*/ 4156 w 69917"/>
+                <a:gd name="connsiteY2" fmla="*/ 50054 h 100275"/>
+                <a:gd name="connsiteX3" fmla="*/ 10183 w 69917"/>
+                <a:gd name="connsiteY3" fmla="*/ 90231 h 100275"/>
+                <a:gd name="connsiteX4" fmla="*/ 34959 w 69917"/>
+                <a:gd name="connsiteY4" fmla="*/ 100275 h 100275"/>
+                <a:gd name="connsiteX5" fmla="*/ 59734 w 69917"/>
+                <a:gd name="connsiteY5" fmla="*/ 90231 h 100275"/>
+                <a:gd name="connsiteX6" fmla="*/ 65761 w 69917"/>
+                <a:gd name="connsiteY6" fmla="*/ 50054 h 100275"/>
+                <a:gd name="connsiteX7" fmla="*/ 51699 w 69917"/>
+                <a:gd name="connsiteY7" fmla="*/ 82196 h 100275"/>
+                <a:gd name="connsiteX8" fmla="*/ 18888 w 69917"/>
+                <a:gd name="connsiteY8" fmla="*/ 82196 h 100275"/>
+                <a:gd name="connsiteX9" fmla="*/ 14870 w 69917"/>
+                <a:gd name="connsiteY9" fmla="*/ 55411 h 100275"/>
+                <a:gd name="connsiteX10" fmla="*/ 34959 w 69917"/>
+                <a:gd name="connsiteY10" fmla="*/ 17912 h 100275"/>
+                <a:gd name="connsiteX11" fmla="*/ 55717 w 69917"/>
+                <a:gd name="connsiteY11" fmla="*/ 55411 h 100275"/>
+                <a:gd name="connsiteX12" fmla="*/ 51699 w 69917"/>
+                <a:gd name="connsiteY12" fmla="*/ 82196 h 100275"/>
+              </a:gdLst>
+              <a:ahLst/>
+              <a:cxnLst>
+                <a:cxn ang="0">
+                  <a:pos x="connsiteX0" y="connsiteY0"/>
+                </a:cxn>
+                <a:cxn ang="0">
+                  <a:pos x="connsiteX1" y="connsiteY1"/>
+                </a:cxn>
+                <a:cxn ang="0">
+                  <a:pos x="connsiteX2" y="connsiteY2"/>
+                </a:cxn>
+                <a:cxn ang="0">
+                  <a:pos x="connsiteX3" y="connsiteY3"/>
+                </a:cxn>
+                <a:cxn ang="0">
+                  <a:pos x="connsiteX4" y="connsiteY4"/>
+                </a:cxn>
+                <a:cxn ang="0">
+                  <a:pos x="connsiteX5" y="connsiteY5"/>
+                </a:cxn>
+                <a:cxn ang="0">
+                  <a:pos x="connsiteX6" y="connsiteY6"/>
+                </a:cxn>
+                <a:cxn ang="0">
+                  <a:pos x="connsiteX7" y="connsiteY7"/>
+                </a:cxn>
+                <a:cxn ang="0">
+                  <a:pos x="connsiteX8" y="connsiteY8"/>
+                </a:cxn>
+                <a:cxn ang="0">
+                  <a:pos x="connsiteX9" y="connsiteY9"/>
+                </a:cxn>
+                <a:cxn ang="0">
+                  <a:pos x="connsiteX10" y="connsiteY10"/>
+                </a:cxn>
+                <a:cxn ang="0">
+                  <a:pos x="connsiteX11" y="connsiteY11"/>
+                </a:cxn>
+                <a:cxn ang="0">
+                  <a:pos x="connsiteX12" y="connsiteY12"/>
+                </a:cxn>
+              </a:cxnLst>
+              <a:rect l="l" t="t" r="r" b="b"/>
+              <a:pathLst>
+                <a:path w="69917" h="100275">
+                  <a:moveTo>
+                    <a:pt x="40315" y="2511"/>
+                  </a:moveTo>
+                  <a:cubicBezTo>
+                    <a:pt x="38307" y="-837"/>
+                    <a:pt x="31610" y="-837"/>
+                    <a:pt x="29602" y="2511"/>
+                  </a:cubicBezTo>
+                  <a:lnTo>
+                    <a:pt x="4156" y="50054"/>
+                  </a:lnTo>
+                  <a:cubicBezTo>
+                    <a:pt x="-3210" y="63446"/>
+                    <a:pt x="-531" y="79517"/>
+                    <a:pt x="10183" y="90231"/>
+                  </a:cubicBezTo>
+                  <a:cubicBezTo>
+                    <a:pt x="16879" y="96927"/>
+                    <a:pt x="25584" y="100275"/>
+                    <a:pt x="34959" y="100275"/>
+                  </a:cubicBezTo>
+                  <a:cubicBezTo>
+                    <a:pt x="44333" y="100275"/>
+                    <a:pt x="53038" y="96927"/>
+                    <a:pt x="59734" y="90231"/>
+                  </a:cubicBezTo>
+                  <a:cubicBezTo>
+                    <a:pt x="70448" y="79517"/>
+                    <a:pt x="73127" y="63446"/>
+                    <a:pt x="65761" y="50054"/>
+                  </a:cubicBezTo>
+                  <a:close/>
+                  <a:moveTo>
+                    <a:pt x="51699" y="82196"/>
+                  </a:moveTo>
+                  <a:cubicBezTo>
+                    <a:pt x="42994" y="90231"/>
+                    <a:pt x="27593" y="90231"/>
+                    <a:pt x="18888" y="82196"/>
+                  </a:cubicBezTo>
+                  <a:cubicBezTo>
+                    <a:pt x="11522" y="74830"/>
+                    <a:pt x="10183" y="64116"/>
+                    <a:pt x="14870" y="55411"/>
+                  </a:cubicBezTo>
+                  <a:lnTo>
+                    <a:pt x="34959" y="17912"/>
+                  </a:lnTo>
+                  <a:lnTo>
+                    <a:pt x="55717" y="55411"/>
+                  </a:lnTo>
+                  <a:cubicBezTo>
+                    <a:pt x="60404" y="64116"/>
+                    <a:pt x="59065" y="74830"/>
+                    <a:pt x="51699" y="82196"/>
+                  </a:cubicBezTo>
+                  <a:close/>
+                </a:path>
+              </a:pathLst>
+            </a:custGeom>
+            <a:solidFill>
+              <a:srgbClr val="3B87FF"/>
+            </a:solidFill>
+            <a:ln w="6537" cap="flat">
+              <a:noFill/>
+              <a:prstDash val="solid"/>
+              <a:miter/>
+            </a:ln>
+          </p:spPr>
+          <p:txBody>
+            <a:bodyPr rtlCol="0" anchor="ctr"/>
+            <a:lstStyle/>
+            <a:p>
+              <a:endParaRPr lang="fr-FR"/>
+            </a:p>
+          </p:txBody>
+        </p:sp>
+      </p:grpSp>
     </p:spTree>
     <p:extLst>
       <p:ext uri="{BB962C8B-B14F-4D97-AF65-F5344CB8AC3E}">
@@ -12428,42 +15090,1368 @@
           </a:p>
         </p:txBody>
       </p:sp>
-      <p:pic>
-        <p:nvPicPr>
-          <p:cNvPr id="8" name="picto_thermometre_baisse_temperature">
-            <a:extLst>
-              <a:ext uri="{FF2B5EF4-FFF2-40B4-BE49-F238E27FC236}">
-                <a16:creationId xmlns:a16="http://schemas.microsoft.com/office/drawing/2014/main" id="{8C67CD90-FD6F-D29F-C16C-E1B92E89FA27}"/>
-              </a:ext>
-            </a:extLst>
-          </p:cNvPr>
-          <p:cNvPicPr>
-            <a:picLocks noChangeAspect="1"/>
-          </p:cNvPicPr>
+      <p:grpSp>
+        <p:nvGrpSpPr>
+          <p:cNvPr id="48" name="picto_thermometre_baisse_temperature">
+            <a:extLst>
+              <a:ext uri="{FF2B5EF4-FFF2-40B4-BE49-F238E27FC236}">
+                <a16:creationId xmlns:a16="http://schemas.microsoft.com/office/drawing/2014/main" id="{CBB3E6B9-4678-4185-2847-5660B7D0B22A}"/>
+              </a:ext>
+            </a:extLst>
+          </p:cNvPr>
+          <p:cNvGrpSpPr/>
           <p:nvPr/>
-        </p:nvPicPr>
-        <p:blipFill>
-          <a:blip r:embed="rId3">
-            <a:extLst>
-              <a:ext uri="{96DAC541-7B7A-43D3-8B79-37D633B846F1}">
-                <asvg:svgBlip xmlns:asvg="http://schemas.microsoft.com/office/drawing/2016/SVG/main" r:embed="rId4"/>
-              </a:ext>
-            </a:extLst>
-          </a:blip>
-          <a:stretch>
-            <a:fillRect/>
-          </a:stretch>
-        </p:blipFill>
-        <p:spPr>
+        </p:nvGrpSpPr>
+        <p:grpSpPr>
           <a:xfrm>
             <a:off x="3047922" y="2349530"/>
             <a:ext cx="705591" cy="705591"/>
+            <a:chOff x="3047922" y="2349530"/>
+            <a:chExt cx="705591" cy="705591"/>
           </a:xfrm>
-          <a:prstGeom prst="rect">
-            <a:avLst/>
-          </a:prstGeom>
-        </p:spPr>
-      </p:pic>
+        </p:grpSpPr>
+        <p:sp>
+          <p:nvSpPr>
+            <p:cNvPr id="35" name="Forme libre : forme 34">
+              <a:extLst>
+                <a:ext uri="{FF2B5EF4-FFF2-40B4-BE49-F238E27FC236}">
+                  <a16:creationId xmlns:a16="http://schemas.microsoft.com/office/drawing/2014/main" id="{36AB6B59-1278-F9DB-D53C-DF0F416D1C60}"/>
+                </a:ext>
+              </a:extLst>
+            </p:cNvPr>
+            <p:cNvSpPr/>
+            <p:nvPr/>
+          </p:nvSpPr>
+          <p:spPr>
+            <a:xfrm>
+              <a:off x="3047922" y="2349530"/>
+              <a:ext cx="705591" cy="705591"/>
+            </a:xfrm>
+            <a:custGeom>
+              <a:avLst/>
+              <a:gdLst>
+                <a:gd name="connsiteX0" fmla="*/ 0 w 705591"/>
+                <a:gd name="connsiteY0" fmla="*/ 0 h 705591"/>
+                <a:gd name="connsiteX1" fmla="*/ 705591 w 705591"/>
+                <a:gd name="connsiteY1" fmla="*/ 0 h 705591"/>
+                <a:gd name="connsiteX2" fmla="*/ 705591 w 705591"/>
+                <a:gd name="connsiteY2" fmla="*/ 705591 h 705591"/>
+                <a:gd name="connsiteX3" fmla="*/ 0 w 705591"/>
+                <a:gd name="connsiteY3" fmla="*/ 705591 h 705591"/>
+              </a:gdLst>
+              <a:ahLst/>
+              <a:cxnLst>
+                <a:cxn ang="0">
+                  <a:pos x="connsiteX0" y="connsiteY0"/>
+                </a:cxn>
+                <a:cxn ang="0">
+                  <a:pos x="connsiteX1" y="connsiteY1"/>
+                </a:cxn>
+                <a:cxn ang="0">
+                  <a:pos x="connsiteX2" y="connsiteY2"/>
+                </a:cxn>
+                <a:cxn ang="0">
+                  <a:pos x="connsiteX3" y="connsiteY3"/>
+                </a:cxn>
+              </a:cxnLst>
+              <a:rect l="l" t="t" r="r" b="b"/>
+              <a:pathLst>
+                <a:path w="705591" h="705591">
+                  <a:moveTo>
+                    <a:pt x="0" y="0"/>
+                  </a:moveTo>
+                  <a:lnTo>
+                    <a:pt x="705591" y="0"/>
+                  </a:lnTo>
+                  <a:lnTo>
+                    <a:pt x="705591" y="705591"/>
+                  </a:lnTo>
+                  <a:lnTo>
+                    <a:pt x="0" y="705591"/>
+                  </a:lnTo>
+                  <a:close/>
+                </a:path>
+              </a:pathLst>
+            </a:custGeom>
+            <a:solidFill>
+              <a:srgbClr val="FFFFFF"/>
+            </a:solidFill>
+            <a:ln w="14097" cap="flat">
+              <a:noFill/>
+              <a:prstDash val="solid"/>
+              <a:miter/>
+            </a:ln>
+          </p:spPr>
+          <p:txBody>
+            <a:bodyPr rtlCol="0" anchor="ctr"/>
+            <a:lstStyle/>
+            <a:p>
+              <a:endParaRPr lang="fr-FR"/>
+            </a:p>
+          </p:txBody>
+        </p:sp>
+        <p:sp>
+          <p:nvSpPr>
+            <p:cNvPr id="36" name="Forme libre : forme 35">
+              <a:extLst>
+                <a:ext uri="{FF2B5EF4-FFF2-40B4-BE49-F238E27FC236}">
+                  <a16:creationId xmlns:a16="http://schemas.microsoft.com/office/drawing/2014/main" id="{3132FF24-074B-71CB-F205-6D23AEEC8BE3}"/>
+                </a:ext>
+              </a:extLst>
+            </p:cNvPr>
+            <p:cNvSpPr/>
+            <p:nvPr/>
+          </p:nvSpPr>
+          <p:spPr>
+            <a:xfrm>
+              <a:off x="3305792" y="2421687"/>
+              <a:ext cx="256174" cy="559066"/>
+            </a:xfrm>
+            <a:custGeom>
+              <a:avLst/>
+              <a:gdLst>
+                <a:gd name="connsiteX0" fmla="*/ 127788 w 256174"/>
+                <a:gd name="connsiteY0" fmla="*/ 74 h 559066"/>
+                <a:gd name="connsiteX1" fmla="*/ 52495 w 256174"/>
+                <a:gd name="connsiteY1" fmla="*/ 62871 h 559066"/>
+                <a:gd name="connsiteX2" fmla="*/ 52495 w 256174"/>
+                <a:gd name="connsiteY2" fmla="*/ 345007 h 559066"/>
+                <a:gd name="connsiteX3" fmla="*/ 0 w 256174"/>
+                <a:gd name="connsiteY3" fmla="*/ 440467 h 559066"/>
+                <a:gd name="connsiteX4" fmla="*/ 128087 w 256174"/>
+                <a:gd name="connsiteY4" fmla="*/ 559067 h 559066"/>
+                <a:gd name="connsiteX5" fmla="*/ 256175 w 256174"/>
+                <a:gd name="connsiteY5" fmla="*/ 440467 h 559066"/>
+                <a:gd name="connsiteX6" fmla="*/ 203456 w 256174"/>
+                <a:gd name="connsiteY6" fmla="*/ 344785 h 559066"/>
+                <a:gd name="connsiteX7" fmla="*/ 203230 w 256174"/>
+                <a:gd name="connsiteY7" fmla="*/ 62796 h 559066"/>
+                <a:gd name="connsiteX8" fmla="*/ 127938 w 256174"/>
+                <a:gd name="connsiteY8" fmla="*/ 0 h 559066"/>
+                <a:gd name="connsiteX9" fmla="*/ 127788 w 256174"/>
+                <a:gd name="connsiteY9" fmla="*/ 74 h 559066"/>
+                <a:gd name="connsiteX10" fmla="*/ 127562 w 256174"/>
+                <a:gd name="connsiteY10" fmla="*/ 14062 h 559066"/>
+                <a:gd name="connsiteX11" fmla="*/ 188082 w 256174"/>
+                <a:gd name="connsiteY11" fmla="*/ 62871 h 559066"/>
+                <a:gd name="connsiteX12" fmla="*/ 188307 w 256174"/>
+                <a:gd name="connsiteY12" fmla="*/ 348133 h 559066"/>
+                <a:gd name="connsiteX13" fmla="*/ 191606 w 256174"/>
+                <a:gd name="connsiteY13" fmla="*/ 353788 h 559066"/>
+                <a:gd name="connsiteX14" fmla="*/ 241026 w 256174"/>
+                <a:gd name="connsiteY14" fmla="*/ 440542 h 559066"/>
+                <a:gd name="connsiteX15" fmla="*/ 128013 w 256174"/>
+                <a:gd name="connsiteY15" fmla="*/ 545153 h 559066"/>
+                <a:gd name="connsiteX16" fmla="*/ 14999 w 256174"/>
+                <a:gd name="connsiteY16" fmla="*/ 440542 h 559066"/>
+                <a:gd name="connsiteX17" fmla="*/ 64195 w 256174"/>
+                <a:gd name="connsiteY17" fmla="*/ 354011 h 559066"/>
+                <a:gd name="connsiteX18" fmla="*/ 67494 w 256174"/>
+                <a:gd name="connsiteY18" fmla="*/ 348356 h 559066"/>
+                <a:gd name="connsiteX19" fmla="*/ 67494 w 256174"/>
+                <a:gd name="connsiteY19" fmla="*/ 62871 h 559066"/>
+                <a:gd name="connsiteX20" fmla="*/ 127488 w 256174"/>
+                <a:gd name="connsiteY20" fmla="*/ 14062 h 559066"/>
+                <a:gd name="connsiteX21" fmla="*/ 127562 w 256174"/>
+                <a:gd name="connsiteY21" fmla="*/ 14062 h 559066"/>
+              </a:gdLst>
+              <a:ahLst/>
+              <a:cxnLst>
+                <a:cxn ang="0">
+                  <a:pos x="connsiteX0" y="connsiteY0"/>
+                </a:cxn>
+                <a:cxn ang="0">
+                  <a:pos x="connsiteX1" y="connsiteY1"/>
+                </a:cxn>
+                <a:cxn ang="0">
+                  <a:pos x="connsiteX2" y="connsiteY2"/>
+                </a:cxn>
+                <a:cxn ang="0">
+                  <a:pos x="connsiteX3" y="connsiteY3"/>
+                </a:cxn>
+                <a:cxn ang="0">
+                  <a:pos x="connsiteX4" y="connsiteY4"/>
+                </a:cxn>
+                <a:cxn ang="0">
+                  <a:pos x="connsiteX5" y="connsiteY5"/>
+                </a:cxn>
+                <a:cxn ang="0">
+                  <a:pos x="connsiteX6" y="connsiteY6"/>
+                </a:cxn>
+                <a:cxn ang="0">
+                  <a:pos x="connsiteX7" y="connsiteY7"/>
+                </a:cxn>
+                <a:cxn ang="0">
+                  <a:pos x="connsiteX8" y="connsiteY8"/>
+                </a:cxn>
+                <a:cxn ang="0">
+                  <a:pos x="connsiteX9" y="connsiteY9"/>
+                </a:cxn>
+                <a:cxn ang="0">
+                  <a:pos x="connsiteX10" y="connsiteY10"/>
+                </a:cxn>
+                <a:cxn ang="0">
+                  <a:pos x="connsiteX11" y="connsiteY11"/>
+                </a:cxn>
+                <a:cxn ang="0">
+                  <a:pos x="connsiteX12" y="connsiteY12"/>
+                </a:cxn>
+                <a:cxn ang="0">
+                  <a:pos x="connsiteX13" y="connsiteY13"/>
+                </a:cxn>
+                <a:cxn ang="0">
+                  <a:pos x="connsiteX14" y="connsiteY14"/>
+                </a:cxn>
+                <a:cxn ang="0">
+                  <a:pos x="connsiteX15" y="connsiteY15"/>
+                </a:cxn>
+                <a:cxn ang="0">
+                  <a:pos x="connsiteX16" y="connsiteY16"/>
+                </a:cxn>
+                <a:cxn ang="0">
+                  <a:pos x="connsiteX17" y="connsiteY17"/>
+                </a:cxn>
+                <a:cxn ang="0">
+                  <a:pos x="connsiteX18" y="connsiteY18"/>
+                </a:cxn>
+                <a:cxn ang="0">
+                  <a:pos x="connsiteX19" y="connsiteY19"/>
+                </a:cxn>
+                <a:cxn ang="0">
+                  <a:pos x="connsiteX20" y="connsiteY20"/>
+                </a:cxn>
+                <a:cxn ang="0">
+                  <a:pos x="connsiteX21" y="connsiteY21"/>
+                </a:cxn>
+              </a:cxnLst>
+              <a:rect l="l" t="t" r="r" b="b"/>
+              <a:pathLst>
+                <a:path w="256174" h="559066">
+                  <a:moveTo>
+                    <a:pt x="127788" y="74"/>
+                  </a:moveTo>
+                  <a:cubicBezTo>
+                    <a:pt x="82793" y="298"/>
+                    <a:pt x="52720" y="21205"/>
+                    <a:pt x="52495" y="62871"/>
+                  </a:cubicBezTo>
+                  <a:lnTo>
+                    <a:pt x="52495" y="345007"/>
+                  </a:lnTo>
+                  <a:cubicBezTo>
+                    <a:pt x="20849" y="366584"/>
+                    <a:pt x="0" y="401331"/>
+                    <a:pt x="0" y="440467"/>
+                  </a:cubicBezTo>
+                  <a:cubicBezTo>
+                    <a:pt x="0" y="505868"/>
+                    <a:pt x="57445" y="559067"/>
+                    <a:pt x="128087" y="559067"/>
+                  </a:cubicBezTo>
+                  <a:cubicBezTo>
+                    <a:pt x="198731" y="559067"/>
+                    <a:pt x="256175" y="505868"/>
+                    <a:pt x="256175" y="440467"/>
+                  </a:cubicBezTo>
+                  <a:cubicBezTo>
+                    <a:pt x="256175" y="401182"/>
+                    <a:pt x="235253" y="366361"/>
+                    <a:pt x="203456" y="344785"/>
+                  </a:cubicBezTo>
+                  <a:cubicBezTo>
+                    <a:pt x="202630" y="212942"/>
+                    <a:pt x="204655" y="187645"/>
+                    <a:pt x="203230" y="62796"/>
+                  </a:cubicBezTo>
+                  <a:cubicBezTo>
+                    <a:pt x="203456" y="21130"/>
+                    <a:pt x="173309" y="223"/>
+                    <a:pt x="127938" y="0"/>
+                  </a:cubicBezTo>
+                  <a:lnTo>
+                    <a:pt x="127788" y="74"/>
+                  </a:lnTo>
+                  <a:close/>
+                  <a:moveTo>
+                    <a:pt x="127562" y="14062"/>
+                  </a:moveTo>
+                  <a:cubicBezTo>
+                    <a:pt x="158160" y="14285"/>
+                    <a:pt x="188307" y="28199"/>
+                    <a:pt x="188082" y="62871"/>
+                  </a:cubicBezTo>
+                  <a:cubicBezTo>
+                    <a:pt x="188607" y="192184"/>
+                    <a:pt x="188307" y="216811"/>
+                    <a:pt x="188307" y="348133"/>
+                  </a:cubicBezTo>
+                  <a:cubicBezTo>
+                    <a:pt x="188307" y="350364"/>
+                    <a:pt x="189581" y="352522"/>
+                    <a:pt x="191606" y="353788"/>
+                  </a:cubicBezTo>
+                  <a:cubicBezTo>
+                    <a:pt x="221454" y="372612"/>
+                    <a:pt x="241026" y="404531"/>
+                    <a:pt x="241026" y="440542"/>
+                  </a:cubicBezTo>
+                  <a:cubicBezTo>
+                    <a:pt x="241026" y="498427"/>
+                    <a:pt x="190556" y="545153"/>
+                    <a:pt x="128013" y="545153"/>
+                  </a:cubicBezTo>
+                  <a:cubicBezTo>
+                    <a:pt x="65469" y="545153"/>
+                    <a:pt x="14999" y="498354"/>
+                    <a:pt x="14999" y="440542"/>
+                  </a:cubicBezTo>
+                  <a:cubicBezTo>
+                    <a:pt x="14999" y="404605"/>
+                    <a:pt x="34498" y="372835"/>
+                    <a:pt x="64195" y="354011"/>
+                  </a:cubicBezTo>
+                  <a:cubicBezTo>
+                    <a:pt x="66218" y="352746"/>
+                    <a:pt x="67419" y="350589"/>
+                    <a:pt x="67494" y="348356"/>
+                  </a:cubicBezTo>
+                  <a:lnTo>
+                    <a:pt x="67494" y="62871"/>
+                  </a:lnTo>
+                  <a:cubicBezTo>
+                    <a:pt x="67718" y="28199"/>
+                    <a:pt x="97865" y="14285"/>
+                    <a:pt x="127488" y="14062"/>
+                  </a:cubicBezTo>
+                  <a:lnTo>
+                    <a:pt x="127562" y="14062"/>
+                  </a:lnTo>
+                  <a:close/>
+                </a:path>
+              </a:pathLst>
+            </a:custGeom>
+            <a:solidFill>
+              <a:srgbClr val="000091"/>
+            </a:solidFill>
+            <a:ln w="14097" cap="flat">
+              <a:solidFill>
+                <a:srgbClr val="000091"/>
+              </a:solidFill>
+              <a:prstDash val="solid"/>
+              <a:miter/>
+            </a:ln>
+          </p:spPr>
+          <p:txBody>
+            <a:bodyPr rtlCol="0" anchor="ctr"/>
+            <a:lstStyle/>
+            <a:p>
+              <a:endParaRPr lang="fr-FR"/>
+            </a:p>
+          </p:txBody>
+        </p:sp>
+        <p:sp>
+          <p:nvSpPr>
+            <p:cNvPr id="37" name="Forme libre : forme 36">
+              <a:extLst>
+                <a:ext uri="{FF2B5EF4-FFF2-40B4-BE49-F238E27FC236}">
+                  <a16:creationId xmlns:a16="http://schemas.microsoft.com/office/drawing/2014/main" id="{9CD76015-2C08-5CAB-5731-9D6EEDB298FD}"/>
+                </a:ext>
+              </a:extLst>
+            </p:cNvPr>
+            <p:cNvSpPr/>
+            <p:nvPr/>
+          </p:nvSpPr>
+          <p:spPr>
+            <a:xfrm>
+              <a:off x="3174928" y="2555530"/>
+              <a:ext cx="130861" cy="203715"/>
+            </a:xfrm>
+            <a:custGeom>
+              <a:avLst/>
+              <a:gdLst>
+                <a:gd name="connsiteX0" fmla="*/ 41171 w 130861"/>
+                <a:gd name="connsiteY0" fmla="*/ 0 h 203715"/>
+                <a:gd name="connsiteX1" fmla="*/ 41171 w 130861"/>
+                <a:gd name="connsiteY1" fmla="*/ 108033 h 203715"/>
+                <a:gd name="connsiteX2" fmla="*/ 0 w 130861"/>
+                <a:gd name="connsiteY2" fmla="*/ 108033 h 203715"/>
+                <a:gd name="connsiteX3" fmla="*/ 65544 w 130861"/>
+                <a:gd name="connsiteY3" fmla="*/ 203715 h 203715"/>
+                <a:gd name="connsiteX4" fmla="*/ 130862 w 130861"/>
+                <a:gd name="connsiteY4" fmla="*/ 108033 h 203715"/>
+                <a:gd name="connsiteX5" fmla="*/ 89841 w 130861"/>
+                <a:gd name="connsiteY5" fmla="*/ 108033 h 203715"/>
+                <a:gd name="connsiteX6" fmla="*/ 89841 w 130861"/>
+                <a:gd name="connsiteY6" fmla="*/ 0 h 203715"/>
+                <a:gd name="connsiteX7" fmla="*/ 41246 w 130861"/>
+                <a:gd name="connsiteY7" fmla="*/ 0 h 203715"/>
+                <a:gd name="connsiteX8" fmla="*/ 41171 w 130861"/>
+                <a:gd name="connsiteY8" fmla="*/ 0 h 203715"/>
+              </a:gdLst>
+              <a:ahLst/>
+              <a:cxnLst>
+                <a:cxn ang="0">
+                  <a:pos x="connsiteX0" y="connsiteY0"/>
+                </a:cxn>
+                <a:cxn ang="0">
+                  <a:pos x="connsiteX1" y="connsiteY1"/>
+                </a:cxn>
+                <a:cxn ang="0">
+                  <a:pos x="connsiteX2" y="connsiteY2"/>
+                </a:cxn>
+                <a:cxn ang="0">
+                  <a:pos x="connsiteX3" y="connsiteY3"/>
+                </a:cxn>
+                <a:cxn ang="0">
+                  <a:pos x="connsiteX4" y="connsiteY4"/>
+                </a:cxn>
+                <a:cxn ang="0">
+                  <a:pos x="connsiteX5" y="connsiteY5"/>
+                </a:cxn>
+                <a:cxn ang="0">
+                  <a:pos x="connsiteX6" y="connsiteY6"/>
+                </a:cxn>
+                <a:cxn ang="0">
+                  <a:pos x="connsiteX7" y="connsiteY7"/>
+                </a:cxn>
+                <a:cxn ang="0">
+                  <a:pos x="connsiteX8" y="connsiteY8"/>
+                </a:cxn>
+              </a:cxnLst>
+              <a:rect l="l" t="t" r="r" b="b"/>
+              <a:pathLst>
+                <a:path w="130861" h="203715">
+                  <a:moveTo>
+                    <a:pt x="41171" y="0"/>
+                  </a:moveTo>
+                  <a:lnTo>
+                    <a:pt x="41171" y="108033"/>
+                  </a:lnTo>
+                  <a:lnTo>
+                    <a:pt x="0" y="108033"/>
+                  </a:lnTo>
+                  <a:cubicBezTo>
+                    <a:pt x="22723" y="145012"/>
+                    <a:pt x="45896" y="171871"/>
+                    <a:pt x="65544" y="203715"/>
+                  </a:cubicBezTo>
+                  <a:cubicBezTo>
+                    <a:pt x="89091" y="164654"/>
+                    <a:pt x="109639" y="142779"/>
+                    <a:pt x="130862" y="108033"/>
+                  </a:cubicBezTo>
+                  <a:lnTo>
+                    <a:pt x="89841" y="108033"/>
+                  </a:lnTo>
+                  <a:lnTo>
+                    <a:pt x="89841" y="0"/>
+                  </a:lnTo>
+                  <a:lnTo>
+                    <a:pt x="41246" y="0"/>
+                  </a:lnTo>
+                  <a:lnTo>
+                    <a:pt x="41171" y="0"/>
+                  </a:lnTo>
+                  <a:close/>
+                </a:path>
+              </a:pathLst>
+            </a:custGeom>
+            <a:solidFill>
+              <a:srgbClr val="000091"/>
+            </a:solidFill>
+            <a:ln w="14097" cap="flat">
+              <a:noFill/>
+              <a:prstDash val="solid"/>
+              <a:miter/>
+            </a:ln>
+          </p:spPr>
+          <p:txBody>
+            <a:bodyPr rtlCol="0" anchor="ctr"/>
+            <a:lstStyle/>
+            <a:p>
+              <a:endParaRPr lang="fr-FR"/>
+            </a:p>
+          </p:txBody>
+        </p:sp>
+        <p:sp>
+          <p:nvSpPr>
+            <p:cNvPr id="38" name="Forme libre : forme 37">
+              <a:extLst>
+                <a:ext uri="{FF2B5EF4-FFF2-40B4-BE49-F238E27FC236}">
+                  <a16:creationId xmlns:a16="http://schemas.microsoft.com/office/drawing/2014/main" id="{6A366F1B-FD39-DF98-F6D7-C2D9D4F6FC86}"/>
+                </a:ext>
+              </a:extLst>
+            </p:cNvPr>
+            <p:cNvSpPr/>
+            <p:nvPr/>
+          </p:nvSpPr>
+          <p:spPr>
+            <a:xfrm>
+              <a:off x="3425288" y="2471685"/>
+              <a:ext cx="46161" cy="14020"/>
+            </a:xfrm>
+            <a:custGeom>
+              <a:avLst/>
+              <a:gdLst>
+                <a:gd name="connsiteX0" fmla="*/ 6866 w 46161"/>
+                <a:gd name="connsiteY0" fmla="*/ 74 h 14020"/>
+                <a:gd name="connsiteX1" fmla="*/ 41 w 46161"/>
+                <a:gd name="connsiteY1" fmla="*/ 7887 h 14020"/>
+                <a:gd name="connsiteX2" fmla="*/ 8515 w 46161"/>
+                <a:gd name="connsiteY2" fmla="*/ 13988 h 14020"/>
+                <a:gd name="connsiteX3" fmla="*/ 38662 w 46161"/>
+                <a:gd name="connsiteY3" fmla="*/ 13988 h 14020"/>
+                <a:gd name="connsiteX4" fmla="*/ 46161 w 46161"/>
+                <a:gd name="connsiteY4" fmla="*/ 6994 h 14020"/>
+                <a:gd name="connsiteX5" fmla="*/ 38662 w 46161"/>
+                <a:gd name="connsiteY5" fmla="*/ 0 h 14020"/>
+                <a:gd name="connsiteX6" fmla="*/ 6866 w 46161"/>
+                <a:gd name="connsiteY6" fmla="*/ 0 h 14020"/>
+                <a:gd name="connsiteX7" fmla="*/ 6866 w 46161"/>
+                <a:gd name="connsiteY7" fmla="*/ 74 h 14020"/>
+              </a:gdLst>
+              <a:ahLst/>
+              <a:cxnLst>
+                <a:cxn ang="0">
+                  <a:pos x="connsiteX0" y="connsiteY0"/>
+                </a:cxn>
+                <a:cxn ang="0">
+                  <a:pos x="connsiteX1" y="connsiteY1"/>
+                </a:cxn>
+                <a:cxn ang="0">
+                  <a:pos x="connsiteX2" y="connsiteY2"/>
+                </a:cxn>
+                <a:cxn ang="0">
+                  <a:pos x="connsiteX3" y="connsiteY3"/>
+                </a:cxn>
+                <a:cxn ang="0">
+                  <a:pos x="connsiteX4" y="connsiteY4"/>
+                </a:cxn>
+                <a:cxn ang="0">
+                  <a:pos x="connsiteX5" y="connsiteY5"/>
+                </a:cxn>
+                <a:cxn ang="0">
+                  <a:pos x="connsiteX6" y="connsiteY6"/>
+                </a:cxn>
+                <a:cxn ang="0">
+                  <a:pos x="connsiteX7" y="connsiteY7"/>
+                </a:cxn>
+              </a:cxnLst>
+              <a:rect l="l" t="t" r="r" b="b"/>
+              <a:pathLst>
+                <a:path w="46161" h="14020">
+                  <a:moveTo>
+                    <a:pt x="6866" y="74"/>
+                  </a:moveTo>
+                  <a:cubicBezTo>
+                    <a:pt x="2892" y="446"/>
+                    <a:pt x="-409" y="4241"/>
+                    <a:pt x="41" y="7887"/>
+                  </a:cubicBezTo>
+                  <a:cubicBezTo>
+                    <a:pt x="491" y="11532"/>
+                    <a:pt x="4541" y="14360"/>
+                    <a:pt x="8515" y="13988"/>
+                  </a:cubicBezTo>
+                  <a:lnTo>
+                    <a:pt x="38662" y="13988"/>
+                  </a:lnTo>
+                  <a:cubicBezTo>
+                    <a:pt x="42638" y="13988"/>
+                    <a:pt x="46161" y="10714"/>
+                    <a:pt x="46161" y="6994"/>
+                  </a:cubicBezTo>
+                  <a:cubicBezTo>
+                    <a:pt x="46161" y="3274"/>
+                    <a:pt x="42638" y="0"/>
+                    <a:pt x="38662" y="0"/>
+                  </a:cubicBezTo>
+                  <a:cubicBezTo>
+                    <a:pt x="28163" y="0"/>
+                    <a:pt x="17215" y="0"/>
+                    <a:pt x="6866" y="0"/>
+                  </a:cubicBezTo>
+                  <a:lnTo>
+                    <a:pt x="6866" y="74"/>
+                  </a:lnTo>
+                  <a:close/>
+                </a:path>
+              </a:pathLst>
+            </a:custGeom>
+            <a:solidFill>
+              <a:srgbClr val="000091"/>
+            </a:solidFill>
+            <a:ln w="14097" cap="flat">
+              <a:noFill/>
+              <a:prstDash val="solid"/>
+              <a:miter/>
+            </a:ln>
+          </p:spPr>
+          <p:txBody>
+            <a:bodyPr rtlCol="0" anchor="ctr"/>
+            <a:lstStyle/>
+            <a:p>
+              <a:endParaRPr lang="fr-FR"/>
+            </a:p>
+          </p:txBody>
+        </p:sp>
+        <p:sp>
+          <p:nvSpPr>
+            <p:cNvPr id="39" name="Forme libre : forme 38">
+              <a:extLst>
+                <a:ext uri="{FF2B5EF4-FFF2-40B4-BE49-F238E27FC236}">
+                  <a16:creationId xmlns:a16="http://schemas.microsoft.com/office/drawing/2014/main" id="{BCF3F8D5-75B3-FEDB-4D56-4CC29927330E}"/>
+                </a:ext>
+              </a:extLst>
+            </p:cNvPr>
+            <p:cNvSpPr/>
+            <p:nvPr/>
+          </p:nvSpPr>
+          <p:spPr>
+            <a:xfrm>
+              <a:off x="3395219" y="2499578"/>
+              <a:ext cx="76308" cy="14020"/>
+            </a:xfrm>
+            <a:custGeom>
+              <a:avLst/>
+              <a:gdLst>
+                <a:gd name="connsiteX0" fmla="*/ 6866 w 76308"/>
+                <a:gd name="connsiteY0" fmla="*/ 75 h 14020"/>
+                <a:gd name="connsiteX1" fmla="*/ 41 w 76308"/>
+                <a:gd name="connsiteY1" fmla="*/ 7887 h 14020"/>
+                <a:gd name="connsiteX2" fmla="*/ 8515 w 76308"/>
+                <a:gd name="connsiteY2" fmla="*/ 13988 h 14020"/>
+                <a:gd name="connsiteX3" fmla="*/ 68810 w 76308"/>
+                <a:gd name="connsiteY3" fmla="*/ 13988 h 14020"/>
+                <a:gd name="connsiteX4" fmla="*/ 76309 w 76308"/>
+                <a:gd name="connsiteY4" fmla="*/ 6994 h 14020"/>
+                <a:gd name="connsiteX5" fmla="*/ 68810 w 76308"/>
+                <a:gd name="connsiteY5" fmla="*/ 0 h 14020"/>
+                <a:gd name="connsiteX6" fmla="*/ 6866 w 76308"/>
+                <a:gd name="connsiteY6" fmla="*/ 0 h 14020"/>
+                <a:gd name="connsiteX7" fmla="*/ 6866 w 76308"/>
+                <a:gd name="connsiteY7" fmla="*/ 75 h 14020"/>
+              </a:gdLst>
+              <a:ahLst/>
+              <a:cxnLst>
+                <a:cxn ang="0">
+                  <a:pos x="connsiteX0" y="connsiteY0"/>
+                </a:cxn>
+                <a:cxn ang="0">
+                  <a:pos x="connsiteX1" y="connsiteY1"/>
+                </a:cxn>
+                <a:cxn ang="0">
+                  <a:pos x="connsiteX2" y="connsiteY2"/>
+                </a:cxn>
+                <a:cxn ang="0">
+                  <a:pos x="connsiteX3" y="connsiteY3"/>
+                </a:cxn>
+                <a:cxn ang="0">
+                  <a:pos x="connsiteX4" y="connsiteY4"/>
+                </a:cxn>
+                <a:cxn ang="0">
+                  <a:pos x="connsiteX5" y="connsiteY5"/>
+                </a:cxn>
+                <a:cxn ang="0">
+                  <a:pos x="connsiteX6" y="connsiteY6"/>
+                </a:cxn>
+                <a:cxn ang="0">
+                  <a:pos x="connsiteX7" y="connsiteY7"/>
+                </a:cxn>
+              </a:cxnLst>
+              <a:rect l="l" t="t" r="r" b="b"/>
+              <a:pathLst>
+                <a:path w="76308" h="14020">
+                  <a:moveTo>
+                    <a:pt x="6866" y="75"/>
+                  </a:moveTo>
+                  <a:cubicBezTo>
+                    <a:pt x="2890" y="446"/>
+                    <a:pt x="-409" y="4241"/>
+                    <a:pt x="41" y="7887"/>
+                  </a:cubicBezTo>
+                  <a:cubicBezTo>
+                    <a:pt x="491" y="11532"/>
+                    <a:pt x="4540" y="14360"/>
+                    <a:pt x="8515" y="13988"/>
+                  </a:cubicBezTo>
+                  <a:lnTo>
+                    <a:pt x="68810" y="13988"/>
+                  </a:lnTo>
+                  <a:cubicBezTo>
+                    <a:pt x="72783" y="13988"/>
+                    <a:pt x="76309" y="10714"/>
+                    <a:pt x="76309" y="6994"/>
+                  </a:cubicBezTo>
+                  <a:cubicBezTo>
+                    <a:pt x="76309" y="3274"/>
+                    <a:pt x="72783" y="0"/>
+                    <a:pt x="68810" y="0"/>
+                  </a:cubicBezTo>
+                  <a:lnTo>
+                    <a:pt x="6866" y="0"/>
+                  </a:lnTo>
+                  <a:lnTo>
+                    <a:pt x="6866" y="75"/>
+                  </a:lnTo>
+                  <a:close/>
+                </a:path>
+              </a:pathLst>
+            </a:custGeom>
+            <a:solidFill>
+              <a:srgbClr val="000091"/>
+            </a:solidFill>
+            <a:ln w="14097" cap="flat">
+              <a:noFill/>
+              <a:prstDash val="solid"/>
+              <a:miter/>
+            </a:ln>
+          </p:spPr>
+          <p:txBody>
+            <a:bodyPr rtlCol="0" anchor="ctr"/>
+            <a:lstStyle/>
+            <a:p>
+              <a:endParaRPr lang="fr-FR"/>
+            </a:p>
+          </p:txBody>
+        </p:sp>
+        <p:sp>
+          <p:nvSpPr>
+            <p:cNvPr id="40" name="Forme libre : forme 39">
+              <a:extLst>
+                <a:ext uri="{FF2B5EF4-FFF2-40B4-BE49-F238E27FC236}">
+                  <a16:creationId xmlns:a16="http://schemas.microsoft.com/office/drawing/2014/main" id="{DD93647D-E8C3-78DF-6291-5205F0E49844}"/>
+                </a:ext>
+              </a:extLst>
+            </p:cNvPr>
+            <p:cNvSpPr/>
+            <p:nvPr/>
+          </p:nvSpPr>
+          <p:spPr>
+            <a:xfrm>
+              <a:off x="3425288" y="2527526"/>
+              <a:ext cx="46161" cy="14020"/>
+            </a:xfrm>
+            <a:custGeom>
+              <a:avLst/>
+              <a:gdLst>
+                <a:gd name="connsiteX0" fmla="*/ 6866 w 46161"/>
+                <a:gd name="connsiteY0" fmla="*/ 75 h 14020"/>
+                <a:gd name="connsiteX1" fmla="*/ 41 w 46161"/>
+                <a:gd name="connsiteY1" fmla="*/ 7887 h 14020"/>
+                <a:gd name="connsiteX2" fmla="*/ 8515 w 46161"/>
+                <a:gd name="connsiteY2" fmla="*/ 13988 h 14020"/>
+                <a:gd name="connsiteX3" fmla="*/ 38662 w 46161"/>
+                <a:gd name="connsiteY3" fmla="*/ 13988 h 14020"/>
+                <a:gd name="connsiteX4" fmla="*/ 46161 w 46161"/>
+                <a:gd name="connsiteY4" fmla="*/ 6994 h 14020"/>
+                <a:gd name="connsiteX5" fmla="*/ 38662 w 46161"/>
+                <a:gd name="connsiteY5" fmla="*/ 0 h 14020"/>
+                <a:gd name="connsiteX6" fmla="*/ 6866 w 46161"/>
+                <a:gd name="connsiteY6" fmla="*/ 0 h 14020"/>
+                <a:gd name="connsiteX7" fmla="*/ 6866 w 46161"/>
+                <a:gd name="connsiteY7" fmla="*/ 75 h 14020"/>
+              </a:gdLst>
+              <a:ahLst/>
+              <a:cxnLst>
+                <a:cxn ang="0">
+                  <a:pos x="connsiteX0" y="connsiteY0"/>
+                </a:cxn>
+                <a:cxn ang="0">
+                  <a:pos x="connsiteX1" y="connsiteY1"/>
+                </a:cxn>
+                <a:cxn ang="0">
+                  <a:pos x="connsiteX2" y="connsiteY2"/>
+                </a:cxn>
+                <a:cxn ang="0">
+                  <a:pos x="connsiteX3" y="connsiteY3"/>
+                </a:cxn>
+                <a:cxn ang="0">
+                  <a:pos x="connsiteX4" y="connsiteY4"/>
+                </a:cxn>
+                <a:cxn ang="0">
+                  <a:pos x="connsiteX5" y="connsiteY5"/>
+                </a:cxn>
+                <a:cxn ang="0">
+                  <a:pos x="connsiteX6" y="connsiteY6"/>
+                </a:cxn>
+                <a:cxn ang="0">
+                  <a:pos x="connsiteX7" y="connsiteY7"/>
+                </a:cxn>
+              </a:cxnLst>
+              <a:rect l="l" t="t" r="r" b="b"/>
+              <a:pathLst>
+                <a:path w="46161" h="14020">
+                  <a:moveTo>
+                    <a:pt x="6866" y="75"/>
+                  </a:moveTo>
+                  <a:cubicBezTo>
+                    <a:pt x="2892" y="446"/>
+                    <a:pt x="-409" y="4241"/>
+                    <a:pt x="41" y="7887"/>
+                  </a:cubicBezTo>
+                  <a:cubicBezTo>
+                    <a:pt x="491" y="11532"/>
+                    <a:pt x="4541" y="14360"/>
+                    <a:pt x="8515" y="13988"/>
+                  </a:cubicBezTo>
+                  <a:lnTo>
+                    <a:pt x="38662" y="13988"/>
+                  </a:lnTo>
+                  <a:cubicBezTo>
+                    <a:pt x="42638" y="13988"/>
+                    <a:pt x="46161" y="10714"/>
+                    <a:pt x="46161" y="6994"/>
+                  </a:cubicBezTo>
+                  <a:cubicBezTo>
+                    <a:pt x="46161" y="3274"/>
+                    <a:pt x="42638" y="0"/>
+                    <a:pt x="38662" y="0"/>
+                  </a:cubicBezTo>
+                  <a:cubicBezTo>
+                    <a:pt x="28163" y="0"/>
+                    <a:pt x="17215" y="0"/>
+                    <a:pt x="6866" y="0"/>
+                  </a:cubicBezTo>
+                  <a:lnTo>
+                    <a:pt x="6866" y="75"/>
+                  </a:lnTo>
+                  <a:close/>
+                </a:path>
+              </a:pathLst>
+            </a:custGeom>
+            <a:solidFill>
+              <a:srgbClr val="000091"/>
+            </a:solidFill>
+            <a:ln w="14097" cap="flat">
+              <a:noFill/>
+              <a:prstDash val="solid"/>
+              <a:miter/>
+            </a:ln>
+          </p:spPr>
+          <p:txBody>
+            <a:bodyPr rtlCol="0" anchor="ctr"/>
+            <a:lstStyle/>
+            <a:p>
+              <a:endParaRPr lang="fr-FR"/>
+            </a:p>
+          </p:txBody>
+        </p:sp>
+        <p:sp>
+          <p:nvSpPr>
+            <p:cNvPr id="41" name="Forme libre : forme 40">
+              <a:extLst>
+                <a:ext uri="{FF2B5EF4-FFF2-40B4-BE49-F238E27FC236}">
+                  <a16:creationId xmlns:a16="http://schemas.microsoft.com/office/drawing/2014/main" id="{9AB51DB1-6776-2543-30ED-5DF94B3D25D4}"/>
+                </a:ext>
+              </a:extLst>
+            </p:cNvPr>
+            <p:cNvSpPr/>
+            <p:nvPr/>
+          </p:nvSpPr>
+          <p:spPr>
+            <a:xfrm>
+              <a:off x="3395219" y="2555418"/>
+              <a:ext cx="76308" cy="14021"/>
+            </a:xfrm>
+            <a:custGeom>
+              <a:avLst/>
+              <a:gdLst>
+                <a:gd name="connsiteX0" fmla="*/ 6866 w 76308"/>
+                <a:gd name="connsiteY0" fmla="*/ 75 h 14021"/>
+                <a:gd name="connsiteX1" fmla="*/ 41 w 76308"/>
+                <a:gd name="connsiteY1" fmla="*/ 7887 h 14021"/>
+                <a:gd name="connsiteX2" fmla="*/ 8515 w 76308"/>
+                <a:gd name="connsiteY2" fmla="*/ 13989 h 14021"/>
+                <a:gd name="connsiteX3" fmla="*/ 68810 w 76308"/>
+                <a:gd name="connsiteY3" fmla="*/ 13989 h 14021"/>
+                <a:gd name="connsiteX4" fmla="*/ 76309 w 76308"/>
+                <a:gd name="connsiteY4" fmla="*/ 6995 h 14021"/>
+                <a:gd name="connsiteX5" fmla="*/ 68810 w 76308"/>
+                <a:gd name="connsiteY5" fmla="*/ 0 h 14021"/>
+                <a:gd name="connsiteX6" fmla="*/ 6866 w 76308"/>
+                <a:gd name="connsiteY6" fmla="*/ 0 h 14021"/>
+                <a:gd name="connsiteX7" fmla="*/ 6866 w 76308"/>
+                <a:gd name="connsiteY7" fmla="*/ 75 h 14021"/>
+              </a:gdLst>
+              <a:ahLst/>
+              <a:cxnLst>
+                <a:cxn ang="0">
+                  <a:pos x="connsiteX0" y="connsiteY0"/>
+                </a:cxn>
+                <a:cxn ang="0">
+                  <a:pos x="connsiteX1" y="connsiteY1"/>
+                </a:cxn>
+                <a:cxn ang="0">
+                  <a:pos x="connsiteX2" y="connsiteY2"/>
+                </a:cxn>
+                <a:cxn ang="0">
+                  <a:pos x="connsiteX3" y="connsiteY3"/>
+                </a:cxn>
+                <a:cxn ang="0">
+                  <a:pos x="connsiteX4" y="connsiteY4"/>
+                </a:cxn>
+                <a:cxn ang="0">
+                  <a:pos x="connsiteX5" y="connsiteY5"/>
+                </a:cxn>
+                <a:cxn ang="0">
+                  <a:pos x="connsiteX6" y="connsiteY6"/>
+                </a:cxn>
+                <a:cxn ang="0">
+                  <a:pos x="connsiteX7" y="connsiteY7"/>
+                </a:cxn>
+              </a:cxnLst>
+              <a:rect l="l" t="t" r="r" b="b"/>
+              <a:pathLst>
+                <a:path w="76308" h="14021">
+                  <a:moveTo>
+                    <a:pt x="6866" y="75"/>
+                  </a:moveTo>
+                  <a:cubicBezTo>
+                    <a:pt x="2890" y="447"/>
+                    <a:pt x="-409" y="4242"/>
+                    <a:pt x="41" y="7887"/>
+                  </a:cubicBezTo>
+                  <a:cubicBezTo>
+                    <a:pt x="491" y="11534"/>
+                    <a:pt x="4540" y="14360"/>
+                    <a:pt x="8515" y="13989"/>
+                  </a:cubicBezTo>
+                  <a:lnTo>
+                    <a:pt x="68810" y="13989"/>
+                  </a:lnTo>
+                  <a:cubicBezTo>
+                    <a:pt x="72783" y="13989"/>
+                    <a:pt x="76309" y="10715"/>
+                    <a:pt x="76309" y="6995"/>
+                  </a:cubicBezTo>
+                  <a:cubicBezTo>
+                    <a:pt x="76309" y="3274"/>
+                    <a:pt x="72783" y="0"/>
+                    <a:pt x="68810" y="0"/>
+                  </a:cubicBezTo>
+                  <a:lnTo>
+                    <a:pt x="6866" y="0"/>
+                  </a:lnTo>
+                  <a:lnTo>
+                    <a:pt x="6866" y="75"/>
+                  </a:lnTo>
+                  <a:close/>
+                </a:path>
+              </a:pathLst>
+            </a:custGeom>
+            <a:solidFill>
+              <a:srgbClr val="000091"/>
+            </a:solidFill>
+            <a:ln w="14097" cap="flat">
+              <a:noFill/>
+              <a:prstDash val="solid"/>
+              <a:miter/>
+            </a:ln>
+          </p:spPr>
+          <p:txBody>
+            <a:bodyPr rtlCol="0" anchor="ctr"/>
+            <a:lstStyle/>
+            <a:p>
+              <a:endParaRPr lang="fr-FR"/>
+            </a:p>
+          </p:txBody>
+        </p:sp>
+        <p:sp>
+          <p:nvSpPr>
+            <p:cNvPr id="42" name="Forme libre : forme 41">
+              <a:extLst>
+                <a:ext uri="{FF2B5EF4-FFF2-40B4-BE49-F238E27FC236}">
+                  <a16:creationId xmlns:a16="http://schemas.microsoft.com/office/drawing/2014/main" id="{0FB56C52-2DFB-4FCB-F80E-39F9FFBCBEB4}"/>
+                </a:ext>
+              </a:extLst>
+            </p:cNvPr>
+            <p:cNvSpPr/>
+            <p:nvPr/>
+          </p:nvSpPr>
+          <p:spPr>
+            <a:xfrm>
+              <a:off x="3425288" y="2583312"/>
+              <a:ext cx="46161" cy="14020"/>
+            </a:xfrm>
+            <a:custGeom>
+              <a:avLst/>
+              <a:gdLst>
+                <a:gd name="connsiteX0" fmla="*/ 6866 w 46161"/>
+                <a:gd name="connsiteY0" fmla="*/ 75 h 14020"/>
+                <a:gd name="connsiteX1" fmla="*/ 41 w 46161"/>
+                <a:gd name="connsiteY1" fmla="*/ 7887 h 14020"/>
+                <a:gd name="connsiteX2" fmla="*/ 8515 w 46161"/>
+                <a:gd name="connsiteY2" fmla="*/ 13988 h 14020"/>
+                <a:gd name="connsiteX3" fmla="*/ 38662 w 46161"/>
+                <a:gd name="connsiteY3" fmla="*/ 13988 h 14020"/>
+                <a:gd name="connsiteX4" fmla="*/ 46161 w 46161"/>
+                <a:gd name="connsiteY4" fmla="*/ 6994 h 14020"/>
+                <a:gd name="connsiteX5" fmla="*/ 38662 w 46161"/>
+                <a:gd name="connsiteY5" fmla="*/ 0 h 14020"/>
+                <a:gd name="connsiteX6" fmla="*/ 6866 w 46161"/>
+                <a:gd name="connsiteY6" fmla="*/ 0 h 14020"/>
+                <a:gd name="connsiteX7" fmla="*/ 6866 w 46161"/>
+                <a:gd name="connsiteY7" fmla="*/ 75 h 14020"/>
+              </a:gdLst>
+              <a:ahLst/>
+              <a:cxnLst>
+                <a:cxn ang="0">
+                  <a:pos x="connsiteX0" y="connsiteY0"/>
+                </a:cxn>
+                <a:cxn ang="0">
+                  <a:pos x="connsiteX1" y="connsiteY1"/>
+                </a:cxn>
+                <a:cxn ang="0">
+                  <a:pos x="connsiteX2" y="connsiteY2"/>
+                </a:cxn>
+                <a:cxn ang="0">
+                  <a:pos x="connsiteX3" y="connsiteY3"/>
+                </a:cxn>
+                <a:cxn ang="0">
+                  <a:pos x="connsiteX4" y="connsiteY4"/>
+                </a:cxn>
+                <a:cxn ang="0">
+                  <a:pos x="connsiteX5" y="connsiteY5"/>
+                </a:cxn>
+                <a:cxn ang="0">
+                  <a:pos x="connsiteX6" y="connsiteY6"/>
+                </a:cxn>
+                <a:cxn ang="0">
+                  <a:pos x="connsiteX7" y="connsiteY7"/>
+                </a:cxn>
+              </a:cxnLst>
+              <a:rect l="l" t="t" r="r" b="b"/>
+              <a:pathLst>
+                <a:path w="46161" h="14020">
+                  <a:moveTo>
+                    <a:pt x="6866" y="75"/>
+                  </a:moveTo>
+                  <a:cubicBezTo>
+                    <a:pt x="2892" y="446"/>
+                    <a:pt x="-409" y="4241"/>
+                    <a:pt x="41" y="7887"/>
+                  </a:cubicBezTo>
+                  <a:cubicBezTo>
+                    <a:pt x="491" y="11532"/>
+                    <a:pt x="4541" y="14360"/>
+                    <a:pt x="8515" y="13988"/>
+                  </a:cubicBezTo>
+                  <a:lnTo>
+                    <a:pt x="38662" y="13988"/>
+                  </a:lnTo>
+                  <a:cubicBezTo>
+                    <a:pt x="42638" y="13988"/>
+                    <a:pt x="46161" y="10714"/>
+                    <a:pt x="46161" y="6994"/>
+                  </a:cubicBezTo>
+                  <a:cubicBezTo>
+                    <a:pt x="46161" y="3274"/>
+                    <a:pt x="42638" y="0"/>
+                    <a:pt x="38662" y="0"/>
+                  </a:cubicBezTo>
+                  <a:cubicBezTo>
+                    <a:pt x="28163" y="0"/>
+                    <a:pt x="17215" y="0"/>
+                    <a:pt x="6866" y="0"/>
+                  </a:cubicBezTo>
+                  <a:lnTo>
+                    <a:pt x="6866" y="75"/>
+                  </a:lnTo>
+                  <a:close/>
+                </a:path>
+              </a:pathLst>
+            </a:custGeom>
+            <a:solidFill>
+              <a:srgbClr val="000091"/>
+            </a:solidFill>
+            <a:ln w="14097" cap="flat">
+              <a:noFill/>
+              <a:prstDash val="solid"/>
+              <a:miter/>
+            </a:ln>
+          </p:spPr>
+          <p:txBody>
+            <a:bodyPr rtlCol="0" anchor="ctr"/>
+            <a:lstStyle/>
+            <a:p>
+              <a:endParaRPr lang="fr-FR"/>
+            </a:p>
+          </p:txBody>
+        </p:sp>
+        <p:sp>
+          <p:nvSpPr>
+            <p:cNvPr id="46" name="Forme libre : forme 45">
+              <a:extLst>
+                <a:ext uri="{FF2B5EF4-FFF2-40B4-BE49-F238E27FC236}">
+                  <a16:creationId xmlns:a16="http://schemas.microsoft.com/office/drawing/2014/main" id="{DD74F5A2-64C2-3104-B190-B09BD7DA310B}"/>
+                </a:ext>
+              </a:extLst>
+            </p:cNvPr>
+            <p:cNvSpPr/>
+            <p:nvPr/>
+          </p:nvSpPr>
+          <p:spPr>
+            <a:xfrm>
+              <a:off x="3395219" y="2611205"/>
+              <a:ext cx="76308" cy="14020"/>
+            </a:xfrm>
+            <a:custGeom>
+              <a:avLst/>
+              <a:gdLst>
+                <a:gd name="connsiteX0" fmla="*/ 6866 w 76308"/>
+                <a:gd name="connsiteY0" fmla="*/ 73 h 14020"/>
+                <a:gd name="connsiteX1" fmla="*/ 41 w 76308"/>
+                <a:gd name="connsiteY1" fmla="*/ 7886 h 14020"/>
+                <a:gd name="connsiteX2" fmla="*/ 8515 w 76308"/>
+                <a:gd name="connsiteY2" fmla="*/ 13988 h 14020"/>
+                <a:gd name="connsiteX3" fmla="*/ 68810 w 76308"/>
+                <a:gd name="connsiteY3" fmla="*/ 13988 h 14020"/>
+                <a:gd name="connsiteX4" fmla="*/ 76309 w 76308"/>
+                <a:gd name="connsiteY4" fmla="*/ 6994 h 14020"/>
+                <a:gd name="connsiteX5" fmla="*/ 68810 w 76308"/>
+                <a:gd name="connsiteY5" fmla="*/ 0 h 14020"/>
+                <a:gd name="connsiteX6" fmla="*/ 6866 w 76308"/>
+                <a:gd name="connsiteY6" fmla="*/ 0 h 14020"/>
+                <a:gd name="connsiteX7" fmla="*/ 6866 w 76308"/>
+                <a:gd name="connsiteY7" fmla="*/ 73 h 14020"/>
+              </a:gdLst>
+              <a:ahLst/>
+              <a:cxnLst>
+                <a:cxn ang="0">
+                  <a:pos x="connsiteX0" y="connsiteY0"/>
+                </a:cxn>
+                <a:cxn ang="0">
+                  <a:pos x="connsiteX1" y="connsiteY1"/>
+                </a:cxn>
+                <a:cxn ang="0">
+                  <a:pos x="connsiteX2" y="connsiteY2"/>
+                </a:cxn>
+                <a:cxn ang="0">
+                  <a:pos x="connsiteX3" y="connsiteY3"/>
+                </a:cxn>
+                <a:cxn ang="0">
+                  <a:pos x="connsiteX4" y="connsiteY4"/>
+                </a:cxn>
+                <a:cxn ang="0">
+                  <a:pos x="connsiteX5" y="connsiteY5"/>
+                </a:cxn>
+                <a:cxn ang="0">
+                  <a:pos x="connsiteX6" y="connsiteY6"/>
+                </a:cxn>
+                <a:cxn ang="0">
+                  <a:pos x="connsiteX7" y="connsiteY7"/>
+                </a:cxn>
+              </a:cxnLst>
+              <a:rect l="l" t="t" r="r" b="b"/>
+              <a:pathLst>
+                <a:path w="76308" h="14020">
+                  <a:moveTo>
+                    <a:pt x="6866" y="73"/>
+                  </a:moveTo>
+                  <a:cubicBezTo>
+                    <a:pt x="2890" y="446"/>
+                    <a:pt x="-409" y="4241"/>
+                    <a:pt x="41" y="7886"/>
+                  </a:cubicBezTo>
+                  <a:cubicBezTo>
+                    <a:pt x="491" y="11532"/>
+                    <a:pt x="4540" y="14359"/>
+                    <a:pt x="8515" y="13988"/>
+                  </a:cubicBezTo>
+                  <a:lnTo>
+                    <a:pt x="68810" y="13988"/>
+                  </a:lnTo>
+                  <a:cubicBezTo>
+                    <a:pt x="72783" y="13988"/>
+                    <a:pt x="76309" y="10714"/>
+                    <a:pt x="76309" y="6994"/>
+                  </a:cubicBezTo>
+                  <a:cubicBezTo>
+                    <a:pt x="76309" y="3274"/>
+                    <a:pt x="72783" y="0"/>
+                    <a:pt x="68810" y="0"/>
+                  </a:cubicBezTo>
+                  <a:lnTo>
+                    <a:pt x="6866" y="0"/>
+                  </a:lnTo>
+                  <a:lnTo>
+                    <a:pt x="6866" y="73"/>
+                  </a:lnTo>
+                  <a:close/>
+                </a:path>
+              </a:pathLst>
+            </a:custGeom>
+            <a:solidFill>
+              <a:srgbClr val="000091"/>
+            </a:solidFill>
+            <a:ln w="14097" cap="flat">
+              <a:noFill/>
+              <a:prstDash val="solid"/>
+              <a:miter/>
+            </a:ln>
+          </p:spPr>
+          <p:txBody>
+            <a:bodyPr rtlCol="0" anchor="ctr"/>
+            <a:lstStyle/>
+            <a:p>
+              <a:endParaRPr lang="fr-FR"/>
+            </a:p>
+          </p:txBody>
+        </p:sp>
+        <p:sp>
+          <p:nvSpPr>
+            <p:cNvPr id="47" name="Forme libre : forme 46">
+              <a:extLst>
+                <a:ext uri="{FF2B5EF4-FFF2-40B4-BE49-F238E27FC236}">
+                  <a16:creationId xmlns:a16="http://schemas.microsoft.com/office/drawing/2014/main" id="{05689BD7-6C4C-88AA-6124-B982018DE877}"/>
+                </a:ext>
+              </a:extLst>
+            </p:cNvPr>
+            <p:cNvSpPr/>
+            <p:nvPr/>
+          </p:nvSpPr>
+          <p:spPr>
+            <a:xfrm>
+              <a:off x="3366002" y="2649020"/>
+              <a:ext cx="135586" cy="275696"/>
+            </a:xfrm>
+            <a:custGeom>
+              <a:avLst/>
+              <a:gdLst>
+                <a:gd name="connsiteX0" fmla="*/ 40721 w 135586"/>
+                <a:gd name="connsiteY0" fmla="*/ 2562 h 275696"/>
+                <a:gd name="connsiteX1" fmla="*/ 37646 w 135586"/>
+                <a:gd name="connsiteY1" fmla="*/ 11045 h 275696"/>
+                <a:gd name="connsiteX2" fmla="*/ 37646 w 135586"/>
+                <a:gd name="connsiteY2" fmla="*/ 157321 h 275696"/>
+                <a:gd name="connsiteX3" fmla="*/ 0 w 135586"/>
+                <a:gd name="connsiteY3" fmla="*/ 212900 h 275696"/>
+                <a:gd name="connsiteX4" fmla="*/ 67793 w 135586"/>
+                <a:gd name="connsiteY4" fmla="*/ 275696 h 275696"/>
+                <a:gd name="connsiteX5" fmla="*/ 135586 w 135586"/>
+                <a:gd name="connsiteY5" fmla="*/ 212900 h 275696"/>
+                <a:gd name="connsiteX6" fmla="*/ 97940 w 135586"/>
+                <a:gd name="connsiteY6" fmla="*/ 157321 h 275696"/>
+                <a:gd name="connsiteX7" fmla="*/ 97940 w 135586"/>
+                <a:gd name="connsiteY7" fmla="*/ 11045 h 275696"/>
+                <a:gd name="connsiteX8" fmla="*/ 86167 w 135586"/>
+                <a:gd name="connsiteY8" fmla="*/ 5167 h 275696"/>
+                <a:gd name="connsiteX9" fmla="*/ 50396 w 135586"/>
+                <a:gd name="connsiteY9" fmla="*/ 181 h 275696"/>
+                <a:gd name="connsiteX10" fmla="*/ 40721 w 135586"/>
+                <a:gd name="connsiteY10" fmla="*/ 2562 h 275696"/>
+              </a:gdLst>
+              <a:ahLst/>
+              <a:cxnLst>
+                <a:cxn ang="0">
+                  <a:pos x="connsiteX0" y="connsiteY0"/>
+                </a:cxn>
+                <a:cxn ang="0">
+                  <a:pos x="connsiteX1" y="connsiteY1"/>
+                </a:cxn>
+                <a:cxn ang="0">
+                  <a:pos x="connsiteX2" y="connsiteY2"/>
+                </a:cxn>
+                <a:cxn ang="0">
+                  <a:pos x="connsiteX3" y="connsiteY3"/>
+                </a:cxn>
+                <a:cxn ang="0">
+                  <a:pos x="connsiteX4" y="connsiteY4"/>
+                </a:cxn>
+                <a:cxn ang="0">
+                  <a:pos x="connsiteX5" y="connsiteY5"/>
+                </a:cxn>
+                <a:cxn ang="0">
+                  <a:pos x="connsiteX6" y="connsiteY6"/>
+                </a:cxn>
+                <a:cxn ang="0">
+                  <a:pos x="connsiteX7" y="connsiteY7"/>
+                </a:cxn>
+                <a:cxn ang="0">
+                  <a:pos x="connsiteX8" y="connsiteY8"/>
+                </a:cxn>
+                <a:cxn ang="0">
+                  <a:pos x="connsiteX9" y="connsiteY9"/>
+                </a:cxn>
+                <a:cxn ang="0">
+                  <a:pos x="connsiteX10" y="connsiteY10"/>
+                </a:cxn>
+              </a:cxnLst>
+              <a:rect l="l" t="t" r="r" b="b"/>
+              <a:pathLst>
+                <a:path w="135586" h="275696">
+                  <a:moveTo>
+                    <a:pt x="40721" y="2562"/>
+                  </a:moveTo>
+                  <a:cubicBezTo>
+                    <a:pt x="37797" y="5240"/>
+                    <a:pt x="37646" y="8440"/>
+                    <a:pt x="37646" y="11045"/>
+                  </a:cubicBezTo>
+                  <a:lnTo>
+                    <a:pt x="37646" y="157321"/>
+                  </a:lnTo>
+                  <a:cubicBezTo>
+                    <a:pt x="15524" y="167663"/>
+                    <a:pt x="0" y="188497"/>
+                    <a:pt x="0" y="212900"/>
+                  </a:cubicBezTo>
+                  <a:cubicBezTo>
+                    <a:pt x="0" y="247498"/>
+                    <a:pt x="30448" y="275696"/>
+                    <a:pt x="67793" y="275696"/>
+                  </a:cubicBezTo>
+                  <a:cubicBezTo>
+                    <a:pt x="105140" y="275696"/>
+                    <a:pt x="135586" y="247498"/>
+                    <a:pt x="135586" y="212900"/>
+                  </a:cubicBezTo>
+                  <a:cubicBezTo>
+                    <a:pt x="135586" y="188422"/>
+                    <a:pt x="120063" y="167663"/>
+                    <a:pt x="97940" y="157321"/>
+                  </a:cubicBezTo>
+                  <a:lnTo>
+                    <a:pt x="97940" y="11045"/>
+                  </a:lnTo>
+                  <a:cubicBezTo>
+                    <a:pt x="98015" y="5986"/>
+                    <a:pt x="90742" y="2264"/>
+                    <a:pt x="86167" y="5167"/>
+                  </a:cubicBezTo>
+                  <a:cubicBezTo>
+                    <a:pt x="72669" y="10970"/>
+                    <a:pt x="61419" y="3753"/>
+                    <a:pt x="50396" y="181"/>
+                  </a:cubicBezTo>
+                  <a:cubicBezTo>
+                    <a:pt x="46645" y="-637"/>
+                    <a:pt x="43271" y="1521"/>
+                    <a:pt x="40721" y="2562"/>
+                  </a:cubicBezTo>
+                  <a:close/>
+                </a:path>
+              </a:pathLst>
+            </a:custGeom>
+            <a:solidFill>
+              <a:srgbClr val="000091"/>
+            </a:solidFill>
+            <a:ln w="14097" cap="flat">
+              <a:noFill/>
+              <a:prstDash val="solid"/>
+              <a:miter/>
+            </a:ln>
+          </p:spPr>
+          <p:txBody>
+            <a:bodyPr rtlCol="0" anchor="ctr"/>
+            <a:lstStyle/>
+            <a:p>
+              <a:endParaRPr lang="fr-FR"/>
+            </a:p>
+          </p:txBody>
+        </p:sp>
+      </p:grpSp>
       <p:sp>
         <p:nvSpPr>
           <p:cNvPr id="9" name="ZoneTexte 8">
@@ -12524,10 +16512,10 @@
           <p:nvPr/>
         </p:nvPicPr>
         <p:blipFill>
-          <a:blip r:embed="rId5">
+          <a:blip r:embed="rId3">
             <a:extLst>
               <a:ext uri="{96DAC541-7B7A-43D3-8B79-37D633B846F1}">
-                <asvg:svgBlip xmlns:asvg="http://schemas.microsoft.com/office/drawing/2016/SVG/main" r:embed="rId6"/>
+                <asvg:svgBlip xmlns:asvg="http://schemas.microsoft.com/office/drawing/2016/SVG/main" r:embed="rId4"/>
               </a:ext>
             </a:extLst>
           </a:blip>
@@ -12560,10 +16548,10 @@
           <p:nvPr/>
         </p:nvPicPr>
         <p:blipFill>
-          <a:blip r:embed="rId5">
+          <a:blip r:embed="rId3">
             <a:extLst>
               <a:ext uri="{96DAC541-7B7A-43D3-8B79-37D633B846F1}">
-                <asvg:svgBlip xmlns:asvg="http://schemas.microsoft.com/office/drawing/2016/SVG/main" r:embed="rId6"/>
+                <asvg:svgBlip xmlns:asvg="http://schemas.microsoft.com/office/drawing/2016/SVG/main" r:embed="rId4"/>
               </a:ext>
             </a:extLst>
           </a:blip>
@@ -12596,10 +16584,10 @@
           <p:nvPr/>
         </p:nvPicPr>
         <p:blipFill>
-          <a:blip r:embed="rId5">
+          <a:blip r:embed="rId3">
             <a:extLst>
               <a:ext uri="{96DAC541-7B7A-43D3-8B79-37D633B846F1}">
-                <asvg:svgBlip xmlns:asvg="http://schemas.microsoft.com/office/drawing/2016/SVG/main" r:embed="rId6"/>
+                <asvg:svgBlip xmlns:asvg="http://schemas.microsoft.com/office/drawing/2016/SVG/main" r:embed="rId4"/>
               </a:ext>
             </a:extLst>
           </a:blip>
@@ -12632,10 +16620,10 @@
           <p:nvPr/>
         </p:nvPicPr>
         <p:blipFill>
-          <a:blip r:embed="rId5">
+          <a:blip r:embed="rId3">
             <a:extLst>
               <a:ext uri="{96DAC541-7B7A-43D3-8B79-37D633B846F1}">
-                <asvg:svgBlip xmlns:asvg="http://schemas.microsoft.com/office/drawing/2016/SVG/main" r:embed="rId6"/>
+                <asvg:svgBlip xmlns:asvg="http://schemas.microsoft.com/office/drawing/2016/SVG/main" r:embed="rId4"/>
               </a:ext>
             </a:extLst>
           </a:blip>
@@ -12668,10 +16656,10 @@
           <p:nvPr/>
         </p:nvPicPr>
         <p:blipFill>
-          <a:blip r:embed="rId5">
+          <a:blip r:embed="rId3">
             <a:extLst>
               <a:ext uri="{96DAC541-7B7A-43D3-8B79-37D633B846F1}">
-                <asvg:svgBlip xmlns:asvg="http://schemas.microsoft.com/office/drawing/2016/SVG/main" r:embed="rId6"/>
+                <asvg:svgBlip xmlns:asvg="http://schemas.microsoft.com/office/drawing/2016/SVG/main" r:embed="rId4"/>
               </a:ext>
             </a:extLst>
           </a:blip>

</xml_diff>

<commit_message>
feat: rajout d'une slide titre pour l'analyse simplifiée
</commit_message>
<xml_diff>
--- a/public/templates/template_synthese_projet.pptx
+++ b/public/templates/template_synthese_projet.pptx
@@ -5,22 +5,23 @@
     <p:sldMasterId id="2147483648" r:id="rId1"/>
   </p:sldMasterIdLst>
   <p:notesMasterIdLst>
-    <p:notesMasterId r:id="rId15"/>
+    <p:notesMasterId r:id="rId16"/>
   </p:notesMasterIdLst>
   <p:sldIdLst>
     <p:sldId id="256" r:id="rId2"/>
     <p:sldId id="264" r:id="rId3"/>
     <p:sldId id="282" r:id="rId4"/>
-    <p:sldId id="281" r:id="rId5"/>
-    <p:sldId id="279" r:id="rId6"/>
-    <p:sldId id="280" r:id="rId7"/>
-    <p:sldId id="270" r:id="rId8"/>
-    <p:sldId id="274" r:id="rId9"/>
-    <p:sldId id="275" r:id="rId10"/>
-    <p:sldId id="278" r:id="rId11"/>
-    <p:sldId id="265" r:id="rId12"/>
-    <p:sldId id="276" r:id="rId13"/>
-    <p:sldId id="277" r:id="rId14"/>
+    <p:sldId id="283" r:id="rId5"/>
+    <p:sldId id="281" r:id="rId6"/>
+    <p:sldId id="279" r:id="rId7"/>
+    <p:sldId id="280" r:id="rId8"/>
+    <p:sldId id="270" r:id="rId9"/>
+    <p:sldId id="274" r:id="rId10"/>
+    <p:sldId id="275" r:id="rId11"/>
+    <p:sldId id="278" r:id="rId12"/>
+    <p:sldId id="265" r:id="rId13"/>
+    <p:sldId id="276" r:id="rId14"/>
+    <p:sldId id="277" r:id="rId15"/>
   </p:sldIdLst>
   <p:sldSz cx="12192000" cy="6858000"/>
   <p:notesSz cx="6858000" cy="9144000"/>
@@ -1043,7 +1044,7 @@
           <a:p>
             <a:fld id="{4C638A9C-6ED0-4718-B5E7-9D405962C144}" type="datetimeFigureOut">
               <a:rPr lang="fr-FR" smtClean="0"/>
-              <a:t>05/10/2026</a:t>
+              <a:t>08/10/2026</a:t>
             </a:fld>
             <a:endParaRPr lang="fr-FR"/>
           </a:p>
@@ -1507,7 +1508,7 @@
           <a:p>
             <a:fld id="{F7021451-1387-4CA6-816F-3879F97B5CBC}" type="slidenum">
               <a:rPr lang="en-US"/>
-              <a:t>5</a:t>
+              <a:t>4</a:t>
             </a:fld>
             <a:endParaRPr lang="en-US"/>
           </a:p>
@@ -1516,7 +1517,7 @@
     </p:spTree>
     <p:extLst>
       <p:ext uri="{BB962C8B-B14F-4D97-AF65-F5344CB8AC3E}">
-        <p14:creationId xmlns:p14="http://schemas.microsoft.com/office/powerpoint/2010/main" val="2811477106"/>
+        <p14:creationId xmlns:p14="http://schemas.microsoft.com/office/powerpoint/2010/main" val="2379991881"/>
       </p:ext>
     </p:extLst>
   </p:cSld>
@@ -1615,7 +1616,7 @@
           <a:p>
             <a:fld id="{F7021451-1387-4CA6-816F-3879F97B5CBC}" type="slidenum">
               <a:rPr lang="en-US"/>
-              <a:t>8</a:t>
+              <a:t>6</a:t>
             </a:fld>
             <a:endParaRPr lang="en-US"/>
           </a:p>
@@ -1624,7 +1625,7 @@
     </p:spTree>
     <p:extLst>
       <p:ext uri="{BB962C8B-B14F-4D97-AF65-F5344CB8AC3E}">
-        <p14:creationId xmlns:p14="http://schemas.microsoft.com/office/powerpoint/2010/main" val="2866518631"/>
+        <p14:creationId xmlns:p14="http://schemas.microsoft.com/office/powerpoint/2010/main" val="2811477106"/>
       </p:ext>
     </p:extLst>
   </p:cSld>
@@ -1723,7 +1724,7 @@
           <a:p>
             <a:fld id="{F7021451-1387-4CA6-816F-3879F97B5CBC}" type="slidenum">
               <a:rPr lang="en-US"/>
-              <a:t>10</a:t>
+              <a:t>9</a:t>
             </a:fld>
             <a:endParaRPr lang="en-US"/>
           </a:p>
@@ -1732,7 +1733,7 @@
     </p:spTree>
     <p:extLst>
       <p:ext uri="{BB962C8B-B14F-4D97-AF65-F5344CB8AC3E}">
-        <p14:creationId xmlns:p14="http://schemas.microsoft.com/office/powerpoint/2010/main" val="3046060735"/>
+        <p14:creationId xmlns:p14="http://schemas.microsoft.com/office/powerpoint/2010/main" val="2866518631"/>
       </p:ext>
     </p:extLst>
   </p:cSld>
@@ -1831,7 +1832,115 @@
           <a:p>
             <a:fld id="{F7021451-1387-4CA6-816F-3879F97B5CBC}" type="slidenum">
               <a:rPr lang="en-US"/>
-              <a:t>12</a:t>
+              <a:t>11</a:t>
+            </a:fld>
+            <a:endParaRPr lang="en-US"/>
+          </a:p>
+        </p:txBody>
+      </p:sp>
+    </p:spTree>
+    <p:extLst>
+      <p:ext uri="{BB962C8B-B14F-4D97-AF65-F5344CB8AC3E}">
+        <p14:creationId xmlns:p14="http://schemas.microsoft.com/office/powerpoint/2010/main" val="3046060735"/>
+      </p:ext>
+    </p:extLst>
+  </p:cSld>
+  <p:clrMapOvr>
+    <a:masterClrMapping/>
+  </p:clrMapOvr>
+</p:notes>
+</file>
+
+<file path=ppt/notesSlides/notesSlide6.xml><?xml version="1.0" encoding="utf-8"?>
+<p:notes xmlns:a="http://schemas.openxmlformats.org/drawingml/2006/main" xmlns:r="http://schemas.openxmlformats.org/officeDocument/2006/relationships" xmlns:p="http://schemas.openxmlformats.org/presentationml/2006/main">
+  <p:cSld>
+    <p:spTree>
+      <p:nvGrpSpPr>
+        <p:cNvPr id="1" name="">
+          <a:extLst>
+            <a:ext uri="{FF2B5EF4-FFF2-40B4-BE49-F238E27FC236}">
+              <a16:creationId xmlns:a16="http://schemas.microsoft.com/office/drawing/2014/main" id="{048D1F06-EBEC-48E7-718E-679E9C7AB652}"/>
+            </a:ext>
+          </a:extLst>
+        </p:cNvPr>
+        <p:cNvGrpSpPr/>
+        <p:nvPr/>
+      </p:nvGrpSpPr>
+      <p:grpSpPr>
+        <a:xfrm>
+          <a:off x="0" y="0"/>
+          <a:ext cx="0" cy="0"/>
+          <a:chOff x="0" y="0"/>
+          <a:chExt cx="0" cy="0"/>
+        </a:xfrm>
+      </p:grpSpPr>
+      <p:sp>
+        <p:nvSpPr>
+          <p:cNvPr id="2" name="Slide Image Placeholder 1">
+            <a:extLst>
+              <a:ext uri="{FF2B5EF4-FFF2-40B4-BE49-F238E27FC236}">
+                <a16:creationId xmlns:a16="http://schemas.microsoft.com/office/drawing/2014/main" id="{15188976-03C7-BDC5-F35A-502E38D967CC}"/>
+              </a:ext>
+            </a:extLst>
+          </p:cNvPr>
+          <p:cNvSpPr>
+            <a:spLocks noGrp="1" noRot="1" noChangeAspect="1"/>
+          </p:cNvSpPr>
+          <p:nvPr>
+            <p:ph type="sldImg"/>
+          </p:nvPr>
+        </p:nvSpPr>
+        <p:spPr/>
+      </p:sp>
+      <p:sp>
+        <p:nvSpPr>
+          <p:cNvPr id="3" name="Notes Placeholder 2">
+            <a:extLst>
+              <a:ext uri="{FF2B5EF4-FFF2-40B4-BE49-F238E27FC236}">
+                <a16:creationId xmlns:a16="http://schemas.microsoft.com/office/drawing/2014/main" id="{32392900-84C4-792B-45B3-9A38832A4769}"/>
+              </a:ext>
+            </a:extLst>
+          </p:cNvPr>
+          <p:cNvSpPr>
+            <a:spLocks noGrp="1"/>
+          </p:cNvSpPr>
+          <p:nvPr>
+            <p:ph type="body" idx="1"/>
+          </p:nvPr>
+        </p:nvSpPr>
+        <p:spPr/>
+        <p:txBody>
+          <a:bodyPr/>
+          <a:lstStyle/>
+          <a:p>
+            <a:endParaRPr lang="en-US"/>
+          </a:p>
+        </p:txBody>
+      </p:sp>
+      <p:sp>
+        <p:nvSpPr>
+          <p:cNvPr id="4" name="Slide Number Placeholder 3">
+            <a:extLst>
+              <a:ext uri="{FF2B5EF4-FFF2-40B4-BE49-F238E27FC236}">
+                <a16:creationId xmlns:a16="http://schemas.microsoft.com/office/drawing/2014/main" id="{FD3A749C-0CD8-8944-6CB6-BFC00D52AF73}"/>
+              </a:ext>
+            </a:extLst>
+          </p:cNvPr>
+          <p:cNvSpPr>
+            <a:spLocks noGrp="1"/>
+          </p:cNvSpPr>
+          <p:nvPr>
+            <p:ph type="sldNum" sz="quarter" idx="10"/>
+          </p:nvPr>
+        </p:nvSpPr>
+        <p:spPr/>
+        <p:txBody>
+          <a:bodyPr/>
+          <a:lstStyle/>
+          <a:p>
+            <a:fld id="{F7021451-1387-4CA6-816F-3879F97B5CBC}" type="slidenum">
+              <a:rPr lang="en-US"/>
+              <a:t>13</a:t>
             </a:fld>
             <a:endParaRPr lang="en-US"/>
           </a:p>
@@ -1997,7 +2106,7 @@
           <a:p>
             <a:fld id="{82E7F8B9-DFDB-4965-877D-C04A580740C9}" type="datetimeFigureOut">
               <a:rPr lang="fr-FR" smtClean="0"/>
-              <a:t>05/10/2026</a:t>
+              <a:t>08/10/2026</a:t>
             </a:fld>
             <a:endParaRPr lang="fr-FR"/>
           </a:p>
@@ -2195,7 +2304,7 @@
           <a:p>
             <a:fld id="{82E7F8B9-DFDB-4965-877D-C04A580740C9}" type="datetimeFigureOut">
               <a:rPr lang="fr-FR" smtClean="0"/>
-              <a:t>05/10/2026</a:t>
+              <a:t>08/10/2026</a:t>
             </a:fld>
             <a:endParaRPr lang="fr-FR"/>
           </a:p>
@@ -2403,7 +2512,7 @@
           <a:p>
             <a:fld id="{82E7F8B9-DFDB-4965-877D-C04A580740C9}" type="datetimeFigureOut">
               <a:rPr lang="fr-FR" smtClean="0"/>
-              <a:t>05/10/2026</a:t>
+              <a:t>08/10/2026</a:t>
             </a:fld>
             <a:endParaRPr lang="fr-FR"/>
           </a:p>
@@ -2636,7 +2745,7 @@
           <a:p>
             <a:fld id="{82E7F8B9-DFDB-4965-877D-C04A580740C9}" type="datetimeFigureOut">
               <a:rPr lang="fr-FR" smtClean="0"/>
-              <a:t>05/10/2026</a:t>
+              <a:t>08/10/2026</a:t>
             </a:fld>
             <a:endParaRPr lang="fr-FR"/>
           </a:p>
@@ -2911,7 +3020,7 @@
           <a:p>
             <a:fld id="{82E7F8B9-DFDB-4965-877D-C04A580740C9}" type="datetimeFigureOut">
               <a:rPr lang="fr-FR" smtClean="0"/>
-              <a:t>05/10/2026</a:t>
+              <a:t>08/10/2026</a:t>
             </a:fld>
             <a:endParaRPr lang="fr-FR"/>
           </a:p>
@@ -3176,7 +3285,7 @@
           <a:p>
             <a:fld id="{82E7F8B9-DFDB-4965-877D-C04A580740C9}" type="datetimeFigureOut">
               <a:rPr lang="fr-FR" smtClean="0"/>
-              <a:t>05/10/2026</a:t>
+              <a:t>08/10/2026</a:t>
             </a:fld>
             <a:endParaRPr lang="fr-FR"/>
           </a:p>
@@ -3588,7 +3697,7 @@
           <a:p>
             <a:fld id="{82E7F8B9-DFDB-4965-877D-C04A580740C9}" type="datetimeFigureOut">
               <a:rPr lang="fr-FR" smtClean="0"/>
-              <a:t>05/10/2026</a:t>
+              <a:t>08/10/2026</a:t>
             </a:fld>
             <a:endParaRPr lang="fr-FR"/>
           </a:p>
@@ -3729,7 +3838,7 @@
           <a:p>
             <a:fld id="{82E7F8B9-DFDB-4965-877D-C04A580740C9}" type="datetimeFigureOut">
               <a:rPr lang="fr-FR" smtClean="0"/>
-              <a:t>05/10/2026</a:t>
+              <a:t>08/10/2026</a:t>
             </a:fld>
             <a:endParaRPr lang="fr-FR"/>
           </a:p>
@@ -3842,7 +3951,7 @@
           <a:p>
             <a:fld id="{82E7F8B9-DFDB-4965-877D-C04A580740C9}" type="datetimeFigureOut">
               <a:rPr lang="fr-FR" smtClean="0"/>
-              <a:t>05/10/2026</a:t>
+              <a:t>08/10/2026</a:t>
             </a:fld>
             <a:endParaRPr lang="fr-FR"/>
           </a:p>
@@ -4153,7 +4262,7 @@
           <a:p>
             <a:fld id="{82E7F8B9-DFDB-4965-877D-C04A580740C9}" type="datetimeFigureOut">
               <a:rPr lang="fr-FR" smtClean="0"/>
-              <a:t>05/10/2026</a:t>
+              <a:t>08/10/2026</a:t>
             </a:fld>
             <a:endParaRPr lang="fr-FR"/>
           </a:p>
@@ -4441,7 +4550,7 @@
           <a:p>
             <a:fld id="{82E7F8B9-DFDB-4965-877D-C04A580740C9}" type="datetimeFigureOut">
               <a:rPr lang="fr-FR" smtClean="0"/>
-              <a:t>05/10/2026</a:t>
+              <a:t>08/10/2026</a:t>
             </a:fld>
             <a:endParaRPr lang="fr-FR"/>
           </a:p>
@@ -4682,7 +4791,7 @@
           <a:p>
             <a:fld id="{82E7F8B9-DFDB-4965-877D-C04A580740C9}" type="datetimeFigureOut">
               <a:rPr lang="fr-FR" smtClean="0"/>
-              <a:t>05/10/2026</a:t>
+              <a:t>08/10/2026</a:t>
             </a:fld>
             <a:endParaRPr lang="fr-FR"/>
           </a:p>
@@ -5526,7 +5635,7 @@
         <p:cNvPr id="1" name="">
           <a:extLst>
             <a:ext uri="{FF2B5EF4-FFF2-40B4-BE49-F238E27FC236}">
-              <a16:creationId xmlns:a16="http://schemas.microsoft.com/office/drawing/2014/main" id="{955CEECE-80BD-24F5-29ED-51D02A8DC5DD}"/>
+              <a16:creationId xmlns:a16="http://schemas.microsoft.com/office/drawing/2014/main" id="{6FBD765A-1FEE-159F-96BA-777FDEE395FF}"/>
             </a:ext>
           </a:extLst>
         </p:cNvPr>
@@ -5541,12 +5650,123 @@
           <a:chExt cx="0" cy="0"/>
         </a:xfrm>
       </p:grpSpPr>
+      <p:sp>
+        <p:nvSpPr>
+          <p:cNvPr id="12" name="bg_recap_estimation_fs">
+            <a:extLst>
+              <a:ext uri="{FF2B5EF4-FFF2-40B4-BE49-F238E27FC236}">
+                <a16:creationId xmlns:a16="http://schemas.microsoft.com/office/drawing/2014/main" id="{6BA12113-ED47-B687-ED73-BF7EB1432512}"/>
+              </a:ext>
+            </a:extLst>
+          </p:cNvPr>
+          <p:cNvSpPr/>
+          <p:nvPr/>
+        </p:nvSpPr>
+        <p:spPr>
+          <a:xfrm>
+            <a:off x="1255554" y="2602517"/>
+            <a:ext cx="9765604" cy="663816"/>
+          </a:xfrm>
+          <a:prstGeom prst="rect">
+            <a:avLst/>
+          </a:prstGeom>
+          <a:solidFill>
+            <a:schemeClr val="bg1">
+              <a:lumMod val="95000"/>
+            </a:schemeClr>
+          </a:solidFill>
+          <a:ln>
+            <a:noFill/>
+          </a:ln>
+        </p:spPr>
+        <p:style>
+          <a:lnRef idx="2">
+            <a:schemeClr val="accent1">
+              <a:shade val="15000"/>
+            </a:schemeClr>
+          </a:lnRef>
+          <a:fillRef idx="1">
+            <a:schemeClr val="accent1"/>
+          </a:fillRef>
+          <a:effectRef idx="0">
+            <a:schemeClr val="accent1"/>
+          </a:effectRef>
+          <a:fontRef idx="minor">
+            <a:schemeClr val="lt1"/>
+          </a:fontRef>
+        </p:style>
+        <p:txBody>
+          <a:bodyPr rtlCol="0" anchor="ctr"/>
+          <a:lstStyle/>
+          <a:p>
+            <a:pPr algn="ctr"/>
+            <a:endParaRPr lang="fr-FR">
+              <a:latin typeface="Marianne" panose="02000000000000000000" pitchFamily="50" charset="0"/>
+            </a:endParaRPr>
+          </a:p>
+        </p:txBody>
+      </p:sp>
+      <p:sp>
+        <p:nvSpPr>
+          <p:cNvPr id="9" name="zone_titre_materiau">
+            <a:extLst>
+              <a:ext uri="{FF2B5EF4-FFF2-40B4-BE49-F238E27FC236}">
+                <a16:creationId xmlns:a16="http://schemas.microsoft.com/office/drawing/2014/main" id="{A88800C3-C9AC-CC70-2E75-A1BBA164B372}"/>
+              </a:ext>
+            </a:extLst>
+          </p:cNvPr>
+          <p:cNvSpPr txBox="1"/>
+          <p:nvPr/>
+        </p:nvSpPr>
+        <p:spPr>
+          <a:xfrm>
+            <a:off x="1865713" y="1529871"/>
+            <a:ext cx="5597103" cy="276999"/>
+          </a:xfrm>
+          <a:prstGeom prst="rect">
+            <a:avLst/>
+          </a:prstGeom>
+          <a:noFill/>
+        </p:spPr>
+        <p:txBody>
+          <a:bodyPr wrap="square">
+            <a:spAutoFit/>
+          </a:bodyPr>
+          <a:lstStyle/>
+          <a:p>
+            <a:r>
+              <a:rPr lang="fr-FR" sz="1200" b="1" i="0" dirty="0">
+                <a:effectLst/>
+                <a:latin typeface="Marianne" panose="02000000000000000000" pitchFamily="50" charset="0"/>
+              </a:rPr>
+              <a:t>{{</a:t>
+            </a:r>
+            <a:r>
+              <a:rPr lang="fr-FR" sz="1200" b="1" i="0" dirty="0" err="1">
+                <a:effectLst/>
+                <a:latin typeface="Marianne" panose="02000000000000000000" pitchFamily="50" charset="0"/>
+              </a:rPr>
+              <a:t>titre_materiau</a:t>
+            </a:r>
+            <a:r>
+              <a:rPr lang="fr-FR" sz="1200" b="1" i="0" dirty="0">
+                <a:effectLst/>
+                <a:latin typeface="Marianne" panose="02000000000000000000" pitchFamily="50" charset="0"/>
+              </a:rPr>
+              <a:t>}}</a:t>
+            </a:r>
+            <a:endParaRPr lang="fr-FR" sz="1200" b="1" dirty="0">
+              <a:latin typeface="Marianne" panose="02000000000000000000" pitchFamily="50" charset="0"/>
+            </a:endParaRPr>
+          </a:p>
+        </p:txBody>
+      </p:sp>
       <p:pic>
         <p:nvPicPr>
-          <p:cNvPr id="10" name="Picture 9">
-            <a:extLst>
-              <a:ext uri="{FF2B5EF4-FFF2-40B4-BE49-F238E27FC236}">
-                <a16:creationId xmlns:a16="http://schemas.microsoft.com/office/drawing/2014/main" id="{E922595D-B49E-4187-3566-440EF1D1B583}"/>
+          <p:cNvPr id="15" name="image_materiau" descr="Une image contenant sol, plein air, bâtiment, propriété&#10;&#10;Description générée automatiquement">
+            <a:extLst>
+              <a:ext uri="{FF2B5EF4-FFF2-40B4-BE49-F238E27FC236}">
+                <a16:creationId xmlns:a16="http://schemas.microsoft.com/office/drawing/2014/main" id="{6FE81792-B99E-A1A7-6F71-0CC62F608A31}"/>
               </a:ext>
             </a:extLst>
           </p:cNvPr>
@@ -5556,15 +5776,15 @@
           <p:nvPr/>
         </p:nvPicPr>
         <p:blipFill>
-          <a:blip r:embed="rId3"/>
+          <a:blip r:embed="rId2"/>
           <a:stretch>
             <a:fillRect/>
           </a:stretch>
         </p:blipFill>
         <p:spPr>
           <a:xfrm>
-            <a:off x="10546452" y="104580"/>
-            <a:ext cx="1552051" cy="758533"/>
+            <a:off x="1403168" y="1575983"/>
+            <a:ext cx="462545" cy="476562"/>
           </a:xfrm>
           <a:prstGeom prst="rect">
             <a:avLst/>
@@ -5573,219 +5793,856 @@
       </p:pic>
       <p:sp>
         <p:nvSpPr>
-          <p:cNvPr id="4" name="Text 2">
-            <a:extLst>
-              <a:ext uri="{FF2B5EF4-FFF2-40B4-BE49-F238E27FC236}">
-                <a16:creationId xmlns:a16="http://schemas.microsoft.com/office/drawing/2014/main" id="{3AA7DA23-AC46-53C2-5481-F11CF1FF75EA}"/>
-              </a:ext>
-            </a:extLst>
-          </p:cNvPr>
-          <p:cNvSpPr/>
+          <p:cNvPr id="19" name="zone_cout_materiau">
+            <a:extLst>
+              <a:ext uri="{FF2B5EF4-FFF2-40B4-BE49-F238E27FC236}">
+                <a16:creationId xmlns:a16="http://schemas.microsoft.com/office/drawing/2014/main" id="{79E9B9CA-0F08-3137-64D1-50FFF50EA47E}"/>
+              </a:ext>
+            </a:extLst>
+          </p:cNvPr>
+          <p:cNvSpPr txBox="1"/>
           <p:nvPr/>
         </p:nvSpPr>
         <p:spPr>
           <a:xfrm>
-            <a:off x="609600" y="2202220"/>
-            <a:ext cx="10972800" cy="792480"/>
+            <a:off x="7417711" y="1632102"/>
+            <a:ext cx="3603447" cy="646331"/>
           </a:xfrm>
           <a:prstGeom prst="rect">
             <a:avLst/>
           </a:prstGeom>
           <a:noFill/>
-          <a:ln/>
         </p:spPr>
         <p:txBody>
-          <a:bodyPr wrap="square" lIns="0" tIns="0" rIns="0" bIns="0" rtlCol="0" anchor="ctr"/>
+          <a:bodyPr wrap="square">
+            <a:spAutoFit/>
+          </a:bodyPr>
           <a:lstStyle/>
           <a:p>
-            <a:r>
-              <a:rPr lang="en-US" sz="3733" b="1" dirty="0">
-                <a:solidFill>
-                  <a:srgbClr val="1A1A1A"/>
-                </a:solidFill>
-                <a:latin typeface="Marianne" panose="02000000000000000000" pitchFamily="50" charset="0"/>
-                <a:ea typeface="Calibri" panose="020F0502020204030204" pitchFamily="34" charset="0"/>
-                <a:cs typeface="Calibri" panose="020F0502020204030204" pitchFamily="34" charset="0"/>
-              </a:rPr>
-              <a:t>Aides </a:t>
-            </a:r>
-            <a:r>
-              <a:rPr lang="en-US" sz="3733" b="1" dirty="0" err="1">
-                <a:solidFill>
-                  <a:srgbClr val="1A1A1A"/>
-                </a:solidFill>
-                <a:latin typeface="Marianne" panose="02000000000000000000" pitchFamily="50" charset="0"/>
-                <a:ea typeface="Calibri" panose="020F0502020204030204" pitchFamily="34" charset="0"/>
-                <a:cs typeface="Calibri" panose="020F0502020204030204" pitchFamily="34" charset="0"/>
-              </a:rPr>
-              <a:t>financières</a:t>
-            </a:r>
-            <a:r>
-              <a:rPr lang="en-US" sz="3733" b="1" dirty="0">
-                <a:solidFill>
-                  <a:srgbClr val="1A1A1A"/>
-                </a:solidFill>
-                <a:latin typeface="Marianne" panose="02000000000000000000" pitchFamily="50" charset="0"/>
-                <a:ea typeface="Calibri" panose="020F0502020204030204" pitchFamily="34" charset="0"/>
-                <a:cs typeface="Calibri" panose="020F0502020204030204" pitchFamily="34" charset="0"/>
-              </a:rPr>
-              <a:t> et </a:t>
-            </a:r>
-            <a:r>
-              <a:rPr lang="en-US" sz="3733" b="1" dirty="0" err="1">
-                <a:solidFill>
-                  <a:srgbClr val="1A1A1A"/>
-                </a:solidFill>
-                <a:latin typeface="Marianne" panose="02000000000000000000" pitchFamily="50" charset="0"/>
-                <a:ea typeface="Calibri" panose="020F0502020204030204" pitchFamily="34" charset="0"/>
-                <a:cs typeface="Calibri" panose="020F0502020204030204" pitchFamily="34" charset="0"/>
-              </a:rPr>
-              <a:t>en</a:t>
-            </a:r>
-            <a:r>
-              <a:rPr lang="en-US" sz="3733" b="1" dirty="0">
-                <a:solidFill>
-                  <a:srgbClr val="1A1A1A"/>
-                </a:solidFill>
-                <a:latin typeface="Marianne" panose="02000000000000000000" pitchFamily="50" charset="0"/>
-                <a:ea typeface="Calibri" panose="020F0502020204030204" pitchFamily="34" charset="0"/>
-                <a:cs typeface="Calibri" panose="020F0502020204030204" pitchFamily="34" charset="0"/>
-              </a:rPr>
-              <a:t> </a:t>
-            </a:r>
-            <a:r>
-              <a:rPr lang="en-US" sz="3733" b="1" dirty="0" err="1">
-                <a:solidFill>
-                  <a:srgbClr val="1A1A1A"/>
-                </a:solidFill>
-                <a:latin typeface="Marianne" panose="02000000000000000000" pitchFamily="50" charset="0"/>
-                <a:ea typeface="Calibri" panose="020F0502020204030204" pitchFamily="34" charset="0"/>
-                <a:cs typeface="Calibri" panose="020F0502020204030204" pitchFamily="34" charset="0"/>
-              </a:rPr>
-              <a:t>ingénierie</a:t>
-            </a:r>
-            <a:endParaRPr lang="en-US" sz="3733" dirty="0">
+            <a:pPr marL="0" indent="0" algn="r">
+              <a:buNone/>
+            </a:pPr>
+            <a:r>
+              <a:rPr lang="en-US" sz="1200" i="1" dirty="0" err="1">
+                <a:solidFill>
+                  <a:srgbClr val="2C2C2C"/>
+                </a:solidFill>
+                <a:latin typeface="Marianne" panose="02000000000000000000" pitchFamily="50" charset="0"/>
+                <a:ea typeface="Calibri" pitchFamily="34" charset="-122"/>
+                <a:cs typeface="Calibri" pitchFamily="34" charset="-120"/>
+              </a:rPr>
+              <a:t>Investissement</a:t>
+            </a:r>
+            <a:r>
+              <a:rPr lang="en-US" sz="1200" i="1" dirty="0">
+                <a:solidFill>
+                  <a:srgbClr val="2C2C2C"/>
+                </a:solidFill>
+                <a:latin typeface="Marianne" panose="02000000000000000000" pitchFamily="50" charset="0"/>
+                <a:ea typeface="Calibri" pitchFamily="34" charset="-122"/>
+                <a:cs typeface="Calibri" pitchFamily="34" charset="-120"/>
+              </a:rPr>
+              <a:t> : {{</a:t>
+            </a:r>
+            <a:r>
+              <a:rPr lang="en-US" sz="1200" i="1" dirty="0" err="1">
+                <a:solidFill>
+                  <a:srgbClr val="2C2C2C"/>
+                </a:solidFill>
+                <a:latin typeface="Marianne" panose="02000000000000000000" pitchFamily="50" charset="0"/>
+                <a:ea typeface="Calibri" pitchFamily="34" charset="-122"/>
+                <a:cs typeface="Calibri" pitchFamily="34" charset="-120"/>
+              </a:rPr>
+              <a:t>cout_investissement_materiau</a:t>
+            </a:r>
+            <a:r>
+              <a:rPr lang="en-US" sz="1200" i="1" dirty="0">
+                <a:solidFill>
+                  <a:srgbClr val="2C2C2C"/>
+                </a:solidFill>
+                <a:latin typeface="Marianne" panose="02000000000000000000" pitchFamily="50" charset="0"/>
+                <a:ea typeface="Calibri" pitchFamily="34" charset="-122"/>
+                <a:cs typeface="Calibri" pitchFamily="34" charset="-120"/>
+              </a:rPr>
+              <a:t>}}</a:t>
+            </a:r>
+          </a:p>
+          <a:p>
+            <a:pPr marL="0" indent="0" algn="r">
+              <a:buNone/>
+            </a:pPr>
+            <a:r>
+              <a:rPr lang="en-US" sz="1200" i="1" dirty="0">
+                <a:solidFill>
+                  <a:srgbClr val="2C2C2C"/>
+                </a:solidFill>
+                <a:latin typeface="Marianne" panose="02000000000000000000" pitchFamily="50" charset="0"/>
+                <a:ea typeface="Calibri" pitchFamily="34" charset="-122"/>
+                <a:cs typeface="Calibri" pitchFamily="34" charset="-120"/>
+              </a:rPr>
+              <a:t>Entretien : {{</a:t>
+            </a:r>
+            <a:r>
+              <a:rPr lang="en-US" sz="1200" i="1" dirty="0" err="1">
+                <a:solidFill>
+                  <a:srgbClr val="2C2C2C"/>
+                </a:solidFill>
+                <a:latin typeface="Marianne" panose="02000000000000000000" pitchFamily="50" charset="0"/>
+                <a:ea typeface="Calibri" pitchFamily="34" charset="-122"/>
+                <a:cs typeface="Calibri" pitchFamily="34" charset="-120"/>
+              </a:rPr>
+              <a:t>cout_entretien_materiau</a:t>
+            </a:r>
+            <a:r>
+              <a:rPr lang="en-US" sz="1200" i="1" dirty="0">
+                <a:solidFill>
+                  <a:srgbClr val="2C2C2C"/>
+                </a:solidFill>
+                <a:latin typeface="Marianne" panose="02000000000000000000" pitchFamily="50" charset="0"/>
+                <a:ea typeface="Calibri" pitchFamily="34" charset="-122"/>
+                <a:cs typeface="Calibri" pitchFamily="34" charset="-120"/>
+              </a:rPr>
+              <a:t>}}</a:t>
+            </a:r>
+            <a:endParaRPr lang="en-US" sz="1200" dirty="0">
               <a:latin typeface="Marianne" panose="02000000000000000000" pitchFamily="50" charset="0"/>
-              <a:ea typeface="Calibri" panose="020F0502020204030204" pitchFamily="34" charset="0"/>
-              <a:cs typeface="Calibri" panose="020F0502020204030204" pitchFamily="34" charset="0"/>
             </a:endParaRPr>
           </a:p>
         </p:txBody>
       </p:sp>
       <p:sp>
         <p:nvSpPr>
-          <p:cNvPr id="5" name="Shape 3">
-            <a:extLst>
-              <a:ext uri="{FF2B5EF4-FFF2-40B4-BE49-F238E27FC236}">
-                <a16:creationId xmlns:a16="http://schemas.microsoft.com/office/drawing/2014/main" id="{302F78CA-65FF-9043-6070-1584BC6D4D54}"/>
-              </a:ext>
-            </a:extLst>
-          </p:cNvPr>
-          <p:cNvSpPr/>
+          <p:cNvPr id="3" name="titre_recap_estimation">
+            <a:extLst>
+              <a:ext uri="{FF2B5EF4-FFF2-40B4-BE49-F238E27FC236}">
+                <a16:creationId xmlns:a16="http://schemas.microsoft.com/office/drawing/2014/main" id="{F82418D9-B39F-2905-A2C1-E7CF651F5D36}"/>
+              </a:ext>
+            </a:extLst>
+          </p:cNvPr>
+          <p:cNvSpPr txBox="1">
+            <a:spLocks/>
+          </p:cNvSpPr>
           <p:nvPr/>
         </p:nvSpPr>
         <p:spPr>
           <a:xfrm>
-            <a:off x="609600" y="3080044"/>
-            <a:ext cx="731520" cy="48768"/>
+            <a:off x="576263" y="345395"/>
+            <a:ext cx="10130008" cy="615294"/>
           </a:xfrm>
           <a:prstGeom prst="rect">
             <a:avLst/>
           </a:prstGeom>
-          <a:solidFill>
-            <a:srgbClr val="1A1A1A"/>
-          </a:solidFill>
-          <a:ln w="12700">
+        </p:spPr>
+        <p:txBody>
+          <a:bodyPr vert="horz" lIns="91440" tIns="45720" rIns="91440" bIns="45720" rtlCol="0" anchor="ctr">
+            <a:noAutofit/>
+          </a:bodyPr>
+          <a:lstStyle>
+            <a:lvl1pPr algn="l" defTabSz="914400" rtl="0" eaLnBrk="1" latinLnBrk="0" hangingPunct="1">
+              <a:lnSpc>
+                <a:spcPct val="90000"/>
+              </a:lnSpc>
+              <a:spcBef>
+                <a:spcPct val="0"/>
+              </a:spcBef>
+              <a:buNone/>
+              <a:defRPr sz="4400" kern="1200">
+                <a:solidFill>
+                  <a:schemeClr val="tx1"/>
+                </a:solidFill>
+                <a:latin typeface="+mj-lt"/>
+                <a:ea typeface="+mj-ea"/>
+                <a:cs typeface="+mj-cs"/>
+              </a:defRPr>
+            </a:lvl1pPr>
+          </a:lstStyle>
+          <a:p>
+            <a:r>
+              <a:rPr lang="en-US" sz="2800" dirty="0" err="1">
+                <a:latin typeface="Marianne" panose="02000000000000000000" pitchFamily="50" charset="0"/>
+                <a:ea typeface="Calibri" panose="020F0502020204030204" pitchFamily="34" charset="0"/>
+                <a:cs typeface="Calibri" panose="020F0502020204030204" pitchFamily="34" charset="0"/>
+              </a:rPr>
+              <a:t>Récapitulatif</a:t>
+            </a:r>
+            <a:r>
+              <a:rPr lang="en-US" sz="2800" dirty="0">
+                <a:latin typeface="Marianne" panose="02000000000000000000" pitchFamily="50" charset="0"/>
+                <a:ea typeface="Calibri" panose="020F0502020204030204" pitchFamily="34" charset="0"/>
+                <a:cs typeface="Calibri" panose="020F0502020204030204" pitchFamily="34" charset="0"/>
+              </a:rPr>
+              <a:t> </a:t>
+            </a:r>
+            <a:r>
+              <a:rPr lang="en-US" sz="2800" dirty="0" err="1">
+                <a:latin typeface="Marianne" panose="02000000000000000000" pitchFamily="50" charset="0"/>
+                <a:ea typeface="Calibri" panose="020F0502020204030204" pitchFamily="34" charset="0"/>
+                <a:cs typeface="Calibri" panose="020F0502020204030204" pitchFamily="34" charset="0"/>
+              </a:rPr>
+              <a:t>budgétaire</a:t>
+            </a:r>
+            <a:r>
+              <a:rPr lang="en-US" sz="2800" dirty="0">
+                <a:latin typeface="Marianne" panose="02000000000000000000" pitchFamily="50" charset="0"/>
+                <a:ea typeface="Calibri" panose="020F0502020204030204" pitchFamily="34" charset="0"/>
+                <a:cs typeface="Calibri" panose="020F0502020204030204" pitchFamily="34" charset="0"/>
+              </a:rPr>
+              <a:t> {{</a:t>
+            </a:r>
+            <a:r>
+              <a:rPr lang="en-US" sz="2800" dirty="0" err="1">
+                <a:latin typeface="Marianne" panose="02000000000000000000" pitchFamily="50" charset="0"/>
+                <a:ea typeface="Calibri" panose="020F0502020204030204" pitchFamily="34" charset="0"/>
+                <a:cs typeface="Calibri" panose="020F0502020204030204" pitchFamily="34" charset="0"/>
+              </a:rPr>
+              <a:t>pagination_recap_estimation</a:t>
+            </a:r>
+            <a:r>
+              <a:rPr lang="en-US" sz="2800" dirty="0">
+                <a:latin typeface="Marianne" panose="02000000000000000000" pitchFamily="50" charset="0"/>
+                <a:ea typeface="Calibri" panose="020F0502020204030204" pitchFamily="34" charset="0"/>
+                <a:cs typeface="Calibri" panose="020F0502020204030204" pitchFamily="34" charset="0"/>
+              </a:rPr>
+              <a:t>}}</a:t>
+            </a:r>
+            <a:endParaRPr lang="fr-FR" sz="2800" dirty="0">
+              <a:latin typeface="Marianne" panose="02000000000000000000" pitchFamily="50" charset="0"/>
+            </a:endParaRPr>
+          </a:p>
+        </p:txBody>
+      </p:sp>
+      <p:cxnSp>
+        <p:nvCxnSpPr>
+          <p:cNvPr id="4" name="Connecteur droit 3">
+            <a:extLst>
+              <a:ext uri="{FF2B5EF4-FFF2-40B4-BE49-F238E27FC236}">
+                <a16:creationId xmlns:a16="http://schemas.microsoft.com/office/drawing/2014/main" id="{E6F030A1-1132-C9A1-903C-C717603846E0}"/>
+              </a:ext>
+            </a:extLst>
+          </p:cNvPr>
+          <p:cNvCxnSpPr>
+            <a:cxnSpLocks/>
+          </p:cNvCxnSpPr>
+          <p:nvPr/>
+        </p:nvCxnSpPr>
+        <p:spPr>
+          <a:xfrm>
+            <a:off x="576263" y="960689"/>
+            <a:ext cx="11615737" cy="0"/>
+          </a:xfrm>
+          <a:prstGeom prst="line">
+            <a:avLst/>
+          </a:prstGeom>
+          <a:ln>
             <a:solidFill>
-              <a:srgbClr val="1A1A1A"/>
+              <a:schemeClr val="bg1">
+                <a:lumMod val="85000"/>
+              </a:schemeClr>
             </a:solidFill>
-            <a:prstDash val="solid"/>
           </a:ln>
         </p:spPr>
-        <p:txBody>
-          <a:bodyPr/>
-          <a:lstStyle/>
-          <a:p>
-            <a:endParaRPr lang="fr-FR" sz="2400">
-              <a:latin typeface="Marianne" panose="02000000000000000000" pitchFamily="50" charset="0"/>
-              <a:ea typeface="Calibri" panose="020F0502020204030204" pitchFamily="34" charset="0"/>
-              <a:cs typeface="Calibri" panose="020F0502020204030204" pitchFamily="34" charset="0"/>
-            </a:endParaRPr>
-          </a:p>
-        </p:txBody>
-      </p:sp>
-      <p:sp>
-        <p:nvSpPr>
-          <p:cNvPr id="6" name="Text 4">
-            <a:extLst>
-              <a:ext uri="{FF2B5EF4-FFF2-40B4-BE49-F238E27FC236}">
-                <a16:creationId xmlns:a16="http://schemas.microsoft.com/office/drawing/2014/main" id="{9328B9A3-CC8F-11E9-FAB1-0824EF7E88D7}"/>
-              </a:ext>
-            </a:extLst>
-          </p:cNvPr>
-          <p:cNvSpPr/>
+        <p:style>
+          <a:lnRef idx="2">
+            <a:schemeClr val="accent1"/>
+          </a:lnRef>
+          <a:fillRef idx="0">
+            <a:schemeClr val="accent1"/>
+          </a:fillRef>
+          <a:effectRef idx="1">
+            <a:schemeClr val="accent1"/>
+          </a:effectRef>
+          <a:fontRef idx="minor">
+            <a:schemeClr val="tx1"/>
+          </a:fontRef>
+        </p:style>
+      </p:cxnSp>
+      <p:sp>
+        <p:nvSpPr>
+          <p:cNvPr id="2" name="zone_titre_fs_recap_estimation">
+            <a:extLst>
+              <a:ext uri="{FF2B5EF4-FFF2-40B4-BE49-F238E27FC236}">
+                <a16:creationId xmlns:a16="http://schemas.microsoft.com/office/drawing/2014/main" id="{B161BF39-D0D2-C1A3-6A29-174F5C4B931B}"/>
+              </a:ext>
+            </a:extLst>
+          </p:cNvPr>
+          <p:cNvSpPr txBox="1"/>
           <p:nvPr/>
         </p:nvSpPr>
         <p:spPr>
           <a:xfrm>
-            <a:off x="609600" y="3398401"/>
-            <a:ext cx="10972800" cy="2879386"/>
+            <a:off x="1097293" y="1153414"/>
+            <a:ext cx="6059347" cy="307777"/>
           </a:xfrm>
           <a:prstGeom prst="rect">
             <a:avLst/>
           </a:prstGeom>
           <a:noFill/>
-          <a:ln/>
         </p:spPr>
         <p:txBody>
-          <a:bodyPr wrap="square" lIns="0" tIns="0" rIns="0" bIns="0" rtlCol="0" anchor="t"/>
+          <a:bodyPr wrap="square">
+            <a:spAutoFit/>
+          </a:bodyPr>
           <a:lstStyle/>
           <a:p>
             <a:r>
-              <a:rPr lang="en-US" sz="1600" dirty="0" err="1">
-                <a:solidFill>
-                  <a:srgbClr val="5C5C5C"/>
+              <a:rPr lang="fr-FR" sz="1400" b="1" i="0" dirty="0">
+                <a:effectLst/>
+                <a:latin typeface="Marianne" panose="02000000000000000000" pitchFamily="50" charset="0"/>
+              </a:rPr>
+              <a:t>{{</a:t>
+            </a:r>
+            <a:r>
+              <a:rPr lang="fr-FR" sz="1400" b="1" i="0" dirty="0" err="1">
+                <a:effectLst/>
+                <a:latin typeface="Marianne" panose="02000000000000000000" pitchFamily="50" charset="0"/>
+              </a:rPr>
+              <a:t>titre_fiche_solution</a:t>
+            </a:r>
+            <a:r>
+              <a:rPr lang="fr-FR" sz="1400" b="1" i="0" dirty="0">
+                <a:effectLst/>
+                <a:latin typeface="Marianne" panose="02000000000000000000" pitchFamily="50" charset="0"/>
+              </a:rPr>
+              <a:t>}}</a:t>
+            </a:r>
+            <a:endParaRPr lang="fr-FR" sz="1400" b="1" dirty="0">
+              <a:latin typeface="Marianne" panose="02000000000000000000" pitchFamily="50" charset="0"/>
+            </a:endParaRPr>
+          </a:p>
+        </p:txBody>
+      </p:sp>
+      <p:sp>
+        <p:nvSpPr>
+          <p:cNvPr id="6" name="recap_total_libelles">
+            <a:extLst>
+              <a:ext uri="{FF2B5EF4-FFF2-40B4-BE49-F238E27FC236}">
+                <a16:creationId xmlns:a16="http://schemas.microsoft.com/office/drawing/2014/main" id="{8CF6B5B8-BAD7-E10A-E363-18498172553F}"/>
+              </a:ext>
+            </a:extLst>
+          </p:cNvPr>
+          <p:cNvSpPr txBox="1"/>
+          <p:nvPr/>
+        </p:nvSpPr>
+        <p:spPr>
+          <a:xfrm>
+            <a:off x="6711181" y="4547787"/>
+            <a:ext cx="1579966" cy="430887"/>
+          </a:xfrm>
+          <a:prstGeom prst="rect">
+            <a:avLst/>
+          </a:prstGeom>
+          <a:noFill/>
+        </p:spPr>
+        <p:txBody>
+          <a:bodyPr wrap="square">
+            <a:spAutoFit/>
+          </a:bodyPr>
+          <a:lstStyle/>
+          <a:p>
+            <a:pPr marL="0" indent="0">
+              <a:buNone/>
+            </a:pPr>
+            <a:r>
+              <a:rPr lang="en-US" sz="1200" b="1" dirty="0" err="1">
+                <a:solidFill>
+                  <a:srgbClr val="2C2C2C"/>
                 </a:solidFill>
                 <a:latin typeface="Marianne" panose="02000000000000000000" pitchFamily="50" charset="0"/>
                 <a:ea typeface="Calibri" pitchFamily="34" charset="-122"/>
                 <a:cs typeface="Calibri" pitchFamily="34" charset="-120"/>
               </a:rPr>
-              <a:t>Dispositifs</a:t>
-            </a:r>
-            <a:r>
-              <a:rPr lang="en-US" sz="1600" dirty="0">
-                <a:solidFill>
-                  <a:srgbClr val="5C5C5C"/>
+              <a:t>Investissement</a:t>
+            </a:r>
+            <a:r>
+              <a:rPr lang="en-US" sz="1200" b="1" dirty="0">
+                <a:solidFill>
+                  <a:srgbClr val="2C2C2C"/>
                 </a:solidFill>
                 <a:latin typeface="Marianne" panose="02000000000000000000" pitchFamily="50" charset="0"/>
                 <a:ea typeface="Calibri" pitchFamily="34" charset="-122"/>
                 <a:cs typeface="Calibri" pitchFamily="34" charset="-120"/>
               </a:rPr>
-              <a:t> </a:t>
-            </a:r>
-            <a:r>
-              <a:rPr lang="en-US" sz="1600" dirty="0" err="1">
-                <a:solidFill>
-                  <a:srgbClr val="5C5C5C"/>
+              <a:t> :</a:t>
+            </a:r>
+          </a:p>
+          <a:p>
+            <a:pPr marL="0" indent="0">
+              <a:buNone/>
+            </a:pPr>
+            <a:r>
+              <a:rPr lang="en-US" sz="1000" dirty="0">
+                <a:solidFill>
+                  <a:schemeClr val="tx1">
+                    <a:lumMod val="75000"/>
+                    <a:lumOff val="25000"/>
+                  </a:schemeClr>
                 </a:solidFill>
                 <a:latin typeface="Marianne" panose="02000000000000000000" pitchFamily="50" charset="0"/>
                 <a:ea typeface="Calibri" pitchFamily="34" charset="-122"/>
                 <a:cs typeface="Calibri" pitchFamily="34" charset="-120"/>
               </a:rPr>
-              <a:t>mobilisables</a:t>
-            </a:r>
-            <a:endParaRPr lang="en-US" sz="1600" dirty="0">
+              <a:t>Entretien :</a:t>
+            </a:r>
+            <a:endParaRPr lang="en-US" sz="1000" dirty="0">
+              <a:solidFill>
+                <a:schemeClr val="tx1">
+                  <a:lumMod val="75000"/>
+                  <a:lumOff val="25000"/>
+                </a:schemeClr>
+              </a:solidFill>
               <a:latin typeface="Marianne" panose="02000000000000000000" pitchFamily="50" charset="0"/>
             </a:endParaRPr>
           </a:p>
         </p:txBody>
       </p:sp>
+      <p:sp>
+        <p:nvSpPr>
+          <p:cNvPr id="11" name="ZoneTexte 10">
+            <a:extLst>
+              <a:ext uri="{FF2B5EF4-FFF2-40B4-BE49-F238E27FC236}">
+                <a16:creationId xmlns:a16="http://schemas.microsoft.com/office/drawing/2014/main" id="{7CB1432B-AE88-BC89-B5DC-87807C1FB1A9}"/>
+              </a:ext>
+            </a:extLst>
+          </p:cNvPr>
+          <p:cNvSpPr txBox="1"/>
+          <p:nvPr/>
+        </p:nvSpPr>
+        <p:spPr>
+          <a:xfrm>
+            <a:off x="6918732" y="2680597"/>
+            <a:ext cx="3950835" cy="430887"/>
+          </a:xfrm>
+          <a:prstGeom prst="rect">
+            <a:avLst/>
+          </a:prstGeom>
+          <a:noFill/>
+        </p:spPr>
+        <p:txBody>
+          <a:bodyPr wrap="square">
+            <a:spAutoFit/>
+          </a:bodyPr>
+          <a:lstStyle/>
+          <a:p>
+            <a:pPr marL="0" indent="0" algn="r">
+              <a:buNone/>
+            </a:pPr>
+            <a:r>
+              <a:rPr lang="en-US" sz="1200" b="1" i="1" dirty="0">
+                <a:solidFill>
+                  <a:srgbClr val="2C2C2C"/>
+                </a:solidFill>
+                <a:latin typeface="Marianne" panose="02000000000000000000" pitchFamily="50" charset="0"/>
+                <a:ea typeface="Calibri" pitchFamily="34" charset="-122"/>
+                <a:cs typeface="Calibri" pitchFamily="34" charset="-120"/>
+              </a:rPr>
+              <a:t>{{</a:t>
+            </a:r>
+            <a:r>
+              <a:rPr lang="en-US" sz="1200" b="1" i="1" dirty="0" err="1">
+                <a:solidFill>
+                  <a:srgbClr val="2C2C2C"/>
+                </a:solidFill>
+                <a:latin typeface="Marianne" panose="02000000000000000000" pitchFamily="50" charset="0"/>
+                <a:ea typeface="Calibri" pitchFamily="34" charset="-122"/>
+                <a:cs typeface="Calibri" pitchFamily="34" charset="-120"/>
+              </a:rPr>
+              <a:t>cout_investissement_fiche_solution</a:t>
+            </a:r>
+            <a:r>
+              <a:rPr lang="en-US" sz="1200" b="1" i="1" dirty="0">
+                <a:solidFill>
+                  <a:srgbClr val="2C2C2C"/>
+                </a:solidFill>
+                <a:latin typeface="Marianne" panose="02000000000000000000" pitchFamily="50" charset="0"/>
+                <a:ea typeface="Calibri" pitchFamily="34" charset="-122"/>
+                <a:cs typeface="Calibri" pitchFamily="34" charset="-120"/>
+              </a:rPr>
+              <a:t>}}</a:t>
+            </a:r>
+          </a:p>
+          <a:p>
+            <a:pPr marL="0" indent="0" algn="r">
+              <a:buNone/>
+            </a:pPr>
+            <a:r>
+              <a:rPr lang="en-US" sz="1000" i="1" dirty="0">
+                <a:solidFill>
+                  <a:srgbClr val="2C2C2C"/>
+                </a:solidFill>
+                <a:latin typeface="Marianne" panose="02000000000000000000" pitchFamily="50" charset="0"/>
+                <a:ea typeface="Calibri" pitchFamily="34" charset="-122"/>
+                <a:cs typeface="Calibri" pitchFamily="34" charset="-120"/>
+              </a:rPr>
+              <a:t>{{</a:t>
+            </a:r>
+            <a:r>
+              <a:rPr lang="en-US" sz="1000" i="1" dirty="0" err="1">
+                <a:solidFill>
+                  <a:srgbClr val="2C2C2C"/>
+                </a:solidFill>
+                <a:latin typeface="Marianne" panose="02000000000000000000" pitchFamily="50" charset="0"/>
+                <a:ea typeface="Calibri" pitchFamily="34" charset="-122"/>
+                <a:cs typeface="Calibri" pitchFamily="34" charset="-120"/>
+              </a:rPr>
+              <a:t>cout_entretien_fiche_solution</a:t>
+            </a:r>
+            <a:r>
+              <a:rPr lang="en-US" sz="1000" i="1" dirty="0">
+                <a:solidFill>
+                  <a:srgbClr val="2C2C2C"/>
+                </a:solidFill>
+                <a:latin typeface="Marianne" panose="02000000000000000000" pitchFamily="50" charset="0"/>
+                <a:ea typeface="Calibri" pitchFamily="34" charset="-122"/>
+                <a:cs typeface="Calibri" pitchFamily="34" charset="-120"/>
+              </a:rPr>
+              <a:t>}}</a:t>
+            </a:r>
+            <a:endParaRPr lang="en-US" sz="1000" dirty="0">
+              <a:latin typeface="Marianne" panose="02000000000000000000" pitchFamily="50" charset="0"/>
+            </a:endParaRPr>
+          </a:p>
+        </p:txBody>
+      </p:sp>
+      <p:sp>
+        <p:nvSpPr>
+          <p:cNvPr id="13" name="recap_titre">
+            <a:extLst>
+              <a:ext uri="{FF2B5EF4-FFF2-40B4-BE49-F238E27FC236}">
+                <a16:creationId xmlns:a16="http://schemas.microsoft.com/office/drawing/2014/main" id="{821261B6-DEDA-B63E-00A5-C946FA7EEF26}"/>
+              </a:ext>
+            </a:extLst>
+          </p:cNvPr>
+          <p:cNvSpPr txBox="1"/>
+          <p:nvPr/>
+        </p:nvSpPr>
+        <p:spPr>
+          <a:xfrm>
+            <a:off x="1097292" y="3955732"/>
+            <a:ext cx="6250712" cy="523220"/>
+          </a:xfrm>
+          <a:prstGeom prst="rect">
+            <a:avLst/>
+          </a:prstGeom>
+          <a:noFill/>
+        </p:spPr>
+        <p:txBody>
+          <a:bodyPr wrap="square">
+            <a:spAutoFit/>
+          </a:bodyPr>
+          <a:lstStyle/>
+          <a:p>
+            <a:r>
+              <a:rPr lang="fr-FR" sz="1400" b="1" i="0" dirty="0">
+                <a:effectLst/>
+                <a:latin typeface="Marianne" panose="02000000000000000000" pitchFamily="50" charset="0"/>
+              </a:rPr>
+              <a:t>Estimation totale des solutions envisagées</a:t>
+            </a:r>
+          </a:p>
+          <a:p>
+            <a:pPr algn="l"/>
+            <a:r>
+              <a:rPr lang="fr-FR" sz="1100" b="0" i="0" dirty="0">
+                <a:solidFill>
+                  <a:srgbClr val="666666"/>
+                </a:solidFill>
+                <a:effectLst/>
+                <a:latin typeface="Marianne" panose="02000000000000000000" pitchFamily="50" charset="0"/>
+                <a:ea typeface="Calibri" panose="020F0502020204030204" pitchFamily="34" charset="0"/>
+                <a:cs typeface="Calibri" panose="020F0502020204030204" pitchFamily="34" charset="0"/>
+              </a:rPr>
+              <a:t> Inclut : fourniture et pose (hors travaux complémentaires de voirie, consolidation, etc.)</a:t>
+            </a:r>
+            <a:r>
+              <a:rPr lang="fr-FR" sz="1400" b="1" dirty="0">
+                <a:latin typeface="Marianne" panose="02000000000000000000" pitchFamily="50" charset="0"/>
+              </a:rPr>
+              <a:t> </a:t>
+            </a:r>
+          </a:p>
+        </p:txBody>
+      </p:sp>
+      <p:sp>
+        <p:nvSpPr>
+          <p:cNvPr id="16" name="zone_recap_fiche_solution">
+            <a:extLst>
+              <a:ext uri="{FF2B5EF4-FFF2-40B4-BE49-F238E27FC236}">
+                <a16:creationId xmlns:a16="http://schemas.microsoft.com/office/drawing/2014/main" id="{2511F9AC-9A80-85A8-5987-7E6F88547863}"/>
+              </a:ext>
+            </a:extLst>
+          </p:cNvPr>
+          <p:cNvSpPr txBox="1"/>
+          <p:nvPr/>
+        </p:nvSpPr>
+        <p:spPr>
+          <a:xfrm>
+            <a:off x="1377181" y="2718981"/>
+            <a:ext cx="3285673" cy="430887"/>
+          </a:xfrm>
+          <a:prstGeom prst="rect">
+            <a:avLst/>
+          </a:prstGeom>
+          <a:noFill/>
+        </p:spPr>
+        <p:txBody>
+          <a:bodyPr wrap="square">
+            <a:spAutoFit/>
+          </a:bodyPr>
+          <a:lstStyle/>
+          <a:p>
+            <a:pPr marL="0" indent="0">
+              <a:buNone/>
+            </a:pPr>
+            <a:r>
+              <a:rPr lang="en-US" sz="1200" b="1" dirty="0">
+                <a:solidFill>
+                  <a:srgbClr val="2C2C2C"/>
+                </a:solidFill>
+                <a:latin typeface="Marianne" panose="02000000000000000000" pitchFamily="50" charset="0"/>
+                <a:ea typeface="Calibri" pitchFamily="34" charset="-122"/>
+                <a:cs typeface="Calibri" pitchFamily="34" charset="-120"/>
+              </a:rPr>
+              <a:t>Total </a:t>
+            </a:r>
+            <a:r>
+              <a:rPr lang="en-US" sz="1200" b="1" dirty="0" err="1">
+                <a:solidFill>
+                  <a:srgbClr val="2C2C2C"/>
+                </a:solidFill>
+                <a:latin typeface="Marianne" panose="02000000000000000000" pitchFamily="50" charset="0"/>
+                <a:ea typeface="Calibri" pitchFamily="34" charset="-122"/>
+                <a:cs typeface="Calibri" pitchFamily="34" charset="-120"/>
+              </a:rPr>
+              <a:t>Investissement</a:t>
+            </a:r>
+            <a:endParaRPr lang="en-US" sz="1200" b="1" dirty="0">
+              <a:solidFill>
+                <a:srgbClr val="2C2C2C"/>
+              </a:solidFill>
+              <a:latin typeface="Marianne" panose="02000000000000000000" pitchFamily="50" charset="0"/>
+              <a:ea typeface="Calibri" pitchFamily="34" charset="-122"/>
+              <a:cs typeface="Calibri" pitchFamily="34" charset="-120"/>
+            </a:endParaRPr>
+          </a:p>
+          <a:p>
+            <a:pPr marL="0" indent="0">
+              <a:buNone/>
+            </a:pPr>
+            <a:r>
+              <a:rPr lang="en-US" sz="1000" dirty="0">
+                <a:solidFill>
+                  <a:schemeClr val="tx1">
+                    <a:lumMod val="75000"/>
+                    <a:lumOff val="25000"/>
+                  </a:schemeClr>
+                </a:solidFill>
+                <a:latin typeface="Marianne" panose="02000000000000000000" pitchFamily="50" charset="0"/>
+                <a:ea typeface="Calibri" pitchFamily="34" charset="-122"/>
+                <a:cs typeface="Calibri" pitchFamily="34" charset="-120"/>
+              </a:rPr>
+              <a:t>Total Entretien</a:t>
+            </a:r>
+            <a:endParaRPr lang="en-US" sz="1000" dirty="0">
+              <a:solidFill>
+                <a:schemeClr val="tx1">
+                  <a:lumMod val="75000"/>
+                  <a:lumOff val="25000"/>
+                </a:schemeClr>
+              </a:solidFill>
+              <a:latin typeface="Marianne" panose="02000000000000000000" pitchFamily="50" charset="0"/>
+            </a:endParaRPr>
+          </a:p>
+        </p:txBody>
+      </p:sp>
+      <p:sp>
+        <p:nvSpPr>
+          <p:cNvPr id="18" name="recap_total_libelles_valeurs">
+            <a:extLst>
+              <a:ext uri="{FF2B5EF4-FFF2-40B4-BE49-F238E27FC236}">
+                <a16:creationId xmlns:a16="http://schemas.microsoft.com/office/drawing/2014/main" id="{09E2F9B4-E5A1-7459-5392-6A6FC53C59B6}"/>
+              </a:ext>
+            </a:extLst>
+          </p:cNvPr>
+          <p:cNvSpPr txBox="1"/>
+          <p:nvPr/>
+        </p:nvSpPr>
+        <p:spPr>
+          <a:xfrm>
+            <a:off x="8093319" y="4547787"/>
+            <a:ext cx="2831124" cy="430887"/>
+          </a:xfrm>
+          <a:prstGeom prst="rect">
+            <a:avLst/>
+          </a:prstGeom>
+          <a:noFill/>
+        </p:spPr>
+        <p:txBody>
+          <a:bodyPr wrap="square">
+            <a:spAutoFit/>
+          </a:bodyPr>
+          <a:lstStyle/>
+          <a:p>
+            <a:r>
+              <a:rPr lang="en-US" sz="1200" b="1" i="1" dirty="0">
+                <a:solidFill>
+                  <a:srgbClr val="2C2C2C"/>
+                </a:solidFill>
+                <a:latin typeface="Marianne" panose="02000000000000000000" pitchFamily="50" charset="0"/>
+                <a:ea typeface="Calibri" pitchFamily="34" charset="-122"/>
+                <a:cs typeface="Calibri" pitchFamily="34" charset="-120"/>
+              </a:rPr>
+              <a:t>{{</a:t>
+            </a:r>
+            <a:r>
+              <a:rPr lang="en-US" sz="1200" b="1" i="1" dirty="0" err="1">
+                <a:solidFill>
+                  <a:srgbClr val="2C2C2C"/>
+                </a:solidFill>
+                <a:latin typeface="Marianne" panose="02000000000000000000" pitchFamily="50" charset="0"/>
+                <a:ea typeface="Calibri" pitchFamily="34" charset="-122"/>
+                <a:cs typeface="Calibri" pitchFamily="34" charset="-120"/>
+              </a:rPr>
+              <a:t>cout_investissement_estimation</a:t>
+            </a:r>
+            <a:r>
+              <a:rPr lang="en-US" sz="1200" b="1" i="1" dirty="0">
+                <a:solidFill>
+                  <a:srgbClr val="2C2C2C"/>
+                </a:solidFill>
+                <a:latin typeface="Marianne" panose="02000000000000000000" pitchFamily="50" charset="0"/>
+                <a:ea typeface="Calibri" pitchFamily="34" charset="-122"/>
+                <a:cs typeface="Calibri" pitchFamily="34" charset="-120"/>
+              </a:rPr>
+              <a:t>}}</a:t>
+            </a:r>
+            <a:endParaRPr lang="en-US" sz="1200" b="1" dirty="0">
+              <a:solidFill>
+                <a:srgbClr val="2C2C2C"/>
+              </a:solidFill>
+              <a:latin typeface="Marianne" panose="02000000000000000000" pitchFamily="50" charset="0"/>
+              <a:ea typeface="Calibri" pitchFamily="34" charset="-122"/>
+              <a:cs typeface="Calibri" pitchFamily="34" charset="-120"/>
+            </a:endParaRPr>
+          </a:p>
+          <a:p>
+            <a:pPr marL="0" indent="0">
+              <a:buNone/>
+            </a:pPr>
+            <a:r>
+              <a:rPr lang="en-US" sz="1000" dirty="0">
+                <a:solidFill>
+                  <a:schemeClr val="tx1">
+                    <a:lumMod val="75000"/>
+                    <a:lumOff val="25000"/>
+                  </a:schemeClr>
+                </a:solidFill>
+                <a:latin typeface="Marianne" panose="02000000000000000000" pitchFamily="50" charset="0"/>
+                <a:ea typeface="Calibri" pitchFamily="34" charset="-122"/>
+                <a:cs typeface="Calibri" pitchFamily="34" charset="-120"/>
+              </a:rPr>
+              <a:t>{{</a:t>
+            </a:r>
+            <a:r>
+              <a:rPr lang="en-US" sz="1000" dirty="0" err="1">
+                <a:solidFill>
+                  <a:schemeClr val="tx1">
+                    <a:lumMod val="75000"/>
+                    <a:lumOff val="25000"/>
+                  </a:schemeClr>
+                </a:solidFill>
+                <a:latin typeface="Marianne" panose="02000000000000000000" pitchFamily="50" charset="0"/>
+                <a:ea typeface="Calibri" pitchFamily="34" charset="-122"/>
+                <a:cs typeface="Calibri" pitchFamily="34" charset="-120"/>
+              </a:rPr>
+              <a:t>cout_enretien_estimation</a:t>
+            </a:r>
+            <a:r>
+              <a:rPr lang="en-US" sz="1000" dirty="0">
+                <a:solidFill>
+                  <a:schemeClr val="tx1">
+                    <a:lumMod val="75000"/>
+                    <a:lumOff val="25000"/>
+                  </a:schemeClr>
+                </a:solidFill>
+                <a:latin typeface="Marianne" panose="02000000000000000000" pitchFamily="50" charset="0"/>
+                <a:ea typeface="Calibri" pitchFamily="34" charset="-122"/>
+                <a:cs typeface="Calibri" pitchFamily="34" charset="-120"/>
+              </a:rPr>
+              <a:t>}}</a:t>
+            </a:r>
+            <a:endParaRPr lang="en-US" sz="1000" dirty="0">
+              <a:solidFill>
+                <a:schemeClr val="tx1">
+                  <a:lumMod val="75000"/>
+                  <a:lumOff val="25000"/>
+                </a:schemeClr>
+              </a:solidFill>
+              <a:latin typeface="Marianne" panose="02000000000000000000" pitchFamily="50" charset="0"/>
+            </a:endParaRPr>
+          </a:p>
+        </p:txBody>
+      </p:sp>
+      <p:sp>
+        <p:nvSpPr>
+          <p:cNvPr id="8" name="zone_quantite_materiau">
+            <a:extLst>
+              <a:ext uri="{FF2B5EF4-FFF2-40B4-BE49-F238E27FC236}">
+                <a16:creationId xmlns:a16="http://schemas.microsoft.com/office/drawing/2014/main" id="{2E3BE4A1-A1C8-70C6-319A-D994B244BC29}"/>
+              </a:ext>
+            </a:extLst>
+          </p:cNvPr>
+          <p:cNvSpPr txBox="1"/>
+          <p:nvPr/>
+        </p:nvSpPr>
+        <p:spPr>
+          <a:xfrm>
+            <a:off x="1865713" y="1824986"/>
+            <a:ext cx="5597103" cy="246221"/>
+          </a:xfrm>
+          <a:prstGeom prst="rect">
+            <a:avLst/>
+          </a:prstGeom>
+          <a:noFill/>
+        </p:spPr>
+        <p:txBody>
+          <a:bodyPr wrap="square">
+            <a:spAutoFit/>
+          </a:bodyPr>
+          <a:lstStyle/>
+          <a:p>
+            <a:r>
+              <a:rPr lang="fr-FR" sz="1000" i="0" dirty="0">
+                <a:effectLst/>
+                <a:latin typeface="Marianne" panose="02000000000000000000" pitchFamily="50" charset="0"/>
+              </a:rPr>
+              <a:t>{{</a:t>
+            </a:r>
+            <a:r>
+              <a:rPr lang="fr-FR" sz="1000" i="0" dirty="0" err="1">
+                <a:effectLst/>
+                <a:latin typeface="Marianne" panose="02000000000000000000" pitchFamily="50" charset="0"/>
+              </a:rPr>
+              <a:t>quantite_materiau</a:t>
+            </a:r>
+            <a:r>
+              <a:rPr lang="fr-FR" sz="1000" i="0" dirty="0">
+                <a:effectLst/>
+                <a:latin typeface="Marianne" panose="02000000000000000000" pitchFamily="50" charset="0"/>
+              </a:rPr>
+              <a:t>}}</a:t>
+            </a:r>
+            <a:endParaRPr lang="fr-FR" sz="1000" dirty="0">
+              <a:latin typeface="Marianne" panose="02000000000000000000" pitchFamily="50" charset="0"/>
+            </a:endParaRPr>
+          </a:p>
+        </p:txBody>
+      </p:sp>
       <p:cxnSp>
         <p:nvCxnSpPr>
-          <p:cNvPr id="2" name="Connecteur droit 1">
-            <a:extLst>
-              <a:ext uri="{FF2B5EF4-FFF2-40B4-BE49-F238E27FC236}">
-                <a16:creationId xmlns:a16="http://schemas.microsoft.com/office/drawing/2014/main" id="{A3CAC41A-66B0-361D-B372-62D87EE7A9F8}"/>
+          <p:cNvPr id="10" name="Connecteur droit 9">
+            <a:extLst>
+              <a:ext uri="{FF2B5EF4-FFF2-40B4-BE49-F238E27FC236}">
+                <a16:creationId xmlns:a16="http://schemas.microsoft.com/office/drawing/2014/main" id="{AC020DFA-7CBC-D296-9C51-4CDB5F6EEA67}"/>
               </a:ext>
             </a:extLst>
           </p:cNvPr>
@@ -5827,10 +6684,10 @@
       </p:cxnSp>
       <p:sp>
         <p:nvSpPr>
-          <p:cNvPr id="8" name="Text 3">
-            <a:extLst>
-              <a:ext uri="{FF2B5EF4-FFF2-40B4-BE49-F238E27FC236}">
-                <a16:creationId xmlns:a16="http://schemas.microsoft.com/office/drawing/2014/main" id="{515558A7-65FA-3B23-4336-CA7CF66783E3}"/>
+          <p:cNvPr id="17" name="Text 3">
+            <a:extLst>
+              <a:ext uri="{FF2B5EF4-FFF2-40B4-BE49-F238E27FC236}">
+                <a16:creationId xmlns:a16="http://schemas.microsoft.com/office/drawing/2014/main" id="{513ED38C-6EE1-7913-25F4-4C8F7039ADA0}"/>
               </a:ext>
             </a:extLst>
           </p:cNvPr>
@@ -5874,6 +6731,405 @@
           </a:p>
         </p:txBody>
       </p:sp>
+      <p:pic>
+        <p:nvPicPr>
+          <p:cNvPr id="5" name="Picture 4">
+            <a:extLst>
+              <a:ext uri="{FF2B5EF4-FFF2-40B4-BE49-F238E27FC236}">
+                <a16:creationId xmlns:a16="http://schemas.microsoft.com/office/drawing/2014/main" id="{DDFE2676-551D-F9A9-1060-DC00E3F770F9}"/>
+              </a:ext>
+            </a:extLst>
+          </p:cNvPr>
+          <p:cNvPicPr>
+            <a:picLocks noChangeAspect="1"/>
+          </p:cNvPicPr>
+          <p:nvPr/>
+        </p:nvPicPr>
+        <p:blipFill>
+          <a:blip r:embed="rId3"/>
+          <a:stretch>
+            <a:fillRect/>
+          </a:stretch>
+        </p:blipFill>
+        <p:spPr>
+          <a:xfrm>
+            <a:off x="10546452" y="104580"/>
+            <a:ext cx="1552051" cy="758533"/>
+          </a:xfrm>
+          <a:prstGeom prst="rect">
+            <a:avLst/>
+          </a:prstGeom>
+        </p:spPr>
+      </p:pic>
+    </p:spTree>
+    <p:extLst>
+      <p:ext uri="{BB962C8B-B14F-4D97-AF65-F5344CB8AC3E}">
+        <p14:creationId xmlns:p14="http://schemas.microsoft.com/office/powerpoint/2010/main" val="2086438628"/>
+      </p:ext>
+    </p:extLst>
+  </p:cSld>
+  <p:clrMapOvr>
+    <a:masterClrMapping/>
+  </p:clrMapOvr>
+</p:sld>
+</file>
+
+<file path=ppt/slides/slide11.xml><?xml version="1.0" encoding="utf-8"?>
+<p:sld xmlns:a="http://schemas.openxmlformats.org/drawingml/2006/main" xmlns:r="http://schemas.openxmlformats.org/officeDocument/2006/relationships" xmlns:p="http://schemas.openxmlformats.org/presentationml/2006/main">
+  <p:cSld>
+    <p:spTree>
+      <p:nvGrpSpPr>
+        <p:cNvPr id="1" name="">
+          <a:extLst>
+            <a:ext uri="{FF2B5EF4-FFF2-40B4-BE49-F238E27FC236}">
+              <a16:creationId xmlns:a16="http://schemas.microsoft.com/office/drawing/2014/main" id="{955CEECE-80BD-24F5-29ED-51D02A8DC5DD}"/>
+            </a:ext>
+          </a:extLst>
+        </p:cNvPr>
+        <p:cNvGrpSpPr/>
+        <p:nvPr/>
+      </p:nvGrpSpPr>
+      <p:grpSpPr>
+        <a:xfrm>
+          <a:off x="0" y="0"/>
+          <a:ext cx="0" cy="0"/>
+          <a:chOff x="0" y="0"/>
+          <a:chExt cx="0" cy="0"/>
+        </a:xfrm>
+      </p:grpSpPr>
+      <p:pic>
+        <p:nvPicPr>
+          <p:cNvPr id="10" name="Picture 9">
+            <a:extLst>
+              <a:ext uri="{FF2B5EF4-FFF2-40B4-BE49-F238E27FC236}">
+                <a16:creationId xmlns:a16="http://schemas.microsoft.com/office/drawing/2014/main" id="{E922595D-B49E-4187-3566-440EF1D1B583}"/>
+              </a:ext>
+            </a:extLst>
+          </p:cNvPr>
+          <p:cNvPicPr>
+            <a:picLocks noChangeAspect="1"/>
+          </p:cNvPicPr>
+          <p:nvPr/>
+        </p:nvPicPr>
+        <p:blipFill>
+          <a:blip r:embed="rId3"/>
+          <a:stretch>
+            <a:fillRect/>
+          </a:stretch>
+        </p:blipFill>
+        <p:spPr>
+          <a:xfrm>
+            <a:off x="10546452" y="104580"/>
+            <a:ext cx="1552051" cy="758533"/>
+          </a:xfrm>
+          <a:prstGeom prst="rect">
+            <a:avLst/>
+          </a:prstGeom>
+        </p:spPr>
+      </p:pic>
+      <p:sp>
+        <p:nvSpPr>
+          <p:cNvPr id="4" name="Text 2">
+            <a:extLst>
+              <a:ext uri="{FF2B5EF4-FFF2-40B4-BE49-F238E27FC236}">
+                <a16:creationId xmlns:a16="http://schemas.microsoft.com/office/drawing/2014/main" id="{3AA7DA23-AC46-53C2-5481-F11CF1FF75EA}"/>
+              </a:ext>
+            </a:extLst>
+          </p:cNvPr>
+          <p:cNvSpPr/>
+          <p:nvPr/>
+        </p:nvSpPr>
+        <p:spPr>
+          <a:xfrm>
+            <a:off x="609600" y="2202220"/>
+            <a:ext cx="10972800" cy="792480"/>
+          </a:xfrm>
+          <a:prstGeom prst="rect">
+            <a:avLst/>
+          </a:prstGeom>
+          <a:noFill/>
+          <a:ln/>
+        </p:spPr>
+        <p:txBody>
+          <a:bodyPr wrap="square" lIns="0" tIns="0" rIns="0" bIns="0" rtlCol="0" anchor="ctr"/>
+          <a:lstStyle/>
+          <a:p>
+            <a:r>
+              <a:rPr lang="en-US" sz="3733" b="1" dirty="0">
+                <a:solidFill>
+                  <a:srgbClr val="1A1A1A"/>
+                </a:solidFill>
+                <a:latin typeface="Marianne" panose="02000000000000000000" pitchFamily="50" charset="0"/>
+                <a:ea typeface="Calibri" panose="020F0502020204030204" pitchFamily="34" charset="0"/>
+                <a:cs typeface="Calibri" panose="020F0502020204030204" pitchFamily="34" charset="0"/>
+              </a:rPr>
+              <a:t>Aides </a:t>
+            </a:r>
+            <a:r>
+              <a:rPr lang="en-US" sz="3733" b="1" dirty="0" err="1">
+                <a:solidFill>
+                  <a:srgbClr val="1A1A1A"/>
+                </a:solidFill>
+                <a:latin typeface="Marianne" panose="02000000000000000000" pitchFamily="50" charset="0"/>
+                <a:ea typeface="Calibri" panose="020F0502020204030204" pitchFamily="34" charset="0"/>
+                <a:cs typeface="Calibri" panose="020F0502020204030204" pitchFamily="34" charset="0"/>
+              </a:rPr>
+              <a:t>financières</a:t>
+            </a:r>
+            <a:r>
+              <a:rPr lang="en-US" sz="3733" b="1" dirty="0">
+                <a:solidFill>
+                  <a:srgbClr val="1A1A1A"/>
+                </a:solidFill>
+                <a:latin typeface="Marianne" panose="02000000000000000000" pitchFamily="50" charset="0"/>
+                <a:ea typeface="Calibri" panose="020F0502020204030204" pitchFamily="34" charset="0"/>
+                <a:cs typeface="Calibri" panose="020F0502020204030204" pitchFamily="34" charset="0"/>
+              </a:rPr>
+              <a:t> et </a:t>
+            </a:r>
+            <a:r>
+              <a:rPr lang="en-US" sz="3733" b="1" dirty="0" err="1">
+                <a:solidFill>
+                  <a:srgbClr val="1A1A1A"/>
+                </a:solidFill>
+                <a:latin typeface="Marianne" panose="02000000000000000000" pitchFamily="50" charset="0"/>
+                <a:ea typeface="Calibri" panose="020F0502020204030204" pitchFamily="34" charset="0"/>
+                <a:cs typeface="Calibri" panose="020F0502020204030204" pitchFamily="34" charset="0"/>
+              </a:rPr>
+              <a:t>en</a:t>
+            </a:r>
+            <a:r>
+              <a:rPr lang="en-US" sz="3733" b="1" dirty="0">
+                <a:solidFill>
+                  <a:srgbClr val="1A1A1A"/>
+                </a:solidFill>
+                <a:latin typeface="Marianne" panose="02000000000000000000" pitchFamily="50" charset="0"/>
+                <a:ea typeface="Calibri" panose="020F0502020204030204" pitchFamily="34" charset="0"/>
+                <a:cs typeface="Calibri" panose="020F0502020204030204" pitchFamily="34" charset="0"/>
+              </a:rPr>
+              <a:t> </a:t>
+            </a:r>
+            <a:r>
+              <a:rPr lang="en-US" sz="3733" b="1" dirty="0" err="1">
+                <a:solidFill>
+                  <a:srgbClr val="1A1A1A"/>
+                </a:solidFill>
+                <a:latin typeface="Marianne" panose="02000000000000000000" pitchFamily="50" charset="0"/>
+                <a:ea typeface="Calibri" panose="020F0502020204030204" pitchFamily="34" charset="0"/>
+                <a:cs typeface="Calibri" panose="020F0502020204030204" pitchFamily="34" charset="0"/>
+              </a:rPr>
+              <a:t>ingénierie</a:t>
+            </a:r>
+            <a:endParaRPr lang="en-US" sz="3733" dirty="0">
+              <a:latin typeface="Marianne" panose="02000000000000000000" pitchFamily="50" charset="0"/>
+              <a:ea typeface="Calibri" panose="020F0502020204030204" pitchFamily="34" charset="0"/>
+              <a:cs typeface="Calibri" panose="020F0502020204030204" pitchFamily="34" charset="0"/>
+            </a:endParaRPr>
+          </a:p>
+        </p:txBody>
+      </p:sp>
+      <p:sp>
+        <p:nvSpPr>
+          <p:cNvPr id="5" name="Shape 3">
+            <a:extLst>
+              <a:ext uri="{FF2B5EF4-FFF2-40B4-BE49-F238E27FC236}">
+                <a16:creationId xmlns:a16="http://schemas.microsoft.com/office/drawing/2014/main" id="{302F78CA-65FF-9043-6070-1584BC6D4D54}"/>
+              </a:ext>
+            </a:extLst>
+          </p:cNvPr>
+          <p:cNvSpPr/>
+          <p:nvPr/>
+        </p:nvSpPr>
+        <p:spPr>
+          <a:xfrm>
+            <a:off x="609600" y="3080044"/>
+            <a:ext cx="731520" cy="48768"/>
+          </a:xfrm>
+          <a:prstGeom prst="rect">
+            <a:avLst/>
+          </a:prstGeom>
+          <a:solidFill>
+            <a:srgbClr val="1A1A1A"/>
+          </a:solidFill>
+          <a:ln w="12700">
+            <a:solidFill>
+              <a:srgbClr val="1A1A1A"/>
+            </a:solidFill>
+            <a:prstDash val="solid"/>
+          </a:ln>
+        </p:spPr>
+        <p:txBody>
+          <a:bodyPr/>
+          <a:lstStyle/>
+          <a:p>
+            <a:endParaRPr lang="fr-FR" sz="2400">
+              <a:latin typeface="Marianne" panose="02000000000000000000" pitchFamily="50" charset="0"/>
+              <a:ea typeface="Calibri" panose="020F0502020204030204" pitchFamily="34" charset="0"/>
+              <a:cs typeface="Calibri" panose="020F0502020204030204" pitchFamily="34" charset="0"/>
+            </a:endParaRPr>
+          </a:p>
+        </p:txBody>
+      </p:sp>
+      <p:sp>
+        <p:nvSpPr>
+          <p:cNvPr id="6" name="Text 4">
+            <a:extLst>
+              <a:ext uri="{FF2B5EF4-FFF2-40B4-BE49-F238E27FC236}">
+                <a16:creationId xmlns:a16="http://schemas.microsoft.com/office/drawing/2014/main" id="{9328B9A3-CC8F-11E9-FAB1-0824EF7E88D7}"/>
+              </a:ext>
+            </a:extLst>
+          </p:cNvPr>
+          <p:cNvSpPr/>
+          <p:nvPr/>
+        </p:nvSpPr>
+        <p:spPr>
+          <a:xfrm>
+            <a:off x="609600" y="3398401"/>
+            <a:ext cx="10972800" cy="2879386"/>
+          </a:xfrm>
+          <a:prstGeom prst="rect">
+            <a:avLst/>
+          </a:prstGeom>
+          <a:noFill/>
+          <a:ln/>
+        </p:spPr>
+        <p:txBody>
+          <a:bodyPr wrap="square" lIns="0" tIns="0" rIns="0" bIns="0" rtlCol="0" anchor="t"/>
+          <a:lstStyle/>
+          <a:p>
+            <a:r>
+              <a:rPr lang="en-US" sz="1600" dirty="0" err="1">
+                <a:solidFill>
+                  <a:srgbClr val="5C5C5C"/>
+                </a:solidFill>
+                <a:latin typeface="Marianne" panose="02000000000000000000" pitchFamily="50" charset="0"/>
+                <a:ea typeface="Calibri" pitchFamily="34" charset="-122"/>
+                <a:cs typeface="Calibri" pitchFamily="34" charset="-120"/>
+              </a:rPr>
+              <a:t>Dispositifs</a:t>
+            </a:r>
+            <a:r>
+              <a:rPr lang="en-US" sz="1600" dirty="0">
+                <a:solidFill>
+                  <a:srgbClr val="5C5C5C"/>
+                </a:solidFill>
+                <a:latin typeface="Marianne" panose="02000000000000000000" pitchFamily="50" charset="0"/>
+                <a:ea typeface="Calibri" pitchFamily="34" charset="-122"/>
+                <a:cs typeface="Calibri" pitchFamily="34" charset="-120"/>
+              </a:rPr>
+              <a:t> </a:t>
+            </a:r>
+            <a:r>
+              <a:rPr lang="en-US" sz="1600" dirty="0" err="1">
+                <a:solidFill>
+                  <a:srgbClr val="5C5C5C"/>
+                </a:solidFill>
+                <a:latin typeface="Marianne" panose="02000000000000000000" pitchFamily="50" charset="0"/>
+                <a:ea typeface="Calibri" pitchFamily="34" charset="-122"/>
+                <a:cs typeface="Calibri" pitchFamily="34" charset="-120"/>
+              </a:rPr>
+              <a:t>mobilisables</a:t>
+            </a:r>
+            <a:endParaRPr lang="en-US" sz="1600" dirty="0">
+              <a:latin typeface="Marianne" panose="02000000000000000000" pitchFamily="50" charset="0"/>
+            </a:endParaRPr>
+          </a:p>
+        </p:txBody>
+      </p:sp>
+      <p:cxnSp>
+        <p:nvCxnSpPr>
+          <p:cNvPr id="2" name="Connecteur droit 1">
+            <a:extLst>
+              <a:ext uri="{FF2B5EF4-FFF2-40B4-BE49-F238E27FC236}">
+                <a16:creationId xmlns:a16="http://schemas.microsoft.com/office/drawing/2014/main" id="{A3CAC41A-66B0-361D-B372-62D87EE7A9F8}"/>
+              </a:ext>
+            </a:extLst>
+          </p:cNvPr>
+          <p:cNvCxnSpPr>
+            <a:cxnSpLocks/>
+          </p:cNvCxnSpPr>
+          <p:nvPr/>
+        </p:nvCxnSpPr>
+        <p:spPr>
+          <a:xfrm>
+            <a:off x="576263" y="6512991"/>
+            <a:ext cx="11615737" cy="0"/>
+          </a:xfrm>
+          <a:prstGeom prst="line">
+            <a:avLst/>
+          </a:prstGeom>
+          <a:ln>
+            <a:solidFill>
+              <a:schemeClr val="bg1">
+                <a:lumMod val="85000"/>
+              </a:schemeClr>
+            </a:solidFill>
+          </a:ln>
+        </p:spPr>
+        <p:style>
+          <a:lnRef idx="2">
+            <a:schemeClr val="accent1"/>
+          </a:lnRef>
+          <a:fillRef idx="0">
+            <a:schemeClr val="accent1"/>
+          </a:fillRef>
+          <a:effectRef idx="1">
+            <a:schemeClr val="accent1"/>
+          </a:effectRef>
+          <a:fontRef idx="minor">
+            <a:schemeClr val="tx1"/>
+          </a:fontRef>
+        </p:style>
+      </p:cxnSp>
+      <p:sp>
+        <p:nvSpPr>
+          <p:cNvPr id="8" name="Text 3">
+            <a:extLst>
+              <a:ext uri="{FF2B5EF4-FFF2-40B4-BE49-F238E27FC236}">
+                <a16:creationId xmlns:a16="http://schemas.microsoft.com/office/drawing/2014/main" id="{515558A7-65FA-3B23-4336-CA7CF66783E3}"/>
+              </a:ext>
+            </a:extLst>
+          </p:cNvPr>
+          <p:cNvSpPr/>
+          <p:nvPr/>
+        </p:nvSpPr>
+        <p:spPr>
+          <a:xfrm>
+            <a:off x="576263" y="6598217"/>
+            <a:ext cx="8229600" cy="182880"/>
+          </a:xfrm>
+          <a:prstGeom prst="rect">
+            <a:avLst/>
+          </a:prstGeom>
+          <a:noFill/>
+          <a:ln/>
+        </p:spPr>
+        <p:txBody>
+          <a:bodyPr wrap="square" lIns="0" tIns="0" rIns="0" bIns="0" rtlCol="0" anchor="ctr"/>
+          <a:lstStyle/>
+          <a:p>
+            <a:pPr marL="0" indent="0">
+              <a:buNone/>
+            </a:pPr>
+            <a:r>
+              <a:rPr lang="en-US" sz="1000" i="1">
+                <a:solidFill>
+                  <a:srgbClr val="A0A0A0"/>
+                </a:solidFill>
+                <a:latin typeface="Marianne" panose="02000000000000000000" pitchFamily="50" charset="0"/>
+                <a:ea typeface="Calibri" panose="020F0502020204030204" pitchFamily="34" charset="0"/>
+                <a:cs typeface="Calibri" panose="020F0502020204030204" pitchFamily="34" charset="0"/>
+              </a:rPr>
+              <a:t>Données issues de Plus fraîche ma ville (ADEME)</a:t>
+            </a:r>
+            <a:endParaRPr lang="en-US" sz="1000">
+              <a:latin typeface="Marianne" panose="02000000000000000000" pitchFamily="50" charset="0"/>
+              <a:ea typeface="Calibri" panose="020F0502020204030204" pitchFamily="34" charset="0"/>
+              <a:cs typeface="Calibri" panose="020F0502020204030204" pitchFamily="34" charset="0"/>
+            </a:endParaRPr>
+          </a:p>
+        </p:txBody>
+      </p:sp>
     </p:spTree>
     <p:extLst>
       <p:ext uri="{BB962C8B-B14F-4D97-AF65-F5344CB8AC3E}">
@@ -5887,7 +7143,7 @@
 </p:sld>
 </file>
 
-<file path=ppt/slides/slide11.xml><?xml version="1.0" encoding="utf-8"?>
+<file path=ppt/slides/slide12.xml><?xml version="1.0" encoding="utf-8"?>
 <p:sld xmlns:a="http://schemas.openxmlformats.org/drawingml/2006/main" xmlns:r="http://schemas.openxmlformats.org/officeDocument/2006/relationships" xmlns:p="http://schemas.openxmlformats.org/presentationml/2006/main">
   <p:cSld>
     <p:spTree>
@@ -6456,7 +7712,7 @@
 </p:sld>
 </file>
 
-<file path=ppt/slides/slide12.xml><?xml version="1.0" encoding="utf-8"?>
+<file path=ppt/slides/slide13.xml><?xml version="1.0" encoding="utf-8"?>
 <p:sld xmlns:a="http://schemas.openxmlformats.org/drawingml/2006/main" xmlns:r="http://schemas.openxmlformats.org/officeDocument/2006/relationships" xmlns:p="http://schemas.openxmlformats.org/presentationml/2006/main">
   <p:cSld>
     <p:spTree>
@@ -6782,7 +8038,7 @@
 </p:sld>
 </file>
 
-<file path=ppt/slides/slide13.xml><?xml version="1.0" encoding="utf-8"?>
+<file path=ppt/slides/slide14.xml><?xml version="1.0" encoding="utf-8"?>
 <p:sld xmlns:a="http://schemas.openxmlformats.org/drawingml/2006/main" xmlns:r="http://schemas.openxmlformats.org/officeDocument/2006/relationships" xmlns:p="http://schemas.openxmlformats.org/presentationml/2006/main">
   <p:cSld>
     <p:spTree>
@@ -7334,7 +8590,7 @@
                 <a:ea typeface="Calibri" panose="020F0502020204030204" pitchFamily="34" charset="0"/>
                 <a:cs typeface="Calibri" panose="020F0502020204030204" pitchFamily="34" charset="0"/>
               </a:rPr>
-              <a:t>Méthodes</a:t>
+              <a:t>Analyse</a:t>
             </a:r>
             <a:r>
               <a:rPr lang="en-US" sz="3733" b="1" dirty="0">
@@ -7345,7 +8601,7 @@
                 <a:ea typeface="Calibri" panose="020F0502020204030204" pitchFamily="34" charset="0"/>
                 <a:cs typeface="Calibri" panose="020F0502020204030204" pitchFamily="34" charset="0"/>
               </a:rPr>
-              <a:t> de diagnostic </a:t>
+              <a:t> de </a:t>
             </a:r>
             <a:r>
               <a:rPr lang="en-US" sz="3733" b="1" dirty="0" err="1">
@@ -7356,7 +8612,29 @@
                 <a:ea typeface="Calibri" panose="020F0502020204030204" pitchFamily="34" charset="0"/>
                 <a:cs typeface="Calibri" panose="020F0502020204030204" pitchFamily="34" charset="0"/>
               </a:rPr>
-              <a:t>identifiées</a:t>
+              <a:t>l’espace</a:t>
+            </a:r>
+            <a:r>
+              <a:rPr lang="en-US" sz="3733" b="1" dirty="0">
+                <a:solidFill>
+                  <a:srgbClr val="1A1A1A"/>
+                </a:solidFill>
+                <a:latin typeface="Marianne" panose="02000000000000000000" pitchFamily="50" charset="0"/>
+                <a:ea typeface="Calibri" panose="020F0502020204030204" pitchFamily="34" charset="0"/>
+                <a:cs typeface="Calibri" panose="020F0502020204030204" pitchFamily="34" charset="0"/>
+              </a:rPr>
+              <a:t> à </a:t>
+            </a:r>
+            <a:r>
+              <a:rPr lang="en-US" sz="3733" b="1" dirty="0" err="1">
+                <a:solidFill>
+                  <a:srgbClr val="1A1A1A"/>
+                </a:solidFill>
+                <a:latin typeface="Marianne" panose="02000000000000000000" pitchFamily="50" charset="0"/>
+                <a:ea typeface="Calibri" panose="020F0502020204030204" pitchFamily="34" charset="0"/>
+                <a:cs typeface="Calibri" panose="020F0502020204030204" pitchFamily="34" charset="0"/>
+              </a:rPr>
+              <a:t>rafraîchir</a:t>
             </a:r>
             <a:endParaRPr lang="en-US" sz="3733" dirty="0">
               <a:latin typeface="Marianne" panose="02000000000000000000" pitchFamily="50" charset="0"/>
@@ -7405,73 +8683,6 @@
               <a:ea typeface="Calibri" panose="020F0502020204030204" pitchFamily="34" charset="0"/>
               <a:cs typeface="Calibri" panose="020F0502020204030204" pitchFamily="34" charset="0"/>
             </a:endParaRPr>
-          </a:p>
-        </p:txBody>
-      </p:sp>
-      <p:sp>
-        <p:nvSpPr>
-          <p:cNvPr id="6" name="zone_titre_fiches_diagnostic">
-            <a:extLst>
-              <a:ext uri="{FF2B5EF4-FFF2-40B4-BE49-F238E27FC236}">
-                <a16:creationId xmlns:a16="http://schemas.microsoft.com/office/drawing/2014/main" id="{9328B9A3-CC8F-11E9-FAB1-0824EF7E88D7}"/>
-              </a:ext>
-            </a:extLst>
-          </p:cNvPr>
-          <p:cNvSpPr/>
-          <p:nvPr/>
-        </p:nvSpPr>
-        <p:spPr>
-          <a:xfrm>
-            <a:off x="609600" y="3398401"/>
-            <a:ext cx="10972800" cy="2879386"/>
-          </a:xfrm>
-          <a:prstGeom prst="rect">
-            <a:avLst/>
-          </a:prstGeom>
-          <a:noFill/>
-          <a:ln/>
-        </p:spPr>
-        <p:txBody>
-          <a:bodyPr wrap="square" lIns="0" tIns="0" rIns="0" bIns="0" numCol="2" rtlCol="0" anchor="t"/>
-          <a:lstStyle/>
-          <a:p>
-            <a:pPr marL="285750" indent="-285750">
-              <a:buFont typeface="Arial" panose="020B0604020202020204" pitchFamily="34" charset="0"/>
-              <a:buChar char="•"/>
-            </a:pPr>
-            <a:r>
-              <a:rPr lang="fr-FR" sz="1600" dirty="0">
-                <a:solidFill>
-                  <a:srgbClr val="5C5C5C"/>
-                </a:solidFill>
-                <a:latin typeface="Marianne" panose="02000000000000000000" pitchFamily="50" charset="0"/>
-                <a:ea typeface="Calibri" panose="020F0502020204030204" pitchFamily="34" charset="0"/>
-                <a:cs typeface="Calibri" panose="020F0502020204030204" pitchFamily="34" charset="0"/>
-              </a:rPr>
-              <a:t>{{</a:t>
-            </a:r>
-            <a:r>
-              <a:rPr lang="fr-FR" sz="1600" dirty="0" err="1">
-                <a:solidFill>
-                  <a:srgbClr val="5C5C5C"/>
-                </a:solidFill>
-                <a:latin typeface="Marianne" panose="02000000000000000000" pitchFamily="50" charset="0"/>
-                <a:ea typeface="Calibri" panose="020F0502020204030204" pitchFamily="34" charset="0"/>
-                <a:cs typeface="Calibri" panose="020F0502020204030204" pitchFamily="34" charset="0"/>
-              </a:rPr>
-              <a:t>titre_fiches_diagnostic</a:t>
-            </a:r>
-            <a:r>
-              <a:rPr lang="fr-FR" sz="1600" dirty="0">
-                <a:solidFill>
-                  <a:srgbClr val="5C5C5C"/>
-                </a:solidFill>
-                <a:latin typeface="Marianne" panose="02000000000000000000" pitchFamily="50" charset="0"/>
-                <a:ea typeface="Calibri" panose="020F0502020204030204" pitchFamily="34" charset="0"/>
-                <a:cs typeface="Calibri" panose="020F0502020204030204" pitchFamily="34" charset="0"/>
-              </a:rPr>
-              <a:t>}}</a:t>
-            </a:r>
           </a:p>
         </p:txBody>
       </p:sp>
@@ -13050,6 +14261,343 @@
         <p:cNvPr id="1" name="">
           <a:extLst>
             <a:ext uri="{FF2B5EF4-FFF2-40B4-BE49-F238E27FC236}">
+              <a16:creationId xmlns:a16="http://schemas.microsoft.com/office/drawing/2014/main" id="{955CEECE-80BD-24F5-29ED-51D02A8DC5DD}"/>
+            </a:ext>
+          </a:extLst>
+        </p:cNvPr>
+        <p:cNvGrpSpPr/>
+        <p:nvPr/>
+      </p:nvGrpSpPr>
+      <p:grpSpPr>
+        <a:xfrm>
+          <a:off x="0" y="0"/>
+          <a:ext cx="0" cy="0"/>
+          <a:chOff x="0" y="0"/>
+          <a:chExt cx="0" cy="0"/>
+        </a:xfrm>
+      </p:grpSpPr>
+      <p:pic>
+        <p:nvPicPr>
+          <p:cNvPr id="10" name="Picture 9">
+            <a:extLst>
+              <a:ext uri="{FF2B5EF4-FFF2-40B4-BE49-F238E27FC236}">
+                <a16:creationId xmlns:a16="http://schemas.microsoft.com/office/drawing/2014/main" id="{E922595D-B49E-4187-3566-440EF1D1B583}"/>
+              </a:ext>
+            </a:extLst>
+          </p:cNvPr>
+          <p:cNvPicPr>
+            <a:picLocks noChangeAspect="1"/>
+          </p:cNvPicPr>
+          <p:nvPr/>
+        </p:nvPicPr>
+        <p:blipFill>
+          <a:blip r:embed="rId3"/>
+          <a:stretch>
+            <a:fillRect/>
+          </a:stretch>
+        </p:blipFill>
+        <p:spPr>
+          <a:xfrm>
+            <a:off x="10546452" y="104580"/>
+            <a:ext cx="1552051" cy="758533"/>
+          </a:xfrm>
+          <a:prstGeom prst="rect">
+            <a:avLst/>
+          </a:prstGeom>
+        </p:spPr>
+      </p:pic>
+      <p:sp>
+        <p:nvSpPr>
+          <p:cNvPr id="4" name="Text 2">
+            <a:extLst>
+              <a:ext uri="{FF2B5EF4-FFF2-40B4-BE49-F238E27FC236}">
+                <a16:creationId xmlns:a16="http://schemas.microsoft.com/office/drawing/2014/main" id="{3AA7DA23-AC46-53C2-5481-F11CF1FF75EA}"/>
+              </a:ext>
+            </a:extLst>
+          </p:cNvPr>
+          <p:cNvSpPr/>
+          <p:nvPr/>
+        </p:nvSpPr>
+        <p:spPr>
+          <a:xfrm>
+            <a:off x="609600" y="2202220"/>
+            <a:ext cx="10972800" cy="792480"/>
+          </a:xfrm>
+          <a:prstGeom prst="rect">
+            <a:avLst/>
+          </a:prstGeom>
+          <a:noFill/>
+          <a:ln/>
+        </p:spPr>
+        <p:txBody>
+          <a:bodyPr wrap="square" lIns="0" tIns="0" rIns="0" bIns="0" rtlCol="0" anchor="ctr"/>
+          <a:lstStyle/>
+          <a:p>
+            <a:r>
+              <a:rPr lang="en-US" sz="3733" b="1" dirty="0" err="1">
+                <a:solidFill>
+                  <a:srgbClr val="1A1A1A"/>
+                </a:solidFill>
+                <a:latin typeface="Marianne" panose="02000000000000000000" pitchFamily="50" charset="0"/>
+                <a:ea typeface="Calibri" panose="020F0502020204030204" pitchFamily="34" charset="0"/>
+                <a:cs typeface="Calibri" panose="020F0502020204030204" pitchFamily="34" charset="0"/>
+              </a:rPr>
+              <a:t>Méthodes</a:t>
+            </a:r>
+            <a:r>
+              <a:rPr lang="en-US" sz="3733" b="1" dirty="0">
+                <a:solidFill>
+                  <a:srgbClr val="1A1A1A"/>
+                </a:solidFill>
+                <a:latin typeface="Marianne" panose="02000000000000000000" pitchFamily="50" charset="0"/>
+                <a:ea typeface="Calibri" panose="020F0502020204030204" pitchFamily="34" charset="0"/>
+                <a:cs typeface="Calibri" panose="020F0502020204030204" pitchFamily="34" charset="0"/>
+              </a:rPr>
+              <a:t> de diagnostic </a:t>
+            </a:r>
+            <a:r>
+              <a:rPr lang="en-US" sz="3733" b="1" dirty="0" err="1">
+                <a:solidFill>
+                  <a:srgbClr val="1A1A1A"/>
+                </a:solidFill>
+                <a:latin typeface="Marianne" panose="02000000000000000000" pitchFamily="50" charset="0"/>
+                <a:ea typeface="Calibri" panose="020F0502020204030204" pitchFamily="34" charset="0"/>
+                <a:cs typeface="Calibri" panose="020F0502020204030204" pitchFamily="34" charset="0"/>
+              </a:rPr>
+              <a:t>identifiées</a:t>
+            </a:r>
+            <a:endParaRPr lang="en-US" sz="3733" dirty="0">
+              <a:latin typeface="Marianne" panose="02000000000000000000" pitchFamily="50" charset="0"/>
+              <a:ea typeface="Calibri" panose="020F0502020204030204" pitchFamily="34" charset="0"/>
+              <a:cs typeface="Calibri" panose="020F0502020204030204" pitchFamily="34" charset="0"/>
+            </a:endParaRPr>
+          </a:p>
+        </p:txBody>
+      </p:sp>
+      <p:sp>
+        <p:nvSpPr>
+          <p:cNvPr id="5" name="Shape 3">
+            <a:extLst>
+              <a:ext uri="{FF2B5EF4-FFF2-40B4-BE49-F238E27FC236}">
+                <a16:creationId xmlns:a16="http://schemas.microsoft.com/office/drawing/2014/main" id="{302F78CA-65FF-9043-6070-1584BC6D4D54}"/>
+              </a:ext>
+            </a:extLst>
+          </p:cNvPr>
+          <p:cNvSpPr/>
+          <p:nvPr/>
+        </p:nvSpPr>
+        <p:spPr>
+          <a:xfrm>
+            <a:off x="609600" y="3080044"/>
+            <a:ext cx="731520" cy="48768"/>
+          </a:xfrm>
+          <a:prstGeom prst="rect">
+            <a:avLst/>
+          </a:prstGeom>
+          <a:solidFill>
+            <a:srgbClr val="1A1A1A"/>
+          </a:solidFill>
+          <a:ln w="12700">
+            <a:solidFill>
+              <a:srgbClr val="1A1A1A"/>
+            </a:solidFill>
+            <a:prstDash val="solid"/>
+          </a:ln>
+        </p:spPr>
+        <p:txBody>
+          <a:bodyPr/>
+          <a:lstStyle/>
+          <a:p>
+            <a:endParaRPr lang="fr-FR" sz="2400">
+              <a:latin typeface="Marianne" panose="02000000000000000000" pitchFamily="50" charset="0"/>
+              <a:ea typeface="Calibri" panose="020F0502020204030204" pitchFamily="34" charset="0"/>
+              <a:cs typeface="Calibri" panose="020F0502020204030204" pitchFamily="34" charset="0"/>
+            </a:endParaRPr>
+          </a:p>
+        </p:txBody>
+      </p:sp>
+      <p:sp>
+        <p:nvSpPr>
+          <p:cNvPr id="6" name="zone_titre_fiches_diagnostic">
+            <a:extLst>
+              <a:ext uri="{FF2B5EF4-FFF2-40B4-BE49-F238E27FC236}">
+                <a16:creationId xmlns:a16="http://schemas.microsoft.com/office/drawing/2014/main" id="{9328B9A3-CC8F-11E9-FAB1-0824EF7E88D7}"/>
+              </a:ext>
+            </a:extLst>
+          </p:cNvPr>
+          <p:cNvSpPr/>
+          <p:nvPr/>
+        </p:nvSpPr>
+        <p:spPr>
+          <a:xfrm>
+            <a:off x="609600" y="3398401"/>
+            <a:ext cx="10972800" cy="2879386"/>
+          </a:xfrm>
+          <a:prstGeom prst="rect">
+            <a:avLst/>
+          </a:prstGeom>
+          <a:noFill/>
+          <a:ln/>
+        </p:spPr>
+        <p:txBody>
+          <a:bodyPr wrap="square" lIns="0" tIns="0" rIns="0" bIns="0" numCol="2" rtlCol="0" anchor="t"/>
+          <a:lstStyle/>
+          <a:p>
+            <a:pPr marL="285750" indent="-285750">
+              <a:buFont typeface="Arial" panose="020B0604020202020204" pitchFamily="34" charset="0"/>
+              <a:buChar char="•"/>
+            </a:pPr>
+            <a:r>
+              <a:rPr lang="fr-FR" sz="1600" dirty="0">
+                <a:solidFill>
+                  <a:srgbClr val="5C5C5C"/>
+                </a:solidFill>
+                <a:latin typeface="Marianne" panose="02000000000000000000" pitchFamily="50" charset="0"/>
+                <a:ea typeface="Calibri" panose="020F0502020204030204" pitchFamily="34" charset="0"/>
+                <a:cs typeface="Calibri" panose="020F0502020204030204" pitchFamily="34" charset="0"/>
+              </a:rPr>
+              <a:t>{{</a:t>
+            </a:r>
+            <a:r>
+              <a:rPr lang="fr-FR" sz="1600" dirty="0" err="1">
+                <a:solidFill>
+                  <a:srgbClr val="5C5C5C"/>
+                </a:solidFill>
+                <a:latin typeface="Marianne" panose="02000000000000000000" pitchFamily="50" charset="0"/>
+                <a:ea typeface="Calibri" panose="020F0502020204030204" pitchFamily="34" charset="0"/>
+                <a:cs typeface="Calibri" panose="020F0502020204030204" pitchFamily="34" charset="0"/>
+              </a:rPr>
+              <a:t>titre_fiches_diagnostic</a:t>
+            </a:r>
+            <a:r>
+              <a:rPr lang="fr-FR" sz="1600" dirty="0">
+                <a:solidFill>
+                  <a:srgbClr val="5C5C5C"/>
+                </a:solidFill>
+                <a:latin typeface="Marianne" panose="02000000000000000000" pitchFamily="50" charset="0"/>
+                <a:ea typeface="Calibri" panose="020F0502020204030204" pitchFamily="34" charset="0"/>
+                <a:cs typeface="Calibri" panose="020F0502020204030204" pitchFamily="34" charset="0"/>
+              </a:rPr>
+              <a:t>}}</a:t>
+            </a:r>
+          </a:p>
+        </p:txBody>
+      </p:sp>
+      <p:cxnSp>
+        <p:nvCxnSpPr>
+          <p:cNvPr id="2" name="Connecteur droit 1">
+            <a:extLst>
+              <a:ext uri="{FF2B5EF4-FFF2-40B4-BE49-F238E27FC236}">
+                <a16:creationId xmlns:a16="http://schemas.microsoft.com/office/drawing/2014/main" id="{A3CAC41A-66B0-361D-B372-62D87EE7A9F8}"/>
+              </a:ext>
+            </a:extLst>
+          </p:cNvPr>
+          <p:cNvCxnSpPr>
+            <a:cxnSpLocks/>
+          </p:cNvCxnSpPr>
+          <p:nvPr/>
+        </p:nvCxnSpPr>
+        <p:spPr>
+          <a:xfrm>
+            <a:off x="576263" y="6512991"/>
+            <a:ext cx="11615737" cy="0"/>
+          </a:xfrm>
+          <a:prstGeom prst="line">
+            <a:avLst/>
+          </a:prstGeom>
+          <a:ln>
+            <a:solidFill>
+              <a:schemeClr val="bg1">
+                <a:lumMod val="85000"/>
+              </a:schemeClr>
+            </a:solidFill>
+          </a:ln>
+        </p:spPr>
+        <p:style>
+          <a:lnRef idx="2">
+            <a:schemeClr val="accent1"/>
+          </a:lnRef>
+          <a:fillRef idx="0">
+            <a:schemeClr val="accent1"/>
+          </a:fillRef>
+          <a:effectRef idx="1">
+            <a:schemeClr val="accent1"/>
+          </a:effectRef>
+          <a:fontRef idx="minor">
+            <a:schemeClr val="tx1"/>
+          </a:fontRef>
+        </p:style>
+      </p:cxnSp>
+      <p:sp>
+        <p:nvSpPr>
+          <p:cNvPr id="8" name="Text 3">
+            <a:extLst>
+              <a:ext uri="{FF2B5EF4-FFF2-40B4-BE49-F238E27FC236}">
+                <a16:creationId xmlns:a16="http://schemas.microsoft.com/office/drawing/2014/main" id="{515558A7-65FA-3B23-4336-CA7CF66783E3}"/>
+              </a:ext>
+            </a:extLst>
+          </p:cNvPr>
+          <p:cNvSpPr/>
+          <p:nvPr/>
+        </p:nvSpPr>
+        <p:spPr>
+          <a:xfrm>
+            <a:off x="576263" y="6598217"/>
+            <a:ext cx="8229600" cy="182880"/>
+          </a:xfrm>
+          <a:prstGeom prst="rect">
+            <a:avLst/>
+          </a:prstGeom>
+          <a:noFill/>
+          <a:ln/>
+        </p:spPr>
+        <p:txBody>
+          <a:bodyPr wrap="square" lIns="0" tIns="0" rIns="0" bIns="0" rtlCol="0" anchor="ctr"/>
+          <a:lstStyle/>
+          <a:p>
+            <a:pPr marL="0" indent="0">
+              <a:buNone/>
+            </a:pPr>
+            <a:r>
+              <a:rPr lang="en-US" sz="1000" i="1">
+                <a:solidFill>
+                  <a:srgbClr val="A0A0A0"/>
+                </a:solidFill>
+                <a:latin typeface="Marianne" panose="02000000000000000000" pitchFamily="50" charset="0"/>
+                <a:ea typeface="Calibri" panose="020F0502020204030204" pitchFamily="34" charset="0"/>
+                <a:cs typeface="Calibri" panose="020F0502020204030204" pitchFamily="34" charset="0"/>
+              </a:rPr>
+              <a:t>Données issues de Plus fraîche ma ville (ADEME)</a:t>
+            </a:r>
+            <a:endParaRPr lang="en-US" sz="1000">
+              <a:latin typeface="Marianne" panose="02000000000000000000" pitchFamily="50" charset="0"/>
+              <a:ea typeface="Calibri" panose="020F0502020204030204" pitchFamily="34" charset="0"/>
+              <a:cs typeface="Calibri" panose="020F0502020204030204" pitchFamily="34" charset="0"/>
+            </a:endParaRPr>
+          </a:p>
+        </p:txBody>
+      </p:sp>
+    </p:spTree>
+    <p:extLst>
+      <p:ext uri="{BB962C8B-B14F-4D97-AF65-F5344CB8AC3E}">
+        <p14:creationId xmlns:p14="http://schemas.microsoft.com/office/powerpoint/2010/main" val="2161847135"/>
+      </p:ext>
+    </p:extLst>
+  </p:cSld>
+  <p:clrMapOvr>
+    <a:masterClrMapping/>
+  </p:clrMapOvr>
+</p:sld>
+</file>
+
+<file path=ppt/slides/slide5.xml><?xml version="1.0" encoding="utf-8"?>
+<p:sld xmlns:a="http://schemas.openxmlformats.org/drawingml/2006/main" xmlns:r="http://schemas.openxmlformats.org/officeDocument/2006/relationships" xmlns:p="http://schemas.openxmlformats.org/presentationml/2006/main">
+  <p:cSld>
+    <p:spTree>
+      <p:nvGrpSpPr>
+        <p:cNvPr id="1" name="">
+          <a:extLst>
+            <a:ext uri="{FF2B5EF4-FFF2-40B4-BE49-F238E27FC236}">
               <a16:creationId xmlns:a16="http://schemas.microsoft.com/office/drawing/2014/main" id="{1917CAA9-6ECD-8F49-8289-13579AAE1FB7}"/>
             </a:ext>
           </a:extLst>
@@ -14073,7 +15621,7 @@
 </p:sld>
 </file>
 
-<file path=ppt/slides/slide5.xml><?xml version="1.0" encoding="utf-8"?>
+<file path=ppt/slides/slide6.xml><?xml version="1.0" encoding="utf-8"?>
 <p:sld xmlns:a="http://schemas.openxmlformats.org/drawingml/2006/main" xmlns:r="http://schemas.openxmlformats.org/officeDocument/2006/relationships" xmlns:p="http://schemas.openxmlformats.org/presentationml/2006/main">
   <p:cSld>
     <p:spTree>
@@ -14421,7 +15969,7 @@
 </p:sld>
 </file>
 
-<file path=ppt/slides/slide6.xml><?xml version="1.0" encoding="utf-8"?>
+<file path=ppt/slides/slide7.xml><?xml version="1.0" encoding="utf-8"?>
 <p:sld xmlns:a="http://schemas.openxmlformats.org/drawingml/2006/main" xmlns:r="http://schemas.openxmlformats.org/officeDocument/2006/relationships" xmlns:p="http://schemas.openxmlformats.org/presentationml/2006/main">
   <p:cSld>
     <p:spTree>
@@ -14563,7 +16111,7 @@
         <p:spPr>
           <a:xfrm>
             <a:off x="576263" y="1093598"/>
-            <a:ext cx="9706988" cy="400110"/>
+            <a:ext cx="11522240" cy="400110"/>
           </a:xfrm>
           <a:prstGeom prst="rect">
             <a:avLst/>
@@ -17145,7 +18693,7 @@
 </p:sld>
 </file>
 
-<file path=ppt/slides/slide7.xml><?xml version="1.0" encoding="utf-8"?>
+<file path=ppt/slides/slide8.xml><?xml version="1.0" encoding="utf-8"?>
 <p:sld xmlns:a="http://schemas.openxmlformats.org/drawingml/2006/main" xmlns:r="http://schemas.openxmlformats.org/officeDocument/2006/relationships" xmlns:p="http://schemas.openxmlformats.org/presentationml/2006/main">
   <p:cSld>
     <p:spTree>
@@ -17768,7 +19316,7 @@
 </p:sld>
 </file>
 
-<file path=ppt/slides/slide8.xml><?xml version="1.0" encoding="utf-8"?>
+<file path=ppt/slides/slide9.xml><?xml version="1.0" encoding="utf-8"?>
 <p:sld xmlns:a="http://schemas.openxmlformats.org/drawingml/2006/main" xmlns:r="http://schemas.openxmlformats.org/officeDocument/2006/relationships" xmlns:p="http://schemas.openxmlformats.org/presentationml/2006/main">
   <p:cSld>
     <p:spTree>
@@ -18128,1153 +19676,6 @@
     <p:extLst>
       <p:ext uri="{BB962C8B-B14F-4D97-AF65-F5344CB8AC3E}">
         <p14:creationId xmlns:p14="http://schemas.microsoft.com/office/powerpoint/2010/main" val="1600001392"/>
-      </p:ext>
-    </p:extLst>
-  </p:cSld>
-  <p:clrMapOvr>
-    <a:masterClrMapping/>
-  </p:clrMapOvr>
-</p:sld>
-</file>
-
-<file path=ppt/slides/slide9.xml><?xml version="1.0" encoding="utf-8"?>
-<p:sld xmlns:a="http://schemas.openxmlformats.org/drawingml/2006/main" xmlns:r="http://schemas.openxmlformats.org/officeDocument/2006/relationships" xmlns:p="http://schemas.openxmlformats.org/presentationml/2006/main">
-  <p:cSld>
-    <p:spTree>
-      <p:nvGrpSpPr>
-        <p:cNvPr id="1" name="">
-          <a:extLst>
-            <a:ext uri="{FF2B5EF4-FFF2-40B4-BE49-F238E27FC236}">
-              <a16:creationId xmlns:a16="http://schemas.microsoft.com/office/drawing/2014/main" id="{6FBD765A-1FEE-159F-96BA-777FDEE395FF}"/>
-            </a:ext>
-          </a:extLst>
-        </p:cNvPr>
-        <p:cNvGrpSpPr/>
-        <p:nvPr/>
-      </p:nvGrpSpPr>
-      <p:grpSpPr>
-        <a:xfrm>
-          <a:off x="0" y="0"/>
-          <a:ext cx="0" cy="0"/>
-          <a:chOff x="0" y="0"/>
-          <a:chExt cx="0" cy="0"/>
-        </a:xfrm>
-      </p:grpSpPr>
-      <p:sp>
-        <p:nvSpPr>
-          <p:cNvPr id="12" name="bg_recap_estimation_fs">
-            <a:extLst>
-              <a:ext uri="{FF2B5EF4-FFF2-40B4-BE49-F238E27FC236}">
-                <a16:creationId xmlns:a16="http://schemas.microsoft.com/office/drawing/2014/main" id="{6BA12113-ED47-B687-ED73-BF7EB1432512}"/>
-              </a:ext>
-            </a:extLst>
-          </p:cNvPr>
-          <p:cNvSpPr/>
-          <p:nvPr/>
-        </p:nvSpPr>
-        <p:spPr>
-          <a:xfrm>
-            <a:off x="1255554" y="2602517"/>
-            <a:ext cx="9765604" cy="663816"/>
-          </a:xfrm>
-          <a:prstGeom prst="rect">
-            <a:avLst/>
-          </a:prstGeom>
-          <a:solidFill>
-            <a:schemeClr val="bg1">
-              <a:lumMod val="95000"/>
-            </a:schemeClr>
-          </a:solidFill>
-          <a:ln>
-            <a:noFill/>
-          </a:ln>
-        </p:spPr>
-        <p:style>
-          <a:lnRef idx="2">
-            <a:schemeClr val="accent1">
-              <a:shade val="15000"/>
-            </a:schemeClr>
-          </a:lnRef>
-          <a:fillRef idx="1">
-            <a:schemeClr val="accent1"/>
-          </a:fillRef>
-          <a:effectRef idx="0">
-            <a:schemeClr val="accent1"/>
-          </a:effectRef>
-          <a:fontRef idx="minor">
-            <a:schemeClr val="lt1"/>
-          </a:fontRef>
-        </p:style>
-        <p:txBody>
-          <a:bodyPr rtlCol="0" anchor="ctr"/>
-          <a:lstStyle/>
-          <a:p>
-            <a:pPr algn="ctr"/>
-            <a:endParaRPr lang="fr-FR">
-              <a:latin typeface="Marianne" panose="02000000000000000000" pitchFamily="50" charset="0"/>
-            </a:endParaRPr>
-          </a:p>
-        </p:txBody>
-      </p:sp>
-      <p:sp>
-        <p:nvSpPr>
-          <p:cNvPr id="9" name="zone_titre_materiau">
-            <a:extLst>
-              <a:ext uri="{FF2B5EF4-FFF2-40B4-BE49-F238E27FC236}">
-                <a16:creationId xmlns:a16="http://schemas.microsoft.com/office/drawing/2014/main" id="{A88800C3-C9AC-CC70-2E75-A1BBA164B372}"/>
-              </a:ext>
-            </a:extLst>
-          </p:cNvPr>
-          <p:cNvSpPr txBox="1"/>
-          <p:nvPr/>
-        </p:nvSpPr>
-        <p:spPr>
-          <a:xfrm>
-            <a:off x="1865713" y="1529871"/>
-            <a:ext cx="5597103" cy="276999"/>
-          </a:xfrm>
-          <a:prstGeom prst="rect">
-            <a:avLst/>
-          </a:prstGeom>
-          <a:noFill/>
-        </p:spPr>
-        <p:txBody>
-          <a:bodyPr wrap="square">
-            <a:spAutoFit/>
-          </a:bodyPr>
-          <a:lstStyle/>
-          <a:p>
-            <a:r>
-              <a:rPr lang="fr-FR" sz="1200" b="1" i="0" dirty="0">
-                <a:effectLst/>
-                <a:latin typeface="Marianne" panose="02000000000000000000" pitchFamily="50" charset="0"/>
-              </a:rPr>
-              <a:t>{{</a:t>
-            </a:r>
-            <a:r>
-              <a:rPr lang="fr-FR" sz="1200" b="1" i="0" dirty="0" err="1">
-                <a:effectLst/>
-                <a:latin typeface="Marianne" panose="02000000000000000000" pitchFamily="50" charset="0"/>
-              </a:rPr>
-              <a:t>titre_materiau</a:t>
-            </a:r>
-            <a:r>
-              <a:rPr lang="fr-FR" sz="1200" b="1" i="0" dirty="0">
-                <a:effectLst/>
-                <a:latin typeface="Marianne" panose="02000000000000000000" pitchFamily="50" charset="0"/>
-              </a:rPr>
-              <a:t>}}</a:t>
-            </a:r>
-            <a:endParaRPr lang="fr-FR" sz="1200" b="1" dirty="0">
-              <a:latin typeface="Marianne" panose="02000000000000000000" pitchFamily="50" charset="0"/>
-            </a:endParaRPr>
-          </a:p>
-        </p:txBody>
-      </p:sp>
-      <p:pic>
-        <p:nvPicPr>
-          <p:cNvPr id="15" name="image_materiau" descr="Une image contenant sol, plein air, bâtiment, propriété&#10;&#10;Description générée automatiquement">
-            <a:extLst>
-              <a:ext uri="{FF2B5EF4-FFF2-40B4-BE49-F238E27FC236}">
-                <a16:creationId xmlns:a16="http://schemas.microsoft.com/office/drawing/2014/main" id="{6FE81792-B99E-A1A7-6F71-0CC62F608A31}"/>
-              </a:ext>
-            </a:extLst>
-          </p:cNvPr>
-          <p:cNvPicPr>
-            <a:picLocks noChangeAspect="1"/>
-          </p:cNvPicPr>
-          <p:nvPr/>
-        </p:nvPicPr>
-        <p:blipFill>
-          <a:blip r:embed="rId2"/>
-          <a:stretch>
-            <a:fillRect/>
-          </a:stretch>
-        </p:blipFill>
-        <p:spPr>
-          <a:xfrm>
-            <a:off x="1403168" y="1575983"/>
-            <a:ext cx="462545" cy="476562"/>
-          </a:xfrm>
-          <a:prstGeom prst="rect">
-            <a:avLst/>
-          </a:prstGeom>
-        </p:spPr>
-      </p:pic>
-      <p:sp>
-        <p:nvSpPr>
-          <p:cNvPr id="19" name="zone_cout_materiau">
-            <a:extLst>
-              <a:ext uri="{FF2B5EF4-FFF2-40B4-BE49-F238E27FC236}">
-                <a16:creationId xmlns:a16="http://schemas.microsoft.com/office/drawing/2014/main" id="{79E9B9CA-0F08-3137-64D1-50FFF50EA47E}"/>
-              </a:ext>
-            </a:extLst>
-          </p:cNvPr>
-          <p:cNvSpPr txBox="1"/>
-          <p:nvPr/>
-        </p:nvSpPr>
-        <p:spPr>
-          <a:xfrm>
-            <a:off x="7417711" y="1632102"/>
-            <a:ext cx="3603447" cy="646331"/>
-          </a:xfrm>
-          <a:prstGeom prst="rect">
-            <a:avLst/>
-          </a:prstGeom>
-          <a:noFill/>
-        </p:spPr>
-        <p:txBody>
-          <a:bodyPr wrap="square">
-            <a:spAutoFit/>
-          </a:bodyPr>
-          <a:lstStyle/>
-          <a:p>
-            <a:pPr marL="0" indent="0" algn="r">
-              <a:buNone/>
-            </a:pPr>
-            <a:r>
-              <a:rPr lang="en-US" sz="1200" i="1" dirty="0" err="1">
-                <a:solidFill>
-                  <a:srgbClr val="2C2C2C"/>
-                </a:solidFill>
-                <a:latin typeface="Marianne" panose="02000000000000000000" pitchFamily="50" charset="0"/>
-                <a:ea typeface="Calibri" pitchFamily="34" charset="-122"/>
-                <a:cs typeface="Calibri" pitchFamily="34" charset="-120"/>
-              </a:rPr>
-              <a:t>Investissement</a:t>
-            </a:r>
-            <a:r>
-              <a:rPr lang="en-US" sz="1200" i="1" dirty="0">
-                <a:solidFill>
-                  <a:srgbClr val="2C2C2C"/>
-                </a:solidFill>
-                <a:latin typeface="Marianne" panose="02000000000000000000" pitchFamily="50" charset="0"/>
-                <a:ea typeface="Calibri" pitchFamily="34" charset="-122"/>
-                <a:cs typeface="Calibri" pitchFamily="34" charset="-120"/>
-              </a:rPr>
-              <a:t> : {{</a:t>
-            </a:r>
-            <a:r>
-              <a:rPr lang="en-US" sz="1200" i="1" dirty="0" err="1">
-                <a:solidFill>
-                  <a:srgbClr val="2C2C2C"/>
-                </a:solidFill>
-                <a:latin typeface="Marianne" panose="02000000000000000000" pitchFamily="50" charset="0"/>
-                <a:ea typeface="Calibri" pitchFamily="34" charset="-122"/>
-                <a:cs typeface="Calibri" pitchFamily="34" charset="-120"/>
-              </a:rPr>
-              <a:t>cout_investissement_materiau</a:t>
-            </a:r>
-            <a:r>
-              <a:rPr lang="en-US" sz="1200" i="1" dirty="0">
-                <a:solidFill>
-                  <a:srgbClr val="2C2C2C"/>
-                </a:solidFill>
-                <a:latin typeface="Marianne" panose="02000000000000000000" pitchFamily="50" charset="0"/>
-                <a:ea typeface="Calibri" pitchFamily="34" charset="-122"/>
-                <a:cs typeface="Calibri" pitchFamily="34" charset="-120"/>
-              </a:rPr>
-              <a:t>}}</a:t>
-            </a:r>
-          </a:p>
-          <a:p>
-            <a:pPr marL="0" indent="0" algn="r">
-              <a:buNone/>
-            </a:pPr>
-            <a:r>
-              <a:rPr lang="en-US" sz="1200" i="1" dirty="0">
-                <a:solidFill>
-                  <a:srgbClr val="2C2C2C"/>
-                </a:solidFill>
-                <a:latin typeface="Marianne" panose="02000000000000000000" pitchFamily="50" charset="0"/>
-                <a:ea typeface="Calibri" pitchFamily="34" charset="-122"/>
-                <a:cs typeface="Calibri" pitchFamily="34" charset="-120"/>
-              </a:rPr>
-              <a:t>Entretien : {{</a:t>
-            </a:r>
-            <a:r>
-              <a:rPr lang="en-US" sz="1200" i="1" dirty="0" err="1">
-                <a:solidFill>
-                  <a:srgbClr val="2C2C2C"/>
-                </a:solidFill>
-                <a:latin typeface="Marianne" panose="02000000000000000000" pitchFamily="50" charset="0"/>
-                <a:ea typeface="Calibri" pitchFamily="34" charset="-122"/>
-                <a:cs typeface="Calibri" pitchFamily="34" charset="-120"/>
-              </a:rPr>
-              <a:t>cout_entretien_materiau</a:t>
-            </a:r>
-            <a:r>
-              <a:rPr lang="en-US" sz="1200" i="1" dirty="0">
-                <a:solidFill>
-                  <a:srgbClr val="2C2C2C"/>
-                </a:solidFill>
-                <a:latin typeface="Marianne" panose="02000000000000000000" pitchFamily="50" charset="0"/>
-                <a:ea typeface="Calibri" pitchFamily="34" charset="-122"/>
-                <a:cs typeface="Calibri" pitchFamily="34" charset="-120"/>
-              </a:rPr>
-              <a:t>}}</a:t>
-            </a:r>
-            <a:endParaRPr lang="en-US" sz="1200" dirty="0">
-              <a:latin typeface="Marianne" panose="02000000000000000000" pitchFamily="50" charset="0"/>
-            </a:endParaRPr>
-          </a:p>
-        </p:txBody>
-      </p:sp>
-      <p:sp>
-        <p:nvSpPr>
-          <p:cNvPr id="3" name="titre_recap_estimation">
-            <a:extLst>
-              <a:ext uri="{FF2B5EF4-FFF2-40B4-BE49-F238E27FC236}">
-                <a16:creationId xmlns:a16="http://schemas.microsoft.com/office/drawing/2014/main" id="{F82418D9-B39F-2905-A2C1-E7CF651F5D36}"/>
-              </a:ext>
-            </a:extLst>
-          </p:cNvPr>
-          <p:cNvSpPr txBox="1">
-            <a:spLocks/>
-          </p:cNvSpPr>
-          <p:nvPr/>
-        </p:nvSpPr>
-        <p:spPr>
-          <a:xfrm>
-            <a:off x="576263" y="345395"/>
-            <a:ext cx="10130008" cy="615294"/>
-          </a:xfrm>
-          <a:prstGeom prst="rect">
-            <a:avLst/>
-          </a:prstGeom>
-        </p:spPr>
-        <p:txBody>
-          <a:bodyPr vert="horz" lIns="91440" tIns="45720" rIns="91440" bIns="45720" rtlCol="0" anchor="ctr">
-            <a:noAutofit/>
-          </a:bodyPr>
-          <a:lstStyle>
-            <a:lvl1pPr algn="l" defTabSz="914400" rtl="0" eaLnBrk="1" latinLnBrk="0" hangingPunct="1">
-              <a:lnSpc>
-                <a:spcPct val="90000"/>
-              </a:lnSpc>
-              <a:spcBef>
-                <a:spcPct val="0"/>
-              </a:spcBef>
-              <a:buNone/>
-              <a:defRPr sz="4400" kern="1200">
-                <a:solidFill>
-                  <a:schemeClr val="tx1"/>
-                </a:solidFill>
-                <a:latin typeface="+mj-lt"/>
-                <a:ea typeface="+mj-ea"/>
-                <a:cs typeface="+mj-cs"/>
-              </a:defRPr>
-            </a:lvl1pPr>
-          </a:lstStyle>
-          <a:p>
-            <a:r>
-              <a:rPr lang="en-US" sz="2800" dirty="0" err="1">
-                <a:latin typeface="Marianne" panose="02000000000000000000" pitchFamily="50" charset="0"/>
-                <a:ea typeface="Calibri" panose="020F0502020204030204" pitchFamily="34" charset="0"/>
-                <a:cs typeface="Calibri" panose="020F0502020204030204" pitchFamily="34" charset="0"/>
-              </a:rPr>
-              <a:t>Récapitulatif</a:t>
-            </a:r>
-            <a:r>
-              <a:rPr lang="en-US" sz="2800" dirty="0">
-                <a:latin typeface="Marianne" panose="02000000000000000000" pitchFamily="50" charset="0"/>
-                <a:ea typeface="Calibri" panose="020F0502020204030204" pitchFamily="34" charset="0"/>
-                <a:cs typeface="Calibri" panose="020F0502020204030204" pitchFamily="34" charset="0"/>
-              </a:rPr>
-              <a:t> </a:t>
-            </a:r>
-            <a:r>
-              <a:rPr lang="en-US" sz="2800" dirty="0" err="1">
-                <a:latin typeface="Marianne" panose="02000000000000000000" pitchFamily="50" charset="0"/>
-                <a:ea typeface="Calibri" panose="020F0502020204030204" pitchFamily="34" charset="0"/>
-                <a:cs typeface="Calibri" panose="020F0502020204030204" pitchFamily="34" charset="0"/>
-              </a:rPr>
-              <a:t>budgétaire</a:t>
-            </a:r>
-            <a:r>
-              <a:rPr lang="en-US" sz="2800" dirty="0">
-                <a:latin typeface="Marianne" panose="02000000000000000000" pitchFamily="50" charset="0"/>
-                <a:ea typeface="Calibri" panose="020F0502020204030204" pitchFamily="34" charset="0"/>
-                <a:cs typeface="Calibri" panose="020F0502020204030204" pitchFamily="34" charset="0"/>
-              </a:rPr>
-              <a:t> {{</a:t>
-            </a:r>
-            <a:r>
-              <a:rPr lang="en-US" sz="2800" dirty="0" err="1">
-                <a:latin typeface="Marianne" panose="02000000000000000000" pitchFamily="50" charset="0"/>
-                <a:ea typeface="Calibri" panose="020F0502020204030204" pitchFamily="34" charset="0"/>
-                <a:cs typeface="Calibri" panose="020F0502020204030204" pitchFamily="34" charset="0"/>
-              </a:rPr>
-              <a:t>pagination_recap_estimation</a:t>
-            </a:r>
-            <a:r>
-              <a:rPr lang="en-US" sz="2800" dirty="0">
-                <a:latin typeface="Marianne" panose="02000000000000000000" pitchFamily="50" charset="0"/>
-                <a:ea typeface="Calibri" panose="020F0502020204030204" pitchFamily="34" charset="0"/>
-                <a:cs typeface="Calibri" panose="020F0502020204030204" pitchFamily="34" charset="0"/>
-              </a:rPr>
-              <a:t>}}</a:t>
-            </a:r>
-            <a:endParaRPr lang="fr-FR" sz="2800" dirty="0">
-              <a:latin typeface="Marianne" panose="02000000000000000000" pitchFamily="50" charset="0"/>
-            </a:endParaRPr>
-          </a:p>
-        </p:txBody>
-      </p:sp>
-      <p:cxnSp>
-        <p:nvCxnSpPr>
-          <p:cNvPr id="4" name="Connecteur droit 3">
-            <a:extLst>
-              <a:ext uri="{FF2B5EF4-FFF2-40B4-BE49-F238E27FC236}">
-                <a16:creationId xmlns:a16="http://schemas.microsoft.com/office/drawing/2014/main" id="{E6F030A1-1132-C9A1-903C-C717603846E0}"/>
-              </a:ext>
-            </a:extLst>
-          </p:cNvPr>
-          <p:cNvCxnSpPr>
-            <a:cxnSpLocks/>
-          </p:cNvCxnSpPr>
-          <p:nvPr/>
-        </p:nvCxnSpPr>
-        <p:spPr>
-          <a:xfrm>
-            <a:off x="576263" y="960689"/>
-            <a:ext cx="11615737" cy="0"/>
-          </a:xfrm>
-          <a:prstGeom prst="line">
-            <a:avLst/>
-          </a:prstGeom>
-          <a:ln>
-            <a:solidFill>
-              <a:schemeClr val="bg1">
-                <a:lumMod val="85000"/>
-              </a:schemeClr>
-            </a:solidFill>
-          </a:ln>
-        </p:spPr>
-        <p:style>
-          <a:lnRef idx="2">
-            <a:schemeClr val="accent1"/>
-          </a:lnRef>
-          <a:fillRef idx="0">
-            <a:schemeClr val="accent1"/>
-          </a:fillRef>
-          <a:effectRef idx="1">
-            <a:schemeClr val="accent1"/>
-          </a:effectRef>
-          <a:fontRef idx="minor">
-            <a:schemeClr val="tx1"/>
-          </a:fontRef>
-        </p:style>
-      </p:cxnSp>
-      <p:sp>
-        <p:nvSpPr>
-          <p:cNvPr id="2" name="zone_titre_fs_recap_estimation">
-            <a:extLst>
-              <a:ext uri="{FF2B5EF4-FFF2-40B4-BE49-F238E27FC236}">
-                <a16:creationId xmlns:a16="http://schemas.microsoft.com/office/drawing/2014/main" id="{B161BF39-D0D2-C1A3-6A29-174F5C4B931B}"/>
-              </a:ext>
-            </a:extLst>
-          </p:cNvPr>
-          <p:cNvSpPr txBox="1"/>
-          <p:nvPr/>
-        </p:nvSpPr>
-        <p:spPr>
-          <a:xfrm>
-            <a:off x="1097293" y="1153414"/>
-            <a:ext cx="6059347" cy="307777"/>
-          </a:xfrm>
-          <a:prstGeom prst="rect">
-            <a:avLst/>
-          </a:prstGeom>
-          <a:noFill/>
-        </p:spPr>
-        <p:txBody>
-          <a:bodyPr wrap="square">
-            <a:spAutoFit/>
-          </a:bodyPr>
-          <a:lstStyle/>
-          <a:p>
-            <a:r>
-              <a:rPr lang="fr-FR" sz="1400" b="1" i="0" dirty="0">
-                <a:effectLst/>
-                <a:latin typeface="Marianne" panose="02000000000000000000" pitchFamily="50" charset="0"/>
-              </a:rPr>
-              <a:t>{{</a:t>
-            </a:r>
-            <a:r>
-              <a:rPr lang="fr-FR" sz="1400" b="1" i="0" dirty="0" err="1">
-                <a:effectLst/>
-                <a:latin typeface="Marianne" panose="02000000000000000000" pitchFamily="50" charset="0"/>
-              </a:rPr>
-              <a:t>titre_fiche_solution</a:t>
-            </a:r>
-            <a:r>
-              <a:rPr lang="fr-FR" sz="1400" b="1" i="0" dirty="0">
-                <a:effectLst/>
-                <a:latin typeface="Marianne" panose="02000000000000000000" pitchFamily="50" charset="0"/>
-              </a:rPr>
-              <a:t>}}</a:t>
-            </a:r>
-            <a:endParaRPr lang="fr-FR" sz="1400" b="1" dirty="0">
-              <a:latin typeface="Marianne" panose="02000000000000000000" pitchFamily="50" charset="0"/>
-            </a:endParaRPr>
-          </a:p>
-        </p:txBody>
-      </p:sp>
-      <p:sp>
-        <p:nvSpPr>
-          <p:cNvPr id="6" name="recap_total_libelles">
-            <a:extLst>
-              <a:ext uri="{FF2B5EF4-FFF2-40B4-BE49-F238E27FC236}">
-                <a16:creationId xmlns:a16="http://schemas.microsoft.com/office/drawing/2014/main" id="{8CF6B5B8-BAD7-E10A-E363-18498172553F}"/>
-              </a:ext>
-            </a:extLst>
-          </p:cNvPr>
-          <p:cNvSpPr txBox="1"/>
-          <p:nvPr/>
-        </p:nvSpPr>
-        <p:spPr>
-          <a:xfrm>
-            <a:off x="6711181" y="4547787"/>
-            <a:ext cx="1579966" cy="430887"/>
-          </a:xfrm>
-          <a:prstGeom prst="rect">
-            <a:avLst/>
-          </a:prstGeom>
-          <a:noFill/>
-        </p:spPr>
-        <p:txBody>
-          <a:bodyPr wrap="square">
-            <a:spAutoFit/>
-          </a:bodyPr>
-          <a:lstStyle/>
-          <a:p>
-            <a:pPr marL="0" indent="0">
-              <a:buNone/>
-            </a:pPr>
-            <a:r>
-              <a:rPr lang="en-US" sz="1200" b="1" dirty="0" err="1">
-                <a:solidFill>
-                  <a:srgbClr val="2C2C2C"/>
-                </a:solidFill>
-                <a:latin typeface="Marianne" panose="02000000000000000000" pitchFamily="50" charset="0"/>
-                <a:ea typeface="Calibri" pitchFamily="34" charset="-122"/>
-                <a:cs typeface="Calibri" pitchFamily="34" charset="-120"/>
-              </a:rPr>
-              <a:t>Investissement</a:t>
-            </a:r>
-            <a:r>
-              <a:rPr lang="en-US" sz="1200" b="1" dirty="0">
-                <a:solidFill>
-                  <a:srgbClr val="2C2C2C"/>
-                </a:solidFill>
-                <a:latin typeface="Marianne" panose="02000000000000000000" pitchFamily="50" charset="0"/>
-                <a:ea typeface="Calibri" pitchFamily="34" charset="-122"/>
-                <a:cs typeface="Calibri" pitchFamily="34" charset="-120"/>
-              </a:rPr>
-              <a:t> :</a:t>
-            </a:r>
-          </a:p>
-          <a:p>
-            <a:pPr marL="0" indent="0">
-              <a:buNone/>
-            </a:pPr>
-            <a:r>
-              <a:rPr lang="en-US" sz="1000" dirty="0">
-                <a:solidFill>
-                  <a:schemeClr val="tx1">
-                    <a:lumMod val="75000"/>
-                    <a:lumOff val="25000"/>
-                  </a:schemeClr>
-                </a:solidFill>
-                <a:latin typeface="Marianne" panose="02000000000000000000" pitchFamily="50" charset="0"/>
-                <a:ea typeface="Calibri" pitchFamily="34" charset="-122"/>
-                <a:cs typeface="Calibri" pitchFamily="34" charset="-120"/>
-              </a:rPr>
-              <a:t>Entretien :</a:t>
-            </a:r>
-            <a:endParaRPr lang="en-US" sz="1000" dirty="0">
-              <a:solidFill>
-                <a:schemeClr val="tx1">
-                  <a:lumMod val="75000"/>
-                  <a:lumOff val="25000"/>
-                </a:schemeClr>
-              </a:solidFill>
-              <a:latin typeface="Marianne" panose="02000000000000000000" pitchFamily="50" charset="0"/>
-            </a:endParaRPr>
-          </a:p>
-        </p:txBody>
-      </p:sp>
-      <p:sp>
-        <p:nvSpPr>
-          <p:cNvPr id="11" name="ZoneTexte 10">
-            <a:extLst>
-              <a:ext uri="{FF2B5EF4-FFF2-40B4-BE49-F238E27FC236}">
-                <a16:creationId xmlns:a16="http://schemas.microsoft.com/office/drawing/2014/main" id="{7CB1432B-AE88-BC89-B5DC-87807C1FB1A9}"/>
-              </a:ext>
-            </a:extLst>
-          </p:cNvPr>
-          <p:cNvSpPr txBox="1"/>
-          <p:nvPr/>
-        </p:nvSpPr>
-        <p:spPr>
-          <a:xfrm>
-            <a:off x="6918732" y="2680597"/>
-            <a:ext cx="3950835" cy="430887"/>
-          </a:xfrm>
-          <a:prstGeom prst="rect">
-            <a:avLst/>
-          </a:prstGeom>
-          <a:noFill/>
-        </p:spPr>
-        <p:txBody>
-          <a:bodyPr wrap="square">
-            <a:spAutoFit/>
-          </a:bodyPr>
-          <a:lstStyle/>
-          <a:p>
-            <a:pPr marL="0" indent="0" algn="r">
-              <a:buNone/>
-            </a:pPr>
-            <a:r>
-              <a:rPr lang="en-US" sz="1200" b="1" i="1" dirty="0">
-                <a:solidFill>
-                  <a:srgbClr val="2C2C2C"/>
-                </a:solidFill>
-                <a:latin typeface="Marianne" panose="02000000000000000000" pitchFamily="50" charset="0"/>
-                <a:ea typeface="Calibri" pitchFamily="34" charset="-122"/>
-                <a:cs typeface="Calibri" pitchFamily="34" charset="-120"/>
-              </a:rPr>
-              <a:t>{{</a:t>
-            </a:r>
-            <a:r>
-              <a:rPr lang="en-US" sz="1200" b="1" i="1" dirty="0" err="1">
-                <a:solidFill>
-                  <a:srgbClr val="2C2C2C"/>
-                </a:solidFill>
-                <a:latin typeface="Marianne" panose="02000000000000000000" pitchFamily="50" charset="0"/>
-                <a:ea typeface="Calibri" pitchFamily="34" charset="-122"/>
-                <a:cs typeface="Calibri" pitchFamily="34" charset="-120"/>
-              </a:rPr>
-              <a:t>cout_investissement_fiche_solution</a:t>
-            </a:r>
-            <a:r>
-              <a:rPr lang="en-US" sz="1200" b="1" i="1" dirty="0">
-                <a:solidFill>
-                  <a:srgbClr val="2C2C2C"/>
-                </a:solidFill>
-                <a:latin typeface="Marianne" panose="02000000000000000000" pitchFamily="50" charset="0"/>
-                <a:ea typeface="Calibri" pitchFamily="34" charset="-122"/>
-                <a:cs typeface="Calibri" pitchFamily="34" charset="-120"/>
-              </a:rPr>
-              <a:t>}}</a:t>
-            </a:r>
-          </a:p>
-          <a:p>
-            <a:pPr marL="0" indent="0" algn="r">
-              <a:buNone/>
-            </a:pPr>
-            <a:r>
-              <a:rPr lang="en-US" sz="1000" i="1" dirty="0">
-                <a:solidFill>
-                  <a:srgbClr val="2C2C2C"/>
-                </a:solidFill>
-                <a:latin typeface="Marianne" panose="02000000000000000000" pitchFamily="50" charset="0"/>
-                <a:ea typeface="Calibri" pitchFamily="34" charset="-122"/>
-                <a:cs typeface="Calibri" pitchFamily="34" charset="-120"/>
-              </a:rPr>
-              <a:t>{{</a:t>
-            </a:r>
-            <a:r>
-              <a:rPr lang="en-US" sz="1000" i="1" dirty="0" err="1">
-                <a:solidFill>
-                  <a:srgbClr val="2C2C2C"/>
-                </a:solidFill>
-                <a:latin typeface="Marianne" panose="02000000000000000000" pitchFamily="50" charset="0"/>
-                <a:ea typeface="Calibri" pitchFamily="34" charset="-122"/>
-                <a:cs typeface="Calibri" pitchFamily="34" charset="-120"/>
-              </a:rPr>
-              <a:t>cout_entretien_fiche_solution</a:t>
-            </a:r>
-            <a:r>
-              <a:rPr lang="en-US" sz="1000" i="1" dirty="0">
-                <a:solidFill>
-                  <a:srgbClr val="2C2C2C"/>
-                </a:solidFill>
-                <a:latin typeface="Marianne" panose="02000000000000000000" pitchFamily="50" charset="0"/>
-                <a:ea typeface="Calibri" pitchFamily="34" charset="-122"/>
-                <a:cs typeface="Calibri" pitchFamily="34" charset="-120"/>
-              </a:rPr>
-              <a:t>}}</a:t>
-            </a:r>
-            <a:endParaRPr lang="en-US" sz="1000" dirty="0">
-              <a:latin typeface="Marianne" panose="02000000000000000000" pitchFamily="50" charset="0"/>
-            </a:endParaRPr>
-          </a:p>
-        </p:txBody>
-      </p:sp>
-      <p:sp>
-        <p:nvSpPr>
-          <p:cNvPr id="13" name="recap_titre">
-            <a:extLst>
-              <a:ext uri="{FF2B5EF4-FFF2-40B4-BE49-F238E27FC236}">
-                <a16:creationId xmlns:a16="http://schemas.microsoft.com/office/drawing/2014/main" id="{821261B6-DEDA-B63E-00A5-C946FA7EEF26}"/>
-              </a:ext>
-            </a:extLst>
-          </p:cNvPr>
-          <p:cNvSpPr txBox="1"/>
-          <p:nvPr/>
-        </p:nvSpPr>
-        <p:spPr>
-          <a:xfrm>
-            <a:off x="1097292" y="3955732"/>
-            <a:ext cx="6250712" cy="523220"/>
-          </a:xfrm>
-          <a:prstGeom prst="rect">
-            <a:avLst/>
-          </a:prstGeom>
-          <a:noFill/>
-        </p:spPr>
-        <p:txBody>
-          <a:bodyPr wrap="square">
-            <a:spAutoFit/>
-          </a:bodyPr>
-          <a:lstStyle/>
-          <a:p>
-            <a:r>
-              <a:rPr lang="fr-FR" sz="1400" b="1" i="0" dirty="0">
-                <a:effectLst/>
-                <a:latin typeface="Marianne" panose="02000000000000000000" pitchFamily="50" charset="0"/>
-              </a:rPr>
-              <a:t>Estimation totale des solutions envisagées</a:t>
-            </a:r>
-          </a:p>
-          <a:p>
-            <a:pPr algn="l"/>
-            <a:r>
-              <a:rPr lang="fr-FR" sz="1100" b="0" i="0" dirty="0">
-                <a:solidFill>
-                  <a:srgbClr val="666666"/>
-                </a:solidFill>
-                <a:effectLst/>
-                <a:latin typeface="Marianne" panose="02000000000000000000" pitchFamily="50" charset="0"/>
-                <a:ea typeface="Calibri" panose="020F0502020204030204" pitchFamily="34" charset="0"/>
-                <a:cs typeface="Calibri" panose="020F0502020204030204" pitchFamily="34" charset="0"/>
-              </a:rPr>
-              <a:t> Inclut : fourniture et pose (hors travaux complémentaires de voirie, consolidation, etc.)</a:t>
-            </a:r>
-            <a:r>
-              <a:rPr lang="fr-FR" sz="1400" b="1" dirty="0">
-                <a:latin typeface="Marianne" panose="02000000000000000000" pitchFamily="50" charset="0"/>
-              </a:rPr>
-              <a:t> </a:t>
-            </a:r>
-          </a:p>
-        </p:txBody>
-      </p:sp>
-      <p:sp>
-        <p:nvSpPr>
-          <p:cNvPr id="16" name="zone_recap_fiche_solution">
-            <a:extLst>
-              <a:ext uri="{FF2B5EF4-FFF2-40B4-BE49-F238E27FC236}">
-                <a16:creationId xmlns:a16="http://schemas.microsoft.com/office/drawing/2014/main" id="{2511F9AC-9A80-85A8-5987-7E6F88547863}"/>
-              </a:ext>
-            </a:extLst>
-          </p:cNvPr>
-          <p:cNvSpPr txBox="1"/>
-          <p:nvPr/>
-        </p:nvSpPr>
-        <p:spPr>
-          <a:xfrm>
-            <a:off x="1377181" y="2718981"/>
-            <a:ext cx="3285673" cy="430887"/>
-          </a:xfrm>
-          <a:prstGeom prst="rect">
-            <a:avLst/>
-          </a:prstGeom>
-          <a:noFill/>
-        </p:spPr>
-        <p:txBody>
-          <a:bodyPr wrap="square">
-            <a:spAutoFit/>
-          </a:bodyPr>
-          <a:lstStyle/>
-          <a:p>
-            <a:pPr marL="0" indent="0">
-              <a:buNone/>
-            </a:pPr>
-            <a:r>
-              <a:rPr lang="en-US" sz="1200" b="1" dirty="0">
-                <a:solidFill>
-                  <a:srgbClr val="2C2C2C"/>
-                </a:solidFill>
-                <a:latin typeface="Marianne" panose="02000000000000000000" pitchFamily="50" charset="0"/>
-                <a:ea typeface="Calibri" pitchFamily="34" charset="-122"/>
-                <a:cs typeface="Calibri" pitchFamily="34" charset="-120"/>
-              </a:rPr>
-              <a:t>Total </a:t>
-            </a:r>
-            <a:r>
-              <a:rPr lang="en-US" sz="1200" b="1" dirty="0" err="1">
-                <a:solidFill>
-                  <a:srgbClr val="2C2C2C"/>
-                </a:solidFill>
-                <a:latin typeface="Marianne" panose="02000000000000000000" pitchFamily="50" charset="0"/>
-                <a:ea typeface="Calibri" pitchFamily="34" charset="-122"/>
-                <a:cs typeface="Calibri" pitchFamily="34" charset="-120"/>
-              </a:rPr>
-              <a:t>Investissement</a:t>
-            </a:r>
-            <a:endParaRPr lang="en-US" sz="1200" b="1" dirty="0">
-              <a:solidFill>
-                <a:srgbClr val="2C2C2C"/>
-              </a:solidFill>
-              <a:latin typeface="Marianne" panose="02000000000000000000" pitchFamily="50" charset="0"/>
-              <a:ea typeface="Calibri" pitchFamily="34" charset="-122"/>
-              <a:cs typeface="Calibri" pitchFamily="34" charset="-120"/>
-            </a:endParaRPr>
-          </a:p>
-          <a:p>
-            <a:pPr marL="0" indent="0">
-              <a:buNone/>
-            </a:pPr>
-            <a:r>
-              <a:rPr lang="en-US" sz="1000" dirty="0">
-                <a:solidFill>
-                  <a:schemeClr val="tx1">
-                    <a:lumMod val="75000"/>
-                    <a:lumOff val="25000"/>
-                  </a:schemeClr>
-                </a:solidFill>
-                <a:latin typeface="Marianne" panose="02000000000000000000" pitchFamily="50" charset="0"/>
-                <a:ea typeface="Calibri" pitchFamily="34" charset="-122"/>
-                <a:cs typeface="Calibri" pitchFamily="34" charset="-120"/>
-              </a:rPr>
-              <a:t>Total Entretien</a:t>
-            </a:r>
-            <a:endParaRPr lang="en-US" sz="1000" dirty="0">
-              <a:solidFill>
-                <a:schemeClr val="tx1">
-                  <a:lumMod val="75000"/>
-                  <a:lumOff val="25000"/>
-                </a:schemeClr>
-              </a:solidFill>
-              <a:latin typeface="Marianne" panose="02000000000000000000" pitchFamily="50" charset="0"/>
-            </a:endParaRPr>
-          </a:p>
-        </p:txBody>
-      </p:sp>
-      <p:sp>
-        <p:nvSpPr>
-          <p:cNvPr id="18" name="recap_total_libelles_valeurs">
-            <a:extLst>
-              <a:ext uri="{FF2B5EF4-FFF2-40B4-BE49-F238E27FC236}">
-                <a16:creationId xmlns:a16="http://schemas.microsoft.com/office/drawing/2014/main" id="{09E2F9B4-E5A1-7459-5392-6A6FC53C59B6}"/>
-              </a:ext>
-            </a:extLst>
-          </p:cNvPr>
-          <p:cNvSpPr txBox="1"/>
-          <p:nvPr/>
-        </p:nvSpPr>
-        <p:spPr>
-          <a:xfrm>
-            <a:off x="8093319" y="4547787"/>
-            <a:ext cx="2831124" cy="430887"/>
-          </a:xfrm>
-          <a:prstGeom prst="rect">
-            <a:avLst/>
-          </a:prstGeom>
-          <a:noFill/>
-        </p:spPr>
-        <p:txBody>
-          <a:bodyPr wrap="square">
-            <a:spAutoFit/>
-          </a:bodyPr>
-          <a:lstStyle/>
-          <a:p>
-            <a:r>
-              <a:rPr lang="en-US" sz="1200" b="1" i="1" dirty="0">
-                <a:solidFill>
-                  <a:srgbClr val="2C2C2C"/>
-                </a:solidFill>
-                <a:latin typeface="Marianne" panose="02000000000000000000" pitchFamily="50" charset="0"/>
-                <a:ea typeface="Calibri" pitchFamily="34" charset="-122"/>
-                <a:cs typeface="Calibri" pitchFamily="34" charset="-120"/>
-              </a:rPr>
-              <a:t>{{</a:t>
-            </a:r>
-            <a:r>
-              <a:rPr lang="en-US" sz="1200" b="1" i="1" dirty="0" err="1">
-                <a:solidFill>
-                  <a:srgbClr val="2C2C2C"/>
-                </a:solidFill>
-                <a:latin typeface="Marianne" panose="02000000000000000000" pitchFamily="50" charset="0"/>
-                <a:ea typeface="Calibri" pitchFamily="34" charset="-122"/>
-                <a:cs typeface="Calibri" pitchFamily="34" charset="-120"/>
-              </a:rPr>
-              <a:t>cout_investissement_estimation</a:t>
-            </a:r>
-            <a:r>
-              <a:rPr lang="en-US" sz="1200" b="1" i="1" dirty="0">
-                <a:solidFill>
-                  <a:srgbClr val="2C2C2C"/>
-                </a:solidFill>
-                <a:latin typeface="Marianne" panose="02000000000000000000" pitchFamily="50" charset="0"/>
-                <a:ea typeface="Calibri" pitchFamily="34" charset="-122"/>
-                <a:cs typeface="Calibri" pitchFamily="34" charset="-120"/>
-              </a:rPr>
-              <a:t>}}</a:t>
-            </a:r>
-            <a:endParaRPr lang="en-US" sz="1200" b="1" dirty="0">
-              <a:solidFill>
-                <a:srgbClr val="2C2C2C"/>
-              </a:solidFill>
-              <a:latin typeface="Marianne" panose="02000000000000000000" pitchFamily="50" charset="0"/>
-              <a:ea typeface="Calibri" pitchFamily="34" charset="-122"/>
-              <a:cs typeface="Calibri" pitchFamily="34" charset="-120"/>
-            </a:endParaRPr>
-          </a:p>
-          <a:p>
-            <a:pPr marL="0" indent="0">
-              <a:buNone/>
-            </a:pPr>
-            <a:r>
-              <a:rPr lang="en-US" sz="1000" dirty="0">
-                <a:solidFill>
-                  <a:schemeClr val="tx1">
-                    <a:lumMod val="75000"/>
-                    <a:lumOff val="25000"/>
-                  </a:schemeClr>
-                </a:solidFill>
-                <a:latin typeface="Marianne" panose="02000000000000000000" pitchFamily="50" charset="0"/>
-                <a:ea typeface="Calibri" pitchFamily="34" charset="-122"/>
-                <a:cs typeface="Calibri" pitchFamily="34" charset="-120"/>
-              </a:rPr>
-              <a:t>{{</a:t>
-            </a:r>
-            <a:r>
-              <a:rPr lang="en-US" sz="1000" dirty="0" err="1">
-                <a:solidFill>
-                  <a:schemeClr val="tx1">
-                    <a:lumMod val="75000"/>
-                    <a:lumOff val="25000"/>
-                  </a:schemeClr>
-                </a:solidFill>
-                <a:latin typeface="Marianne" panose="02000000000000000000" pitchFamily="50" charset="0"/>
-                <a:ea typeface="Calibri" pitchFamily="34" charset="-122"/>
-                <a:cs typeface="Calibri" pitchFamily="34" charset="-120"/>
-              </a:rPr>
-              <a:t>cout_enretien_estimation</a:t>
-            </a:r>
-            <a:r>
-              <a:rPr lang="en-US" sz="1000" dirty="0">
-                <a:solidFill>
-                  <a:schemeClr val="tx1">
-                    <a:lumMod val="75000"/>
-                    <a:lumOff val="25000"/>
-                  </a:schemeClr>
-                </a:solidFill>
-                <a:latin typeface="Marianne" panose="02000000000000000000" pitchFamily="50" charset="0"/>
-                <a:ea typeface="Calibri" pitchFamily="34" charset="-122"/>
-                <a:cs typeface="Calibri" pitchFamily="34" charset="-120"/>
-              </a:rPr>
-              <a:t>}}</a:t>
-            </a:r>
-            <a:endParaRPr lang="en-US" sz="1000" dirty="0">
-              <a:solidFill>
-                <a:schemeClr val="tx1">
-                  <a:lumMod val="75000"/>
-                  <a:lumOff val="25000"/>
-                </a:schemeClr>
-              </a:solidFill>
-              <a:latin typeface="Marianne" panose="02000000000000000000" pitchFamily="50" charset="0"/>
-            </a:endParaRPr>
-          </a:p>
-        </p:txBody>
-      </p:sp>
-      <p:sp>
-        <p:nvSpPr>
-          <p:cNvPr id="8" name="zone_quantite_materiau">
-            <a:extLst>
-              <a:ext uri="{FF2B5EF4-FFF2-40B4-BE49-F238E27FC236}">
-                <a16:creationId xmlns:a16="http://schemas.microsoft.com/office/drawing/2014/main" id="{2E3BE4A1-A1C8-70C6-319A-D994B244BC29}"/>
-              </a:ext>
-            </a:extLst>
-          </p:cNvPr>
-          <p:cNvSpPr txBox="1"/>
-          <p:nvPr/>
-        </p:nvSpPr>
-        <p:spPr>
-          <a:xfrm>
-            <a:off x="1865713" y="1824986"/>
-            <a:ext cx="5597103" cy="246221"/>
-          </a:xfrm>
-          <a:prstGeom prst="rect">
-            <a:avLst/>
-          </a:prstGeom>
-          <a:noFill/>
-        </p:spPr>
-        <p:txBody>
-          <a:bodyPr wrap="square">
-            <a:spAutoFit/>
-          </a:bodyPr>
-          <a:lstStyle/>
-          <a:p>
-            <a:r>
-              <a:rPr lang="fr-FR" sz="1000" i="0" dirty="0">
-                <a:effectLst/>
-                <a:latin typeface="Marianne" panose="02000000000000000000" pitchFamily="50" charset="0"/>
-              </a:rPr>
-              <a:t>{{</a:t>
-            </a:r>
-            <a:r>
-              <a:rPr lang="fr-FR" sz="1000" i="0" dirty="0" err="1">
-                <a:effectLst/>
-                <a:latin typeface="Marianne" panose="02000000000000000000" pitchFamily="50" charset="0"/>
-              </a:rPr>
-              <a:t>quantite_materiau</a:t>
-            </a:r>
-            <a:r>
-              <a:rPr lang="fr-FR" sz="1000" i="0" dirty="0">
-                <a:effectLst/>
-                <a:latin typeface="Marianne" panose="02000000000000000000" pitchFamily="50" charset="0"/>
-              </a:rPr>
-              <a:t>}}</a:t>
-            </a:r>
-            <a:endParaRPr lang="fr-FR" sz="1000" dirty="0">
-              <a:latin typeface="Marianne" panose="02000000000000000000" pitchFamily="50" charset="0"/>
-            </a:endParaRPr>
-          </a:p>
-        </p:txBody>
-      </p:sp>
-      <p:cxnSp>
-        <p:nvCxnSpPr>
-          <p:cNvPr id="10" name="Connecteur droit 9">
-            <a:extLst>
-              <a:ext uri="{FF2B5EF4-FFF2-40B4-BE49-F238E27FC236}">
-                <a16:creationId xmlns:a16="http://schemas.microsoft.com/office/drawing/2014/main" id="{AC020DFA-7CBC-D296-9C51-4CDB5F6EEA67}"/>
-              </a:ext>
-            </a:extLst>
-          </p:cNvPr>
-          <p:cNvCxnSpPr>
-            <a:cxnSpLocks/>
-          </p:cNvCxnSpPr>
-          <p:nvPr/>
-        </p:nvCxnSpPr>
-        <p:spPr>
-          <a:xfrm>
-            <a:off x="576263" y="6512991"/>
-            <a:ext cx="11615737" cy="0"/>
-          </a:xfrm>
-          <a:prstGeom prst="line">
-            <a:avLst/>
-          </a:prstGeom>
-          <a:ln>
-            <a:solidFill>
-              <a:schemeClr val="bg1">
-                <a:lumMod val="85000"/>
-              </a:schemeClr>
-            </a:solidFill>
-          </a:ln>
-        </p:spPr>
-        <p:style>
-          <a:lnRef idx="2">
-            <a:schemeClr val="accent1"/>
-          </a:lnRef>
-          <a:fillRef idx="0">
-            <a:schemeClr val="accent1"/>
-          </a:fillRef>
-          <a:effectRef idx="1">
-            <a:schemeClr val="accent1"/>
-          </a:effectRef>
-          <a:fontRef idx="minor">
-            <a:schemeClr val="tx1"/>
-          </a:fontRef>
-        </p:style>
-      </p:cxnSp>
-      <p:sp>
-        <p:nvSpPr>
-          <p:cNvPr id="17" name="Text 3">
-            <a:extLst>
-              <a:ext uri="{FF2B5EF4-FFF2-40B4-BE49-F238E27FC236}">
-                <a16:creationId xmlns:a16="http://schemas.microsoft.com/office/drawing/2014/main" id="{513ED38C-6EE1-7913-25F4-4C8F7039ADA0}"/>
-              </a:ext>
-            </a:extLst>
-          </p:cNvPr>
-          <p:cNvSpPr/>
-          <p:nvPr/>
-        </p:nvSpPr>
-        <p:spPr>
-          <a:xfrm>
-            <a:off x="576263" y="6598217"/>
-            <a:ext cx="8229600" cy="182880"/>
-          </a:xfrm>
-          <a:prstGeom prst="rect">
-            <a:avLst/>
-          </a:prstGeom>
-          <a:noFill/>
-          <a:ln/>
-        </p:spPr>
-        <p:txBody>
-          <a:bodyPr wrap="square" lIns="0" tIns="0" rIns="0" bIns="0" rtlCol="0" anchor="ctr"/>
-          <a:lstStyle/>
-          <a:p>
-            <a:pPr marL="0" indent="0">
-              <a:buNone/>
-            </a:pPr>
-            <a:r>
-              <a:rPr lang="en-US" sz="1000" i="1">
-                <a:solidFill>
-                  <a:srgbClr val="A0A0A0"/>
-                </a:solidFill>
-                <a:latin typeface="Marianne" panose="02000000000000000000" pitchFamily="50" charset="0"/>
-                <a:ea typeface="Calibri" panose="020F0502020204030204" pitchFamily="34" charset="0"/>
-                <a:cs typeface="Calibri" panose="020F0502020204030204" pitchFamily="34" charset="0"/>
-              </a:rPr>
-              <a:t>Données issues de Plus fraîche ma ville (ADEME)</a:t>
-            </a:r>
-            <a:endParaRPr lang="en-US" sz="1000">
-              <a:latin typeface="Marianne" panose="02000000000000000000" pitchFamily="50" charset="0"/>
-              <a:ea typeface="Calibri" panose="020F0502020204030204" pitchFamily="34" charset="0"/>
-              <a:cs typeface="Calibri" panose="020F0502020204030204" pitchFamily="34" charset="0"/>
-            </a:endParaRPr>
-          </a:p>
-        </p:txBody>
-      </p:sp>
-      <p:pic>
-        <p:nvPicPr>
-          <p:cNvPr id="5" name="Picture 4">
-            <a:extLst>
-              <a:ext uri="{FF2B5EF4-FFF2-40B4-BE49-F238E27FC236}">
-                <a16:creationId xmlns:a16="http://schemas.microsoft.com/office/drawing/2014/main" id="{DDFE2676-551D-F9A9-1060-DC00E3F770F9}"/>
-              </a:ext>
-            </a:extLst>
-          </p:cNvPr>
-          <p:cNvPicPr>
-            <a:picLocks noChangeAspect="1"/>
-          </p:cNvPicPr>
-          <p:nvPr/>
-        </p:nvPicPr>
-        <p:blipFill>
-          <a:blip r:embed="rId3"/>
-          <a:stretch>
-            <a:fillRect/>
-          </a:stretch>
-        </p:blipFill>
-        <p:spPr>
-          <a:xfrm>
-            <a:off x="10546452" y="104580"/>
-            <a:ext cx="1552051" cy="758533"/>
-          </a:xfrm>
-          <a:prstGeom prst="rect">
-            <a:avLst/>
-          </a:prstGeom>
-        </p:spPr>
-      </p:pic>
-    </p:spTree>
-    <p:extLst>
-      <p:ext uri="{BB962C8B-B14F-4D97-AF65-F5344CB8AC3E}">
-        <p14:creationId xmlns:p14="http://schemas.microsoft.com/office/powerpoint/2010/main" val="2086438628"/>
       </p:ext>
     </p:extLst>
   </p:cSld>

</xml_diff>